<commit_message>
docs: embed Web screenshots in defense PPT
Add six答辩界面截图 to docs/assets and regenerate the 26-slide
答辩_CareCompanion.pptx via generate_presentation.py; include PPT checklist.
</commit_message>
<xml_diff>
--- a/docs/答辩_CareCompanion.pptx
+++ b/docs/答辩_CareCompanion.pptx
@@ -25,6 +25,12 @@
     <p:sldId id="273" r:id="rId24"/>
     <p:sldId id="274" r:id="rId25"/>
     <p:sldId id="275" r:id="rId26"/>
+    <p:sldId id="276" r:id="rId27"/>
+    <p:sldId id="277" r:id="rId28"/>
+    <p:sldId id="278" r:id="rId29"/>
+    <p:sldId id="279" r:id="rId30"/>
+    <p:sldId id="280" r:id="rId31"/>
+    <p:sldId id="281" r:id="rId32"/>
   </p:sldIdLst>
   <p:sldSz cx="9144000" cy="5143500" type="screen4x3"/>
   <p:notesSz cx="6858000" cy="9144000"/>
@@ -3547,7 +3553,7 @@
         </p:nvSpPr>
         <p:spPr>
           <a:xfrm>
-            <a:off x="502920" y="1325880"/>
+            <a:off x="502920" y="1234440"/>
             <a:ext cx="8138160" cy="3840480"/>
           </a:xfrm>
           <a:prstGeom prst="rect">
@@ -3565,7 +3571,7 @@
               <a:spcAft>
                 <a:spcPts val="600"/>
               </a:spcAft>
-              <a:defRPr sz="1400">
+              <a:defRPr sz="1300">
                 <a:solidFill>
                   <a:srgbClr val="1E1E1E"/>
                 </a:solidFill>
@@ -3580,14 +3586,14 @@
               <a:spcAft>
                 <a:spcPts val="600"/>
               </a:spcAft>
-              <a:defRPr sz="1400">
+              <a:defRPr sz="1300">
                 <a:solidFill>
                   <a:srgbClr val="1E1E1E"/>
                 </a:solidFill>
               </a:defRPr>
             </a:pPr>
             <a:r>
-              <a:t>示例：「最近有点孤独」→ 温暖安抚 + speak + gesture</a:t>
+              <a:t>紧急链路：alert_sound → speak → call_emergency → raise_hand</a:t>
             </a:r>
           </a:p>
           <a:p>
@@ -3595,29 +3601,14 @@
               <a:spcAft>
                 <a:spcPts val="600"/>
               </a:spcAft>
-              <a:defRPr sz="1400">
+              <a:defRPr sz="1300">
                 <a:solidFill>
                   <a:srgbClr val="1E1E1E"/>
                 </a:solidFill>
               </a:defRPr>
             </a:pPr>
             <a:r>
-              <a:t>紧急：alert_sound → speak → call_emergency → raise_hand</a:t>
-            </a:r>
-          </a:p>
-          <a:p>
-            <a:pPr>
-              <a:spcAft>
-                <a:spcPts val="600"/>
-              </a:spcAft>
-              <a:defRPr sz="1400">
-                <a:solidFill>
-                  <a:srgbClr val="1E1E1E"/>
-                </a:solidFill>
-              </a:defRPr>
-            </a:pPr>
-            <a:r>
-              <a:t>EmergencyNotifier：家属 App 推送 / 短信备份 / 本地告警（日志可审计）</a:t>
+              <a:t>EmergencyNotifier：家属 App / 短信 / 本地告警（可审计日志）</a:t>
             </a:r>
           </a:p>
         </p:txBody>
@@ -3768,21 +3759,45 @@
               </a:defRPr>
             </a:pPr>
             <a:r>
-              <a:t>数据处理与决策流程</a:t>
-            </a:r>
-          </a:p>
-        </p:txBody>
-      </p:sp>
-      <p:sp>
-        <p:nvSpPr>
-          <p:cNvPr id="5" name="TextBox 4"/>
+              <a:t>（界面）情感倾诉交互</a:t>
+            </a:r>
+          </a:p>
+        </p:txBody>
+      </p:sp>
+      <p:pic>
+        <p:nvPicPr>
+          <p:cNvPr id="5" name="Picture 4" descr="ppt_emotion_input.png"/>
+          <p:cNvPicPr>
+            <a:picLocks noChangeAspect="1"/>
+          </p:cNvPicPr>
+          <p:nvPr/>
+        </p:nvPicPr>
+        <p:blipFill>
+          <a:blip r:embed="rId2"/>
+          <a:stretch>
+            <a:fillRect/>
+          </a:stretch>
+        </p:blipFill>
+        <p:spPr>
+          <a:xfrm>
+            <a:off x="292608" y="1024128"/>
+            <a:ext cx="8549640" cy="7272204"/>
+          </a:xfrm>
+          <a:prstGeom prst="rect">
+            <a:avLst/>
+          </a:prstGeom>
+        </p:spPr>
+      </p:pic>
+      <p:sp>
+        <p:nvSpPr>
+          <p:cNvPr id="6" name="TextBox 5"/>
           <p:cNvSpPr txBox="1"/>
           <p:nvPr/>
         </p:nvSpPr>
         <p:spPr>
           <a:xfrm>
-            <a:off x="502920" y="1325880"/>
-            <a:ext cx="8138160" cy="3840480"/>
+            <a:off x="292608" y="4617720"/>
+            <a:ext cx="8549640" cy="411480"/>
           </a:xfrm>
           <a:prstGeom prst="rect">
             <a:avLst/>
@@ -3790,83 +3805,20 @@
           <a:noFill/>
         </p:spPr>
         <p:txBody>
-          <a:bodyPr wrap="square">
+          <a:bodyPr wrap="none">
             <a:spAutoFit/>
           </a:bodyPr>
           <a:lstStyle/>
           <a:p>
-            <a:pPr>
-              <a:spcAft>
-                <a:spcPts val="600"/>
-              </a:spcAft>
-              <a:defRPr sz="1400">
-                <a:solidFill>
-                  <a:srgbClr val="1E1E1E"/>
-                </a:solidFill>
-              </a:defRPr>
-            </a:pPr>
-            <a:r>
-              <a:t>1. 采集感知帧：摄像头骨架 / 滑块仿真 / 可穿戴 JSON</a:t>
-            </a:r>
-          </a:p>
-          <a:p>
-            <a:pPr>
-              <a:spcAft>
-                <a:spcPts val="600"/>
-              </a:spcAft>
-              <a:defRPr sz="1400">
-                <a:solidFill>
-                  <a:srgbClr val="1E1E1E"/>
-                </a:solidFill>
-              </a:defRPr>
-            </a:pPr>
-            <a:r>
-              <a:t>2. FallDetector 更新跌倒分数，Emotion/Health 更新标签</a:t>
-            </a:r>
-          </a:p>
-          <a:p>
-            <a:pPr>
-              <a:spcAft>
-                <a:spcPts val="600"/>
-              </a:spcAft>
-              <a:defRPr sz="1400">
-                <a:solidFill>
-                  <a:srgbClr val="1E1E1E"/>
-                </a:solidFill>
-              </a:defRPr>
-            </a:pPr>
-            <a:r>
-              <a:t>3. RiskEngine 评估等级，状态机切换</a:t>
-            </a:r>
-          </a:p>
-          <a:p>
-            <a:pPr>
-              <a:spcAft>
-                <a:spcPts val="600"/>
-              </a:spcAft>
-              <a:defRPr sz="1400">
-                <a:solidFill>
-                  <a:srgbClr val="1E1E1E"/>
-                </a:solidFill>
-              </a:defRPr>
-            </a:pPr>
-            <a:r>
-              <a:t>4. DialogueManager 生成回复，CarePlanner 输出 RobotAction 序列</a:t>
-            </a:r>
-          </a:p>
-          <a:p>
-            <a:pPr>
-              <a:spcAft>
-                <a:spcPts val="600"/>
-              </a:spcAft>
-              <a:defRPr sz="1400">
-                <a:solidFill>
-                  <a:srgbClr val="1E1E1E"/>
-                </a:solidFill>
-              </a:defRPr>
-            </a:pPr>
-            <a:r>
-              <a:t>5. RobotAdapter 下发至仿真日志或 ROS2 /care/robot_cmd</a:t>
+            <a:pPr algn="ctr">
+              <a:defRPr sz="1100">
+                <a:solidFill>
+                  <a:srgbClr val="505050"/>
+                </a:solidFill>
+              </a:defRPr>
+            </a:pPr>
+            <a:r>
+              <a:t>老人输入「最近有点孤独，睡不太好」→ 系统识别情绪低落并生成安抚话术</a:t>
             </a:r>
           </a:p>
         </p:txBody>
@@ -3995,7 +3947,7 @@
         </p:nvSpPr>
         <p:spPr>
           <a:xfrm>
-            <a:off x="502920" y="1828800"/>
+            <a:off x="502920" y="685800"/>
             <a:ext cx="8138160" cy="731520"/>
           </a:xfrm>
           <a:prstGeom prst="rect">
@@ -4009,15 +3961,15 @@
           </a:bodyPr>
           <a:lstStyle/>
           <a:p>
-            <a:pPr algn="ctr">
-              <a:defRPr sz="3200" b="1">
+            <a:pPr algn="l">
+              <a:defRPr sz="2600" b="1">
                 <a:solidFill>
                   <a:srgbClr val="1E1E1E"/>
                 </a:solidFill>
               </a:defRPr>
             </a:pPr>
             <a:r>
-              <a:t>第三部分</a:t>
+              <a:t>数据处理与决策流程</a:t>
             </a:r>
           </a:p>
         </p:txBody>
@@ -4030,8 +3982,8 @@
         </p:nvSpPr>
         <p:spPr>
           <a:xfrm>
-            <a:off x="502920" y="2606040"/>
-            <a:ext cx="8138160" cy="731520"/>
+            <a:off x="502920" y="1325880"/>
+            <a:ext cx="8138160" cy="3840480"/>
           </a:xfrm>
           <a:prstGeom prst="rect">
             <a:avLst/>
@@ -4039,20 +3991,83 @@
           <a:noFill/>
         </p:spPr>
         <p:txBody>
-          <a:bodyPr wrap="none">
+          <a:bodyPr wrap="square">
             <a:spAutoFit/>
           </a:bodyPr>
           <a:lstStyle/>
           <a:p>
-            <a:pPr algn="ctr">
-              <a:defRPr sz="2200" b="1">
-                <a:solidFill>
-                  <a:srgbClr val="143278"/>
-                </a:solidFill>
-              </a:defRPr>
-            </a:pPr>
-            <a:r>
-              <a:t>系统实现 · 评测 · 演示</a:t>
+            <a:pPr>
+              <a:spcAft>
+                <a:spcPts val="600"/>
+              </a:spcAft>
+              <a:defRPr sz="1400">
+                <a:solidFill>
+                  <a:srgbClr val="1E1E1E"/>
+                </a:solidFill>
+              </a:defRPr>
+            </a:pPr>
+            <a:r>
+              <a:t>1. 采集感知帧：摄像头骨架 / 滑块仿真 / 可穿戴 JSON</a:t>
+            </a:r>
+          </a:p>
+          <a:p>
+            <a:pPr>
+              <a:spcAft>
+                <a:spcPts val="600"/>
+              </a:spcAft>
+              <a:defRPr sz="1400">
+                <a:solidFill>
+                  <a:srgbClr val="1E1E1E"/>
+                </a:solidFill>
+              </a:defRPr>
+            </a:pPr>
+            <a:r>
+              <a:t>2. FallDetector 更新跌倒分数，Emotion/Health 更新标签</a:t>
+            </a:r>
+          </a:p>
+          <a:p>
+            <a:pPr>
+              <a:spcAft>
+                <a:spcPts val="600"/>
+              </a:spcAft>
+              <a:defRPr sz="1400">
+                <a:solidFill>
+                  <a:srgbClr val="1E1E1E"/>
+                </a:solidFill>
+              </a:defRPr>
+            </a:pPr>
+            <a:r>
+              <a:t>3. RiskEngine 评估等级，状态机切换</a:t>
+            </a:r>
+          </a:p>
+          <a:p>
+            <a:pPr>
+              <a:spcAft>
+                <a:spcPts val="600"/>
+              </a:spcAft>
+              <a:defRPr sz="1400">
+                <a:solidFill>
+                  <a:srgbClr val="1E1E1E"/>
+                </a:solidFill>
+              </a:defRPr>
+            </a:pPr>
+            <a:r>
+              <a:t>4. DialogueManager 生成回复，CarePlanner 输出 RobotAction 序列</a:t>
+            </a:r>
+          </a:p>
+          <a:p>
+            <a:pPr>
+              <a:spcAft>
+                <a:spcPts val="600"/>
+              </a:spcAft>
+              <a:defRPr sz="1400">
+                <a:solidFill>
+                  <a:srgbClr val="1E1E1E"/>
+                </a:solidFill>
+              </a:defRPr>
+            </a:pPr>
+            <a:r>
+              <a:t>5. RobotAdapter 下发至仿真日志或 ROS2 /care/robot_cmd</a:t>
             </a:r>
           </a:p>
         </p:txBody>
@@ -4181,7 +4196,7 @@
         </p:nvSpPr>
         <p:spPr>
           <a:xfrm>
-            <a:off x="502920" y="685800"/>
+            <a:off x="502920" y="1828800"/>
             <a:ext cx="8138160" cy="731520"/>
           </a:xfrm>
           <a:prstGeom prst="rect">
@@ -4195,15 +4210,15 @@
           </a:bodyPr>
           <a:lstStyle/>
           <a:p>
-            <a:pPr algn="l">
-              <a:defRPr sz="2600" b="1">
+            <a:pPr algn="ctr">
+              <a:defRPr sz="3200" b="1">
                 <a:solidFill>
                   <a:srgbClr val="1E1E1E"/>
                 </a:solidFill>
               </a:defRPr>
             </a:pPr>
             <a:r>
-              <a:t>Web 控制台与视觉演示</a:t>
+              <a:t>第三部分</a:t>
             </a:r>
           </a:p>
         </p:txBody>
@@ -4216,8 +4231,8 @@
         </p:nvSpPr>
         <p:spPr>
           <a:xfrm>
-            <a:off x="502920" y="1325880"/>
-            <a:ext cx="8138160" cy="3840480"/>
+            <a:off x="502920" y="2606040"/>
+            <a:ext cx="8138160" cy="731520"/>
           </a:xfrm>
           <a:prstGeom prst="rect">
             <a:avLst/>
@@ -4225,83 +4240,20 @@
           <a:noFill/>
         </p:spPr>
         <p:txBody>
-          <a:bodyPr wrap="square">
+          <a:bodyPr wrap="none">
             <a:spAutoFit/>
           </a:bodyPr>
           <a:lstStyle/>
           <a:p>
-            <a:pPr>
-              <a:spcAft>
-                <a:spcPts val="600"/>
-              </a:spcAft>
-              <a:defRPr sz="1400">
-                <a:solidFill>
-                  <a:srgbClr val="1E1E1E"/>
-                </a:solidFill>
-              </a:defRPr>
-            </a:pPr>
-            <a:r>
-              <a:t>FastAPI + 现代化 Web 前端，浏览器即可答辩演示</a:t>
-            </a:r>
-          </a:p>
-          <a:p>
-            <a:pPr>
-              <a:spcAft>
-                <a:spcPts val="600"/>
-              </a:spcAft>
-              <a:defRPr sz="1400">
-                <a:solidFill>
-                  <a:srgbClr val="1E1E1E"/>
-                </a:solidFill>
-              </a:defRPr>
-            </a:pPr>
-            <a:r>
-              <a:t>功能：感知调节 · 实时风险仪表盘 · 对话日志 · 机器人指令流</a:t>
-            </a:r>
-          </a:p>
-          <a:p>
-            <a:pPr>
-              <a:spcAft>
-                <a:spcPts val="600"/>
-              </a:spcAft>
-              <a:defRPr sz="1400">
-                <a:solidFill>
-                  <a:srgbClr val="1E1E1E"/>
-                </a:solidFill>
-              </a:defRPr>
-            </a:pPr>
-            <a:r>
-              <a:t>摄像头：打开 → 分析当前帧 → MediaPipe 骨架叠加</a:t>
-            </a:r>
-          </a:p>
-          <a:p>
-            <a:pPr>
-              <a:spcAft>
-                <a:spcPts val="600"/>
-              </a:spcAft>
-              <a:defRPr sz="1400">
-                <a:solidFill>
-                  <a:srgbClr val="1E1E1E"/>
-                </a:solidFill>
-              </a:defRPr>
-            </a:pPr>
-            <a:r>
-              <a:t>一键剧本：日常监测 → 老人倾诉 → 跌倒 → 紧急呼叫</a:t>
-            </a:r>
-          </a:p>
-          <a:p>
-            <a:pPr>
-              <a:spcAft>
-                <a:spcPts val="600"/>
-              </a:spcAft>
-              <a:defRPr sz="1400">
-                <a:solidFill>
-                  <a:srgbClr val="1E1E1E"/>
-                </a:solidFill>
-              </a:defRPr>
-            </a:pPr>
-            <a:r>
-              <a:t>启动：bash scripts/run_web.sh  →  http://localhost:8765</a:t>
+            <a:pPr algn="ctr">
+              <a:defRPr sz="2200" b="1">
+                <a:solidFill>
+                  <a:srgbClr val="143278"/>
+                </a:solidFill>
+              </a:defRPr>
+            </a:pPr>
+            <a:r>
+              <a:t>系统实现 · 评测 · 演示</a:t>
             </a:r>
           </a:p>
         </p:txBody>
@@ -4315,6 +4267,1461 @@
 </file>
 
 <file path=ppt/slides/slide14.xml><?xml version="1.0" encoding="utf-8"?>
+<p:sld xmlns:a="http://schemas.openxmlformats.org/drawingml/2006/main" xmlns:p="http://schemas.openxmlformats.org/presentationml/2006/main" xmlns:r="http://schemas.openxmlformats.org/officeDocument/2006/relationships">
+  <p:cSld>
+    <p:bg>
+      <p:bgPr>
+        <a:solidFill>
+          <a:srgbClr val="FFFFFF"/>
+        </a:solidFill>
+        <a:effectLst/>
+      </p:bgPr>
+    </p:bg>
+    <p:spTree>
+      <p:nvGrpSpPr>
+        <p:cNvPr id="1" name=""/>
+        <p:cNvGrpSpPr/>
+        <p:nvPr/>
+      </p:nvGrpSpPr>
+      <p:grpSpPr/>
+      <p:sp>
+        <p:nvSpPr>
+          <p:cNvPr id="2" name="Rectangle 1"/>
+          <p:cNvSpPr/>
+          <p:nvPr/>
+        </p:nvSpPr>
+        <p:spPr>
+          <a:xfrm>
+            <a:off x="0" y="0"/>
+            <a:ext cx="9144000" cy="502920"/>
+          </a:xfrm>
+          <a:prstGeom prst="rect">
+            <a:avLst/>
+          </a:prstGeom>
+          <a:solidFill>
+            <a:srgbClr val="143278"/>
+          </a:solidFill>
+          <a:ln>
+            <a:noFill/>
+          </a:ln>
+        </p:spPr>
+        <p:style>
+          <a:lnRef idx="1">
+            <a:schemeClr val="accent1"/>
+          </a:lnRef>
+          <a:fillRef idx="3">
+            <a:schemeClr val="accent1"/>
+          </a:fillRef>
+          <a:effectRef idx="2">
+            <a:schemeClr val="accent1"/>
+          </a:effectRef>
+          <a:fontRef idx="minor">
+            <a:schemeClr val="lt1"/>
+          </a:fontRef>
+        </p:style>
+        <p:txBody>
+          <a:bodyPr rtlCol="0" anchor="ctr"/>
+          <a:lstStyle/>
+          <a:p>
+            <a:pPr algn="ctr"/>
+          </a:p>
+        </p:txBody>
+      </p:sp>
+      <p:sp>
+        <p:nvSpPr>
+          <p:cNvPr id="3" name="TextBox 2"/>
+          <p:cNvSpPr txBox="1"/>
+          <p:nvPr/>
+        </p:nvSpPr>
+        <p:spPr>
+          <a:xfrm>
+            <a:off x="137160" y="73152"/>
+            <a:ext cx="8869680" cy="411480"/>
+          </a:xfrm>
+          <a:prstGeom prst="rect">
+            <a:avLst/>
+          </a:prstGeom>
+          <a:noFill/>
+        </p:spPr>
+        <p:txBody>
+          <a:bodyPr wrap="none">
+            <a:spAutoFit/>
+          </a:bodyPr>
+          <a:lstStyle/>
+          <a:p>
+            <a:pPr>
+              <a:defRPr sz="1100" b="1">
+                <a:solidFill>
+                  <a:srgbClr val="FFFFFF"/>
+                </a:solidFill>
+              </a:defRPr>
+            </a:pPr>
+            <a:r>
+              <a:t>第二十六届中国机器人及人工智能大赛</a:t>
+            </a:r>
+          </a:p>
+          <a:p>
+            <a:pPr>
+              <a:defRPr sz="1000">
+                <a:solidFill>
+                  <a:srgbClr val="C8DCFF"/>
+                </a:solidFill>
+              </a:defRPr>
+            </a:pPr>
+            <a:r>
+              <a:t>机器人创新赛道</a:t>
+            </a:r>
+          </a:p>
+        </p:txBody>
+      </p:sp>
+      <p:sp>
+        <p:nvSpPr>
+          <p:cNvPr id="4" name="TextBox 3"/>
+          <p:cNvSpPr txBox="1"/>
+          <p:nvPr/>
+        </p:nvSpPr>
+        <p:spPr>
+          <a:xfrm>
+            <a:off x="502920" y="685800"/>
+            <a:ext cx="8138160" cy="731520"/>
+          </a:xfrm>
+          <a:prstGeom prst="rect">
+            <a:avLst/>
+          </a:prstGeom>
+          <a:noFill/>
+        </p:spPr>
+        <p:txBody>
+          <a:bodyPr wrap="none">
+            <a:spAutoFit/>
+          </a:bodyPr>
+          <a:lstStyle/>
+          <a:p>
+            <a:pPr algn="l">
+              <a:defRPr sz="2600" b="1">
+                <a:solidFill>
+                  <a:srgbClr val="1E1E1E"/>
+                </a:solidFill>
+              </a:defRPr>
+            </a:pPr>
+            <a:r>
+              <a:t>Web 控制台（CareCompanion）</a:t>
+            </a:r>
+          </a:p>
+        </p:txBody>
+      </p:sp>
+      <p:sp>
+        <p:nvSpPr>
+          <p:cNvPr id="5" name="TextBox 4"/>
+          <p:cNvSpPr txBox="1"/>
+          <p:nvPr/>
+        </p:nvSpPr>
+        <p:spPr>
+          <a:xfrm>
+            <a:off x="502920" y="1234440"/>
+            <a:ext cx="8138160" cy="3840480"/>
+          </a:xfrm>
+          <a:prstGeom prst="rect">
+            <a:avLst/>
+          </a:prstGeom>
+          <a:noFill/>
+        </p:spPr>
+        <p:txBody>
+          <a:bodyPr wrap="square">
+            <a:spAutoFit/>
+          </a:bodyPr>
+          <a:lstStyle/>
+          <a:p>
+            <a:pPr>
+              <a:spcAft>
+                <a:spcPts val="600"/>
+              </a:spcAft>
+              <a:defRPr sz="1300">
+                <a:solidFill>
+                  <a:srgbClr val="1E1E1E"/>
+                </a:solidFill>
+              </a:defRPr>
+            </a:pPr>
+            <a:r>
+              <a:t>访问地址：http://localhost:8765（bash scripts/run_web.sh）</a:t>
+            </a:r>
+          </a:p>
+          <a:p>
+            <a:pPr>
+              <a:spcAft>
+                <a:spcPts val="600"/>
+              </a:spcAft>
+              <a:defRPr sz="1300">
+                <a:solidFill>
+                  <a:srgbClr val="1E1E1E"/>
+                </a:solidFill>
+              </a:defRPr>
+            </a:pPr>
+            <a:r>
+              <a:t>技术栈：FastAPI + 浏览器前端，支持答辩现场演示</a:t>
+            </a:r>
+          </a:p>
+          <a:p>
+            <a:pPr>
+              <a:spcAft>
+                <a:spcPts val="600"/>
+              </a:spcAft>
+              <a:defRPr sz="1300">
+                <a:solidFill>
+                  <a:srgbClr val="1E1E1E"/>
+                </a:solidFill>
+              </a:defRPr>
+            </a:pPr>
+            <a:r>
+              <a:t>以下截图为实际运行界面（2026-05-27 答辩预演录制）</a:t>
+            </a:r>
+          </a:p>
+        </p:txBody>
+      </p:sp>
+    </p:spTree>
+  </p:cSld>
+  <p:clrMapOvr>
+    <a:masterClrMapping/>
+  </p:clrMapOvr>
+</p:sld>
+</file>
+
+<file path=ppt/slides/slide15.xml><?xml version="1.0" encoding="utf-8"?>
+<p:sld xmlns:a="http://schemas.openxmlformats.org/drawingml/2006/main" xmlns:p="http://schemas.openxmlformats.org/presentationml/2006/main" xmlns:r="http://schemas.openxmlformats.org/officeDocument/2006/relationships">
+  <p:cSld>
+    <p:bg>
+      <p:bgPr>
+        <a:solidFill>
+          <a:srgbClr val="FFFFFF"/>
+        </a:solidFill>
+        <a:effectLst/>
+      </p:bgPr>
+    </p:bg>
+    <p:spTree>
+      <p:nvGrpSpPr>
+        <p:cNvPr id="1" name=""/>
+        <p:cNvGrpSpPr/>
+        <p:nvPr/>
+      </p:nvGrpSpPr>
+      <p:grpSpPr/>
+      <p:sp>
+        <p:nvSpPr>
+          <p:cNvPr id="2" name="Rectangle 1"/>
+          <p:cNvSpPr/>
+          <p:nvPr/>
+        </p:nvSpPr>
+        <p:spPr>
+          <a:xfrm>
+            <a:off x="0" y="0"/>
+            <a:ext cx="9144000" cy="502920"/>
+          </a:xfrm>
+          <a:prstGeom prst="rect">
+            <a:avLst/>
+          </a:prstGeom>
+          <a:solidFill>
+            <a:srgbClr val="143278"/>
+          </a:solidFill>
+          <a:ln>
+            <a:noFill/>
+          </a:ln>
+        </p:spPr>
+        <p:style>
+          <a:lnRef idx="1">
+            <a:schemeClr val="accent1"/>
+          </a:lnRef>
+          <a:fillRef idx="3">
+            <a:schemeClr val="accent1"/>
+          </a:fillRef>
+          <a:effectRef idx="2">
+            <a:schemeClr val="accent1"/>
+          </a:effectRef>
+          <a:fontRef idx="minor">
+            <a:schemeClr val="lt1"/>
+          </a:fontRef>
+        </p:style>
+        <p:txBody>
+          <a:bodyPr rtlCol="0" anchor="ctr"/>
+          <a:lstStyle/>
+          <a:p>
+            <a:pPr algn="ctr"/>
+          </a:p>
+        </p:txBody>
+      </p:sp>
+      <p:sp>
+        <p:nvSpPr>
+          <p:cNvPr id="3" name="TextBox 2"/>
+          <p:cNvSpPr txBox="1"/>
+          <p:nvPr/>
+        </p:nvSpPr>
+        <p:spPr>
+          <a:xfrm>
+            <a:off x="137160" y="73152"/>
+            <a:ext cx="8869680" cy="411480"/>
+          </a:xfrm>
+          <a:prstGeom prst="rect">
+            <a:avLst/>
+          </a:prstGeom>
+          <a:noFill/>
+        </p:spPr>
+        <p:txBody>
+          <a:bodyPr wrap="none">
+            <a:spAutoFit/>
+          </a:bodyPr>
+          <a:lstStyle/>
+          <a:p>
+            <a:pPr>
+              <a:defRPr sz="1100" b="1">
+                <a:solidFill>
+                  <a:srgbClr val="FFFFFF"/>
+                </a:solidFill>
+              </a:defRPr>
+            </a:pPr>
+            <a:r>
+              <a:t>第二十六届中国机器人及人工智能大赛</a:t>
+            </a:r>
+          </a:p>
+          <a:p>
+            <a:pPr>
+              <a:defRPr sz="1000">
+                <a:solidFill>
+                  <a:srgbClr val="C8DCFF"/>
+                </a:solidFill>
+              </a:defRPr>
+            </a:pPr>
+            <a:r>
+              <a:t>机器人创新赛道</a:t>
+            </a:r>
+          </a:p>
+        </p:txBody>
+      </p:sp>
+      <p:sp>
+        <p:nvSpPr>
+          <p:cNvPr id="4" name="TextBox 3"/>
+          <p:cNvSpPr txBox="1"/>
+          <p:nvPr/>
+        </p:nvSpPr>
+        <p:spPr>
+          <a:xfrm>
+            <a:off x="502920" y="685800"/>
+            <a:ext cx="8138160" cy="731520"/>
+          </a:xfrm>
+          <a:prstGeom prst="rect">
+            <a:avLst/>
+          </a:prstGeom>
+          <a:noFill/>
+        </p:spPr>
+        <p:txBody>
+          <a:bodyPr wrap="none">
+            <a:spAutoFit/>
+          </a:bodyPr>
+          <a:lstStyle/>
+          <a:p>
+            <a:pPr algn="l">
+              <a:defRPr sz="2600" b="1">
+                <a:solidFill>
+                  <a:srgbClr val="1E1E1E"/>
+                </a:solidFill>
+              </a:defRPr>
+            </a:pPr>
+            <a:r>
+              <a:t>系统界面：老人倾诉场景（演示剧本）</a:t>
+            </a:r>
+          </a:p>
+        </p:txBody>
+      </p:sp>
+      <p:pic>
+        <p:nvPicPr>
+          <p:cNvPr id="5" name="Picture 4" descr="ppt_full_dashboard.png"/>
+          <p:cNvPicPr>
+            <a:picLocks noChangeAspect="1"/>
+          </p:cNvPicPr>
+          <p:nvPr/>
+        </p:nvPicPr>
+        <p:blipFill>
+          <a:blip r:embed="rId2"/>
+          <a:stretch>
+            <a:fillRect/>
+          </a:stretch>
+        </p:blipFill>
+        <p:spPr>
+          <a:xfrm>
+            <a:off x="292608" y="1024128"/>
+            <a:ext cx="8549640" cy="4458504"/>
+          </a:xfrm>
+          <a:prstGeom prst="rect">
+            <a:avLst/>
+          </a:prstGeom>
+        </p:spPr>
+      </p:pic>
+      <p:sp>
+        <p:nvSpPr>
+          <p:cNvPr id="6" name="TextBox 5"/>
+          <p:cNvSpPr txBox="1"/>
+          <p:nvPr/>
+        </p:nvSpPr>
+        <p:spPr>
+          <a:xfrm>
+            <a:off x="292608" y="4617720"/>
+            <a:ext cx="8549640" cy="411480"/>
+          </a:xfrm>
+          <a:prstGeom prst="rect">
+            <a:avLst/>
+          </a:prstGeom>
+          <a:noFill/>
+        </p:spPr>
+        <p:txBody>
+          <a:bodyPr wrap="none">
+            <a:spAutoFit/>
+          </a:bodyPr>
+          <a:lstStyle/>
+          <a:p>
+            <a:pPr algn="ctr">
+              <a:defRPr sz="1100">
+                <a:solidFill>
+                  <a:srgbClr val="505050"/>
+                </a:solidFill>
+              </a:defRPr>
+            </a:pPr>
+            <a:r>
+              <a:t>演示场景「老人倾诉」· 风险 0.23 · 机器人主动安抚回复</a:t>
+            </a:r>
+          </a:p>
+        </p:txBody>
+      </p:sp>
+    </p:spTree>
+  </p:cSld>
+  <p:clrMapOvr>
+    <a:masterClrMapping/>
+  </p:clrMapOvr>
+</p:sld>
+</file>
+
+<file path=ppt/slides/slide16.xml><?xml version="1.0" encoding="utf-8"?>
+<p:sld xmlns:a="http://schemas.openxmlformats.org/drawingml/2006/main" xmlns:p="http://schemas.openxmlformats.org/presentationml/2006/main" xmlns:r="http://schemas.openxmlformats.org/officeDocument/2006/relationships">
+  <p:cSld>
+    <p:bg>
+      <p:bgPr>
+        <a:solidFill>
+          <a:srgbClr val="FFFFFF"/>
+        </a:solidFill>
+        <a:effectLst/>
+      </p:bgPr>
+    </p:bg>
+    <p:spTree>
+      <p:nvGrpSpPr>
+        <p:cNvPr id="1" name=""/>
+        <p:cNvGrpSpPr/>
+        <p:nvPr/>
+      </p:nvGrpSpPr>
+      <p:grpSpPr/>
+      <p:sp>
+        <p:nvSpPr>
+          <p:cNvPr id="2" name="Rectangle 1"/>
+          <p:cNvSpPr/>
+          <p:nvPr/>
+        </p:nvSpPr>
+        <p:spPr>
+          <a:xfrm>
+            <a:off x="0" y="0"/>
+            <a:ext cx="9144000" cy="502920"/>
+          </a:xfrm>
+          <a:prstGeom prst="rect">
+            <a:avLst/>
+          </a:prstGeom>
+          <a:solidFill>
+            <a:srgbClr val="143278"/>
+          </a:solidFill>
+          <a:ln>
+            <a:noFill/>
+          </a:ln>
+        </p:spPr>
+        <p:style>
+          <a:lnRef idx="1">
+            <a:schemeClr val="accent1"/>
+          </a:lnRef>
+          <a:fillRef idx="3">
+            <a:schemeClr val="accent1"/>
+          </a:fillRef>
+          <a:effectRef idx="2">
+            <a:schemeClr val="accent1"/>
+          </a:effectRef>
+          <a:fontRef idx="minor">
+            <a:schemeClr val="lt1"/>
+          </a:fontRef>
+        </p:style>
+        <p:txBody>
+          <a:bodyPr rtlCol="0" anchor="ctr"/>
+          <a:lstStyle/>
+          <a:p>
+            <a:pPr algn="ctr"/>
+          </a:p>
+        </p:txBody>
+      </p:sp>
+      <p:sp>
+        <p:nvSpPr>
+          <p:cNvPr id="3" name="TextBox 2"/>
+          <p:cNvSpPr txBox="1"/>
+          <p:nvPr/>
+        </p:nvSpPr>
+        <p:spPr>
+          <a:xfrm>
+            <a:off x="137160" y="73152"/>
+            <a:ext cx="8869680" cy="411480"/>
+          </a:xfrm>
+          <a:prstGeom prst="rect">
+            <a:avLst/>
+          </a:prstGeom>
+          <a:noFill/>
+        </p:spPr>
+        <p:txBody>
+          <a:bodyPr wrap="none">
+            <a:spAutoFit/>
+          </a:bodyPr>
+          <a:lstStyle/>
+          <a:p>
+            <a:pPr>
+              <a:defRPr sz="1100" b="1">
+                <a:solidFill>
+                  <a:srgbClr val="FFFFFF"/>
+                </a:solidFill>
+              </a:defRPr>
+            </a:pPr>
+            <a:r>
+              <a:t>第二十六届中国机器人及人工智能大赛</a:t>
+            </a:r>
+          </a:p>
+          <a:p>
+            <a:pPr>
+              <a:defRPr sz="1000">
+                <a:solidFill>
+                  <a:srgbClr val="C8DCFF"/>
+                </a:solidFill>
+              </a:defRPr>
+            </a:pPr>
+            <a:r>
+              <a:t>机器人创新赛道</a:t>
+            </a:r>
+          </a:p>
+        </p:txBody>
+      </p:sp>
+      <p:sp>
+        <p:nvSpPr>
+          <p:cNvPr id="4" name="TextBox 3"/>
+          <p:cNvSpPr txBox="1"/>
+          <p:nvPr/>
+        </p:nvSpPr>
+        <p:spPr>
+          <a:xfrm>
+            <a:off x="502920" y="685800"/>
+            <a:ext cx="8138160" cy="731520"/>
+          </a:xfrm>
+          <a:prstGeom prst="rect">
+            <a:avLst/>
+          </a:prstGeom>
+          <a:noFill/>
+        </p:spPr>
+        <p:txBody>
+          <a:bodyPr wrap="none">
+            <a:spAutoFit/>
+          </a:bodyPr>
+          <a:lstStyle/>
+          <a:p>
+            <a:pPr algn="l">
+              <a:defRPr sz="2600" b="1">
+                <a:solidFill>
+                  <a:srgbClr val="1E1E1E"/>
+                </a:solidFill>
+              </a:defRPr>
+            </a:pPr>
+            <a:r>
+              <a:t>系统界面：风险决策仪表盘</a:t>
+            </a:r>
+          </a:p>
+        </p:txBody>
+      </p:sp>
+      <p:pic>
+        <p:nvPicPr>
+          <p:cNvPr id="5" name="Picture 4" descr="ppt_risk_panel.png"/>
+          <p:cNvPicPr>
+            <a:picLocks noChangeAspect="1"/>
+          </p:cNvPicPr>
+          <p:nvPr/>
+        </p:nvPicPr>
+        <p:blipFill>
+          <a:blip r:embed="rId2"/>
+          <a:stretch>
+            <a:fillRect/>
+          </a:stretch>
+        </p:blipFill>
+        <p:spPr>
+          <a:xfrm>
+            <a:off x="292608" y="1024128"/>
+            <a:ext cx="8549640" cy="10180036"/>
+          </a:xfrm>
+          <a:prstGeom prst="rect">
+            <a:avLst/>
+          </a:prstGeom>
+        </p:spPr>
+      </p:pic>
+      <p:sp>
+        <p:nvSpPr>
+          <p:cNvPr id="6" name="TextBox 5"/>
+          <p:cNvSpPr txBox="1"/>
+          <p:nvPr/>
+        </p:nvSpPr>
+        <p:spPr>
+          <a:xfrm>
+            <a:off x="292608" y="4617720"/>
+            <a:ext cx="8549640" cy="411480"/>
+          </a:xfrm>
+          <a:prstGeom prst="rect">
+            <a:avLst/>
+          </a:prstGeom>
+          <a:noFill/>
+        </p:spPr>
+        <p:txBody>
+          <a:bodyPr wrap="none">
+            <a:spAutoFit/>
+          </a:bodyPr>
+          <a:lstStyle/>
+          <a:p>
+            <a:pPr algn="ctr">
+              <a:defRPr sz="1100">
+                <a:solidFill>
+                  <a:srgbClr val="505050"/>
+                </a:solidFill>
+              </a:defRPr>
+            </a:pPr>
+            <a:r>
+              <a:t>多模态融合输出：风险分数、因素、机器人回应及四项监测指标</a:t>
+            </a:r>
+          </a:p>
+        </p:txBody>
+      </p:sp>
+    </p:spTree>
+  </p:cSld>
+  <p:clrMapOvr>
+    <a:masterClrMapping/>
+  </p:clrMapOvr>
+</p:sld>
+</file>
+
+<file path=ppt/slides/slide17.xml><?xml version="1.0" encoding="utf-8"?>
+<p:sld xmlns:a="http://schemas.openxmlformats.org/drawingml/2006/main" xmlns:p="http://schemas.openxmlformats.org/presentationml/2006/main" xmlns:r="http://schemas.openxmlformats.org/officeDocument/2006/relationships">
+  <p:cSld>
+    <p:bg>
+      <p:bgPr>
+        <a:solidFill>
+          <a:srgbClr val="FFFFFF"/>
+        </a:solidFill>
+        <a:effectLst/>
+      </p:bgPr>
+    </p:bg>
+    <p:spTree>
+      <p:nvGrpSpPr>
+        <p:cNvPr id="1" name=""/>
+        <p:cNvGrpSpPr/>
+        <p:nvPr/>
+      </p:nvGrpSpPr>
+      <p:grpSpPr/>
+      <p:sp>
+        <p:nvSpPr>
+          <p:cNvPr id="2" name="Rectangle 1"/>
+          <p:cNvSpPr/>
+          <p:nvPr/>
+        </p:nvSpPr>
+        <p:spPr>
+          <a:xfrm>
+            <a:off x="0" y="0"/>
+            <a:ext cx="9144000" cy="502920"/>
+          </a:xfrm>
+          <a:prstGeom prst="rect">
+            <a:avLst/>
+          </a:prstGeom>
+          <a:solidFill>
+            <a:srgbClr val="143278"/>
+          </a:solidFill>
+          <a:ln>
+            <a:noFill/>
+          </a:ln>
+        </p:spPr>
+        <p:style>
+          <a:lnRef idx="1">
+            <a:schemeClr val="accent1"/>
+          </a:lnRef>
+          <a:fillRef idx="3">
+            <a:schemeClr val="accent1"/>
+          </a:fillRef>
+          <a:effectRef idx="2">
+            <a:schemeClr val="accent1"/>
+          </a:effectRef>
+          <a:fontRef idx="minor">
+            <a:schemeClr val="lt1"/>
+          </a:fontRef>
+        </p:style>
+        <p:txBody>
+          <a:bodyPr rtlCol="0" anchor="ctr"/>
+          <a:lstStyle/>
+          <a:p>
+            <a:pPr algn="ctr"/>
+          </a:p>
+        </p:txBody>
+      </p:sp>
+      <p:sp>
+        <p:nvSpPr>
+          <p:cNvPr id="3" name="TextBox 2"/>
+          <p:cNvSpPr txBox="1"/>
+          <p:nvPr/>
+        </p:nvSpPr>
+        <p:spPr>
+          <a:xfrm>
+            <a:off x="137160" y="73152"/>
+            <a:ext cx="8869680" cy="411480"/>
+          </a:xfrm>
+          <a:prstGeom prst="rect">
+            <a:avLst/>
+          </a:prstGeom>
+          <a:noFill/>
+        </p:spPr>
+        <p:txBody>
+          <a:bodyPr wrap="none">
+            <a:spAutoFit/>
+          </a:bodyPr>
+          <a:lstStyle/>
+          <a:p>
+            <a:pPr>
+              <a:defRPr sz="1100" b="1">
+                <a:solidFill>
+                  <a:srgbClr val="FFFFFF"/>
+                </a:solidFill>
+              </a:defRPr>
+            </a:pPr>
+            <a:r>
+              <a:t>第二十六届中国机器人及人工智能大赛</a:t>
+            </a:r>
+          </a:p>
+          <a:p>
+            <a:pPr>
+              <a:defRPr sz="1000">
+                <a:solidFill>
+                  <a:srgbClr val="C8DCFF"/>
+                </a:solidFill>
+              </a:defRPr>
+            </a:pPr>
+            <a:r>
+              <a:t>机器人创新赛道</a:t>
+            </a:r>
+          </a:p>
+        </p:txBody>
+      </p:sp>
+      <p:sp>
+        <p:nvSpPr>
+          <p:cNvPr id="4" name="TextBox 3"/>
+          <p:cNvSpPr txBox="1"/>
+          <p:nvPr/>
+        </p:nvSpPr>
+        <p:spPr>
+          <a:xfrm>
+            <a:off x="502920" y="685800"/>
+            <a:ext cx="8138160" cy="731520"/>
+          </a:xfrm>
+          <a:prstGeom prst="rect">
+            <a:avLst/>
+          </a:prstGeom>
+          <a:noFill/>
+        </p:spPr>
+        <p:txBody>
+          <a:bodyPr wrap="none">
+            <a:spAutoFit/>
+          </a:bodyPr>
+          <a:lstStyle/>
+          <a:p>
+            <a:pPr algn="l">
+              <a:defRPr sz="2600" b="1">
+                <a:solidFill>
+                  <a:srgbClr val="1E1E1E"/>
+                </a:solidFill>
+              </a:defRPr>
+            </a:pPr>
+            <a:r>
+              <a:t>系统界面：紧急状态监测</a:t>
+            </a:r>
+          </a:p>
+        </p:txBody>
+      </p:sp>
+      <p:pic>
+        <p:nvPicPr>
+          <p:cNvPr id="5" name="Picture 4" descr="ppt_header_perception.png"/>
+          <p:cNvPicPr>
+            <a:picLocks noChangeAspect="1"/>
+          </p:cNvPicPr>
+          <p:nvPr/>
+        </p:nvPicPr>
+        <p:blipFill>
+          <a:blip r:embed="rId2"/>
+          <a:stretch>
+            <a:fillRect/>
+          </a:stretch>
+        </p:blipFill>
+        <p:spPr>
+          <a:xfrm>
+            <a:off x="292608" y="1024128"/>
+            <a:ext cx="8549640" cy="4425107"/>
+          </a:xfrm>
+          <a:prstGeom prst="rect">
+            <a:avLst/>
+          </a:prstGeom>
+        </p:spPr>
+      </p:pic>
+      <p:sp>
+        <p:nvSpPr>
+          <p:cNvPr id="6" name="TextBox 5"/>
+          <p:cNvSpPr txBox="1"/>
+          <p:nvPr/>
+        </p:nvSpPr>
+        <p:spPr>
+          <a:xfrm>
+            <a:off x="292608" y="4617720"/>
+            <a:ext cx="8549640" cy="411480"/>
+          </a:xfrm>
+          <a:prstGeom prst="rect">
+            <a:avLst/>
+          </a:prstGeom>
+          <a:noFill/>
+        </p:spPr>
+        <p:txBody>
+          <a:bodyPr wrap="none">
+            <a:spAutoFit/>
+          </a:bodyPr>
+          <a:lstStyle/>
+          <a:p>
+            <a:pPr algn="ctr">
+              <a:defRPr sz="1100">
+                <a:solidFill>
+                  <a:srgbClr val="505050"/>
+                </a:solidFill>
+              </a:defRPr>
+            </a:pPr>
+            <a:r>
+              <a:t>状态机进入「紧急」· 感知输入与 MediaPipe 视觉模块</a:t>
+            </a:r>
+          </a:p>
+        </p:txBody>
+      </p:sp>
+    </p:spTree>
+  </p:cSld>
+  <p:clrMapOvr>
+    <a:masterClrMapping/>
+  </p:clrMapOvr>
+</p:sld>
+</file>
+
+<file path=ppt/slides/slide18.xml><?xml version="1.0" encoding="utf-8"?>
+<p:sld xmlns:a="http://schemas.openxmlformats.org/drawingml/2006/main" xmlns:p="http://schemas.openxmlformats.org/presentationml/2006/main" xmlns:r="http://schemas.openxmlformats.org/officeDocument/2006/relationships">
+  <p:cSld>
+    <p:bg>
+      <p:bgPr>
+        <a:solidFill>
+          <a:srgbClr val="FFFFFF"/>
+        </a:solidFill>
+        <a:effectLst/>
+      </p:bgPr>
+    </p:bg>
+    <p:spTree>
+      <p:nvGrpSpPr>
+        <p:cNvPr id="1" name=""/>
+        <p:cNvGrpSpPr/>
+        <p:nvPr/>
+      </p:nvGrpSpPr>
+      <p:grpSpPr/>
+      <p:sp>
+        <p:nvSpPr>
+          <p:cNvPr id="2" name="Rectangle 1"/>
+          <p:cNvSpPr/>
+          <p:nvPr/>
+        </p:nvSpPr>
+        <p:spPr>
+          <a:xfrm>
+            <a:off x="0" y="0"/>
+            <a:ext cx="9144000" cy="502920"/>
+          </a:xfrm>
+          <a:prstGeom prst="rect">
+            <a:avLst/>
+          </a:prstGeom>
+          <a:solidFill>
+            <a:srgbClr val="143278"/>
+          </a:solidFill>
+          <a:ln>
+            <a:noFill/>
+          </a:ln>
+        </p:spPr>
+        <p:style>
+          <a:lnRef idx="1">
+            <a:schemeClr val="accent1"/>
+          </a:lnRef>
+          <a:fillRef idx="3">
+            <a:schemeClr val="accent1"/>
+          </a:fillRef>
+          <a:effectRef idx="2">
+            <a:schemeClr val="accent1"/>
+          </a:effectRef>
+          <a:fontRef idx="minor">
+            <a:schemeClr val="lt1"/>
+          </a:fontRef>
+        </p:style>
+        <p:txBody>
+          <a:bodyPr rtlCol="0" anchor="ctr"/>
+          <a:lstStyle/>
+          <a:p>
+            <a:pPr algn="ctr"/>
+          </a:p>
+        </p:txBody>
+      </p:sp>
+      <p:sp>
+        <p:nvSpPr>
+          <p:cNvPr id="3" name="TextBox 2"/>
+          <p:cNvSpPr txBox="1"/>
+          <p:nvPr/>
+        </p:nvSpPr>
+        <p:spPr>
+          <a:xfrm>
+            <a:off x="137160" y="73152"/>
+            <a:ext cx="8869680" cy="411480"/>
+          </a:xfrm>
+          <a:prstGeom prst="rect">
+            <a:avLst/>
+          </a:prstGeom>
+          <a:noFill/>
+        </p:spPr>
+        <p:txBody>
+          <a:bodyPr wrap="none">
+            <a:spAutoFit/>
+          </a:bodyPr>
+          <a:lstStyle/>
+          <a:p>
+            <a:pPr>
+              <a:defRPr sz="1100" b="1">
+                <a:solidFill>
+                  <a:srgbClr val="FFFFFF"/>
+                </a:solidFill>
+              </a:defRPr>
+            </a:pPr>
+            <a:r>
+              <a:t>第二十六届中国机器人及人工智能大赛</a:t>
+            </a:r>
+          </a:p>
+          <a:p>
+            <a:pPr>
+              <a:defRPr sz="1000">
+                <a:solidFill>
+                  <a:srgbClr val="C8DCFF"/>
+                </a:solidFill>
+              </a:defRPr>
+            </a:pPr>
+            <a:r>
+              <a:t>机器人创新赛道</a:t>
+            </a:r>
+          </a:p>
+        </p:txBody>
+      </p:sp>
+      <p:sp>
+        <p:nvSpPr>
+          <p:cNvPr id="4" name="TextBox 3"/>
+          <p:cNvSpPr txBox="1"/>
+          <p:nvPr/>
+        </p:nvSpPr>
+        <p:spPr>
+          <a:xfrm>
+            <a:off x="502920" y="685800"/>
+            <a:ext cx="8138160" cy="731520"/>
+          </a:xfrm>
+          <a:prstGeom prst="rect">
+            <a:avLst/>
+          </a:prstGeom>
+          <a:noFill/>
+        </p:spPr>
+        <p:txBody>
+          <a:bodyPr wrap="none">
+            <a:spAutoFit/>
+          </a:bodyPr>
+          <a:lstStyle/>
+          <a:p>
+            <a:pPr algn="l">
+              <a:defRPr sz="2600" b="1">
+                <a:solidFill>
+                  <a:srgbClr val="1E1E1E"/>
+                </a:solidFill>
+              </a:defRPr>
+            </a:pPr>
+            <a:r>
+              <a:t>系统界面：跌倒紧急对话日志</a:t>
+            </a:r>
+          </a:p>
+        </p:txBody>
+      </p:sp>
+      <p:pic>
+        <p:nvPicPr>
+          <p:cNvPr id="5" name="Picture 4" descr="ppt_chat_emergency.png"/>
+          <p:cNvPicPr>
+            <a:picLocks noChangeAspect="1"/>
+          </p:cNvPicPr>
+          <p:nvPr/>
+        </p:nvPicPr>
+        <p:blipFill>
+          <a:blip r:embed="rId2"/>
+          <a:stretch>
+            <a:fillRect/>
+          </a:stretch>
+        </p:blipFill>
+        <p:spPr>
+          <a:xfrm>
+            <a:off x="292608" y="1024128"/>
+            <a:ext cx="8549640" cy="4600441"/>
+          </a:xfrm>
+          <a:prstGeom prst="rect">
+            <a:avLst/>
+          </a:prstGeom>
+        </p:spPr>
+      </p:pic>
+      <p:sp>
+        <p:nvSpPr>
+          <p:cNvPr id="6" name="TextBox 5"/>
+          <p:cNvSpPr txBox="1"/>
+          <p:nvPr/>
+        </p:nvSpPr>
+        <p:spPr>
+          <a:xfrm>
+            <a:off x="292608" y="4617720"/>
+            <a:ext cx="8549640" cy="411480"/>
+          </a:xfrm>
+          <a:prstGeom prst="rect">
+            <a:avLst/>
+          </a:prstGeom>
+          <a:noFill/>
+        </p:spPr>
+        <p:txBody>
+          <a:bodyPr wrap="none">
+            <a:spAutoFit/>
+          </a:bodyPr>
+          <a:lstStyle/>
+          <a:p>
+            <a:pPr algn="ctr">
+              <a:defRPr sz="1100">
+                <a:solidFill>
+                  <a:srgbClr val="505050"/>
+                </a:solidFill>
+              </a:defRPr>
+            </a:pPr>
+            <a:r>
+              <a:t>演示完成：跌倒紧急流程已成功触发 · 多次紧急安抚语音</a:t>
+            </a:r>
+          </a:p>
+        </p:txBody>
+      </p:sp>
+    </p:spTree>
+  </p:cSld>
+  <p:clrMapOvr>
+    <a:masterClrMapping/>
+  </p:clrMapOvr>
+</p:sld>
+</file>
+
+<file path=ppt/slides/slide19.xml><?xml version="1.0" encoding="utf-8"?>
+<p:sld xmlns:a="http://schemas.openxmlformats.org/drawingml/2006/main" xmlns:p="http://schemas.openxmlformats.org/presentationml/2006/main" xmlns:r="http://schemas.openxmlformats.org/officeDocument/2006/relationships">
+  <p:cSld>
+    <p:bg>
+      <p:bgPr>
+        <a:solidFill>
+          <a:srgbClr val="FFFFFF"/>
+        </a:solidFill>
+        <a:effectLst/>
+      </p:bgPr>
+    </p:bg>
+    <p:spTree>
+      <p:nvGrpSpPr>
+        <p:cNvPr id="1" name=""/>
+        <p:cNvGrpSpPr/>
+        <p:nvPr/>
+      </p:nvGrpSpPr>
+      <p:grpSpPr/>
+      <p:sp>
+        <p:nvSpPr>
+          <p:cNvPr id="2" name="Rectangle 1"/>
+          <p:cNvSpPr/>
+          <p:nvPr/>
+        </p:nvSpPr>
+        <p:spPr>
+          <a:xfrm>
+            <a:off x="0" y="0"/>
+            <a:ext cx="9144000" cy="502920"/>
+          </a:xfrm>
+          <a:prstGeom prst="rect">
+            <a:avLst/>
+          </a:prstGeom>
+          <a:solidFill>
+            <a:srgbClr val="143278"/>
+          </a:solidFill>
+          <a:ln>
+            <a:noFill/>
+          </a:ln>
+        </p:spPr>
+        <p:style>
+          <a:lnRef idx="1">
+            <a:schemeClr val="accent1"/>
+          </a:lnRef>
+          <a:fillRef idx="3">
+            <a:schemeClr val="accent1"/>
+          </a:fillRef>
+          <a:effectRef idx="2">
+            <a:schemeClr val="accent1"/>
+          </a:effectRef>
+          <a:fontRef idx="minor">
+            <a:schemeClr val="lt1"/>
+          </a:fontRef>
+        </p:style>
+        <p:txBody>
+          <a:bodyPr rtlCol="0" anchor="ctr"/>
+          <a:lstStyle/>
+          <a:p>
+            <a:pPr algn="ctr"/>
+          </a:p>
+        </p:txBody>
+      </p:sp>
+      <p:sp>
+        <p:nvSpPr>
+          <p:cNvPr id="3" name="TextBox 2"/>
+          <p:cNvSpPr txBox="1"/>
+          <p:nvPr/>
+        </p:nvSpPr>
+        <p:spPr>
+          <a:xfrm>
+            <a:off x="137160" y="73152"/>
+            <a:ext cx="8869680" cy="411480"/>
+          </a:xfrm>
+          <a:prstGeom prst="rect">
+            <a:avLst/>
+          </a:prstGeom>
+          <a:noFill/>
+        </p:spPr>
+        <p:txBody>
+          <a:bodyPr wrap="none">
+            <a:spAutoFit/>
+          </a:bodyPr>
+          <a:lstStyle/>
+          <a:p>
+            <a:pPr>
+              <a:defRPr sz="1100" b="1">
+                <a:solidFill>
+                  <a:srgbClr val="FFFFFF"/>
+                </a:solidFill>
+              </a:defRPr>
+            </a:pPr>
+            <a:r>
+              <a:t>第二十六届中国机器人及人工智能大赛</a:t>
+            </a:r>
+          </a:p>
+          <a:p>
+            <a:pPr>
+              <a:defRPr sz="1000">
+                <a:solidFill>
+                  <a:srgbClr val="C8DCFF"/>
+                </a:solidFill>
+              </a:defRPr>
+            </a:pPr>
+            <a:r>
+              <a:t>机器人创新赛道</a:t>
+            </a:r>
+          </a:p>
+        </p:txBody>
+      </p:sp>
+      <p:sp>
+        <p:nvSpPr>
+          <p:cNvPr id="4" name="TextBox 3"/>
+          <p:cNvSpPr txBox="1"/>
+          <p:nvPr/>
+        </p:nvSpPr>
+        <p:spPr>
+          <a:xfrm>
+            <a:off x="502920" y="685800"/>
+            <a:ext cx="8138160" cy="731520"/>
+          </a:xfrm>
+          <a:prstGeom prst="rect">
+            <a:avLst/>
+          </a:prstGeom>
+          <a:noFill/>
+        </p:spPr>
+        <p:txBody>
+          <a:bodyPr wrap="none">
+            <a:spAutoFit/>
+          </a:bodyPr>
+          <a:lstStyle/>
+          <a:p>
+            <a:pPr algn="l">
+              <a:defRPr sz="2600" b="1">
+                <a:solidFill>
+                  <a:srgbClr val="1E1E1E"/>
+                </a:solidFill>
+              </a:defRPr>
+            </a:pPr>
+            <a:r>
+              <a:t>系统界面：机器人指令流</a:t>
+            </a:r>
+          </a:p>
+        </p:txBody>
+      </p:sp>
+      <p:pic>
+        <p:nvPicPr>
+          <p:cNvPr id="5" name="Picture 4" descr="ppt_robot_commands.png"/>
+          <p:cNvPicPr>
+            <a:picLocks noChangeAspect="1"/>
+          </p:cNvPicPr>
+          <p:nvPr/>
+        </p:nvPicPr>
+        <p:blipFill>
+          <a:blip r:embed="rId2"/>
+          <a:stretch>
+            <a:fillRect/>
+          </a:stretch>
+        </p:blipFill>
+        <p:spPr>
+          <a:xfrm>
+            <a:off x="292608" y="1024128"/>
+            <a:ext cx="8549640" cy="1928679"/>
+          </a:xfrm>
+          <a:prstGeom prst="rect">
+            <a:avLst/>
+          </a:prstGeom>
+        </p:spPr>
+      </p:pic>
+      <p:sp>
+        <p:nvSpPr>
+          <p:cNvPr id="6" name="TextBox 5"/>
+          <p:cNvSpPr txBox="1"/>
+          <p:nvPr/>
+        </p:nvSpPr>
+        <p:spPr>
+          <a:xfrm>
+            <a:off x="292608" y="4617720"/>
+            <a:ext cx="8549640" cy="411480"/>
+          </a:xfrm>
+          <a:prstGeom prst="rect">
+            <a:avLst/>
+          </a:prstGeom>
+          <a:noFill/>
+        </p:spPr>
+        <p:txBody>
+          <a:bodyPr wrap="none">
+            <a:spAutoFit/>
+          </a:bodyPr>
+          <a:lstStyle/>
+          <a:p>
+            <a:pPr algn="ctr">
+              <a:defRPr sz="1100">
+                <a:solidFill>
+                  <a:srgbClr val="505050"/>
+                </a:solidFill>
+              </a:defRPr>
+            </a:pPr>
+            <a:r>
+              <a:t>告警音 → 语音 → 紧急呼叫（跌倒事件）→ 举手手势，全链路可追溯</a:t>
+            </a:r>
+          </a:p>
+        </p:txBody>
+      </p:sp>
+    </p:spTree>
+  </p:cSld>
+  <p:clrMapOvr>
+    <a:masterClrMapping/>
+  </p:clrMapOvr>
+</p:sld>
+</file>
+
+<file path=ppt/slides/slide2.xml><?xml version="1.0" encoding="utf-8"?>
+<p:sld xmlns:a="http://schemas.openxmlformats.org/drawingml/2006/main" xmlns:p="http://schemas.openxmlformats.org/presentationml/2006/main" xmlns:r="http://schemas.openxmlformats.org/officeDocument/2006/relationships">
+  <p:cSld>
+    <p:bg>
+      <p:bgPr>
+        <a:solidFill>
+          <a:srgbClr val="FFFFFF"/>
+        </a:solidFill>
+        <a:effectLst/>
+      </p:bgPr>
+    </p:bg>
+    <p:spTree>
+      <p:nvGrpSpPr>
+        <p:cNvPr id="1" name=""/>
+        <p:cNvGrpSpPr/>
+        <p:nvPr/>
+      </p:nvGrpSpPr>
+      <p:grpSpPr/>
+      <p:sp>
+        <p:nvSpPr>
+          <p:cNvPr id="2" name="Rectangle 1"/>
+          <p:cNvSpPr/>
+          <p:nvPr/>
+        </p:nvSpPr>
+        <p:spPr>
+          <a:xfrm>
+            <a:off x="0" y="0"/>
+            <a:ext cx="9144000" cy="502920"/>
+          </a:xfrm>
+          <a:prstGeom prst="rect">
+            <a:avLst/>
+          </a:prstGeom>
+          <a:solidFill>
+            <a:srgbClr val="143278"/>
+          </a:solidFill>
+          <a:ln>
+            <a:noFill/>
+          </a:ln>
+        </p:spPr>
+        <p:style>
+          <a:lnRef idx="1">
+            <a:schemeClr val="accent1"/>
+          </a:lnRef>
+          <a:fillRef idx="3">
+            <a:schemeClr val="accent1"/>
+          </a:fillRef>
+          <a:effectRef idx="2">
+            <a:schemeClr val="accent1"/>
+          </a:effectRef>
+          <a:fontRef idx="minor">
+            <a:schemeClr val="lt1"/>
+          </a:fontRef>
+        </p:style>
+        <p:txBody>
+          <a:bodyPr rtlCol="0" anchor="ctr"/>
+          <a:lstStyle/>
+          <a:p>
+            <a:pPr algn="ctr"/>
+          </a:p>
+        </p:txBody>
+      </p:sp>
+      <p:sp>
+        <p:nvSpPr>
+          <p:cNvPr id="3" name="TextBox 2"/>
+          <p:cNvSpPr txBox="1"/>
+          <p:nvPr/>
+        </p:nvSpPr>
+        <p:spPr>
+          <a:xfrm>
+            <a:off x="137160" y="73152"/>
+            <a:ext cx="8869680" cy="411480"/>
+          </a:xfrm>
+          <a:prstGeom prst="rect">
+            <a:avLst/>
+          </a:prstGeom>
+          <a:noFill/>
+        </p:spPr>
+        <p:txBody>
+          <a:bodyPr wrap="none">
+            <a:spAutoFit/>
+          </a:bodyPr>
+          <a:lstStyle/>
+          <a:p>
+            <a:pPr>
+              <a:defRPr sz="1100" b="1">
+                <a:solidFill>
+                  <a:srgbClr val="FFFFFF"/>
+                </a:solidFill>
+              </a:defRPr>
+            </a:pPr>
+            <a:r>
+              <a:t>第二十六届中国机器人及人工智能大赛</a:t>
+            </a:r>
+          </a:p>
+          <a:p>
+            <a:pPr>
+              <a:defRPr sz="1000">
+                <a:solidFill>
+                  <a:srgbClr val="C8DCFF"/>
+                </a:solidFill>
+              </a:defRPr>
+            </a:pPr>
+            <a:r>
+              <a:t>机器人创新赛道</a:t>
+            </a:r>
+          </a:p>
+        </p:txBody>
+      </p:sp>
+      <p:sp>
+        <p:nvSpPr>
+          <p:cNvPr id="4" name="TextBox 3"/>
+          <p:cNvSpPr txBox="1"/>
+          <p:nvPr/>
+        </p:nvSpPr>
+        <p:spPr>
+          <a:xfrm>
+            <a:off x="502920" y="1828800"/>
+            <a:ext cx="8138160" cy="731520"/>
+          </a:xfrm>
+          <a:prstGeom prst="rect">
+            <a:avLst/>
+          </a:prstGeom>
+          <a:noFill/>
+        </p:spPr>
+        <p:txBody>
+          <a:bodyPr wrap="none">
+            <a:spAutoFit/>
+          </a:bodyPr>
+          <a:lstStyle/>
+          <a:p>
+            <a:pPr algn="ctr">
+              <a:defRPr sz="3200" b="1">
+                <a:solidFill>
+                  <a:srgbClr val="1E1E1E"/>
+                </a:solidFill>
+              </a:defRPr>
+            </a:pPr>
+            <a:r>
+              <a:t>第一部分</a:t>
+            </a:r>
+          </a:p>
+        </p:txBody>
+      </p:sp>
+      <p:sp>
+        <p:nvSpPr>
+          <p:cNvPr id="5" name="TextBox 4"/>
+          <p:cNvSpPr txBox="1"/>
+          <p:nvPr/>
+        </p:nvSpPr>
+        <p:spPr>
+          <a:xfrm>
+            <a:off x="502920" y="2606040"/>
+            <a:ext cx="8138160" cy="731520"/>
+          </a:xfrm>
+          <a:prstGeom prst="rect">
+            <a:avLst/>
+          </a:prstGeom>
+          <a:noFill/>
+        </p:spPr>
+        <p:txBody>
+          <a:bodyPr wrap="none">
+            <a:spAutoFit/>
+          </a:bodyPr>
+          <a:lstStyle/>
+          <a:p>
+            <a:pPr algn="ctr">
+              <a:defRPr sz="2200" b="1">
+                <a:solidFill>
+                  <a:srgbClr val="143278"/>
+                </a:solidFill>
+              </a:defRPr>
+            </a:pPr>
+            <a:r>
+              <a:t>项目背景与需求分析</a:t>
+            </a:r>
+          </a:p>
+        </p:txBody>
+      </p:sp>
+    </p:spTree>
+  </p:cSld>
+  <p:clrMapOvr>
+    <a:masterClrMapping/>
+  </p:clrMapOvr>
+</p:sld>
+</file>
+
+<file path=ppt/slides/slide20.xml><?xml version="1.0" encoding="utf-8"?>
 <p:sld xmlns:a="http://schemas.openxmlformats.org/drawingml/2006/main" xmlns:p="http://schemas.openxmlformats.org/presentationml/2006/main" xmlns:r="http://schemas.openxmlformats.org/officeDocument/2006/relationships">
   <p:cSld>
     <p:bg>
@@ -4817,7 +6224,7 @@
 </p:sld>
 </file>
 
-<file path=ppt/slides/slide15.xml><?xml version="1.0" encoding="utf-8"?>
+<file path=ppt/slides/slide21.xml><?xml version="1.0" encoding="utf-8"?>
 <p:sld xmlns:a="http://schemas.openxmlformats.org/drawingml/2006/main" xmlns:p="http://schemas.openxmlformats.org/presentationml/2006/main" xmlns:r="http://schemas.openxmlformats.org/officeDocument/2006/relationships">
   <p:cSld>
     <p:bg>
@@ -5008,6 +6415,21 @@
               </a:defRPr>
             </a:pPr>
             <a:r>
+              <a:t>答辩演示：http://localhost:8765（现场端口转发）</a:t>
+            </a:r>
+          </a:p>
+          <a:p>
+            <a:pPr>
+              <a:spcAft>
+                <a:spcPts val="600"/>
+              </a:spcAft>
+              <a:defRPr sz="1400">
+                <a:solidFill>
+                  <a:srgbClr val="1E1E1E"/>
+                </a:solidFill>
+              </a:defRPr>
+            </a:pPr>
+            <a:r>
               <a:t>软件名称建议：CareCompanion 智能养老人形陪伴机器人系统 V1.0</a:t>
             </a:r>
           </a:p>
@@ -5066,7 +6488,7 @@
 </p:sld>
 </file>
 
-<file path=ppt/slides/slide16.xml><?xml version="1.0" encoding="utf-8"?>
+<file path=ppt/slides/slide22.xml><?xml version="1.0" encoding="utf-8"?>
 <p:sld xmlns:a="http://schemas.openxmlformats.org/drawingml/2006/main" xmlns:p="http://schemas.openxmlformats.org/presentationml/2006/main" xmlns:r="http://schemas.openxmlformats.org/officeDocument/2006/relationships">
   <p:cSld>
     <p:bg>
@@ -5252,7 +6674,7 @@
 </p:sld>
 </file>
 
-<file path=ppt/slides/slide17.xml><?xml version="1.0" encoding="utf-8"?>
+<file path=ppt/slides/slide23.xml><?xml version="1.0" encoding="utf-8"?>
 <p:sld xmlns:a="http://schemas.openxmlformats.org/drawingml/2006/main" xmlns:p="http://schemas.openxmlformats.org/presentationml/2006/main" xmlns:r="http://schemas.openxmlformats.org/officeDocument/2006/relationships">
   <p:cSld>
     <p:bg>
@@ -5677,7 +7099,7 @@
 </p:sld>
 </file>
 
-<file path=ppt/slides/slide18.xml><?xml version="1.0" encoding="utf-8"?>
+<file path=ppt/slides/slide24.xml><?xml version="1.0" encoding="utf-8"?>
 <p:sld xmlns:a="http://schemas.openxmlformats.org/drawingml/2006/main" xmlns:p="http://schemas.openxmlformats.org/presentationml/2006/main" xmlns:r="http://schemas.openxmlformats.org/officeDocument/2006/relationships">
   <p:cSld>
     <p:bg>
@@ -5926,7 +7348,7 @@
 </p:sld>
 </file>
 
-<file path=ppt/slides/slide19.xml><?xml version="1.0" encoding="utf-8"?>
+<file path=ppt/slides/slide25.xml><?xml version="1.0" encoding="utf-8"?>
 <p:sld xmlns:a="http://schemas.openxmlformats.org/drawingml/2006/main" xmlns:p="http://schemas.openxmlformats.org/presentationml/2006/main" xmlns:r="http://schemas.openxmlformats.org/officeDocument/2006/relationships">
   <p:cSld>
     <p:bg>
@@ -6175,193 +7597,7 @@
 </p:sld>
 </file>
 
-<file path=ppt/slides/slide2.xml><?xml version="1.0" encoding="utf-8"?>
-<p:sld xmlns:a="http://schemas.openxmlformats.org/drawingml/2006/main" xmlns:p="http://schemas.openxmlformats.org/presentationml/2006/main" xmlns:r="http://schemas.openxmlformats.org/officeDocument/2006/relationships">
-  <p:cSld>
-    <p:bg>
-      <p:bgPr>
-        <a:solidFill>
-          <a:srgbClr val="FFFFFF"/>
-        </a:solidFill>
-        <a:effectLst/>
-      </p:bgPr>
-    </p:bg>
-    <p:spTree>
-      <p:nvGrpSpPr>
-        <p:cNvPr id="1" name=""/>
-        <p:cNvGrpSpPr/>
-        <p:nvPr/>
-      </p:nvGrpSpPr>
-      <p:grpSpPr/>
-      <p:sp>
-        <p:nvSpPr>
-          <p:cNvPr id="2" name="Rectangle 1"/>
-          <p:cNvSpPr/>
-          <p:nvPr/>
-        </p:nvSpPr>
-        <p:spPr>
-          <a:xfrm>
-            <a:off x="0" y="0"/>
-            <a:ext cx="9144000" cy="502920"/>
-          </a:xfrm>
-          <a:prstGeom prst="rect">
-            <a:avLst/>
-          </a:prstGeom>
-          <a:solidFill>
-            <a:srgbClr val="143278"/>
-          </a:solidFill>
-          <a:ln>
-            <a:noFill/>
-          </a:ln>
-        </p:spPr>
-        <p:style>
-          <a:lnRef idx="1">
-            <a:schemeClr val="accent1"/>
-          </a:lnRef>
-          <a:fillRef idx="3">
-            <a:schemeClr val="accent1"/>
-          </a:fillRef>
-          <a:effectRef idx="2">
-            <a:schemeClr val="accent1"/>
-          </a:effectRef>
-          <a:fontRef idx="minor">
-            <a:schemeClr val="lt1"/>
-          </a:fontRef>
-        </p:style>
-        <p:txBody>
-          <a:bodyPr rtlCol="0" anchor="ctr"/>
-          <a:lstStyle/>
-          <a:p>
-            <a:pPr algn="ctr"/>
-          </a:p>
-        </p:txBody>
-      </p:sp>
-      <p:sp>
-        <p:nvSpPr>
-          <p:cNvPr id="3" name="TextBox 2"/>
-          <p:cNvSpPr txBox="1"/>
-          <p:nvPr/>
-        </p:nvSpPr>
-        <p:spPr>
-          <a:xfrm>
-            <a:off x="137160" y="73152"/>
-            <a:ext cx="8869680" cy="411480"/>
-          </a:xfrm>
-          <a:prstGeom prst="rect">
-            <a:avLst/>
-          </a:prstGeom>
-          <a:noFill/>
-        </p:spPr>
-        <p:txBody>
-          <a:bodyPr wrap="none">
-            <a:spAutoFit/>
-          </a:bodyPr>
-          <a:lstStyle/>
-          <a:p>
-            <a:pPr>
-              <a:defRPr sz="1100" b="1">
-                <a:solidFill>
-                  <a:srgbClr val="FFFFFF"/>
-                </a:solidFill>
-              </a:defRPr>
-            </a:pPr>
-            <a:r>
-              <a:t>第二十六届中国机器人及人工智能大赛</a:t>
-            </a:r>
-          </a:p>
-          <a:p>
-            <a:pPr>
-              <a:defRPr sz="1000">
-                <a:solidFill>
-                  <a:srgbClr val="C8DCFF"/>
-                </a:solidFill>
-              </a:defRPr>
-            </a:pPr>
-            <a:r>
-              <a:t>机器人创新赛道</a:t>
-            </a:r>
-          </a:p>
-        </p:txBody>
-      </p:sp>
-      <p:sp>
-        <p:nvSpPr>
-          <p:cNvPr id="4" name="TextBox 3"/>
-          <p:cNvSpPr txBox="1"/>
-          <p:nvPr/>
-        </p:nvSpPr>
-        <p:spPr>
-          <a:xfrm>
-            <a:off x="502920" y="1828800"/>
-            <a:ext cx="8138160" cy="731520"/>
-          </a:xfrm>
-          <a:prstGeom prst="rect">
-            <a:avLst/>
-          </a:prstGeom>
-          <a:noFill/>
-        </p:spPr>
-        <p:txBody>
-          <a:bodyPr wrap="none">
-            <a:spAutoFit/>
-          </a:bodyPr>
-          <a:lstStyle/>
-          <a:p>
-            <a:pPr algn="ctr">
-              <a:defRPr sz="3200" b="1">
-                <a:solidFill>
-                  <a:srgbClr val="1E1E1E"/>
-                </a:solidFill>
-              </a:defRPr>
-            </a:pPr>
-            <a:r>
-              <a:t>第一部分</a:t>
-            </a:r>
-          </a:p>
-        </p:txBody>
-      </p:sp>
-      <p:sp>
-        <p:nvSpPr>
-          <p:cNvPr id="5" name="TextBox 4"/>
-          <p:cNvSpPr txBox="1"/>
-          <p:nvPr/>
-        </p:nvSpPr>
-        <p:spPr>
-          <a:xfrm>
-            <a:off x="502920" y="2606040"/>
-            <a:ext cx="8138160" cy="731520"/>
-          </a:xfrm>
-          <a:prstGeom prst="rect">
-            <a:avLst/>
-          </a:prstGeom>
-          <a:noFill/>
-        </p:spPr>
-        <p:txBody>
-          <a:bodyPr wrap="none">
-            <a:spAutoFit/>
-          </a:bodyPr>
-          <a:lstStyle/>
-          <a:p>
-            <a:pPr algn="ctr">
-              <a:defRPr sz="2200" b="1">
-                <a:solidFill>
-                  <a:srgbClr val="143278"/>
-                </a:solidFill>
-              </a:defRPr>
-            </a:pPr>
-            <a:r>
-              <a:t>项目背景与需求分析</a:t>
-            </a:r>
-          </a:p>
-        </p:txBody>
-      </p:sp>
-    </p:spTree>
-  </p:cSld>
-  <p:clrMapOvr>
-    <a:masterClrMapping/>
-  </p:clrMapOvr>
-</p:sld>
-</file>
-
-<file path=ppt/slides/slide20.xml><?xml version="1.0" encoding="utf-8"?>
+<file path=ppt/slides/slide26.xml><?xml version="1.0" encoding="utf-8"?>
 <p:sld xmlns:a="http://schemas.openxmlformats.org/drawingml/2006/main" xmlns:p="http://schemas.openxmlformats.org/presentationml/2006/main" xmlns:r="http://schemas.openxmlformats.org/officeDocument/2006/relationships">
   <p:cSld>
     <p:bg>

</xml_diff>

<commit_message>
fix(docs): correct screenshot layout in defense PPT
Place titles above images with bounded scaling and centered placement
so screenshots no longer overlap slide headings in WPS/PowerPoint.
</commit_message>
<xml_diff>
--- a/docs/答辩_CareCompanion.pptx
+++ b/docs/答辩_CareCompanion.pptx
@@ -3228,7 +3228,7 @@
           <a:noFill/>
         </p:spPr>
         <p:txBody>
-          <a:bodyPr wrap="none">
+          <a:bodyPr wrap="square">
             <a:spAutoFit/>
           </a:bodyPr>
           <a:lstStyle/>
@@ -3263,7 +3263,7 @@
           <a:noFill/>
         </p:spPr>
         <p:txBody>
-          <a:bodyPr wrap="none">
+          <a:bodyPr wrap="square">
             <a:spAutoFit/>
           </a:bodyPr>
           <a:lstStyle/>
@@ -3527,7 +3527,7 @@
           <a:noFill/>
         </p:spPr>
         <p:txBody>
-          <a:bodyPr wrap="none">
+          <a:bodyPr wrap="square">
             <a:spAutoFit/>
           </a:bodyPr>
           <a:lstStyle/>
@@ -3729,44 +3729,9 @@
           </a:p>
         </p:txBody>
       </p:sp>
-      <p:sp>
-        <p:nvSpPr>
-          <p:cNvPr id="4" name="TextBox 3"/>
-          <p:cNvSpPr txBox="1"/>
-          <p:nvPr/>
-        </p:nvSpPr>
-        <p:spPr>
-          <a:xfrm>
-            <a:off x="502920" y="685800"/>
-            <a:ext cx="8138160" cy="731520"/>
-          </a:xfrm>
-          <a:prstGeom prst="rect">
-            <a:avLst/>
-          </a:prstGeom>
-          <a:noFill/>
-        </p:spPr>
-        <p:txBody>
-          <a:bodyPr wrap="none">
-            <a:spAutoFit/>
-          </a:bodyPr>
-          <a:lstStyle/>
-          <a:p>
-            <a:pPr algn="l">
-              <a:defRPr sz="2600" b="1">
-                <a:solidFill>
-                  <a:srgbClr val="1E1E1E"/>
-                </a:solidFill>
-              </a:defRPr>
-            </a:pPr>
-            <a:r>
-              <a:t>（界面）情感倾诉交互</a:t>
-            </a:r>
-          </a:p>
-        </p:txBody>
-      </p:sp>
       <p:pic>
         <p:nvPicPr>
-          <p:cNvPr id="5" name="Picture 4" descr="ppt_emotion_input.png"/>
+          <p:cNvPr id="4" name="Picture 3" descr="ppt_emotion_input.png"/>
           <p:cNvPicPr>
             <a:picLocks noChangeAspect="1"/>
           </p:cNvPicPr>
@@ -3780,14 +3745,49 @@
         </p:blipFill>
         <p:spPr>
           <a:xfrm>
-            <a:off x="292608" y="1024128"/>
-            <a:ext cx="8549640" cy="7272204"/>
+            <a:off x="1803814" y="1261872"/>
+            <a:ext cx="5536371" cy="4709160"/>
           </a:xfrm>
           <a:prstGeom prst="rect">
             <a:avLst/>
           </a:prstGeom>
         </p:spPr>
       </p:pic>
+      <p:sp>
+        <p:nvSpPr>
+          <p:cNvPr id="5" name="TextBox 4"/>
+          <p:cNvSpPr txBox="1"/>
+          <p:nvPr/>
+        </p:nvSpPr>
+        <p:spPr>
+          <a:xfrm>
+            <a:off x="365760" y="6144768"/>
+            <a:ext cx="8412480" cy="502920"/>
+          </a:xfrm>
+          <a:prstGeom prst="rect">
+            <a:avLst/>
+          </a:prstGeom>
+          <a:noFill/>
+        </p:spPr>
+        <p:txBody>
+          <a:bodyPr wrap="square">
+            <a:spAutoFit/>
+          </a:bodyPr>
+          <a:lstStyle/>
+          <a:p>
+            <a:pPr algn="ctr">
+              <a:defRPr sz="1000">
+                <a:solidFill>
+                  <a:srgbClr val="505050"/>
+                </a:solidFill>
+              </a:defRPr>
+            </a:pPr>
+            <a:r>
+              <a:t>老人输入「最近有点孤独，睡不太好」→ 系统识别情绪低落并生成安抚话术</a:t>
+            </a:r>
+          </a:p>
+        </p:txBody>
+      </p:sp>
       <p:sp>
         <p:nvSpPr>
           <p:cNvPr id="6" name="TextBox 5"/>
@@ -3796,8 +3796,8 @@
         </p:nvSpPr>
         <p:spPr>
           <a:xfrm>
-            <a:off x="292608" y="4617720"/>
-            <a:ext cx="8549640" cy="411480"/>
+            <a:off x="365760" y="530352"/>
+            <a:ext cx="8412480" cy="566928"/>
           </a:xfrm>
           <a:prstGeom prst="rect">
             <a:avLst/>
@@ -3805,20 +3805,20 @@
           <a:noFill/>
         </p:spPr>
         <p:txBody>
-          <a:bodyPr wrap="none">
+          <a:bodyPr wrap="square">
             <a:spAutoFit/>
           </a:bodyPr>
           <a:lstStyle/>
           <a:p>
-            <a:pPr algn="ctr">
-              <a:defRPr sz="1100">
-                <a:solidFill>
-                  <a:srgbClr val="505050"/>
-                </a:solidFill>
-              </a:defRPr>
-            </a:pPr>
-            <a:r>
-              <a:t>老人输入「最近有点孤独，睡不太好」→ 系统识别情绪低落并生成安抚话术</a:t>
+            <a:pPr algn="l">
+              <a:defRPr sz="2100" b="1">
+                <a:solidFill>
+                  <a:srgbClr val="1E1E1E"/>
+                </a:solidFill>
+              </a:defRPr>
+            </a:pPr>
+            <a:r>
+              <a:t>（界面）情感倾诉交互</a:t>
             </a:r>
           </a:p>
         </p:txBody>
@@ -3956,7 +3956,7 @@
           <a:noFill/>
         </p:spPr>
         <p:txBody>
-          <a:bodyPr wrap="none">
+          <a:bodyPr wrap="square">
             <a:spAutoFit/>
           </a:bodyPr>
           <a:lstStyle/>
@@ -4205,7 +4205,7 @@
           <a:noFill/>
         </p:spPr>
         <p:txBody>
-          <a:bodyPr wrap="none">
+          <a:bodyPr wrap="square">
             <a:spAutoFit/>
           </a:bodyPr>
           <a:lstStyle/>
@@ -4240,7 +4240,7 @@
           <a:noFill/>
         </p:spPr>
         <p:txBody>
-          <a:bodyPr wrap="none">
+          <a:bodyPr wrap="square">
             <a:spAutoFit/>
           </a:bodyPr>
           <a:lstStyle/>
@@ -4391,7 +4391,7 @@
           <a:noFill/>
         </p:spPr>
         <p:txBody>
-          <a:bodyPr wrap="none">
+          <a:bodyPr wrap="square">
             <a:spAutoFit/>
           </a:bodyPr>
           <a:lstStyle/>
@@ -4593,44 +4593,9 @@
           </a:p>
         </p:txBody>
       </p:sp>
-      <p:sp>
-        <p:nvSpPr>
-          <p:cNvPr id="4" name="TextBox 3"/>
-          <p:cNvSpPr txBox="1"/>
-          <p:nvPr/>
-        </p:nvSpPr>
-        <p:spPr>
-          <a:xfrm>
-            <a:off x="502920" y="685800"/>
-            <a:ext cx="8138160" cy="731520"/>
-          </a:xfrm>
-          <a:prstGeom prst="rect">
-            <a:avLst/>
-          </a:prstGeom>
-          <a:noFill/>
-        </p:spPr>
-        <p:txBody>
-          <a:bodyPr wrap="none">
-            <a:spAutoFit/>
-          </a:bodyPr>
-          <a:lstStyle/>
-          <a:p>
-            <a:pPr algn="l">
-              <a:defRPr sz="2600" b="1">
-                <a:solidFill>
-                  <a:srgbClr val="1E1E1E"/>
-                </a:solidFill>
-              </a:defRPr>
-            </a:pPr>
-            <a:r>
-              <a:t>系统界面：老人倾诉场景（演示剧本）</a:t>
-            </a:r>
-          </a:p>
-        </p:txBody>
-      </p:sp>
       <p:pic>
         <p:nvPicPr>
-          <p:cNvPr id="5" name="Picture 4" descr="ppt_full_dashboard.png"/>
+          <p:cNvPr id="4" name="Picture 3" descr="ppt_full_dashboard.png"/>
           <p:cNvPicPr>
             <a:picLocks noChangeAspect="1"/>
           </p:cNvPicPr>
@@ -4644,14 +4609,49 @@
         </p:blipFill>
         <p:spPr>
           <a:xfrm>
-            <a:off x="292608" y="1024128"/>
-            <a:ext cx="8549640" cy="4458504"/>
+            <a:off x="502919" y="1261872"/>
+            <a:ext cx="8138160" cy="4243923"/>
           </a:xfrm>
           <a:prstGeom prst="rect">
             <a:avLst/>
           </a:prstGeom>
         </p:spPr>
       </p:pic>
+      <p:sp>
+        <p:nvSpPr>
+          <p:cNvPr id="5" name="TextBox 4"/>
+          <p:cNvSpPr txBox="1"/>
+          <p:nvPr/>
+        </p:nvSpPr>
+        <p:spPr>
+          <a:xfrm>
+            <a:off x="365760" y="6144768"/>
+            <a:ext cx="8412480" cy="502920"/>
+          </a:xfrm>
+          <a:prstGeom prst="rect">
+            <a:avLst/>
+          </a:prstGeom>
+          <a:noFill/>
+        </p:spPr>
+        <p:txBody>
+          <a:bodyPr wrap="square">
+            <a:spAutoFit/>
+          </a:bodyPr>
+          <a:lstStyle/>
+          <a:p>
+            <a:pPr algn="ctr">
+              <a:defRPr sz="1000">
+                <a:solidFill>
+                  <a:srgbClr val="505050"/>
+                </a:solidFill>
+              </a:defRPr>
+            </a:pPr>
+            <a:r>
+              <a:t>演示场景「老人倾诉」· 风险 0.23 · 机器人主动安抚回复</a:t>
+            </a:r>
+          </a:p>
+        </p:txBody>
+      </p:sp>
       <p:sp>
         <p:nvSpPr>
           <p:cNvPr id="6" name="TextBox 5"/>
@@ -4660,8 +4660,8 @@
         </p:nvSpPr>
         <p:spPr>
           <a:xfrm>
-            <a:off x="292608" y="4617720"/>
-            <a:ext cx="8549640" cy="411480"/>
+            <a:off x="365760" y="530352"/>
+            <a:ext cx="8412480" cy="566928"/>
           </a:xfrm>
           <a:prstGeom prst="rect">
             <a:avLst/>
@@ -4669,20 +4669,20 @@
           <a:noFill/>
         </p:spPr>
         <p:txBody>
-          <a:bodyPr wrap="none">
+          <a:bodyPr wrap="square">
             <a:spAutoFit/>
           </a:bodyPr>
           <a:lstStyle/>
           <a:p>
-            <a:pPr algn="ctr">
-              <a:defRPr sz="1100">
-                <a:solidFill>
-                  <a:srgbClr val="505050"/>
-                </a:solidFill>
-              </a:defRPr>
-            </a:pPr>
-            <a:r>
-              <a:t>演示场景「老人倾诉」· 风险 0.23 · 机器人主动安抚回复</a:t>
+            <a:pPr algn="l">
+              <a:defRPr sz="2100" b="1">
+                <a:solidFill>
+                  <a:srgbClr val="1E1E1E"/>
+                </a:solidFill>
+              </a:defRPr>
+            </a:pPr>
+            <a:r>
+              <a:t>系统界面：老人倾诉场景（演示剧本）</a:t>
             </a:r>
           </a:p>
         </p:txBody>
@@ -4803,44 +4803,9 @@
           </a:p>
         </p:txBody>
       </p:sp>
-      <p:sp>
-        <p:nvSpPr>
-          <p:cNvPr id="4" name="TextBox 3"/>
-          <p:cNvSpPr txBox="1"/>
-          <p:nvPr/>
-        </p:nvSpPr>
-        <p:spPr>
-          <a:xfrm>
-            <a:off x="502920" y="685800"/>
-            <a:ext cx="8138160" cy="731520"/>
-          </a:xfrm>
-          <a:prstGeom prst="rect">
-            <a:avLst/>
-          </a:prstGeom>
-          <a:noFill/>
-        </p:spPr>
-        <p:txBody>
-          <a:bodyPr wrap="none">
-            <a:spAutoFit/>
-          </a:bodyPr>
-          <a:lstStyle/>
-          <a:p>
-            <a:pPr algn="l">
-              <a:defRPr sz="2600" b="1">
-                <a:solidFill>
-                  <a:srgbClr val="1E1E1E"/>
-                </a:solidFill>
-              </a:defRPr>
-            </a:pPr>
-            <a:r>
-              <a:t>系统界面：风险决策仪表盘</a:t>
-            </a:r>
-          </a:p>
-        </p:txBody>
-      </p:sp>
       <p:pic>
         <p:nvPicPr>
-          <p:cNvPr id="5" name="Picture 4" descr="ppt_risk_panel.png"/>
+          <p:cNvPr id="4" name="Picture 3" descr="ppt_risk_panel.png"/>
           <p:cNvPicPr>
             <a:picLocks noChangeAspect="1"/>
           </p:cNvPicPr>
@@ -4854,14 +4819,49 @@
         </p:blipFill>
         <p:spPr>
           <a:xfrm>
-            <a:off x="292608" y="1024128"/>
-            <a:ext cx="8549640" cy="10180036"/>
+            <a:off x="2594520" y="1261872"/>
+            <a:ext cx="3954958" cy="4709160"/>
           </a:xfrm>
           <a:prstGeom prst="rect">
             <a:avLst/>
           </a:prstGeom>
         </p:spPr>
       </p:pic>
+      <p:sp>
+        <p:nvSpPr>
+          <p:cNvPr id="5" name="TextBox 4"/>
+          <p:cNvSpPr txBox="1"/>
+          <p:nvPr/>
+        </p:nvSpPr>
+        <p:spPr>
+          <a:xfrm>
+            <a:off x="365760" y="6144768"/>
+            <a:ext cx="8412480" cy="502920"/>
+          </a:xfrm>
+          <a:prstGeom prst="rect">
+            <a:avLst/>
+          </a:prstGeom>
+          <a:noFill/>
+        </p:spPr>
+        <p:txBody>
+          <a:bodyPr wrap="square">
+            <a:spAutoFit/>
+          </a:bodyPr>
+          <a:lstStyle/>
+          <a:p>
+            <a:pPr algn="ctr">
+              <a:defRPr sz="1000">
+                <a:solidFill>
+                  <a:srgbClr val="505050"/>
+                </a:solidFill>
+              </a:defRPr>
+            </a:pPr>
+            <a:r>
+              <a:t>多模态融合输出：风险分数、因素、机器人回应及四项监测指标</a:t>
+            </a:r>
+          </a:p>
+        </p:txBody>
+      </p:sp>
       <p:sp>
         <p:nvSpPr>
           <p:cNvPr id="6" name="TextBox 5"/>
@@ -4870,8 +4870,8 @@
         </p:nvSpPr>
         <p:spPr>
           <a:xfrm>
-            <a:off x="292608" y="4617720"/>
-            <a:ext cx="8549640" cy="411480"/>
+            <a:off x="365760" y="530352"/>
+            <a:ext cx="8412480" cy="566928"/>
           </a:xfrm>
           <a:prstGeom prst="rect">
             <a:avLst/>
@@ -4879,20 +4879,20 @@
           <a:noFill/>
         </p:spPr>
         <p:txBody>
-          <a:bodyPr wrap="none">
+          <a:bodyPr wrap="square">
             <a:spAutoFit/>
           </a:bodyPr>
           <a:lstStyle/>
           <a:p>
-            <a:pPr algn="ctr">
-              <a:defRPr sz="1100">
-                <a:solidFill>
-                  <a:srgbClr val="505050"/>
-                </a:solidFill>
-              </a:defRPr>
-            </a:pPr>
-            <a:r>
-              <a:t>多模态融合输出：风险分数、因素、机器人回应及四项监测指标</a:t>
+            <a:pPr algn="l">
+              <a:defRPr sz="2100" b="1">
+                <a:solidFill>
+                  <a:srgbClr val="1E1E1E"/>
+                </a:solidFill>
+              </a:defRPr>
+            </a:pPr>
+            <a:r>
+              <a:t>系统界面：风险决策仪表盘</a:t>
             </a:r>
           </a:p>
         </p:txBody>
@@ -5013,44 +5013,9 @@
           </a:p>
         </p:txBody>
       </p:sp>
-      <p:sp>
-        <p:nvSpPr>
-          <p:cNvPr id="4" name="TextBox 3"/>
-          <p:cNvSpPr txBox="1"/>
-          <p:nvPr/>
-        </p:nvSpPr>
-        <p:spPr>
-          <a:xfrm>
-            <a:off x="502920" y="685800"/>
-            <a:ext cx="8138160" cy="731520"/>
-          </a:xfrm>
-          <a:prstGeom prst="rect">
-            <a:avLst/>
-          </a:prstGeom>
-          <a:noFill/>
-        </p:spPr>
-        <p:txBody>
-          <a:bodyPr wrap="none">
-            <a:spAutoFit/>
-          </a:bodyPr>
-          <a:lstStyle/>
-          <a:p>
-            <a:pPr algn="l">
-              <a:defRPr sz="2600" b="1">
-                <a:solidFill>
-                  <a:srgbClr val="1E1E1E"/>
-                </a:solidFill>
-              </a:defRPr>
-            </a:pPr>
-            <a:r>
-              <a:t>系统界面：紧急状态监测</a:t>
-            </a:r>
-          </a:p>
-        </p:txBody>
-      </p:sp>
       <p:pic>
         <p:nvPicPr>
-          <p:cNvPr id="5" name="Picture 4" descr="ppt_header_perception.png"/>
+          <p:cNvPr id="4" name="Picture 3" descr="ppt_header_perception.png"/>
           <p:cNvPicPr>
             <a:picLocks noChangeAspect="1"/>
           </p:cNvPicPr>
@@ -5064,14 +5029,49 @@
         </p:blipFill>
         <p:spPr>
           <a:xfrm>
-            <a:off x="292608" y="1024128"/>
-            <a:ext cx="8549640" cy="4425107"/>
+            <a:off x="502919" y="1261872"/>
+            <a:ext cx="8138160" cy="4212133"/>
           </a:xfrm>
           <a:prstGeom prst="rect">
             <a:avLst/>
           </a:prstGeom>
         </p:spPr>
       </p:pic>
+      <p:sp>
+        <p:nvSpPr>
+          <p:cNvPr id="5" name="TextBox 4"/>
+          <p:cNvSpPr txBox="1"/>
+          <p:nvPr/>
+        </p:nvSpPr>
+        <p:spPr>
+          <a:xfrm>
+            <a:off x="365760" y="6144768"/>
+            <a:ext cx="8412480" cy="502920"/>
+          </a:xfrm>
+          <a:prstGeom prst="rect">
+            <a:avLst/>
+          </a:prstGeom>
+          <a:noFill/>
+        </p:spPr>
+        <p:txBody>
+          <a:bodyPr wrap="square">
+            <a:spAutoFit/>
+          </a:bodyPr>
+          <a:lstStyle/>
+          <a:p>
+            <a:pPr algn="ctr">
+              <a:defRPr sz="1000">
+                <a:solidFill>
+                  <a:srgbClr val="505050"/>
+                </a:solidFill>
+              </a:defRPr>
+            </a:pPr>
+            <a:r>
+              <a:t>状态机进入「紧急」· 感知输入与 MediaPipe 视觉模块</a:t>
+            </a:r>
+          </a:p>
+        </p:txBody>
+      </p:sp>
       <p:sp>
         <p:nvSpPr>
           <p:cNvPr id="6" name="TextBox 5"/>
@@ -5080,8 +5080,8 @@
         </p:nvSpPr>
         <p:spPr>
           <a:xfrm>
-            <a:off x="292608" y="4617720"/>
-            <a:ext cx="8549640" cy="411480"/>
+            <a:off x="365760" y="530352"/>
+            <a:ext cx="8412480" cy="566928"/>
           </a:xfrm>
           <a:prstGeom prst="rect">
             <a:avLst/>
@@ -5089,20 +5089,20 @@
           <a:noFill/>
         </p:spPr>
         <p:txBody>
-          <a:bodyPr wrap="none">
+          <a:bodyPr wrap="square">
             <a:spAutoFit/>
           </a:bodyPr>
           <a:lstStyle/>
           <a:p>
-            <a:pPr algn="ctr">
-              <a:defRPr sz="1100">
-                <a:solidFill>
-                  <a:srgbClr val="505050"/>
-                </a:solidFill>
-              </a:defRPr>
-            </a:pPr>
-            <a:r>
-              <a:t>状态机进入「紧急」· 感知输入与 MediaPipe 视觉模块</a:t>
+            <a:pPr algn="l">
+              <a:defRPr sz="2100" b="1">
+                <a:solidFill>
+                  <a:srgbClr val="1E1E1E"/>
+                </a:solidFill>
+              </a:defRPr>
+            </a:pPr>
+            <a:r>
+              <a:t>系统界面：紧急状态监测</a:t>
             </a:r>
           </a:p>
         </p:txBody>
@@ -5223,44 +5223,9 @@
           </a:p>
         </p:txBody>
       </p:sp>
-      <p:sp>
-        <p:nvSpPr>
-          <p:cNvPr id="4" name="TextBox 3"/>
-          <p:cNvSpPr txBox="1"/>
-          <p:nvPr/>
-        </p:nvSpPr>
-        <p:spPr>
-          <a:xfrm>
-            <a:off x="502920" y="685800"/>
-            <a:ext cx="8138160" cy="731520"/>
-          </a:xfrm>
-          <a:prstGeom prst="rect">
-            <a:avLst/>
-          </a:prstGeom>
-          <a:noFill/>
-        </p:spPr>
-        <p:txBody>
-          <a:bodyPr wrap="none">
-            <a:spAutoFit/>
-          </a:bodyPr>
-          <a:lstStyle/>
-          <a:p>
-            <a:pPr algn="l">
-              <a:defRPr sz="2600" b="1">
-                <a:solidFill>
-                  <a:srgbClr val="1E1E1E"/>
-                </a:solidFill>
-              </a:defRPr>
-            </a:pPr>
-            <a:r>
-              <a:t>系统界面：跌倒紧急对话日志</a:t>
-            </a:r>
-          </a:p>
-        </p:txBody>
-      </p:sp>
       <p:pic>
         <p:nvPicPr>
-          <p:cNvPr id="5" name="Picture 4" descr="ppt_chat_emergency.png"/>
+          <p:cNvPr id="4" name="Picture 3" descr="ppt_chat_emergency.png"/>
           <p:cNvPicPr>
             <a:picLocks noChangeAspect="1"/>
           </p:cNvPicPr>
@@ -5274,14 +5239,49 @@
         </p:blipFill>
         <p:spPr>
           <a:xfrm>
-            <a:off x="292608" y="1024128"/>
-            <a:ext cx="8549640" cy="4600441"/>
+            <a:off x="502919" y="1261872"/>
+            <a:ext cx="8138160" cy="4379029"/>
           </a:xfrm>
           <a:prstGeom prst="rect">
             <a:avLst/>
           </a:prstGeom>
         </p:spPr>
       </p:pic>
+      <p:sp>
+        <p:nvSpPr>
+          <p:cNvPr id="5" name="TextBox 4"/>
+          <p:cNvSpPr txBox="1"/>
+          <p:nvPr/>
+        </p:nvSpPr>
+        <p:spPr>
+          <a:xfrm>
+            <a:off x="365760" y="6144768"/>
+            <a:ext cx="8412480" cy="502920"/>
+          </a:xfrm>
+          <a:prstGeom prst="rect">
+            <a:avLst/>
+          </a:prstGeom>
+          <a:noFill/>
+        </p:spPr>
+        <p:txBody>
+          <a:bodyPr wrap="square">
+            <a:spAutoFit/>
+          </a:bodyPr>
+          <a:lstStyle/>
+          <a:p>
+            <a:pPr algn="ctr">
+              <a:defRPr sz="1000">
+                <a:solidFill>
+                  <a:srgbClr val="505050"/>
+                </a:solidFill>
+              </a:defRPr>
+            </a:pPr>
+            <a:r>
+              <a:t>演示完成：跌倒紧急流程已成功触发 · 多次紧急安抚语音</a:t>
+            </a:r>
+          </a:p>
+        </p:txBody>
+      </p:sp>
       <p:sp>
         <p:nvSpPr>
           <p:cNvPr id="6" name="TextBox 5"/>
@@ -5290,8 +5290,8 @@
         </p:nvSpPr>
         <p:spPr>
           <a:xfrm>
-            <a:off x="292608" y="4617720"/>
-            <a:ext cx="8549640" cy="411480"/>
+            <a:off x="365760" y="530352"/>
+            <a:ext cx="8412480" cy="566928"/>
           </a:xfrm>
           <a:prstGeom prst="rect">
             <a:avLst/>
@@ -5299,20 +5299,20 @@
           <a:noFill/>
         </p:spPr>
         <p:txBody>
-          <a:bodyPr wrap="none">
+          <a:bodyPr wrap="square">
             <a:spAutoFit/>
           </a:bodyPr>
           <a:lstStyle/>
           <a:p>
-            <a:pPr algn="ctr">
-              <a:defRPr sz="1100">
-                <a:solidFill>
-                  <a:srgbClr val="505050"/>
-                </a:solidFill>
-              </a:defRPr>
-            </a:pPr>
-            <a:r>
-              <a:t>演示完成：跌倒紧急流程已成功触发 · 多次紧急安抚语音</a:t>
+            <a:pPr algn="l">
+              <a:defRPr sz="2100" b="1">
+                <a:solidFill>
+                  <a:srgbClr val="1E1E1E"/>
+                </a:solidFill>
+              </a:defRPr>
+            </a:pPr>
+            <a:r>
+              <a:t>系统界面：跌倒紧急对话日志</a:t>
             </a:r>
           </a:p>
         </p:txBody>
@@ -5433,44 +5433,9 @@
           </a:p>
         </p:txBody>
       </p:sp>
-      <p:sp>
-        <p:nvSpPr>
-          <p:cNvPr id="4" name="TextBox 3"/>
-          <p:cNvSpPr txBox="1"/>
-          <p:nvPr/>
-        </p:nvSpPr>
-        <p:spPr>
-          <a:xfrm>
-            <a:off x="502920" y="685800"/>
-            <a:ext cx="8138160" cy="731520"/>
-          </a:xfrm>
-          <a:prstGeom prst="rect">
-            <a:avLst/>
-          </a:prstGeom>
-          <a:noFill/>
-        </p:spPr>
-        <p:txBody>
-          <a:bodyPr wrap="none">
-            <a:spAutoFit/>
-          </a:bodyPr>
-          <a:lstStyle/>
-          <a:p>
-            <a:pPr algn="l">
-              <a:defRPr sz="2600" b="1">
-                <a:solidFill>
-                  <a:srgbClr val="1E1E1E"/>
-                </a:solidFill>
-              </a:defRPr>
-            </a:pPr>
-            <a:r>
-              <a:t>系统界面：机器人指令流</a:t>
-            </a:r>
-          </a:p>
-        </p:txBody>
-      </p:sp>
       <p:pic>
         <p:nvPicPr>
-          <p:cNvPr id="5" name="Picture 4" descr="ppt_robot_commands.png"/>
+          <p:cNvPr id="4" name="Picture 3" descr="ppt_robot_commands.png"/>
           <p:cNvPicPr>
             <a:picLocks noChangeAspect="1"/>
           </p:cNvPicPr>
@@ -5484,14 +5449,49 @@
         </p:blipFill>
         <p:spPr>
           <a:xfrm>
-            <a:off x="292608" y="1024128"/>
-            <a:ext cx="8549640" cy="1928679"/>
+            <a:off x="502919" y="1261872"/>
+            <a:ext cx="8138160" cy="1835854"/>
           </a:xfrm>
           <a:prstGeom prst="rect">
             <a:avLst/>
           </a:prstGeom>
         </p:spPr>
       </p:pic>
+      <p:sp>
+        <p:nvSpPr>
+          <p:cNvPr id="5" name="TextBox 4"/>
+          <p:cNvSpPr txBox="1"/>
+          <p:nvPr/>
+        </p:nvSpPr>
+        <p:spPr>
+          <a:xfrm>
+            <a:off x="365760" y="6144768"/>
+            <a:ext cx="8412480" cy="502920"/>
+          </a:xfrm>
+          <a:prstGeom prst="rect">
+            <a:avLst/>
+          </a:prstGeom>
+          <a:noFill/>
+        </p:spPr>
+        <p:txBody>
+          <a:bodyPr wrap="square">
+            <a:spAutoFit/>
+          </a:bodyPr>
+          <a:lstStyle/>
+          <a:p>
+            <a:pPr algn="ctr">
+              <a:defRPr sz="1000">
+                <a:solidFill>
+                  <a:srgbClr val="505050"/>
+                </a:solidFill>
+              </a:defRPr>
+            </a:pPr>
+            <a:r>
+              <a:t>告警音 → 语音 → 紧急呼叫（跌倒事件）→ 举手手势，全链路可追溯</a:t>
+            </a:r>
+          </a:p>
+        </p:txBody>
+      </p:sp>
       <p:sp>
         <p:nvSpPr>
           <p:cNvPr id="6" name="TextBox 5"/>
@@ -5500,8 +5500,8 @@
         </p:nvSpPr>
         <p:spPr>
           <a:xfrm>
-            <a:off x="292608" y="4617720"/>
-            <a:ext cx="8549640" cy="411480"/>
+            <a:off x="365760" y="530352"/>
+            <a:ext cx="8412480" cy="566928"/>
           </a:xfrm>
           <a:prstGeom prst="rect">
             <a:avLst/>
@@ -5509,20 +5509,20 @@
           <a:noFill/>
         </p:spPr>
         <p:txBody>
-          <a:bodyPr wrap="none">
+          <a:bodyPr wrap="square">
             <a:spAutoFit/>
           </a:bodyPr>
           <a:lstStyle/>
           <a:p>
-            <a:pPr algn="ctr">
-              <a:defRPr sz="1100">
-                <a:solidFill>
-                  <a:srgbClr val="505050"/>
-                </a:solidFill>
-              </a:defRPr>
-            </a:pPr>
-            <a:r>
-              <a:t>告警音 → 语音 → 紧急呼叫（跌倒事件）→ 举手手势，全链路可追溯</a:t>
+            <a:pPr algn="l">
+              <a:defRPr sz="2100" b="1">
+                <a:solidFill>
+                  <a:srgbClr val="1E1E1E"/>
+                </a:solidFill>
+              </a:defRPr>
+            </a:pPr>
+            <a:r>
+              <a:t>系统界面：机器人指令流</a:t>
             </a:r>
           </a:p>
         </p:txBody>
@@ -5660,7 +5660,7 @@
           <a:noFill/>
         </p:spPr>
         <p:txBody>
-          <a:bodyPr wrap="none">
+          <a:bodyPr wrap="square">
             <a:spAutoFit/>
           </a:bodyPr>
           <a:lstStyle/>
@@ -5695,7 +5695,7 @@
           <a:noFill/>
         </p:spPr>
         <p:txBody>
-          <a:bodyPr wrap="none">
+          <a:bodyPr wrap="square">
             <a:spAutoFit/>
           </a:bodyPr>
           <a:lstStyle/>
@@ -5846,7 +5846,7 @@
           <a:noFill/>
         </p:spPr>
         <p:txBody>
-          <a:bodyPr wrap="none">
+          <a:bodyPr wrap="square">
             <a:spAutoFit/>
           </a:bodyPr>
           <a:lstStyle/>
@@ -6349,7 +6349,7 @@
           <a:noFill/>
         </p:spPr>
         <p:txBody>
-          <a:bodyPr wrap="none">
+          <a:bodyPr wrap="square">
             <a:spAutoFit/>
           </a:bodyPr>
           <a:lstStyle/>
@@ -6613,7 +6613,7 @@
           <a:noFill/>
         </p:spPr>
         <p:txBody>
-          <a:bodyPr wrap="none">
+          <a:bodyPr wrap="square">
             <a:spAutoFit/>
           </a:bodyPr>
           <a:lstStyle/>
@@ -6648,7 +6648,7 @@
           <a:noFill/>
         </p:spPr>
         <p:txBody>
-          <a:bodyPr wrap="none">
+          <a:bodyPr wrap="square">
             <a:spAutoFit/>
           </a:bodyPr>
           <a:lstStyle/>
@@ -6799,7 +6799,7 @@
           <a:noFill/>
         </p:spPr>
         <p:txBody>
-          <a:bodyPr wrap="none">
+          <a:bodyPr wrap="square">
             <a:spAutoFit/>
           </a:bodyPr>
           <a:lstStyle/>
@@ -7224,7 +7224,7 @@
           <a:noFill/>
         </p:spPr>
         <p:txBody>
-          <a:bodyPr wrap="none">
+          <a:bodyPr wrap="square">
             <a:spAutoFit/>
           </a:bodyPr>
           <a:lstStyle/>
@@ -7473,7 +7473,7 @@
           <a:noFill/>
         </p:spPr>
         <p:txBody>
-          <a:bodyPr wrap="none">
+          <a:bodyPr wrap="square">
             <a:spAutoFit/>
           </a:bodyPr>
           <a:lstStyle/>
@@ -7908,7 +7908,7 @@
           <a:noFill/>
         </p:spPr>
         <p:txBody>
-          <a:bodyPr wrap="none">
+          <a:bodyPr wrap="square">
             <a:spAutoFit/>
           </a:bodyPr>
           <a:lstStyle/>
@@ -8097,7 +8097,7 @@
           <a:noFill/>
         </p:spPr>
         <p:txBody>
-          <a:bodyPr wrap="none">
+          <a:bodyPr wrap="square">
             <a:spAutoFit/>
           </a:bodyPr>
           <a:lstStyle/>
@@ -8472,7 +8472,7 @@
           <a:noFill/>
         </p:spPr>
         <p:txBody>
-          <a:bodyPr wrap="none">
+          <a:bodyPr wrap="square">
             <a:spAutoFit/>
           </a:bodyPr>
           <a:lstStyle/>
@@ -8661,7 +8661,7 @@
           <a:noFill/>
         </p:spPr>
         <p:txBody>
-          <a:bodyPr wrap="none">
+          <a:bodyPr wrap="square">
             <a:spAutoFit/>
           </a:bodyPr>
           <a:lstStyle/>
@@ -8696,7 +8696,7 @@
           <a:noFill/>
         </p:spPr>
         <p:txBody>
-          <a:bodyPr wrap="none">
+          <a:bodyPr wrap="square">
             <a:spAutoFit/>
           </a:bodyPr>
           <a:lstStyle/>
@@ -8847,7 +8847,7 @@
           <a:noFill/>
         </p:spPr>
         <p:txBody>
-          <a:bodyPr wrap="none">
+          <a:bodyPr wrap="square">
             <a:spAutoFit/>
           </a:bodyPr>
           <a:lstStyle/>
@@ -9096,7 +9096,7 @@
           <a:noFill/>
         </p:spPr>
         <p:txBody>
-          <a:bodyPr wrap="none">
+          <a:bodyPr wrap="square">
             <a:spAutoFit/>
           </a:bodyPr>
           <a:lstStyle/>
@@ -9368,7 +9368,7 @@
           <a:noFill/>
         </p:spPr>
         <p:txBody>
-          <a:bodyPr wrap="none">
+          <a:bodyPr wrap="square">
             <a:spAutoFit/>
           </a:bodyPr>
           <a:lstStyle/>

</xml_diff>

<commit_message>
fix(docs): finalize 16:9 PPT layout and 28th competition edition
Compute screenshot placement from actual 10×5.625 slide size, center
images with frame, and update header to the 28th national competition.
</commit_message>
<xml_diff>
--- a/docs/答辩_CareCompanion.pptx
+++ b/docs/答辩_CareCompanion.pptx
@@ -3130,7 +3130,7 @@
         <p:spPr>
           <a:xfrm>
             <a:off x="0" y="0"/>
-            <a:ext cx="9144000" cy="502920"/>
+            <a:ext cx="9144000" cy="475488"/>
           </a:xfrm>
           <a:prstGeom prst="rect">
             <a:avLst/>
@@ -3187,14 +3187,14 @@
           <a:lstStyle/>
           <a:p>
             <a:pPr>
-              <a:defRPr sz="1100" b="1">
+              <a:defRPr sz="1000" b="1">
                 <a:solidFill>
                   <a:srgbClr val="FFFFFF"/>
                 </a:solidFill>
               </a:defRPr>
             </a:pPr>
             <a:r>
-              <a:t>第二十六届中国机器人及人工智能大赛</a:t>
+              <a:t>第二十八届中国机器人及人工智能大赛</a:t>
             </a:r>
           </a:p>
           <a:p>
@@ -3219,7 +3219,7 @@
         </p:nvSpPr>
         <p:spPr>
           <a:xfrm>
-            <a:off x="502920" y="1463040"/>
+            <a:off x="502920" y="1051560"/>
             <a:ext cx="8138160" cy="731520"/>
           </a:xfrm>
           <a:prstGeom prst="rect">
@@ -3234,7 +3234,7 @@
           <a:lstStyle/>
           <a:p>
             <a:pPr algn="ctr">
-              <a:defRPr sz="3600" b="1">
+              <a:defRPr sz="3400" b="1">
                 <a:solidFill>
                   <a:srgbClr val="143278"/>
                 </a:solidFill>
@@ -3254,7 +3254,7 @@
         </p:nvSpPr>
         <p:spPr>
           <a:xfrm>
-            <a:off x="502920" y="2148840"/>
+            <a:off x="502920" y="1627632"/>
             <a:ext cx="8138160" cy="731520"/>
           </a:xfrm>
           <a:prstGeom prst="rect">
@@ -3269,7 +3269,7 @@
           <a:lstStyle/>
           <a:p>
             <a:pPr algn="ctr">
-              <a:defRPr sz="2200" b="1">
+              <a:defRPr sz="2100" b="1">
                 <a:solidFill>
                   <a:srgbClr val="1E1E1E"/>
                 </a:solidFill>
@@ -3289,8 +3289,8 @@
         </p:nvSpPr>
         <p:spPr>
           <a:xfrm>
-            <a:off x="502920" y="2743200"/>
-            <a:ext cx="7315200" cy="3474720"/>
+            <a:off x="502920" y="2240280"/>
+            <a:ext cx="7498079" cy="3474720"/>
           </a:xfrm>
           <a:prstGeom prst="rect">
             <a:avLst/>
@@ -3307,17 +3307,12 @@
               <a:lnSpc>
                 <a:spcPct val="135000"/>
               </a:lnSpc>
-              <a:defRPr sz="1800" b="1">
+              <a:defRPr sz="1600" b="1">
                 <a:solidFill>
                   <a:srgbClr val="1E1E1E"/>
                 </a:solidFill>
               </a:defRPr>
             </a:pPr>
-            <a:r>
-              <a:t>第一部分</a:t>
-            </a:r>
-            <a:br/>
-            <a:br/>
             <a:r>
               <a:t>「感知—决策—执行」一体化的居家养老安全陪伴平台</a:t>
             </a:r>
@@ -3332,7 +3327,7 @@
         </p:nvSpPr>
         <p:spPr>
           <a:xfrm>
-            <a:off x="502920" y="4434840"/>
+            <a:off x="502920" y="4274820"/>
             <a:ext cx="8138160" cy="274320"/>
           </a:xfrm>
           <a:prstGeom prst="rect">
@@ -3354,7 +3349,7 @@
               </a:defRPr>
             </a:pPr>
             <a:r>
-              <a:t>第二十六届中国机器人及人工智能大赛</a:t>
+              <a:t>第二十八届中国机器人及人工智能大赛</a:t>
             </a:r>
           </a:p>
         </p:txBody>
@@ -3367,7 +3362,7 @@
         </p:nvSpPr>
         <p:spPr>
           <a:xfrm>
-            <a:off x="502920" y="4690872"/>
+            <a:off x="502920" y="4512564"/>
             <a:ext cx="8138160" cy="274320"/>
           </a:xfrm>
           <a:prstGeom prst="rect">
@@ -3429,7 +3424,7 @@
         <p:spPr>
           <a:xfrm>
             <a:off x="0" y="0"/>
-            <a:ext cx="9144000" cy="502920"/>
+            <a:ext cx="9144000" cy="475488"/>
           </a:xfrm>
           <a:prstGeom prst="rect">
             <a:avLst/>
@@ -3486,14 +3481,14 @@
           <a:lstStyle/>
           <a:p>
             <a:pPr>
-              <a:defRPr sz="1100" b="1">
+              <a:defRPr sz="1000" b="1">
                 <a:solidFill>
                   <a:srgbClr val="FFFFFF"/>
                 </a:solidFill>
               </a:defRPr>
             </a:pPr>
             <a:r>
-              <a:t>第二十六届中国机器人及人工智能大赛</a:t>
+              <a:t>第二十八届中国机器人及人工智能大赛</a:t>
             </a:r>
           </a:p>
           <a:p>
@@ -3518,7 +3513,7 @@
         </p:nvSpPr>
         <p:spPr>
           <a:xfrm>
-            <a:off x="502920" y="685800"/>
+            <a:off x="502920" y="566928"/>
             <a:ext cx="8138160" cy="731520"/>
           </a:xfrm>
           <a:prstGeom prst="rect">
@@ -3533,7 +3528,7 @@
           <a:lstStyle/>
           <a:p>
             <a:pPr algn="l">
-              <a:defRPr sz="2600" b="1">
+              <a:defRPr sz="2400" b="1">
                 <a:solidFill>
                   <a:srgbClr val="1E1E1E"/>
                 </a:solidFill>
@@ -3648,7 +3643,7 @@
         <p:spPr>
           <a:xfrm>
             <a:off x="0" y="0"/>
-            <a:ext cx="9144000" cy="502920"/>
+            <a:ext cx="9144000" cy="475488"/>
           </a:xfrm>
           <a:prstGeom prst="rect">
             <a:avLst/>
@@ -3705,14 +3700,14 @@
           <a:lstStyle/>
           <a:p>
             <a:pPr>
-              <a:defRPr sz="1100" b="1">
+              <a:defRPr sz="1000" b="1">
                 <a:solidFill>
                   <a:srgbClr val="FFFFFF"/>
                 </a:solidFill>
               </a:defRPr>
             </a:pPr>
             <a:r>
-              <a:t>第二十六届中国机器人及人工智能大赛</a:t>
+              <a:t>第二十八届中国机器人及人工智能大赛</a:t>
             </a:r>
           </a:p>
           <a:p>
@@ -3726,12 +3721,57 @@
             <a:r>
               <a:t>机器人创新赛道</a:t>
             </a:r>
+          </a:p>
+        </p:txBody>
+      </p:sp>
+      <p:sp>
+        <p:nvSpPr>
+          <p:cNvPr id="4" name="Rectangle 3"/>
+          <p:cNvSpPr/>
+          <p:nvPr/>
+        </p:nvSpPr>
+        <p:spPr>
+          <a:xfrm>
+            <a:off x="2375151" y="914400"/>
+            <a:ext cx="4393697" cy="3753611"/>
+          </a:xfrm>
+          <a:prstGeom prst="rect">
+            <a:avLst/>
+          </a:prstGeom>
+          <a:solidFill>
+            <a:srgbClr val="EBF2FA"/>
+          </a:solidFill>
+          <a:ln w="9525">
+            <a:solidFill>
+              <a:srgbClr val="B4C3DC"/>
+            </a:solidFill>
+          </a:ln>
+        </p:spPr>
+        <p:style>
+          <a:lnRef idx="1">
+            <a:schemeClr val="accent1"/>
+          </a:lnRef>
+          <a:fillRef idx="3">
+            <a:schemeClr val="accent1"/>
+          </a:fillRef>
+          <a:effectRef idx="2">
+            <a:schemeClr val="accent1"/>
+          </a:effectRef>
+          <a:fontRef idx="minor">
+            <a:schemeClr val="lt1"/>
+          </a:fontRef>
+        </p:style>
+        <p:txBody>
+          <a:bodyPr rtlCol="0" anchor="ctr"/>
+          <a:lstStyle/>
+          <a:p>
+            <a:pPr algn="ctr"/>
           </a:p>
         </p:txBody>
       </p:sp>
       <p:pic>
         <p:nvPicPr>
-          <p:cNvPr id="4" name="Picture 3" descr="ppt_emotion_input.png"/>
+          <p:cNvPr id="5" name="Picture 4" descr="ppt_emotion_input.png"/>
           <p:cNvPicPr>
             <a:picLocks noChangeAspect="1"/>
           </p:cNvPicPr>
@@ -3745,8 +3785,8 @@
         </p:blipFill>
         <p:spPr>
           <a:xfrm>
-            <a:off x="1803814" y="1261872"/>
-            <a:ext cx="5536371" cy="4709160"/>
+            <a:off x="2430015" y="969264"/>
+            <a:ext cx="4283969" cy="3643884"/>
           </a:xfrm>
           <a:prstGeom prst="rect">
             <a:avLst/>
@@ -3755,14 +3795,49 @@
       </p:pic>
       <p:sp>
         <p:nvSpPr>
-          <p:cNvPr id="5" name="TextBox 4"/>
+          <p:cNvPr id="6" name="TextBox 5"/>
           <p:cNvSpPr txBox="1"/>
           <p:nvPr/>
         </p:nvSpPr>
         <p:spPr>
           <a:xfrm>
-            <a:off x="365760" y="6144768"/>
-            <a:ext cx="8412480" cy="502920"/>
+            <a:off x="411480" y="4638751"/>
+            <a:ext cx="8321040" cy="347472"/>
+          </a:xfrm>
+          <a:prstGeom prst="rect">
+            <a:avLst/>
+          </a:prstGeom>
+          <a:noFill/>
+        </p:spPr>
+        <p:txBody>
+          <a:bodyPr wrap="square" anchor="ctr">
+            <a:spAutoFit/>
+          </a:bodyPr>
+          <a:lstStyle/>
+          <a:p>
+            <a:pPr algn="ctr">
+              <a:defRPr sz="900">
+                <a:solidFill>
+                  <a:srgbClr val="505050"/>
+                </a:solidFill>
+              </a:defRPr>
+            </a:pPr>
+            <a:r>
+              <a:t>老人输入「最近有点孤独，睡不太好」→ 系统识别情绪低落并生成安抚话术</a:t>
+            </a:r>
+          </a:p>
+        </p:txBody>
+      </p:sp>
+      <p:sp>
+        <p:nvSpPr>
+          <p:cNvPr id="7" name="TextBox 6"/>
+          <p:cNvSpPr txBox="1"/>
+          <p:nvPr/>
+        </p:nvSpPr>
+        <p:spPr>
+          <a:xfrm>
+            <a:off x="411480" y="530352"/>
+            <a:ext cx="8321040" cy="384048"/>
           </a:xfrm>
           <a:prstGeom prst="rect">
             <a:avLst/>
@@ -3776,42 +3851,7 @@
           <a:lstStyle/>
           <a:p>
             <a:pPr algn="ctr">
-              <a:defRPr sz="1000">
-                <a:solidFill>
-                  <a:srgbClr val="505050"/>
-                </a:solidFill>
-              </a:defRPr>
-            </a:pPr>
-            <a:r>
-              <a:t>老人输入「最近有点孤独，睡不太好」→ 系统识别情绪低落并生成安抚话术</a:t>
-            </a:r>
-          </a:p>
-        </p:txBody>
-      </p:sp>
-      <p:sp>
-        <p:nvSpPr>
-          <p:cNvPr id="6" name="TextBox 5"/>
-          <p:cNvSpPr txBox="1"/>
-          <p:nvPr/>
-        </p:nvSpPr>
-        <p:spPr>
-          <a:xfrm>
-            <a:off x="365760" y="530352"/>
-            <a:ext cx="8412480" cy="566928"/>
-          </a:xfrm>
-          <a:prstGeom prst="rect">
-            <a:avLst/>
-          </a:prstGeom>
-          <a:noFill/>
-        </p:spPr>
-        <p:txBody>
-          <a:bodyPr wrap="square">
-            <a:spAutoFit/>
-          </a:bodyPr>
-          <a:lstStyle/>
-          <a:p>
-            <a:pPr algn="l">
-              <a:defRPr sz="2100" b="1">
+              <a:defRPr sz="1900" b="1">
                 <a:solidFill>
                   <a:srgbClr val="1E1E1E"/>
                 </a:solidFill>
@@ -3858,7 +3898,7 @@
         <p:spPr>
           <a:xfrm>
             <a:off x="0" y="0"/>
-            <a:ext cx="9144000" cy="502920"/>
+            <a:ext cx="9144000" cy="475488"/>
           </a:xfrm>
           <a:prstGeom prst="rect">
             <a:avLst/>
@@ -3915,14 +3955,14 @@
           <a:lstStyle/>
           <a:p>
             <a:pPr>
-              <a:defRPr sz="1100" b="1">
+              <a:defRPr sz="1000" b="1">
                 <a:solidFill>
                   <a:srgbClr val="FFFFFF"/>
                 </a:solidFill>
               </a:defRPr>
             </a:pPr>
             <a:r>
-              <a:t>第二十六届中国机器人及人工智能大赛</a:t>
+              <a:t>第二十八届中国机器人及人工智能大赛</a:t>
             </a:r>
           </a:p>
           <a:p>
@@ -3947,7 +3987,7 @@
         </p:nvSpPr>
         <p:spPr>
           <a:xfrm>
-            <a:off x="502920" y="685800"/>
+            <a:off x="502920" y="566928"/>
             <a:ext cx="8138160" cy="731520"/>
           </a:xfrm>
           <a:prstGeom prst="rect">
@@ -3962,7 +4002,7 @@
           <a:lstStyle/>
           <a:p>
             <a:pPr algn="l">
-              <a:defRPr sz="2600" b="1">
+              <a:defRPr sz="2400" b="1">
                 <a:solidFill>
                   <a:srgbClr val="1E1E1E"/>
                 </a:solidFill>
@@ -4107,7 +4147,7 @@
         <p:spPr>
           <a:xfrm>
             <a:off x="0" y="0"/>
-            <a:ext cx="9144000" cy="502920"/>
+            <a:ext cx="9144000" cy="475488"/>
           </a:xfrm>
           <a:prstGeom prst="rect">
             <a:avLst/>
@@ -4164,14 +4204,14 @@
           <a:lstStyle/>
           <a:p>
             <a:pPr>
-              <a:defRPr sz="1100" b="1">
+              <a:defRPr sz="1000" b="1">
                 <a:solidFill>
                   <a:srgbClr val="FFFFFF"/>
                 </a:solidFill>
               </a:defRPr>
             </a:pPr>
             <a:r>
-              <a:t>第二十六届中国机器人及人工智能大赛</a:t>
+              <a:t>第二十八届中国机器人及人工智能大赛</a:t>
             </a:r>
           </a:p>
           <a:p>
@@ -4196,7 +4236,7 @@
         </p:nvSpPr>
         <p:spPr>
           <a:xfrm>
-            <a:off x="502920" y="1828800"/>
+            <a:off x="502920" y="2068830"/>
             <a:ext cx="8138160" cy="731520"/>
           </a:xfrm>
           <a:prstGeom prst="rect">
@@ -4211,7 +4251,7 @@
           <a:lstStyle/>
           <a:p>
             <a:pPr algn="ctr">
-              <a:defRPr sz="3200" b="1">
+              <a:defRPr sz="3000" b="1">
                 <a:solidFill>
                   <a:srgbClr val="1E1E1E"/>
                 </a:solidFill>
@@ -4231,7 +4271,7 @@
         </p:nvSpPr>
         <p:spPr>
           <a:xfrm>
-            <a:off x="502920" y="2606040"/>
+            <a:off x="502920" y="2617470"/>
             <a:ext cx="8138160" cy="731520"/>
           </a:xfrm>
           <a:prstGeom prst="rect">
@@ -4246,7 +4286,7 @@
           <a:lstStyle/>
           <a:p>
             <a:pPr algn="ctr">
-              <a:defRPr sz="2200" b="1">
+              <a:defRPr sz="2000" b="1">
                 <a:solidFill>
                   <a:srgbClr val="143278"/>
                 </a:solidFill>
@@ -4293,7 +4333,7 @@
         <p:spPr>
           <a:xfrm>
             <a:off x="0" y="0"/>
-            <a:ext cx="9144000" cy="502920"/>
+            <a:ext cx="9144000" cy="475488"/>
           </a:xfrm>
           <a:prstGeom prst="rect">
             <a:avLst/>
@@ -4350,14 +4390,14 @@
           <a:lstStyle/>
           <a:p>
             <a:pPr>
-              <a:defRPr sz="1100" b="1">
+              <a:defRPr sz="1000" b="1">
                 <a:solidFill>
                   <a:srgbClr val="FFFFFF"/>
                 </a:solidFill>
               </a:defRPr>
             </a:pPr>
             <a:r>
-              <a:t>第二十六届中国机器人及人工智能大赛</a:t>
+              <a:t>第二十八届中国机器人及人工智能大赛</a:t>
             </a:r>
           </a:p>
           <a:p>
@@ -4382,7 +4422,7 @@
         </p:nvSpPr>
         <p:spPr>
           <a:xfrm>
-            <a:off x="502920" y="685800"/>
+            <a:off x="502920" y="566928"/>
             <a:ext cx="8138160" cy="731520"/>
           </a:xfrm>
           <a:prstGeom prst="rect">
@@ -4397,7 +4437,7 @@
           <a:lstStyle/>
           <a:p>
             <a:pPr algn="l">
-              <a:defRPr sz="2600" b="1">
+              <a:defRPr sz="2400" b="1">
                 <a:solidFill>
                   <a:srgbClr val="1E1E1E"/>
                 </a:solidFill>
@@ -4512,7 +4552,7 @@
         <p:spPr>
           <a:xfrm>
             <a:off x="0" y="0"/>
-            <a:ext cx="9144000" cy="502920"/>
+            <a:ext cx="9144000" cy="475488"/>
           </a:xfrm>
           <a:prstGeom prst="rect">
             <a:avLst/>
@@ -4569,14 +4609,14 @@
           <a:lstStyle/>
           <a:p>
             <a:pPr>
-              <a:defRPr sz="1100" b="1">
+              <a:defRPr sz="1000" b="1">
                 <a:solidFill>
                   <a:srgbClr val="FFFFFF"/>
                 </a:solidFill>
               </a:defRPr>
             </a:pPr>
             <a:r>
-              <a:t>第二十六届中国机器人及人工智能大赛</a:t>
+              <a:t>第二十八届中国机器人及人工智能大赛</a:t>
             </a:r>
           </a:p>
           <a:p>
@@ -4590,12 +4630,57 @@
             <a:r>
               <a:t>机器人创新赛道</a:t>
             </a:r>
+          </a:p>
+        </p:txBody>
+      </p:sp>
+      <p:sp>
+        <p:nvSpPr>
+          <p:cNvPr id="4" name="Rectangle 3"/>
+          <p:cNvSpPr/>
+          <p:nvPr/>
+        </p:nvSpPr>
+        <p:spPr>
+          <a:xfrm>
+            <a:off x="1023374" y="914400"/>
+            <a:ext cx="7097250" cy="3753611"/>
+          </a:xfrm>
+          <a:prstGeom prst="rect">
+            <a:avLst/>
+          </a:prstGeom>
+          <a:solidFill>
+            <a:srgbClr val="EBF2FA"/>
+          </a:solidFill>
+          <a:ln w="9525">
+            <a:solidFill>
+              <a:srgbClr val="B4C3DC"/>
+            </a:solidFill>
+          </a:ln>
+        </p:spPr>
+        <p:style>
+          <a:lnRef idx="1">
+            <a:schemeClr val="accent1"/>
+          </a:lnRef>
+          <a:fillRef idx="3">
+            <a:schemeClr val="accent1"/>
+          </a:fillRef>
+          <a:effectRef idx="2">
+            <a:schemeClr val="accent1"/>
+          </a:effectRef>
+          <a:fontRef idx="minor">
+            <a:schemeClr val="lt1"/>
+          </a:fontRef>
+        </p:style>
+        <p:txBody>
+          <a:bodyPr rtlCol="0" anchor="ctr"/>
+          <a:lstStyle/>
+          <a:p>
+            <a:pPr algn="ctr"/>
           </a:p>
         </p:txBody>
       </p:sp>
       <p:pic>
         <p:nvPicPr>
-          <p:cNvPr id="4" name="Picture 3" descr="ppt_full_dashboard.png"/>
+          <p:cNvPr id="5" name="Picture 4" descr="ppt_full_dashboard.png"/>
           <p:cNvPicPr>
             <a:picLocks noChangeAspect="1"/>
           </p:cNvPicPr>
@@ -4609,8 +4694,8 @@
         </p:blipFill>
         <p:spPr>
           <a:xfrm>
-            <a:off x="502919" y="1261872"/>
-            <a:ext cx="8138160" cy="4243923"/>
+            <a:off x="1078238" y="969264"/>
+            <a:ext cx="6987522" cy="3643884"/>
           </a:xfrm>
           <a:prstGeom prst="rect">
             <a:avLst/>
@@ -4619,14 +4704,49 @@
       </p:pic>
       <p:sp>
         <p:nvSpPr>
-          <p:cNvPr id="5" name="TextBox 4"/>
+          <p:cNvPr id="6" name="TextBox 5"/>
           <p:cNvSpPr txBox="1"/>
           <p:nvPr/>
         </p:nvSpPr>
         <p:spPr>
           <a:xfrm>
-            <a:off x="365760" y="6144768"/>
-            <a:ext cx="8412480" cy="502920"/>
+            <a:off x="411480" y="4638751"/>
+            <a:ext cx="8321040" cy="347472"/>
+          </a:xfrm>
+          <a:prstGeom prst="rect">
+            <a:avLst/>
+          </a:prstGeom>
+          <a:noFill/>
+        </p:spPr>
+        <p:txBody>
+          <a:bodyPr wrap="square" anchor="ctr">
+            <a:spAutoFit/>
+          </a:bodyPr>
+          <a:lstStyle/>
+          <a:p>
+            <a:pPr algn="ctr">
+              <a:defRPr sz="900">
+                <a:solidFill>
+                  <a:srgbClr val="505050"/>
+                </a:solidFill>
+              </a:defRPr>
+            </a:pPr>
+            <a:r>
+              <a:t>演示场景「老人倾诉」· 风险 0.23 · 机器人主动安抚回复</a:t>
+            </a:r>
+          </a:p>
+        </p:txBody>
+      </p:sp>
+      <p:sp>
+        <p:nvSpPr>
+          <p:cNvPr id="7" name="TextBox 6"/>
+          <p:cNvSpPr txBox="1"/>
+          <p:nvPr/>
+        </p:nvSpPr>
+        <p:spPr>
+          <a:xfrm>
+            <a:off x="411480" y="530352"/>
+            <a:ext cx="8321040" cy="384048"/>
           </a:xfrm>
           <a:prstGeom prst="rect">
             <a:avLst/>
@@ -4640,42 +4760,7 @@
           <a:lstStyle/>
           <a:p>
             <a:pPr algn="ctr">
-              <a:defRPr sz="1000">
-                <a:solidFill>
-                  <a:srgbClr val="505050"/>
-                </a:solidFill>
-              </a:defRPr>
-            </a:pPr>
-            <a:r>
-              <a:t>演示场景「老人倾诉」· 风险 0.23 · 机器人主动安抚回复</a:t>
-            </a:r>
-          </a:p>
-        </p:txBody>
-      </p:sp>
-      <p:sp>
-        <p:nvSpPr>
-          <p:cNvPr id="6" name="TextBox 5"/>
-          <p:cNvSpPr txBox="1"/>
-          <p:nvPr/>
-        </p:nvSpPr>
-        <p:spPr>
-          <a:xfrm>
-            <a:off x="365760" y="530352"/>
-            <a:ext cx="8412480" cy="566928"/>
-          </a:xfrm>
-          <a:prstGeom prst="rect">
-            <a:avLst/>
-          </a:prstGeom>
-          <a:noFill/>
-        </p:spPr>
-        <p:txBody>
-          <a:bodyPr wrap="square">
-            <a:spAutoFit/>
-          </a:bodyPr>
-          <a:lstStyle/>
-          <a:p>
-            <a:pPr algn="l">
-              <a:defRPr sz="2100" b="1">
+              <a:defRPr sz="1900" b="1">
                 <a:solidFill>
                   <a:srgbClr val="1E1E1E"/>
                 </a:solidFill>
@@ -4722,7 +4807,7 @@
         <p:spPr>
           <a:xfrm>
             <a:off x="0" y="0"/>
-            <a:ext cx="9144000" cy="502920"/>
+            <a:ext cx="9144000" cy="475488"/>
           </a:xfrm>
           <a:prstGeom prst="rect">
             <a:avLst/>
@@ -4779,14 +4864,14 @@
           <a:lstStyle/>
           <a:p>
             <a:pPr>
-              <a:defRPr sz="1100" b="1">
+              <a:defRPr sz="1000" b="1">
                 <a:solidFill>
                   <a:srgbClr val="FFFFFF"/>
                 </a:solidFill>
               </a:defRPr>
             </a:pPr>
             <a:r>
-              <a:t>第二十六届中国机器人及人工智能大赛</a:t>
+              <a:t>第二十八届中国机器人及人工智能大赛</a:t>
             </a:r>
           </a:p>
           <a:p>
@@ -4800,12 +4885,57 @@
             <a:r>
               <a:t>机器人创新赛道</a:t>
             </a:r>
+          </a:p>
+        </p:txBody>
+      </p:sp>
+      <p:sp>
+        <p:nvSpPr>
+          <p:cNvPr id="4" name="Rectangle 3"/>
+          <p:cNvSpPr/>
+          <p:nvPr/>
+        </p:nvSpPr>
+        <p:spPr>
+          <a:xfrm>
+            <a:off x="2986989" y="914400"/>
+            <a:ext cx="3170021" cy="3753611"/>
+          </a:xfrm>
+          <a:prstGeom prst="rect">
+            <a:avLst/>
+          </a:prstGeom>
+          <a:solidFill>
+            <a:srgbClr val="EBF2FA"/>
+          </a:solidFill>
+          <a:ln w="9525">
+            <a:solidFill>
+              <a:srgbClr val="B4C3DC"/>
+            </a:solidFill>
+          </a:ln>
+        </p:spPr>
+        <p:style>
+          <a:lnRef idx="1">
+            <a:schemeClr val="accent1"/>
+          </a:lnRef>
+          <a:fillRef idx="3">
+            <a:schemeClr val="accent1"/>
+          </a:fillRef>
+          <a:effectRef idx="2">
+            <a:schemeClr val="accent1"/>
+          </a:effectRef>
+          <a:fontRef idx="minor">
+            <a:schemeClr val="lt1"/>
+          </a:fontRef>
+        </p:style>
+        <p:txBody>
+          <a:bodyPr rtlCol="0" anchor="ctr"/>
+          <a:lstStyle/>
+          <a:p>
+            <a:pPr algn="ctr"/>
           </a:p>
         </p:txBody>
       </p:sp>
       <p:pic>
         <p:nvPicPr>
-          <p:cNvPr id="4" name="Picture 3" descr="ppt_risk_panel.png"/>
+          <p:cNvPr id="5" name="Picture 4" descr="ppt_risk_panel.png"/>
           <p:cNvPicPr>
             <a:picLocks noChangeAspect="1"/>
           </p:cNvPicPr>
@@ -4819,8 +4949,8 @@
         </p:blipFill>
         <p:spPr>
           <a:xfrm>
-            <a:off x="2594520" y="1261872"/>
-            <a:ext cx="3954958" cy="4709160"/>
+            <a:off x="3041853" y="969264"/>
+            <a:ext cx="3060293" cy="3643884"/>
           </a:xfrm>
           <a:prstGeom prst="rect">
             <a:avLst/>
@@ -4829,14 +4959,49 @@
       </p:pic>
       <p:sp>
         <p:nvSpPr>
-          <p:cNvPr id="5" name="TextBox 4"/>
+          <p:cNvPr id="6" name="TextBox 5"/>
           <p:cNvSpPr txBox="1"/>
           <p:nvPr/>
         </p:nvSpPr>
         <p:spPr>
           <a:xfrm>
-            <a:off x="365760" y="6144768"/>
-            <a:ext cx="8412480" cy="502920"/>
+            <a:off x="411480" y="4638751"/>
+            <a:ext cx="8321040" cy="347472"/>
+          </a:xfrm>
+          <a:prstGeom prst="rect">
+            <a:avLst/>
+          </a:prstGeom>
+          <a:noFill/>
+        </p:spPr>
+        <p:txBody>
+          <a:bodyPr wrap="square" anchor="ctr">
+            <a:spAutoFit/>
+          </a:bodyPr>
+          <a:lstStyle/>
+          <a:p>
+            <a:pPr algn="ctr">
+              <a:defRPr sz="900">
+                <a:solidFill>
+                  <a:srgbClr val="505050"/>
+                </a:solidFill>
+              </a:defRPr>
+            </a:pPr>
+            <a:r>
+              <a:t>多模态融合输出：风险分数、因素、机器人回应及四项监测指标</a:t>
+            </a:r>
+          </a:p>
+        </p:txBody>
+      </p:sp>
+      <p:sp>
+        <p:nvSpPr>
+          <p:cNvPr id="7" name="TextBox 6"/>
+          <p:cNvSpPr txBox="1"/>
+          <p:nvPr/>
+        </p:nvSpPr>
+        <p:spPr>
+          <a:xfrm>
+            <a:off x="411480" y="530352"/>
+            <a:ext cx="8321040" cy="384048"/>
           </a:xfrm>
           <a:prstGeom prst="rect">
             <a:avLst/>
@@ -4850,42 +5015,7 @@
           <a:lstStyle/>
           <a:p>
             <a:pPr algn="ctr">
-              <a:defRPr sz="1000">
-                <a:solidFill>
-                  <a:srgbClr val="505050"/>
-                </a:solidFill>
-              </a:defRPr>
-            </a:pPr>
-            <a:r>
-              <a:t>多模态融合输出：风险分数、因素、机器人回应及四项监测指标</a:t>
-            </a:r>
-          </a:p>
-        </p:txBody>
-      </p:sp>
-      <p:sp>
-        <p:nvSpPr>
-          <p:cNvPr id="6" name="TextBox 5"/>
-          <p:cNvSpPr txBox="1"/>
-          <p:nvPr/>
-        </p:nvSpPr>
-        <p:spPr>
-          <a:xfrm>
-            <a:off x="365760" y="530352"/>
-            <a:ext cx="8412480" cy="566928"/>
-          </a:xfrm>
-          <a:prstGeom prst="rect">
-            <a:avLst/>
-          </a:prstGeom>
-          <a:noFill/>
-        </p:spPr>
-        <p:txBody>
-          <a:bodyPr wrap="square">
-            <a:spAutoFit/>
-          </a:bodyPr>
-          <a:lstStyle/>
-          <a:p>
-            <a:pPr algn="l">
-              <a:defRPr sz="2100" b="1">
+              <a:defRPr sz="1900" b="1">
                 <a:solidFill>
                   <a:srgbClr val="1E1E1E"/>
                 </a:solidFill>
@@ -4932,7 +5062,7 @@
         <p:spPr>
           <a:xfrm>
             <a:off x="0" y="0"/>
-            <a:ext cx="9144000" cy="502920"/>
+            <a:ext cx="9144000" cy="475488"/>
           </a:xfrm>
           <a:prstGeom prst="rect">
             <a:avLst/>
@@ -4989,14 +5119,14 @@
           <a:lstStyle/>
           <a:p>
             <a:pPr>
-              <a:defRPr sz="1100" b="1">
+              <a:defRPr sz="1000" b="1">
                 <a:solidFill>
                   <a:srgbClr val="FFFFFF"/>
                 </a:solidFill>
               </a:defRPr>
             </a:pPr>
             <a:r>
-              <a:t>第二十六届中国机器人及人工智能大赛</a:t>
+              <a:t>第二十八届中国机器人及人工智能大赛</a:t>
             </a:r>
           </a:p>
           <a:p>
@@ -5010,12 +5140,57 @@
             <a:r>
               <a:t>机器人创新赛道</a:t>
             </a:r>
+          </a:p>
+        </p:txBody>
+      </p:sp>
+      <p:sp>
+        <p:nvSpPr>
+          <p:cNvPr id="4" name="Rectangle 3"/>
+          <p:cNvSpPr/>
+          <p:nvPr/>
+        </p:nvSpPr>
+        <p:spPr>
+          <a:xfrm>
+            <a:off x="997006" y="914400"/>
+            <a:ext cx="7149986" cy="3753611"/>
+          </a:xfrm>
+          <a:prstGeom prst="rect">
+            <a:avLst/>
+          </a:prstGeom>
+          <a:solidFill>
+            <a:srgbClr val="EBF2FA"/>
+          </a:solidFill>
+          <a:ln w="9525">
+            <a:solidFill>
+              <a:srgbClr val="B4C3DC"/>
+            </a:solidFill>
+          </a:ln>
+        </p:spPr>
+        <p:style>
+          <a:lnRef idx="1">
+            <a:schemeClr val="accent1"/>
+          </a:lnRef>
+          <a:fillRef idx="3">
+            <a:schemeClr val="accent1"/>
+          </a:fillRef>
+          <a:effectRef idx="2">
+            <a:schemeClr val="accent1"/>
+          </a:effectRef>
+          <a:fontRef idx="minor">
+            <a:schemeClr val="lt1"/>
+          </a:fontRef>
+        </p:style>
+        <p:txBody>
+          <a:bodyPr rtlCol="0" anchor="ctr"/>
+          <a:lstStyle/>
+          <a:p>
+            <a:pPr algn="ctr"/>
           </a:p>
         </p:txBody>
       </p:sp>
       <p:pic>
         <p:nvPicPr>
-          <p:cNvPr id="4" name="Picture 3" descr="ppt_header_perception.png"/>
+          <p:cNvPr id="5" name="Picture 4" descr="ppt_header_perception.png"/>
           <p:cNvPicPr>
             <a:picLocks noChangeAspect="1"/>
           </p:cNvPicPr>
@@ -5029,8 +5204,8 @@
         </p:blipFill>
         <p:spPr>
           <a:xfrm>
-            <a:off x="502919" y="1261872"/>
-            <a:ext cx="8138160" cy="4212133"/>
+            <a:off x="1051870" y="969264"/>
+            <a:ext cx="7040258" cy="3643884"/>
           </a:xfrm>
           <a:prstGeom prst="rect">
             <a:avLst/>
@@ -5039,14 +5214,49 @@
       </p:pic>
       <p:sp>
         <p:nvSpPr>
-          <p:cNvPr id="5" name="TextBox 4"/>
+          <p:cNvPr id="6" name="TextBox 5"/>
           <p:cNvSpPr txBox="1"/>
           <p:nvPr/>
         </p:nvSpPr>
         <p:spPr>
           <a:xfrm>
-            <a:off x="365760" y="6144768"/>
-            <a:ext cx="8412480" cy="502920"/>
+            <a:off x="411480" y="4638751"/>
+            <a:ext cx="8321040" cy="347472"/>
+          </a:xfrm>
+          <a:prstGeom prst="rect">
+            <a:avLst/>
+          </a:prstGeom>
+          <a:noFill/>
+        </p:spPr>
+        <p:txBody>
+          <a:bodyPr wrap="square" anchor="ctr">
+            <a:spAutoFit/>
+          </a:bodyPr>
+          <a:lstStyle/>
+          <a:p>
+            <a:pPr algn="ctr">
+              <a:defRPr sz="900">
+                <a:solidFill>
+                  <a:srgbClr val="505050"/>
+                </a:solidFill>
+              </a:defRPr>
+            </a:pPr>
+            <a:r>
+              <a:t>状态机进入「紧急」· 感知输入与 MediaPipe 视觉模块</a:t>
+            </a:r>
+          </a:p>
+        </p:txBody>
+      </p:sp>
+      <p:sp>
+        <p:nvSpPr>
+          <p:cNvPr id="7" name="TextBox 6"/>
+          <p:cNvSpPr txBox="1"/>
+          <p:nvPr/>
+        </p:nvSpPr>
+        <p:spPr>
+          <a:xfrm>
+            <a:off x="411480" y="530352"/>
+            <a:ext cx="8321040" cy="384048"/>
           </a:xfrm>
           <a:prstGeom prst="rect">
             <a:avLst/>
@@ -5060,42 +5270,7 @@
           <a:lstStyle/>
           <a:p>
             <a:pPr algn="ctr">
-              <a:defRPr sz="1000">
-                <a:solidFill>
-                  <a:srgbClr val="505050"/>
-                </a:solidFill>
-              </a:defRPr>
-            </a:pPr>
-            <a:r>
-              <a:t>状态机进入「紧急」· 感知输入与 MediaPipe 视觉模块</a:t>
-            </a:r>
-          </a:p>
-        </p:txBody>
-      </p:sp>
-      <p:sp>
-        <p:nvSpPr>
-          <p:cNvPr id="6" name="TextBox 5"/>
-          <p:cNvSpPr txBox="1"/>
-          <p:nvPr/>
-        </p:nvSpPr>
-        <p:spPr>
-          <a:xfrm>
-            <a:off x="365760" y="530352"/>
-            <a:ext cx="8412480" cy="566928"/>
-          </a:xfrm>
-          <a:prstGeom prst="rect">
-            <a:avLst/>
-          </a:prstGeom>
-          <a:noFill/>
-        </p:spPr>
-        <p:txBody>
-          <a:bodyPr wrap="square">
-            <a:spAutoFit/>
-          </a:bodyPr>
-          <a:lstStyle/>
-          <a:p>
-            <a:pPr algn="l">
-              <a:defRPr sz="2100" b="1">
+              <a:defRPr sz="1900" b="1">
                 <a:solidFill>
                   <a:srgbClr val="1E1E1E"/>
                 </a:solidFill>
@@ -5142,7 +5317,7 @@
         <p:spPr>
           <a:xfrm>
             <a:off x="0" y="0"/>
-            <a:ext cx="9144000" cy="502920"/>
+            <a:ext cx="9144000" cy="475488"/>
           </a:xfrm>
           <a:prstGeom prst="rect">
             <a:avLst/>
@@ -5199,14 +5374,14 @@
           <a:lstStyle/>
           <a:p>
             <a:pPr>
-              <a:defRPr sz="1100" b="1">
+              <a:defRPr sz="1000" b="1">
                 <a:solidFill>
                   <a:srgbClr val="FFFFFF"/>
                 </a:solidFill>
               </a:defRPr>
             </a:pPr>
             <a:r>
-              <a:t>第二十六届中国机器人及人工智能大赛</a:t>
+              <a:t>第二十八届中国机器人及人工智能大赛</a:t>
             </a:r>
           </a:p>
           <a:p>
@@ -5220,12 +5395,57 @@
             <a:r>
               <a:t>机器人创新赛道</a:t>
             </a:r>
+          </a:p>
+        </p:txBody>
+      </p:sp>
+      <p:sp>
+        <p:nvSpPr>
+          <p:cNvPr id="4" name="Rectangle 3"/>
+          <p:cNvSpPr/>
+          <p:nvPr/>
+        </p:nvSpPr>
+        <p:spPr>
+          <a:xfrm>
+            <a:off x="1131167" y="914400"/>
+            <a:ext cx="6881664" cy="3753611"/>
+          </a:xfrm>
+          <a:prstGeom prst="rect">
+            <a:avLst/>
+          </a:prstGeom>
+          <a:solidFill>
+            <a:srgbClr val="EBF2FA"/>
+          </a:solidFill>
+          <a:ln w="9525">
+            <a:solidFill>
+              <a:srgbClr val="B4C3DC"/>
+            </a:solidFill>
+          </a:ln>
+        </p:spPr>
+        <p:style>
+          <a:lnRef idx="1">
+            <a:schemeClr val="accent1"/>
+          </a:lnRef>
+          <a:fillRef idx="3">
+            <a:schemeClr val="accent1"/>
+          </a:fillRef>
+          <a:effectRef idx="2">
+            <a:schemeClr val="accent1"/>
+          </a:effectRef>
+          <a:fontRef idx="minor">
+            <a:schemeClr val="lt1"/>
+          </a:fontRef>
+        </p:style>
+        <p:txBody>
+          <a:bodyPr rtlCol="0" anchor="ctr"/>
+          <a:lstStyle/>
+          <a:p>
+            <a:pPr algn="ctr"/>
           </a:p>
         </p:txBody>
       </p:sp>
       <p:pic>
         <p:nvPicPr>
-          <p:cNvPr id="4" name="Picture 3" descr="ppt_chat_emergency.png"/>
+          <p:cNvPr id="5" name="Picture 4" descr="ppt_chat_emergency.png"/>
           <p:cNvPicPr>
             <a:picLocks noChangeAspect="1"/>
           </p:cNvPicPr>
@@ -5239,8 +5459,8 @@
         </p:blipFill>
         <p:spPr>
           <a:xfrm>
-            <a:off x="502919" y="1261872"/>
-            <a:ext cx="8138160" cy="4379029"/>
+            <a:off x="1186031" y="969264"/>
+            <a:ext cx="6771936" cy="3643884"/>
           </a:xfrm>
           <a:prstGeom prst="rect">
             <a:avLst/>
@@ -5249,14 +5469,49 @@
       </p:pic>
       <p:sp>
         <p:nvSpPr>
-          <p:cNvPr id="5" name="TextBox 4"/>
+          <p:cNvPr id="6" name="TextBox 5"/>
           <p:cNvSpPr txBox="1"/>
           <p:nvPr/>
         </p:nvSpPr>
         <p:spPr>
           <a:xfrm>
-            <a:off x="365760" y="6144768"/>
-            <a:ext cx="8412480" cy="502920"/>
+            <a:off x="411480" y="4638751"/>
+            <a:ext cx="8321040" cy="347472"/>
+          </a:xfrm>
+          <a:prstGeom prst="rect">
+            <a:avLst/>
+          </a:prstGeom>
+          <a:noFill/>
+        </p:spPr>
+        <p:txBody>
+          <a:bodyPr wrap="square" anchor="ctr">
+            <a:spAutoFit/>
+          </a:bodyPr>
+          <a:lstStyle/>
+          <a:p>
+            <a:pPr algn="ctr">
+              <a:defRPr sz="900">
+                <a:solidFill>
+                  <a:srgbClr val="505050"/>
+                </a:solidFill>
+              </a:defRPr>
+            </a:pPr>
+            <a:r>
+              <a:t>演示完成：跌倒紧急流程已成功触发 · 多次紧急安抚语音</a:t>
+            </a:r>
+          </a:p>
+        </p:txBody>
+      </p:sp>
+      <p:sp>
+        <p:nvSpPr>
+          <p:cNvPr id="7" name="TextBox 6"/>
+          <p:cNvSpPr txBox="1"/>
+          <p:nvPr/>
+        </p:nvSpPr>
+        <p:spPr>
+          <a:xfrm>
+            <a:off x="411480" y="530352"/>
+            <a:ext cx="8321040" cy="384048"/>
           </a:xfrm>
           <a:prstGeom prst="rect">
             <a:avLst/>
@@ -5270,42 +5525,7 @@
           <a:lstStyle/>
           <a:p>
             <a:pPr algn="ctr">
-              <a:defRPr sz="1000">
-                <a:solidFill>
-                  <a:srgbClr val="505050"/>
-                </a:solidFill>
-              </a:defRPr>
-            </a:pPr>
-            <a:r>
-              <a:t>演示完成：跌倒紧急流程已成功触发 · 多次紧急安抚语音</a:t>
-            </a:r>
-          </a:p>
-        </p:txBody>
-      </p:sp>
-      <p:sp>
-        <p:nvSpPr>
-          <p:cNvPr id="6" name="TextBox 5"/>
-          <p:cNvSpPr txBox="1"/>
-          <p:nvPr/>
-        </p:nvSpPr>
-        <p:spPr>
-          <a:xfrm>
-            <a:off x="365760" y="530352"/>
-            <a:ext cx="8412480" cy="566928"/>
-          </a:xfrm>
-          <a:prstGeom prst="rect">
-            <a:avLst/>
-          </a:prstGeom>
-          <a:noFill/>
-        </p:spPr>
-        <p:txBody>
-          <a:bodyPr wrap="square">
-            <a:spAutoFit/>
-          </a:bodyPr>
-          <a:lstStyle/>
-          <a:p>
-            <a:pPr algn="l">
-              <a:defRPr sz="2100" b="1">
+              <a:defRPr sz="1900" b="1">
                 <a:solidFill>
                   <a:srgbClr val="1E1E1E"/>
                 </a:solidFill>
@@ -5352,7 +5572,7 @@
         <p:spPr>
           <a:xfrm>
             <a:off x="0" y="0"/>
-            <a:ext cx="9144000" cy="502920"/>
+            <a:ext cx="9144000" cy="475488"/>
           </a:xfrm>
           <a:prstGeom prst="rect">
             <a:avLst/>
@@ -5409,14 +5629,14 @@
           <a:lstStyle/>
           <a:p>
             <a:pPr>
-              <a:defRPr sz="1100" b="1">
+              <a:defRPr sz="1000" b="1">
                 <a:solidFill>
                   <a:srgbClr val="FFFFFF"/>
                 </a:solidFill>
               </a:defRPr>
             </a:pPr>
             <a:r>
-              <a:t>第二十六届中国机器人及人工智能大赛</a:t>
+              <a:t>第二十八届中国机器人及人工智能大赛</a:t>
             </a:r>
           </a:p>
           <a:p>
@@ -5430,12 +5650,57 @@
             <a:r>
               <a:t>机器人创新赛道</a:t>
             </a:r>
+          </a:p>
+        </p:txBody>
+      </p:sp>
+      <p:sp>
+        <p:nvSpPr>
+          <p:cNvPr id="4" name="Rectangle 3"/>
+          <p:cNvSpPr/>
+          <p:nvPr/>
+        </p:nvSpPr>
+        <p:spPr>
+          <a:xfrm>
+            <a:off x="356616" y="1797787"/>
+            <a:ext cx="8430767" cy="1986837"/>
+          </a:xfrm>
+          <a:prstGeom prst="rect">
+            <a:avLst/>
+          </a:prstGeom>
+          <a:solidFill>
+            <a:srgbClr val="EBF2FA"/>
+          </a:solidFill>
+          <a:ln w="9525">
+            <a:solidFill>
+              <a:srgbClr val="B4C3DC"/>
+            </a:solidFill>
+          </a:ln>
+        </p:spPr>
+        <p:style>
+          <a:lnRef idx="1">
+            <a:schemeClr val="accent1"/>
+          </a:lnRef>
+          <a:fillRef idx="3">
+            <a:schemeClr val="accent1"/>
+          </a:fillRef>
+          <a:effectRef idx="2">
+            <a:schemeClr val="accent1"/>
+          </a:effectRef>
+          <a:fontRef idx="minor">
+            <a:schemeClr val="lt1"/>
+          </a:fontRef>
+        </p:style>
+        <p:txBody>
+          <a:bodyPr rtlCol="0" anchor="ctr"/>
+          <a:lstStyle/>
+          <a:p>
+            <a:pPr algn="ctr"/>
           </a:p>
         </p:txBody>
       </p:sp>
       <p:pic>
         <p:nvPicPr>
-          <p:cNvPr id="4" name="Picture 3" descr="ppt_robot_commands.png"/>
+          <p:cNvPr id="5" name="Picture 4" descr="ppt_robot_commands.png"/>
           <p:cNvPicPr>
             <a:picLocks noChangeAspect="1"/>
           </p:cNvPicPr>
@@ -5449,8 +5714,8 @@
         </p:blipFill>
         <p:spPr>
           <a:xfrm>
-            <a:off x="502919" y="1261872"/>
-            <a:ext cx="8138160" cy="1835854"/>
+            <a:off x="411480" y="1852651"/>
+            <a:ext cx="8321040" cy="1877110"/>
           </a:xfrm>
           <a:prstGeom prst="rect">
             <a:avLst/>
@@ -5459,14 +5724,49 @@
       </p:pic>
       <p:sp>
         <p:nvSpPr>
-          <p:cNvPr id="5" name="TextBox 4"/>
+          <p:cNvPr id="6" name="TextBox 5"/>
           <p:cNvSpPr txBox="1"/>
           <p:nvPr/>
         </p:nvSpPr>
         <p:spPr>
           <a:xfrm>
-            <a:off x="365760" y="6144768"/>
-            <a:ext cx="8412480" cy="502920"/>
+            <a:off x="411480" y="4638751"/>
+            <a:ext cx="8321040" cy="347472"/>
+          </a:xfrm>
+          <a:prstGeom prst="rect">
+            <a:avLst/>
+          </a:prstGeom>
+          <a:noFill/>
+        </p:spPr>
+        <p:txBody>
+          <a:bodyPr wrap="square" anchor="ctr">
+            <a:spAutoFit/>
+          </a:bodyPr>
+          <a:lstStyle/>
+          <a:p>
+            <a:pPr algn="ctr">
+              <a:defRPr sz="900">
+                <a:solidFill>
+                  <a:srgbClr val="505050"/>
+                </a:solidFill>
+              </a:defRPr>
+            </a:pPr>
+            <a:r>
+              <a:t>告警音 → 语音 → 紧急呼叫（跌倒事件）→ 举手手势，全链路可追溯</a:t>
+            </a:r>
+          </a:p>
+        </p:txBody>
+      </p:sp>
+      <p:sp>
+        <p:nvSpPr>
+          <p:cNvPr id="7" name="TextBox 6"/>
+          <p:cNvSpPr txBox="1"/>
+          <p:nvPr/>
+        </p:nvSpPr>
+        <p:spPr>
+          <a:xfrm>
+            <a:off x="411480" y="530352"/>
+            <a:ext cx="8321040" cy="384048"/>
           </a:xfrm>
           <a:prstGeom prst="rect">
             <a:avLst/>
@@ -5480,42 +5780,7 @@
           <a:lstStyle/>
           <a:p>
             <a:pPr algn="ctr">
-              <a:defRPr sz="1000">
-                <a:solidFill>
-                  <a:srgbClr val="505050"/>
-                </a:solidFill>
-              </a:defRPr>
-            </a:pPr>
-            <a:r>
-              <a:t>告警音 → 语音 → 紧急呼叫（跌倒事件）→ 举手手势，全链路可追溯</a:t>
-            </a:r>
-          </a:p>
-        </p:txBody>
-      </p:sp>
-      <p:sp>
-        <p:nvSpPr>
-          <p:cNvPr id="6" name="TextBox 5"/>
-          <p:cNvSpPr txBox="1"/>
-          <p:nvPr/>
-        </p:nvSpPr>
-        <p:spPr>
-          <a:xfrm>
-            <a:off x="365760" y="530352"/>
-            <a:ext cx="8412480" cy="566928"/>
-          </a:xfrm>
-          <a:prstGeom prst="rect">
-            <a:avLst/>
-          </a:prstGeom>
-          <a:noFill/>
-        </p:spPr>
-        <p:txBody>
-          <a:bodyPr wrap="square">
-            <a:spAutoFit/>
-          </a:bodyPr>
-          <a:lstStyle/>
-          <a:p>
-            <a:pPr algn="l">
-              <a:defRPr sz="2100" b="1">
+              <a:defRPr sz="1900" b="1">
                 <a:solidFill>
                   <a:srgbClr val="1E1E1E"/>
                 </a:solidFill>
@@ -5562,7 +5827,7 @@
         <p:spPr>
           <a:xfrm>
             <a:off x="0" y="0"/>
-            <a:ext cx="9144000" cy="502920"/>
+            <a:ext cx="9144000" cy="475488"/>
           </a:xfrm>
           <a:prstGeom prst="rect">
             <a:avLst/>
@@ -5619,14 +5884,14 @@
           <a:lstStyle/>
           <a:p>
             <a:pPr>
-              <a:defRPr sz="1100" b="1">
+              <a:defRPr sz="1000" b="1">
                 <a:solidFill>
                   <a:srgbClr val="FFFFFF"/>
                 </a:solidFill>
               </a:defRPr>
             </a:pPr>
             <a:r>
-              <a:t>第二十六届中国机器人及人工智能大赛</a:t>
+              <a:t>第二十八届中国机器人及人工智能大赛</a:t>
             </a:r>
           </a:p>
           <a:p>
@@ -5651,7 +5916,7 @@
         </p:nvSpPr>
         <p:spPr>
           <a:xfrm>
-            <a:off x="502920" y="1828800"/>
+            <a:off x="502920" y="2068830"/>
             <a:ext cx="8138160" cy="731520"/>
           </a:xfrm>
           <a:prstGeom prst="rect">
@@ -5666,7 +5931,7 @@
           <a:lstStyle/>
           <a:p>
             <a:pPr algn="ctr">
-              <a:defRPr sz="3200" b="1">
+              <a:defRPr sz="3000" b="1">
                 <a:solidFill>
                   <a:srgbClr val="1E1E1E"/>
                 </a:solidFill>
@@ -5686,7 +5951,7 @@
         </p:nvSpPr>
         <p:spPr>
           <a:xfrm>
-            <a:off x="502920" y="2606040"/>
+            <a:off x="502920" y="2617470"/>
             <a:ext cx="8138160" cy="731520"/>
           </a:xfrm>
           <a:prstGeom prst="rect">
@@ -5701,7 +5966,7 @@
           <a:lstStyle/>
           <a:p>
             <a:pPr algn="ctr">
-              <a:defRPr sz="2200" b="1">
+              <a:defRPr sz="2000" b="1">
                 <a:solidFill>
                   <a:srgbClr val="143278"/>
                 </a:solidFill>
@@ -5748,7 +6013,7 @@
         <p:spPr>
           <a:xfrm>
             <a:off x="0" y="0"/>
-            <a:ext cx="9144000" cy="502920"/>
+            <a:ext cx="9144000" cy="475488"/>
           </a:xfrm>
           <a:prstGeom prst="rect">
             <a:avLst/>
@@ -5805,14 +6070,14 @@
           <a:lstStyle/>
           <a:p>
             <a:pPr>
-              <a:defRPr sz="1100" b="1">
+              <a:defRPr sz="1000" b="1">
                 <a:solidFill>
                   <a:srgbClr val="FFFFFF"/>
                 </a:solidFill>
               </a:defRPr>
             </a:pPr>
             <a:r>
-              <a:t>第二十六届中国机器人及人工智能大赛</a:t>
+              <a:t>第二十八届中国机器人及人工智能大赛</a:t>
             </a:r>
           </a:p>
           <a:p>
@@ -5837,7 +6102,7 @@
         </p:nvSpPr>
         <p:spPr>
           <a:xfrm>
-            <a:off x="502920" y="685800"/>
+            <a:off x="502920" y="566928"/>
             <a:ext cx="8138160" cy="731520"/>
           </a:xfrm>
           <a:prstGeom prst="rect">
@@ -5852,7 +6117,7 @@
           <a:lstStyle/>
           <a:p>
             <a:pPr algn="l">
-              <a:defRPr sz="2600" b="1">
+              <a:defRPr sz="2400" b="1">
                 <a:solidFill>
                   <a:srgbClr val="1E1E1E"/>
                 </a:solidFill>
@@ -6186,7 +6451,7 @@
         </p:nvSpPr>
         <p:spPr>
           <a:xfrm>
-            <a:off x="502920" y="3977639"/>
+            <a:off x="502920" y="3703320"/>
             <a:ext cx="8138160" cy="3474720"/>
           </a:xfrm>
           <a:prstGeom prst="rect">
@@ -6251,7 +6516,7 @@
         <p:spPr>
           <a:xfrm>
             <a:off x="0" y="0"/>
-            <a:ext cx="9144000" cy="502920"/>
+            <a:ext cx="9144000" cy="475488"/>
           </a:xfrm>
           <a:prstGeom prst="rect">
             <a:avLst/>
@@ -6308,14 +6573,14 @@
           <a:lstStyle/>
           <a:p>
             <a:pPr>
-              <a:defRPr sz="1100" b="1">
+              <a:defRPr sz="1000" b="1">
                 <a:solidFill>
                   <a:srgbClr val="FFFFFF"/>
                 </a:solidFill>
               </a:defRPr>
             </a:pPr>
             <a:r>
-              <a:t>第二十六届中国机器人及人工智能大赛</a:t>
+              <a:t>第二十八届中国机器人及人工智能大赛</a:t>
             </a:r>
           </a:p>
           <a:p>
@@ -6340,7 +6605,7 @@
         </p:nvSpPr>
         <p:spPr>
           <a:xfrm>
-            <a:off x="502920" y="685800"/>
+            <a:off x="502920" y="566928"/>
             <a:ext cx="8138160" cy="731520"/>
           </a:xfrm>
           <a:prstGeom prst="rect">
@@ -6355,7 +6620,7 @@
           <a:lstStyle/>
           <a:p>
             <a:pPr algn="l">
-              <a:defRPr sz="2600" b="1">
+              <a:defRPr sz="2400" b="1">
                 <a:solidFill>
                   <a:srgbClr val="1E1E1E"/>
                 </a:solidFill>
@@ -6515,7 +6780,7 @@
         <p:spPr>
           <a:xfrm>
             <a:off x="0" y="0"/>
-            <a:ext cx="9144000" cy="502920"/>
+            <a:ext cx="9144000" cy="475488"/>
           </a:xfrm>
           <a:prstGeom prst="rect">
             <a:avLst/>
@@ -6572,14 +6837,14 @@
           <a:lstStyle/>
           <a:p>
             <a:pPr>
-              <a:defRPr sz="1100" b="1">
+              <a:defRPr sz="1000" b="1">
                 <a:solidFill>
                   <a:srgbClr val="FFFFFF"/>
                 </a:solidFill>
               </a:defRPr>
             </a:pPr>
             <a:r>
-              <a:t>第二十六届中国机器人及人工智能大赛</a:t>
+              <a:t>第二十八届中国机器人及人工智能大赛</a:t>
             </a:r>
           </a:p>
           <a:p>
@@ -6604,7 +6869,7 @@
         </p:nvSpPr>
         <p:spPr>
           <a:xfrm>
-            <a:off x="502920" y="1828800"/>
+            <a:off x="502920" y="2068830"/>
             <a:ext cx="8138160" cy="731520"/>
           </a:xfrm>
           <a:prstGeom prst="rect">
@@ -6619,7 +6884,7 @@
           <a:lstStyle/>
           <a:p>
             <a:pPr algn="ctr">
-              <a:defRPr sz="3200" b="1">
+              <a:defRPr sz="3000" b="1">
                 <a:solidFill>
                   <a:srgbClr val="1E1E1E"/>
                 </a:solidFill>
@@ -6639,7 +6904,7 @@
         </p:nvSpPr>
         <p:spPr>
           <a:xfrm>
-            <a:off x="502920" y="2606040"/>
+            <a:off x="502920" y="2617470"/>
             <a:ext cx="8138160" cy="731520"/>
           </a:xfrm>
           <a:prstGeom prst="rect">
@@ -6654,7 +6919,7 @@
           <a:lstStyle/>
           <a:p>
             <a:pPr algn="ctr">
-              <a:defRPr sz="2200" b="1">
+              <a:defRPr sz="2000" b="1">
                 <a:solidFill>
                   <a:srgbClr val="143278"/>
                 </a:solidFill>
@@ -6701,7 +6966,7 @@
         <p:spPr>
           <a:xfrm>
             <a:off x="0" y="0"/>
-            <a:ext cx="9144000" cy="502920"/>
+            <a:ext cx="9144000" cy="475488"/>
           </a:xfrm>
           <a:prstGeom prst="rect">
             <a:avLst/>
@@ -6758,14 +7023,14 @@
           <a:lstStyle/>
           <a:p>
             <a:pPr>
-              <a:defRPr sz="1100" b="1">
+              <a:defRPr sz="1000" b="1">
                 <a:solidFill>
                   <a:srgbClr val="FFFFFF"/>
                 </a:solidFill>
               </a:defRPr>
             </a:pPr>
             <a:r>
-              <a:t>第二十六届中国机器人及人工智能大赛</a:t>
+              <a:t>第二十八届中国机器人及人工智能大赛</a:t>
             </a:r>
           </a:p>
           <a:p>
@@ -6790,7 +7055,7 @@
         </p:nvSpPr>
         <p:spPr>
           <a:xfrm>
-            <a:off x="502920" y="685800"/>
+            <a:off x="502920" y="566928"/>
             <a:ext cx="8138160" cy="731520"/>
           </a:xfrm>
           <a:prstGeom prst="rect">
@@ -6805,7 +7070,7 @@
           <a:lstStyle/>
           <a:p>
             <a:pPr algn="l">
-              <a:defRPr sz="2600" b="1">
+              <a:defRPr sz="2400" b="1">
                 <a:solidFill>
                   <a:srgbClr val="1E1E1E"/>
                 </a:solidFill>
@@ -7126,7 +7391,7 @@
         <p:spPr>
           <a:xfrm>
             <a:off x="0" y="0"/>
-            <a:ext cx="9144000" cy="502920"/>
+            <a:ext cx="9144000" cy="475488"/>
           </a:xfrm>
           <a:prstGeom prst="rect">
             <a:avLst/>
@@ -7183,14 +7448,14 @@
           <a:lstStyle/>
           <a:p>
             <a:pPr>
-              <a:defRPr sz="1100" b="1">
+              <a:defRPr sz="1000" b="1">
                 <a:solidFill>
                   <a:srgbClr val="FFFFFF"/>
                 </a:solidFill>
               </a:defRPr>
             </a:pPr>
             <a:r>
-              <a:t>第二十六届中国机器人及人工智能大赛</a:t>
+              <a:t>第二十八届中国机器人及人工智能大赛</a:t>
             </a:r>
           </a:p>
           <a:p>
@@ -7215,7 +7480,7 @@
         </p:nvSpPr>
         <p:spPr>
           <a:xfrm>
-            <a:off x="502920" y="685800"/>
+            <a:off x="502920" y="566928"/>
             <a:ext cx="8138160" cy="731520"/>
           </a:xfrm>
           <a:prstGeom prst="rect">
@@ -7230,7 +7495,7 @@
           <a:lstStyle/>
           <a:p>
             <a:pPr algn="l">
-              <a:defRPr sz="2600" b="1">
+              <a:defRPr sz="2400" b="1">
                 <a:solidFill>
                   <a:srgbClr val="1E1E1E"/>
                 </a:solidFill>
@@ -7375,7 +7640,7 @@
         <p:spPr>
           <a:xfrm>
             <a:off x="0" y="0"/>
-            <a:ext cx="9144000" cy="502920"/>
+            <a:ext cx="9144000" cy="475488"/>
           </a:xfrm>
           <a:prstGeom prst="rect">
             <a:avLst/>
@@ -7432,14 +7697,14 @@
           <a:lstStyle/>
           <a:p>
             <a:pPr>
-              <a:defRPr sz="1100" b="1">
+              <a:defRPr sz="1000" b="1">
                 <a:solidFill>
                   <a:srgbClr val="FFFFFF"/>
                 </a:solidFill>
               </a:defRPr>
             </a:pPr>
             <a:r>
-              <a:t>第二十六届中国机器人及人工智能大赛</a:t>
+              <a:t>第二十八届中国机器人及人工智能大赛</a:t>
             </a:r>
           </a:p>
           <a:p>
@@ -7464,7 +7729,7 @@
         </p:nvSpPr>
         <p:spPr>
           <a:xfrm>
-            <a:off x="502920" y="685800"/>
+            <a:off x="502920" y="566928"/>
             <a:ext cx="8138160" cy="731520"/>
           </a:xfrm>
           <a:prstGeom prst="rect">
@@ -7479,7 +7744,7 @@
           <a:lstStyle/>
           <a:p>
             <a:pPr algn="l">
-              <a:defRPr sz="2600" b="1">
+              <a:defRPr sz="2400" b="1">
                 <a:solidFill>
                   <a:srgbClr val="1E1E1E"/>
                 </a:solidFill>
@@ -7624,7 +7889,7 @@
         <p:spPr>
           <a:xfrm>
             <a:off x="0" y="0"/>
-            <a:ext cx="9144000" cy="502920"/>
+            <a:ext cx="9144000" cy="475488"/>
           </a:xfrm>
           <a:prstGeom prst="rect">
             <a:avLst/>
@@ -7681,14 +7946,14 @@
           <a:lstStyle/>
           <a:p>
             <a:pPr>
-              <a:defRPr sz="1100" b="1">
+              <a:defRPr sz="1000" b="1">
                 <a:solidFill>
                   <a:srgbClr val="FFFFFF"/>
                 </a:solidFill>
               </a:defRPr>
             </a:pPr>
             <a:r>
-              <a:t>第二十六届中国机器人及人工智能大赛</a:t>
+              <a:t>第二十八届中国机器人及人工智能大赛</a:t>
             </a:r>
           </a:p>
           <a:p>
@@ -7713,8 +7978,8 @@
         </p:nvSpPr>
         <p:spPr>
           <a:xfrm>
-            <a:off x="502920" y="2011680"/>
-            <a:ext cx="8138160" cy="1097280"/>
+            <a:off x="502920" y="2068830"/>
+            <a:ext cx="8138160" cy="914400"/>
           </a:xfrm>
           <a:prstGeom prst="rect">
             <a:avLst/>
@@ -7728,7 +7993,7 @@
           <a:lstStyle/>
           <a:p>
             <a:pPr algn="ctr">
-              <a:defRPr sz="3600" b="1">
+              <a:defRPr sz="3200" b="1">
                 <a:solidFill>
                   <a:srgbClr val="143278"/>
                 </a:solidFill>
@@ -7748,8 +8013,8 @@
         </p:nvSpPr>
         <p:spPr>
           <a:xfrm>
-            <a:off x="502920" y="2926080"/>
-            <a:ext cx="8138160" cy="548640"/>
+            <a:off x="502920" y="2891790"/>
+            <a:ext cx="8138160" cy="457200"/>
           </a:xfrm>
           <a:prstGeom prst="rect">
             <a:avLst/>
@@ -7810,7 +8075,7 @@
         <p:spPr>
           <a:xfrm>
             <a:off x="0" y="0"/>
-            <a:ext cx="9144000" cy="502920"/>
+            <a:ext cx="9144000" cy="475488"/>
           </a:xfrm>
           <a:prstGeom prst="rect">
             <a:avLst/>
@@ -7867,14 +8132,14 @@
           <a:lstStyle/>
           <a:p>
             <a:pPr>
-              <a:defRPr sz="1100" b="1">
+              <a:defRPr sz="1000" b="1">
                 <a:solidFill>
                   <a:srgbClr val="FFFFFF"/>
                 </a:solidFill>
               </a:defRPr>
             </a:pPr>
             <a:r>
-              <a:t>第二十六届中国机器人及人工智能大赛</a:t>
+              <a:t>第二十八届中国机器人及人工智能大赛</a:t>
             </a:r>
           </a:p>
           <a:p>
@@ -7899,7 +8164,7 @@
         </p:nvSpPr>
         <p:spPr>
           <a:xfrm>
-            <a:off x="502920" y="685800"/>
+            <a:off x="502920" y="566928"/>
             <a:ext cx="8138160" cy="731520"/>
           </a:xfrm>
           <a:prstGeom prst="rect">
@@ -7914,7 +8179,7 @@
           <a:lstStyle/>
           <a:p>
             <a:pPr algn="l">
-              <a:defRPr sz="2600" b="1">
+              <a:defRPr sz="2400" b="1">
                 <a:solidFill>
                   <a:srgbClr val="1E1E1E"/>
                 </a:solidFill>
@@ -7999,7 +8264,7 @@
         <p:spPr>
           <a:xfrm>
             <a:off x="0" y="0"/>
-            <a:ext cx="9144000" cy="502920"/>
+            <a:ext cx="9144000" cy="475488"/>
           </a:xfrm>
           <a:prstGeom prst="rect">
             <a:avLst/>
@@ -8056,14 +8321,14 @@
           <a:lstStyle/>
           <a:p>
             <a:pPr>
-              <a:defRPr sz="1100" b="1">
+              <a:defRPr sz="1000" b="1">
                 <a:solidFill>
                   <a:srgbClr val="FFFFFF"/>
                 </a:solidFill>
               </a:defRPr>
             </a:pPr>
             <a:r>
-              <a:t>第二十六届中国机器人及人工智能大赛</a:t>
+              <a:t>第二十八届中国机器人及人工智能大赛</a:t>
             </a:r>
           </a:p>
           <a:p>
@@ -8088,7 +8353,7 @@
         </p:nvSpPr>
         <p:spPr>
           <a:xfrm>
-            <a:off x="502920" y="685800"/>
+            <a:off x="502920" y="566928"/>
             <a:ext cx="8138160" cy="731520"/>
           </a:xfrm>
           <a:prstGeom prst="rect">
@@ -8103,7 +8368,7 @@
           <a:lstStyle/>
           <a:p>
             <a:pPr algn="l">
-              <a:defRPr sz="2600" b="1">
+              <a:defRPr sz="2400" b="1">
                 <a:solidFill>
                   <a:srgbClr val="1E1E1E"/>
                 </a:solidFill>
@@ -8374,7 +8639,7 @@
         <p:spPr>
           <a:xfrm>
             <a:off x="0" y="0"/>
-            <a:ext cx="9144000" cy="502920"/>
+            <a:ext cx="9144000" cy="475488"/>
           </a:xfrm>
           <a:prstGeom prst="rect">
             <a:avLst/>
@@ -8431,14 +8696,14 @@
           <a:lstStyle/>
           <a:p>
             <a:pPr>
-              <a:defRPr sz="1100" b="1">
+              <a:defRPr sz="1000" b="1">
                 <a:solidFill>
                   <a:srgbClr val="FFFFFF"/>
                 </a:solidFill>
               </a:defRPr>
             </a:pPr>
             <a:r>
-              <a:t>第二十六届中国机器人及人工智能大赛</a:t>
+              <a:t>第二十八届中国机器人及人工智能大赛</a:t>
             </a:r>
           </a:p>
           <a:p>
@@ -8463,7 +8728,7 @@
         </p:nvSpPr>
         <p:spPr>
           <a:xfrm>
-            <a:off x="502920" y="685800"/>
+            <a:off x="502920" y="566928"/>
             <a:ext cx="8138160" cy="731520"/>
           </a:xfrm>
           <a:prstGeom prst="rect">
@@ -8478,7 +8743,7 @@
           <a:lstStyle/>
           <a:p>
             <a:pPr algn="l">
-              <a:defRPr sz="2600" b="1">
+              <a:defRPr sz="2400" b="1">
                 <a:solidFill>
                   <a:srgbClr val="1E1E1E"/>
                 </a:solidFill>
@@ -8563,7 +8828,7 @@
         <p:spPr>
           <a:xfrm>
             <a:off x="0" y="0"/>
-            <a:ext cx="9144000" cy="502920"/>
+            <a:ext cx="9144000" cy="475488"/>
           </a:xfrm>
           <a:prstGeom prst="rect">
             <a:avLst/>
@@ -8620,14 +8885,14 @@
           <a:lstStyle/>
           <a:p>
             <a:pPr>
-              <a:defRPr sz="1100" b="1">
+              <a:defRPr sz="1000" b="1">
                 <a:solidFill>
                   <a:srgbClr val="FFFFFF"/>
                 </a:solidFill>
               </a:defRPr>
             </a:pPr>
             <a:r>
-              <a:t>第二十六届中国机器人及人工智能大赛</a:t>
+              <a:t>第二十八届中国机器人及人工智能大赛</a:t>
             </a:r>
           </a:p>
           <a:p>
@@ -8652,7 +8917,7 @@
         </p:nvSpPr>
         <p:spPr>
           <a:xfrm>
-            <a:off x="502920" y="1828800"/>
+            <a:off x="502920" y="2068830"/>
             <a:ext cx="8138160" cy="731520"/>
           </a:xfrm>
           <a:prstGeom prst="rect">
@@ -8667,7 +8932,7 @@
           <a:lstStyle/>
           <a:p>
             <a:pPr algn="ctr">
-              <a:defRPr sz="3200" b="1">
+              <a:defRPr sz="3000" b="1">
                 <a:solidFill>
                   <a:srgbClr val="1E1E1E"/>
                 </a:solidFill>
@@ -8687,7 +8952,7 @@
         </p:nvSpPr>
         <p:spPr>
           <a:xfrm>
-            <a:off x="502920" y="2606040"/>
+            <a:off x="502920" y="2617470"/>
             <a:ext cx="8138160" cy="731520"/>
           </a:xfrm>
           <a:prstGeom prst="rect">
@@ -8702,7 +8967,7 @@
           <a:lstStyle/>
           <a:p>
             <a:pPr algn="ctr">
-              <a:defRPr sz="2200" b="1">
+              <a:defRPr sz="2000" b="1">
                 <a:solidFill>
                   <a:srgbClr val="143278"/>
                 </a:solidFill>
@@ -8749,7 +9014,7 @@
         <p:spPr>
           <a:xfrm>
             <a:off x="0" y="0"/>
-            <a:ext cx="9144000" cy="502920"/>
+            <a:ext cx="9144000" cy="475488"/>
           </a:xfrm>
           <a:prstGeom prst="rect">
             <a:avLst/>
@@ -8806,14 +9071,14 @@
           <a:lstStyle/>
           <a:p>
             <a:pPr>
-              <a:defRPr sz="1100" b="1">
+              <a:defRPr sz="1000" b="1">
                 <a:solidFill>
                   <a:srgbClr val="FFFFFF"/>
                 </a:solidFill>
               </a:defRPr>
             </a:pPr>
             <a:r>
-              <a:t>第二十六届中国机器人及人工智能大赛</a:t>
+              <a:t>第二十八届中国机器人及人工智能大赛</a:t>
             </a:r>
           </a:p>
           <a:p>
@@ -8838,7 +9103,7 @@
         </p:nvSpPr>
         <p:spPr>
           <a:xfrm>
-            <a:off x="502920" y="685800"/>
+            <a:off x="502920" y="566928"/>
             <a:ext cx="8138160" cy="731520"/>
           </a:xfrm>
           <a:prstGeom prst="rect">
@@ -8853,7 +9118,7 @@
           <a:lstStyle/>
           <a:p>
             <a:pPr algn="l">
-              <a:defRPr sz="2600" b="1">
+              <a:defRPr sz="2400" b="1">
                 <a:solidFill>
                   <a:srgbClr val="1E1E1E"/>
                 </a:solidFill>
@@ -8998,7 +9263,7 @@
         <p:spPr>
           <a:xfrm>
             <a:off x="0" y="0"/>
-            <a:ext cx="9144000" cy="502920"/>
+            <a:ext cx="9144000" cy="475488"/>
           </a:xfrm>
           <a:prstGeom prst="rect">
             <a:avLst/>
@@ -9055,14 +9320,14 @@
           <a:lstStyle/>
           <a:p>
             <a:pPr>
-              <a:defRPr sz="1100" b="1">
+              <a:defRPr sz="1000" b="1">
                 <a:solidFill>
                   <a:srgbClr val="FFFFFF"/>
                 </a:solidFill>
               </a:defRPr>
             </a:pPr>
             <a:r>
-              <a:t>第二十六届中国机器人及人工智能大赛</a:t>
+              <a:t>第二十八届中国机器人及人工智能大赛</a:t>
             </a:r>
           </a:p>
           <a:p>
@@ -9087,7 +9352,7 @@
         </p:nvSpPr>
         <p:spPr>
           <a:xfrm>
-            <a:off x="502920" y="685800"/>
+            <a:off x="502920" y="566928"/>
             <a:ext cx="8138160" cy="731520"/>
           </a:xfrm>
           <a:prstGeom prst="rect">
@@ -9102,7 +9367,7 @@
           <a:lstStyle/>
           <a:p>
             <a:pPr algn="l">
-              <a:defRPr sz="2600" b="1">
+              <a:defRPr sz="2400" b="1">
                 <a:solidFill>
                   <a:srgbClr val="1E1E1E"/>
                 </a:solidFill>
@@ -9270,7 +9535,7 @@
         <p:spPr>
           <a:xfrm>
             <a:off x="0" y="0"/>
-            <a:ext cx="9144000" cy="502920"/>
+            <a:ext cx="9144000" cy="475488"/>
           </a:xfrm>
           <a:prstGeom prst="rect">
             <a:avLst/>
@@ -9327,14 +9592,14 @@
           <a:lstStyle/>
           <a:p>
             <a:pPr>
-              <a:defRPr sz="1100" b="1">
+              <a:defRPr sz="1000" b="1">
                 <a:solidFill>
                   <a:srgbClr val="FFFFFF"/>
                 </a:solidFill>
               </a:defRPr>
             </a:pPr>
             <a:r>
-              <a:t>第二十六届中国机器人及人工智能大赛</a:t>
+              <a:t>第二十八届中国机器人及人工智能大赛</a:t>
             </a:r>
           </a:p>
           <a:p>
@@ -9359,7 +9624,7 @@
         </p:nvSpPr>
         <p:spPr>
           <a:xfrm>
-            <a:off x="502920" y="685800"/>
+            <a:off x="502920" y="566928"/>
             <a:ext cx="8138160" cy="731520"/>
           </a:xfrm>
           <a:prstGeom prst="rect">
@@ -9374,7 +9639,7 @@
           <a:lstStyle/>
           <a:p>
             <a:pPr algn="l">
-              <a:defRPr sz="2600" b="1">
+              <a:defRPr sz="2400" b="1">
                 <a:solidFill>
                   <a:srgbClr val="1E1E1E"/>
                 </a:solidFill>

</xml_diff>

<commit_message>
docs: add MediaPipe pose screenshot to defense PPT
Embed skeleton analysis UI capture and add web「保存骨架图」plus
export_pose_image.py for full-resolution annotated exports.
</commit_message>
<xml_diff>
--- a/docs/答辩_CareCompanion.pptx
+++ b/docs/答辩_CareCompanion.pptx
@@ -31,6 +31,7 @@
     <p:sldId id="279" r:id="rId30"/>
     <p:sldId id="280" r:id="rId31"/>
     <p:sldId id="281" r:id="rId32"/>
+    <p:sldId id="282" r:id="rId33"/>
   </p:sldIdLst>
   <p:sldSz cx="9144000" cy="5143500" type="screen4x3"/>
   <p:notesSz cx="6858000" cy="9144000"/>
@@ -4641,8 +4642,8 @@
         </p:nvSpPr>
         <p:spPr>
           <a:xfrm>
-            <a:off x="1023374" y="914400"/>
-            <a:ext cx="7097250" cy="3753611"/>
+            <a:off x="2274745" y="914400"/>
+            <a:ext cx="4594508" cy="3753611"/>
           </a:xfrm>
           <a:prstGeom prst="rect">
             <a:avLst/>
@@ -4680,7 +4681,7 @@
       </p:sp>
       <p:pic>
         <p:nvPicPr>
-          <p:cNvPr id="5" name="Picture 4" descr="ppt_full_dashboard.png"/>
+          <p:cNvPr id="5" name="Picture 4" descr="ppt_mediapipe_pose.png"/>
           <p:cNvPicPr>
             <a:picLocks noChangeAspect="1"/>
           </p:cNvPicPr>
@@ -4694,8 +4695,8 @@
         </p:blipFill>
         <p:spPr>
           <a:xfrm>
-            <a:off x="1078238" y="969264"/>
-            <a:ext cx="6987522" cy="3643884"/>
+            <a:off x="2329609" y="969264"/>
+            <a:ext cx="4484780" cy="3643884"/>
           </a:xfrm>
           <a:prstGeom prst="rect">
             <a:avLst/>
@@ -4732,7 +4733,7 @@
               </a:defRPr>
             </a:pPr>
             <a:r>
-              <a:t>演示场景「老人倾诉」· 风险 0.23 · 机器人主动安抚回复</a:t>
+              <a:t>上传全身/上半身照片 → 自动叠加骨架关键点 · 计算宽高比 0.48 · 跌倒判定</a:t>
             </a:r>
           </a:p>
         </p:txBody>
@@ -4767,7 +4768,7 @@
               </a:defRPr>
             </a:pPr>
             <a:r>
-              <a:t>系统界面：老人倾诉场景（演示剧本）</a:t>
+              <a:t>系统界面：MediaPipe 骨架分析（上传照片）</a:t>
             </a:r>
           </a:p>
         </p:txBody>
@@ -4896,8 +4897,8 @@
         </p:nvSpPr>
         <p:spPr>
           <a:xfrm>
-            <a:off x="2986989" y="914400"/>
-            <a:ext cx="3170021" cy="3753611"/>
+            <a:off x="1023374" y="914400"/>
+            <a:ext cx="7097250" cy="3753611"/>
           </a:xfrm>
           <a:prstGeom prst="rect">
             <a:avLst/>
@@ -4935,7 +4936,7 @@
       </p:sp>
       <p:pic>
         <p:nvPicPr>
-          <p:cNvPr id="5" name="Picture 4" descr="ppt_risk_panel.png"/>
+          <p:cNvPr id="5" name="Picture 4" descr="ppt_full_dashboard.png"/>
           <p:cNvPicPr>
             <a:picLocks noChangeAspect="1"/>
           </p:cNvPicPr>
@@ -4949,8 +4950,8 @@
         </p:blipFill>
         <p:spPr>
           <a:xfrm>
-            <a:off x="3041853" y="969264"/>
-            <a:ext cx="3060293" cy="3643884"/>
+            <a:off x="1078238" y="969264"/>
+            <a:ext cx="6987522" cy="3643884"/>
           </a:xfrm>
           <a:prstGeom prst="rect">
             <a:avLst/>
@@ -4987,7 +4988,7 @@
               </a:defRPr>
             </a:pPr>
             <a:r>
-              <a:t>多模态融合输出：风险分数、因素、机器人回应及四项监测指标</a:t>
+              <a:t>演示场景「老人倾诉」· 风险 0.23 · 机器人主动安抚回复</a:t>
             </a:r>
           </a:p>
         </p:txBody>
@@ -5022,7 +5023,7 @@
               </a:defRPr>
             </a:pPr>
             <a:r>
-              <a:t>系统界面：风险决策仪表盘</a:t>
+              <a:t>系统界面：老人倾诉场景（演示剧本）</a:t>
             </a:r>
           </a:p>
         </p:txBody>
@@ -5151,8 +5152,8 @@
         </p:nvSpPr>
         <p:spPr>
           <a:xfrm>
-            <a:off x="997006" y="914400"/>
-            <a:ext cx="7149986" cy="3753611"/>
+            <a:off x="2986989" y="914400"/>
+            <a:ext cx="3170021" cy="3753611"/>
           </a:xfrm>
           <a:prstGeom prst="rect">
             <a:avLst/>
@@ -5190,7 +5191,7 @@
       </p:sp>
       <p:pic>
         <p:nvPicPr>
-          <p:cNvPr id="5" name="Picture 4" descr="ppt_header_perception.png"/>
+          <p:cNvPr id="5" name="Picture 4" descr="ppt_risk_panel.png"/>
           <p:cNvPicPr>
             <a:picLocks noChangeAspect="1"/>
           </p:cNvPicPr>
@@ -5204,8 +5205,8 @@
         </p:blipFill>
         <p:spPr>
           <a:xfrm>
-            <a:off x="1051870" y="969264"/>
-            <a:ext cx="7040258" cy="3643884"/>
+            <a:off x="3041853" y="969264"/>
+            <a:ext cx="3060293" cy="3643884"/>
           </a:xfrm>
           <a:prstGeom prst="rect">
             <a:avLst/>
@@ -5242,7 +5243,7 @@
               </a:defRPr>
             </a:pPr>
             <a:r>
-              <a:t>状态机进入「紧急」· 感知输入与 MediaPipe 视觉模块</a:t>
+              <a:t>多模态融合输出：风险分数、因素、机器人回应及四项监测指标</a:t>
             </a:r>
           </a:p>
         </p:txBody>
@@ -5277,7 +5278,7 @@
               </a:defRPr>
             </a:pPr>
             <a:r>
-              <a:t>系统界面：紧急状态监测</a:t>
+              <a:t>系统界面：风险决策仪表盘</a:t>
             </a:r>
           </a:p>
         </p:txBody>
@@ -5406,8 +5407,8 @@
         </p:nvSpPr>
         <p:spPr>
           <a:xfrm>
-            <a:off x="1131167" y="914400"/>
-            <a:ext cx="6881664" cy="3753611"/>
+            <a:off x="997006" y="914400"/>
+            <a:ext cx="7149986" cy="3753611"/>
           </a:xfrm>
           <a:prstGeom prst="rect">
             <a:avLst/>
@@ -5445,7 +5446,7 @@
       </p:sp>
       <p:pic>
         <p:nvPicPr>
-          <p:cNvPr id="5" name="Picture 4" descr="ppt_chat_emergency.png"/>
+          <p:cNvPr id="5" name="Picture 4" descr="ppt_header_perception.png"/>
           <p:cNvPicPr>
             <a:picLocks noChangeAspect="1"/>
           </p:cNvPicPr>
@@ -5459,8 +5460,8 @@
         </p:blipFill>
         <p:spPr>
           <a:xfrm>
-            <a:off x="1186031" y="969264"/>
-            <a:ext cx="6771936" cy="3643884"/>
+            <a:off x="1051870" y="969264"/>
+            <a:ext cx="7040258" cy="3643884"/>
           </a:xfrm>
           <a:prstGeom prst="rect">
             <a:avLst/>
@@ -5497,7 +5498,7 @@
               </a:defRPr>
             </a:pPr>
             <a:r>
-              <a:t>演示完成：跌倒紧急流程已成功触发 · 多次紧急安抚语音</a:t>
+              <a:t>状态机进入「紧急」· 感知输入与 MediaPipe 视觉模块</a:t>
             </a:r>
           </a:p>
         </p:txBody>
@@ -5532,7 +5533,7 @@
               </a:defRPr>
             </a:pPr>
             <a:r>
-              <a:t>系统界面：跌倒紧急对话日志</a:t>
+              <a:t>系统界面：紧急状态监测</a:t>
             </a:r>
           </a:p>
         </p:txBody>
@@ -5661,8 +5662,8 @@
         </p:nvSpPr>
         <p:spPr>
           <a:xfrm>
-            <a:off x="356616" y="1797787"/>
-            <a:ext cx="8430767" cy="1986837"/>
+            <a:off x="1131167" y="914400"/>
+            <a:ext cx="6881664" cy="3753611"/>
           </a:xfrm>
           <a:prstGeom prst="rect">
             <a:avLst/>
@@ -5700,7 +5701,7 @@
       </p:sp>
       <p:pic>
         <p:nvPicPr>
-          <p:cNvPr id="5" name="Picture 4" descr="ppt_robot_commands.png"/>
+          <p:cNvPr id="5" name="Picture 4" descr="ppt_chat_emergency.png"/>
           <p:cNvPicPr>
             <a:picLocks noChangeAspect="1"/>
           </p:cNvPicPr>
@@ -5714,8 +5715,8 @@
         </p:blipFill>
         <p:spPr>
           <a:xfrm>
-            <a:off x="411480" y="1852651"/>
-            <a:ext cx="8321040" cy="1877110"/>
+            <a:off x="1186031" y="969264"/>
+            <a:ext cx="6771936" cy="3643884"/>
           </a:xfrm>
           <a:prstGeom prst="rect">
             <a:avLst/>
@@ -5752,7 +5753,7 @@
               </a:defRPr>
             </a:pPr>
             <a:r>
-              <a:t>告警音 → 语音 → 紧急呼叫（跌倒事件）→ 举手手势，全链路可追溯</a:t>
+              <a:t>演示完成：跌倒紧急流程已成功触发 · 多次紧急安抚语音</a:t>
             </a:r>
           </a:p>
         </p:txBody>
@@ -5787,7 +5788,7 @@
               </a:defRPr>
             </a:pPr>
             <a:r>
-              <a:t>系统界面：机器人指令流</a:t>
+              <a:t>系统界面：跌倒紧急对话日志</a:t>
             </a:r>
           </a:p>
         </p:txBody>
@@ -5987,6 +5988,261 @@
 </file>
 
 <file path=ppt/slides/slide20.xml><?xml version="1.0" encoding="utf-8"?>
+<p:sld xmlns:a="http://schemas.openxmlformats.org/drawingml/2006/main" xmlns:p="http://schemas.openxmlformats.org/presentationml/2006/main" xmlns:r="http://schemas.openxmlformats.org/officeDocument/2006/relationships">
+  <p:cSld>
+    <p:bg>
+      <p:bgPr>
+        <a:solidFill>
+          <a:srgbClr val="FFFFFF"/>
+        </a:solidFill>
+        <a:effectLst/>
+      </p:bgPr>
+    </p:bg>
+    <p:spTree>
+      <p:nvGrpSpPr>
+        <p:cNvPr id="1" name=""/>
+        <p:cNvGrpSpPr/>
+        <p:nvPr/>
+      </p:nvGrpSpPr>
+      <p:grpSpPr/>
+      <p:sp>
+        <p:nvSpPr>
+          <p:cNvPr id="2" name="Rectangle 1"/>
+          <p:cNvSpPr/>
+          <p:nvPr/>
+        </p:nvSpPr>
+        <p:spPr>
+          <a:xfrm>
+            <a:off x="0" y="0"/>
+            <a:ext cx="9144000" cy="475488"/>
+          </a:xfrm>
+          <a:prstGeom prst="rect">
+            <a:avLst/>
+          </a:prstGeom>
+          <a:solidFill>
+            <a:srgbClr val="143278"/>
+          </a:solidFill>
+          <a:ln>
+            <a:noFill/>
+          </a:ln>
+        </p:spPr>
+        <p:style>
+          <a:lnRef idx="1">
+            <a:schemeClr val="accent1"/>
+          </a:lnRef>
+          <a:fillRef idx="3">
+            <a:schemeClr val="accent1"/>
+          </a:fillRef>
+          <a:effectRef idx="2">
+            <a:schemeClr val="accent1"/>
+          </a:effectRef>
+          <a:fontRef idx="minor">
+            <a:schemeClr val="lt1"/>
+          </a:fontRef>
+        </p:style>
+        <p:txBody>
+          <a:bodyPr rtlCol="0" anchor="ctr"/>
+          <a:lstStyle/>
+          <a:p>
+            <a:pPr algn="ctr"/>
+          </a:p>
+        </p:txBody>
+      </p:sp>
+      <p:sp>
+        <p:nvSpPr>
+          <p:cNvPr id="3" name="TextBox 2"/>
+          <p:cNvSpPr txBox="1"/>
+          <p:nvPr/>
+        </p:nvSpPr>
+        <p:spPr>
+          <a:xfrm>
+            <a:off x="137160" y="73152"/>
+            <a:ext cx="8869680" cy="411480"/>
+          </a:xfrm>
+          <a:prstGeom prst="rect">
+            <a:avLst/>
+          </a:prstGeom>
+          <a:noFill/>
+        </p:spPr>
+        <p:txBody>
+          <a:bodyPr wrap="none">
+            <a:spAutoFit/>
+          </a:bodyPr>
+          <a:lstStyle/>
+          <a:p>
+            <a:pPr>
+              <a:defRPr sz="1000" b="1">
+                <a:solidFill>
+                  <a:srgbClr val="FFFFFF"/>
+                </a:solidFill>
+              </a:defRPr>
+            </a:pPr>
+            <a:r>
+              <a:t>第二十八届中国机器人及人工智能大赛</a:t>
+            </a:r>
+          </a:p>
+          <a:p>
+            <a:pPr>
+              <a:defRPr sz="1000">
+                <a:solidFill>
+                  <a:srgbClr val="C8DCFF"/>
+                </a:solidFill>
+              </a:defRPr>
+            </a:pPr>
+            <a:r>
+              <a:t>机器人创新赛道</a:t>
+            </a:r>
+          </a:p>
+        </p:txBody>
+      </p:sp>
+      <p:sp>
+        <p:nvSpPr>
+          <p:cNvPr id="4" name="Rectangle 3"/>
+          <p:cNvSpPr/>
+          <p:nvPr/>
+        </p:nvSpPr>
+        <p:spPr>
+          <a:xfrm>
+            <a:off x="356616" y="1797787"/>
+            <a:ext cx="8430767" cy="1986837"/>
+          </a:xfrm>
+          <a:prstGeom prst="rect">
+            <a:avLst/>
+          </a:prstGeom>
+          <a:solidFill>
+            <a:srgbClr val="EBF2FA"/>
+          </a:solidFill>
+          <a:ln w="9525">
+            <a:solidFill>
+              <a:srgbClr val="B4C3DC"/>
+            </a:solidFill>
+          </a:ln>
+        </p:spPr>
+        <p:style>
+          <a:lnRef idx="1">
+            <a:schemeClr val="accent1"/>
+          </a:lnRef>
+          <a:fillRef idx="3">
+            <a:schemeClr val="accent1"/>
+          </a:fillRef>
+          <a:effectRef idx="2">
+            <a:schemeClr val="accent1"/>
+          </a:effectRef>
+          <a:fontRef idx="minor">
+            <a:schemeClr val="lt1"/>
+          </a:fontRef>
+        </p:style>
+        <p:txBody>
+          <a:bodyPr rtlCol="0" anchor="ctr"/>
+          <a:lstStyle/>
+          <a:p>
+            <a:pPr algn="ctr"/>
+          </a:p>
+        </p:txBody>
+      </p:sp>
+      <p:pic>
+        <p:nvPicPr>
+          <p:cNvPr id="5" name="Picture 4" descr="ppt_robot_commands.png"/>
+          <p:cNvPicPr>
+            <a:picLocks noChangeAspect="1"/>
+          </p:cNvPicPr>
+          <p:nvPr/>
+        </p:nvPicPr>
+        <p:blipFill>
+          <a:blip r:embed="rId2"/>
+          <a:stretch>
+            <a:fillRect/>
+          </a:stretch>
+        </p:blipFill>
+        <p:spPr>
+          <a:xfrm>
+            <a:off x="411480" y="1852651"/>
+            <a:ext cx="8321040" cy="1877110"/>
+          </a:xfrm>
+          <a:prstGeom prst="rect">
+            <a:avLst/>
+          </a:prstGeom>
+        </p:spPr>
+      </p:pic>
+      <p:sp>
+        <p:nvSpPr>
+          <p:cNvPr id="6" name="TextBox 5"/>
+          <p:cNvSpPr txBox="1"/>
+          <p:nvPr/>
+        </p:nvSpPr>
+        <p:spPr>
+          <a:xfrm>
+            <a:off x="411480" y="4638751"/>
+            <a:ext cx="8321040" cy="347472"/>
+          </a:xfrm>
+          <a:prstGeom prst="rect">
+            <a:avLst/>
+          </a:prstGeom>
+          <a:noFill/>
+        </p:spPr>
+        <p:txBody>
+          <a:bodyPr wrap="square" anchor="ctr">
+            <a:spAutoFit/>
+          </a:bodyPr>
+          <a:lstStyle/>
+          <a:p>
+            <a:pPr algn="ctr">
+              <a:defRPr sz="900">
+                <a:solidFill>
+                  <a:srgbClr val="505050"/>
+                </a:solidFill>
+              </a:defRPr>
+            </a:pPr>
+            <a:r>
+              <a:t>告警音 → 语音 → 紧急呼叫（跌倒事件）→ 举手手势，全链路可追溯</a:t>
+            </a:r>
+          </a:p>
+        </p:txBody>
+      </p:sp>
+      <p:sp>
+        <p:nvSpPr>
+          <p:cNvPr id="7" name="TextBox 6"/>
+          <p:cNvSpPr txBox="1"/>
+          <p:nvPr/>
+        </p:nvSpPr>
+        <p:spPr>
+          <a:xfrm>
+            <a:off x="411480" y="530352"/>
+            <a:ext cx="8321040" cy="384048"/>
+          </a:xfrm>
+          <a:prstGeom prst="rect">
+            <a:avLst/>
+          </a:prstGeom>
+          <a:noFill/>
+        </p:spPr>
+        <p:txBody>
+          <a:bodyPr wrap="square">
+            <a:spAutoFit/>
+          </a:bodyPr>
+          <a:lstStyle/>
+          <a:p>
+            <a:pPr algn="ctr">
+              <a:defRPr sz="1900" b="1">
+                <a:solidFill>
+                  <a:srgbClr val="1E1E1E"/>
+                </a:solidFill>
+              </a:defRPr>
+            </a:pPr>
+            <a:r>
+              <a:t>系统界面：机器人指令流</a:t>
+            </a:r>
+          </a:p>
+        </p:txBody>
+      </p:sp>
+    </p:spTree>
+  </p:cSld>
+  <p:clrMapOvr>
+    <a:masterClrMapping/>
+  </p:clrMapOvr>
+</p:sld>
+</file>
+
+<file path=ppt/slides/slide21.xml><?xml version="1.0" encoding="utf-8"?>
 <p:sld xmlns:a="http://schemas.openxmlformats.org/drawingml/2006/main" xmlns:p="http://schemas.openxmlformats.org/presentationml/2006/main" xmlns:r="http://schemas.openxmlformats.org/officeDocument/2006/relationships">
   <p:cSld>
     <p:bg>
@@ -6489,270 +6745,6 @@
 </p:sld>
 </file>
 
-<file path=ppt/slides/slide21.xml><?xml version="1.0" encoding="utf-8"?>
-<p:sld xmlns:a="http://schemas.openxmlformats.org/drawingml/2006/main" xmlns:p="http://schemas.openxmlformats.org/presentationml/2006/main" xmlns:r="http://schemas.openxmlformats.org/officeDocument/2006/relationships">
-  <p:cSld>
-    <p:bg>
-      <p:bgPr>
-        <a:solidFill>
-          <a:srgbClr val="FFFFFF"/>
-        </a:solidFill>
-        <a:effectLst/>
-      </p:bgPr>
-    </p:bg>
-    <p:spTree>
-      <p:nvGrpSpPr>
-        <p:cNvPr id="1" name=""/>
-        <p:cNvGrpSpPr/>
-        <p:nvPr/>
-      </p:nvGrpSpPr>
-      <p:grpSpPr/>
-      <p:sp>
-        <p:nvSpPr>
-          <p:cNvPr id="2" name="Rectangle 1"/>
-          <p:cNvSpPr/>
-          <p:nvPr/>
-        </p:nvSpPr>
-        <p:spPr>
-          <a:xfrm>
-            <a:off x="0" y="0"/>
-            <a:ext cx="9144000" cy="475488"/>
-          </a:xfrm>
-          <a:prstGeom prst="rect">
-            <a:avLst/>
-          </a:prstGeom>
-          <a:solidFill>
-            <a:srgbClr val="143278"/>
-          </a:solidFill>
-          <a:ln>
-            <a:noFill/>
-          </a:ln>
-        </p:spPr>
-        <p:style>
-          <a:lnRef idx="1">
-            <a:schemeClr val="accent1"/>
-          </a:lnRef>
-          <a:fillRef idx="3">
-            <a:schemeClr val="accent1"/>
-          </a:fillRef>
-          <a:effectRef idx="2">
-            <a:schemeClr val="accent1"/>
-          </a:effectRef>
-          <a:fontRef idx="minor">
-            <a:schemeClr val="lt1"/>
-          </a:fontRef>
-        </p:style>
-        <p:txBody>
-          <a:bodyPr rtlCol="0" anchor="ctr"/>
-          <a:lstStyle/>
-          <a:p>
-            <a:pPr algn="ctr"/>
-          </a:p>
-        </p:txBody>
-      </p:sp>
-      <p:sp>
-        <p:nvSpPr>
-          <p:cNvPr id="3" name="TextBox 2"/>
-          <p:cNvSpPr txBox="1"/>
-          <p:nvPr/>
-        </p:nvSpPr>
-        <p:spPr>
-          <a:xfrm>
-            <a:off x="137160" y="73152"/>
-            <a:ext cx="8869680" cy="411480"/>
-          </a:xfrm>
-          <a:prstGeom prst="rect">
-            <a:avLst/>
-          </a:prstGeom>
-          <a:noFill/>
-        </p:spPr>
-        <p:txBody>
-          <a:bodyPr wrap="none">
-            <a:spAutoFit/>
-          </a:bodyPr>
-          <a:lstStyle/>
-          <a:p>
-            <a:pPr>
-              <a:defRPr sz="1000" b="1">
-                <a:solidFill>
-                  <a:srgbClr val="FFFFFF"/>
-                </a:solidFill>
-              </a:defRPr>
-            </a:pPr>
-            <a:r>
-              <a:t>第二十八届中国机器人及人工智能大赛</a:t>
-            </a:r>
-          </a:p>
-          <a:p>
-            <a:pPr>
-              <a:defRPr sz="1000">
-                <a:solidFill>
-                  <a:srgbClr val="C8DCFF"/>
-                </a:solidFill>
-              </a:defRPr>
-            </a:pPr>
-            <a:r>
-              <a:t>机器人创新赛道</a:t>
-            </a:r>
-          </a:p>
-        </p:txBody>
-      </p:sp>
-      <p:sp>
-        <p:nvSpPr>
-          <p:cNvPr id="4" name="TextBox 3"/>
-          <p:cNvSpPr txBox="1"/>
-          <p:nvPr/>
-        </p:nvSpPr>
-        <p:spPr>
-          <a:xfrm>
-            <a:off x="502920" y="566928"/>
-            <a:ext cx="8138160" cy="731520"/>
-          </a:xfrm>
-          <a:prstGeom prst="rect">
-            <a:avLst/>
-          </a:prstGeom>
-          <a:noFill/>
-        </p:spPr>
-        <p:txBody>
-          <a:bodyPr wrap="square">
-            <a:spAutoFit/>
-          </a:bodyPr>
-          <a:lstStyle/>
-          <a:p>
-            <a:pPr algn="l">
-              <a:defRPr sz="2400" b="1">
-                <a:solidFill>
-                  <a:srgbClr val="1E1E1E"/>
-                </a:solidFill>
-              </a:defRPr>
-            </a:pPr>
-            <a:r>
-              <a:t>开源与知识产权</a:t>
-            </a:r>
-          </a:p>
-        </p:txBody>
-      </p:sp>
-      <p:sp>
-        <p:nvSpPr>
-          <p:cNvPr id="5" name="TextBox 4"/>
-          <p:cNvSpPr txBox="1"/>
-          <p:nvPr/>
-        </p:nvSpPr>
-        <p:spPr>
-          <a:xfrm>
-            <a:off x="502920" y="1325880"/>
-            <a:ext cx="8138160" cy="3840480"/>
-          </a:xfrm>
-          <a:prstGeom prst="rect">
-            <a:avLst/>
-          </a:prstGeom>
-          <a:noFill/>
-        </p:spPr>
-        <p:txBody>
-          <a:bodyPr wrap="square">
-            <a:spAutoFit/>
-          </a:bodyPr>
-          <a:lstStyle/>
-          <a:p>
-            <a:pPr>
-              <a:spcAft>
-                <a:spcPts val="600"/>
-              </a:spcAft>
-              <a:defRPr sz="1400">
-                <a:solidFill>
-                  <a:srgbClr val="1E1E1E"/>
-                </a:solidFill>
-              </a:defRPr>
-            </a:pPr>
-            <a:r>
-              <a:t>GitHub 开源：https://github.com/FBB123571/ElderCare-Humanoid-Platform</a:t>
-            </a:r>
-          </a:p>
-          <a:p>
-            <a:pPr>
-              <a:spcAft>
-                <a:spcPts val="600"/>
-              </a:spcAft>
-              <a:defRPr sz="1400">
-                <a:solidFill>
-                  <a:srgbClr val="1E1E1E"/>
-                </a:solidFill>
-              </a:defRPr>
-            </a:pPr>
-            <a:r>
-              <a:t>答辩演示：http://localhost:8765（现场端口转发）</a:t>
-            </a:r>
-          </a:p>
-          <a:p>
-            <a:pPr>
-              <a:spcAft>
-                <a:spcPts val="600"/>
-              </a:spcAft>
-              <a:defRPr sz="1400">
-                <a:solidFill>
-                  <a:srgbClr val="1E1E1E"/>
-                </a:solidFill>
-              </a:defRPr>
-            </a:pPr>
-            <a:r>
-              <a:t>软件名称建议：CareCompanion 智能养老人形陪伴机器人系统 V1.0</a:t>
-            </a:r>
-          </a:p>
-          <a:p>
-            <a:pPr>
-              <a:spcAft>
-                <a:spcPts val="600"/>
-              </a:spcAft>
-              <a:defRPr sz="1400">
-                <a:solidFill>
-                  <a:srgbClr val="1E1E1E"/>
-                </a:solidFill>
-              </a:defRPr>
-            </a:pPr>
-            <a:r>
-              <a:t>核心代码：care_companion/ · web/ · scripts/ · tests/</a:t>
-            </a:r>
-          </a:p>
-          <a:p>
-            <a:pPr>
-              <a:spcAft>
-                <a:spcPts val="600"/>
-              </a:spcAft>
-              <a:defRPr sz="1400">
-                <a:solidFill>
-                  <a:srgbClr val="1E1E1E"/>
-                </a:solidFill>
-              </a:defRPr>
-            </a:pPr>
-            <a:r>
-              <a:t>文档：技术报告 · 架构说明 · 部署指南 · 竞赛答辩要点</a:t>
-            </a:r>
-          </a:p>
-          <a:p>
-            <a:pPr>
-              <a:spcAft>
-                <a:spcPts val="600"/>
-              </a:spcAft>
-              <a:defRPr sz="1400">
-                <a:solidFill>
-                  <a:srgbClr val="1E1E1E"/>
-                </a:solidFill>
-              </a:defRPr>
-            </a:pPr>
-            <a:r>
-              <a:t>（请填写）软著登记号 / 团队成员 / 指导教师</a:t>
-            </a:r>
-          </a:p>
-        </p:txBody>
-      </p:sp>
-    </p:spTree>
-  </p:cSld>
-  <p:clrMapOvr>
-    <a:masterClrMapping/>
-  </p:clrMapOvr>
-</p:sld>
-</file>
-
 <file path=ppt/slides/slide22.xml><?xml version="1.0" encoding="utf-8"?>
 <p:sld xmlns:a="http://schemas.openxmlformats.org/drawingml/2006/main" xmlns:p="http://schemas.openxmlformats.org/presentationml/2006/main" xmlns:r="http://schemas.openxmlformats.org/officeDocument/2006/relationships">
   <p:cSld>
@@ -6869,7 +6861,7 @@
         </p:nvSpPr>
         <p:spPr>
           <a:xfrm>
-            <a:off x="502920" y="2068830"/>
+            <a:off x="502920" y="566928"/>
             <a:ext cx="8138160" cy="731520"/>
           </a:xfrm>
           <a:prstGeom prst="rect">
@@ -6883,15 +6875,15 @@
           </a:bodyPr>
           <a:lstStyle/>
           <a:p>
-            <a:pPr algn="ctr">
-              <a:defRPr sz="3000" b="1">
+            <a:pPr algn="l">
+              <a:defRPr sz="2400" b="1">
                 <a:solidFill>
                   <a:srgbClr val="1E1E1E"/>
                 </a:solidFill>
               </a:defRPr>
             </a:pPr>
             <a:r>
-              <a:t>第四部分</a:t>
+              <a:t>开源与知识产权</a:t>
             </a:r>
           </a:p>
         </p:txBody>
@@ -6904,8 +6896,8 @@
         </p:nvSpPr>
         <p:spPr>
           <a:xfrm>
-            <a:off x="502920" y="2617470"/>
-            <a:ext cx="8138160" cy="731520"/>
+            <a:off x="502920" y="1325880"/>
+            <a:ext cx="8138160" cy="3840480"/>
           </a:xfrm>
           <a:prstGeom prst="rect">
             <a:avLst/>
@@ -6918,15 +6910,93 @@
           </a:bodyPr>
           <a:lstStyle/>
           <a:p>
-            <a:pPr algn="ctr">
-              <a:defRPr sz="2000" b="1">
-                <a:solidFill>
-                  <a:srgbClr val="143278"/>
-                </a:solidFill>
-              </a:defRPr>
-            </a:pPr>
-            <a:r>
-              <a:t>创新维度与未来展望</a:t>
+            <a:pPr>
+              <a:spcAft>
+                <a:spcPts val="600"/>
+              </a:spcAft>
+              <a:defRPr sz="1400">
+                <a:solidFill>
+                  <a:srgbClr val="1E1E1E"/>
+                </a:solidFill>
+              </a:defRPr>
+            </a:pPr>
+            <a:r>
+              <a:t>GitHub 开源：https://github.com/FBB123571/ElderCare-Humanoid-Platform</a:t>
+            </a:r>
+          </a:p>
+          <a:p>
+            <a:pPr>
+              <a:spcAft>
+                <a:spcPts val="600"/>
+              </a:spcAft>
+              <a:defRPr sz="1400">
+                <a:solidFill>
+                  <a:srgbClr val="1E1E1E"/>
+                </a:solidFill>
+              </a:defRPr>
+            </a:pPr>
+            <a:r>
+              <a:t>答辩演示：http://localhost:8765（现场端口转发）</a:t>
+            </a:r>
+          </a:p>
+          <a:p>
+            <a:pPr>
+              <a:spcAft>
+                <a:spcPts val="600"/>
+              </a:spcAft>
+              <a:defRPr sz="1400">
+                <a:solidFill>
+                  <a:srgbClr val="1E1E1E"/>
+                </a:solidFill>
+              </a:defRPr>
+            </a:pPr>
+            <a:r>
+              <a:t>软件名称建议：CareCompanion 智能养老人形陪伴机器人系统 V1.0</a:t>
+            </a:r>
+          </a:p>
+          <a:p>
+            <a:pPr>
+              <a:spcAft>
+                <a:spcPts val="600"/>
+              </a:spcAft>
+              <a:defRPr sz="1400">
+                <a:solidFill>
+                  <a:srgbClr val="1E1E1E"/>
+                </a:solidFill>
+              </a:defRPr>
+            </a:pPr>
+            <a:r>
+              <a:t>核心代码：care_companion/ · web/ · scripts/ · tests/</a:t>
+            </a:r>
+          </a:p>
+          <a:p>
+            <a:pPr>
+              <a:spcAft>
+                <a:spcPts val="600"/>
+              </a:spcAft>
+              <a:defRPr sz="1400">
+                <a:solidFill>
+                  <a:srgbClr val="1E1E1E"/>
+                </a:solidFill>
+              </a:defRPr>
+            </a:pPr>
+            <a:r>
+              <a:t>文档：技术报告 · 架构说明 · 部署指南 · 竞赛答辩要点</a:t>
+            </a:r>
+          </a:p>
+          <a:p>
+            <a:pPr>
+              <a:spcAft>
+                <a:spcPts val="600"/>
+              </a:spcAft>
+              <a:defRPr sz="1400">
+                <a:solidFill>
+                  <a:srgbClr val="1E1E1E"/>
+                </a:solidFill>
+              </a:defRPr>
+            </a:pPr>
+            <a:r>
+              <a:t>（请填写）软著登记号 / 团队成员 / 指导教师</a:t>
             </a:r>
           </a:p>
         </p:txBody>
@@ -6940,6 +7010,192 @@
 </file>
 
 <file path=ppt/slides/slide23.xml><?xml version="1.0" encoding="utf-8"?>
+<p:sld xmlns:a="http://schemas.openxmlformats.org/drawingml/2006/main" xmlns:p="http://schemas.openxmlformats.org/presentationml/2006/main" xmlns:r="http://schemas.openxmlformats.org/officeDocument/2006/relationships">
+  <p:cSld>
+    <p:bg>
+      <p:bgPr>
+        <a:solidFill>
+          <a:srgbClr val="FFFFFF"/>
+        </a:solidFill>
+        <a:effectLst/>
+      </p:bgPr>
+    </p:bg>
+    <p:spTree>
+      <p:nvGrpSpPr>
+        <p:cNvPr id="1" name=""/>
+        <p:cNvGrpSpPr/>
+        <p:nvPr/>
+      </p:nvGrpSpPr>
+      <p:grpSpPr/>
+      <p:sp>
+        <p:nvSpPr>
+          <p:cNvPr id="2" name="Rectangle 1"/>
+          <p:cNvSpPr/>
+          <p:nvPr/>
+        </p:nvSpPr>
+        <p:spPr>
+          <a:xfrm>
+            <a:off x="0" y="0"/>
+            <a:ext cx="9144000" cy="475488"/>
+          </a:xfrm>
+          <a:prstGeom prst="rect">
+            <a:avLst/>
+          </a:prstGeom>
+          <a:solidFill>
+            <a:srgbClr val="143278"/>
+          </a:solidFill>
+          <a:ln>
+            <a:noFill/>
+          </a:ln>
+        </p:spPr>
+        <p:style>
+          <a:lnRef idx="1">
+            <a:schemeClr val="accent1"/>
+          </a:lnRef>
+          <a:fillRef idx="3">
+            <a:schemeClr val="accent1"/>
+          </a:fillRef>
+          <a:effectRef idx="2">
+            <a:schemeClr val="accent1"/>
+          </a:effectRef>
+          <a:fontRef idx="minor">
+            <a:schemeClr val="lt1"/>
+          </a:fontRef>
+        </p:style>
+        <p:txBody>
+          <a:bodyPr rtlCol="0" anchor="ctr"/>
+          <a:lstStyle/>
+          <a:p>
+            <a:pPr algn="ctr"/>
+          </a:p>
+        </p:txBody>
+      </p:sp>
+      <p:sp>
+        <p:nvSpPr>
+          <p:cNvPr id="3" name="TextBox 2"/>
+          <p:cNvSpPr txBox="1"/>
+          <p:nvPr/>
+        </p:nvSpPr>
+        <p:spPr>
+          <a:xfrm>
+            <a:off x="137160" y="73152"/>
+            <a:ext cx="8869680" cy="411480"/>
+          </a:xfrm>
+          <a:prstGeom prst="rect">
+            <a:avLst/>
+          </a:prstGeom>
+          <a:noFill/>
+        </p:spPr>
+        <p:txBody>
+          <a:bodyPr wrap="none">
+            <a:spAutoFit/>
+          </a:bodyPr>
+          <a:lstStyle/>
+          <a:p>
+            <a:pPr>
+              <a:defRPr sz="1000" b="1">
+                <a:solidFill>
+                  <a:srgbClr val="FFFFFF"/>
+                </a:solidFill>
+              </a:defRPr>
+            </a:pPr>
+            <a:r>
+              <a:t>第二十八届中国机器人及人工智能大赛</a:t>
+            </a:r>
+          </a:p>
+          <a:p>
+            <a:pPr>
+              <a:defRPr sz="1000">
+                <a:solidFill>
+                  <a:srgbClr val="C8DCFF"/>
+                </a:solidFill>
+              </a:defRPr>
+            </a:pPr>
+            <a:r>
+              <a:t>机器人创新赛道</a:t>
+            </a:r>
+          </a:p>
+        </p:txBody>
+      </p:sp>
+      <p:sp>
+        <p:nvSpPr>
+          <p:cNvPr id="4" name="TextBox 3"/>
+          <p:cNvSpPr txBox="1"/>
+          <p:nvPr/>
+        </p:nvSpPr>
+        <p:spPr>
+          <a:xfrm>
+            <a:off x="502920" y="2068830"/>
+            <a:ext cx="8138160" cy="731520"/>
+          </a:xfrm>
+          <a:prstGeom prst="rect">
+            <a:avLst/>
+          </a:prstGeom>
+          <a:noFill/>
+        </p:spPr>
+        <p:txBody>
+          <a:bodyPr wrap="square">
+            <a:spAutoFit/>
+          </a:bodyPr>
+          <a:lstStyle/>
+          <a:p>
+            <a:pPr algn="ctr">
+              <a:defRPr sz="3000" b="1">
+                <a:solidFill>
+                  <a:srgbClr val="1E1E1E"/>
+                </a:solidFill>
+              </a:defRPr>
+            </a:pPr>
+            <a:r>
+              <a:t>第四部分</a:t>
+            </a:r>
+          </a:p>
+        </p:txBody>
+      </p:sp>
+      <p:sp>
+        <p:nvSpPr>
+          <p:cNvPr id="5" name="TextBox 4"/>
+          <p:cNvSpPr txBox="1"/>
+          <p:nvPr/>
+        </p:nvSpPr>
+        <p:spPr>
+          <a:xfrm>
+            <a:off x="502920" y="2617470"/>
+            <a:ext cx="8138160" cy="731520"/>
+          </a:xfrm>
+          <a:prstGeom prst="rect">
+            <a:avLst/>
+          </a:prstGeom>
+          <a:noFill/>
+        </p:spPr>
+        <p:txBody>
+          <a:bodyPr wrap="square">
+            <a:spAutoFit/>
+          </a:bodyPr>
+          <a:lstStyle/>
+          <a:p>
+            <a:pPr algn="ctr">
+              <a:defRPr sz="2000" b="1">
+                <a:solidFill>
+                  <a:srgbClr val="143278"/>
+                </a:solidFill>
+              </a:defRPr>
+            </a:pPr>
+            <a:r>
+              <a:t>创新维度与未来展望</a:t>
+            </a:r>
+          </a:p>
+        </p:txBody>
+      </p:sp>
+    </p:spTree>
+  </p:cSld>
+  <p:clrMapOvr>
+    <a:masterClrMapping/>
+  </p:clrMapOvr>
+</p:sld>
+</file>
+
+<file path=ppt/slides/slide24.xml><?xml version="1.0" encoding="utf-8"?>
 <p:sld xmlns:a="http://schemas.openxmlformats.org/drawingml/2006/main" xmlns:p="http://schemas.openxmlformats.org/presentationml/2006/main" xmlns:r="http://schemas.openxmlformats.org/officeDocument/2006/relationships">
   <p:cSld>
     <p:bg>
@@ -7364,255 +7620,6 @@
 </p:sld>
 </file>
 
-<file path=ppt/slides/slide24.xml><?xml version="1.0" encoding="utf-8"?>
-<p:sld xmlns:a="http://schemas.openxmlformats.org/drawingml/2006/main" xmlns:p="http://schemas.openxmlformats.org/presentationml/2006/main" xmlns:r="http://schemas.openxmlformats.org/officeDocument/2006/relationships">
-  <p:cSld>
-    <p:bg>
-      <p:bgPr>
-        <a:solidFill>
-          <a:srgbClr val="FFFFFF"/>
-        </a:solidFill>
-        <a:effectLst/>
-      </p:bgPr>
-    </p:bg>
-    <p:spTree>
-      <p:nvGrpSpPr>
-        <p:cNvPr id="1" name=""/>
-        <p:cNvGrpSpPr/>
-        <p:nvPr/>
-      </p:nvGrpSpPr>
-      <p:grpSpPr/>
-      <p:sp>
-        <p:nvSpPr>
-          <p:cNvPr id="2" name="Rectangle 1"/>
-          <p:cNvSpPr/>
-          <p:nvPr/>
-        </p:nvSpPr>
-        <p:spPr>
-          <a:xfrm>
-            <a:off x="0" y="0"/>
-            <a:ext cx="9144000" cy="475488"/>
-          </a:xfrm>
-          <a:prstGeom prst="rect">
-            <a:avLst/>
-          </a:prstGeom>
-          <a:solidFill>
-            <a:srgbClr val="143278"/>
-          </a:solidFill>
-          <a:ln>
-            <a:noFill/>
-          </a:ln>
-        </p:spPr>
-        <p:style>
-          <a:lnRef idx="1">
-            <a:schemeClr val="accent1"/>
-          </a:lnRef>
-          <a:fillRef idx="3">
-            <a:schemeClr val="accent1"/>
-          </a:fillRef>
-          <a:effectRef idx="2">
-            <a:schemeClr val="accent1"/>
-          </a:effectRef>
-          <a:fontRef idx="minor">
-            <a:schemeClr val="lt1"/>
-          </a:fontRef>
-        </p:style>
-        <p:txBody>
-          <a:bodyPr rtlCol="0" anchor="ctr"/>
-          <a:lstStyle/>
-          <a:p>
-            <a:pPr algn="ctr"/>
-          </a:p>
-        </p:txBody>
-      </p:sp>
-      <p:sp>
-        <p:nvSpPr>
-          <p:cNvPr id="3" name="TextBox 2"/>
-          <p:cNvSpPr txBox="1"/>
-          <p:nvPr/>
-        </p:nvSpPr>
-        <p:spPr>
-          <a:xfrm>
-            <a:off x="137160" y="73152"/>
-            <a:ext cx="8869680" cy="411480"/>
-          </a:xfrm>
-          <a:prstGeom prst="rect">
-            <a:avLst/>
-          </a:prstGeom>
-          <a:noFill/>
-        </p:spPr>
-        <p:txBody>
-          <a:bodyPr wrap="none">
-            <a:spAutoFit/>
-          </a:bodyPr>
-          <a:lstStyle/>
-          <a:p>
-            <a:pPr>
-              <a:defRPr sz="1000" b="1">
-                <a:solidFill>
-                  <a:srgbClr val="FFFFFF"/>
-                </a:solidFill>
-              </a:defRPr>
-            </a:pPr>
-            <a:r>
-              <a:t>第二十八届中国机器人及人工智能大赛</a:t>
-            </a:r>
-          </a:p>
-          <a:p>
-            <a:pPr>
-              <a:defRPr sz="1000">
-                <a:solidFill>
-                  <a:srgbClr val="C8DCFF"/>
-                </a:solidFill>
-              </a:defRPr>
-            </a:pPr>
-            <a:r>
-              <a:t>机器人创新赛道</a:t>
-            </a:r>
-          </a:p>
-        </p:txBody>
-      </p:sp>
-      <p:sp>
-        <p:nvSpPr>
-          <p:cNvPr id="4" name="TextBox 3"/>
-          <p:cNvSpPr txBox="1"/>
-          <p:nvPr/>
-        </p:nvSpPr>
-        <p:spPr>
-          <a:xfrm>
-            <a:off x="502920" y="566928"/>
-            <a:ext cx="8138160" cy="731520"/>
-          </a:xfrm>
-          <a:prstGeom prst="rect">
-            <a:avLst/>
-          </a:prstGeom>
-          <a:noFill/>
-        </p:spPr>
-        <p:txBody>
-          <a:bodyPr wrap="square">
-            <a:spAutoFit/>
-          </a:bodyPr>
-          <a:lstStyle/>
-          <a:p>
-            <a:pPr algn="l">
-              <a:defRPr sz="2400" b="1">
-                <a:solidFill>
-                  <a:srgbClr val="1E1E1E"/>
-                </a:solidFill>
-              </a:defRPr>
-            </a:pPr>
-            <a:r>
-              <a:t>未来工作</a:t>
-            </a:r>
-          </a:p>
-        </p:txBody>
-      </p:sp>
-      <p:sp>
-        <p:nvSpPr>
-          <p:cNvPr id="5" name="TextBox 4"/>
-          <p:cNvSpPr txBox="1"/>
-          <p:nvPr/>
-        </p:nvSpPr>
-        <p:spPr>
-          <a:xfrm>
-            <a:off x="502920" y="1325880"/>
-            <a:ext cx="8138160" cy="3840480"/>
-          </a:xfrm>
-          <a:prstGeom prst="rect">
-            <a:avLst/>
-          </a:prstGeom>
-          <a:noFill/>
-        </p:spPr>
-        <p:txBody>
-          <a:bodyPr wrap="square">
-            <a:spAutoFit/>
-          </a:bodyPr>
-          <a:lstStyle/>
-          <a:p>
-            <a:pPr>
-              <a:spcAft>
-                <a:spcPts val="600"/>
-              </a:spcAft>
-              <a:defRPr sz="1400">
-                <a:solidFill>
-                  <a:srgbClr val="1E1E1E"/>
-                </a:solidFill>
-              </a:defRPr>
-            </a:pPr>
-            <a:r>
-              <a:t>p 对接 Unitree 等人形机器人，完成 speak/gesture/approach 真机视频</a:t>
-            </a:r>
-          </a:p>
-          <a:p>
-            <a:pPr>
-              <a:spcAft>
-                <a:spcPts val="600"/>
-              </a:spcAft>
-              <a:defRPr sz="1400">
-                <a:solidFill>
-                  <a:srgbClr val="1E1E1E"/>
-                </a:solidFill>
-              </a:defRPr>
-            </a:pPr>
-            <a:r>
-              <a:t>p 引入 UR Fall 等公开数据集，开展泛化评测与误报分析</a:t>
-            </a:r>
-          </a:p>
-          <a:p>
-            <a:pPr>
-              <a:spcAft>
-                <a:spcPts val="600"/>
-              </a:spcAft>
-              <a:defRPr sz="1400">
-                <a:solidFill>
-                  <a:srgbClr val="1E1E1E"/>
-                </a:solidFill>
-              </a:defRPr>
-            </a:pPr>
-            <a:r>
-              <a:t>p 多老人房间场景、遮挡与光照鲁棒性优化</a:t>
-            </a:r>
-          </a:p>
-          <a:p>
-            <a:pPr>
-              <a:spcAft>
-                <a:spcPts val="600"/>
-              </a:spcAft>
-              <a:defRPr sz="1400">
-                <a:solidFill>
-                  <a:srgbClr val="1E1E1E"/>
-                </a:solidFill>
-              </a:defRPr>
-            </a:pPr>
-            <a:r>
-              <a:t>p 结合社区/养老院调研，完善产品化与成本评估</a:t>
-            </a:r>
-          </a:p>
-          <a:p>
-            <a:pPr>
-              <a:spcAft>
-                <a:spcPts val="600"/>
-              </a:spcAft>
-              <a:defRPr sz="1400">
-                <a:solidFill>
-                  <a:srgbClr val="1E1E1E"/>
-                </a:solidFill>
-              </a:defRPr>
-            </a:pPr>
-            <a:r>
-              <a:t>p 申请软件著作权 V1.0，探索专利（跌倒融合决策方法）</a:t>
-            </a:r>
-          </a:p>
-        </p:txBody>
-      </p:sp>
-    </p:spTree>
-  </p:cSld>
-  <p:clrMapOvr>
-    <a:masterClrMapping/>
-  </p:clrMapOvr>
-</p:sld>
-</file>
-
 <file path=ppt/slides/slide25.xml><?xml version="1.0" encoding="utf-8"?>
 <p:sld xmlns:a="http://schemas.openxmlformats.org/drawingml/2006/main" xmlns:p="http://schemas.openxmlformats.org/presentationml/2006/main" xmlns:r="http://schemas.openxmlformats.org/officeDocument/2006/relationships">
   <p:cSld>
@@ -7751,7 +7758,7 @@
               </a:defRPr>
             </a:pPr>
             <a:r>
-              <a:t>参考文献</a:t>
+              <a:t>未来工作</a:t>
             </a:r>
           </a:p>
         </p:txBody>
@@ -7764,7 +7771,7 @@
         </p:nvSpPr>
         <p:spPr>
           <a:xfrm>
-            <a:off x="502920" y="1234440"/>
+            <a:off x="502920" y="1325880"/>
             <a:ext cx="8138160" cy="3840480"/>
           </a:xfrm>
           <a:prstGeom prst="rect">
@@ -7782,14 +7789,14 @@
               <a:spcAft>
                 <a:spcPts val="600"/>
               </a:spcAft>
-              <a:defRPr sz="1200">
+              <a:defRPr sz="1400">
                 <a:solidFill>
                   <a:srgbClr val="1E1E1E"/>
                 </a:solidFill>
               </a:defRPr>
             </a:pPr>
             <a:r>
-              <a:t>[1] Google MediaPipe Pose: Real-time pose estimation.</a:t>
+              <a:t>p 对接 Unitree 等人形机器人，完成 speak/gesture/approach 真机视频</a:t>
             </a:r>
           </a:p>
           <a:p>
@@ -7797,14 +7804,14 @@
               <a:spcAft>
                 <a:spcPts val="600"/>
               </a:spcAft>
-              <a:defRPr sz="1200">
+              <a:defRPr sz="1400">
                 <a:solidFill>
                   <a:srgbClr val="1E1E1E"/>
                 </a:solidFill>
               </a:defRPr>
             </a:pPr>
             <a:r>
-              <a:t>[2] Unitree Robotics SDK / ROS2 documentation.</a:t>
+              <a:t>p 引入 UR Fall 等公开数据集，开展泛化评测与误报分析</a:t>
             </a:r>
           </a:p>
           <a:p>
@@ -7812,14 +7819,14 @@
               <a:spcAft>
                 <a:spcPts val="600"/>
               </a:spcAft>
-              <a:defRPr sz="1200">
+              <a:defRPr sz="1400">
                 <a:solidFill>
                   <a:srgbClr val="1E1E1E"/>
                 </a:solidFill>
               </a:defRPr>
             </a:pPr>
             <a:r>
-              <a:t>[3] 国务院：《「十四五」国家老龄事业发展和养老服务体系规划》.</a:t>
+              <a:t>p 多老人房间场景、遮挡与光照鲁棒性优化</a:t>
             </a:r>
           </a:p>
           <a:p>
@@ -7827,14 +7834,14 @@
               <a:spcAft>
                 <a:spcPts val="600"/>
               </a:spcAft>
-              <a:defRPr sz="1200">
+              <a:defRPr sz="1400">
                 <a:solidFill>
                   <a:srgbClr val="1E1E1E"/>
                 </a:solidFill>
               </a:defRPr>
             </a:pPr>
             <a:r>
-              <a:t>[4] CareCompanion 项目文档：docs/TECHNICAL_REPORT.md</a:t>
+              <a:t>p 结合社区/养老院调研，完善产品化与成本评估</a:t>
             </a:r>
           </a:p>
           <a:p>
@@ -7842,14 +7849,14 @@
               <a:spcAft>
                 <a:spcPts val="600"/>
               </a:spcAft>
-              <a:defRPr sz="1200">
+              <a:defRPr sz="1400">
                 <a:solidFill>
                   <a:srgbClr val="1E1E1E"/>
                 </a:solidFill>
               </a:defRPr>
             </a:pPr>
             <a:r>
-              <a:t>[5] 仓库：github.com/FBB123571/ElderCare-Humanoid-Platform</a:t>
+              <a:t>p 申请软件著作权 V1.0，探索专利（跌倒融合决策方法）</a:t>
             </a:r>
           </a:p>
         </p:txBody>
@@ -7863,6 +7870,255 @@
 </file>
 
 <file path=ppt/slides/slide26.xml><?xml version="1.0" encoding="utf-8"?>
+<p:sld xmlns:a="http://schemas.openxmlformats.org/drawingml/2006/main" xmlns:p="http://schemas.openxmlformats.org/presentationml/2006/main" xmlns:r="http://schemas.openxmlformats.org/officeDocument/2006/relationships">
+  <p:cSld>
+    <p:bg>
+      <p:bgPr>
+        <a:solidFill>
+          <a:srgbClr val="FFFFFF"/>
+        </a:solidFill>
+        <a:effectLst/>
+      </p:bgPr>
+    </p:bg>
+    <p:spTree>
+      <p:nvGrpSpPr>
+        <p:cNvPr id="1" name=""/>
+        <p:cNvGrpSpPr/>
+        <p:nvPr/>
+      </p:nvGrpSpPr>
+      <p:grpSpPr/>
+      <p:sp>
+        <p:nvSpPr>
+          <p:cNvPr id="2" name="Rectangle 1"/>
+          <p:cNvSpPr/>
+          <p:nvPr/>
+        </p:nvSpPr>
+        <p:spPr>
+          <a:xfrm>
+            <a:off x="0" y="0"/>
+            <a:ext cx="9144000" cy="475488"/>
+          </a:xfrm>
+          <a:prstGeom prst="rect">
+            <a:avLst/>
+          </a:prstGeom>
+          <a:solidFill>
+            <a:srgbClr val="143278"/>
+          </a:solidFill>
+          <a:ln>
+            <a:noFill/>
+          </a:ln>
+        </p:spPr>
+        <p:style>
+          <a:lnRef idx="1">
+            <a:schemeClr val="accent1"/>
+          </a:lnRef>
+          <a:fillRef idx="3">
+            <a:schemeClr val="accent1"/>
+          </a:fillRef>
+          <a:effectRef idx="2">
+            <a:schemeClr val="accent1"/>
+          </a:effectRef>
+          <a:fontRef idx="minor">
+            <a:schemeClr val="lt1"/>
+          </a:fontRef>
+        </p:style>
+        <p:txBody>
+          <a:bodyPr rtlCol="0" anchor="ctr"/>
+          <a:lstStyle/>
+          <a:p>
+            <a:pPr algn="ctr"/>
+          </a:p>
+        </p:txBody>
+      </p:sp>
+      <p:sp>
+        <p:nvSpPr>
+          <p:cNvPr id="3" name="TextBox 2"/>
+          <p:cNvSpPr txBox="1"/>
+          <p:nvPr/>
+        </p:nvSpPr>
+        <p:spPr>
+          <a:xfrm>
+            <a:off x="137160" y="73152"/>
+            <a:ext cx="8869680" cy="411480"/>
+          </a:xfrm>
+          <a:prstGeom prst="rect">
+            <a:avLst/>
+          </a:prstGeom>
+          <a:noFill/>
+        </p:spPr>
+        <p:txBody>
+          <a:bodyPr wrap="none">
+            <a:spAutoFit/>
+          </a:bodyPr>
+          <a:lstStyle/>
+          <a:p>
+            <a:pPr>
+              <a:defRPr sz="1000" b="1">
+                <a:solidFill>
+                  <a:srgbClr val="FFFFFF"/>
+                </a:solidFill>
+              </a:defRPr>
+            </a:pPr>
+            <a:r>
+              <a:t>第二十八届中国机器人及人工智能大赛</a:t>
+            </a:r>
+          </a:p>
+          <a:p>
+            <a:pPr>
+              <a:defRPr sz="1000">
+                <a:solidFill>
+                  <a:srgbClr val="C8DCFF"/>
+                </a:solidFill>
+              </a:defRPr>
+            </a:pPr>
+            <a:r>
+              <a:t>机器人创新赛道</a:t>
+            </a:r>
+          </a:p>
+        </p:txBody>
+      </p:sp>
+      <p:sp>
+        <p:nvSpPr>
+          <p:cNvPr id="4" name="TextBox 3"/>
+          <p:cNvSpPr txBox="1"/>
+          <p:nvPr/>
+        </p:nvSpPr>
+        <p:spPr>
+          <a:xfrm>
+            <a:off x="502920" y="566928"/>
+            <a:ext cx="8138160" cy="731520"/>
+          </a:xfrm>
+          <a:prstGeom prst="rect">
+            <a:avLst/>
+          </a:prstGeom>
+          <a:noFill/>
+        </p:spPr>
+        <p:txBody>
+          <a:bodyPr wrap="square">
+            <a:spAutoFit/>
+          </a:bodyPr>
+          <a:lstStyle/>
+          <a:p>
+            <a:pPr algn="l">
+              <a:defRPr sz="2400" b="1">
+                <a:solidFill>
+                  <a:srgbClr val="1E1E1E"/>
+                </a:solidFill>
+              </a:defRPr>
+            </a:pPr>
+            <a:r>
+              <a:t>参考文献</a:t>
+            </a:r>
+          </a:p>
+        </p:txBody>
+      </p:sp>
+      <p:sp>
+        <p:nvSpPr>
+          <p:cNvPr id="5" name="TextBox 4"/>
+          <p:cNvSpPr txBox="1"/>
+          <p:nvPr/>
+        </p:nvSpPr>
+        <p:spPr>
+          <a:xfrm>
+            <a:off x="502920" y="1234440"/>
+            <a:ext cx="8138160" cy="3840480"/>
+          </a:xfrm>
+          <a:prstGeom prst="rect">
+            <a:avLst/>
+          </a:prstGeom>
+          <a:noFill/>
+        </p:spPr>
+        <p:txBody>
+          <a:bodyPr wrap="square">
+            <a:spAutoFit/>
+          </a:bodyPr>
+          <a:lstStyle/>
+          <a:p>
+            <a:pPr>
+              <a:spcAft>
+                <a:spcPts val="600"/>
+              </a:spcAft>
+              <a:defRPr sz="1200">
+                <a:solidFill>
+                  <a:srgbClr val="1E1E1E"/>
+                </a:solidFill>
+              </a:defRPr>
+            </a:pPr>
+            <a:r>
+              <a:t>[1] Google MediaPipe Pose: Real-time pose estimation.</a:t>
+            </a:r>
+          </a:p>
+          <a:p>
+            <a:pPr>
+              <a:spcAft>
+                <a:spcPts val="600"/>
+              </a:spcAft>
+              <a:defRPr sz="1200">
+                <a:solidFill>
+                  <a:srgbClr val="1E1E1E"/>
+                </a:solidFill>
+              </a:defRPr>
+            </a:pPr>
+            <a:r>
+              <a:t>[2] Unitree Robotics SDK / ROS2 documentation.</a:t>
+            </a:r>
+          </a:p>
+          <a:p>
+            <a:pPr>
+              <a:spcAft>
+                <a:spcPts val="600"/>
+              </a:spcAft>
+              <a:defRPr sz="1200">
+                <a:solidFill>
+                  <a:srgbClr val="1E1E1E"/>
+                </a:solidFill>
+              </a:defRPr>
+            </a:pPr>
+            <a:r>
+              <a:t>[3] 国务院：《「十四五」国家老龄事业发展和养老服务体系规划》.</a:t>
+            </a:r>
+          </a:p>
+          <a:p>
+            <a:pPr>
+              <a:spcAft>
+                <a:spcPts val="600"/>
+              </a:spcAft>
+              <a:defRPr sz="1200">
+                <a:solidFill>
+                  <a:srgbClr val="1E1E1E"/>
+                </a:solidFill>
+              </a:defRPr>
+            </a:pPr>
+            <a:r>
+              <a:t>[4] CareCompanion 项目文档：docs/TECHNICAL_REPORT.md</a:t>
+            </a:r>
+          </a:p>
+          <a:p>
+            <a:pPr>
+              <a:spcAft>
+                <a:spcPts val="600"/>
+              </a:spcAft>
+              <a:defRPr sz="1200">
+                <a:solidFill>
+                  <a:srgbClr val="1E1E1E"/>
+                </a:solidFill>
+              </a:defRPr>
+            </a:pPr>
+            <a:r>
+              <a:t>[5] 仓库：github.com/FBB123571/ElderCare-Humanoid-Platform</a:t>
+            </a:r>
+          </a:p>
+        </p:txBody>
+      </p:sp>
+    </p:spTree>
+  </p:cSld>
+  <p:clrMapOvr>
+    <a:masterClrMapping/>
+  </p:clrMapOvr>
+</p:sld>
+</file>
+
+<file path=ppt/slides/slide27.xml><?xml version="1.0" encoding="utf-8"?>
 <p:sld xmlns:a="http://schemas.openxmlformats.org/drawingml/2006/main" xmlns:p="http://schemas.openxmlformats.org/presentationml/2006/main" xmlns:r="http://schemas.openxmlformats.org/officeDocument/2006/relationships">
   <p:cSld>
     <p:bg>

</xml_diff>

<commit_message>
docs: update PPT with full-body MediaPipe pose export
Replace skeleton slide with full-resolution annotated photo and add
team checklist for remaining competition materials.
</commit_message>
<xml_diff>
--- a/docs/答辩_CareCompanion.pptx
+++ b/docs/答辩_CareCompanion.pptx
@@ -4642,8 +4642,8 @@
         </p:nvSpPr>
         <p:spPr>
           <a:xfrm>
-            <a:off x="2274745" y="914400"/>
-            <a:ext cx="4594508" cy="3753611"/>
+            <a:off x="3300989" y="914400"/>
+            <a:ext cx="2542020" cy="3753611"/>
           </a:xfrm>
           <a:prstGeom prst="rect">
             <a:avLst/>
@@ -4695,8 +4695,8 @@
         </p:blipFill>
         <p:spPr>
           <a:xfrm>
-            <a:off x="2329609" y="969264"/>
-            <a:ext cx="4484780" cy="3643884"/>
+            <a:off x="3355853" y="969264"/>
+            <a:ext cx="2432292" cy="3643883"/>
           </a:xfrm>
           <a:prstGeom prst="rect">
             <a:avLst/>
@@ -4733,7 +4733,7 @@
               </a:defRPr>
             </a:pPr>
             <a:r>
-              <a:t>上传全身/上半身照片 → 自动叠加骨架关键点 · 计算宽高比 0.48 · 跌倒判定</a:t>
+              <a:t>上传全身照后导出骨架叠加图 · 宽高比 0.48 · 支持答辩现场上传演示</a:t>
             </a:r>
           </a:p>
         </p:txBody>

</xml_diff>

<commit_message>
docs: add CRAIC team info and GitHub QR to defense PPT
Fill cover and entry slides for 从容应队 / SYSU, embed repo QR code,
and sync README with registration IDs.
</commit_message>
<xml_diff>
--- a/docs/答辩_CareCompanion.pptx
+++ b/docs/答辩_CareCompanion.pptx
@@ -32,6 +32,8 @@
     <p:sldId id="280" r:id="rId31"/>
     <p:sldId id="281" r:id="rId32"/>
     <p:sldId id="282" r:id="rId33"/>
+    <p:sldId id="283" r:id="rId34"/>
+    <p:sldId id="284" r:id="rId35"/>
   </p:sldIdLst>
   <p:sldSz cx="9144000" cy="5143500" type="screen4x3"/>
   <p:notesSz cx="6858000" cy="9144000"/>
@@ -3207,7 +3209,7 @@
               </a:defRPr>
             </a:pPr>
             <a:r>
-              <a:t>机器人创新赛道</a:t>
+              <a:t>创新赛 · 机器人创新赛道</a:t>
             </a:r>
           </a:p>
         </p:txBody>
@@ -3220,7 +3222,7 @@
         </p:nvSpPr>
         <p:spPr>
           <a:xfrm>
-            <a:off x="502920" y="1051560"/>
+            <a:off x="502920" y="868680"/>
             <a:ext cx="8138160" cy="731520"/>
           </a:xfrm>
           <a:prstGeom prst="rect">
@@ -3235,7 +3237,7 @@
           <a:lstStyle/>
           <a:p>
             <a:pPr algn="ctr">
-              <a:defRPr sz="3400" b="1">
+              <a:defRPr sz="3200" b="1">
                 <a:solidFill>
                   <a:srgbClr val="143278"/>
                 </a:solidFill>
@@ -3255,7 +3257,7 @@
         </p:nvSpPr>
         <p:spPr>
           <a:xfrm>
-            <a:off x="502920" y="1627632"/>
+            <a:off x="502920" y="1353312"/>
             <a:ext cx="8138160" cy="731520"/>
           </a:xfrm>
           <a:prstGeom prst="rect">
@@ -3270,14 +3272,14 @@
           <a:lstStyle/>
           <a:p>
             <a:pPr algn="ctr">
-              <a:defRPr sz="2100" b="1">
+              <a:defRPr sz="1700" b="1">
                 <a:solidFill>
                   <a:srgbClr val="1E1E1E"/>
                 </a:solidFill>
               </a:defRPr>
             </a:pPr>
             <a:r>
-              <a:t>智能养老人形陪伴机器人系统</a:t>
+              <a:t>基于大语言模型的智能养老陪伴机器人仿真平台</a:t>
             </a:r>
           </a:p>
         </p:txBody>
@@ -3290,8 +3292,8 @@
         </p:nvSpPr>
         <p:spPr>
           <a:xfrm>
-            <a:off x="502920" y="2240280"/>
-            <a:ext cx="7498079" cy="3474720"/>
+            <a:off x="502920" y="2148840"/>
+            <a:ext cx="8046720" cy="3474720"/>
           </a:xfrm>
           <a:prstGeom prst="rect">
             <a:avLst/>
@@ -3308,14 +3310,18 @@
               <a:lnSpc>
                 <a:spcPct val="135000"/>
               </a:lnSpc>
-              <a:defRPr sz="1600" b="1">
+              <a:defRPr sz="1300" b="0">
                 <a:solidFill>
                   <a:srgbClr val="1E1E1E"/>
                 </a:solidFill>
               </a:defRPr>
             </a:pPr>
             <a:r>
-              <a:t>「感知—决策—执行」一体化的居家养老安全陪伴平台</a:t>
+              <a:t>参赛团队：从容应队　|　中山大学（广东）</a:t>
+            </a:r>
+            <a:br/>
+            <a:r>
+              <a:t>队长 刘小凡　队员 白冉　指导教师 彭键清（智能科学与技术）</a:t>
             </a:r>
           </a:p>
         </p:txBody>
@@ -3328,8 +3334,8 @@
         </p:nvSpPr>
         <p:spPr>
           <a:xfrm>
-            <a:off x="502920" y="4274820"/>
-            <a:ext cx="8138160" cy="274320"/>
+            <a:off x="502920" y="4183380"/>
+            <a:ext cx="8138160" cy="502920"/>
           </a:xfrm>
           <a:prstGeom prst="rect">
             <a:avLst/>
@@ -3343,49 +3349,26 @@
           <a:lstStyle/>
           <a:p>
             <a:pPr algn="ctr">
-              <a:defRPr sz="1100">
+              <a:defRPr sz="1000">
                 <a:solidFill>
                   <a:srgbClr val="505050"/>
                 </a:solidFill>
               </a:defRPr>
             </a:pPr>
             <a:r>
-              <a:t>第二十八届中国机器人及人工智能大赛</a:t>
-            </a:r>
-          </a:p>
-        </p:txBody>
-      </p:sp>
-      <p:sp>
-        <p:nvSpPr>
-          <p:cNvPr id="8" name="TextBox 7"/>
-          <p:cNvSpPr txBox="1"/>
-          <p:nvPr/>
-        </p:nvSpPr>
-        <p:spPr>
-          <a:xfrm>
-            <a:off x="502920" y="4512564"/>
-            <a:ext cx="8138160" cy="274320"/>
-          </a:xfrm>
-          <a:prstGeom prst="rect">
-            <a:avLst/>
-          </a:prstGeom>
-          <a:noFill/>
-        </p:spPr>
-        <p:txBody>
-          <a:bodyPr wrap="none">
-            <a:spAutoFit/>
-          </a:bodyPr>
-          <a:lstStyle/>
+              <a:t>第二十八届中国机器人及人工智能大赛　·　创新赛 · 机器人创新赛道</a:t>
+            </a:r>
+          </a:p>
           <a:p>
             <a:pPr algn="ctr">
-              <a:defRPr sz="1100">
+              <a:defRPr sz="900">
                 <a:solidFill>
                   <a:srgbClr val="505050"/>
                 </a:solidFill>
               </a:defRPr>
             </a:pPr>
             <a:r>
-              <a:t>机器人创新赛道</a:t>
+              <a:t>团队编号 CRAIC2026-TEAM-8FJQKLMI　作品编号 CRAIC20264ZEFT1DF</a:t>
             </a:r>
           </a:p>
         </p:txBody>
@@ -3501,7 +3484,7 @@
               </a:defRPr>
             </a:pPr>
             <a:r>
-              <a:t>机器人创新赛道</a:t>
+              <a:t>创新赛 · 机器人创新赛道</a:t>
             </a:r>
           </a:p>
         </p:txBody>
@@ -3536,7 +3519,7 @@
               </a:defRPr>
             </a:pPr>
             <a:r>
-              <a:t>情感陪伴与紧急响应</a:t>
+              <a:t>跌倒检测算法</a:t>
             </a:r>
           </a:p>
         </p:txBody>
@@ -3549,7 +3532,7 @@
         </p:nvSpPr>
         <p:spPr>
           <a:xfrm>
-            <a:off x="502920" y="1234440"/>
+            <a:off x="502920" y="1325880"/>
             <a:ext cx="8138160" cy="3840480"/>
           </a:xfrm>
           <a:prstGeom prst="rect">
@@ -3567,14 +3550,14 @@
               <a:spcAft>
                 <a:spcPts val="600"/>
               </a:spcAft>
-              <a:defRPr sz="1300">
+              <a:defRPr sz="1400">
                 <a:solidFill>
                   <a:srgbClr val="1E1E1E"/>
                 </a:solidFill>
               </a:defRPr>
             </a:pPr>
             <a:r>
-              <a:t>对话：文本情感词典 + 视觉情绪标签融合；可插拔 LLM（默认离线 Mock）</a:t>
+              <a:t>几何特征：骨架宽高比 R=w/h、垂直速度 v_y、静止持续时间</a:t>
             </a:r>
           </a:p>
           <a:p>
@@ -3582,14 +3565,14 @@
               <a:spcAft>
                 <a:spcPts val="600"/>
               </a:spcAft>
-              <a:defRPr sz="1300">
+              <a:defRPr sz="1400">
                 <a:solidFill>
                   <a:srgbClr val="1E1E1E"/>
                 </a:solidFill>
               </a:defRPr>
             </a:pPr>
             <a:r>
-              <a:t>紧急链路：alert_sound → speak → call_emergency → raise_hand</a:t>
+              <a:t>快速跌倒：快速下落 + 躺倒姿态（score ≥ 0.7）</a:t>
             </a:r>
           </a:p>
           <a:p>
@@ -3597,14 +3580,44 @@
               <a:spcAft>
                 <a:spcPts val="600"/>
               </a:spcAft>
-              <a:defRPr sz="1300">
+              <a:defRPr sz="1400">
                 <a:solidFill>
                   <a:srgbClr val="1E1E1E"/>
                 </a:solidFill>
               </a:defRPr>
             </a:pPr>
             <a:r>
-              <a:t>EmergencyNotifier：家属 App / 短信 / 本地告警（可审计日志）</a:t>
+              <a:t>慢速跌倒：躺倒静止 ≥ 2s（养老场景常见，score ≥ 0.55）</a:t>
+            </a:r>
+          </a:p>
+          <a:p>
+            <a:pPr>
+              <a:spcAft>
+                <a:spcPts val="600"/>
+              </a:spcAft>
+              <a:defRPr sz="1400">
+                <a:solidFill>
+                  <a:srgbClr val="1E1E1E"/>
+                </a:solidFill>
+              </a:defRPr>
+            </a:pPr>
+            <a:r>
+              <a:t>MediaPipe Pose：浏览器/摄像头实时骨架 → 自动填充感知参数</a:t>
+            </a:r>
+          </a:p>
+          <a:p>
+            <a:pPr>
+              <a:spcAft>
+                <a:spcPts val="600"/>
+              </a:spcAft>
+              <a:defRPr sz="1400">
+                <a:solidFill>
+                  <a:srgbClr val="1E1E1E"/>
+                </a:solidFill>
+              </a:defRPr>
+            </a:pPr>
+            <a:r>
+              <a:t>评测：6 类合成场景，Precision/Recall/F1 = 100%</a:t>
             </a:r>
           </a:p>
         </p:txBody>
@@ -3720,125 +3733,21 @@
               </a:defRPr>
             </a:pPr>
             <a:r>
-              <a:t>机器人创新赛道</a:t>
-            </a:r>
-          </a:p>
-        </p:txBody>
-      </p:sp>
-      <p:sp>
-        <p:nvSpPr>
-          <p:cNvPr id="4" name="Rectangle 3"/>
-          <p:cNvSpPr/>
-          <p:nvPr/>
-        </p:nvSpPr>
-        <p:spPr>
-          <a:xfrm>
-            <a:off x="2375151" y="914400"/>
-            <a:ext cx="4393697" cy="3753611"/>
-          </a:xfrm>
-          <a:prstGeom prst="rect">
-            <a:avLst/>
-          </a:prstGeom>
-          <a:solidFill>
-            <a:srgbClr val="EBF2FA"/>
-          </a:solidFill>
-          <a:ln w="9525">
-            <a:solidFill>
-              <a:srgbClr val="B4C3DC"/>
-            </a:solidFill>
-          </a:ln>
-        </p:spPr>
-        <p:style>
-          <a:lnRef idx="1">
-            <a:schemeClr val="accent1"/>
-          </a:lnRef>
-          <a:fillRef idx="3">
-            <a:schemeClr val="accent1"/>
-          </a:fillRef>
-          <a:effectRef idx="2">
-            <a:schemeClr val="accent1"/>
-          </a:effectRef>
-          <a:fontRef idx="minor">
-            <a:schemeClr val="lt1"/>
-          </a:fontRef>
-        </p:style>
-        <p:txBody>
-          <a:bodyPr rtlCol="0" anchor="ctr"/>
-          <a:lstStyle/>
-          <a:p>
-            <a:pPr algn="ctr"/>
-          </a:p>
-        </p:txBody>
-      </p:sp>
-      <p:pic>
-        <p:nvPicPr>
-          <p:cNvPr id="5" name="Picture 4" descr="ppt_emotion_input.png"/>
-          <p:cNvPicPr>
-            <a:picLocks noChangeAspect="1"/>
-          </p:cNvPicPr>
-          <p:nvPr/>
-        </p:nvPicPr>
-        <p:blipFill>
-          <a:blip r:embed="rId2"/>
-          <a:stretch>
-            <a:fillRect/>
-          </a:stretch>
-        </p:blipFill>
-        <p:spPr>
-          <a:xfrm>
-            <a:off x="2430015" y="969264"/>
-            <a:ext cx="4283969" cy="3643884"/>
-          </a:xfrm>
-          <a:prstGeom prst="rect">
-            <a:avLst/>
-          </a:prstGeom>
-        </p:spPr>
-      </p:pic>
-      <p:sp>
-        <p:nvSpPr>
-          <p:cNvPr id="6" name="TextBox 5"/>
+              <a:t>创新赛 · 机器人创新赛道</a:t>
+            </a:r>
+          </a:p>
+        </p:txBody>
+      </p:sp>
+      <p:sp>
+        <p:nvSpPr>
+          <p:cNvPr id="4" name="TextBox 3"/>
           <p:cNvSpPr txBox="1"/>
           <p:nvPr/>
         </p:nvSpPr>
         <p:spPr>
           <a:xfrm>
-            <a:off x="411480" y="4638751"/>
-            <a:ext cx="8321040" cy="347472"/>
-          </a:xfrm>
-          <a:prstGeom prst="rect">
-            <a:avLst/>
-          </a:prstGeom>
-          <a:noFill/>
-        </p:spPr>
-        <p:txBody>
-          <a:bodyPr wrap="square" anchor="ctr">
-            <a:spAutoFit/>
-          </a:bodyPr>
-          <a:lstStyle/>
-          <a:p>
-            <a:pPr algn="ctr">
-              <a:defRPr sz="900">
-                <a:solidFill>
-                  <a:srgbClr val="505050"/>
-                </a:solidFill>
-              </a:defRPr>
-            </a:pPr>
-            <a:r>
-              <a:t>老人输入「最近有点孤独，睡不太好」→ 系统识别情绪低落并生成安抚话术</a:t>
-            </a:r>
-          </a:p>
-        </p:txBody>
-      </p:sp>
-      <p:sp>
-        <p:nvSpPr>
-          <p:cNvPr id="7" name="TextBox 6"/>
-          <p:cNvSpPr txBox="1"/>
-          <p:nvPr/>
-        </p:nvSpPr>
-        <p:spPr>
-          <a:xfrm>
-            <a:off x="411480" y="530352"/>
-            <a:ext cx="8321040" cy="384048"/>
+            <a:off x="502920" y="566928"/>
+            <a:ext cx="8138160" cy="731520"/>
           </a:xfrm>
           <a:prstGeom prst="rect">
             <a:avLst/>
@@ -3851,15 +3760,83 @@
           </a:bodyPr>
           <a:lstStyle/>
           <a:p>
-            <a:pPr algn="ctr">
-              <a:defRPr sz="1900" b="1">
+            <a:pPr algn="l">
+              <a:defRPr sz="2400" b="1">
                 <a:solidFill>
                   <a:srgbClr val="1E1E1E"/>
                 </a:solidFill>
               </a:defRPr>
             </a:pPr>
             <a:r>
-              <a:t>（界面）情感倾诉交互</a:t>
+              <a:t>情感陪伴与紧急响应</a:t>
+            </a:r>
+          </a:p>
+        </p:txBody>
+      </p:sp>
+      <p:sp>
+        <p:nvSpPr>
+          <p:cNvPr id="5" name="TextBox 4"/>
+          <p:cNvSpPr txBox="1"/>
+          <p:nvPr/>
+        </p:nvSpPr>
+        <p:spPr>
+          <a:xfrm>
+            <a:off x="502920" y="1234440"/>
+            <a:ext cx="8138160" cy="3840480"/>
+          </a:xfrm>
+          <a:prstGeom prst="rect">
+            <a:avLst/>
+          </a:prstGeom>
+          <a:noFill/>
+        </p:spPr>
+        <p:txBody>
+          <a:bodyPr wrap="square">
+            <a:spAutoFit/>
+          </a:bodyPr>
+          <a:lstStyle/>
+          <a:p>
+            <a:pPr>
+              <a:spcAft>
+                <a:spcPts val="600"/>
+              </a:spcAft>
+              <a:defRPr sz="1300">
+                <a:solidFill>
+                  <a:srgbClr val="1E1E1E"/>
+                </a:solidFill>
+              </a:defRPr>
+            </a:pPr>
+            <a:r>
+              <a:t>对话：文本情感词典 + 视觉情绪标签融合；可插拔 LLM（默认离线 Mock）</a:t>
+            </a:r>
+          </a:p>
+          <a:p>
+            <a:pPr>
+              <a:spcAft>
+                <a:spcPts val="600"/>
+              </a:spcAft>
+              <a:defRPr sz="1300">
+                <a:solidFill>
+                  <a:srgbClr val="1E1E1E"/>
+                </a:solidFill>
+              </a:defRPr>
+            </a:pPr>
+            <a:r>
+              <a:t>紧急链路：alert_sound → speak → call_emergency → raise_hand</a:t>
+            </a:r>
+          </a:p>
+          <a:p>
+            <a:pPr>
+              <a:spcAft>
+                <a:spcPts val="600"/>
+              </a:spcAft>
+              <a:defRPr sz="1300">
+                <a:solidFill>
+                  <a:srgbClr val="1E1E1E"/>
+                </a:solidFill>
+              </a:defRPr>
+            </a:pPr>
+            <a:r>
+              <a:t>EmergencyNotifier：家属 App / 短信 / 本地告警（可审计日志）</a:t>
             </a:r>
           </a:p>
         </p:txBody>
@@ -3975,21 +3952,125 @@
               </a:defRPr>
             </a:pPr>
             <a:r>
-              <a:t>机器人创新赛道</a:t>
-            </a:r>
-          </a:p>
-        </p:txBody>
-      </p:sp>
-      <p:sp>
-        <p:nvSpPr>
-          <p:cNvPr id="4" name="TextBox 3"/>
+              <a:t>创新赛 · 机器人创新赛道</a:t>
+            </a:r>
+          </a:p>
+        </p:txBody>
+      </p:sp>
+      <p:sp>
+        <p:nvSpPr>
+          <p:cNvPr id="4" name="Rectangle 3"/>
+          <p:cNvSpPr/>
+          <p:nvPr/>
+        </p:nvSpPr>
+        <p:spPr>
+          <a:xfrm>
+            <a:off x="2375151" y="914400"/>
+            <a:ext cx="4393697" cy="3753611"/>
+          </a:xfrm>
+          <a:prstGeom prst="rect">
+            <a:avLst/>
+          </a:prstGeom>
+          <a:solidFill>
+            <a:srgbClr val="EBF2FA"/>
+          </a:solidFill>
+          <a:ln w="9525">
+            <a:solidFill>
+              <a:srgbClr val="B4C3DC"/>
+            </a:solidFill>
+          </a:ln>
+        </p:spPr>
+        <p:style>
+          <a:lnRef idx="1">
+            <a:schemeClr val="accent1"/>
+          </a:lnRef>
+          <a:fillRef idx="3">
+            <a:schemeClr val="accent1"/>
+          </a:fillRef>
+          <a:effectRef idx="2">
+            <a:schemeClr val="accent1"/>
+          </a:effectRef>
+          <a:fontRef idx="minor">
+            <a:schemeClr val="lt1"/>
+          </a:fontRef>
+        </p:style>
+        <p:txBody>
+          <a:bodyPr rtlCol="0" anchor="ctr"/>
+          <a:lstStyle/>
+          <a:p>
+            <a:pPr algn="ctr"/>
+          </a:p>
+        </p:txBody>
+      </p:sp>
+      <p:pic>
+        <p:nvPicPr>
+          <p:cNvPr id="5" name="Picture 4" descr="ppt_emotion_input.png"/>
+          <p:cNvPicPr>
+            <a:picLocks noChangeAspect="1"/>
+          </p:cNvPicPr>
+          <p:nvPr/>
+        </p:nvPicPr>
+        <p:blipFill>
+          <a:blip r:embed="rId2"/>
+          <a:stretch>
+            <a:fillRect/>
+          </a:stretch>
+        </p:blipFill>
+        <p:spPr>
+          <a:xfrm>
+            <a:off x="2430015" y="969264"/>
+            <a:ext cx="4283969" cy="3643884"/>
+          </a:xfrm>
+          <a:prstGeom prst="rect">
+            <a:avLst/>
+          </a:prstGeom>
+        </p:spPr>
+      </p:pic>
+      <p:sp>
+        <p:nvSpPr>
+          <p:cNvPr id="6" name="TextBox 5"/>
           <p:cNvSpPr txBox="1"/>
           <p:nvPr/>
         </p:nvSpPr>
         <p:spPr>
           <a:xfrm>
-            <a:off x="502920" y="566928"/>
-            <a:ext cx="8138160" cy="731520"/>
+            <a:off x="411480" y="4638751"/>
+            <a:ext cx="8321040" cy="347472"/>
+          </a:xfrm>
+          <a:prstGeom prst="rect">
+            <a:avLst/>
+          </a:prstGeom>
+          <a:noFill/>
+        </p:spPr>
+        <p:txBody>
+          <a:bodyPr wrap="square" anchor="ctr">
+            <a:spAutoFit/>
+          </a:bodyPr>
+          <a:lstStyle/>
+          <a:p>
+            <a:pPr algn="ctr">
+              <a:defRPr sz="900">
+                <a:solidFill>
+                  <a:srgbClr val="505050"/>
+                </a:solidFill>
+              </a:defRPr>
+            </a:pPr>
+            <a:r>
+              <a:t>老人输入「最近有点孤独，睡不太好」→ 系统识别情绪低落并生成安抚话术</a:t>
+            </a:r>
+          </a:p>
+        </p:txBody>
+      </p:sp>
+      <p:sp>
+        <p:nvSpPr>
+          <p:cNvPr id="7" name="TextBox 6"/>
+          <p:cNvSpPr txBox="1"/>
+          <p:nvPr/>
+        </p:nvSpPr>
+        <p:spPr>
+          <a:xfrm>
+            <a:off x="411480" y="530352"/>
+            <a:ext cx="8321040" cy="384048"/>
           </a:xfrm>
           <a:prstGeom prst="rect">
             <a:avLst/>
@@ -4002,113 +4083,15 @@
           </a:bodyPr>
           <a:lstStyle/>
           <a:p>
-            <a:pPr algn="l">
-              <a:defRPr sz="2400" b="1">
+            <a:pPr algn="ctr">
+              <a:defRPr sz="1900" b="1">
                 <a:solidFill>
                   <a:srgbClr val="1E1E1E"/>
                 </a:solidFill>
               </a:defRPr>
             </a:pPr>
             <a:r>
-              <a:t>数据处理与决策流程</a:t>
-            </a:r>
-          </a:p>
-        </p:txBody>
-      </p:sp>
-      <p:sp>
-        <p:nvSpPr>
-          <p:cNvPr id="5" name="TextBox 4"/>
-          <p:cNvSpPr txBox="1"/>
-          <p:nvPr/>
-        </p:nvSpPr>
-        <p:spPr>
-          <a:xfrm>
-            <a:off x="502920" y="1325880"/>
-            <a:ext cx="8138160" cy="3840480"/>
-          </a:xfrm>
-          <a:prstGeom prst="rect">
-            <a:avLst/>
-          </a:prstGeom>
-          <a:noFill/>
-        </p:spPr>
-        <p:txBody>
-          <a:bodyPr wrap="square">
-            <a:spAutoFit/>
-          </a:bodyPr>
-          <a:lstStyle/>
-          <a:p>
-            <a:pPr>
-              <a:spcAft>
-                <a:spcPts val="600"/>
-              </a:spcAft>
-              <a:defRPr sz="1400">
-                <a:solidFill>
-                  <a:srgbClr val="1E1E1E"/>
-                </a:solidFill>
-              </a:defRPr>
-            </a:pPr>
-            <a:r>
-              <a:t>1. 采集感知帧：摄像头骨架 / 滑块仿真 / 可穿戴 JSON</a:t>
-            </a:r>
-          </a:p>
-          <a:p>
-            <a:pPr>
-              <a:spcAft>
-                <a:spcPts val="600"/>
-              </a:spcAft>
-              <a:defRPr sz="1400">
-                <a:solidFill>
-                  <a:srgbClr val="1E1E1E"/>
-                </a:solidFill>
-              </a:defRPr>
-            </a:pPr>
-            <a:r>
-              <a:t>2. FallDetector 更新跌倒分数，Emotion/Health 更新标签</a:t>
-            </a:r>
-          </a:p>
-          <a:p>
-            <a:pPr>
-              <a:spcAft>
-                <a:spcPts val="600"/>
-              </a:spcAft>
-              <a:defRPr sz="1400">
-                <a:solidFill>
-                  <a:srgbClr val="1E1E1E"/>
-                </a:solidFill>
-              </a:defRPr>
-            </a:pPr>
-            <a:r>
-              <a:t>3. RiskEngine 评估等级，状态机切换</a:t>
-            </a:r>
-          </a:p>
-          <a:p>
-            <a:pPr>
-              <a:spcAft>
-                <a:spcPts val="600"/>
-              </a:spcAft>
-              <a:defRPr sz="1400">
-                <a:solidFill>
-                  <a:srgbClr val="1E1E1E"/>
-                </a:solidFill>
-              </a:defRPr>
-            </a:pPr>
-            <a:r>
-              <a:t>4. DialogueManager 生成回复，CarePlanner 输出 RobotAction 序列</a:t>
-            </a:r>
-          </a:p>
-          <a:p>
-            <a:pPr>
-              <a:spcAft>
-                <a:spcPts val="600"/>
-              </a:spcAft>
-              <a:defRPr sz="1400">
-                <a:solidFill>
-                  <a:srgbClr val="1E1E1E"/>
-                </a:solidFill>
-              </a:defRPr>
-            </a:pPr>
-            <a:r>
-              <a:t>5. RobotAdapter 下发至仿真日志或 ROS2 /care/robot_cmd</a:t>
+              <a:t>（界面）情感倾诉交互</a:t>
             </a:r>
           </a:p>
         </p:txBody>
@@ -4224,7 +4207,7 @@
               </a:defRPr>
             </a:pPr>
             <a:r>
-              <a:t>机器人创新赛道</a:t>
+              <a:t>创新赛 · 机器人创新赛道</a:t>
             </a:r>
           </a:p>
         </p:txBody>
@@ -4237,7 +4220,7 @@
         </p:nvSpPr>
         <p:spPr>
           <a:xfrm>
-            <a:off x="502920" y="2068830"/>
+            <a:off x="502920" y="566928"/>
             <a:ext cx="8138160" cy="731520"/>
           </a:xfrm>
           <a:prstGeom prst="rect">
@@ -4251,15 +4234,15 @@
           </a:bodyPr>
           <a:lstStyle/>
           <a:p>
-            <a:pPr algn="ctr">
-              <a:defRPr sz="3000" b="1">
+            <a:pPr algn="l">
+              <a:defRPr sz="2400" b="1">
                 <a:solidFill>
                   <a:srgbClr val="1E1E1E"/>
                 </a:solidFill>
               </a:defRPr>
             </a:pPr>
             <a:r>
-              <a:t>第三部分</a:t>
+              <a:t>数据处理与决策流程</a:t>
             </a:r>
           </a:p>
         </p:txBody>
@@ -4272,8 +4255,8 @@
         </p:nvSpPr>
         <p:spPr>
           <a:xfrm>
-            <a:off x="502920" y="2617470"/>
-            <a:ext cx="8138160" cy="731520"/>
+            <a:off x="502920" y="1325880"/>
+            <a:ext cx="8138160" cy="3840480"/>
           </a:xfrm>
           <a:prstGeom prst="rect">
             <a:avLst/>
@@ -4286,15 +4269,78 @@
           </a:bodyPr>
           <a:lstStyle/>
           <a:p>
-            <a:pPr algn="ctr">
-              <a:defRPr sz="2000" b="1">
-                <a:solidFill>
-                  <a:srgbClr val="143278"/>
-                </a:solidFill>
-              </a:defRPr>
-            </a:pPr>
-            <a:r>
-              <a:t>系统实现 · 评测 · 演示</a:t>
+            <a:pPr>
+              <a:spcAft>
+                <a:spcPts val="600"/>
+              </a:spcAft>
+              <a:defRPr sz="1400">
+                <a:solidFill>
+                  <a:srgbClr val="1E1E1E"/>
+                </a:solidFill>
+              </a:defRPr>
+            </a:pPr>
+            <a:r>
+              <a:t>1. 采集感知帧：摄像头骨架 / 滑块仿真 / 可穿戴 JSON</a:t>
+            </a:r>
+          </a:p>
+          <a:p>
+            <a:pPr>
+              <a:spcAft>
+                <a:spcPts val="600"/>
+              </a:spcAft>
+              <a:defRPr sz="1400">
+                <a:solidFill>
+                  <a:srgbClr val="1E1E1E"/>
+                </a:solidFill>
+              </a:defRPr>
+            </a:pPr>
+            <a:r>
+              <a:t>2. FallDetector 更新跌倒分数，Emotion/Health 更新标签</a:t>
+            </a:r>
+          </a:p>
+          <a:p>
+            <a:pPr>
+              <a:spcAft>
+                <a:spcPts val="600"/>
+              </a:spcAft>
+              <a:defRPr sz="1400">
+                <a:solidFill>
+                  <a:srgbClr val="1E1E1E"/>
+                </a:solidFill>
+              </a:defRPr>
+            </a:pPr>
+            <a:r>
+              <a:t>3. RiskEngine 评估等级，状态机切换</a:t>
+            </a:r>
+          </a:p>
+          <a:p>
+            <a:pPr>
+              <a:spcAft>
+                <a:spcPts val="600"/>
+              </a:spcAft>
+              <a:defRPr sz="1400">
+                <a:solidFill>
+                  <a:srgbClr val="1E1E1E"/>
+                </a:solidFill>
+              </a:defRPr>
+            </a:pPr>
+            <a:r>
+              <a:t>4. DialogueManager 生成回复，CarePlanner 输出 RobotAction 序列</a:t>
+            </a:r>
+          </a:p>
+          <a:p>
+            <a:pPr>
+              <a:spcAft>
+                <a:spcPts val="600"/>
+              </a:spcAft>
+              <a:defRPr sz="1400">
+                <a:solidFill>
+                  <a:srgbClr val="1E1E1E"/>
+                </a:solidFill>
+              </a:defRPr>
+            </a:pPr>
+            <a:r>
+              <a:t>5. RobotAdapter 下发至仿真日志或 ROS2 /care/robot_cmd</a:t>
             </a:r>
           </a:p>
         </p:txBody>
@@ -4410,7 +4456,7 @@
               </a:defRPr>
             </a:pPr>
             <a:r>
-              <a:t>机器人创新赛道</a:t>
+              <a:t>创新赛 · 机器人创新赛道</a:t>
             </a:r>
           </a:p>
         </p:txBody>
@@ -4423,7 +4469,7 @@
         </p:nvSpPr>
         <p:spPr>
           <a:xfrm>
-            <a:off x="502920" y="566928"/>
+            <a:off x="502920" y="2068830"/>
             <a:ext cx="8138160" cy="731520"/>
           </a:xfrm>
           <a:prstGeom prst="rect">
@@ -4437,15 +4483,15 @@
           </a:bodyPr>
           <a:lstStyle/>
           <a:p>
-            <a:pPr algn="l">
-              <a:defRPr sz="2400" b="1">
+            <a:pPr algn="ctr">
+              <a:defRPr sz="3000" b="1">
                 <a:solidFill>
                   <a:srgbClr val="1E1E1E"/>
                 </a:solidFill>
               </a:defRPr>
             </a:pPr>
             <a:r>
-              <a:t>Web 控制台（CareCompanion）</a:t>
+              <a:t>第三部分</a:t>
             </a:r>
           </a:p>
         </p:txBody>
@@ -4458,8 +4504,8 @@
         </p:nvSpPr>
         <p:spPr>
           <a:xfrm>
-            <a:off x="502920" y="1234440"/>
-            <a:ext cx="8138160" cy="3840480"/>
+            <a:off x="502920" y="2617470"/>
+            <a:ext cx="8138160" cy="731520"/>
           </a:xfrm>
           <a:prstGeom prst="rect">
             <a:avLst/>
@@ -4472,48 +4518,15 @@
           </a:bodyPr>
           <a:lstStyle/>
           <a:p>
-            <a:pPr>
-              <a:spcAft>
-                <a:spcPts val="600"/>
-              </a:spcAft>
-              <a:defRPr sz="1300">
-                <a:solidFill>
-                  <a:srgbClr val="1E1E1E"/>
-                </a:solidFill>
-              </a:defRPr>
-            </a:pPr>
-            <a:r>
-              <a:t>访问地址：http://localhost:8765（bash scripts/run_web.sh）</a:t>
-            </a:r>
-          </a:p>
-          <a:p>
-            <a:pPr>
-              <a:spcAft>
-                <a:spcPts val="600"/>
-              </a:spcAft>
-              <a:defRPr sz="1300">
-                <a:solidFill>
-                  <a:srgbClr val="1E1E1E"/>
-                </a:solidFill>
-              </a:defRPr>
-            </a:pPr>
-            <a:r>
-              <a:t>技术栈：FastAPI + 浏览器前端，支持答辩现场演示</a:t>
-            </a:r>
-          </a:p>
-          <a:p>
-            <a:pPr>
-              <a:spcAft>
-                <a:spcPts val="600"/>
-              </a:spcAft>
-              <a:defRPr sz="1300">
-                <a:solidFill>
-                  <a:srgbClr val="1E1E1E"/>
-                </a:solidFill>
-              </a:defRPr>
-            </a:pPr>
-            <a:r>
-              <a:t>以下截图为实际运行界面（2026-05-27 答辩预演录制）</a:t>
+            <a:pPr algn="ctr">
+              <a:defRPr sz="2000" b="1">
+                <a:solidFill>
+                  <a:srgbClr val="143278"/>
+                </a:solidFill>
+              </a:defRPr>
+            </a:pPr>
+            <a:r>
+              <a:t>系统实现 · 评测 · 演示</a:t>
             </a:r>
           </a:p>
         </p:txBody>
@@ -4629,125 +4642,21 @@
               </a:defRPr>
             </a:pPr>
             <a:r>
-              <a:t>机器人创新赛道</a:t>
-            </a:r>
-          </a:p>
-        </p:txBody>
-      </p:sp>
-      <p:sp>
-        <p:nvSpPr>
-          <p:cNvPr id="4" name="Rectangle 3"/>
-          <p:cNvSpPr/>
-          <p:nvPr/>
-        </p:nvSpPr>
-        <p:spPr>
-          <a:xfrm>
-            <a:off x="3300989" y="914400"/>
-            <a:ext cx="2542020" cy="3753611"/>
-          </a:xfrm>
-          <a:prstGeom prst="rect">
-            <a:avLst/>
-          </a:prstGeom>
-          <a:solidFill>
-            <a:srgbClr val="EBF2FA"/>
-          </a:solidFill>
-          <a:ln w="9525">
-            <a:solidFill>
-              <a:srgbClr val="B4C3DC"/>
-            </a:solidFill>
-          </a:ln>
-        </p:spPr>
-        <p:style>
-          <a:lnRef idx="1">
-            <a:schemeClr val="accent1"/>
-          </a:lnRef>
-          <a:fillRef idx="3">
-            <a:schemeClr val="accent1"/>
-          </a:fillRef>
-          <a:effectRef idx="2">
-            <a:schemeClr val="accent1"/>
-          </a:effectRef>
-          <a:fontRef idx="minor">
-            <a:schemeClr val="lt1"/>
-          </a:fontRef>
-        </p:style>
-        <p:txBody>
-          <a:bodyPr rtlCol="0" anchor="ctr"/>
-          <a:lstStyle/>
-          <a:p>
-            <a:pPr algn="ctr"/>
-          </a:p>
-        </p:txBody>
-      </p:sp>
-      <p:pic>
-        <p:nvPicPr>
-          <p:cNvPr id="5" name="Picture 4" descr="ppt_mediapipe_pose.png"/>
-          <p:cNvPicPr>
-            <a:picLocks noChangeAspect="1"/>
-          </p:cNvPicPr>
-          <p:nvPr/>
-        </p:nvPicPr>
-        <p:blipFill>
-          <a:blip r:embed="rId2"/>
-          <a:stretch>
-            <a:fillRect/>
-          </a:stretch>
-        </p:blipFill>
-        <p:spPr>
-          <a:xfrm>
-            <a:off x="3355853" y="969264"/>
-            <a:ext cx="2432292" cy="3643883"/>
-          </a:xfrm>
-          <a:prstGeom prst="rect">
-            <a:avLst/>
-          </a:prstGeom>
-        </p:spPr>
-      </p:pic>
-      <p:sp>
-        <p:nvSpPr>
-          <p:cNvPr id="6" name="TextBox 5"/>
+              <a:t>创新赛 · 机器人创新赛道</a:t>
+            </a:r>
+          </a:p>
+        </p:txBody>
+      </p:sp>
+      <p:sp>
+        <p:nvSpPr>
+          <p:cNvPr id="4" name="TextBox 3"/>
           <p:cNvSpPr txBox="1"/>
           <p:nvPr/>
         </p:nvSpPr>
         <p:spPr>
           <a:xfrm>
-            <a:off x="411480" y="4638751"/>
-            <a:ext cx="8321040" cy="347472"/>
-          </a:xfrm>
-          <a:prstGeom prst="rect">
-            <a:avLst/>
-          </a:prstGeom>
-          <a:noFill/>
-        </p:spPr>
-        <p:txBody>
-          <a:bodyPr wrap="square" anchor="ctr">
-            <a:spAutoFit/>
-          </a:bodyPr>
-          <a:lstStyle/>
-          <a:p>
-            <a:pPr algn="ctr">
-              <a:defRPr sz="900">
-                <a:solidFill>
-                  <a:srgbClr val="505050"/>
-                </a:solidFill>
-              </a:defRPr>
-            </a:pPr>
-            <a:r>
-              <a:t>上传全身照后导出骨架叠加图 · 宽高比 0.48 · 支持答辩现场上传演示</a:t>
-            </a:r>
-          </a:p>
-        </p:txBody>
-      </p:sp>
-      <p:sp>
-        <p:nvSpPr>
-          <p:cNvPr id="7" name="TextBox 6"/>
-          <p:cNvSpPr txBox="1"/>
-          <p:nvPr/>
-        </p:nvSpPr>
-        <p:spPr>
-          <a:xfrm>
-            <a:off x="411480" y="530352"/>
-            <a:ext cx="8321040" cy="384048"/>
+            <a:off x="502920" y="566928"/>
+            <a:ext cx="8138160" cy="731520"/>
           </a:xfrm>
           <a:prstGeom prst="rect">
             <a:avLst/>
@@ -4760,15 +4669,83 @@
           </a:bodyPr>
           <a:lstStyle/>
           <a:p>
-            <a:pPr algn="ctr">
-              <a:defRPr sz="1900" b="1">
+            <a:pPr algn="l">
+              <a:defRPr sz="2400" b="1">
                 <a:solidFill>
                   <a:srgbClr val="1E1E1E"/>
                 </a:solidFill>
               </a:defRPr>
             </a:pPr>
             <a:r>
-              <a:t>系统界面：MediaPipe 骨架分析（上传照片）</a:t>
+              <a:t>Web 控制台（CareCompanion）</a:t>
+            </a:r>
+          </a:p>
+        </p:txBody>
+      </p:sp>
+      <p:sp>
+        <p:nvSpPr>
+          <p:cNvPr id="5" name="TextBox 4"/>
+          <p:cNvSpPr txBox="1"/>
+          <p:nvPr/>
+        </p:nvSpPr>
+        <p:spPr>
+          <a:xfrm>
+            <a:off x="502920" y="1234440"/>
+            <a:ext cx="8138160" cy="3840480"/>
+          </a:xfrm>
+          <a:prstGeom prst="rect">
+            <a:avLst/>
+          </a:prstGeom>
+          <a:noFill/>
+        </p:spPr>
+        <p:txBody>
+          <a:bodyPr wrap="square">
+            <a:spAutoFit/>
+          </a:bodyPr>
+          <a:lstStyle/>
+          <a:p>
+            <a:pPr>
+              <a:spcAft>
+                <a:spcPts val="600"/>
+              </a:spcAft>
+              <a:defRPr sz="1300">
+                <a:solidFill>
+                  <a:srgbClr val="1E1E1E"/>
+                </a:solidFill>
+              </a:defRPr>
+            </a:pPr>
+            <a:r>
+              <a:t>访问地址：http://localhost:8765（bash scripts/run_web.sh）</a:t>
+            </a:r>
+          </a:p>
+          <a:p>
+            <a:pPr>
+              <a:spcAft>
+                <a:spcPts val="600"/>
+              </a:spcAft>
+              <a:defRPr sz="1300">
+                <a:solidFill>
+                  <a:srgbClr val="1E1E1E"/>
+                </a:solidFill>
+              </a:defRPr>
+            </a:pPr>
+            <a:r>
+              <a:t>技术栈：FastAPI + 浏览器前端，支持答辩现场演示</a:t>
+            </a:r>
+          </a:p>
+          <a:p>
+            <a:pPr>
+              <a:spcAft>
+                <a:spcPts val="600"/>
+              </a:spcAft>
+              <a:defRPr sz="1300">
+                <a:solidFill>
+                  <a:srgbClr val="1E1E1E"/>
+                </a:solidFill>
+              </a:defRPr>
+            </a:pPr>
+            <a:r>
+              <a:t>以下截图为实际运行界面（2026-05-27 答辩预演录制）</a:t>
             </a:r>
           </a:p>
         </p:txBody>
@@ -4884,7 +4861,7 @@
               </a:defRPr>
             </a:pPr>
             <a:r>
-              <a:t>机器人创新赛道</a:t>
+              <a:t>创新赛 · 机器人创新赛道</a:t>
             </a:r>
           </a:p>
         </p:txBody>
@@ -4897,8 +4874,8 @@
         </p:nvSpPr>
         <p:spPr>
           <a:xfrm>
-            <a:off x="1023374" y="914400"/>
-            <a:ext cx="7097250" cy="3753611"/>
+            <a:off x="3300989" y="914400"/>
+            <a:ext cx="2542020" cy="3753611"/>
           </a:xfrm>
           <a:prstGeom prst="rect">
             <a:avLst/>
@@ -4936,7 +4913,7 @@
       </p:sp>
       <p:pic>
         <p:nvPicPr>
-          <p:cNvPr id="5" name="Picture 4" descr="ppt_full_dashboard.png"/>
+          <p:cNvPr id="5" name="Picture 4" descr="ppt_mediapipe_pose.png"/>
           <p:cNvPicPr>
             <a:picLocks noChangeAspect="1"/>
           </p:cNvPicPr>
@@ -4950,8 +4927,8 @@
         </p:blipFill>
         <p:spPr>
           <a:xfrm>
-            <a:off x="1078238" y="969264"/>
-            <a:ext cx="6987522" cy="3643884"/>
+            <a:off x="3355853" y="969264"/>
+            <a:ext cx="2432292" cy="3643883"/>
           </a:xfrm>
           <a:prstGeom prst="rect">
             <a:avLst/>
@@ -4988,7 +4965,7 @@
               </a:defRPr>
             </a:pPr>
             <a:r>
-              <a:t>演示场景「老人倾诉」· 风险 0.23 · 机器人主动安抚回复</a:t>
+              <a:t>上传全身照后导出骨架叠加图 · 宽高比 0.48 · 支持答辩现场上传演示</a:t>
             </a:r>
           </a:p>
         </p:txBody>
@@ -5023,7 +5000,7 @@
               </a:defRPr>
             </a:pPr>
             <a:r>
-              <a:t>系统界面：老人倾诉场景（演示剧本）</a:t>
+              <a:t>系统界面：MediaPipe 骨架分析（上传照片）</a:t>
             </a:r>
           </a:p>
         </p:txBody>
@@ -5139,7 +5116,7 @@
               </a:defRPr>
             </a:pPr>
             <a:r>
-              <a:t>机器人创新赛道</a:t>
+              <a:t>创新赛 · 机器人创新赛道</a:t>
             </a:r>
           </a:p>
         </p:txBody>
@@ -5152,8 +5129,8 @@
         </p:nvSpPr>
         <p:spPr>
           <a:xfrm>
-            <a:off x="2986989" y="914400"/>
-            <a:ext cx="3170021" cy="3753611"/>
+            <a:off x="1023374" y="914400"/>
+            <a:ext cx="7097250" cy="3753611"/>
           </a:xfrm>
           <a:prstGeom prst="rect">
             <a:avLst/>
@@ -5191,7 +5168,7 @@
       </p:sp>
       <p:pic>
         <p:nvPicPr>
-          <p:cNvPr id="5" name="Picture 4" descr="ppt_risk_panel.png"/>
+          <p:cNvPr id="5" name="Picture 4" descr="ppt_full_dashboard.png"/>
           <p:cNvPicPr>
             <a:picLocks noChangeAspect="1"/>
           </p:cNvPicPr>
@@ -5205,8 +5182,8 @@
         </p:blipFill>
         <p:spPr>
           <a:xfrm>
-            <a:off x="3041853" y="969264"/>
-            <a:ext cx="3060293" cy="3643884"/>
+            <a:off x="1078238" y="969264"/>
+            <a:ext cx="6987522" cy="3643884"/>
           </a:xfrm>
           <a:prstGeom prst="rect">
             <a:avLst/>
@@ -5243,7 +5220,7 @@
               </a:defRPr>
             </a:pPr>
             <a:r>
-              <a:t>多模态融合输出：风险分数、因素、机器人回应及四项监测指标</a:t>
+              <a:t>演示场景「老人倾诉」· 风险 0.23 · 机器人主动安抚回复</a:t>
             </a:r>
           </a:p>
         </p:txBody>
@@ -5278,7 +5255,7 @@
               </a:defRPr>
             </a:pPr>
             <a:r>
-              <a:t>系统界面：风险决策仪表盘</a:t>
+              <a:t>系统界面：老人倾诉场景（演示剧本）</a:t>
             </a:r>
           </a:p>
         </p:txBody>
@@ -5394,7 +5371,7 @@
               </a:defRPr>
             </a:pPr>
             <a:r>
-              <a:t>机器人创新赛道</a:t>
+              <a:t>创新赛 · 机器人创新赛道</a:t>
             </a:r>
           </a:p>
         </p:txBody>
@@ -5407,8 +5384,8 @@
         </p:nvSpPr>
         <p:spPr>
           <a:xfrm>
-            <a:off x="997006" y="914400"/>
-            <a:ext cx="7149986" cy="3753611"/>
+            <a:off x="2986989" y="914400"/>
+            <a:ext cx="3170021" cy="3753611"/>
           </a:xfrm>
           <a:prstGeom prst="rect">
             <a:avLst/>
@@ -5446,7 +5423,7 @@
       </p:sp>
       <p:pic>
         <p:nvPicPr>
-          <p:cNvPr id="5" name="Picture 4" descr="ppt_header_perception.png"/>
+          <p:cNvPr id="5" name="Picture 4" descr="ppt_risk_panel.png"/>
           <p:cNvPicPr>
             <a:picLocks noChangeAspect="1"/>
           </p:cNvPicPr>
@@ -5460,8 +5437,8 @@
         </p:blipFill>
         <p:spPr>
           <a:xfrm>
-            <a:off x="1051870" y="969264"/>
-            <a:ext cx="7040258" cy="3643884"/>
+            <a:off x="3041853" y="969264"/>
+            <a:ext cx="3060293" cy="3643884"/>
           </a:xfrm>
           <a:prstGeom prst="rect">
             <a:avLst/>
@@ -5498,7 +5475,7 @@
               </a:defRPr>
             </a:pPr>
             <a:r>
-              <a:t>状态机进入「紧急」· 感知输入与 MediaPipe 视觉模块</a:t>
+              <a:t>多模态融合输出：风险分数、因素、机器人回应及四项监测指标</a:t>
             </a:r>
           </a:p>
         </p:txBody>
@@ -5533,7 +5510,7 @@
               </a:defRPr>
             </a:pPr>
             <a:r>
-              <a:t>系统界面：紧急状态监测</a:t>
+              <a:t>系统界面：风险决策仪表盘</a:t>
             </a:r>
           </a:p>
         </p:txBody>
@@ -5649,7 +5626,7 @@
               </a:defRPr>
             </a:pPr>
             <a:r>
-              <a:t>机器人创新赛道</a:t>
+              <a:t>创新赛 · 机器人创新赛道</a:t>
             </a:r>
           </a:p>
         </p:txBody>
@@ -5662,8 +5639,8 @@
         </p:nvSpPr>
         <p:spPr>
           <a:xfrm>
-            <a:off x="1131167" y="914400"/>
-            <a:ext cx="6881664" cy="3753611"/>
+            <a:off x="997006" y="914400"/>
+            <a:ext cx="7149986" cy="3753611"/>
           </a:xfrm>
           <a:prstGeom prst="rect">
             <a:avLst/>
@@ -5701,7 +5678,7 @@
       </p:sp>
       <p:pic>
         <p:nvPicPr>
-          <p:cNvPr id="5" name="Picture 4" descr="ppt_chat_emergency.png"/>
+          <p:cNvPr id="5" name="Picture 4" descr="ppt_header_perception.png"/>
           <p:cNvPicPr>
             <a:picLocks noChangeAspect="1"/>
           </p:cNvPicPr>
@@ -5715,8 +5692,8 @@
         </p:blipFill>
         <p:spPr>
           <a:xfrm>
-            <a:off x="1186031" y="969264"/>
-            <a:ext cx="6771936" cy="3643884"/>
+            <a:off x="1051870" y="969264"/>
+            <a:ext cx="7040258" cy="3643884"/>
           </a:xfrm>
           <a:prstGeom prst="rect">
             <a:avLst/>
@@ -5753,7 +5730,7 @@
               </a:defRPr>
             </a:pPr>
             <a:r>
-              <a:t>演示完成：跌倒紧急流程已成功触发 · 多次紧急安抚语音</a:t>
+              <a:t>状态机进入「紧急」· 感知输入与 MediaPipe 视觉模块</a:t>
             </a:r>
           </a:p>
         </p:txBody>
@@ -5788,7 +5765,7 @@
               </a:defRPr>
             </a:pPr>
             <a:r>
-              <a:t>系统界面：跌倒紧急对话日志</a:t>
+              <a:t>系统界面：紧急状态监测</a:t>
             </a:r>
           </a:p>
         </p:txBody>
@@ -5904,7 +5881,7 @@
               </a:defRPr>
             </a:pPr>
             <a:r>
-              <a:t>机器人创新赛道</a:t>
+              <a:t>创新赛 · 机器人创新赛道</a:t>
             </a:r>
           </a:p>
         </p:txBody>
@@ -5917,7 +5894,7 @@
         </p:nvSpPr>
         <p:spPr>
           <a:xfrm>
-            <a:off x="502920" y="2068830"/>
+            <a:off x="502920" y="566928"/>
             <a:ext cx="8138160" cy="731520"/>
           </a:xfrm>
           <a:prstGeom prst="rect">
@@ -5931,15 +5908,15 @@
           </a:bodyPr>
           <a:lstStyle/>
           <a:p>
-            <a:pPr algn="ctr">
-              <a:defRPr sz="3000" b="1">
+            <a:pPr algn="l">
+              <a:defRPr sz="2400" b="1">
                 <a:solidFill>
                   <a:srgbClr val="1E1E1E"/>
                 </a:solidFill>
               </a:defRPr>
             </a:pPr>
             <a:r>
-              <a:t>第一部分</a:t>
+              <a:t>参赛信息</a:t>
             </a:r>
           </a:p>
         </p:txBody>
@@ -5952,8 +5929,8 @@
         </p:nvSpPr>
         <p:spPr>
           <a:xfrm>
-            <a:off x="502920" y="2617470"/>
-            <a:ext cx="8138160" cy="731520"/>
+            <a:off x="502920" y="1170432"/>
+            <a:ext cx="8138160" cy="3840480"/>
           </a:xfrm>
           <a:prstGeom prst="rect">
             <a:avLst/>
@@ -5966,15 +5943,138 @@
           </a:bodyPr>
           <a:lstStyle/>
           <a:p>
-            <a:pPr algn="ctr">
-              <a:defRPr sz="2000" b="1">
-                <a:solidFill>
-                  <a:srgbClr val="143278"/>
-                </a:solidFill>
-              </a:defRPr>
-            </a:pPr>
-            <a:r>
-              <a:t>项目背景与需求分析</a:t>
+            <a:pPr>
+              <a:spcAft>
+                <a:spcPts val="600"/>
+              </a:spcAft>
+              <a:defRPr sz="1300">
+                <a:solidFill>
+                  <a:srgbClr val="1E1E1E"/>
+                </a:solidFill>
+              </a:defRPr>
+            </a:pPr>
+            <a:r>
+              <a:t>赛项：创新赛 · 机器人创新赛道</a:t>
+            </a:r>
+          </a:p>
+          <a:p>
+            <a:pPr>
+              <a:spcAft>
+                <a:spcPts val="600"/>
+              </a:spcAft>
+              <a:defRPr sz="1300">
+                <a:solidFill>
+                  <a:srgbClr val="1E1E1E"/>
+                </a:solidFill>
+              </a:defRPr>
+            </a:pPr>
+            <a:r>
+              <a:t>团队名称：从容应队</a:t>
+            </a:r>
+          </a:p>
+          <a:p>
+            <a:pPr>
+              <a:spcAft>
+                <a:spcPts val="600"/>
+              </a:spcAft>
+              <a:defRPr sz="1300">
+                <a:solidFill>
+                  <a:srgbClr val="1E1E1E"/>
+                </a:solidFill>
+              </a:defRPr>
+            </a:pPr>
+            <a:r>
+              <a:t>学校：中山大学（广东）</a:t>
+            </a:r>
+          </a:p>
+          <a:p>
+            <a:pPr>
+              <a:spcAft>
+                <a:spcPts val="600"/>
+              </a:spcAft>
+              <a:defRPr sz="1300">
+                <a:solidFill>
+                  <a:srgbClr val="1E1E1E"/>
+                </a:solidFill>
+              </a:defRPr>
+            </a:pPr>
+            <a:r>
+              <a:t>作品名称：基于大语言模型的智能养老陪伴机器人仿真平台</a:t>
+            </a:r>
+          </a:p>
+          <a:p>
+            <a:pPr>
+              <a:spcAft>
+                <a:spcPts val="600"/>
+              </a:spcAft>
+              <a:defRPr sz="1300">
+                <a:solidFill>
+                  <a:srgbClr val="1E1E1E"/>
+                </a:solidFill>
+              </a:defRPr>
+            </a:pPr>
+            <a:r>
+              <a:t>团队编号：CRAIC2026-TEAM-8FJQKLMI</a:t>
+            </a:r>
+          </a:p>
+          <a:p>
+            <a:pPr>
+              <a:spcAft>
+                <a:spcPts val="600"/>
+              </a:spcAft>
+              <a:defRPr sz="1300">
+                <a:solidFill>
+                  <a:srgbClr val="1E1E1E"/>
+                </a:solidFill>
+              </a:defRPr>
+            </a:pPr>
+            <a:r>
+              <a:t>作品编号：CRAIC20264ZEFT1DF</a:t>
+            </a:r>
+          </a:p>
+          <a:p>
+            <a:pPr>
+              <a:spcAft>
+                <a:spcPts val="600"/>
+              </a:spcAft>
+              <a:defRPr sz="1300">
+                <a:solidFill>
+                  <a:srgbClr val="1E1E1E"/>
+                </a:solidFill>
+              </a:defRPr>
+            </a:pPr>
+            <a:r>
+              <a:t>队员：队长 刘小凡，队员 白冉</a:t>
+            </a:r>
+          </a:p>
+          <a:p>
+            <a:pPr>
+              <a:spcAft>
+                <a:spcPts val="600"/>
+              </a:spcAft>
+              <a:defRPr sz="1300">
+                <a:solidFill>
+                  <a:srgbClr val="1E1E1E"/>
+                </a:solidFill>
+              </a:defRPr>
+            </a:pPr>
+            <a:r>
+              <a:t>指导教师：彭键清（智能科学与技术）</a:t>
+            </a:r>
+          </a:p>
+          <a:p>
+            <a:pPr>
+              <a:spcAft>
+                <a:spcPts val="600"/>
+              </a:spcAft>
+              <a:defRPr sz="1300">
+                <a:solidFill>
+                  <a:srgbClr val="1E1E1E"/>
+                </a:solidFill>
+              </a:defRPr>
+            </a:pPr>
+            <a:r>
+              <a:t>代码仓库：https://github.com/FBB123571/ElderCare-Humanoid-Platform</a:t>
             </a:r>
           </a:p>
         </p:txBody>
@@ -6090,7 +6190,7 @@
               </a:defRPr>
             </a:pPr>
             <a:r>
-              <a:t>机器人创新赛道</a:t>
+              <a:t>创新赛 · 机器人创新赛道</a:t>
             </a:r>
           </a:p>
         </p:txBody>
@@ -6103,8 +6203,8 @@
         </p:nvSpPr>
         <p:spPr>
           <a:xfrm>
-            <a:off x="356616" y="1797787"/>
-            <a:ext cx="8430767" cy="1986837"/>
+            <a:off x="1131167" y="914400"/>
+            <a:ext cx="6881664" cy="3753611"/>
           </a:xfrm>
           <a:prstGeom prst="rect">
             <a:avLst/>
@@ -6142,7 +6242,7 @@
       </p:sp>
       <p:pic>
         <p:nvPicPr>
-          <p:cNvPr id="5" name="Picture 4" descr="ppt_robot_commands.png"/>
+          <p:cNvPr id="5" name="Picture 4" descr="ppt_chat_emergency.png"/>
           <p:cNvPicPr>
             <a:picLocks noChangeAspect="1"/>
           </p:cNvPicPr>
@@ -6156,8 +6256,8 @@
         </p:blipFill>
         <p:spPr>
           <a:xfrm>
-            <a:off x="411480" y="1852651"/>
-            <a:ext cx="8321040" cy="1877110"/>
+            <a:off x="1186031" y="969264"/>
+            <a:ext cx="6771936" cy="3643884"/>
           </a:xfrm>
           <a:prstGeom prst="rect">
             <a:avLst/>
@@ -6194,7 +6294,7 @@
               </a:defRPr>
             </a:pPr>
             <a:r>
-              <a:t>告警音 → 语音 → 紧急呼叫（跌倒事件）→ 举手手势，全链路可追溯</a:t>
+              <a:t>演示完成：跌倒紧急流程已成功触发 · 多次紧急安抚语音</a:t>
             </a:r>
           </a:p>
         </p:txBody>
@@ -6229,7 +6329,7 @@
               </a:defRPr>
             </a:pPr>
             <a:r>
-              <a:t>系统界面：机器人指令流</a:t>
+              <a:t>系统界面：跌倒紧急对话日志</a:t>
             </a:r>
           </a:p>
         </p:txBody>
@@ -6345,7 +6445,262 @@
               </a:defRPr>
             </a:pPr>
             <a:r>
-              <a:t>机器人创新赛道</a:t>
+              <a:t>创新赛 · 机器人创新赛道</a:t>
+            </a:r>
+          </a:p>
+        </p:txBody>
+      </p:sp>
+      <p:sp>
+        <p:nvSpPr>
+          <p:cNvPr id="4" name="Rectangle 3"/>
+          <p:cNvSpPr/>
+          <p:nvPr/>
+        </p:nvSpPr>
+        <p:spPr>
+          <a:xfrm>
+            <a:off x="356616" y="1797787"/>
+            <a:ext cx="8430767" cy="1986837"/>
+          </a:xfrm>
+          <a:prstGeom prst="rect">
+            <a:avLst/>
+          </a:prstGeom>
+          <a:solidFill>
+            <a:srgbClr val="EBF2FA"/>
+          </a:solidFill>
+          <a:ln w="9525">
+            <a:solidFill>
+              <a:srgbClr val="B4C3DC"/>
+            </a:solidFill>
+          </a:ln>
+        </p:spPr>
+        <p:style>
+          <a:lnRef idx="1">
+            <a:schemeClr val="accent1"/>
+          </a:lnRef>
+          <a:fillRef idx="3">
+            <a:schemeClr val="accent1"/>
+          </a:fillRef>
+          <a:effectRef idx="2">
+            <a:schemeClr val="accent1"/>
+          </a:effectRef>
+          <a:fontRef idx="minor">
+            <a:schemeClr val="lt1"/>
+          </a:fontRef>
+        </p:style>
+        <p:txBody>
+          <a:bodyPr rtlCol="0" anchor="ctr"/>
+          <a:lstStyle/>
+          <a:p>
+            <a:pPr algn="ctr"/>
+          </a:p>
+        </p:txBody>
+      </p:sp>
+      <p:pic>
+        <p:nvPicPr>
+          <p:cNvPr id="5" name="Picture 4" descr="ppt_robot_commands.png"/>
+          <p:cNvPicPr>
+            <a:picLocks noChangeAspect="1"/>
+          </p:cNvPicPr>
+          <p:nvPr/>
+        </p:nvPicPr>
+        <p:blipFill>
+          <a:blip r:embed="rId2"/>
+          <a:stretch>
+            <a:fillRect/>
+          </a:stretch>
+        </p:blipFill>
+        <p:spPr>
+          <a:xfrm>
+            <a:off x="411480" y="1852651"/>
+            <a:ext cx="8321040" cy="1877110"/>
+          </a:xfrm>
+          <a:prstGeom prst="rect">
+            <a:avLst/>
+          </a:prstGeom>
+        </p:spPr>
+      </p:pic>
+      <p:sp>
+        <p:nvSpPr>
+          <p:cNvPr id="6" name="TextBox 5"/>
+          <p:cNvSpPr txBox="1"/>
+          <p:nvPr/>
+        </p:nvSpPr>
+        <p:spPr>
+          <a:xfrm>
+            <a:off x="411480" y="4638751"/>
+            <a:ext cx="8321040" cy="347472"/>
+          </a:xfrm>
+          <a:prstGeom prst="rect">
+            <a:avLst/>
+          </a:prstGeom>
+          <a:noFill/>
+        </p:spPr>
+        <p:txBody>
+          <a:bodyPr wrap="square" anchor="ctr">
+            <a:spAutoFit/>
+          </a:bodyPr>
+          <a:lstStyle/>
+          <a:p>
+            <a:pPr algn="ctr">
+              <a:defRPr sz="900">
+                <a:solidFill>
+                  <a:srgbClr val="505050"/>
+                </a:solidFill>
+              </a:defRPr>
+            </a:pPr>
+            <a:r>
+              <a:t>告警音 → 语音 → 紧急呼叫（跌倒事件）→ 举手手势，全链路可追溯</a:t>
+            </a:r>
+          </a:p>
+        </p:txBody>
+      </p:sp>
+      <p:sp>
+        <p:nvSpPr>
+          <p:cNvPr id="7" name="TextBox 6"/>
+          <p:cNvSpPr txBox="1"/>
+          <p:nvPr/>
+        </p:nvSpPr>
+        <p:spPr>
+          <a:xfrm>
+            <a:off x="411480" y="530352"/>
+            <a:ext cx="8321040" cy="384048"/>
+          </a:xfrm>
+          <a:prstGeom prst="rect">
+            <a:avLst/>
+          </a:prstGeom>
+          <a:noFill/>
+        </p:spPr>
+        <p:txBody>
+          <a:bodyPr wrap="square">
+            <a:spAutoFit/>
+          </a:bodyPr>
+          <a:lstStyle/>
+          <a:p>
+            <a:pPr algn="ctr">
+              <a:defRPr sz="1900" b="1">
+                <a:solidFill>
+                  <a:srgbClr val="1E1E1E"/>
+                </a:solidFill>
+              </a:defRPr>
+            </a:pPr>
+            <a:r>
+              <a:t>系统界面：机器人指令流</a:t>
+            </a:r>
+          </a:p>
+        </p:txBody>
+      </p:sp>
+    </p:spTree>
+  </p:cSld>
+  <p:clrMapOvr>
+    <a:masterClrMapping/>
+  </p:clrMapOvr>
+</p:sld>
+</file>
+
+<file path=ppt/slides/slide22.xml><?xml version="1.0" encoding="utf-8"?>
+<p:sld xmlns:a="http://schemas.openxmlformats.org/drawingml/2006/main" xmlns:p="http://schemas.openxmlformats.org/presentationml/2006/main" xmlns:r="http://schemas.openxmlformats.org/officeDocument/2006/relationships">
+  <p:cSld>
+    <p:bg>
+      <p:bgPr>
+        <a:solidFill>
+          <a:srgbClr val="FFFFFF"/>
+        </a:solidFill>
+        <a:effectLst/>
+      </p:bgPr>
+    </p:bg>
+    <p:spTree>
+      <p:nvGrpSpPr>
+        <p:cNvPr id="1" name=""/>
+        <p:cNvGrpSpPr/>
+        <p:nvPr/>
+      </p:nvGrpSpPr>
+      <p:grpSpPr/>
+      <p:sp>
+        <p:nvSpPr>
+          <p:cNvPr id="2" name="Rectangle 1"/>
+          <p:cNvSpPr/>
+          <p:nvPr/>
+        </p:nvSpPr>
+        <p:spPr>
+          <a:xfrm>
+            <a:off x="0" y="0"/>
+            <a:ext cx="9144000" cy="475488"/>
+          </a:xfrm>
+          <a:prstGeom prst="rect">
+            <a:avLst/>
+          </a:prstGeom>
+          <a:solidFill>
+            <a:srgbClr val="143278"/>
+          </a:solidFill>
+          <a:ln>
+            <a:noFill/>
+          </a:ln>
+        </p:spPr>
+        <p:style>
+          <a:lnRef idx="1">
+            <a:schemeClr val="accent1"/>
+          </a:lnRef>
+          <a:fillRef idx="3">
+            <a:schemeClr val="accent1"/>
+          </a:fillRef>
+          <a:effectRef idx="2">
+            <a:schemeClr val="accent1"/>
+          </a:effectRef>
+          <a:fontRef idx="minor">
+            <a:schemeClr val="lt1"/>
+          </a:fontRef>
+        </p:style>
+        <p:txBody>
+          <a:bodyPr rtlCol="0" anchor="ctr"/>
+          <a:lstStyle/>
+          <a:p>
+            <a:pPr algn="ctr"/>
+          </a:p>
+        </p:txBody>
+      </p:sp>
+      <p:sp>
+        <p:nvSpPr>
+          <p:cNvPr id="3" name="TextBox 2"/>
+          <p:cNvSpPr txBox="1"/>
+          <p:nvPr/>
+        </p:nvSpPr>
+        <p:spPr>
+          <a:xfrm>
+            <a:off x="137160" y="73152"/>
+            <a:ext cx="8869680" cy="411480"/>
+          </a:xfrm>
+          <a:prstGeom prst="rect">
+            <a:avLst/>
+          </a:prstGeom>
+          <a:noFill/>
+        </p:spPr>
+        <p:txBody>
+          <a:bodyPr wrap="none">
+            <a:spAutoFit/>
+          </a:bodyPr>
+          <a:lstStyle/>
+          <a:p>
+            <a:pPr>
+              <a:defRPr sz="1000" b="1">
+                <a:solidFill>
+                  <a:srgbClr val="FFFFFF"/>
+                </a:solidFill>
+              </a:defRPr>
+            </a:pPr>
+            <a:r>
+              <a:t>第二十八届中国机器人及人工智能大赛</a:t>
+            </a:r>
+          </a:p>
+          <a:p>
+            <a:pPr>
+              <a:defRPr sz="1000">
+                <a:solidFill>
+                  <a:srgbClr val="C8DCFF"/>
+                </a:solidFill>
+              </a:defRPr>
+            </a:pPr>
+            <a:r>
+              <a:t>创新赛 · 机器人创新赛道</a:t>
             </a:r>
           </a:p>
         </p:txBody>
@@ -6745,270 +7100,6 @@
 </p:sld>
 </file>
 
-<file path=ppt/slides/slide22.xml><?xml version="1.0" encoding="utf-8"?>
-<p:sld xmlns:a="http://schemas.openxmlformats.org/drawingml/2006/main" xmlns:p="http://schemas.openxmlformats.org/presentationml/2006/main" xmlns:r="http://schemas.openxmlformats.org/officeDocument/2006/relationships">
-  <p:cSld>
-    <p:bg>
-      <p:bgPr>
-        <a:solidFill>
-          <a:srgbClr val="FFFFFF"/>
-        </a:solidFill>
-        <a:effectLst/>
-      </p:bgPr>
-    </p:bg>
-    <p:spTree>
-      <p:nvGrpSpPr>
-        <p:cNvPr id="1" name=""/>
-        <p:cNvGrpSpPr/>
-        <p:nvPr/>
-      </p:nvGrpSpPr>
-      <p:grpSpPr/>
-      <p:sp>
-        <p:nvSpPr>
-          <p:cNvPr id="2" name="Rectangle 1"/>
-          <p:cNvSpPr/>
-          <p:nvPr/>
-        </p:nvSpPr>
-        <p:spPr>
-          <a:xfrm>
-            <a:off x="0" y="0"/>
-            <a:ext cx="9144000" cy="475488"/>
-          </a:xfrm>
-          <a:prstGeom prst="rect">
-            <a:avLst/>
-          </a:prstGeom>
-          <a:solidFill>
-            <a:srgbClr val="143278"/>
-          </a:solidFill>
-          <a:ln>
-            <a:noFill/>
-          </a:ln>
-        </p:spPr>
-        <p:style>
-          <a:lnRef idx="1">
-            <a:schemeClr val="accent1"/>
-          </a:lnRef>
-          <a:fillRef idx="3">
-            <a:schemeClr val="accent1"/>
-          </a:fillRef>
-          <a:effectRef idx="2">
-            <a:schemeClr val="accent1"/>
-          </a:effectRef>
-          <a:fontRef idx="minor">
-            <a:schemeClr val="lt1"/>
-          </a:fontRef>
-        </p:style>
-        <p:txBody>
-          <a:bodyPr rtlCol="0" anchor="ctr"/>
-          <a:lstStyle/>
-          <a:p>
-            <a:pPr algn="ctr"/>
-          </a:p>
-        </p:txBody>
-      </p:sp>
-      <p:sp>
-        <p:nvSpPr>
-          <p:cNvPr id="3" name="TextBox 2"/>
-          <p:cNvSpPr txBox="1"/>
-          <p:nvPr/>
-        </p:nvSpPr>
-        <p:spPr>
-          <a:xfrm>
-            <a:off x="137160" y="73152"/>
-            <a:ext cx="8869680" cy="411480"/>
-          </a:xfrm>
-          <a:prstGeom prst="rect">
-            <a:avLst/>
-          </a:prstGeom>
-          <a:noFill/>
-        </p:spPr>
-        <p:txBody>
-          <a:bodyPr wrap="none">
-            <a:spAutoFit/>
-          </a:bodyPr>
-          <a:lstStyle/>
-          <a:p>
-            <a:pPr>
-              <a:defRPr sz="1000" b="1">
-                <a:solidFill>
-                  <a:srgbClr val="FFFFFF"/>
-                </a:solidFill>
-              </a:defRPr>
-            </a:pPr>
-            <a:r>
-              <a:t>第二十八届中国机器人及人工智能大赛</a:t>
-            </a:r>
-          </a:p>
-          <a:p>
-            <a:pPr>
-              <a:defRPr sz="1000">
-                <a:solidFill>
-                  <a:srgbClr val="C8DCFF"/>
-                </a:solidFill>
-              </a:defRPr>
-            </a:pPr>
-            <a:r>
-              <a:t>机器人创新赛道</a:t>
-            </a:r>
-          </a:p>
-        </p:txBody>
-      </p:sp>
-      <p:sp>
-        <p:nvSpPr>
-          <p:cNvPr id="4" name="TextBox 3"/>
-          <p:cNvSpPr txBox="1"/>
-          <p:nvPr/>
-        </p:nvSpPr>
-        <p:spPr>
-          <a:xfrm>
-            <a:off x="502920" y="566928"/>
-            <a:ext cx="8138160" cy="731520"/>
-          </a:xfrm>
-          <a:prstGeom prst="rect">
-            <a:avLst/>
-          </a:prstGeom>
-          <a:noFill/>
-        </p:spPr>
-        <p:txBody>
-          <a:bodyPr wrap="square">
-            <a:spAutoFit/>
-          </a:bodyPr>
-          <a:lstStyle/>
-          <a:p>
-            <a:pPr algn="l">
-              <a:defRPr sz="2400" b="1">
-                <a:solidFill>
-                  <a:srgbClr val="1E1E1E"/>
-                </a:solidFill>
-              </a:defRPr>
-            </a:pPr>
-            <a:r>
-              <a:t>开源与知识产权</a:t>
-            </a:r>
-          </a:p>
-        </p:txBody>
-      </p:sp>
-      <p:sp>
-        <p:nvSpPr>
-          <p:cNvPr id="5" name="TextBox 4"/>
-          <p:cNvSpPr txBox="1"/>
-          <p:nvPr/>
-        </p:nvSpPr>
-        <p:spPr>
-          <a:xfrm>
-            <a:off x="502920" y="1325880"/>
-            <a:ext cx="8138160" cy="3840480"/>
-          </a:xfrm>
-          <a:prstGeom prst="rect">
-            <a:avLst/>
-          </a:prstGeom>
-          <a:noFill/>
-        </p:spPr>
-        <p:txBody>
-          <a:bodyPr wrap="square">
-            <a:spAutoFit/>
-          </a:bodyPr>
-          <a:lstStyle/>
-          <a:p>
-            <a:pPr>
-              <a:spcAft>
-                <a:spcPts val="600"/>
-              </a:spcAft>
-              <a:defRPr sz="1400">
-                <a:solidFill>
-                  <a:srgbClr val="1E1E1E"/>
-                </a:solidFill>
-              </a:defRPr>
-            </a:pPr>
-            <a:r>
-              <a:t>GitHub 开源：https://github.com/FBB123571/ElderCare-Humanoid-Platform</a:t>
-            </a:r>
-          </a:p>
-          <a:p>
-            <a:pPr>
-              <a:spcAft>
-                <a:spcPts val="600"/>
-              </a:spcAft>
-              <a:defRPr sz="1400">
-                <a:solidFill>
-                  <a:srgbClr val="1E1E1E"/>
-                </a:solidFill>
-              </a:defRPr>
-            </a:pPr>
-            <a:r>
-              <a:t>答辩演示：http://localhost:8765（现场端口转发）</a:t>
-            </a:r>
-          </a:p>
-          <a:p>
-            <a:pPr>
-              <a:spcAft>
-                <a:spcPts val="600"/>
-              </a:spcAft>
-              <a:defRPr sz="1400">
-                <a:solidFill>
-                  <a:srgbClr val="1E1E1E"/>
-                </a:solidFill>
-              </a:defRPr>
-            </a:pPr>
-            <a:r>
-              <a:t>软件名称建议：CareCompanion 智能养老人形陪伴机器人系统 V1.0</a:t>
-            </a:r>
-          </a:p>
-          <a:p>
-            <a:pPr>
-              <a:spcAft>
-                <a:spcPts val="600"/>
-              </a:spcAft>
-              <a:defRPr sz="1400">
-                <a:solidFill>
-                  <a:srgbClr val="1E1E1E"/>
-                </a:solidFill>
-              </a:defRPr>
-            </a:pPr>
-            <a:r>
-              <a:t>核心代码：care_companion/ · web/ · scripts/ · tests/</a:t>
-            </a:r>
-          </a:p>
-          <a:p>
-            <a:pPr>
-              <a:spcAft>
-                <a:spcPts val="600"/>
-              </a:spcAft>
-              <a:defRPr sz="1400">
-                <a:solidFill>
-                  <a:srgbClr val="1E1E1E"/>
-                </a:solidFill>
-              </a:defRPr>
-            </a:pPr>
-            <a:r>
-              <a:t>文档：技术报告 · 架构说明 · 部署指南 · 竞赛答辩要点</a:t>
-            </a:r>
-          </a:p>
-          <a:p>
-            <a:pPr>
-              <a:spcAft>
-                <a:spcPts val="600"/>
-              </a:spcAft>
-              <a:defRPr sz="1400">
-                <a:solidFill>
-                  <a:srgbClr val="1E1E1E"/>
-                </a:solidFill>
-              </a:defRPr>
-            </a:pPr>
-            <a:r>
-              <a:t>（请填写）软著登记号 / 团队成员 / 指导教师</a:t>
-            </a:r>
-          </a:p>
-        </p:txBody>
-      </p:sp>
-    </p:spTree>
-  </p:cSld>
-  <p:clrMapOvr>
-    <a:masterClrMapping/>
-  </p:clrMapOvr>
-</p:sld>
-</file>
-
 <file path=ppt/slides/slide23.xml><?xml version="1.0" encoding="utf-8"?>
 <p:sld xmlns:a="http://schemas.openxmlformats.org/drawingml/2006/main" xmlns:p="http://schemas.openxmlformats.org/presentationml/2006/main" xmlns:r="http://schemas.openxmlformats.org/officeDocument/2006/relationships">
   <p:cSld>
@@ -7112,7 +7203,7 @@
               </a:defRPr>
             </a:pPr>
             <a:r>
-              <a:t>机器人创新赛道</a:t>
+              <a:t>创新赛 · 机器人创新赛道</a:t>
             </a:r>
           </a:p>
         </p:txBody>
@@ -7125,7 +7216,7 @@
         </p:nvSpPr>
         <p:spPr>
           <a:xfrm>
-            <a:off x="502920" y="2068830"/>
+            <a:off x="502920" y="566928"/>
             <a:ext cx="8138160" cy="731520"/>
           </a:xfrm>
           <a:prstGeom prst="rect">
@@ -7139,15 +7230,15 @@
           </a:bodyPr>
           <a:lstStyle/>
           <a:p>
-            <a:pPr algn="ctr">
-              <a:defRPr sz="3000" b="1">
+            <a:pPr algn="l">
+              <a:defRPr sz="2400" b="1">
                 <a:solidFill>
                   <a:srgbClr val="1E1E1E"/>
                 </a:solidFill>
               </a:defRPr>
             </a:pPr>
             <a:r>
-              <a:t>第四部分</a:t>
+              <a:t>开源与知识产权</a:t>
             </a:r>
           </a:p>
         </p:txBody>
@@ -7160,8 +7251,8 @@
         </p:nvSpPr>
         <p:spPr>
           <a:xfrm>
-            <a:off x="502920" y="2617470"/>
-            <a:ext cx="8138160" cy="731520"/>
+            <a:off x="502920" y="1170432"/>
+            <a:ext cx="8138160" cy="3840480"/>
           </a:xfrm>
           <a:prstGeom prst="rect">
             <a:avLst/>
@@ -7174,15 +7265,93 @@
           </a:bodyPr>
           <a:lstStyle/>
           <a:p>
-            <a:pPr algn="ctr">
-              <a:defRPr sz="2000" b="1">
-                <a:solidFill>
-                  <a:srgbClr val="143278"/>
-                </a:solidFill>
-              </a:defRPr>
-            </a:pPr>
-            <a:r>
-              <a:t>创新维度与未来展望</a:t>
+            <a:pPr>
+              <a:spcAft>
+                <a:spcPts val="600"/>
+              </a:spcAft>
+              <a:defRPr sz="1300">
+                <a:solidFill>
+                  <a:srgbClr val="1E1E1E"/>
+                </a:solidFill>
+              </a:defRPr>
+            </a:pPr>
+            <a:r>
+              <a:t>开源地址：https://github.com/FBB123571/ElderCare-Humanoid-Platform</a:t>
+            </a:r>
+          </a:p>
+          <a:p>
+            <a:pPr>
+              <a:spcAft>
+                <a:spcPts val="600"/>
+              </a:spcAft>
+              <a:defRPr sz="1300">
+                <a:solidFill>
+                  <a:srgbClr val="1E1E1E"/>
+                </a:solidFill>
+              </a:defRPr>
+            </a:pPr>
+            <a:r>
+              <a:t>参赛团队：从容应队（中山大学）</a:t>
+            </a:r>
+          </a:p>
+          <a:p>
+            <a:pPr>
+              <a:spcAft>
+                <a:spcPts val="600"/>
+              </a:spcAft>
+              <a:defRPr sz="1300">
+                <a:solidFill>
+                  <a:srgbClr val="1E1E1E"/>
+                </a:solidFill>
+              </a:defRPr>
+            </a:pPr>
+            <a:r>
+              <a:t>现场演示：http://localhost:8765（bash scripts/run_web.sh）</a:t>
+            </a:r>
+          </a:p>
+          <a:p>
+            <a:pPr>
+              <a:spcAft>
+                <a:spcPts val="600"/>
+              </a:spcAft>
+              <a:defRPr sz="1300">
+                <a:solidFill>
+                  <a:srgbClr val="1E1E1E"/>
+                </a:solidFill>
+              </a:defRPr>
+            </a:pPr>
+            <a:r>
+              <a:t>演示录像：docs/assets/demo_carecompanion.mp4</a:t>
+            </a:r>
+          </a:p>
+          <a:p>
+            <a:pPr>
+              <a:spcAft>
+                <a:spcPts val="600"/>
+              </a:spcAft>
+              <a:defRPr sz="1300">
+                <a:solidFill>
+                  <a:srgbClr val="1E1E1E"/>
+                </a:solidFill>
+              </a:defRPr>
+            </a:pPr>
+            <a:r>
+              <a:t>软件名称：CareCompanion 智能养老人形陪伴机器人系统 V1.0</a:t>
+            </a:r>
+          </a:p>
+          <a:p>
+            <a:pPr>
+              <a:spcAft>
+                <a:spcPts val="600"/>
+              </a:spcAft>
+              <a:defRPr sz="1300">
+                <a:solidFill>
+                  <a:srgbClr val="1E1E1E"/>
+                </a:solidFill>
+              </a:defRPr>
+            </a:pPr>
+            <a:r>
+              <a:t>软著登记：（申请中 / 按实际填写）</a:t>
             </a:r>
           </a:p>
         </p:txBody>
@@ -7298,7 +7467,193 @@
               </a:defRPr>
             </a:pPr>
             <a:r>
-              <a:t>机器人创新赛道</a:t>
+              <a:t>创新赛 · 机器人创新赛道</a:t>
+            </a:r>
+          </a:p>
+        </p:txBody>
+      </p:sp>
+      <p:sp>
+        <p:nvSpPr>
+          <p:cNvPr id="4" name="TextBox 3"/>
+          <p:cNvSpPr txBox="1"/>
+          <p:nvPr/>
+        </p:nvSpPr>
+        <p:spPr>
+          <a:xfrm>
+            <a:off x="502920" y="2068830"/>
+            <a:ext cx="8138160" cy="731520"/>
+          </a:xfrm>
+          <a:prstGeom prst="rect">
+            <a:avLst/>
+          </a:prstGeom>
+          <a:noFill/>
+        </p:spPr>
+        <p:txBody>
+          <a:bodyPr wrap="square">
+            <a:spAutoFit/>
+          </a:bodyPr>
+          <a:lstStyle/>
+          <a:p>
+            <a:pPr algn="ctr">
+              <a:defRPr sz="3000" b="1">
+                <a:solidFill>
+                  <a:srgbClr val="1E1E1E"/>
+                </a:solidFill>
+              </a:defRPr>
+            </a:pPr>
+            <a:r>
+              <a:t>第四部分</a:t>
+            </a:r>
+          </a:p>
+        </p:txBody>
+      </p:sp>
+      <p:sp>
+        <p:nvSpPr>
+          <p:cNvPr id="5" name="TextBox 4"/>
+          <p:cNvSpPr txBox="1"/>
+          <p:nvPr/>
+        </p:nvSpPr>
+        <p:spPr>
+          <a:xfrm>
+            <a:off x="502920" y="2617470"/>
+            <a:ext cx="8138160" cy="731520"/>
+          </a:xfrm>
+          <a:prstGeom prst="rect">
+            <a:avLst/>
+          </a:prstGeom>
+          <a:noFill/>
+        </p:spPr>
+        <p:txBody>
+          <a:bodyPr wrap="square">
+            <a:spAutoFit/>
+          </a:bodyPr>
+          <a:lstStyle/>
+          <a:p>
+            <a:pPr algn="ctr">
+              <a:defRPr sz="2000" b="1">
+                <a:solidFill>
+                  <a:srgbClr val="143278"/>
+                </a:solidFill>
+              </a:defRPr>
+            </a:pPr>
+            <a:r>
+              <a:t>创新维度与未来展望</a:t>
+            </a:r>
+          </a:p>
+        </p:txBody>
+      </p:sp>
+    </p:spTree>
+  </p:cSld>
+  <p:clrMapOvr>
+    <a:masterClrMapping/>
+  </p:clrMapOvr>
+</p:sld>
+</file>
+
+<file path=ppt/slides/slide25.xml><?xml version="1.0" encoding="utf-8"?>
+<p:sld xmlns:a="http://schemas.openxmlformats.org/drawingml/2006/main" xmlns:p="http://schemas.openxmlformats.org/presentationml/2006/main" xmlns:r="http://schemas.openxmlformats.org/officeDocument/2006/relationships">
+  <p:cSld>
+    <p:bg>
+      <p:bgPr>
+        <a:solidFill>
+          <a:srgbClr val="FFFFFF"/>
+        </a:solidFill>
+        <a:effectLst/>
+      </p:bgPr>
+    </p:bg>
+    <p:spTree>
+      <p:nvGrpSpPr>
+        <p:cNvPr id="1" name=""/>
+        <p:cNvGrpSpPr/>
+        <p:nvPr/>
+      </p:nvGrpSpPr>
+      <p:grpSpPr/>
+      <p:sp>
+        <p:nvSpPr>
+          <p:cNvPr id="2" name="Rectangle 1"/>
+          <p:cNvSpPr/>
+          <p:nvPr/>
+        </p:nvSpPr>
+        <p:spPr>
+          <a:xfrm>
+            <a:off x="0" y="0"/>
+            <a:ext cx="9144000" cy="475488"/>
+          </a:xfrm>
+          <a:prstGeom prst="rect">
+            <a:avLst/>
+          </a:prstGeom>
+          <a:solidFill>
+            <a:srgbClr val="143278"/>
+          </a:solidFill>
+          <a:ln>
+            <a:noFill/>
+          </a:ln>
+        </p:spPr>
+        <p:style>
+          <a:lnRef idx="1">
+            <a:schemeClr val="accent1"/>
+          </a:lnRef>
+          <a:fillRef idx="3">
+            <a:schemeClr val="accent1"/>
+          </a:fillRef>
+          <a:effectRef idx="2">
+            <a:schemeClr val="accent1"/>
+          </a:effectRef>
+          <a:fontRef idx="minor">
+            <a:schemeClr val="lt1"/>
+          </a:fontRef>
+        </p:style>
+        <p:txBody>
+          <a:bodyPr rtlCol="0" anchor="ctr"/>
+          <a:lstStyle/>
+          <a:p>
+            <a:pPr algn="ctr"/>
+          </a:p>
+        </p:txBody>
+      </p:sp>
+      <p:sp>
+        <p:nvSpPr>
+          <p:cNvPr id="3" name="TextBox 2"/>
+          <p:cNvSpPr txBox="1"/>
+          <p:nvPr/>
+        </p:nvSpPr>
+        <p:spPr>
+          <a:xfrm>
+            <a:off x="137160" y="73152"/>
+            <a:ext cx="8869680" cy="411480"/>
+          </a:xfrm>
+          <a:prstGeom prst="rect">
+            <a:avLst/>
+          </a:prstGeom>
+          <a:noFill/>
+        </p:spPr>
+        <p:txBody>
+          <a:bodyPr wrap="none">
+            <a:spAutoFit/>
+          </a:bodyPr>
+          <a:lstStyle/>
+          <a:p>
+            <a:pPr>
+              <a:defRPr sz="1000" b="1">
+                <a:solidFill>
+                  <a:srgbClr val="FFFFFF"/>
+                </a:solidFill>
+              </a:defRPr>
+            </a:pPr>
+            <a:r>
+              <a:t>第二十八届中国机器人及人工智能大赛</a:t>
+            </a:r>
+          </a:p>
+          <a:p>
+            <a:pPr>
+              <a:defRPr sz="1000">
+                <a:solidFill>
+                  <a:srgbClr val="C8DCFF"/>
+                </a:solidFill>
+              </a:defRPr>
+            </a:pPr>
+            <a:r>
+              <a:t>创新赛 · 机器人创新赛道</a:t>
             </a:r>
           </a:p>
         </p:txBody>
@@ -7620,255 +7975,6 @@
 </p:sld>
 </file>
 
-<file path=ppt/slides/slide25.xml><?xml version="1.0" encoding="utf-8"?>
-<p:sld xmlns:a="http://schemas.openxmlformats.org/drawingml/2006/main" xmlns:p="http://schemas.openxmlformats.org/presentationml/2006/main" xmlns:r="http://schemas.openxmlformats.org/officeDocument/2006/relationships">
-  <p:cSld>
-    <p:bg>
-      <p:bgPr>
-        <a:solidFill>
-          <a:srgbClr val="FFFFFF"/>
-        </a:solidFill>
-        <a:effectLst/>
-      </p:bgPr>
-    </p:bg>
-    <p:spTree>
-      <p:nvGrpSpPr>
-        <p:cNvPr id="1" name=""/>
-        <p:cNvGrpSpPr/>
-        <p:nvPr/>
-      </p:nvGrpSpPr>
-      <p:grpSpPr/>
-      <p:sp>
-        <p:nvSpPr>
-          <p:cNvPr id="2" name="Rectangle 1"/>
-          <p:cNvSpPr/>
-          <p:nvPr/>
-        </p:nvSpPr>
-        <p:spPr>
-          <a:xfrm>
-            <a:off x="0" y="0"/>
-            <a:ext cx="9144000" cy="475488"/>
-          </a:xfrm>
-          <a:prstGeom prst="rect">
-            <a:avLst/>
-          </a:prstGeom>
-          <a:solidFill>
-            <a:srgbClr val="143278"/>
-          </a:solidFill>
-          <a:ln>
-            <a:noFill/>
-          </a:ln>
-        </p:spPr>
-        <p:style>
-          <a:lnRef idx="1">
-            <a:schemeClr val="accent1"/>
-          </a:lnRef>
-          <a:fillRef idx="3">
-            <a:schemeClr val="accent1"/>
-          </a:fillRef>
-          <a:effectRef idx="2">
-            <a:schemeClr val="accent1"/>
-          </a:effectRef>
-          <a:fontRef idx="minor">
-            <a:schemeClr val="lt1"/>
-          </a:fontRef>
-        </p:style>
-        <p:txBody>
-          <a:bodyPr rtlCol="0" anchor="ctr"/>
-          <a:lstStyle/>
-          <a:p>
-            <a:pPr algn="ctr"/>
-          </a:p>
-        </p:txBody>
-      </p:sp>
-      <p:sp>
-        <p:nvSpPr>
-          <p:cNvPr id="3" name="TextBox 2"/>
-          <p:cNvSpPr txBox="1"/>
-          <p:nvPr/>
-        </p:nvSpPr>
-        <p:spPr>
-          <a:xfrm>
-            <a:off x="137160" y="73152"/>
-            <a:ext cx="8869680" cy="411480"/>
-          </a:xfrm>
-          <a:prstGeom prst="rect">
-            <a:avLst/>
-          </a:prstGeom>
-          <a:noFill/>
-        </p:spPr>
-        <p:txBody>
-          <a:bodyPr wrap="none">
-            <a:spAutoFit/>
-          </a:bodyPr>
-          <a:lstStyle/>
-          <a:p>
-            <a:pPr>
-              <a:defRPr sz="1000" b="1">
-                <a:solidFill>
-                  <a:srgbClr val="FFFFFF"/>
-                </a:solidFill>
-              </a:defRPr>
-            </a:pPr>
-            <a:r>
-              <a:t>第二十八届中国机器人及人工智能大赛</a:t>
-            </a:r>
-          </a:p>
-          <a:p>
-            <a:pPr>
-              <a:defRPr sz="1000">
-                <a:solidFill>
-                  <a:srgbClr val="C8DCFF"/>
-                </a:solidFill>
-              </a:defRPr>
-            </a:pPr>
-            <a:r>
-              <a:t>机器人创新赛道</a:t>
-            </a:r>
-          </a:p>
-        </p:txBody>
-      </p:sp>
-      <p:sp>
-        <p:nvSpPr>
-          <p:cNvPr id="4" name="TextBox 3"/>
-          <p:cNvSpPr txBox="1"/>
-          <p:nvPr/>
-        </p:nvSpPr>
-        <p:spPr>
-          <a:xfrm>
-            <a:off x="502920" y="566928"/>
-            <a:ext cx="8138160" cy="731520"/>
-          </a:xfrm>
-          <a:prstGeom prst="rect">
-            <a:avLst/>
-          </a:prstGeom>
-          <a:noFill/>
-        </p:spPr>
-        <p:txBody>
-          <a:bodyPr wrap="square">
-            <a:spAutoFit/>
-          </a:bodyPr>
-          <a:lstStyle/>
-          <a:p>
-            <a:pPr algn="l">
-              <a:defRPr sz="2400" b="1">
-                <a:solidFill>
-                  <a:srgbClr val="1E1E1E"/>
-                </a:solidFill>
-              </a:defRPr>
-            </a:pPr>
-            <a:r>
-              <a:t>未来工作</a:t>
-            </a:r>
-          </a:p>
-        </p:txBody>
-      </p:sp>
-      <p:sp>
-        <p:nvSpPr>
-          <p:cNvPr id="5" name="TextBox 4"/>
-          <p:cNvSpPr txBox="1"/>
-          <p:nvPr/>
-        </p:nvSpPr>
-        <p:spPr>
-          <a:xfrm>
-            <a:off x="502920" y="1325880"/>
-            <a:ext cx="8138160" cy="3840480"/>
-          </a:xfrm>
-          <a:prstGeom prst="rect">
-            <a:avLst/>
-          </a:prstGeom>
-          <a:noFill/>
-        </p:spPr>
-        <p:txBody>
-          <a:bodyPr wrap="square">
-            <a:spAutoFit/>
-          </a:bodyPr>
-          <a:lstStyle/>
-          <a:p>
-            <a:pPr>
-              <a:spcAft>
-                <a:spcPts val="600"/>
-              </a:spcAft>
-              <a:defRPr sz="1400">
-                <a:solidFill>
-                  <a:srgbClr val="1E1E1E"/>
-                </a:solidFill>
-              </a:defRPr>
-            </a:pPr>
-            <a:r>
-              <a:t>p 对接 Unitree 等人形机器人，完成 speak/gesture/approach 真机视频</a:t>
-            </a:r>
-          </a:p>
-          <a:p>
-            <a:pPr>
-              <a:spcAft>
-                <a:spcPts val="600"/>
-              </a:spcAft>
-              <a:defRPr sz="1400">
-                <a:solidFill>
-                  <a:srgbClr val="1E1E1E"/>
-                </a:solidFill>
-              </a:defRPr>
-            </a:pPr>
-            <a:r>
-              <a:t>p 引入 UR Fall 等公开数据集，开展泛化评测与误报分析</a:t>
-            </a:r>
-          </a:p>
-          <a:p>
-            <a:pPr>
-              <a:spcAft>
-                <a:spcPts val="600"/>
-              </a:spcAft>
-              <a:defRPr sz="1400">
-                <a:solidFill>
-                  <a:srgbClr val="1E1E1E"/>
-                </a:solidFill>
-              </a:defRPr>
-            </a:pPr>
-            <a:r>
-              <a:t>p 多老人房间场景、遮挡与光照鲁棒性优化</a:t>
-            </a:r>
-          </a:p>
-          <a:p>
-            <a:pPr>
-              <a:spcAft>
-                <a:spcPts val="600"/>
-              </a:spcAft>
-              <a:defRPr sz="1400">
-                <a:solidFill>
-                  <a:srgbClr val="1E1E1E"/>
-                </a:solidFill>
-              </a:defRPr>
-            </a:pPr>
-            <a:r>
-              <a:t>p 结合社区/养老院调研，完善产品化与成本评估</a:t>
-            </a:r>
-          </a:p>
-          <a:p>
-            <a:pPr>
-              <a:spcAft>
-                <a:spcPts val="600"/>
-              </a:spcAft>
-              <a:defRPr sz="1400">
-                <a:solidFill>
-                  <a:srgbClr val="1E1E1E"/>
-                </a:solidFill>
-              </a:defRPr>
-            </a:pPr>
-            <a:r>
-              <a:t>p 申请软件著作权 V1.0，探索专利（跌倒融合决策方法）</a:t>
-            </a:r>
-          </a:p>
-        </p:txBody>
-      </p:sp>
-    </p:spTree>
-  </p:cSld>
-  <p:clrMapOvr>
-    <a:masterClrMapping/>
-  </p:clrMapOvr>
-</p:sld>
-</file>
-
 <file path=ppt/slides/slide26.xml><?xml version="1.0" encoding="utf-8"?>
 <p:sld xmlns:a="http://schemas.openxmlformats.org/drawingml/2006/main" xmlns:p="http://schemas.openxmlformats.org/presentationml/2006/main" xmlns:r="http://schemas.openxmlformats.org/officeDocument/2006/relationships">
   <p:cSld>
@@ -7972,7 +8078,7 @@
               </a:defRPr>
             </a:pPr>
             <a:r>
-              <a:t>机器人创新赛道</a:t>
+              <a:t>创新赛 · 机器人创新赛道</a:t>
             </a:r>
           </a:p>
         </p:txBody>
@@ -8007,7 +8113,7 @@
               </a:defRPr>
             </a:pPr>
             <a:r>
-              <a:t>参考文献</a:t>
+              <a:t>未来工作</a:t>
             </a:r>
           </a:p>
         </p:txBody>
@@ -8020,7 +8126,7 @@
         </p:nvSpPr>
         <p:spPr>
           <a:xfrm>
-            <a:off x="502920" y="1234440"/>
+            <a:off x="502920" y="1325880"/>
             <a:ext cx="8138160" cy="3840480"/>
           </a:xfrm>
           <a:prstGeom prst="rect">
@@ -8038,14 +8144,14 @@
               <a:spcAft>
                 <a:spcPts val="600"/>
               </a:spcAft>
-              <a:defRPr sz="1200">
+              <a:defRPr sz="1400">
                 <a:solidFill>
                   <a:srgbClr val="1E1E1E"/>
                 </a:solidFill>
               </a:defRPr>
             </a:pPr>
             <a:r>
-              <a:t>[1] Google MediaPipe Pose: Real-time pose estimation.</a:t>
+              <a:t>p 对接 Unitree 等人形机器人，完成 speak/gesture/approach 真机视频</a:t>
             </a:r>
           </a:p>
           <a:p>
@@ -8053,14 +8159,14 @@
               <a:spcAft>
                 <a:spcPts val="600"/>
               </a:spcAft>
-              <a:defRPr sz="1200">
+              <a:defRPr sz="1400">
                 <a:solidFill>
                   <a:srgbClr val="1E1E1E"/>
                 </a:solidFill>
               </a:defRPr>
             </a:pPr>
             <a:r>
-              <a:t>[2] Unitree Robotics SDK / ROS2 documentation.</a:t>
+              <a:t>p 引入 UR Fall 等公开数据集，开展泛化评测与误报分析</a:t>
             </a:r>
           </a:p>
           <a:p>
@@ -8068,14 +8174,14 @@
               <a:spcAft>
                 <a:spcPts val="600"/>
               </a:spcAft>
-              <a:defRPr sz="1200">
+              <a:defRPr sz="1400">
                 <a:solidFill>
                   <a:srgbClr val="1E1E1E"/>
                 </a:solidFill>
               </a:defRPr>
             </a:pPr>
             <a:r>
-              <a:t>[3] 国务院：《「十四五」国家老龄事业发展和养老服务体系规划》.</a:t>
+              <a:t>p 多老人房间场景、遮挡与光照鲁棒性优化</a:t>
             </a:r>
           </a:p>
           <a:p>
@@ -8083,14 +8189,14 @@
               <a:spcAft>
                 <a:spcPts val="600"/>
               </a:spcAft>
-              <a:defRPr sz="1200">
+              <a:defRPr sz="1400">
                 <a:solidFill>
                   <a:srgbClr val="1E1E1E"/>
                 </a:solidFill>
               </a:defRPr>
             </a:pPr>
             <a:r>
-              <a:t>[4] CareCompanion 项目文档：docs/TECHNICAL_REPORT.md</a:t>
+              <a:t>p 结合社区/养老院调研，完善产品化与成本评估</a:t>
             </a:r>
           </a:p>
           <a:p>
@@ -8098,14 +8204,14 @@
               <a:spcAft>
                 <a:spcPts val="600"/>
               </a:spcAft>
-              <a:defRPr sz="1200">
+              <a:defRPr sz="1400">
                 <a:solidFill>
                   <a:srgbClr val="1E1E1E"/>
                 </a:solidFill>
               </a:defRPr>
             </a:pPr>
             <a:r>
-              <a:t>[5] 仓库：github.com/FBB123571/ElderCare-Humanoid-Platform</a:t>
+              <a:t>p 申请软件著作权 V1.0，探索专利（跌倒融合决策方法）</a:t>
             </a:r>
           </a:p>
         </p:txBody>
@@ -8221,7 +8327,7 @@
               </a:defRPr>
             </a:pPr>
             <a:r>
-              <a:t>机器人创新赛道</a:t>
+              <a:t>创新赛 · 机器人创新赛道</a:t>
             </a:r>
           </a:p>
         </p:txBody>
@@ -8234,8 +8340,210 @@
         </p:nvSpPr>
         <p:spPr>
           <a:xfrm>
-            <a:off x="502920" y="2068830"/>
-            <a:ext cx="8138160" cy="914400"/>
+            <a:off x="502920" y="566928"/>
+            <a:ext cx="8138160" cy="731520"/>
+          </a:xfrm>
+          <a:prstGeom prst="rect">
+            <a:avLst/>
+          </a:prstGeom>
+          <a:noFill/>
+        </p:spPr>
+        <p:txBody>
+          <a:bodyPr wrap="square">
+            <a:spAutoFit/>
+          </a:bodyPr>
+          <a:lstStyle/>
+          <a:p>
+            <a:pPr algn="l">
+              <a:defRPr sz="2400" b="1">
+                <a:solidFill>
+                  <a:srgbClr val="1E1E1E"/>
+                </a:solidFill>
+              </a:defRPr>
+            </a:pPr>
+            <a:r>
+              <a:t>参考文献</a:t>
+            </a:r>
+          </a:p>
+        </p:txBody>
+      </p:sp>
+      <p:sp>
+        <p:nvSpPr>
+          <p:cNvPr id="5" name="TextBox 4"/>
+          <p:cNvSpPr txBox="1"/>
+          <p:nvPr/>
+        </p:nvSpPr>
+        <p:spPr>
+          <a:xfrm>
+            <a:off x="502920" y="1234440"/>
+            <a:ext cx="8138160" cy="3840480"/>
+          </a:xfrm>
+          <a:prstGeom prst="rect">
+            <a:avLst/>
+          </a:prstGeom>
+          <a:noFill/>
+        </p:spPr>
+        <p:txBody>
+          <a:bodyPr wrap="square">
+            <a:spAutoFit/>
+          </a:bodyPr>
+          <a:lstStyle/>
+          <a:p>
+            <a:pPr>
+              <a:spcAft>
+                <a:spcPts val="600"/>
+              </a:spcAft>
+              <a:defRPr sz="1200">
+                <a:solidFill>
+                  <a:srgbClr val="1E1E1E"/>
+                </a:solidFill>
+              </a:defRPr>
+            </a:pPr>
+            <a:r>
+              <a:t>[1] Google MediaPipe Pose: Real-time pose estimation.</a:t>
+            </a:r>
+          </a:p>
+          <a:p>
+            <a:pPr>
+              <a:spcAft>
+                <a:spcPts val="600"/>
+              </a:spcAft>
+              <a:defRPr sz="1200">
+                <a:solidFill>
+                  <a:srgbClr val="1E1E1E"/>
+                </a:solidFill>
+              </a:defRPr>
+            </a:pPr>
+            <a:r>
+              <a:t>[2] Unitree Robotics SDK / ROS2 documentation.</a:t>
+            </a:r>
+          </a:p>
+          <a:p>
+            <a:pPr>
+              <a:spcAft>
+                <a:spcPts val="600"/>
+              </a:spcAft>
+              <a:defRPr sz="1200">
+                <a:solidFill>
+                  <a:srgbClr val="1E1E1E"/>
+                </a:solidFill>
+              </a:defRPr>
+            </a:pPr>
+            <a:r>
+              <a:t>[3] 国务院：《「十四五」国家老龄事业发展和养老服务体系规划》.</a:t>
+            </a:r>
+          </a:p>
+          <a:p>
+            <a:pPr>
+              <a:spcAft>
+                <a:spcPts val="600"/>
+              </a:spcAft>
+              <a:defRPr sz="1200">
+                <a:solidFill>
+                  <a:srgbClr val="1E1E1E"/>
+                </a:solidFill>
+              </a:defRPr>
+            </a:pPr>
+            <a:r>
+              <a:t>[4] CareCompanion 项目文档：docs/TECHNICAL_REPORT.md</a:t>
+            </a:r>
+          </a:p>
+          <a:p>
+            <a:pPr>
+              <a:spcAft>
+                <a:spcPts val="600"/>
+              </a:spcAft>
+              <a:defRPr sz="1200">
+                <a:solidFill>
+                  <a:srgbClr val="1E1E1E"/>
+                </a:solidFill>
+              </a:defRPr>
+            </a:pPr>
+            <a:r>
+              <a:t>[5] 仓库：github.com/FBB123571/ElderCare-Humanoid-Platform</a:t>
+            </a:r>
+          </a:p>
+        </p:txBody>
+      </p:sp>
+    </p:spTree>
+  </p:cSld>
+  <p:clrMapOvr>
+    <a:masterClrMapping/>
+  </p:clrMapOvr>
+</p:sld>
+</file>
+
+<file path=ppt/slides/slide28.xml><?xml version="1.0" encoding="utf-8"?>
+<p:sld xmlns:a="http://schemas.openxmlformats.org/drawingml/2006/main" xmlns:p="http://schemas.openxmlformats.org/presentationml/2006/main" xmlns:r="http://schemas.openxmlformats.org/officeDocument/2006/relationships">
+  <p:cSld>
+    <p:bg>
+      <p:bgPr>
+        <a:solidFill>
+          <a:srgbClr val="FFFFFF"/>
+        </a:solidFill>
+        <a:effectLst/>
+      </p:bgPr>
+    </p:bg>
+    <p:spTree>
+      <p:nvGrpSpPr>
+        <p:cNvPr id="1" name=""/>
+        <p:cNvGrpSpPr/>
+        <p:nvPr/>
+      </p:nvGrpSpPr>
+      <p:grpSpPr/>
+      <p:sp>
+        <p:nvSpPr>
+          <p:cNvPr id="2" name="Rectangle 1"/>
+          <p:cNvSpPr/>
+          <p:nvPr/>
+        </p:nvSpPr>
+        <p:spPr>
+          <a:xfrm>
+            <a:off x="0" y="0"/>
+            <a:ext cx="9144000" cy="475488"/>
+          </a:xfrm>
+          <a:prstGeom prst="rect">
+            <a:avLst/>
+          </a:prstGeom>
+          <a:solidFill>
+            <a:srgbClr val="143278"/>
+          </a:solidFill>
+          <a:ln>
+            <a:noFill/>
+          </a:ln>
+        </p:spPr>
+        <p:style>
+          <a:lnRef idx="1">
+            <a:schemeClr val="accent1"/>
+          </a:lnRef>
+          <a:fillRef idx="3">
+            <a:schemeClr val="accent1"/>
+          </a:fillRef>
+          <a:effectRef idx="2">
+            <a:schemeClr val="accent1"/>
+          </a:effectRef>
+          <a:fontRef idx="minor">
+            <a:schemeClr val="lt1"/>
+          </a:fontRef>
+        </p:style>
+        <p:txBody>
+          <a:bodyPr rtlCol="0" anchor="ctr"/>
+          <a:lstStyle/>
+          <a:p>
+            <a:pPr algn="ctr"/>
+          </a:p>
+        </p:txBody>
+      </p:sp>
+      <p:sp>
+        <p:nvSpPr>
+          <p:cNvPr id="3" name="TextBox 2"/>
+          <p:cNvSpPr txBox="1"/>
+          <p:nvPr/>
+        </p:nvSpPr>
+        <p:spPr>
+          <a:xfrm>
+            <a:off x="137160" y="73152"/>
+            <a:ext cx="8869680" cy="411480"/>
           </a:xfrm>
           <a:prstGeom prst="rect">
             <a:avLst/>
@@ -8248,29 +8556,220 @@
           </a:bodyPr>
           <a:lstStyle/>
           <a:p>
+            <a:pPr>
+              <a:defRPr sz="1000" b="1">
+                <a:solidFill>
+                  <a:srgbClr val="FFFFFF"/>
+                </a:solidFill>
+              </a:defRPr>
+            </a:pPr>
+            <a:r>
+              <a:t>第二十八届中国机器人及人工智能大赛</a:t>
+            </a:r>
+          </a:p>
+          <a:p>
+            <a:pPr>
+              <a:defRPr sz="1000">
+                <a:solidFill>
+                  <a:srgbClr val="C8DCFF"/>
+                </a:solidFill>
+              </a:defRPr>
+            </a:pPr>
+            <a:r>
+              <a:t>创新赛 · 机器人创新赛道</a:t>
+            </a:r>
+          </a:p>
+        </p:txBody>
+      </p:sp>
+      <p:sp>
+        <p:nvSpPr>
+          <p:cNvPr id="4" name="TextBox 3"/>
+          <p:cNvSpPr txBox="1"/>
+          <p:nvPr/>
+        </p:nvSpPr>
+        <p:spPr>
+          <a:xfrm>
+            <a:off x="502920" y="566928"/>
+            <a:ext cx="8138160" cy="731520"/>
+          </a:xfrm>
+          <a:prstGeom prst="rect">
+            <a:avLst/>
+          </a:prstGeom>
+          <a:noFill/>
+        </p:spPr>
+        <p:txBody>
+          <a:bodyPr wrap="square">
+            <a:spAutoFit/>
+          </a:bodyPr>
+          <a:lstStyle/>
+          <a:p>
+            <a:pPr algn="l">
+              <a:defRPr sz="2400" b="1">
+                <a:solidFill>
+                  <a:srgbClr val="1E1E1E"/>
+                </a:solidFill>
+              </a:defRPr>
+            </a:pPr>
+            <a:r>
+              <a:t>扫码获取代码与演示视频</a:t>
+            </a:r>
+          </a:p>
+        </p:txBody>
+      </p:sp>
+      <p:pic>
+        <p:nvPicPr>
+          <p:cNvPr id="5" name="Picture 4" descr="ppt_demo_qr.png"/>
+          <p:cNvPicPr>
+            <a:picLocks noChangeAspect="1"/>
+          </p:cNvPicPr>
+          <p:nvPr/>
+        </p:nvPicPr>
+        <p:blipFill>
+          <a:blip r:embed="rId2"/>
+          <a:stretch>
+            <a:fillRect/>
+          </a:stretch>
+        </p:blipFill>
+        <p:spPr>
+          <a:xfrm>
+            <a:off x="3429000" y="1115568"/>
+            <a:ext cx="2286000" cy="2286000"/>
+          </a:xfrm>
+          <a:prstGeom prst="rect">
+            <a:avLst/>
+          </a:prstGeom>
+        </p:spPr>
+      </p:pic>
+      <p:sp>
+        <p:nvSpPr>
+          <p:cNvPr id="6" name="TextBox 5"/>
+          <p:cNvSpPr txBox="1"/>
+          <p:nvPr/>
+        </p:nvSpPr>
+        <p:spPr>
+          <a:xfrm>
+            <a:off x="411480" y="3611880"/>
+            <a:ext cx="8321040" cy="1005840"/>
+          </a:xfrm>
+          <a:prstGeom prst="rect">
+            <a:avLst/>
+          </a:prstGeom>
+          <a:noFill/>
+        </p:spPr>
+        <p:txBody>
+          <a:bodyPr wrap="square">
+            <a:spAutoFit/>
+          </a:bodyPr>
+          <a:lstStyle/>
+          <a:p>
             <a:pPr algn="ctr">
-              <a:defRPr sz="3200" b="1">
-                <a:solidFill>
-                  <a:srgbClr val="143278"/>
-                </a:solidFill>
-              </a:defRPr>
-            </a:pPr>
-            <a:r>
-              <a:t>敬请批评指正</a:t>
-            </a:r>
-          </a:p>
-        </p:txBody>
-      </p:sp>
-      <p:sp>
-        <p:nvSpPr>
-          <p:cNvPr id="5" name="TextBox 4"/>
+              <a:defRPr sz="1200">
+                <a:solidFill>
+                  <a:srgbClr val="505050"/>
+                </a:solidFill>
+              </a:defRPr>
+            </a:pPr>
+            <a:r>
+              <a:t>扫码进入 GitHub 仓库</a:t>
+            </a:r>
+            <a:br/>
+            <a:r>
+              <a:t>https://github.com/FBB123571/ElderCare-Humanoid-Platform</a:t>
+            </a:r>
+          </a:p>
+          <a:p>
+            <a:pPr algn="ctr">
+              <a:defRPr sz="1100">
+                <a:solidFill>
+                  <a:srgbClr val="505050"/>
+                </a:solidFill>
+              </a:defRPr>
+            </a:pPr>
+            <a:r>
+              <a:t>演示视频：仓库内 docs/assets/demo_carecompanion.mp4</a:t>
+            </a:r>
+          </a:p>
+        </p:txBody>
+      </p:sp>
+    </p:spTree>
+  </p:cSld>
+  <p:clrMapOvr>
+    <a:masterClrMapping/>
+  </p:clrMapOvr>
+</p:sld>
+</file>
+
+<file path=ppt/slides/slide29.xml><?xml version="1.0" encoding="utf-8"?>
+<p:sld xmlns:a="http://schemas.openxmlformats.org/drawingml/2006/main" xmlns:p="http://schemas.openxmlformats.org/presentationml/2006/main" xmlns:r="http://schemas.openxmlformats.org/officeDocument/2006/relationships">
+  <p:cSld>
+    <p:bg>
+      <p:bgPr>
+        <a:solidFill>
+          <a:srgbClr val="FFFFFF"/>
+        </a:solidFill>
+        <a:effectLst/>
+      </p:bgPr>
+    </p:bg>
+    <p:spTree>
+      <p:nvGrpSpPr>
+        <p:cNvPr id="1" name=""/>
+        <p:cNvGrpSpPr/>
+        <p:nvPr/>
+      </p:nvGrpSpPr>
+      <p:grpSpPr/>
+      <p:sp>
+        <p:nvSpPr>
+          <p:cNvPr id="2" name="Rectangle 1"/>
+          <p:cNvSpPr/>
+          <p:nvPr/>
+        </p:nvSpPr>
+        <p:spPr>
+          <a:xfrm>
+            <a:off x="0" y="0"/>
+            <a:ext cx="9144000" cy="475488"/>
+          </a:xfrm>
+          <a:prstGeom prst="rect">
+            <a:avLst/>
+          </a:prstGeom>
+          <a:solidFill>
+            <a:srgbClr val="143278"/>
+          </a:solidFill>
+          <a:ln>
+            <a:noFill/>
+          </a:ln>
+        </p:spPr>
+        <p:style>
+          <a:lnRef idx="1">
+            <a:schemeClr val="accent1"/>
+          </a:lnRef>
+          <a:fillRef idx="3">
+            <a:schemeClr val="accent1"/>
+          </a:fillRef>
+          <a:effectRef idx="2">
+            <a:schemeClr val="accent1"/>
+          </a:effectRef>
+          <a:fontRef idx="minor">
+            <a:schemeClr val="lt1"/>
+          </a:fontRef>
+        </p:style>
+        <p:txBody>
+          <a:bodyPr rtlCol="0" anchor="ctr"/>
+          <a:lstStyle/>
+          <a:p>
+            <a:pPr algn="ctr"/>
+          </a:p>
+        </p:txBody>
+      </p:sp>
+      <p:sp>
+        <p:nvSpPr>
+          <p:cNvPr id="3" name="TextBox 2"/>
           <p:cNvSpPr txBox="1"/>
           <p:nvPr/>
         </p:nvSpPr>
         <p:spPr>
           <a:xfrm>
-            <a:off x="502920" y="2891790"/>
-            <a:ext cx="8138160" cy="457200"/>
+            <a:off x="137160" y="73152"/>
+            <a:ext cx="8869680" cy="411480"/>
           </a:xfrm>
           <a:prstGeom prst="rect">
             <a:avLst/>
@@ -8283,6 +8782,88 @@
           </a:bodyPr>
           <a:lstStyle/>
           <a:p>
+            <a:pPr>
+              <a:defRPr sz="1000" b="1">
+                <a:solidFill>
+                  <a:srgbClr val="FFFFFF"/>
+                </a:solidFill>
+              </a:defRPr>
+            </a:pPr>
+            <a:r>
+              <a:t>第二十八届中国机器人及人工智能大赛</a:t>
+            </a:r>
+          </a:p>
+          <a:p>
+            <a:pPr>
+              <a:defRPr sz="1000">
+                <a:solidFill>
+                  <a:srgbClr val="C8DCFF"/>
+                </a:solidFill>
+              </a:defRPr>
+            </a:pPr>
+            <a:r>
+              <a:t>创新赛 · 机器人创新赛道</a:t>
+            </a:r>
+          </a:p>
+        </p:txBody>
+      </p:sp>
+      <p:sp>
+        <p:nvSpPr>
+          <p:cNvPr id="4" name="TextBox 3"/>
+          <p:cNvSpPr txBox="1"/>
+          <p:nvPr/>
+        </p:nvSpPr>
+        <p:spPr>
+          <a:xfrm>
+            <a:off x="502920" y="2068830"/>
+            <a:ext cx="8138160" cy="914400"/>
+          </a:xfrm>
+          <a:prstGeom prst="rect">
+            <a:avLst/>
+          </a:prstGeom>
+          <a:noFill/>
+        </p:spPr>
+        <p:txBody>
+          <a:bodyPr wrap="none">
+            <a:spAutoFit/>
+          </a:bodyPr>
+          <a:lstStyle/>
+          <a:p>
+            <a:pPr algn="ctr">
+              <a:defRPr sz="3200" b="1">
+                <a:solidFill>
+                  <a:srgbClr val="143278"/>
+                </a:solidFill>
+              </a:defRPr>
+            </a:pPr>
+            <a:r>
+              <a:t>敬请批评指正</a:t>
+            </a:r>
+          </a:p>
+        </p:txBody>
+      </p:sp>
+      <p:sp>
+        <p:nvSpPr>
+          <p:cNvPr id="5" name="TextBox 4"/>
+          <p:cNvSpPr txBox="1"/>
+          <p:nvPr/>
+        </p:nvSpPr>
+        <p:spPr>
+          <a:xfrm>
+            <a:off x="502920" y="2891790"/>
+            <a:ext cx="8138160" cy="457200"/>
+          </a:xfrm>
+          <a:prstGeom prst="rect">
+            <a:avLst/>
+          </a:prstGeom>
+          <a:noFill/>
+        </p:spPr>
+        <p:txBody>
+          <a:bodyPr wrap="none">
+            <a:spAutoFit/>
+          </a:bodyPr>
+          <a:lstStyle/>
+          <a:p>
             <a:pPr algn="ctr">
               <a:defRPr sz="1600">
                 <a:solidFill>
@@ -8291,7 +8872,7 @@
               </a:defRPr>
             </a:pPr>
             <a:r>
-              <a:t>CareCompanion 团队 · 感谢各位评委老师</a:t>
+              <a:t>从容应队 · 中山大学 · 感谢各位评委老师</a:t>
             </a:r>
           </a:p>
         </p:txBody>
@@ -8407,7 +8988,7 @@
               </a:defRPr>
             </a:pPr>
             <a:r>
-              <a:t>机器人创新赛道</a:t>
+              <a:t>创新赛 · 机器人创新赛道</a:t>
             </a:r>
           </a:p>
         </p:txBody>
@@ -8420,7 +9001,7 @@
         </p:nvSpPr>
         <p:spPr>
           <a:xfrm>
-            <a:off x="502920" y="566928"/>
+            <a:off x="502920" y="2068830"/>
             <a:ext cx="8138160" cy="731520"/>
           </a:xfrm>
           <a:prstGeom prst="rect">
@@ -8434,15 +9015,15 @@
           </a:bodyPr>
           <a:lstStyle/>
           <a:p>
-            <a:pPr algn="l">
-              <a:defRPr sz="2400" b="1">
+            <a:pPr algn="ctr">
+              <a:defRPr sz="3000" b="1">
                 <a:solidFill>
                   <a:srgbClr val="1E1E1E"/>
                 </a:solidFill>
               </a:defRPr>
             </a:pPr>
             <a:r>
-              <a:t>社会背景与痛点</a:t>
+              <a:t>第一部分</a:t>
             </a:r>
           </a:p>
         </p:txBody>
@@ -8455,8 +9036,8 @@
         </p:nvSpPr>
         <p:spPr>
           <a:xfrm>
-            <a:off x="502920" y="1234440"/>
-            <a:ext cx="8138160" cy="3474720"/>
+            <a:off x="502920" y="2617470"/>
+            <a:ext cx="8138160" cy="731520"/>
           </a:xfrm>
           <a:prstGeom prst="rect">
             <a:avLst/>
@@ -8469,18 +9050,15 @@
           </a:bodyPr>
           <a:lstStyle/>
           <a:p>
-            <a:pPr>
-              <a:lnSpc>
-                <a:spcPct val="135000"/>
-              </a:lnSpc>
-              <a:defRPr sz="1500" b="0">
-                <a:solidFill>
-                  <a:srgbClr val="1E1E1E"/>
-                </a:solidFill>
-              </a:defRPr>
-            </a:pPr>
-            <a:r>
-              <a:t>随着我国老龄化程度加深，空巢与独居老人数量持续增加。跌倒已成为老年人意外伤害的首要原因之一，而「发现延迟」往往导致救援错过黄金时间。与此同时，老人对情感陪伴的需求日益增长——他们不仅需要被监测，更需要被理解、被回应。</a:t>
+            <a:pPr algn="ctr">
+              <a:defRPr sz="2000" b="1">
+                <a:solidFill>
+                  <a:srgbClr val="143278"/>
+                </a:solidFill>
+              </a:defRPr>
+            </a:pPr>
+            <a:r>
+              <a:t>项目背景与需求分析</a:t>
             </a:r>
           </a:p>
         </p:txBody>
@@ -8596,7 +9174,7 @@
               </a:defRPr>
             </a:pPr>
             <a:r>
-              <a:t>机器人创新赛道</a:t>
+              <a:t>创新赛 · 机器人创新赛道</a:t>
             </a:r>
           </a:p>
         </p:txBody>
@@ -8631,7 +9209,7 @@
               </a:defRPr>
             </a:pPr>
             <a:r>
-              <a:t>现有方案的不足</a:t>
+              <a:t>社会背景与痛点</a:t>
             </a:r>
           </a:p>
         </p:txBody>
@@ -8644,43 +9222,8 @@
         </p:nvSpPr>
         <p:spPr>
           <a:xfrm>
-            <a:off x="411480" y="1234440"/>
-            <a:ext cx="4023360" cy="457200"/>
-          </a:xfrm>
-          <a:prstGeom prst="rect">
-            <a:avLst/>
-          </a:prstGeom>
-          <a:noFill/>
-        </p:spPr>
-        <p:txBody>
-          <a:bodyPr wrap="none">
-            <a:spAutoFit/>
-          </a:bodyPr>
-          <a:lstStyle/>
-          <a:p>
-            <a:pPr>
-              <a:defRPr sz="1400" b="1">
-                <a:solidFill>
-                  <a:srgbClr val="C00000"/>
-                </a:solidFill>
-              </a:defRPr>
-            </a:pPr>
-            <a:r>
-              <a:t>现有产品/方案（Ø）</a:t>
-            </a:r>
-          </a:p>
-        </p:txBody>
-      </p:sp>
-      <p:sp>
-        <p:nvSpPr>
-          <p:cNvPr id="6" name="TextBox 5"/>
-          <p:cNvSpPr txBox="1"/>
-          <p:nvPr/>
-        </p:nvSpPr>
-        <p:spPr>
-          <a:xfrm>
-            <a:off x="411480" y="1691640"/>
-            <a:ext cx="4023360" cy="3200400"/>
+            <a:off x="502920" y="1234440"/>
+            <a:ext cx="8138160" cy="3474720"/>
           </a:xfrm>
           <a:prstGeom prst="rect">
             <a:avLst/>
@@ -8694,168 +9237,17 @@
           <a:lstStyle/>
           <a:p>
             <a:pPr>
-              <a:defRPr sz="1300">
+              <a:lnSpc>
+                <a:spcPct val="135000"/>
+              </a:lnSpc>
+              <a:defRPr sz="1500" b="0">
                 <a:solidFill>
                   <a:srgbClr val="1E1E1E"/>
                 </a:solidFill>
               </a:defRPr>
             </a:pPr>
             <a:r>
-              <a:t>Ø 智能音箱：无视觉安全闭环，无法实体援助</a:t>
-            </a:r>
-          </a:p>
-          <a:p>
-            <a:pPr>
-              <a:defRPr sz="1300">
-                <a:solidFill>
-                  <a:srgbClr val="1E1E1E"/>
-                </a:solidFill>
-              </a:defRPr>
-            </a:pPr>
-            <a:r>
-              <a:t>Ø 监控摄像头：只告警不陪伴，缺乏对话与动作</a:t>
-            </a:r>
-          </a:p>
-          <a:p>
-            <a:pPr>
-              <a:defRPr sz="1300">
-                <a:solidFill>
-                  <a:srgbClr val="1E1E1E"/>
-                </a:solidFill>
-              </a:defRPr>
-            </a:pPr>
-            <a:r>
-              <a:t>Ø 健康手环：难发现跌倒过程，无机器人执行</a:t>
-            </a:r>
-          </a:p>
-          <a:p>
-            <a:pPr>
-              <a:defRPr sz="1300">
-                <a:solidFill>
-                  <a:srgbClr val="1E1E1E"/>
-                </a:solidFill>
-              </a:defRPr>
-            </a:pPr>
-            <a:r>
-              <a:t>Ø 纯仿真毕设：缺少真机部署路径与量化评测</a:t>
-            </a:r>
-          </a:p>
-        </p:txBody>
-      </p:sp>
-      <p:sp>
-        <p:nvSpPr>
-          <p:cNvPr id="7" name="TextBox 6"/>
-          <p:cNvSpPr txBox="1"/>
-          <p:nvPr/>
-        </p:nvSpPr>
-        <p:spPr>
-          <a:xfrm>
-            <a:off x="4617720" y="1234440"/>
-            <a:ext cx="4023360" cy="457200"/>
-          </a:xfrm>
-          <a:prstGeom prst="rect">
-            <a:avLst/>
-          </a:prstGeom>
-          <a:noFill/>
-        </p:spPr>
-        <p:txBody>
-          <a:bodyPr wrap="none">
-            <a:spAutoFit/>
-          </a:bodyPr>
-          <a:lstStyle/>
-          <a:p>
-            <a:pPr>
-              <a:defRPr sz="1400" b="1">
-                <a:solidFill>
-                  <a:srgbClr val="143278"/>
-                </a:solidFill>
-              </a:defRPr>
-            </a:pPr>
-            <a:r>
-              <a:t>CareCompanion（ü）</a:t>
-            </a:r>
-          </a:p>
-        </p:txBody>
-      </p:sp>
-      <p:sp>
-        <p:nvSpPr>
-          <p:cNvPr id="8" name="TextBox 7"/>
-          <p:cNvSpPr txBox="1"/>
-          <p:nvPr/>
-        </p:nvSpPr>
-        <p:spPr>
-          <a:xfrm>
-            <a:off x="4617720" y="1691640"/>
-            <a:ext cx="4023360" cy="3200400"/>
-          </a:xfrm>
-          <a:prstGeom prst="rect">
-            <a:avLst/>
-          </a:prstGeom>
-          <a:noFill/>
-        </p:spPr>
-        <p:txBody>
-          <a:bodyPr wrap="square">
-            <a:spAutoFit/>
-          </a:bodyPr>
-          <a:lstStyle/>
-          <a:p>
-            <a:pPr>
-              <a:defRPr sz="1300">
-                <a:solidFill>
-                  <a:srgbClr val="1E1E1E"/>
-                </a:solidFill>
-              </a:defRPr>
-            </a:pPr>
-            <a:r>
-              <a:t>ü 多模态融合：跌倒+情绪+生理→统一风险引擎</a:t>
-            </a:r>
-          </a:p>
-          <a:p>
-            <a:pPr>
-              <a:defRPr sz="1300">
-                <a:solidFill>
-                  <a:srgbClr val="1E1E1E"/>
-                </a:solidFill>
-              </a:defRPr>
-            </a:pPr>
-            <a:r>
-              <a:t>ü 可解释决策：输出风险分数与原因列表</a:t>
-            </a:r>
-          </a:p>
-          <a:p>
-            <a:pPr>
-              <a:defRPr sz="1300">
-                <a:solidFill>
-                  <a:srgbClr val="1E1E1E"/>
-                </a:solidFill>
-              </a:defRPr>
-            </a:pPr>
-            <a:r>
-              <a:t>ü 主动照护：告警/语音/手势/紧急呼叫联动</a:t>
-            </a:r>
-          </a:p>
-          <a:p>
-            <a:pPr>
-              <a:defRPr sz="1300">
-                <a:solidFill>
-                  <a:srgbClr val="1E1E1E"/>
-                </a:solidFill>
-              </a:defRPr>
-            </a:pPr>
-            <a:r>
-              <a:t>ü 人形接口：ROS2 标准话题，仿真与真机同源</a:t>
-            </a:r>
-          </a:p>
-          <a:p>
-            <a:pPr>
-              <a:defRPr sz="1300">
-                <a:solidFill>
-                  <a:srgbClr val="1E1E1E"/>
-                </a:solidFill>
-              </a:defRPr>
-            </a:pPr>
-            <a:r>
-              <a:t>ü 开源可复现：Web 控制台 + 评测脚本 + GitHub</a:t>
+              <a:t>随着我国老龄化程度加深，空巢与独居老人数量持续增加。跌倒已成为老年人意外伤害的首要原因之一，而「发现延迟」往往导致救援错过黄金时间。与此同时，老人对情感陪伴的需求日益增长——他们不仅需要被监测，更需要被理解、被回应。</a:t>
             </a:r>
           </a:p>
         </p:txBody>
@@ -8971,7 +9363,7 @@
               </a:defRPr>
             </a:pPr>
             <a:r>
-              <a:t>机器人创新赛道</a:t>
+              <a:t>创新赛 · 机器人创新赛道</a:t>
             </a:r>
           </a:p>
         </p:txBody>
@@ -9006,7 +9398,7 @@
               </a:defRPr>
             </a:pPr>
             <a:r>
-              <a:t>项目概述</a:t>
+              <a:t>现有方案的不足</a:t>
             </a:r>
           </a:p>
         </p:txBody>
@@ -9019,8 +9411,43 @@
         </p:nvSpPr>
         <p:spPr>
           <a:xfrm>
-            <a:off x="502920" y="1234440"/>
-            <a:ext cx="8138160" cy="3474720"/>
+            <a:off x="411480" y="1234440"/>
+            <a:ext cx="4023360" cy="457200"/>
+          </a:xfrm>
+          <a:prstGeom prst="rect">
+            <a:avLst/>
+          </a:prstGeom>
+          <a:noFill/>
+        </p:spPr>
+        <p:txBody>
+          <a:bodyPr wrap="none">
+            <a:spAutoFit/>
+          </a:bodyPr>
+          <a:lstStyle/>
+          <a:p>
+            <a:pPr>
+              <a:defRPr sz="1400" b="1">
+                <a:solidFill>
+                  <a:srgbClr val="C00000"/>
+                </a:solidFill>
+              </a:defRPr>
+            </a:pPr>
+            <a:r>
+              <a:t>现有产品/方案（Ø）</a:t>
+            </a:r>
+          </a:p>
+        </p:txBody>
+      </p:sp>
+      <p:sp>
+        <p:nvSpPr>
+          <p:cNvPr id="6" name="TextBox 5"/>
+          <p:cNvSpPr txBox="1"/>
+          <p:nvPr/>
+        </p:nvSpPr>
+        <p:spPr>
+          <a:xfrm>
+            <a:off x="411480" y="1691640"/>
+            <a:ext cx="4023360" cy="3200400"/>
           </a:xfrm>
           <a:prstGeom prst="rect">
             <a:avLst/>
@@ -9034,17 +9461,168 @@
           <a:lstStyle/>
           <a:p>
             <a:pPr>
-              <a:lnSpc>
-                <a:spcPct val="135000"/>
-              </a:lnSpc>
-              <a:defRPr sz="1500" b="0">
+              <a:defRPr sz="1300">
                 <a:solidFill>
                   <a:srgbClr val="1E1E1E"/>
                 </a:solidFill>
               </a:defRPr>
             </a:pPr>
             <a:r>
-              <a:t>基于上述需求，我们开发了 CareCompanion 智能养老人形陪伴机器人软件平台。平台以 CareOrchestrator 为核心，融合 MediaPipe 视觉姿态、文本情感与健康指标，在 Web 控制台完成演示验证，并通过 ROS2 适配层对接人形机器人。系统已实现跌倒紧急链路自动化验证，合成场景跌倒检测 F1 达 100%。</a:t>
+              <a:t>Ø 智能音箱：无视觉安全闭环，无法实体援助</a:t>
+            </a:r>
+          </a:p>
+          <a:p>
+            <a:pPr>
+              <a:defRPr sz="1300">
+                <a:solidFill>
+                  <a:srgbClr val="1E1E1E"/>
+                </a:solidFill>
+              </a:defRPr>
+            </a:pPr>
+            <a:r>
+              <a:t>Ø 监控摄像头：只告警不陪伴，缺乏对话与动作</a:t>
+            </a:r>
+          </a:p>
+          <a:p>
+            <a:pPr>
+              <a:defRPr sz="1300">
+                <a:solidFill>
+                  <a:srgbClr val="1E1E1E"/>
+                </a:solidFill>
+              </a:defRPr>
+            </a:pPr>
+            <a:r>
+              <a:t>Ø 健康手环：难发现跌倒过程，无机器人执行</a:t>
+            </a:r>
+          </a:p>
+          <a:p>
+            <a:pPr>
+              <a:defRPr sz="1300">
+                <a:solidFill>
+                  <a:srgbClr val="1E1E1E"/>
+                </a:solidFill>
+              </a:defRPr>
+            </a:pPr>
+            <a:r>
+              <a:t>Ø 纯仿真毕设：缺少真机部署路径与量化评测</a:t>
+            </a:r>
+          </a:p>
+        </p:txBody>
+      </p:sp>
+      <p:sp>
+        <p:nvSpPr>
+          <p:cNvPr id="7" name="TextBox 6"/>
+          <p:cNvSpPr txBox="1"/>
+          <p:nvPr/>
+        </p:nvSpPr>
+        <p:spPr>
+          <a:xfrm>
+            <a:off x="4617720" y="1234440"/>
+            <a:ext cx="4023360" cy="457200"/>
+          </a:xfrm>
+          <a:prstGeom prst="rect">
+            <a:avLst/>
+          </a:prstGeom>
+          <a:noFill/>
+        </p:spPr>
+        <p:txBody>
+          <a:bodyPr wrap="none">
+            <a:spAutoFit/>
+          </a:bodyPr>
+          <a:lstStyle/>
+          <a:p>
+            <a:pPr>
+              <a:defRPr sz="1400" b="1">
+                <a:solidFill>
+                  <a:srgbClr val="143278"/>
+                </a:solidFill>
+              </a:defRPr>
+            </a:pPr>
+            <a:r>
+              <a:t>CareCompanion（ü）</a:t>
+            </a:r>
+          </a:p>
+        </p:txBody>
+      </p:sp>
+      <p:sp>
+        <p:nvSpPr>
+          <p:cNvPr id="8" name="TextBox 7"/>
+          <p:cNvSpPr txBox="1"/>
+          <p:nvPr/>
+        </p:nvSpPr>
+        <p:spPr>
+          <a:xfrm>
+            <a:off x="4617720" y="1691640"/>
+            <a:ext cx="4023360" cy="3200400"/>
+          </a:xfrm>
+          <a:prstGeom prst="rect">
+            <a:avLst/>
+          </a:prstGeom>
+          <a:noFill/>
+        </p:spPr>
+        <p:txBody>
+          <a:bodyPr wrap="square">
+            <a:spAutoFit/>
+          </a:bodyPr>
+          <a:lstStyle/>
+          <a:p>
+            <a:pPr>
+              <a:defRPr sz="1300">
+                <a:solidFill>
+                  <a:srgbClr val="1E1E1E"/>
+                </a:solidFill>
+              </a:defRPr>
+            </a:pPr>
+            <a:r>
+              <a:t>ü 多模态融合：跌倒+情绪+生理→统一风险引擎</a:t>
+            </a:r>
+          </a:p>
+          <a:p>
+            <a:pPr>
+              <a:defRPr sz="1300">
+                <a:solidFill>
+                  <a:srgbClr val="1E1E1E"/>
+                </a:solidFill>
+              </a:defRPr>
+            </a:pPr>
+            <a:r>
+              <a:t>ü 可解释决策：输出风险分数与原因列表</a:t>
+            </a:r>
+          </a:p>
+          <a:p>
+            <a:pPr>
+              <a:defRPr sz="1300">
+                <a:solidFill>
+                  <a:srgbClr val="1E1E1E"/>
+                </a:solidFill>
+              </a:defRPr>
+            </a:pPr>
+            <a:r>
+              <a:t>ü 主动照护：告警/语音/手势/紧急呼叫联动</a:t>
+            </a:r>
+          </a:p>
+          <a:p>
+            <a:pPr>
+              <a:defRPr sz="1300">
+                <a:solidFill>
+                  <a:srgbClr val="1E1E1E"/>
+                </a:solidFill>
+              </a:defRPr>
+            </a:pPr>
+            <a:r>
+              <a:t>ü 人形接口：ROS2 标准话题，仿真与真机同源</a:t>
+            </a:r>
+          </a:p>
+          <a:p>
+            <a:pPr>
+              <a:defRPr sz="1300">
+                <a:solidFill>
+                  <a:srgbClr val="1E1E1E"/>
+                </a:solidFill>
+              </a:defRPr>
+            </a:pPr>
+            <a:r>
+              <a:t>ü 开源可复现：Web 控制台 + 评测脚本 + GitHub</a:t>
             </a:r>
           </a:p>
         </p:txBody>
@@ -9160,7 +9738,7 @@
               </a:defRPr>
             </a:pPr>
             <a:r>
-              <a:t>机器人创新赛道</a:t>
+              <a:t>创新赛 · 机器人创新赛道</a:t>
             </a:r>
           </a:p>
         </p:txBody>
@@ -9173,7 +9751,7 @@
         </p:nvSpPr>
         <p:spPr>
           <a:xfrm>
-            <a:off x="502920" y="2068830"/>
+            <a:off x="502920" y="566928"/>
             <a:ext cx="8138160" cy="731520"/>
           </a:xfrm>
           <a:prstGeom prst="rect">
@@ -9187,15 +9765,15 @@
           </a:bodyPr>
           <a:lstStyle/>
           <a:p>
-            <a:pPr algn="ctr">
-              <a:defRPr sz="3000" b="1">
+            <a:pPr algn="l">
+              <a:defRPr sz="2400" b="1">
                 <a:solidFill>
                   <a:srgbClr val="1E1E1E"/>
                 </a:solidFill>
               </a:defRPr>
             </a:pPr>
             <a:r>
-              <a:t>第二部分</a:t>
+              <a:t>项目概述</a:t>
             </a:r>
           </a:p>
         </p:txBody>
@@ -9208,8 +9786,8 @@
         </p:nvSpPr>
         <p:spPr>
           <a:xfrm>
-            <a:off x="502920" y="2617470"/>
-            <a:ext cx="8138160" cy="731520"/>
+            <a:off x="502920" y="1234440"/>
+            <a:ext cx="8138160" cy="3474720"/>
           </a:xfrm>
           <a:prstGeom prst="rect">
             <a:avLst/>
@@ -9222,15 +9800,18 @@
           </a:bodyPr>
           <a:lstStyle/>
           <a:p>
-            <a:pPr algn="ctr">
-              <a:defRPr sz="2000" b="1">
-                <a:solidFill>
-                  <a:srgbClr val="143278"/>
-                </a:solidFill>
-              </a:defRPr>
-            </a:pPr>
-            <a:r>
-              <a:t>关键技术与系统架构</a:t>
+            <a:pPr>
+              <a:lnSpc>
+                <a:spcPct val="135000"/>
+              </a:lnSpc>
+              <a:defRPr sz="1500" b="0">
+                <a:solidFill>
+                  <a:srgbClr val="1E1E1E"/>
+                </a:solidFill>
+              </a:defRPr>
+            </a:pPr>
+            <a:r>
+              <a:t>基于上述需求，我们开发了 CareCompanion 智能养老人形陪伴机器人软件平台。平台以 CareOrchestrator 为核心，融合 MediaPipe 视觉姿态、文本情感与健康指标，在 Web 控制台完成演示验证，并通过 ROS2 适配层对接人形机器人。系统已实现跌倒紧急链路自动化验证，合成场景跌倒检测 F1 达 100%。</a:t>
             </a:r>
           </a:p>
         </p:txBody>
@@ -9346,7 +9927,7 @@
               </a:defRPr>
             </a:pPr>
             <a:r>
-              <a:t>机器人创新赛道</a:t>
+              <a:t>创新赛 · 机器人创新赛道</a:t>
             </a:r>
           </a:p>
         </p:txBody>
@@ -9359,7 +9940,7 @@
         </p:nvSpPr>
         <p:spPr>
           <a:xfrm>
-            <a:off x="502920" y="566928"/>
+            <a:off x="502920" y="2068830"/>
             <a:ext cx="8138160" cy="731520"/>
           </a:xfrm>
           <a:prstGeom prst="rect">
@@ -9373,15 +9954,15 @@
           </a:bodyPr>
           <a:lstStyle/>
           <a:p>
-            <a:pPr algn="l">
-              <a:defRPr sz="2400" b="1">
+            <a:pPr algn="ctr">
+              <a:defRPr sz="3000" b="1">
                 <a:solidFill>
                   <a:srgbClr val="1E1E1E"/>
                 </a:solidFill>
               </a:defRPr>
             </a:pPr>
             <a:r>
-              <a:t>系统总体架构</a:t>
+              <a:t>第二部分</a:t>
             </a:r>
           </a:p>
         </p:txBody>
@@ -9394,8 +9975,8 @@
         </p:nvSpPr>
         <p:spPr>
           <a:xfrm>
-            <a:off x="502920" y="1325880"/>
-            <a:ext cx="8138160" cy="3840480"/>
+            <a:off x="502920" y="2617470"/>
+            <a:ext cx="8138160" cy="731520"/>
           </a:xfrm>
           <a:prstGeom prst="rect">
             <a:avLst/>
@@ -9408,78 +9989,15 @@
           </a:bodyPr>
           <a:lstStyle/>
           <a:p>
-            <a:pPr>
-              <a:spcAft>
-                <a:spcPts val="600"/>
-              </a:spcAft>
-              <a:defRPr sz="1400">
-                <a:solidFill>
-                  <a:srgbClr val="1E1E1E"/>
-                </a:solidFill>
-              </a:defRPr>
-            </a:pPr>
-            <a:r>
-              <a:t>感知层：FallDetector · EmotionRecognizer · HealthMonitor · PosePipeline（MediaPipe）</a:t>
-            </a:r>
-          </a:p>
-          <a:p>
-            <a:pPr>
-              <a:spcAft>
-                <a:spcPts val="600"/>
-              </a:spcAft>
-              <a:defRPr sz="1400">
-                <a:solidFill>
-                  <a:srgbClr val="1E1E1E"/>
-                </a:solidFill>
-              </a:defRPr>
-            </a:pPr>
-            <a:r>
-              <a:t>认知层：RiskEngine（多模态融合）· DialogueManager · CarePlanner</a:t>
-            </a:r>
-          </a:p>
-          <a:p>
-            <a:pPr>
-              <a:spcAft>
-                <a:spcPts val="600"/>
-              </a:spcAft>
-              <a:defRPr sz="1400">
-                <a:solidFill>
-                  <a:srgbClr val="1E1E1E"/>
-                </a:solidFill>
-              </a:defRPr>
-            </a:pPr>
-            <a:r>
-              <a:t>执行层：RobotAdapter → SimulationAdapter / ROS2Adapter</a:t>
-            </a:r>
-          </a:p>
-          <a:p>
-            <a:pPr>
-              <a:spcAft>
-                <a:spcPts val="600"/>
-              </a:spcAft>
-              <a:defRPr sz="1400">
-                <a:solidFill>
-                  <a:srgbClr val="1E1E1E"/>
-                </a:solidFill>
-              </a:defRPr>
-            </a:pPr>
-            <a:r>
-              <a:t>交互层：Web 控制台 · 桌面 GUI · 无头自动化剧本</a:t>
-            </a:r>
-          </a:p>
-          <a:p>
-            <a:pPr>
-              <a:spcAft>
-                <a:spcPts val="600"/>
-              </a:spcAft>
-              <a:defRPr sz="1400">
-                <a:solidFill>
-                  <a:srgbClr val="1E1E1E"/>
-                </a:solidFill>
-              </a:defRPr>
-            </a:pPr>
-            <a:r>
-              <a:t>状态机：MONITOR → CONVERSE → ALERT → EMERGENCY（紧急硬优先级）</a:t>
+            <a:pPr algn="ctr">
+              <a:defRPr sz="2000" b="1">
+                <a:solidFill>
+                  <a:srgbClr val="143278"/>
+                </a:solidFill>
+              </a:defRPr>
+            </a:pPr>
+            <a:r>
+              <a:t>关键技术与系统架构</a:t>
             </a:r>
           </a:p>
         </p:txBody>
@@ -9595,7 +10113,7 @@
               </a:defRPr>
             </a:pPr>
             <a:r>
-              <a:t>机器人创新赛道</a:t>
+              <a:t>创新赛 · 机器人创新赛道</a:t>
             </a:r>
           </a:p>
         </p:txBody>
@@ -9630,7 +10148,7 @@
               </a:defRPr>
             </a:pPr>
             <a:r>
-              <a:t>多模态风险融合引擎</a:t>
+              <a:t>系统总体架构</a:t>
             </a:r>
           </a:p>
         </p:txBody>
@@ -9668,7 +10186,7 @@
               </a:defRPr>
             </a:pPr>
             <a:r>
-              <a:t>融合公式：S = 0.45·S_fall + 0.25·S_emo + 0.30·S_health</a:t>
+              <a:t>感知层：FallDetector · EmotionRecognizer · HealthMonitor · PosePipeline（MediaPipe）</a:t>
             </a:r>
           </a:p>
           <a:p>
@@ -9683,7 +10201,7 @@
               </a:defRPr>
             </a:pPr>
             <a:r>
-              <a:t>输出：风险分数、等级（normal/alert/emergency）、原因列表</a:t>
+              <a:t>认知层：RiskEngine（多模态融合）· DialogueManager · CarePlanner</a:t>
             </a:r>
           </a:p>
           <a:p>
@@ -9698,7 +10216,7 @@
               </a:defRPr>
             </a:pPr>
             <a:r>
-              <a:t>阈值：alert ≥ 0.65，emergency ≥ 0.85 或确认跌倒</a:t>
+              <a:t>执行层：RobotAdapter → SimulationAdapter / ROS2Adapter</a:t>
             </a:r>
           </a:p>
           <a:p>
@@ -9713,45 +10231,22 @@
               </a:defRPr>
             </a:pPr>
             <a:r>
-              <a:t>优势：非黑盒 LLM，便于答辩解释与医疗合规沟通</a:t>
-            </a:r>
-          </a:p>
-        </p:txBody>
-      </p:sp>
-      <p:sp>
-        <p:nvSpPr>
-          <p:cNvPr id="6" name="TextBox 5"/>
-          <p:cNvSpPr txBox="1"/>
-          <p:nvPr/>
-        </p:nvSpPr>
-        <p:spPr>
-          <a:xfrm>
-            <a:off x="502920" y="3657600"/>
-            <a:ext cx="8138160" cy="3474720"/>
-          </a:xfrm>
-          <a:prstGeom prst="rect">
-            <a:avLst/>
-          </a:prstGeom>
-          <a:noFill/>
-        </p:spPr>
-        <p:txBody>
-          <a:bodyPr wrap="square">
-            <a:spAutoFit/>
-          </a:bodyPr>
-          <a:lstStyle/>
-          <a:p>
-            <a:pPr>
-              <a:lnSpc>
-                <a:spcPct val="135000"/>
-              </a:lnSpc>
-              <a:defRPr sz="1200" b="0">
+              <a:t>交互层：Web 控制台 · 桌面 GUI · 无头自动化剧本</a:t>
+            </a:r>
+          </a:p>
+          <a:p>
+            <a:pPr>
+              <a:spcAft>
+                <a:spcPts val="600"/>
+              </a:spcAft>
+              <a:defRPr sz="1400">
                 <a:solidFill>
                   <a:srgbClr val="1E1E1E"/>
                 </a:solidFill>
               </a:defRPr>
             </a:pPr>
             <a:r>
-              <a:t>config/default.yaml 集中管理权重与阈值，支持场景调参。</a:t>
+              <a:t>状态机：MONITOR → CONVERSE → ALERT → EMERGENCY（紧急硬优先级）</a:t>
             </a:r>
           </a:p>
         </p:txBody>
@@ -9867,7 +10362,7 @@
               </a:defRPr>
             </a:pPr>
             <a:r>
-              <a:t>机器人创新赛道</a:t>
+              <a:t>创新赛 · 机器人创新赛道</a:t>
             </a:r>
           </a:p>
         </p:txBody>
@@ -9902,7 +10397,7 @@
               </a:defRPr>
             </a:pPr>
             <a:r>
-              <a:t>跌倒检测算法</a:t>
+              <a:t>多模态风险融合引擎</a:t>
             </a:r>
           </a:p>
         </p:txBody>
@@ -9940,7 +10435,7 @@
               </a:defRPr>
             </a:pPr>
             <a:r>
-              <a:t>几何特征：骨架宽高比 R=w/h、垂直速度 v_y、静止持续时间</a:t>
+              <a:t>融合公式：S = 0.45·S_fall + 0.25·S_emo + 0.30·S_health</a:t>
             </a:r>
           </a:p>
           <a:p>
@@ -9955,7 +10450,7 @@
               </a:defRPr>
             </a:pPr>
             <a:r>
-              <a:t>快速跌倒：快速下落 + 躺倒姿态（score ≥ 0.7）</a:t>
+              <a:t>输出：风险分数、等级（normal/alert/emergency）、原因列表</a:t>
             </a:r>
           </a:p>
           <a:p>
@@ -9970,7 +10465,7 @@
               </a:defRPr>
             </a:pPr>
             <a:r>
-              <a:t>慢速跌倒：躺倒静止 ≥ 2s（养老场景常见，score ≥ 0.55）</a:t>
+              <a:t>阈值：alert ≥ 0.65，emergency ≥ 0.85 或确认跌倒</a:t>
             </a:r>
           </a:p>
           <a:p>
@@ -9985,22 +10480,45 @@
               </a:defRPr>
             </a:pPr>
             <a:r>
-              <a:t>MediaPipe Pose：浏览器/摄像头实时骨架 → 自动填充感知参数</a:t>
-            </a:r>
-          </a:p>
-          <a:p>
-            <a:pPr>
-              <a:spcAft>
-                <a:spcPts val="600"/>
-              </a:spcAft>
-              <a:defRPr sz="1400">
+              <a:t>优势：非黑盒 LLM，便于答辩解释与医疗合规沟通</a:t>
+            </a:r>
+          </a:p>
+        </p:txBody>
+      </p:sp>
+      <p:sp>
+        <p:nvSpPr>
+          <p:cNvPr id="6" name="TextBox 5"/>
+          <p:cNvSpPr txBox="1"/>
+          <p:nvPr/>
+        </p:nvSpPr>
+        <p:spPr>
+          <a:xfrm>
+            <a:off x="502920" y="3657600"/>
+            <a:ext cx="8138160" cy="3474720"/>
+          </a:xfrm>
+          <a:prstGeom prst="rect">
+            <a:avLst/>
+          </a:prstGeom>
+          <a:noFill/>
+        </p:spPr>
+        <p:txBody>
+          <a:bodyPr wrap="square">
+            <a:spAutoFit/>
+          </a:bodyPr>
+          <a:lstStyle/>
+          <a:p>
+            <a:pPr>
+              <a:lnSpc>
+                <a:spcPct val="135000"/>
+              </a:lnSpc>
+              <a:defRPr sz="1200" b="0">
                 <a:solidFill>
                   <a:srgbClr val="1E1E1E"/>
                 </a:solidFill>
               </a:defRPr>
             </a:pPr>
             <a:r>
-              <a:t>评测：6 类合成场景，Precision/Recall/F1 = 100%</a:t>
+              <a:t>config/default.yaml 集中管理权重与阈值，支持场景调参。</a:t>
             </a:r>
           </a:p>
         </p:txBody>

</xml_diff>

<commit_message>
docs: fix team info and aging slides (readable cards, chart fill)
Replace slide 3 tiny PNG with native info cards, enlarge aging chart with cover fill and correct caption, and embed takeaways inside bullet panels.

Co-authored-by: Cursor <cursoragent@cursor.com>
</commit_message>
<xml_diff>
--- a/docs/答辩_CareCompanion.pptx
+++ b/docs/答辩_CareCompanion.pptx
@@ -4064,8 +4064,8 @@
         </p:nvSpPr>
         <p:spPr>
           <a:xfrm>
-            <a:off x="475488" y="1161288"/>
-            <a:ext cx="3300984" cy="3525012"/>
+            <a:off x="475488" y="1143000"/>
+            <a:ext cx="3300984" cy="3579876"/>
           </a:xfrm>
           <a:prstGeom prst="rect">
             <a:avLst/>
@@ -4083,7 +4083,7 @@
                 <a:spcPct val="120000"/>
               </a:lnSpc>
               <a:spcAft>
-                <a:spcPts val="6900"/>
+                <a:spcPts val="7100"/>
               </a:spcAft>
             </a:pPr>
             <a:r>
@@ -4103,7 +4103,7 @@
                 <a:spcPct val="120000"/>
               </a:lnSpc>
               <a:spcAft>
-                <a:spcPts val="6900"/>
+                <a:spcPts val="7100"/>
               </a:spcAft>
             </a:pPr>
             <a:r>
@@ -4123,7 +4123,7 @@
                 <a:spcPct val="120000"/>
               </a:lnSpc>
               <a:spcAft>
-                <a:spcPts val="6900"/>
+                <a:spcPts val="7100"/>
               </a:spcAft>
             </a:pPr>
             <a:r>
@@ -4143,7 +4143,7 @@
                 <a:spcPct val="120000"/>
               </a:lnSpc>
               <a:spcAft>
-                <a:spcPts val="6900"/>
+                <a:spcPts val="7100"/>
               </a:spcAft>
             </a:pPr>
             <a:r>
@@ -4622,8 +4622,8 @@
         </p:nvSpPr>
         <p:spPr>
           <a:xfrm>
-            <a:off x="475488" y="1161288"/>
-            <a:ext cx="3300984" cy="3525012"/>
+            <a:off x="475488" y="1143000"/>
+            <a:ext cx="3300984" cy="3579876"/>
           </a:xfrm>
           <a:prstGeom prst="rect">
             <a:avLst/>
@@ -4641,7 +4641,7 @@
                 <a:spcPct val="120000"/>
               </a:lnSpc>
               <a:spcAft>
-                <a:spcPts val="6900"/>
+                <a:spcPts val="7100"/>
               </a:spcAft>
             </a:pPr>
             <a:r>
@@ -4661,7 +4661,7 @@
                 <a:spcPct val="120000"/>
               </a:lnSpc>
               <a:spcAft>
-                <a:spcPts val="6900"/>
+                <a:spcPts val="7100"/>
               </a:spcAft>
             </a:pPr>
             <a:r>
@@ -4681,7 +4681,7 @@
                 <a:spcPct val="120000"/>
               </a:lnSpc>
               <a:spcAft>
-                <a:spcPts val="6900"/>
+                <a:spcPts val="7100"/>
               </a:spcAft>
             </a:pPr>
             <a:r>
@@ -4701,7 +4701,7 @@
                 <a:spcPct val="120000"/>
               </a:lnSpc>
               <a:spcAft>
-                <a:spcPts val="6900"/>
+                <a:spcPts val="7100"/>
               </a:spcAft>
             </a:pPr>
             <a:r>
@@ -5180,8 +5180,8 @@
         </p:nvSpPr>
         <p:spPr>
           <a:xfrm>
-            <a:off x="475488" y="1161288"/>
-            <a:ext cx="3300984" cy="3525012"/>
+            <a:off x="475488" y="1143000"/>
+            <a:ext cx="3300984" cy="3579876"/>
           </a:xfrm>
           <a:prstGeom prst="rect">
             <a:avLst/>
@@ -5199,7 +5199,7 @@
                 <a:spcPct val="120000"/>
               </a:lnSpc>
               <a:spcAft>
-                <a:spcPts val="6900"/>
+                <a:spcPts val="7100"/>
               </a:spcAft>
             </a:pPr>
             <a:r>
@@ -5219,7 +5219,7 @@
                 <a:spcPct val="120000"/>
               </a:lnSpc>
               <a:spcAft>
-                <a:spcPts val="6900"/>
+                <a:spcPts val="7100"/>
               </a:spcAft>
             </a:pPr>
             <a:r>
@@ -5239,7 +5239,7 @@
                 <a:spcPct val="120000"/>
               </a:lnSpc>
               <a:spcAft>
-                <a:spcPts val="6900"/>
+                <a:spcPts val="7100"/>
               </a:spcAft>
             </a:pPr>
             <a:r>
@@ -5259,7 +5259,7 @@
                 <a:spcPct val="120000"/>
               </a:lnSpc>
               <a:spcAft>
-                <a:spcPts val="6900"/>
+                <a:spcPts val="7100"/>
               </a:spcAft>
             </a:pPr>
             <a:r>
@@ -5738,8 +5738,8 @@
         </p:nvSpPr>
         <p:spPr>
           <a:xfrm>
-            <a:off x="475488" y="1161288"/>
-            <a:ext cx="3300984" cy="3525012"/>
+            <a:off x="475488" y="1143000"/>
+            <a:ext cx="3300984" cy="3579876"/>
           </a:xfrm>
           <a:prstGeom prst="rect">
             <a:avLst/>
@@ -5757,7 +5757,7 @@
                 <a:spcPct val="120000"/>
               </a:lnSpc>
               <a:spcAft>
-                <a:spcPts val="6900"/>
+                <a:spcPts val="7100"/>
               </a:spcAft>
             </a:pPr>
             <a:r>
@@ -5777,7 +5777,7 @@
                 <a:spcPct val="120000"/>
               </a:lnSpc>
               <a:spcAft>
-                <a:spcPts val="6900"/>
+                <a:spcPts val="7100"/>
               </a:spcAft>
             </a:pPr>
             <a:r>
@@ -5797,7 +5797,7 @@
                 <a:spcPct val="120000"/>
               </a:lnSpc>
               <a:spcAft>
-                <a:spcPts val="6900"/>
+                <a:spcPts val="7100"/>
               </a:spcAft>
             </a:pPr>
             <a:r>
@@ -5817,7 +5817,7 @@
                 <a:spcPct val="120000"/>
               </a:lnSpc>
               <a:spcAft>
-                <a:spcPts val="6900"/>
+                <a:spcPts val="7100"/>
               </a:spcAft>
             </a:pPr>
             <a:r>
@@ -6296,8 +6296,8 @@
         </p:nvSpPr>
         <p:spPr>
           <a:xfrm>
-            <a:off x="475488" y="1161288"/>
-            <a:ext cx="3300984" cy="3525012"/>
+            <a:off x="475488" y="1143000"/>
+            <a:ext cx="3300984" cy="3579876"/>
           </a:xfrm>
           <a:prstGeom prst="rect">
             <a:avLst/>
@@ -6315,7 +6315,7 @@
                 <a:spcPct val="120000"/>
               </a:lnSpc>
               <a:spcAft>
-                <a:spcPts val="6900"/>
+                <a:spcPts val="7100"/>
               </a:spcAft>
             </a:pPr>
             <a:r>
@@ -6335,7 +6335,7 @@
                 <a:spcPct val="120000"/>
               </a:lnSpc>
               <a:spcAft>
-                <a:spcPts val="6900"/>
+                <a:spcPts val="7100"/>
               </a:spcAft>
             </a:pPr>
             <a:r>
@@ -6355,7 +6355,7 @@
                 <a:spcPct val="120000"/>
               </a:lnSpc>
               <a:spcAft>
-                <a:spcPts val="6900"/>
+                <a:spcPts val="7100"/>
               </a:spcAft>
             </a:pPr>
             <a:r>
@@ -6375,7 +6375,7 @@
                 <a:spcPct val="120000"/>
               </a:lnSpc>
               <a:spcAft>
-                <a:spcPts val="6900"/>
+                <a:spcPts val="7100"/>
               </a:spcAft>
             </a:pPr>
             <a:r>
@@ -6767,7 +6767,7 @@
         <p:spPr>
           <a:xfrm>
             <a:off x="274320" y="996696"/>
-            <a:ext cx="3611880" cy="3451860"/>
+            <a:ext cx="3611880" cy="3854196"/>
           </a:xfrm>
           <a:prstGeom prst="rect">
             <a:avLst/>
@@ -6812,7 +6812,7 @@
         <p:spPr>
           <a:xfrm>
             <a:off x="274320" y="996696"/>
-            <a:ext cx="73152" cy="3451860"/>
+            <a:ext cx="73152" cy="3854196"/>
           </a:xfrm>
           <a:prstGeom prst="rect">
             <a:avLst/>
@@ -6848,14 +6848,93 @@
       </p:sp>
       <p:sp>
         <p:nvSpPr>
-          <p:cNvPr id="10" name="TextBox 9"/>
+          <p:cNvPr id="10" name="Rectangle 9"/>
+          <p:cNvSpPr/>
+          <p:nvPr/>
+        </p:nvSpPr>
+        <p:spPr>
+          <a:xfrm>
+            <a:off x="347472" y="4503420"/>
+            <a:ext cx="3465576" cy="310896"/>
+          </a:xfrm>
+          <a:prstGeom prst="rect">
+            <a:avLst/>
+          </a:prstGeom>
+          <a:solidFill>
+            <a:srgbClr val="143278"/>
+          </a:solidFill>
+          <a:ln>
+            <a:noFill/>
+          </a:ln>
+        </p:spPr>
+        <p:style>
+          <a:lnRef idx="1">
+            <a:schemeClr val="accent1"/>
+          </a:lnRef>
+          <a:fillRef idx="3">
+            <a:schemeClr val="accent1"/>
+          </a:fillRef>
+          <a:effectRef idx="2">
+            <a:schemeClr val="accent1"/>
+          </a:effectRef>
+          <a:fontRef idx="minor">
+            <a:schemeClr val="lt1"/>
+          </a:fontRef>
+        </p:style>
+        <p:txBody>
+          <a:bodyPr rtlCol="0" anchor="ctr"/>
+          <a:lstStyle/>
+          <a:p>
+            <a:pPr algn="ctr"/>
+          </a:p>
+        </p:txBody>
+      </p:sp>
+      <p:sp>
+        <p:nvSpPr>
+          <p:cNvPr id="11" name="TextBox 10"/>
           <p:cNvSpPr txBox="1"/>
           <p:nvPr/>
         </p:nvSpPr>
         <p:spPr>
           <a:xfrm>
-            <a:off x="475488" y="1161288"/>
-            <a:ext cx="3300984" cy="3122676"/>
+            <a:off x="402336" y="4576572"/>
+            <a:ext cx="3355848" cy="237744"/>
+          </a:xfrm>
+          <a:prstGeom prst="rect">
+            <a:avLst/>
+          </a:prstGeom>
+          <a:noFill/>
+        </p:spPr>
+        <p:txBody>
+          <a:bodyPr wrap="none">
+            <a:spAutoFit/>
+          </a:bodyPr>
+          <a:lstStyle/>
+          <a:p>
+            <a:pPr algn="ctr"/>
+            <a:r>
+              <a:rPr sz="1100" b="1">
+                <a:solidFill>
+                  <a:srgbClr val="FFFFFF"/>
+                </a:solidFill>
+                <a:latin typeface="微软雅黑"/>
+                <ns3:rFonts xmlns:ns3="http://schemas.openxmlformats.org/wordprocessingml/2006/main" ns3:eastAsia="微软雅黑" ns3:ascii="微软雅黑" ns3:hAnsi="微软雅黑"/>
+              </a:rPr>
+              <a:t>紧急链路可端到端验证</a:t>
+            </a:r>
+          </a:p>
+        </p:txBody>
+      </p:sp>
+      <p:sp>
+        <p:nvSpPr>
+          <p:cNvPr id="12" name="TextBox 11"/>
+          <p:cNvSpPr txBox="1"/>
+          <p:nvPr/>
+        </p:nvSpPr>
+        <p:spPr>
+          <a:xfrm>
+            <a:off x="475488" y="1143000"/>
+            <a:ext cx="3300984" cy="3232404"/>
           </a:xfrm>
           <a:prstGeom prst="rect">
             <a:avLst/>
@@ -6873,7 +6952,7 @@
                 <a:spcPct val="120000"/>
               </a:lnSpc>
               <a:spcAft>
-                <a:spcPts val="5900"/>
+                <a:spcPts val="6200"/>
               </a:spcAft>
             </a:pPr>
             <a:r>
@@ -6882,7 +6961,7 @@
                   <a:srgbClr val="1C202C"/>
                 </a:solidFill>
                 <a:latin typeface="微软雅黑"/>
-                <ns3:rFonts xmlns:ns3="http://schemas.openxmlformats.org/wordprocessingml/2006/main" ns3:eastAsia="微软雅黑" ns3:ascii="微软雅黑" ns3:hAnsi="微软雅黑"/>
+                <ns4:rFonts xmlns:ns4="http://schemas.openxmlformats.org/wordprocessingml/2006/main" ns4:eastAsia="微软雅黑" ns4:ascii="微软雅黑" ns4:hAnsi="微软雅黑"/>
               </a:rPr>
               <a:t>● 确认跌倒后按序触发四类动作</a:t>
             </a:r>
@@ -6893,7 +6972,7 @@
                 <a:spcPct val="120000"/>
               </a:lnSpc>
               <a:spcAft>
-                <a:spcPts val="5900"/>
+                <a:spcPts val="6200"/>
               </a:spcAft>
             </a:pPr>
             <a:r>
@@ -6902,7 +6981,7 @@
                   <a:srgbClr val="1C202C"/>
                 </a:solidFill>
                 <a:latin typeface="微软雅黑"/>
-                <ns4:rFonts xmlns:ns4="http://schemas.openxmlformats.org/wordprocessingml/2006/main" ns4:eastAsia="微软雅黑" ns4:ascii="微软雅黑" ns4:hAnsi="微软雅黑"/>
+                <ns5:rFonts xmlns:ns5="http://schemas.openxmlformats.org/wordprocessingml/2006/main" ns5:eastAsia="微软雅黑" ns5:ascii="微软雅黑" ns5:hAnsi="微软雅黑"/>
               </a:rPr>
               <a:t>● 告警音 → 语音 → 家属通知 → 手势</a:t>
             </a:r>
@@ -6913,7 +6992,7 @@
                 <a:spcPct val="120000"/>
               </a:lnSpc>
               <a:spcAft>
-                <a:spcPts val="5900"/>
+                <a:spcPts val="6200"/>
               </a:spcAft>
             </a:pPr>
             <a:r>
@@ -6922,7 +7001,7 @@
                   <a:srgbClr val="1C202C"/>
                 </a:solidFill>
                 <a:latin typeface="微软雅黑"/>
-                <ns5:rFonts xmlns:ns5="http://schemas.openxmlformats.org/wordprocessingml/2006/main" ns5:eastAsia="微软雅黑" ns5:ascii="微软雅黑" ns5:hAnsi="微软雅黑"/>
+                <ns6:rFonts xmlns:ns6="http://schemas.openxmlformats.org/wordprocessingml/2006/main" ns6:eastAsia="微软雅黑" ns6:ascii="微软雅黑" ns6:hAnsi="微软雅黑"/>
               </a:rPr>
               <a:t>● EmergencyNotifier 记录推送渠道</a:t>
             </a:r>
@@ -6933,7 +7012,7 @@
                 <a:spcPct val="120000"/>
               </a:lnSpc>
               <a:spcAft>
-                <a:spcPts val="5900"/>
+                <a:spcPts val="6200"/>
               </a:spcAft>
             </a:pPr>
             <a:r>
@@ -6942,7 +7021,7 @@
                   <a:srgbClr val="1C202C"/>
                 </a:solidFill>
                 <a:latin typeface="微软雅黑"/>
-                <ns6:rFonts xmlns:ns6="http://schemas.openxmlformats.org/wordprocessingml/2006/main" ns6:eastAsia="微软雅黑" ns6:ascii="微软雅黑" ns6:hAnsi="微软雅黑"/>
+                <ns7:rFonts xmlns:ns7="http://schemas.openxmlformats.org/wordprocessingml/2006/main" ns7:eastAsia="微软雅黑" ns7:ascii="微软雅黑" ns7:hAnsi="微软雅黑"/>
               </a:rPr>
               <a:t>● 端到端触发率评测 100%</a:t>
             </a:r>
@@ -6951,7 +7030,7 @@
       </p:sp>
       <p:sp>
         <p:nvSpPr>
-          <p:cNvPr id="11" name="Rectangle 10"/>
+          <p:cNvPr id="13" name="Rectangle 12"/>
           <p:cNvSpPr/>
           <p:nvPr/>
         </p:nvSpPr>
@@ -6996,7 +7075,7 @@
       </p:sp>
       <p:pic>
         <p:nvPicPr>
-          <p:cNvPr id="12" name="Picture 11" descr="emergency_flow.png"/>
+          <p:cNvPr id="14" name="Picture 13" descr="emergency_flow.png"/>
           <p:cNvPicPr>
             <a:picLocks noChangeAspect="1"/>
           </p:cNvPicPr>
@@ -7020,7 +7099,7 @@
       </p:pic>
       <p:sp>
         <p:nvSpPr>
-          <p:cNvPr id="13" name="TextBox 12"/>
+          <p:cNvPr id="15" name="TextBox 14"/>
           <p:cNvSpPr txBox="1"/>
           <p:nvPr/>
         </p:nvSpPr>
@@ -7047,88 +7126,9 @@
                   <a:srgbClr val="5A6273"/>
                 </a:solidFill>
                 <a:latin typeface="微软雅黑"/>
-                <ns7:rFonts xmlns:ns7="http://schemas.openxmlformats.org/wordprocessingml/2006/main" ns7:eastAsia="微软雅黑" ns7:ascii="微软雅黑" ns7:hAnsi="微软雅黑"/>
+                <ns8:rFonts xmlns:ns8="http://schemas.openxmlformats.org/wordprocessingml/2006/main" ns8:eastAsia="微软雅黑" ns8:ascii="微软雅黑" ns8:hAnsi="微软雅黑"/>
               </a:rPr>
               <a:t>理论框图</a:t>
-            </a:r>
-          </a:p>
-        </p:txBody>
-      </p:sp>
-      <p:sp>
-        <p:nvSpPr>
-          <p:cNvPr id="14" name="Rectangle 13"/>
-          <p:cNvSpPr/>
-          <p:nvPr/>
-        </p:nvSpPr>
-        <p:spPr>
-          <a:xfrm>
-            <a:off x="274320" y="4539996"/>
-            <a:ext cx="3611880" cy="310896"/>
-          </a:xfrm>
-          <a:prstGeom prst="rect">
-            <a:avLst/>
-          </a:prstGeom>
-          <a:solidFill>
-            <a:srgbClr val="143278"/>
-          </a:solidFill>
-          <a:ln>
-            <a:noFill/>
-          </a:ln>
-        </p:spPr>
-        <p:style>
-          <a:lnRef idx="1">
-            <a:schemeClr val="accent1"/>
-          </a:lnRef>
-          <a:fillRef idx="3">
-            <a:schemeClr val="accent1"/>
-          </a:fillRef>
-          <a:effectRef idx="2">
-            <a:schemeClr val="accent1"/>
-          </a:effectRef>
-          <a:fontRef idx="minor">
-            <a:schemeClr val="lt1"/>
-          </a:fontRef>
-        </p:style>
-        <p:txBody>
-          <a:bodyPr rtlCol="0" anchor="ctr"/>
-          <a:lstStyle/>
-          <a:p>
-            <a:pPr algn="ctr"/>
-          </a:p>
-        </p:txBody>
-      </p:sp>
-      <p:sp>
-        <p:nvSpPr>
-          <p:cNvPr id="15" name="TextBox 14"/>
-          <p:cNvSpPr txBox="1"/>
-          <p:nvPr/>
-        </p:nvSpPr>
-        <p:spPr>
-          <a:xfrm>
-            <a:off x="384048" y="4604004"/>
-            <a:ext cx="3392424" cy="219456"/>
-          </a:xfrm>
-          <a:prstGeom prst="rect">
-            <a:avLst/>
-          </a:prstGeom>
-          <a:noFill/>
-        </p:spPr>
-        <p:txBody>
-          <a:bodyPr wrap="none">
-            <a:spAutoFit/>
-          </a:bodyPr>
-          <a:lstStyle/>
-          <a:p>
-            <a:pPr algn="ctr"/>
-            <a:r>
-              <a:rPr sz="1100" b="1">
-                <a:solidFill>
-                  <a:srgbClr val="FFFFFF"/>
-                </a:solidFill>
-                <a:latin typeface="微软雅黑"/>
-                <ns8:rFonts xmlns:ns8="http://schemas.openxmlformats.org/wordprocessingml/2006/main" ns8:eastAsia="微软雅黑" ns8:ascii="微软雅黑" ns8:hAnsi="微软雅黑"/>
-              </a:rPr>
-              <a:t>紧急链路可端到端验证</a:t>
             </a:r>
           </a:p>
         </p:txBody>
@@ -8173,8 +8173,8 @@
         </p:nvSpPr>
         <p:spPr>
           <a:xfrm>
-            <a:off x="475488" y="1161288"/>
-            <a:ext cx="3300984" cy="3525012"/>
+            <a:off x="475488" y="1143000"/>
+            <a:ext cx="3300984" cy="3579876"/>
           </a:xfrm>
           <a:prstGeom prst="rect">
             <a:avLst/>
@@ -8192,7 +8192,7 @@
                 <a:spcPct val="120000"/>
               </a:lnSpc>
               <a:spcAft>
-                <a:spcPts val="6900"/>
+                <a:spcPts val="7100"/>
               </a:spcAft>
             </a:pPr>
             <a:r>
@@ -8212,7 +8212,7 @@
                 <a:spcPct val="120000"/>
               </a:lnSpc>
               <a:spcAft>
-                <a:spcPts val="6900"/>
+                <a:spcPts val="7100"/>
               </a:spcAft>
             </a:pPr>
             <a:r>
@@ -8232,7 +8232,7 @@
                 <a:spcPct val="120000"/>
               </a:lnSpc>
               <a:spcAft>
-                <a:spcPts val="6900"/>
+                <a:spcPts val="7100"/>
               </a:spcAft>
             </a:pPr>
             <a:r>
@@ -8252,7 +8252,7 @@
                 <a:spcPct val="120000"/>
               </a:lnSpc>
               <a:spcAft>
-                <a:spcPts val="6900"/>
+                <a:spcPts val="7100"/>
               </a:spcAft>
             </a:pPr>
             <a:r>
@@ -9378,7 +9378,7 @@
         <p:spPr>
           <a:xfrm>
             <a:off x="274320" y="996696"/>
-            <a:ext cx="3611880" cy="3451860"/>
+            <a:ext cx="3611880" cy="3854196"/>
           </a:xfrm>
           <a:prstGeom prst="rect">
             <a:avLst/>
@@ -9423,7 +9423,7 @@
         <p:spPr>
           <a:xfrm>
             <a:off x="274320" y="996696"/>
-            <a:ext cx="73152" cy="3451860"/>
+            <a:ext cx="73152" cy="3854196"/>
           </a:xfrm>
           <a:prstGeom prst="rect">
             <a:avLst/>
@@ -9459,14 +9459,93 @@
       </p:sp>
       <p:sp>
         <p:nvSpPr>
-          <p:cNvPr id="10" name="TextBox 9"/>
+          <p:cNvPr id="10" name="Rectangle 9"/>
+          <p:cNvSpPr/>
+          <p:nvPr/>
+        </p:nvSpPr>
+        <p:spPr>
+          <a:xfrm>
+            <a:off x="347472" y="4503420"/>
+            <a:ext cx="3465576" cy="310896"/>
+          </a:xfrm>
+          <a:prstGeom prst="rect">
+            <a:avLst/>
+          </a:prstGeom>
+          <a:solidFill>
+            <a:srgbClr val="143278"/>
+          </a:solidFill>
+          <a:ln>
+            <a:noFill/>
+          </a:ln>
+        </p:spPr>
+        <p:style>
+          <a:lnRef idx="1">
+            <a:schemeClr val="accent1"/>
+          </a:lnRef>
+          <a:fillRef idx="3">
+            <a:schemeClr val="accent1"/>
+          </a:fillRef>
+          <a:effectRef idx="2">
+            <a:schemeClr val="accent1"/>
+          </a:effectRef>
+          <a:fontRef idx="minor">
+            <a:schemeClr val="lt1"/>
+          </a:fontRef>
+        </p:style>
+        <p:txBody>
+          <a:bodyPr rtlCol="0" anchor="ctr"/>
+          <a:lstStyle/>
+          <a:p>
+            <a:pPr algn="ctr"/>
+          </a:p>
+        </p:txBody>
+      </p:sp>
+      <p:sp>
+        <p:nvSpPr>
+          <p:cNvPr id="11" name="TextBox 10"/>
           <p:cNvSpPr txBox="1"/>
           <p:nvPr/>
         </p:nvSpPr>
         <p:spPr>
           <a:xfrm>
-            <a:off x="475488" y="1161288"/>
-            <a:ext cx="3300984" cy="3122676"/>
+            <a:off x="402336" y="4576572"/>
+            <a:ext cx="3355848" cy="237744"/>
+          </a:xfrm>
+          <a:prstGeom prst="rect">
+            <a:avLst/>
+          </a:prstGeom>
+          <a:noFill/>
+        </p:spPr>
+        <p:txBody>
+          <a:bodyPr wrap="none">
+            <a:spAutoFit/>
+          </a:bodyPr>
+          <a:lstStyle/>
+          <a:p>
+            <a:pPr algn="ctr"/>
+            <a:r>
+              <a:rPr sz="1100" b="1">
+                <a:solidFill>
+                  <a:srgbClr val="FFFFFF"/>
+                </a:solidFill>
+                <a:latin typeface="微软雅黑"/>
+                <ns3:rFonts xmlns:ns3="http://schemas.openxmlformats.org/wordprocessingml/2006/main" ns3:eastAsia="微软雅黑" ns3:ascii="微软雅黑" ns3:hAnsi="微软雅黑"/>
+              </a:rPr>
+              <a:t>理论 + 工程 + 现场演示</a:t>
+            </a:r>
+          </a:p>
+        </p:txBody>
+      </p:sp>
+      <p:sp>
+        <p:nvSpPr>
+          <p:cNvPr id="12" name="TextBox 11"/>
+          <p:cNvSpPr txBox="1"/>
+          <p:nvPr/>
+        </p:nvSpPr>
+        <p:spPr>
+          <a:xfrm>
+            <a:off x="475488" y="1143000"/>
+            <a:ext cx="3300984" cy="3232404"/>
           </a:xfrm>
           <a:prstGeom prst="rect">
             <a:avLst/>
@@ -9484,7 +9563,7 @@
                 <a:spcPct val="120000"/>
               </a:lnSpc>
               <a:spcAft>
-                <a:spcPts val="4000"/>
+                <a:spcPts val="4200"/>
               </a:spcAft>
             </a:pPr>
             <a:r>
@@ -9493,7 +9572,7 @@
                   <a:srgbClr val="1C202C"/>
                 </a:solidFill>
                 <a:latin typeface="微软雅黑"/>
-                <ns3:rFonts xmlns:ns3="http://schemas.openxmlformats.org/wordprocessingml/2006/main" ns3:eastAsia="微软雅黑" ns3:ascii="微软雅黑" ns3:hAnsi="微软雅黑"/>
+                <ns4:rFonts xmlns:ns4="http://schemas.openxmlformats.org/wordprocessingml/2006/main" ns4:eastAsia="微软雅黑" ns4:ascii="微软雅黑" ns4:hAnsi="微软雅黑"/>
               </a:rPr>
               <a:t>● 第一部分  项目背景与需求分析</a:t>
             </a:r>
@@ -9504,7 +9583,7 @@
                 <a:spcPct val="120000"/>
               </a:lnSpc>
               <a:spcAft>
-                <a:spcPts val="4000"/>
+                <a:spcPts val="4200"/>
               </a:spcAft>
             </a:pPr>
             <a:r>
@@ -9513,7 +9592,7 @@
                   <a:srgbClr val="1C202C"/>
                 </a:solidFill>
                 <a:latin typeface="微软雅黑"/>
-                <ns4:rFonts xmlns:ns4="http://schemas.openxmlformats.org/wordprocessingml/2006/main" ns4:eastAsia="微软雅黑" ns4:ascii="微软雅黑" ns4:hAnsi="微软雅黑"/>
+                <ns5:rFonts xmlns:ns5="http://schemas.openxmlformats.org/wordprocessingml/2006/main" ns5:eastAsia="微软雅黑" ns5:ascii="微软雅黑" ns5:hAnsi="微软雅黑"/>
               </a:rPr>
               <a:t>● 第二部分  关键技术与理论模型</a:t>
             </a:r>
@@ -9524,7 +9603,7 @@
                 <a:spcPct val="120000"/>
               </a:lnSpc>
               <a:spcAft>
-                <a:spcPts val="4000"/>
+                <a:spcPts val="4200"/>
               </a:spcAft>
             </a:pPr>
             <a:r>
@@ -9533,7 +9612,7 @@
                   <a:srgbClr val="1C202C"/>
                 </a:solidFill>
                 <a:latin typeface="微软雅黑"/>
-                <ns5:rFonts xmlns:ns5="http://schemas.openxmlformats.org/wordprocessingml/2006/main" ns5:eastAsia="微软雅黑" ns5:ascii="微软雅黑" ns5:hAnsi="微软雅黑"/>
+                <ns6:rFonts xmlns:ns6="http://schemas.openxmlformats.org/wordprocessingml/2006/main" ns6:eastAsia="微软雅黑" ns6:ascii="微软雅黑" ns6:hAnsi="微软雅黑"/>
               </a:rPr>
               <a:t>● 第三部分  系统实现与实验验证</a:t>
             </a:r>
@@ -9544,7 +9623,7 @@
                 <a:spcPct val="120000"/>
               </a:lnSpc>
               <a:spcAft>
-                <a:spcPts val="4000"/>
+                <a:spcPts val="4200"/>
               </a:spcAft>
             </a:pPr>
             <a:r>
@@ -9553,7 +9632,7 @@
                   <a:srgbClr val="1C202C"/>
                 </a:solidFill>
                 <a:latin typeface="微软雅黑"/>
-                <ns6:rFonts xmlns:ns6="http://schemas.openxmlformats.org/wordprocessingml/2006/main" ns6:eastAsia="微软雅黑" ns6:ascii="微软雅黑" ns6:hAnsi="微软雅黑"/>
+                <ns7:rFonts xmlns:ns7="http://schemas.openxmlformats.org/wordprocessingml/2006/main" ns7:eastAsia="微软雅黑" ns7:ascii="微软雅黑" ns7:hAnsi="微软雅黑"/>
               </a:rPr>
               <a:t>● 第四部分  创新点与展望</a:t>
             </a:r>
@@ -9564,7 +9643,7 @@
                 <a:spcPct val="120000"/>
               </a:lnSpc>
               <a:spcAft>
-                <a:spcPts val="4000"/>
+                <a:spcPts val="4200"/>
               </a:spcAft>
             </a:pPr>
             <a:r>
@@ -9573,7 +9652,7 @@
                   <a:srgbClr val="1C202C"/>
                 </a:solidFill>
                 <a:latin typeface="微软雅黑"/>
-                <ns7:rFonts xmlns:ns7="http://schemas.openxmlformats.org/wordprocessingml/2006/main" ns7:eastAsia="微软雅黑" ns7:ascii="微软雅黑" ns7:hAnsi="微软雅黑"/>
+                <ns8:rFonts xmlns:ns8="http://schemas.openxmlformats.org/wordprocessingml/2006/main" ns8:eastAsia="微软雅黑" ns8:ascii="微软雅黑" ns8:hAnsi="微软雅黑"/>
               </a:rPr>
               <a:t>● 附录  演示界面与开源仓库</a:t>
             </a:r>
@@ -9582,7 +9661,7 @@
       </p:sp>
       <p:sp>
         <p:nvSpPr>
-          <p:cNvPr id="11" name="Rectangle 10"/>
+          <p:cNvPr id="13" name="Rectangle 12"/>
           <p:cNvSpPr/>
           <p:nvPr/>
         </p:nvSpPr>
@@ -9627,7 +9706,7 @@
       </p:sp>
       <p:pic>
         <p:nvPicPr>
-          <p:cNvPr id="12" name="Picture 11" descr="pipeline.png"/>
+          <p:cNvPr id="14" name="Picture 13" descr="pipeline.png"/>
           <p:cNvPicPr>
             <a:picLocks noChangeAspect="1"/>
           </p:cNvPicPr>
@@ -9651,7 +9730,7 @@
       </p:pic>
       <p:sp>
         <p:nvSpPr>
-          <p:cNvPr id="13" name="TextBox 12"/>
+          <p:cNvPr id="15" name="TextBox 14"/>
           <p:cNvSpPr txBox="1"/>
           <p:nvPr/>
         </p:nvSpPr>
@@ -9678,88 +9757,9 @@
                   <a:srgbClr val="5A6273"/>
                 </a:solidFill>
                 <a:latin typeface="微软雅黑"/>
-                <ns8:rFonts xmlns:ns8="http://schemas.openxmlformats.org/wordprocessingml/2006/main" ns8:eastAsia="微软雅黑" ns8:ascii="微软雅黑" ns8:hAnsi="微软雅黑"/>
+                <ns9:rFonts xmlns:ns9="http://schemas.openxmlformats.org/wordprocessingml/2006/main" ns9:eastAsia="微软雅黑" ns9:ascii="微软雅黑" ns9:hAnsi="微软雅黑"/>
               </a:rPr>
               <a:t>全篇结构</a:t>
-            </a:r>
-          </a:p>
-        </p:txBody>
-      </p:sp>
-      <p:sp>
-        <p:nvSpPr>
-          <p:cNvPr id="14" name="Rectangle 13"/>
-          <p:cNvSpPr/>
-          <p:nvPr/>
-        </p:nvSpPr>
-        <p:spPr>
-          <a:xfrm>
-            <a:off x="274320" y="4539996"/>
-            <a:ext cx="3611880" cy="310896"/>
-          </a:xfrm>
-          <a:prstGeom prst="rect">
-            <a:avLst/>
-          </a:prstGeom>
-          <a:solidFill>
-            <a:srgbClr val="143278"/>
-          </a:solidFill>
-          <a:ln>
-            <a:noFill/>
-          </a:ln>
-        </p:spPr>
-        <p:style>
-          <a:lnRef idx="1">
-            <a:schemeClr val="accent1"/>
-          </a:lnRef>
-          <a:fillRef idx="3">
-            <a:schemeClr val="accent1"/>
-          </a:fillRef>
-          <a:effectRef idx="2">
-            <a:schemeClr val="accent1"/>
-          </a:effectRef>
-          <a:fontRef idx="minor">
-            <a:schemeClr val="lt1"/>
-          </a:fontRef>
-        </p:style>
-        <p:txBody>
-          <a:bodyPr rtlCol="0" anchor="ctr"/>
-          <a:lstStyle/>
-          <a:p>
-            <a:pPr algn="ctr"/>
-          </a:p>
-        </p:txBody>
-      </p:sp>
-      <p:sp>
-        <p:nvSpPr>
-          <p:cNvPr id="15" name="TextBox 14"/>
-          <p:cNvSpPr txBox="1"/>
-          <p:nvPr/>
-        </p:nvSpPr>
-        <p:spPr>
-          <a:xfrm>
-            <a:off x="384048" y="4604004"/>
-            <a:ext cx="3392424" cy="219456"/>
-          </a:xfrm>
-          <a:prstGeom prst="rect">
-            <a:avLst/>
-          </a:prstGeom>
-          <a:noFill/>
-        </p:spPr>
-        <p:txBody>
-          <a:bodyPr wrap="none">
-            <a:spAutoFit/>
-          </a:bodyPr>
-          <a:lstStyle/>
-          <a:p>
-            <a:pPr algn="ctr"/>
-            <a:r>
-              <a:rPr sz="1100" b="1">
-                <a:solidFill>
-                  <a:srgbClr val="FFFFFF"/>
-                </a:solidFill>
-                <a:latin typeface="微软雅黑"/>
-                <ns9:rFonts xmlns:ns9="http://schemas.openxmlformats.org/wordprocessingml/2006/main" ns9:eastAsia="微软雅黑" ns9:ascii="微软雅黑" ns9:hAnsi="微软雅黑"/>
-              </a:rPr>
-              <a:t>理论 + 工程 + 现场演示</a:t>
             </a:r>
           </a:p>
         </p:txBody>
@@ -11503,7 +11503,7 @@
         <p:spPr>
           <a:xfrm>
             <a:off x="274320" y="996696"/>
-            <a:ext cx="3611880" cy="3451860"/>
+            <a:ext cx="3611880" cy="3854196"/>
           </a:xfrm>
           <a:prstGeom prst="rect">
             <a:avLst/>
@@ -11548,7 +11548,7 @@
         <p:spPr>
           <a:xfrm>
             <a:off x="274320" y="996696"/>
-            <a:ext cx="73152" cy="3451860"/>
+            <a:ext cx="73152" cy="3854196"/>
           </a:xfrm>
           <a:prstGeom prst="rect">
             <a:avLst/>
@@ -11584,14 +11584,93 @@
       </p:sp>
       <p:sp>
         <p:nvSpPr>
-          <p:cNvPr id="10" name="TextBox 9"/>
+          <p:cNvPr id="10" name="Rectangle 9"/>
+          <p:cNvSpPr/>
+          <p:nvPr/>
+        </p:nvSpPr>
+        <p:spPr>
+          <a:xfrm>
+            <a:off x="347472" y="4503420"/>
+            <a:ext cx="3465576" cy="310896"/>
+          </a:xfrm>
+          <a:prstGeom prst="rect">
+            <a:avLst/>
+          </a:prstGeom>
+          <a:solidFill>
+            <a:srgbClr val="143278"/>
+          </a:solidFill>
+          <a:ln>
+            <a:noFill/>
+          </a:ln>
+        </p:spPr>
+        <p:style>
+          <a:lnRef idx="1">
+            <a:schemeClr val="accent1"/>
+          </a:lnRef>
+          <a:fillRef idx="3">
+            <a:schemeClr val="accent1"/>
+          </a:fillRef>
+          <a:effectRef idx="2">
+            <a:schemeClr val="accent1"/>
+          </a:effectRef>
+          <a:fontRef idx="minor">
+            <a:schemeClr val="lt1"/>
+          </a:fontRef>
+        </p:style>
+        <p:txBody>
+          <a:bodyPr rtlCol="0" anchor="ctr"/>
+          <a:lstStyle/>
+          <a:p>
+            <a:pPr algn="ctr"/>
+          </a:p>
+        </p:txBody>
+      </p:sp>
+      <p:sp>
+        <p:nvSpPr>
+          <p:cNvPr id="11" name="TextBox 10"/>
           <p:cNvSpPr txBox="1"/>
           <p:nvPr/>
         </p:nvSpPr>
         <p:spPr>
           <a:xfrm>
-            <a:off x="475488" y="1161288"/>
-            <a:ext cx="3300984" cy="3122676"/>
+            <a:off x="402336" y="4576572"/>
+            <a:ext cx="3355848" cy="237744"/>
+          </a:xfrm>
+          <a:prstGeom prst="rect">
+            <a:avLst/>
+          </a:prstGeom>
+          <a:noFill/>
+        </p:spPr>
+        <p:txBody>
+          <a:bodyPr wrap="none">
+            <a:spAutoFit/>
+          </a:bodyPr>
+          <a:lstStyle/>
+          <a:p>
+            <a:pPr algn="ctr"/>
+            <a:r>
+              <a:rPr sz="1100" b="1">
+                <a:solidFill>
+                  <a:srgbClr val="FFFFFF"/>
+                </a:solidFill>
+                <a:latin typeface="微软雅黑"/>
+                <ns3:rFonts xmlns:ns3="http://schemas.openxmlformats.org/wordprocessingml/2006/main" ns3:eastAsia="微软雅黑" ns3:ascii="微软雅黑" ns3:hAnsi="微软雅黑"/>
+              </a:rPr>
+              <a:t>指标可复现、脚本一键运行</a:t>
+            </a:r>
+          </a:p>
+        </p:txBody>
+      </p:sp>
+      <p:sp>
+        <p:nvSpPr>
+          <p:cNvPr id="12" name="TextBox 11"/>
+          <p:cNvSpPr txBox="1"/>
+          <p:nvPr/>
+        </p:nvSpPr>
+        <p:spPr>
+          <a:xfrm>
+            <a:off x="475488" y="1143000"/>
+            <a:ext cx="3300984" cy="3232404"/>
           </a:xfrm>
           <a:prstGeom prst="rect">
             <a:avLst/>
@@ -11609,7 +11688,7 @@
                 <a:spcPct val="120000"/>
               </a:lnSpc>
               <a:spcAft>
-                <a:spcPts val="4000"/>
+                <a:spcPts val="4200"/>
               </a:spcAft>
             </a:pPr>
             <a:r>
@@ -11618,7 +11697,7 @@
                   <a:srgbClr val="1C202C"/>
                 </a:solidFill>
                 <a:latin typeface="微软雅黑"/>
-                <ns3:rFonts xmlns:ns3="http://schemas.openxmlformats.org/wordprocessingml/2006/main" ns3:eastAsia="微软雅黑" ns3:ascii="微软雅黑" ns3:hAnsi="微软雅黑"/>
+                <ns4:rFonts xmlns:ns4="http://schemas.openxmlformats.org/wordprocessingml/2006/main" ns4:eastAsia="微软雅黑" ns4:ascii="微软雅黑" ns4:hAnsi="微软雅黑"/>
               </a:rPr>
               <a:t>● 跌倒检测 P/R/F1：100%（6类合成场景）</a:t>
             </a:r>
@@ -11629,7 +11708,7 @@
                 <a:spcPct val="120000"/>
               </a:lnSpc>
               <a:spcAft>
-                <a:spcPts val="4000"/>
+                <a:spcPts val="4200"/>
               </a:spcAft>
             </a:pPr>
             <a:r>
@@ -11638,7 +11717,7 @@
                   <a:srgbClr val="1C202C"/>
                 </a:solidFill>
                 <a:latin typeface="微软雅黑"/>
-                <ns4:rFonts xmlns:ns4="http://schemas.openxmlformats.org/wordprocessingml/2006/main" ns4:eastAsia="微软雅黑" ns4:ascii="微软雅黑" ns4:hAnsi="微软雅黑"/>
+                <ns5:rFonts xmlns:ns5="http://schemas.openxmlformats.org/wordprocessingml/2006/main" ns5:eastAsia="微软雅黑" ns5:ascii="微软雅黑" ns5:hAnsi="微软雅黑"/>
               </a:rPr>
               <a:t>● 紧急呼叫端到端触发率：100%</a:t>
             </a:r>
@@ -11649,7 +11728,7 @@
                 <a:spcPct val="120000"/>
               </a:lnSpc>
               <a:spcAft>
-                <a:spcPts val="4000"/>
+                <a:spcPts val="4200"/>
               </a:spcAft>
             </a:pPr>
             <a:r>
@@ -11658,7 +11737,7 @@
                   <a:srgbClr val="1C202C"/>
                 </a:solidFill>
                 <a:latin typeface="微软雅黑"/>
-                <ns5:rFonts xmlns:ns5="http://schemas.openxmlformats.org/wordprocessingml/2006/main" ns5:eastAsia="微软雅黑" ns5:ascii="微软雅黑" ns5:hAnsi="微软雅黑"/>
+                <ns6:rFonts xmlns:ns6="http://schemas.openxmlformats.org/wordprocessingml/2006/main" ns6:eastAsia="微软雅黑" ns6:ascii="微软雅黑" ns6:hAnsi="微软雅黑"/>
               </a:rPr>
               <a:t>● 单帧决策延迟 &lt; 50ms（CPU）</a:t>
             </a:r>
@@ -11669,7 +11748,7 @@
                 <a:spcPct val="120000"/>
               </a:lnSpc>
               <a:spcAft>
-                <a:spcPts val="4000"/>
+                <a:spcPts val="4200"/>
               </a:spcAft>
             </a:pPr>
             <a:r>
@@ -11678,7 +11757,7 @@
                   <a:srgbClr val="1C202C"/>
                 </a:solidFill>
                 <a:latin typeface="微软雅黑"/>
-                <ns6:rFonts xmlns:ns6="http://schemas.openxmlformats.org/wordprocessingml/2006/main" ns6:eastAsia="微软雅黑" ns6:ascii="微软雅黑" ns6:hAnsi="微软雅黑"/>
+                <ns7:rFonts xmlns:ns7="http://schemas.openxmlformats.org/wordprocessingml/2006/main" ns7:eastAsia="微软雅黑" ns7:ascii="微软雅黑" ns7:hAnsi="微软雅黑"/>
               </a:rPr>
               <a:t>● pytest + 无头压测全部通过</a:t>
             </a:r>
@@ -11689,7 +11768,7 @@
                 <a:spcPct val="120000"/>
               </a:lnSpc>
               <a:spcAft>
-                <a:spcPts val="4000"/>
+                <a:spcPts val="4200"/>
               </a:spcAft>
             </a:pPr>
             <a:r>
@@ -11698,7 +11777,7 @@
                   <a:srgbClr val="1C202C"/>
                 </a:solidFill>
                 <a:latin typeface="微软雅黑"/>
-                <ns7:rFonts xmlns:ns7="http://schemas.openxmlformats.org/wordprocessingml/2006/main" ns7:eastAsia="微软雅黑" ns7:ascii="微软雅黑" ns7:hAnsi="微软雅黑"/>
+                <ns8:rFonts xmlns:ns8="http://schemas.openxmlformats.org/wordprocessingml/2006/main" ns8:eastAsia="微软雅黑" ns8:ascii="微软雅黑" ns8:hAnsi="微软雅黑"/>
               </a:rPr>
               <a:t>● 报告：fall_eval_report.json</a:t>
             </a:r>
@@ -11707,7 +11786,7 @@
       </p:sp>
       <p:sp>
         <p:nvSpPr>
-          <p:cNvPr id="11" name="Rectangle 10"/>
+          <p:cNvPr id="13" name="Rectangle 12"/>
           <p:cNvSpPr/>
           <p:nvPr/>
         </p:nvSpPr>
@@ -11752,7 +11831,7 @@
       </p:sp>
       <p:pic>
         <p:nvPicPr>
-          <p:cNvPr id="12" name="Picture 11" descr="metrics_chart.png"/>
+          <p:cNvPr id="14" name="Picture 13" descr="metrics_chart.png"/>
           <p:cNvPicPr>
             <a:picLocks noChangeAspect="1"/>
           </p:cNvPicPr>
@@ -11776,7 +11855,7 @@
       </p:pic>
       <p:sp>
         <p:nvSpPr>
-          <p:cNvPr id="13" name="TextBox 12"/>
+          <p:cNvPr id="15" name="TextBox 14"/>
           <p:cNvSpPr txBox="1"/>
           <p:nvPr/>
         </p:nvSpPr>
@@ -11803,88 +11882,9 @@
                   <a:srgbClr val="5A6273"/>
                 </a:solidFill>
                 <a:latin typeface="微软雅黑"/>
-                <ns8:rFonts xmlns:ns8="http://schemas.openxmlformats.org/wordprocessingml/2006/main" ns8:eastAsia="微软雅黑" ns8:ascii="微软雅黑" ns8:hAnsi="微软雅黑"/>
+                <ns9:rFonts xmlns:ns9="http://schemas.openxmlformats.org/wordprocessingml/2006/main" ns9:eastAsia="微软雅黑" ns9:ascii="微软雅黑" ns9:hAnsi="微软雅黑"/>
               </a:rPr>
               <a:t>理论框图</a:t>
-            </a:r>
-          </a:p>
-        </p:txBody>
-      </p:sp>
-      <p:sp>
-        <p:nvSpPr>
-          <p:cNvPr id="14" name="Rectangle 13"/>
-          <p:cNvSpPr/>
-          <p:nvPr/>
-        </p:nvSpPr>
-        <p:spPr>
-          <a:xfrm>
-            <a:off x="274320" y="4539996"/>
-            <a:ext cx="3611880" cy="310896"/>
-          </a:xfrm>
-          <a:prstGeom prst="rect">
-            <a:avLst/>
-          </a:prstGeom>
-          <a:solidFill>
-            <a:srgbClr val="143278"/>
-          </a:solidFill>
-          <a:ln>
-            <a:noFill/>
-          </a:ln>
-        </p:spPr>
-        <p:style>
-          <a:lnRef idx="1">
-            <a:schemeClr val="accent1"/>
-          </a:lnRef>
-          <a:fillRef idx="3">
-            <a:schemeClr val="accent1"/>
-          </a:fillRef>
-          <a:effectRef idx="2">
-            <a:schemeClr val="accent1"/>
-          </a:effectRef>
-          <a:fontRef idx="minor">
-            <a:schemeClr val="lt1"/>
-          </a:fontRef>
-        </p:style>
-        <p:txBody>
-          <a:bodyPr rtlCol="0" anchor="ctr"/>
-          <a:lstStyle/>
-          <a:p>
-            <a:pPr algn="ctr"/>
-          </a:p>
-        </p:txBody>
-      </p:sp>
-      <p:sp>
-        <p:nvSpPr>
-          <p:cNvPr id="15" name="TextBox 14"/>
-          <p:cNvSpPr txBox="1"/>
-          <p:nvPr/>
-        </p:nvSpPr>
-        <p:spPr>
-          <a:xfrm>
-            <a:off x="384048" y="4604004"/>
-            <a:ext cx="3392424" cy="219456"/>
-          </a:xfrm>
-          <a:prstGeom prst="rect">
-            <a:avLst/>
-          </a:prstGeom>
-          <a:noFill/>
-        </p:spPr>
-        <p:txBody>
-          <a:bodyPr wrap="none">
-            <a:spAutoFit/>
-          </a:bodyPr>
-          <a:lstStyle/>
-          <a:p>
-            <a:pPr algn="ctr"/>
-            <a:r>
-              <a:rPr sz="1100" b="1">
-                <a:solidFill>
-                  <a:srgbClr val="FFFFFF"/>
-                </a:solidFill>
-                <a:latin typeface="微软雅黑"/>
-                <ns9:rFonts xmlns:ns9="http://schemas.openxmlformats.org/wordprocessingml/2006/main" ns9:eastAsia="微软雅黑" ns9:ascii="微软雅黑" ns9:hAnsi="微软雅黑"/>
-              </a:rPr>
-              <a:t>指标可复现、脚本一键运行</a:t>
             </a:r>
           </a:p>
         </p:txBody>
@@ -12159,17 +12159,19 @@
         </p:nvSpPr>
         <p:spPr>
           <a:xfrm>
-            <a:off x="274320" y="4539996"/>
-            <a:ext cx="3611880" cy="310896"/>
-          </a:xfrm>
-          <a:prstGeom prst="rect">
-            <a:avLst/>
-          </a:prstGeom>
-          <a:solidFill>
-            <a:srgbClr val="143278"/>
+            <a:off x="274320" y="1042416"/>
+            <a:ext cx="3611880" cy="679399"/>
+          </a:xfrm>
+          <a:prstGeom prst="rect">
+            <a:avLst/>
+          </a:prstGeom>
+          <a:solidFill>
+            <a:srgbClr val="F1F7FF"/>
           </a:solidFill>
           <a:ln>
-            <a:noFill/>
+            <a:solidFill>
+              <a:srgbClr val="BAC8DC"/>
+            </a:solidFill>
           </a:ln>
         </p:spPr>
         <p:style>
@@ -12202,8 +12204,8 @@
         </p:nvSpPr>
         <p:spPr>
           <a:xfrm>
-            <a:off x="384048" y="4604004"/>
-            <a:ext cx="3392424" cy="219456"/>
+            <a:off x="411479" y="1097280"/>
+            <a:ext cx="914400" cy="642823"/>
           </a:xfrm>
           <a:prstGeom prst="rect">
             <a:avLst/>
@@ -12216,36 +12218,70 @@
           </a:bodyPr>
           <a:lstStyle/>
           <a:p>
-            <a:pPr algn="ctr"/>
-            <a:r>
-              <a:rPr sz="1100" b="1">
-                <a:solidFill>
-                  <a:srgbClr val="FFFFFF"/>
+            <a:r>
+              <a:rPr sz="1000" b="1">
+                <a:solidFill>
+                  <a:srgbClr val="5A6273"/>
                 </a:solidFill>
                 <a:latin typeface="微软雅黑"/>
                 <ns3:rFonts xmlns:ns3="http://schemas.openxmlformats.org/wordprocessingml/2006/main" ns3:eastAsia="微软雅黑" ns3:ascii="微软雅黑" ns3:hAnsi="微软雅黑"/>
               </a:rPr>
-              <a:t>完整源码 · 可复现演示 · 欢迎评委扫码</a:t>
-            </a:r>
-          </a:p>
-        </p:txBody>
-      </p:sp>
-      <p:sp>
-        <p:nvSpPr>
-          <p:cNvPr id="10" name="Rectangle 9"/>
+              <a:t>GitHub 仓库</a:t>
+            </a:r>
+          </a:p>
+        </p:txBody>
+      </p:sp>
+      <p:sp>
+        <p:nvSpPr>
+          <p:cNvPr id="10" name="TextBox 9"/>
+          <p:cNvSpPr txBox="1"/>
+          <p:nvPr/>
+        </p:nvSpPr>
+        <p:spPr>
+          <a:xfrm>
+            <a:off x="1280160" y="1097280"/>
+            <a:ext cx="2468880" cy="642823"/>
+          </a:xfrm>
+          <a:prstGeom prst="rect">
+            <a:avLst/>
+          </a:prstGeom>
+          <a:noFill/>
+        </p:spPr>
+        <p:txBody>
+          <a:bodyPr wrap="none">
+            <a:spAutoFit/>
+          </a:bodyPr>
+          <a:lstStyle/>
+          <a:p>
+            <a:r>
+              <a:rPr sz="900" b="0">
+                <a:solidFill>
+                  <a:srgbClr val="143278"/>
+                </a:solidFill>
+                <a:latin typeface="微软雅黑"/>
+                <ns4:rFonts xmlns:ns4="http://schemas.openxmlformats.org/wordprocessingml/2006/main" ns4:eastAsia="微软雅黑" ns4:ascii="微软雅黑" ns4:hAnsi="微软雅黑"/>
+              </a:rPr>
+              <a:t>https://github.com/FBB123571/ElderCare-Humanoid-Platform</a:t>
+            </a:r>
+          </a:p>
+        </p:txBody>
+      </p:sp>
+      <p:sp>
+        <p:nvSpPr>
+          <p:cNvPr id="11" name="Rectangle 10"/>
           <p:cNvSpPr/>
           <p:nvPr/>
         </p:nvSpPr>
         <p:spPr>
           <a:xfrm>
-            <a:off x="274320" y="1042416"/>
-            <a:ext cx="3611880" cy="598932"/>
-          </a:xfrm>
-          <a:prstGeom prst="rect">
-            <a:avLst/>
-          </a:prstGeom>
-          <a:solidFill>
-            <a:srgbClr val="F1F7FF"/>
+            <a:off x="274320" y="1794967"/>
+            <a:ext cx="3611880" cy="679399"/>
+          </a:xfrm>
+          <a:prstGeom prst="rect">
+            <a:avLst/>
+          </a:prstGeom>
+          <a:solidFill>
+            <a:srgbClr val="FFFFFF"/>
           </a:solidFill>
           <a:ln>
             <a:solidFill>
@@ -12277,14 +12313,14 @@
       </p:sp>
       <p:sp>
         <p:nvSpPr>
-          <p:cNvPr id="11" name="TextBox 10"/>
+          <p:cNvPr id="12" name="TextBox 11"/>
           <p:cNvSpPr txBox="1"/>
           <p:nvPr/>
         </p:nvSpPr>
         <p:spPr>
           <a:xfrm>
-            <a:off x="411479" y="1097280"/>
-            <a:ext cx="914400" cy="562356"/>
+            <a:off x="411479" y="1849831"/>
+            <a:ext cx="914400" cy="642823"/>
           </a:xfrm>
           <a:prstGeom prst="rect">
             <a:avLst/>
@@ -12303,23 +12339,23 @@
                   <a:srgbClr val="5A6273"/>
                 </a:solidFill>
                 <a:latin typeface="微软雅黑"/>
-                <ns4:rFonts xmlns:ns4="http://schemas.openxmlformats.org/wordprocessingml/2006/main" ns4:eastAsia="微软雅黑" ns4:ascii="微软雅黑" ns4:hAnsi="微软雅黑"/>
-              </a:rPr>
-              <a:t>GitHub 仓库</a:t>
-            </a:r>
-          </a:p>
-        </p:txBody>
-      </p:sp>
-      <p:sp>
-        <p:nvSpPr>
-          <p:cNvPr id="12" name="TextBox 11"/>
+                <ns5:rFonts xmlns:ns5="http://schemas.openxmlformats.org/wordprocessingml/2006/main" ns5:eastAsia="微软雅黑" ns5:ascii="微软雅黑" ns5:hAnsi="微软雅黑"/>
+              </a:rPr>
+              <a:t>团队</a:t>
+            </a:r>
+          </a:p>
+        </p:txBody>
+      </p:sp>
+      <p:sp>
+        <p:nvSpPr>
+          <p:cNvPr id="13" name="TextBox 12"/>
           <p:cNvSpPr txBox="1"/>
           <p:nvPr/>
         </p:nvSpPr>
         <p:spPr>
           <a:xfrm>
-            <a:off x="1280160" y="1097280"/>
-            <a:ext cx="2468880" cy="562356"/>
+            <a:off x="1280160" y="1849831"/>
+            <a:ext cx="2468880" cy="642823"/>
           </a:xfrm>
           <a:prstGeom prst="rect">
             <a:avLst/>
@@ -12333,34 +12369,34 @@
           <a:lstStyle/>
           <a:p>
             <a:r>
-              <a:rPr sz="900" b="0">
+              <a:rPr sz="1000" b="0">
                 <a:solidFill>
                   <a:srgbClr val="143278"/>
                 </a:solidFill>
                 <a:latin typeface="微软雅黑"/>
-                <ns5:rFonts xmlns:ns5="http://schemas.openxmlformats.org/wordprocessingml/2006/main" ns5:eastAsia="微软雅黑" ns5:ascii="微软雅黑" ns5:hAnsi="微软雅黑"/>
-              </a:rPr>
-              <a:t>https://github.com/FBB123571/ElderCare-Humanoid-Platform</a:t>
-            </a:r>
-          </a:p>
-        </p:txBody>
-      </p:sp>
-      <p:sp>
-        <p:nvSpPr>
-          <p:cNvPr id="13" name="Rectangle 12"/>
+                <ns6:rFonts xmlns:ns6="http://schemas.openxmlformats.org/wordprocessingml/2006/main" ns6:eastAsia="微软雅黑" ns6:ascii="微软雅黑" ns6:hAnsi="微软雅黑"/>
+              </a:rPr>
+              <a:t>从容应队（中山大学）</a:t>
+            </a:r>
+          </a:p>
+        </p:txBody>
+      </p:sp>
+      <p:sp>
+        <p:nvSpPr>
+          <p:cNvPr id="14" name="Rectangle 13"/>
           <p:cNvSpPr/>
           <p:nvPr/>
         </p:nvSpPr>
         <p:spPr>
           <a:xfrm>
-            <a:off x="274320" y="1714500"/>
-            <a:ext cx="3611880" cy="598932"/>
-          </a:xfrm>
-          <a:prstGeom prst="rect">
-            <a:avLst/>
-          </a:prstGeom>
-          <a:solidFill>
-            <a:srgbClr val="FFFFFF"/>
+            <a:off x="274320" y="2547518"/>
+            <a:ext cx="3611880" cy="679399"/>
+          </a:xfrm>
+          <a:prstGeom prst="rect">
+            <a:avLst/>
+          </a:prstGeom>
+          <a:solidFill>
+            <a:srgbClr val="F1F7FF"/>
           </a:solidFill>
           <a:ln>
             <a:solidFill>
@@ -12392,14 +12428,14 @@
       </p:sp>
       <p:sp>
         <p:nvSpPr>
-          <p:cNvPr id="14" name="TextBox 13"/>
+          <p:cNvPr id="15" name="TextBox 14"/>
           <p:cNvSpPr txBox="1"/>
           <p:nvPr/>
         </p:nvSpPr>
         <p:spPr>
           <a:xfrm>
-            <a:off x="411479" y="1769364"/>
-            <a:ext cx="914400" cy="562356"/>
+            <a:off x="411479" y="2602382"/>
+            <a:ext cx="914400" cy="642823"/>
           </a:xfrm>
           <a:prstGeom prst="rect">
             <a:avLst/>
@@ -12418,23 +12454,23 @@
                   <a:srgbClr val="5A6273"/>
                 </a:solidFill>
                 <a:latin typeface="微软雅黑"/>
-                <ns6:rFonts xmlns:ns6="http://schemas.openxmlformats.org/wordprocessingml/2006/main" ns6:eastAsia="微软雅黑" ns6:ascii="微软雅黑" ns6:hAnsi="微软雅黑"/>
-              </a:rPr>
-              <a:t>团队</a:t>
-            </a:r>
-          </a:p>
-        </p:txBody>
-      </p:sp>
-      <p:sp>
-        <p:nvSpPr>
-          <p:cNvPr id="15" name="TextBox 14"/>
+                <ns7:rFonts xmlns:ns7="http://schemas.openxmlformats.org/wordprocessingml/2006/main" ns7:eastAsia="微软雅黑" ns7:ascii="微软雅黑" ns7:hAnsi="微软雅黑"/>
+              </a:rPr>
+              <a:t>本地演示</a:t>
+            </a:r>
+          </a:p>
+        </p:txBody>
+      </p:sp>
+      <p:sp>
+        <p:nvSpPr>
+          <p:cNvPr id="16" name="TextBox 15"/>
           <p:cNvSpPr txBox="1"/>
           <p:nvPr/>
         </p:nvSpPr>
         <p:spPr>
           <a:xfrm>
-            <a:off x="1280160" y="1769364"/>
-            <a:ext cx="2468880" cy="562356"/>
+            <a:off x="1280160" y="2602382"/>
+            <a:ext cx="2468880" cy="642823"/>
           </a:xfrm>
           <a:prstGeom prst="rect">
             <a:avLst/>
@@ -12453,29 +12489,29 @@
                   <a:srgbClr val="143278"/>
                 </a:solidFill>
                 <a:latin typeface="微软雅黑"/>
-                <ns7:rFonts xmlns:ns7="http://schemas.openxmlformats.org/wordprocessingml/2006/main" ns7:eastAsia="微软雅黑" ns7:ascii="微软雅黑" ns7:hAnsi="微软雅黑"/>
-              </a:rPr>
-              <a:t>从容应队（中山大学）</a:t>
-            </a:r>
-          </a:p>
-        </p:txBody>
-      </p:sp>
-      <p:sp>
-        <p:nvSpPr>
-          <p:cNvPr id="16" name="Rectangle 15"/>
+                <ns8:rFonts xmlns:ns8="http://schemas.openxmlformats.org/wordprocessingml/2006/main" ns8:eastAsia="微软雅黑" ns8:ascii="微软雅黑" ns8:hAnsi="微软雅黑"/>
+              </a:rPr>
+              <a:t>bash scripts/run_web.sh</a:t>
+            </a:r>
+          </a:p>
+        </p:txBody>
+      </p:sp>
+      <p:sp>
+        <p:nvSpPr>
+          <p:cNvPr id="17" name="Rectangle 16"/>
           <p:cNvSpPr/>
           <p:nvPr/>
         </p:nvSpPr>
         <p:spPr>
           <a:xfrm>
-            <a:off x="274320" y="2386584"/>
-            <a:ext cx="3611880" cy="598932"/>
-          </a:xfrm>
-          <a:prstGeom prst="rect">
-            <a:avLst/>
-          </a:prstGeom>
-          <a:solidFill>
-            <a:srgbClr val="F1F7FF"/>
+            <a:off x="274320" y="3300069"/>
+            <a:ext cx="3611880" cy="679399"/>
+          </a:xfrm>
+          <a:prstGeom prst="rect">
+            <a:avLst/>
+          </a:prstGeom>
+          <a:solidFill>
+            <a:srgbClr val="FFFFFF"/>
           </a:solidFill>
           <a:ln>
             <a:solidFill>
@@ -12507,14 +12543,14 @@
       </p:sp>
       <p:sp>
         <p:nvSpPr>
-          <p:cNvPr id="17" name="TextBox 16"/>
+          <p:cNvPr id="18" name="TextBox 17"/>
           <p:cNvSpPr txBox="1"/>
           <p:nvPr/>
         </p:nvSpPr>
         <p:spPr>
           <a:xfrm>
-            <a:off x="411479" y="2441448"/>
-            <a:ext cx="914400" cy="562356"/>
+            <a:off x="411479" y="3354933"/>
+            <a:ext cx="914400" cy="642823"/>
           </a:xfrm>
           <a:prstGeom prst="rect">
             <a:avLst/>
@@ -12533,23 +12569,23 @@
                   <a:srgbClr val="5A6273"/>
                 </a:solidFill>
                 <a:latin typeface="微软雅黑"/>
-                <ns8:rFonts xmlns:ns8="http://schemas.openxmlformats.org/wordprocessingml/2006/main" ns8:eastAsia="微软雅黑" ns8:ascii="微软雅黑" ns8:hAnsi="微软雅黑"/>
-              </a:rPr>
-              <a:t>本地演示</a:t>
-            </a:r>
-          </a:p>
-        </p:txBody>
-      </p:sp>
-      <p:sp>
-        <p:nvSpPr>
-          <p:cNvPr id="18" name="TextBox 17"/>
+                <ns9:rFonts xmlns:ns9="http://schemas.openxmlformats.org/wordprocessingml/2006/main" ns9:eastAsia="微软雅黑" ns9:ascii="微软雅黑" ns9:hAnsi="微软雅黑"/>
+              </a:rPr>
+              <a:t>演示录像</a:t>
+            </a:r>
+          </a:p>
+        </p:txBody>
+      </p:sp>
+      <p:sp>
+        <p:nvSpPr>
+          <p:cNvPr id="19" name="TextBox 18"/>
           <p:cNvSpPr txBox="1"/>
           <p:nvPr/>
         </p:nvSpPr>
         <p:spPr>
           <a:xfrm>
-            <a:off x="1280160" y="2441448"/>
-            <a:ext cx="2468880" cy="562356"/>
+            <a:off x="1280160" y="3354933"/>
+            <a:ext cx="2468880" cy="642823"/>
           </a:xfrm>
           <a:prstGeom prst="rect">
             <a:avLst/>
@@ -12568,29 +12604,29 @@
                   <a:srgbClr val="143278"/>
                 </a:solidFill>
                 <a:latin typeface="微软雅黑"/>
-                <ns9:rFonts xmlns:ns9="http://schemas.openxmlformats.org/wordprocessingml/2006/main" ns9:eastAsia="微软雅黑" ns9:ascii="微软雅黑" ns9:hAnsi="微软雅黑"/>
-              </a:rPr>
-              <a:t>bash scripts/run_web.sh</a:t>
-            </a:r>
-          </a:p>
-        </p:txBody>
-      </p:sp>
-      <p:sp>
-        <p:nvSpPr>
-          <p:cNvPr id="19" name="Rectangle 18"/>
+                <ns10:rFonts xmlns:ns10="http://schemas.openxmlformats.org/wordprocessingml/2006/main" ns10:eastAsia="微软雅黑" ns10:ascii="微软雅黑" ns10:hAnsi="微软雅黑"/>
+              </a:rPr>
+              <a:t>docs/assets/demo_carecompanion.mp4</a:t>
+            </a:r>
+          </a:p>
+        </p:txBody>
+      </p:sp>
+      <p:sp>
+        <p:nvSpPr>
+          <p:cNvPr id="20" name="Rectangle 19"/>
           <p:cNvSpPr/>
           <p:nvPr/>
         </p:nvSpPr>
         <p:spPr>
           <a:xfrm>
-            <a:off x="274320" y="3058668"/>
-            <a:ext cx="3611880" cy="598932"/>
-          </a:xfrm>
-          <a:prstGeom prst="rect">
-            <a:avLst/>
-          </a:prstGeom>
-          <a:solidFill>
-            <a:srgbClr val="FFFFFF"/>
+            <a:off x="274320" y="4052620"/>
+            <a:ext cx="3611880" cy="679399"/>
+          </a:xfrm>
+          <a:prstGeom prst="rect">
+            <a:avLst/>
+          </a:prstGeom>
+          <a:solidFill>
+            <a:srgbClr val="F1F7FF"/>
           </a:solidFill>
           <a:ln>
             <a:solidFill>
@@ -12622,14 +12658,14 @@
       </p:sp>
       <p:sp>
         <p:nvSpPr>
-          <p:cNvPr id="20" name="TextBox 19"/>
+          <p:cNvPr id="21" name="TextBox 20"/>
           <p:cNvSpPr txBox="1"/>
           <p:nvPr/>
         </p:nvSpPr>
         <p:spPr>
           <a:xfrm>
-            <a:off x="411479" y="3113532"/>
-            <a:ext cx="914400" cy="562356"/>
+            <a:off x="411479" y="4107484"/>
+            <a:ext cx="914400" cy="642823"/>
           </a:xfrm>
           <a:prstGeom prst="rect">
             <a:avLst/>
@@ -12648,23 +12684,23 @@
                   <a:srgbClr val="5A6273"/>
                 </a:solidFill>
                 <a:latin typeface="微软雅黑"/>
-                <ns10:rFonts xmlns:ns10="http://schemas.openxmlformats.org/wordprocessingml/2006/main" ns10:eastAsia="微软雅黑" ns10:ascii="微软雅黑" ns10:hAnsi="微软雅黑"/>
-              </a:rPr>
-              <a:t>演示录像</a:t>
-            </a:r>
-          </a:p>
-        </p:txBody>
-      </p:sp>
-      <p:sp>
-        <p:nvSpPr>
-          <p:cNvPr id="21" name="TextBox 20"/>
+                <ns11:rFonts xmlns:ns11="http://schemas.openxmlformats.org/wordprocessingml/2006/main" ns11:eastAsia="微软雅黑" ns11:ascii="微软雅黑" ns11:hAnsi="微软雅黑"/>
+              </a:rPr>
+              <a:t>软著</a:t>
+            </a:r>
+          </a:p>
+        </p:txBody>
+      </p:sp>
+      <p:sp>
+        <p:nvSpPr>
+          <p:cNvPr id="22" name="TextBox 21"/>
           <p:cNvSpPr txBox="1"/>
           <p:nvPr/>
         </p:nvSpPr>
         <p:spPr>
           <a:xfrm>
-            <a:off x="1280160" y="3113532"/>
-            <a:ext cx="2468880" cy="562356"/>
+            <a:off x="1280160" y="4107484"/>
+            <a:ext cx="2468880" cy="642823"/>
           </a:xfrm>
           <a:prstGeom prst="rect">
             <a:avLst/>
@@ -12683,31 +12719,31 @@
                   <a:srgbClr val="143278"/>
                 </a:solidFill>
                 <a:latin typeface="微软雅黑"/>
-                <ns11:rFonts xmlns:ns11="http://schemas.openxmlformats.org/wordprocessingml/2006/main" ns11:eastAsia="微软雅黑" ns11:ascii="微软雅黑" ns11:hAnsi="微软雅黑"/>
-              </a:rPr>
-              <a:t>docs/assets/demo_carecompanion.mp4</a:t>
-            </a:r>
-          </a:p>
-        </p:txBody>
-      </p:sp>
-      <p:sp>
-        <p:nvSpPr>
-          <p:cNvPr id="22" name="Rectangle 21"/>
+                <ns12:rFonts xmlns:ns12="http://schemas.openxmlformats.org/wordprocessingml/2006/main" ns12:eastAsia="微软雅黑" ns12:ascii="微软雅黑" ns12:hAnsi="微软雅黑"/>
+              </a:rPr>
+              <a:t>申请中</a:t>
+            </a:r>
+          </a:p>
+        </p:txBody>
+      </p:sp>
+      <p:sp>
+        <p:nvSpPr>
+          <p:cNvPr id="23" name="Rectangle 22"/>
           <p:cNvSpPr/>
           <p:nvPr/>
         </p:nvSpPr>
         <p:spPr>
           <a:xfrm>
-            <a:off x="274320" y="3730752"/>
-            <a:ext cx="3611880" cy="598932"/>
-          </a:xfrm>
-          <a:prstGeom prst="rect">
-            <a:avLst/>
-          </a:prstGeom>
-          <a:solidFill>
-            <a:srgbClr val="F1F7FF"/>
-          </a:solidFill>
-          <a:ln>
+            <a:off x="4251960" y="1024128"/>
+            <a:ext cx="1737360" cy="1920240"/>
+          </a:xfrm>
+          <a:prstGeom prst="rect">
+            <a:avLst/>
+          </a:prstGeom>
+          <a:solidFill>
+            <a:srgbClr val="FFFFFF"/>
+          </a:solidFill>
+          <a:ln w="10160">
             <a:solidFill>
               <a:srgbClr val="BAC8DC"/>
             </a:solidFill>
@@ -12735,124 +12771,9 @@
           </a:p>
         </p:txBody>
       </p:sp>
-      <p:sp>
-        <p:nvSpPr>
-          <p:cNvPr id="23" name="TextBox 22"/>
-          <p:cNvSpPr txBox="1"/>
-          <p:nvPr/>
-        </p:nvSpPr>
-        <p:spPr>
-          <a:xfrm>
-            <a:off x="411479" y="3785615"/>
-            <a:ext cx="914400" cy="562356"/>
-          </a:xfrm>
-          <a:prstGeom prst="rect">
-            <a:avLst/>
-          </a:prstGeom>
-          <a:noFill/>
-        </p:spPr>
-        <p:txBody>
-          <a:bodyPr wrap="none">
-            <a:spAutoFit/>
-          </a:bodyPr>
-          <a:lstStyle/>
-          <a:p>
-            <a:r>
-              <a:rPr sz="1000" b="1">
-                <a:solidFill>
-                  <a:srgbClr val="5A6273"/>
-                </a:solidFill>
-                <a:latin typeface="微软雅黑"/>
-                <ns12:rFonts xmlns:ns12="http://schemas.openxmlformats.org/wordprocessingml/2006/main" ns12:eastAsia="微软雅黑" ns12:ascii="微软雅黑" ns12:hAnsi="微软雅黑"/>
-              </a:rPr>
-              <a:t>软著</a:t>
-            </a:r>
-          </a:p>
-        </p:txBody>
-      </p:sp>
-      <p:sp>
-        <p:nvSpPr>
-          <p:cNvPr id="24" name="TextBox 23"/>
-          <p:cNvSpPr txBox="1"/>
-          <p:nvPr/>
-        </p:nvSpPr>
-        <p:spPr>
-          <a:xfrm>
-            <a:off x="1280160" y="3785615"/>
-            <a:ext cx="2468880" cy="562356"/>
-          </a:xfrm>
-          <a:prstGeom prst="rect">
-            <a:avLst/>
-          </a:prstGeom>
-          <a:noFill/>
-        </p:spPr>
-        <p:txBody>
-          <a:bodyPr wrap="none">
-            <a:spAutoFit/>
-          </a:bodyPr>
-          <a:lstStyle/>
-          <a:p>
-            <a:r>
-              <a:rPr sz="1000" b="0">
-                <a:solidFill>
-                  <a:srgbClr val="143278"/>
-                </a:solidFill>
-                <a:latin typeface="微软雅黑"/>
-                <ns13:rFonts xmlns:ns13="http://schemas.openxmlformats.org/wordprocessingml/2006/main" ns13:eastAsia="微软雅黑" ns13:ascii="微软雅黑" ns13:hAnsi="微软雅黑"/>
-              </a:rPr>
-              <a:t>申请中</a:t>
-            </a:r>
-          </a:p>
-        </p:txBody>
-      </p:sp>
-      <p:sp>
-        <p:nvSpPr>
-          <p:cNvPr id="25" name="Rectangle 24"/>
-          <p:cNvSpPr/>
-          <p:nvPr/>
-        </p:nvSpPr>
-        <p:spPr>
-          <a:xfrm>
-            <a:off x="4251960" y="1024128"/>
-            <a:ext cx="1737360" cy="1920240"/>
-          </a:xfrm>
-          <a:prstGeom prst="rect">
-            <a:avLst/>
-          </a:prstGeom>
-          <a:solidFill>
-            <a:srgbClr val="FFFFFF"/>
-          </a:solidFill>
-          <a:ln w="10160">
-            <a:solidFill>
-              <a:srgbClr val="BAC8DC"/>
-            </a:solidFill>
-          </a:ln>
-        </p:spPr>
-        <p:style>
-          <a:lnRef idx="1">
-            <a:schemeClr val="accent1"/>
-          </a:lnRef>
-          <a:fillRef idx="3">
-            <a:schemeClr val="accent1"/>
-          </a:fillRef>
-          <a:effectRef idx="2">
-            <a:schemeClr val="accent1"/>
-          </a:effectRef>
-          <a:fontRef idx="minor">
-            <a:schemeClr val="lt1"/>
-          </a:fontRef>
-        </p:style>
-        <p:txBody>
-          <a:bodyPr rtlCol="0" anchor="ctr"/>
-          <a:lstStyle/>
-          <a:p>
-            <a:pPr algn="ctr"/>
-          </a:p>
-        </p:txBody>
-      </p:sp>
       <p:pic>
         <p:nvPicPr>
-          <p:cNvPr id="26" name="Picture 25" descr="ppt_demo_qr.png"/>
+          <p:cNvPr id="24" name="Picture 23" descr="ppt_demo_qr.png"/>
           <p:cNvPicPr>
             <a:picLocks noChangeAspect="1"/>
           </p:cNvPicPr>
@@ -12876,7 +12797,7 @@
       </p:pic>
       <p:sp>
         <p:nvSpPr>
-          <p:cNvPr id="27" name="TextBox 26"/>
+          <p:cNvPr id="25" name="TextBox 24"/>
           <p:cNvSpPr txBox="1"/>
           <p:nvPr/>
         </p:nvSpPr>
@@ -12903,7 +12824,7 @@
                   <a:srgbClr val="5A6273"/>
                 </a:solidFill>
                 <a:latin typeface="微软雅黑"/>
-                <ns14:rFonts xmlns:ns14="http://schemas.openxmlformats.org/wordprocessingml/2006/main" ns14:eastAsia="微软雅黑" ns14:ascii="微软雅黑" ns14:hAnsi="微软雅黑"/>
+                <ns13:rFonts xmlns:ns13="http://schemas.openxmlformats.org/wordprocessingml/2006/main" ns13:eastAsia="微软雅黑" ns13:ascii="微软雅黑" ns13:hAnsi="微软雅黑"/>
               </a:rPr>
               <a:t>扫码访问</a:t>
             </a:r>
@@ -12912,13 +12833,13 @@
       </p:sp>
       <p:sp>
         <p:nvSpPr>
-          <p:cNvPr id="28" name="Rectangle 27"/>
+          <p:cNvPr id="26" name="Rectangle 25"/>
           <p:cNvSpPr/>
           <p:nvPr/>
         </p:nvSpPr>
         <p:spPr>
           <a:xfrm>
-            <a:off x="6222492" y="1956030"/>
+            <a:off x="6222492" y="2157198"/>
             <a:ext cx="2505456" cy="1533191"/>
           </a:xfrm>
           <a:prstGeom prst="rect">
@@ -12957,7 +12878,7 @@
       </p:sp>
       <p:pic>
         <p:nvPicPr>
-          <p:cNvPr id="29" name="Picture 28" descr="ppt_full_dashboard.png"/>
+          <p:cNvPr id="27" name="Picture 26" descr="ppt_full_dashboard.png"/>
           <p:cNvPicPr>
             <a:picLocks noChangeAspect="1"/>
           </p:cNvPicPr>
@@ -12971,7 +12892,7 @@
         </p:blipFill>
         <p:spPr>
           <a:xfrm>
-            <a:off x="6268212" y="2001750"/>
+            <a:off x="6268212" y="2202918"/>
             <a:ext cx="2414015" cy="1258871"/>
           </a:xfrm>
           <a:prstGeom prst="rect">
@@ -12981,13 +12902,13 @@
       </p:pic>
       <p:sp>
         <p:nvSpPr>
-          <p:cNvPr id="30" name="TextBox 29"/>
+          <p:cNvPr id="28" name="TextBox 27"/>
           <p:cNvSpPr txBox="1"/>
           <p:nvPr/>
         </p:nvSpPr>
         <p:spPr>
           <a:xfrm>
-            <a:off x="6217920" y="3315485"/>
+            <a:off x="6217920" y="3516653"/>
             <a:ext cx="2514600" cy="182880"/>
           </a:xfrm>
           <a:prstGeom prst="rect">
@@ -13008,7 +12929,7 @@
                   <a:srgbClr val="5A6273"/>
                 </a:solidFill>
                 <a:latin typeface="微软雅黑"/>
-                <ns15:rFonts xmlns:ns15="http://schemas.openxmlformats.org/wordprocessingml/2006/main" ns15:eastAsia="微软雅黑" ns15:ascii="微软雅黑" ns15:hAnsi="微软雅黑"/>
+                <ns14:rFonts xmlns:ns14="http://schemas.openxmlformats.org/wordprocessingml/2006/main" ns14:eastAsia="微软雅黑" ns14:ascii="微软雅黑" ns14:hAnsi="微软雅黑"/>
               </a:rPr>
               <a:t>Web 控制台实拍</a:t>
             </a:r>
@@ -14055,8 +13976,8 @@
         </p:nvSpPr>
         <p:spPr>
           <a:xfrm>
-            <a:off x="475488" y="1161288"/>
-            <a:ext cx="3300984" cy="3525012"/>
+            <a:off x="475488" y="1143000"/>
+            <a:ext cx="3300984" cy="3579876"/>
           </a:xfrm>
           <a:prstGeom prst="rect">
             <a:avLst/>
@@ -14074,7 +13995,7 @@
                 <a:spcPct val="120000"/>
               </a:lnSpc>
               <a:spcAft>
-                <a:spcPts val="4800"/>
+                <a:spcPts val="4900"/>
               </a:spcAft>
             </a:pPr>
             <a:r>
@@ -14094,7 +14015,7 @@
                 <a:spcPct val="120000"/>
               </a:lnSpc>
               <a:spcAft>
-                <a:spcPts val="4800"/>
+                <a:spcPts val="4900"/>
               </a:spcAft>
             </a:pPr>
             <a:r>
@@ -14114,7 +14035,7 @@
                 <a:spcPct val="120000"/>
               </a:lnSpc>
               <a:spcAft>
-                <a:spcPts val="4800"/>
+                <a:spcPts val="4900"/>
               </a:spcAft>
             </a:pPr>
             <a:r>
@@ -14134,7 +14055,7 @@
                 <a:spcPct val="120000"/>
               </a:lnSpc>
               <a:spcAft>
-                <a:spcPts val="4800"/>
+                <a:spcPts val="4900"/>
               </a:spcAft>
             </a:pPr>
             <a:r>
@@ -14154,7 +14075,7 @@
                 <a:spcPct val="120000"/>
               </a:lnSpc>
               <a:spcAft>
-                <a:spcPts val="4800"/>
+                <a:spcPts val="4900"/>
               </a:spcAft>
             </a:pPr>
             <a:r>
@@ -14633,8 +14554,8 @@
         </p:nvSpPr>
         <p:spPr>
           <a:xfrm>
-            <a:off x="475488" y="1161288"/>
-            <a:ext cx="3300984" cy="3525012"/>
+            <a:off x="475488" y="1143000"/>
+            <a:ext cx="3300984" cy="3579876"/>
           </a:xfrm>
           <a:prstGeom prst="rect">
             <a:avLst/>
@@ -14652,7 +14573,7 @@
                 <a:spcPct val="120000"/>
               </a:lnSpc>
               <a:spcAft>
-                <a:spcPts val="4800"/>
+                <a:spcPts val="4900"/>
               </a:spcAft>
             </a:pPr>
             <a:r>
@@ -14672,7 +14593,7 @@
                 <a:spcPct val="120000"/>
               </a:lnSpc>
               <a:spcAft>
-                <a:spcPts val="4800"/>
+                <a:spcPts val="4900"/>
               </a:spcAft>
             </a:pPr>
             <a:r>
@@ -14692,7 +14613,7 @@
                 <a:spcPct val="120000"/>
               </a:lnSpc>
               <a:spcAft>
-                <a:spcPts val="4800"/>
+                <a:spcPts val="4900"/>
               </a:spcAft>
             </a:pPr>
             <a:r>
@@ -14712,7 +14633,7 @@
                 <a:spcPct val="120000"/>
               </a:lnSpc>
               <a:spcAft>
-                <a:spcPts val="4800"/>
+                <a:spcPts val="4900"/>
               </a:spcAft>
             </a:pPr>
             <a:r>
@@ -14732,7 +14653,7 @@
                 <a:spcPct val="120000"/>
               </a:lnSpc>
               <a:spcAft>
-                <a:spcPts val="4800"/>
+                <a:spcPts val="4900"/>
               </a:spcAft>
             </a:pPr>
             <a:r>
@@ -15211,8 +15132,8 @@
         </p:nvSpPr>
         <p:spPr>
           <a:xfrm>
-            <a:off x="475488" y="1161288"/>
-            <a:ext cx="3300984" cy="3525012"/>
+            <a:off x="475488" y="1143000"/>
+            <a:ext cx="3300984" cy="3579876"/>
           </a:xfrm>
           <a:prstGeom prst="rect">
             <a:avLst/>
@@ -15230,7 +15151,7 @@
                 <a:spcPct val="120000"/>
               </a:lnSpc>
               <a:spcAft>
-                <a:spcPts val="4800"/>
+                <a:spcPts val="4900"/>
               </a:spcAft>
             </a:pPr>
             <a:r>
@@ -15250,7 +15171,7 @@
                 <a:spcPct val="120000"/>
               </a:lnSpc>
               <a:spcAft>
-                <a:spcPts val="4800"/>
+                <a:spcPts val="4900"/>
               </a:spcAft>
             </a:pPr>
             <a:r>
@@ -15270,7 +15191,7 @@
                 <a:spcPct val="120000"/>
               </a:lnSpc>
               <a:spcAft>
-                <a:spcPts val="4800"/>
+                <a:spcPts val="4900"/>
               </a:spcAft>
             </a:pPr>
             <a:r>
@@ -15290,7 +15211,7 @@
                 <a:spcPct val="120000"/>
               </a:lnSpc>
               <a:spcAft>
-                <a:spcPts val="4800"/>
+                <a:spcPts val="4900"/>
               </a:spcAft>
             </a:pPr>
             <a:r>
@@ -15310,7 +15231,7 @@
                 <a:spcPct val="120000"/>
               </a:lnSpc>
               <a:spcAft>
-                <a:spcPts val="4800"/>
+                <a:spcPts val="4900"/>
               </a:spcAft>
             </a:pPr>
             <a:r>
@@ -15789,8 +15710,8 @@
         </p:nvSpPr>
         <p:spPr>
           <a:xfrm>
-            <a:off x="475488" y="1161288"/>
-            <a:ext cx="3300984" cy="3525012"/>
+            <a:off x="475488" y="1143000"/>
+            <a:ext cx="3300984" cy="3579876"/>
           </a:xfrm>
           <a:prstGeom prst="rect">
             <a:avLst/>
@@ -15808,7 +15729,7 @@
                 <a:spcPct val="120000"/>
               </a:lnSpc>
               <a:spcAft>
-                <a:spcPts val="3500"/>
+                <a:spcPts val="11500"/>
               </a:spcAft>
             </a:pPr>
             <a:r>
@@ -15819,7 +15740,7 @@
                 <a:latin typeface="微软雅黑"/>
                 <ns3:rFonts xmlns:ns3="http://schemas.openxmlformats.org/wordprocessingml/2006/main" ns3:eastAsia="微软雅黑" ns3:ascii="微软雅黑" ns3:hAnsi="微软雅黑"/>
               </a:rPr>
-              <a:t>● 作品：基于大语言模型的智能养老陪伴机器人仿真平台</a:t>
+              <a:t>● 赛项：创新赛 · 机器人创新赛道</a:t>
             </a:r>
           </a:p>
           <a:p>
@@ -15828,7 +15749,7 @@
                 <a:spcPct val="120000"/>
               </a:lnSpc>
               <a:spcAft>
-                <a:spcPts val="3500"/>
+                <a:spcPts val="11500"/>
               </a:spcAft>
             </a:pPr>
             <a:r>
@@ -15839,7 +15760,7 @@
                 <a:latin typeface="微软雅黑"/>
                 <ns4:rFonts xmlns:ns4="http://schemas.openxmlformats.org/wordprocessingml/2006/main" ns4:eastAsia="微软雅黑" ns4:ascii="微软雅黑" ns4:hAnsi="微软雅黑"/>
               </a:rPr>
-              <a:t>● 赛项：创新赛 · 机器人创新赛道</a:t>
+              <a:t>● 作品：基于大语言模型的智能养老陪伴机器人仿真平台</a:t>
             </a:r>
           </a:p>
           <a:p>
@@ -15848,7 +15769,7 @@
                 <a:spcPct val="120000"/>
               </a:lnSpc>
               <a:spcAft>
-                <a:spcPts val="3500"/>
+                <a:spcPts val="11500"/>
               </a:spcAft>
             </a:pPr>
             <a:r>
@@ -15859,67 +15780,7 @@
                 <a:latin typeface="微软雅黑"/>
                 <ns5:rFonts xmlns:ns5="http://schemas.openxmlformats.org/wordprocessingml/2006/main" ns5:eastAsia="微软雅黑" ns5:ascii="微软雅黑" ns5:hAnsi="微软雅黑"/>
               </a:rPr>
-              <a:t>● 团队编号：CRAIC2026-TEAM-8FJQKLMI</a:t>
-            </a:r>
-          </a:p>
-          <a:p>
-            <a:pPr>
-              <a:lnSpc>
-                <a:spcPct val="120000"/>
-              </a:lnSpc>
-              <a:spcAft>
-                <a:spcPts val="3500"/>
-              </a:spcAft>
-            </a:pPr>
-            <a:r>
-              <a:rPr sz="1300" b="0">
-                <a:solidFill>
-                  <a:srgbClr val="1C202C"/>
-                </a:solidFill>
-                <a:latin typeface="微软雅黑"/>
-                <ns6:rFonts xmlns:ns6="http://schemas.openxmlformats.org/wordprocessingml/2006/main" ns6:eastAsia="微软雅黑" ns6:ascii="微软雅黑" ns6:hAnsi="微软雅黑"/>
-              </a:rPr>
-              <a:t>● 作品编号：CRAIC20264ZEFT1DF</a:t>
-            </a:r>
-          </a:p>
-          <a:p>
-            <a:pPr>
-              <a:lnSpc>
-                <a:spcPct val="120000"/>
-              </a:lnSpc>
-              <a:spcAft>
-                <a:spcPts val="3500"/>
-              </a:spcAft>
-            </a:pPr>
-            <a:r>
-              <a:rPr sz="1300" b="0">
-                <a:solidFill>
-                  <a:srgbClr val="1C202C"/>
-                </a:solidFill>
-                <a:latin typeface="微软雅黑"/>
-                <ns7:rFonts xmlns:ns7="http://schemas.openxmlformats.org/wordprocessingml/2006/main" ns7:eastAsia="微软雅黑" ns7:ascii="微软雅黑" ns7:hAnsi="微软雅黑"/>
-              </a:rPr>
-              <a:t>● 队员：刘小凡（队长）、白冉</a:t>
-            </a:r>
-          </a:p>
-          <a:p>
-            <a:pPr>
-              <a:lnSpc>
-                <a:spcPct val="120000"/>
-              </a:lnSpc>
-              <a:spcAft>
-                <a:spcPts val="3500"/>
-              </a:spcAft>
-            </a:pPr>
-            <a:r>
-              <a:rPr sz="1300" b="0">
-                <a:solidFill>
-                  <a:srgbClr val="1C202C"/>
-                </a:solidFill>
-                <a:latin typeface="微软雅黑"/>
-                <ns8:rFonts xmlns:ns8="http://schemas.openxmlformats.org/wordprocessingml/2006/main" ns8:eastAsia="微软雅黑" ns8:ascii="微软雅黑" ns8:hAnsi="微软雅黑"/>
-              </a:rPr>
-              <a:t>● 指导教师：彭键清</a:t>
+              <a:t>● 特色：理论可讲清 · 系统可演示 · 指标可复现</a:t>
             </a:r>
           </a:p>
         </p:txBody>
@@ -15932,8 +15793,8 @@
         </p:nvSpPr>
         <p:spPr>
           <a:xfrm>
-            <a:off x="4710992" y="1005840"/>
-            <a:ext cx="3516775" cy="3835908"/>
+            <a:off x="4069080" y="996696"/>
+            <a:ext cx="4800600" cy="3854196"/>
           </a:xfrm>
           <a:prstGeom prst="rect">
             <a:avLst/>
@@ -15941,7 +15802,7 @@
           <a:solidFill>
             <a:srgbClr val="FFFFFF"/>
           </a:solidFill>
-          <a:ln w="10160">
+          <a:ln w="12700">
             <a:solidFill>
               <a:srgbClr val="BAC8DC"/>
             </a:solidFill>
@@ -15969,30 +15830,49 @@
           </a:p>
         </p:txBody>
       </p:sp>
-      <p:pic>
-        <p:nvPicPr>
-          <p:cNvPr id="12" name="Picture 11" descr="team_card.png"/>
-          <p:cNvPicPr>
-            <a:picLocks noChangeAspect="1"/>
-          </p:cNvPicPr>
-          <p:nvPr/>
-        </p:nvPicPr>
-        <p:blipFill>
-          <a:blip r:embed="rId2"/>
-          <a:stretch>
-            <a:fillRect/>
-          </a:stretch>
-        </p:blipFill>
-        <p:spPr>
-          <a:xfrm>
-            <a:off x="4756712" y="1051560"/>
-            <a:ext cx="3425335" cy="3561588"/>
-          </a:xfrm>
-          <a:prstGeom prst="rect">
-            <a:avLst/>
-          </a:prstGeom>
-        </p:spPr>
-      </p:pic>
+      <p:sp>
+        <p:nvSpPr>
+          <p:cNvPr id="12" name="Rectangle 11"/>
+          <p:cNvSpPr/>
+          <p:nvPr/>
+        </p:nvSpPr>
+        <p:spPr>
+          <a:xfrm>
+            <a:off x="4178808" y="1060704"/>
+            <a:ext cx="960120" cy="477447"/>
+          </a:xfrm>
+          <a:prstGeom prst="rect">
+            <a:avLst/>
+          </a:prstGeom>
+          <a:solidFill>
+            <a:srgbClr val="143278"/>
+          </a:solidFill>
+          <a:ln>
+            <a:noFill/>
+          </a:ln>
+        </p:spPr>
+        <p:style>
+          <a:lnRef idx="1">
+            <a:schemeClr val="accent1"/>
+          </a:lnRef>
+          <a:fillRef idx="3">
+            <a:schemeClr val="accent1"/>
+          </a:fillRef>
+          <a:effectRef idx="2">
+            <a:schemeClr val="accent1"/>
+          </a:effectRef>
+          <a:fontRef idx="minor">
+            <a:schemeClr val="lt1"/>
+          </a:fontRef>
+        </p:style>
+        <p:txBody>
+          <a:bodyPr rtlCol="0" anchor="ctr"/>
+          <a:lstStyle/>
+          <a:p>
+            <a:pPr algn="ctr"/>
+          </a:p>
+        </p:txBody>
+      </p:sp>
       <p:sp>
         <p:nvSpPr>
           <p:cNvPr id="13" name="TextBox 12"/>
@@ -16001,8 +15881,8 @@
         </p:nvSpPr>
         <p:spPr>
           <a:xfrm>
-            <a:off x="4069080" y="4668012"/>
-            <a:ext cx="4800600" cy="182880"/>
+            <a:off x="4178808" y="1194389"/>
+            <a:ext cx="960120" cy="238723"/>
           </a:xfrm>
           <a:prstGeom prst="rect">
             <a:avLst/>
@@ -16017,14 +15897,1048 @@
           <a:p>
             <a:pPr algn="ctr"/>
             <a:r>
-              <a:rPr sz="900" b="0">
-                <a:solidFill>
-                  <a:srgbClr val="5A6273"/>
+              <a:rPr sz="1100" b="1">
+                <a:solidFill>
+                  <a:srgbClr val="FFFFFF"/>
+                </a:solidFill>
+                <a:latin typeface="微软雅黑"/>
+                <ns6:rFonts xmlns:ns6="http://schemas.openxmlformats.org/wordprocessingml/2006/main" ns6:eastAsia="微软雅黑" ns6:ascii="微软雅黑" ns6:hAnsi="微软雅黑"/>
+              </a:rPr>
+              <a:t>团队</a:t>
+            </a:r>
+          </a:p>
+        </p:txBody>
+      </p:sp>
+      <p:sp>
+        <p:nvSpPr>
+          <p:cNvPr id="14" name="Rectangle 13"/>
+          <p:cNvSpPr/>
+          <p:nvPr/>
+        </p:nvSpPr>
+        <p:spPr>
+          <a:xfrm>
+            <a:off x="5184648" y="1060704"/>
+            <a:ext cx="3575304" cy="477447"/>
+          </a:xfrm>
+          <a:prstGeom prst="rect">
+            <a:avLst/>
+          </a:prstGeom>
+          <a:solidFill>
+            <a:srgbClr val="F1F7FF"/>
+          </a:solidFill>
+          <a:ln>
+            <a:solidFill>
+              <a:srgbClr val="BAC8DC"/>
+            </a:solidFill>
+          </a:ln>
+        </p:spPr>
+        <p:style>
+          <a:lnRef idx="1">
+            <a:schemeClr val="accent1"/>
+          </a:lnRef>
+          <a:fillRef idx="3">
+            <a:schemeClr val="accent1"/>
+          </a:fillRef>
+          <a:effectRef idx="2">
+            <a:schemeClr val="accent1"/>
+          </a:effectRef>
+          <a:fontRef idx="minor">
+            <a:schemeClr val="lt1"/>
+          </a:fontRef>
+        </p:style>
+        <p:txBody>
+          <a:bodyPr rtlCol="0" anchor="ctr"/>
+          <a:lstStyle/>
+          <a:p>
+            <a:pPr algn="ctr"/>
+          </a:p>
+        </p:txBody>
+      </p:sp>
+      <p:sp>
+        <p:nvSpPr>
+          <p:cNvPr id="15" name="TextBox 14"/>
+          <p:cNvSpPr txBox="1"/>
+          <p:nvPr/>
+        </p:nvSpPr>
+        <p:spPr>
+          <a:xfrm>
+            <a:off x="5276088" y="1115568"/>
+            <a:ext cx="3410712" cy="386007"/>
+          </a:xfrm>
+          <a:prstGeom prst="rect">
+            <a:avLst/>
+          </a:prstGeom>
+          <a:noFill/>
+        </p:spPr>
+        <p:txBody>
+          <a:bodyPr wrap="square">
+            <a:spAutoFit/>
+          </a:bodyPr>
+          <a:lstStyle/>
+          <a:p>
+            <a:r>
+              <a:rPr sz="1100" b="1">
+                <a:solidFill>
+                  <a:srgbClr val="143278"/>
+                </a:solidFill>
+                <a:latin typeface="微软雅黑"/>
+                <ns7:rFonts xmlns:ns7="http://schemas.openxmlformats.org/wordprocessingml/2006/main" ns7:eastAsia="微软雅黑" ns7:ascii="微软雅黑" ns7:hAnsi="微软雅黑"/>
+              </a:rPr>
+              <a:t>从容应队</a:t>
+            </a:r>
+          </a:p>
+        </p:txBody>
+      </p:sp>
+      <p:sp>
+        <p:nvSpPr>
+          <p:cNvPr id="16" name="Rectangle 15"/>
+          <p:cNvSpPr/>
+          <p:nvPr/>
+        </p:nvSpPr>
+        <p:spPr>
+          <a:xfrm>
+            <a:off x="4178808" y="1602159"/>
+            <a:ext cx="960120" cy="477447"/>
+          </a:xfrm>
+          <a:prstGeom prst="rect">
+            <a:avLst/>
+          </a:prstGeom>
+          <a:solidFill>
+            <a:srgbClr val="143278"/>
+          </a:solidFill>
+          <a:ln>
+            <a:noFill/>
+          </a:ln>
+        </p:spPr>
+        <p:style>
+          <a:lnRef idx="1">
+            <a:schemeClr val="accent1"/>
+          </a:lnRef>
+          <a:fillRef idx="3">
+            <a:schemeClr val="accent1"/>
+          </a:fillRef>
+          <a:effectRef idx="2">
+            <a:schemeClr val="accent1"/>
+          </a:effectRef>
+          <a:fontRef idx="minor">
+            <a:schemeClr val="lt1"/>
+          </a:fontRef>
+        </p:style>
+        <p:txBody>
+          <a:bodyPr rtlCol="0" anchor="ctr"/>
+          <a:lstStyle/>
+          <a:p>
+            <a:pPr algn="ctr"/>
+          </a:p>
+        </p:txBody>
+      </p:sp>
+      <p:sp>
+        <p:nvSpPr>
+          <p:cNvPr id="17" name="TextBox 16"/>
+          <p:cNvSpPr txBox="1"/>
+          <p:nvPr/>
+        </p:nvSpPr>
+        <p:spPr>
+          <a:xfrm>
+            <a:off x="4178808" y="1735844"/>
+            <a:ext cx="960120" cy="238723"/>
+          </a:xfrm>
+          <a:prstGeom prst="rect">
+            <a:avLst/>
+          </a:prstGeom>
+          <a:noFill/>
+        </p:spPr>
+        <p:txBody>
+          <a:bodyPr wrap="none">
+            <a:spAutoFit/>
+          </a:bodyPr>
+          <a:lstStyle/>
+          <a:p>
+            <a:pPr algn="ctr"/>
+            <a:r>
+              <a:rPr sz="1100" b="1">
+                <a:solidFill>
+                  <a:srgbClr val="FFFFFF"/>
+                </a:solidFill>
+                <a:latin typeface="微软雅黑"/>
+                <ns8:rFonts xmlns:ns8="http://schemas.openxmlformats.org/wordprocessingml/2006/main" ns8:eastAsia="微软雅黑" ns8:ascii="微软雅黑" ns8:hAnsi="微软雅黑"/>
+              </a:rPr>
+              <a:t>学校</a:t>
+            </a:r>
+          </a:p>
+        </p:txBody>
+      </p:sp>
+      <p:sp>
+        <p:nvSpPr>
+          <p:cNvPr id="18" name="Rectangle 17"/>
+          <p:cNvSpPr/>
+          <p:nvPr/>
+        </p:nvSpPr>
+        <p:spPr>
+          <a:xfrm>
+            <a:off x="5184648" y="1602159"/>
+            <a:ext cx="3575304" cy="477447"/>
+          </a:xfrm>
+          <a:prstGeom prst="rect">
+            <a:avLst/>
+          </a:prstGeom>
+          <a:solidFill>
+            <a:srgbClr val="F1F7FF"/>
+          </a:solidFill>
+          <a:ln>
+            <a:solidFill>
+              <a:srgbClr val="BAC8DC"/>
+            </a:solidFill>
+          </a:ln>
+        </p:spPr>
+        <p:style>
+          <a:lnRef idx="1">
+            <a:schemeClr val="accent1"/>
+          </a:lnRef>
+          <a:fillRef idx="3">
+            <a:schemeClr val="accent1"/>
+          </a:fillRef>
+          <a:effectRef idx="2">
+            <a:schemeClr val="accent1"/>
+          </a:effectRef>
+          <a:fontRef idx="minor">
+            <a:schemeClr val="lt1"/>
+          </a:fontRef>
+        </p:style>
+        <p:txBody>
+          <a:bodyPr rtlCol="0" anchor="ctr"/>
+          <a:lstStyle/>
+          <a:p>
+            <a:pPr algn="ctr"/>
+          </a:p>
+        </p:txBody>
+      </p:sp>
+      <p:sp>
+        <p:nvSpPr>
+          <p:cNvPr id="19" name="TextBox 18"/>
+          <p:cNvSpPr txBox="1"/>
+          <p:nvPr/>
+        </p:nvSpPr>
+        <p:spPr>
+          <a:xfrm>
+            <a:off x="5276088" y="1657023"/>
+            <a:ext cx="3410712" cy="386007"/>
+          </a:xfrm>
+          <a:prstGeom prst="rect">
+            <a:avLst/>
+          </a:prstGeom>
+          <a:noFill/>
+        </p:spPr>
+        <p:txBody>
+          <a:bodyPr wrap="square">
+            <a:spAutoFit/>
+          </a:bodyPr>
+          <a:lstStyle/>
+          <a:p>
+            <a:r>
+              <a:rPr sz="1100" b="1">
+                <a:solidFill>
+                  <a:srgbClr val="143278"/>
                 </a:solidFill>
                 <a:latin typeface="微软雅黑"/>
                 <ns9:rFonts xmlns:ns9="http://schemas.openxmlformats.org/wordprocessingml/2006/main" ns9:eastAsia="微软雅黑" ns9:ascii="微软雅黑" ns9:hAnsi="微软雅黑"/>
               </a:rPr>
-              <a:t>报名信息</a:t>
+              <a:t>中山大学</a:t>
+            </a:r>
+          </a:p>
+        </p:txBody>
+      </p:sp>
+      <p:sp>
+        <p:nvSpPr>
+          <p:cNvPr id="20" name="Rectangle 19"/>
+          <p:cNvSpPr/>
+          <p:nvPr/>
+        </p:nvSpPr>
+        <p:spPr>
+          <a:xfrm>
+            <a:off x="4178808" y="2143614"/>
+            <a:ext cx="960120" cy="477447"/>
+          </a:xfrm>
+          <a:prstGeom prst="rect">
+            <a:avLst/>
+          </a:prstGeom>
+          <a:solidFill>
+            <a:srgbClr val="143278"/>
+          </a:solidFill>
+          <a:ln>
+            <a:noFill/>
+          </a:ln>
+        </p:spPr>
+        <p:style>
+          <a:lnRef idx="1">
+            <a:schemeClr val="accent1"/>
+          </a:lnRef>
+          <a:fillRef idx="3">
+            <a:schemeClr val="accent1"/>
+          </a:fillRef>
+          <a:effectRef idx="2">
+            <a:schemeClr val="accent1"/>
+          </a:effectRef>
+          <a:fontRef idx="minor">
+            <a:schemeClr val="lt1"/>
+          </a:fontRef>
+        </p:style>
+        <p:txBody>
+          <a:bodyPr rtlCol="0" anchor="ctr"/>
+          <a:lstStyle/>
+          <a:p>
+            <a:pPr algn="ctr"/>
+          </a:p>
+        </p:txBody>
+      </p:sp>
+      <p:sp>
+        <p:nvSpPr>
+          <p:cNvPr id="21" name="TextBox 20"/>
+          <p:cNvSpPr txBox="1"/>
+          <p:nvPr/>
+        </p:nvSpPr>
+        <p:spPr>
+          <a:xfrm>
+            <a:off x="4178808" y="2277300"/>
+            <a:ext cx="960120" cy="238723"/>
+          </a:xfrm>
+          <a:prstGeom prst="rect">
+            <a:avLst/>
+          </a:prstGeom>
+          <a:noFill/>
+        </p:spPr>
+        <p:txBody>
+          <a:bodyPr wrap="none">
+            <a:spAutoFit/>
+          </a:bodyPr>
+          <a:lstStyle/>
+          <a:p>
+            <a:pPr algn="ctr"/>
+            <a:r>
+              <a:rPr sz="1100" b="1">
+                <a:solidFill>
+                  <a:srgbClr val="FFFFFF"/>
+                </a:solidFill>
+                <a:latin typeface="微软雅黑"/>
+                <ns10:rFonts xmlns:ns10="http://schemas.openxmlformats.org/wordprocessingml/2006/main" ns10:eastAsia="微软雅黑" ns10:ascii="微软雅黑" ns10:hAnsi="微软雅黑"/>
+              </a:rPr>
+              <a:t>队长</a:t>
+            </a:r>
+          </a:p>
+        </p:txBody>
+      </p:sp>
+      <p:sp>
+        <p:nvSpPr>
+          <p:cNvPr id="22" name="Rectangle 21"/>
+          <p:cNvSpPr/>
+          <p:nvPr/>
+        </p:nvSpPr>
+        <p:spPr>
+          <a:xfrm>
+            <a:off x="5184648" y="2143614"/>
+            <a:ext cx="3575304" cy="477447"/>
+          </a:xfrm>
+          <a:prstGeom prst="rect">
+            <a:avLst/>
+          </a:prstGeom>
+          <a:solidFill>
+            <a:srgbClr val="F1F7FF"/>
+          </a:solidFill>
+          <a:ln>
+            <a:solidFill>
+              <a:srgbClr val="BAC8DC"/>
+            </a:solidFill>
+          </a:ln>
+        </p:spPr>
+        <p:style>
+          <a:lnRef idx="1">
+            <a:schemeClr val="accent1"/>
+          </a:lnRef>
+          <a:fillRef idx="3">
+            <a:schemeClr val="accent1"/>
+          </a:fillRef>
+          <a:effectRef idx="2">
+            <a:schemeClr val="accent1"/>
+          </a:effectRef>
+          <a:fontRef idx="minor">
+            <a:schemeClr val="lt1"/>
+          </a:fontRef>
+        </p:style>
+        <p:txBody>
+          <a:bodyPr rtlCol="0" anchor="ctr"/>
+          <a:lstStyle/>
+          <a:p>
+            <a:pPr algn="ctr"/>
+          </a:p>
+        </p:txBody>
+      </p:sp>
+      <p:sp>
+        <p:nvSpPr>
+          <p:cNvPr id="23" name="TextBox 22"/>
+          <p:cNvSpPr txBox="1"/>
+          <p:nvPr/>
+        </p:nvSpPr>
+        <p:spPr>
+          <a:xfrm>
+            <a:off x="5276088" y="2198478"/>
+            <a:ext cx="3410712" cy="386007"/>
+          </a:xfrm>
+          <a:prstGeom prst="rect">
+            <a:avLst/>
+          </a:prstGeom>
+          <a:noFill/>
+        </p:spPr>
+        <p:txBody>
+          <a:bodyPr wrap="square">
+            <a:spAutoFit/>
+          </a:bodyPr>
+          <a:lstStyle/>
+          <a:p>
+            <a:r>
+              <a:rPr sz="1100" b="1">
+                <a:solidFill>
+                  <a:srgbClr val="143278"/>
+                </a:solidFill>
+                <a:latin typeface="微软雅黑"/>
+                <ns11:rFonts xmlns:ns11="http://schemas.openxmlformats.org/wordprocessingml/2006/main" ns11:eastAsia="微软雅黑" ns11:ascii="微软雅黑" ns11:hAnsi="微软雅黑"/>
+              </a:rPr>
+              <a:t>刘小凡</a:t>
+            </a:r>
+          </a:p>
+        </p:txBody>
+      </p:sp>
+      <p:sp>
+        <p:nvSpPr>
+          <p:cNvPr id="24" name="Rectangle 23"/>
+          <p:cNvSpPr/>
+          <p:nvPr/>
+        </p:nvSpPr>
+        <p:spPr>
+          <a:xfrm>
+            <a:off x="4178808" y="2685070"/>
+            <a:ext cx="960120" cy="477447"/>
+          </a:xfrm>
+          <a:prstGeom prst="rect">
+            <a:avLst/>
+          </a:prstGeom>
+          <a:solidFill>
+            <a:srgbClr val="143278"/>
+          </a:solidFill>
+          <a:ln>
+            <a:noFill/>
+          </a:ln>
+        </p:spPr>
+        <p:style>
+          <a:lnRef idx="1">
+            <a:schemeClr val="accent1"/>
+          </a:lnRef>
+          <a:fillRef idx="3">
+            <a:schemeClr val="accent1"/>
+          </a:fillRef>
+          <a:effectRef idx="2">
+            <a:schemeClr val="accent1"/>
+          </a:effectRef>
+          <a:fontRef idx="minor">
+            <a:schemeClr val="lt1"/>
+          </a:fontRef>
+        </p:style>
+        <p:txBody>
+          <a:bodyPr rtlCol="0" anchor="ctr"/>
+          <a:lstStyle/>
+          <a:p>
+            <a:pPr algn="ctr"/>
+          </a:p>
+        </p:txBody>
+      </p:sp>
+      <p:sp>
+        <p:nvSpPr>
+          <p:cNvPr id="25" name="TextBox 24"/>
+          <p:cNvSpPr txBox="1"/>
+          <p:nvPr/>
+        </p:nvSpPr>
+        <p:spPr>
+          <a:xfrm>
+            <a:off x="4178808" y="2818755"/>
+            <a:ext cx="960120" cy="238723"/>
+          </a:xfrm>
+          <a:prstGeom prst="rect">
+            <a:avLst/>
+          </a:prstGeom>
+          <a:noFill/>
+        </p:spPr>
+        <p:txBody>
+          <a:bodyPr wrap="none">
+            <a:spAutoFit/>
+          </a:bodyPr>
+          <a:lstStyle/>
+          <a:p>
+            <a:pPr algn="ctr"/>
+            <a:r>
+              <a:rPr sz="1100" b="1">
+                <a:solidFill>
+                  <a:srgbClr val="FFFFFF"/>
+                </a:solidFill>
+                <a:latin typeface="微软雅黑"/>
+                <ns12:rFonts xmlns:ns12="http://schemas.openxmlformats.org/wordprocessingml/2006/main" ns12:eastAsia="微软雅黑" ns12:ascii="微软雅黑" ns12:hAnsi="微软雅黑"/>
+              </a:rPr>
+              <a:t>队员</a:t>
+            </a:r>
+          </a:p>
+        </p:txBody>
+      </p:sp>
+      <p:sp>
+        <p:nvSpPr>
+          <p:cNvPr id="26" name="Rectangle 25"/>
+          <p:cNvSpPr/>
+          <p:nvPr/>
+        </p:nvSpPr>
+        <p:spPr>
+          <a:xfrm>
+            <a:off x="5184648" y="2685070"/>
+            <a:ext cx="3575304" cy="477447"/>
+          </a:xfrm>
+          <a:prstGeom prst="rect">
+            <a:avLst/>
+          </a:prstGeom>
+          <a:solidFill>
+            <a:srgbClr val="F1F7FF"/>
+          </a:solidFill>
+          <a:ln>
+            <a:solidFill>
+              <a:srgbClr val="BAC8DC"/>
+            </a:solidFill>
+          </a:ln>
+        </p:spPr>
+        <p:style>
+          <a:lnRef idx="1">
+            <a:schemeClr val="accent1"/>
+          </a:lnRef>
+          <a:fillRef idx="3">
+            <a:schemeClr val="accent1"/>
+          </a:fillRef>
+          <a:effectRef idx="2">
+            <a:schemeClr val="accent1"/>
+          </a:effectRef>
+          <a:fontRef idx="minor">
+            <a:schemeClr val="lt1"/>
+          </a:fontRef>
+        </p:style>
+        <p:txBody>
+          <a:bodyPr rtlCol="0" anchor="ctr"/>
+          <a:lstStyle/>
+          <a:p>
+            <a:pPr algn="ctr"/>
+          </a:p>
+        </p:txBody>
+      </p:sp>
+      <p:sp>
+        <p:nvSpPr>
+          <p:cNvPr id="27" name="TextBox 26"/>
+          <p:cNvSpPr txBox="1"/>
+          <p:nvPr/>
+        </p:nvSpPr>
+        <p:spPr>
+          <a:xfrm>
+            <a:off x="5276088" y="2739934"/>
+            <a:ext cx="3410712" cy="386007"/>
+          </a:xfrm>
+          <a:prstGeom prst="rect">
+            <a:avLst/>
+          </a:prstGeom>
+          <a:noFill/>
+        </p:spPr>
+        <p:txBody>
+          <a:bodyPr wrap="square">
+            <a:spAutoFit/>
+          </a:bodyPr>
+          <a:lstStyle/>
+          <a:p>
+            <a:r>
+              <a:rPr sz="1100" b="1">
+                <a:solidFill>
+                  <a:srgbClr val="143278"/>
+                </a:solidFill>
+                <a:latin typeface="微软雅黑"/>
+                <ns13:rFonts xmlns:ns13="http://schemas.openxmlformats.org/wordprocessingml/2006/main" ns13:eastAsia="微软雅黑" ns13:ascii="微软雅黑" ns13:hAnsi="微软雅黑"/>
+              </a:rPr>
+              <a:t>白冉</a:t>
+            </a:r>
+          </a:p>
+        </p:txBody>
+      </p:sp>
+      <p:sp>
+        <p:nvSpPr>
+          <p:cNvPr id="28" name="Rectangle 27"/>
+          <p:cNvSpPr/>
+          <p:nvPr/>
+        </p:nvSpPr>
+        <p:spPr>
+          <a:xfrm>
+            <a:off x="4178808" y="3226525"/>
+            <a:ext cx="960120" cy="477447"/>
+          </a:xfrm>
+          <a:prstGeom prst="rect">
+            <a:avLst/>
+          </a:prstGeom>
+          <a:solidFill>
+            <a:srgbClr val="143278"/>
+          </a:solidFill>
+          <a:ln>
+            <a:noFill/>
+          </a:ln>
+        </p:spPr>
+        <p:style>
+          <a:lnRef idx="1">
+            <a:schemeClr val="accent1"/>
+          </a:lnRef>
+          <a:fillRef idx="3">
+            <a:schemeClr val="accent1"/>
+          </a:fillRef>
+          <a:effectRef idx="2">
+            <a:schemeClr val="accent1"/>
+          </a:effectRef>
+          <a:fontRef idx="minor">
+            <a:schemeClr val="lt1"/>
+          </a:fontRef>
+        </p:style>
+        <p:txBody>
+          <a:bodyPr rtlCol="0" anchor="ctr"/>
+          <a:lstStyle/>
+          <a:p>
+            <a:pPr algn="ctr"/>
+          </a:p>
+        </p:txBody>
+      </p:sp>
+      <p:sp>
+        <p:nvSpPr>
+          <p:cNvPr id="29" name="TextBox 28"/>
+          <p:cNvSpPr txBox="1"/>
+          <p:nvPr/>
+        </p:nvSpPr>
+        <p:spPr>
+          <a:xfrm>
+            <a:off x="4178808" y="3360210"/>
+            <a:ext cx="960120" cy="238723"/>
+          </a:xfrm>
+          <a:prstGeom prst="rect">
+            <a:avLst/>
+          </a:prstGeom>
+          <a:noFill/>
+        </p:spPr>
+        <p:txBody>
+          <a:bodyPr wrap="none">
+            <a:spAutoFit/>
+          </a:bodyPr>
+          <a:lstStyle/>
+          <a:p>
+            <a:pPr algn="ctr"/>
+            <a:r>
+              <a:rPr sz="1100" b="1">
+                <a:solidFill>
+                  <a:srgbClr val="FFFFFF"/>
+                </a:solidFill>
+                <a:latin typeface="微软雅黑"/>
+                <ns14:rFonts xmlns:ns14="http://schemas.openxmlformats.org/wordprocessingml/2006/main" ns14:eastAsia="微软雅黑" ns14:ascii="微软雅黑" ns14:hAnsi="微软雅黑"/>
+              </a:rPr>
+              <a:t>指导教师</a:t>
+            </a:r>
+          </a:p>
+        </p:txBody>
+      </p:sp>
+      <p:sp>
+        <p:nvSpPr>
+          <p:cNvPr id="30" name="Rectangle 29"/>
+          <p:cNvSpPr/>
+          <p:nvPr/>
+        </p:nvSpPr>
+        <p:spPr>
+          <a:xfrm>
+            <a:off x="5184648" y="3226525"/>
+            <a:ext cx="3575304" cy="477447"/>
+          </a:xfrm>
+          <a:prstGeom prst="rect">
+            <a:avLst/>
+          </a:prstGeom>
+          <a:solidFill>
+            <a:srgbClr val="F1F7FF"/>
+          </a:solidFill>
+          <a:ln>
+            <a:solidFill>
+              <a:srgbClr val="BAC8DC"/>
+            </a:solidFill>
+          </a:ln>
+        </p:spPr>
+        <p:style>
+          <a:lnRef idx="1">
+            <a:schemeClr val="accent1"/>
+          </a:lnRef>
+          <a:fillRef idx="3">
+            <a:schemeClr val="accent1"/>
+          </a:fillRef>
+          <a:effectRef idx="2">
+            <a:schemeClr val="accent1"/>
+          </a:effectRef>
+          <a:fontRef idx="minor">
+            <a:schemeClr val="lt1"/>
+          </a:fontRef>
+        </p:style>
+        <p:txBody>
+          <a:bodyPr rtlCol="0" anchor="ctr"/>
+          <a:lstStyle/>
+          <a:p>
+            <a:pPr algn="ctr"/>
+          </a:p>
+        </p:txBody>
+      </p:sp>
+      <p:sp>
+        <p:nvSpPr>
+          <p:cNvPr id="31" name="TextBox 30"/>
+          <p:cNvSpPr txBox="1"/>
+          <p:nvPr/>
+        </p:nvSpPr>
+        <p:spPr>
+          <a:xfrm>
+            <a:off x="5276088" y="3281389"/>
+            <a:ext cx="3410712" cy="386007"/>
+          </a:xfrm>
+          <a:prstGeom prst="rect">
+            <a:avLst/>
+          </a:prstGeom>
+          <a:noFill/>
+        </p:spPr>
+        <p:txBody>
+          <a:bodyPr wrap="square">
+            <a:spAutoFit/>
+          </a:bodyPr>
+          <a:lstStyle/>
+          <a:p>
+            <a:r>
+              <a:rPr sz="1100" b="1">
+                <a:solidFill>
+                  <a:srgbClr val="143278"/>
+                </a:solidFill>
+                <a:latin typeface="微软雅黑"/>
+                <ns15:rFonts xmlns:ns15="http://schemas.openxmlformats.org/wordprocessingml/2006/main" ns15:eastAsia="微软雅黑" ns15:ascii="微软雅黑" ns15:hAnsi="微软雅黑"/>
+              </a:rPr>
+              <a:t>彭键清</a:t>
+            </a:r>
+          </a:p>
+        </p:txBody>
+      </p:sp>
+      <p:sp>
+        <p:nvSpPr>
+          <p:cNvPr id="32" name="Rectangle 31"/>
+          <p:cNvSpPr/>
+          <p:nvPr/>
+        </p:nvSpPr>
+        <p:spPr>
+          <a:xfrm>
+            <a:off x="4178808" y="3767981"/>
+            <a:ext cx="960120" cy="477447"/>
+          </a:xfrm>
+          <a:prstGeom prst="rect">
+            <a:avLst/>
+          </a:prstGeom>
+          <a:solidFill>
+            <a:srgbClr val="143278"/>
+          </a:solidFill>
+          <a:ln>
+            <a:noFill/>
+          </a:ln>
+        </p:spPr>
+        <p:style>
+          <a:lnRef idx="1">
+            <a:schemeClr val="accent1"/>
+          </a:lnRef>
+          <a:fillRef idx="3">
+            <a:schemeClr val="accent1"/>
+          </a:fillRef>
+          <a:effectRef idx="2">
+            <a:schemeClr val="accent1"/>
+          </a:effectRef>
+          <a:fontRef idx="minor">
+            <a:schemeClr val="lt1"/>
+          </a:fontRef>
+        </p:style>
+        <p:txBody>
+          <a:bodyPr rtlCol="0" anchor="ctr"/>
+          <a:lstStyle/>
+          <a:p>
+            <a:pPr algn="ctr"/>
+          </a:p>
+        </p:txBody>
+      </p:sp>
+      <p:sp>
+        <p:nvSpPr>
+          <p:cNvPr id="33" name="TextBox 32"/>
+          <p:cNvSpPr txBox="1"/>
+          <p:nvPr/>
+        </p:nvSpPr>
+        <p:spPr>
+          <a:xfrm>
+            <a:off x="4178808" y="3901666"/>
+            <a:ext cx="960120" cy="238723"/>
+          </a:xfrm>
+          <a:prstGeom prst="rect">
+            <a:avLst/>
+          </a:prstGeom>
+          <a:noFill/>
+        </p:spPr>
+        <p:txBody>
+          <a:bodyPr wrap="none">
+            <a:spAutoFit/>
+          </a:bodyPr>
+          <a:lstStyle/>
+          <a:p>
+            <a:pPr algn="ctr"/>
+            <a:r>
+              <a:rPr sz="1100" b="1">
+                <a:solidFill>
+                  <a:srgbClr val="FFFFFF"/>
+                </a:solidFill>
+                <a:latin typeface="微软雅黑"/>
+                <ns16:rFonts xmlns:ns16="http://schemas.openxmlformats.org/wordprocessingml/2006/main" ns16:eastAsia="微软雅黑" ns16:ascii="微软雅黑" ns16:hAnsi="微软雅黑"/>
+              </a:rPr>
+              <a:t>团队编号</a:t>
+            </a:r>
+          </a:p>
+        </p:txBody>
+      </p:sp>
+      <p:sp>
+        <p:nvSpPr>
+          <p:cNvPr id="34" name="Rectangle 33"/>
+          <p:cNvSpPr/>
+          <p:nvPr/>
+        </p:nvSpPr>
+        <p:spPr>
+          <a:xfrm>
+            <a:off x="5184648" y="3767981"/>
+            <a:ext cx="3575304" cy="477447"/>
+          </a:xfrm>
+          <a:prstGeom prst="rect">
+            <a:avLst/>
+          </a:prstGeom>
+          <a:solidFill>
+            <a:srgbClr val="F1F7FF"/>
+          </a:solidFill>
+          <a:ln>
+            <a:solidFill>
+              <a:srgbClr val="BAC8DC"/>
+            </a:solidFill>
+          </a:ln>
+        </p:spPr>
+        <p:style>
+          <a:lnRef idx="1">
+            <a:schemeClr val="accent1"/>
+          </a:lnRef>
+          <a:fillRef idx="3">
+            <a:schemeClr val="accent1"/>
+          </a:fillRef>
+          <a:effectRef idx="2">
+            <a:schemeClr val="accent1"/>
+          </a:effectRef>
+          <a:fontRef idx="minor">
+            <a:schemeClr val="lt1"/>
+          </a:fontRef>
+        </p:style>
+        <p:txBody>
+          <a:bodyPr rtlCol="0" anchor="ctr"/>
+          <a:lstStyle/>
+          <a:p>
+            <a:pPr algn="ctr"/>
+          </a:p>
+        </p:txBody>
+      </p:sp>
+      <p:sp>
+        <p:nvSpPr>
+          <p:cNvPr id="35" name="TextBox 34"/>
+          <p:cNvSpPr txBox="1"/>
+          <p:nvPr/>
+        </p:nvSpPr>
+        <p:spPr>
+          <a:xfrm>
+            <a:off x="5276088" y="3822845"/>
+            <a:ext cx="3410712" cy="386007"/>
+          </a:xfrm>
+          <a:prstGeom prst="rect">
+            <a:avLst/>
+          </a:prstGeom>
+          <a:noFill/>
+        </p:spPr>
+        <p:txBody>
+          <a:bodyPr wrap="square">
+            <a:spAutoFit/>
+          </a:bodyPr>
+          <a:lstStyle/>
+          <a:p>
+            <a:r>
+              <a:rPr sz="1100" b="1">
+                <a:solidFill>
+                  <a:srgbClr val="143278"/>
+                </a:solidFill>
+                <a:latin typeface="微软雅黑"/>
+                <ns17:rFonts xmlns:ns17="http://schemas.openxmlformats.org/wordprocessingml/2006/main" ns17:eastAsia="微软雅黑" ns17:ascii="微软雅黑" ns17:hAnsi="微软雅黑"/>
+              </a:rPr>
+              <a:t>CRAIC2026-TEAM-8FJQKLMI</a:t>
+            </a:r>
+          </a:p>
+        </p:txBody>
+      </p:sp>
+      <p:sp>
+        <p:nvSpPr>
+          <p:cNvPr id="36" name="Rectangle 35"/>
+          <p:cNvSpPr/>
+          <p:nvPr/>
+        </p:nvSpPr>
+        <p:spPr>
+          <a:xfrm>
+            <a:off x="4178808" y="4309436"/>
+            <a:ext cx="960120" cy="477447"/>
+          </a:xfrm>
+          <a:prstGeom prst="rect">
+            <a:avLst/>
+          </a:prstGeom>
+          <a:solidFill>
+            <a:srgbClr val="143278"/>
+          </a:solidFill>
+          <a:ln>
+            <a:noFill/>
+          </a:ln>
+        </p:spPr>
+        <p:style>
+          <a:lnRef idx="1">
+            <a:schemeClr val="accent1"/>
+          </a:lnRef>
+          <a:fillRef idx="3">
+            <a:schemeClr val="accent1"/>
+          </a:fillRef>
+          <a:effectRef idx="2">
+            <a:schemeClr val="accent1"/>
+          </a:effectRef>
+          <a:fontRef idx="minor">
+            <a:schemeClr val="lt1"/>
+          </a:fontRef>
+        </p:style>
+        <p:txBody>
+          <a:bodyPr rtlCol="0" anchor="ctr"/>
+          <a:lstStyle/>
+          <a:p>
+            <a:pPr algn="ctr"/>
+          </a:p>
+        </p:txBody>
+      </p:sp>
+      <p:sp>
+        <p:nvSpPr>
+          <p:cNvPr id="37" name="TextBox 36"/>
+          <p:cNvSpPr txBox="1"/>
+          <p:nvPr/>
+        </p:nvSpPr>
+        <p:spPr>
+          <a:xfrm>
+            <a:off x="4178808" y="4443121"/>
+            <a:ext cx="960120" cy="238723"/>
+          </a:xfrm>
+          <a:prstGeom prst="rect">
+            <a:avLst/>
+          </a:prstGeom>
+          <a:noFill/>
+        </p:spPr>
+        <p:txBody>
+          <a:bodyPr wrap="none">
+            <a:spAutoFit/>
+          </a:bodyPr>
+          <a:lstStyle/>
+          <a:p>
+            <a:pPr algn="ctr"/>
+            <a:r>
+              <a:rPr sz="1100" b="1">
+                <a:solidFill>
+                  <a:srgbClr val="FFFFFF"/>
+                </a:solidFill>
+                <a:latin typeface="微软雅黑"/>
+                <ns18:rFonts xmlns:ns18="http://schemas.openxmlformats.org/wordprocessingml/2006/main" ns18:eastAsia="微软雅黑" ns18:ascii="微软雅黑" ns18:hAnsi="微软雅黑"/>
+              </a:rPr>
+              <a:t>作品编号</a:t>
+            </a:r>
+          </a:p>
+        </p:txBody>
+      </p:sp>
+      <p:sp>
+        <p:nvSpPr>
+          <p:cNvPr id="38" name="Rectangle 37"/>
+          <p:cNvSpPr/>
+          <p:nvPr/>
+        </p:nvSpPr>
+        <p:spPr>
+          <a:xfrm>
+            <a:off x="5184648" y="4309436"/>
+            <a:ext cx="3575304" cy="477447"/>
+          </a:xfrm>
+          <a:prstGeom prst="rect">
+            <a:avLst/>
+          </a:prstGeom>
+          <a:solidFill>
+            <a:srgbClr val="F1F7FF"/>
+          </a:solidFill>
+          <a:ln>
+            <a:solidFill>
+              <a:srgbClr val="BAC8DC"/>
+            </a:solidFill>
+          </a:ln>
+        </p:spPr>
+        <p:style>
+          <a:lnRef idx="1">
+            <a:schemeClr val="accent1"/>
+          </a:lnRef>
+          <a:fillRef idx="3">
+            <a:schemeClr val="accent1"/>
+          </a:fillRef>
+          <a:effectRef idx="2">
+            <a:schemeClr val="accent1"/>
+          </a:effectRef>
+          <a:fontRef idx="minor">
+            <a:schemeClr val="lt1"/>
+          </a:fontRef>
+        </p:style>
+        <p:txBody>
+          <a:bodyPr rtlCol="0" anchor="ctr"/>
+          <a:lstStyle/>
+          <a:p>
+            <a:pPr algn="ctr"/>
+          </a:p>
+        </p:txBody>
+      </p:sp>
+      <p:sp>
+        <p:nvSpPr>
+          <p:cNvPr id="39" name="TextBox 38"/>
+          <p:cNvSpPr txBox="1"/>
+          <p:nvPr/>
+        </p:nvSpPr>
+        <p:spPr>
+          <a:xfrm>
+            <a:off x="5276088" y="4364300"/>
+            <a:ext cx="3410712" cy="386007"/>
+          </a:xfrm>
+          <a:prstGeom prst="rect">
+            <a:avLst/>
+          </a:prstGeom>
+          <a:noFill/>
+        </p:spPr>
+        <p:txBody>
+          <a:bodyPr wrap="square">
+            <a:spAutoFit/>
+          </a:bodyPr>
+          <a:lstStyle/>
+          <a:p>
+            <a:r>
+              <a:rPr sz="1100" b="1">
+                <a:solidFill>
+                  <a:srgbClr val="143278"/>
+                </a:solidFill>
+                <a:latin typeface="微软雅黑"/>
+                <ns19:rFonts xmlns:ns19="http://schemas.openxmlformats.org/wordprocessingml/2006/main" ns19:eastAsia="微软雅黑" ns19:ascii="微软雅黑" ns19:hAnsi="微软雅黑"/>
+              </a:rPr>
+              <a:t>CRAIC20264ZEFT1DF</a:t>
             </a:r>
           </a:p>
         </p:txBody>
@@ -16387,8 +17301,8 @@
         </p:nvSpPr>
         <p:spPr>
           <a:xfrm>
-            <a:off x="475488" y="1161288"/>
-            <a:ext cx="3300984" cy="3525012"/>
+            <a:off x="475488" y="1143000"/>
+            <a:ext cx="3300984" cy="3579876"/>
           </a:xfrm>
           <a:prstGeom prst="rect">
             <a:avLst/>
@@ -16406,7 +17320,7 @@
                 <a:spcPct val="120000"/>
               </a:lnSpc>
               <a:spcAft>
-                <a:spcPts val="6900"/>
+                <a:spcPts val="7100"/>
               </a:spcAft>
             </a:pPr>
             <a:r>
@@ -16426,7 +17340,7 @@
                 <a:spcPct val="120000"/>
               </a:lnSpc>
               <a:spcAft>
-                <a:spcPts val="6900"/>
+                <a:spcPts val="7100"/>
               </a:spcAft>
             </a:pPr>
             <a:r>
@@ -16446,7 +17360,7 @@
                 <a:spcPct val="120000"/>
               </a:lnSpc>
               <a:spcAft>
-                <a:spcPts val="6900"/>
+                <a:spcPts val="7100"/>
               </a:spcAft>
             </a:pPr>
             <a:r>
@@ -16466,7 +17380,7 @@
                 <a:spcPct val="120000"/>
               </a:lnSpc>
               <a:spcAft>
-                <a:spcPts val="6900"/>
+                <a:spcPts val="7100"/>
               </a:spcAft>
             </a:pPr>
             <a:r>
@@ -17868,8 +18782,8 @@
         </p:blipFill>
         <p:spPr>
           <a:xfrm>
-            <a:off x="4398264" y="1198237"/>
-            <a:ext cx="4690872" cy="3451113"/>
+            <a:off x="4398264" y="1113481"/>
+            <a:ext cx="4690872" cy="3620624"/>
           </a:xfrm>
           <a:prstGeom prst="rect">
             <a:avLst/>
@@ -18147,7 +19061,7 @@
         <p:spPr>
           <a:xfrm>
             <a:off x="274320" y="996696"/>
-            <a:ext cx="3611880" cy="3451860"/>
+            <a:ext cx="3611880" cy="3854196"/>
           </a:xfrm>
           <a:prstGeom prst="rect">
             <a:avLst/>
@@ -18192,7 +19106,7 @@
         <p:spPr>
           <a:xfrm>
             <a:off x="274320" y="996696"/>
-            <a:ext cx="73152" cy="3451860"/>
+            <a:ext cx="73152" cy="3854196"/>
           </a:xfrm>
           <a:prstGeom prst="rect">
             <a:avLst/>
@@ -18228,14 +19142,93 @@
       </p:sp>
       <p:sp>
         <p:nvSpPr>
-          <p:cNvPr id="10" name="TextBox 9"/>
+          <p:cNvPr id="10" name="Rectangle 9"/>
+          <p:cNvSpPr/>
+          <p:nvPr/>
+        </p:nvSpPr>
+        <p:spPr>
+          <a:xfrm>
+            <a:off x="347472" y="4503420"/>
+            <a:ext cx="3465576" cy="310896"/>
+          </a:xfrm>
+          <a:prstGeom prst="rect">
+            <a:avLst/>
+          </a:prstGeom>
+          <a:solidFill>
+            <a:srgbClr val="143278"/>
+          </a:solidFill>
+          <a:ln>
+            <a:noFill/>
+          </a:ln>
+        </p:spPr>
+        <p:style>
+          <a:lnRef idx="1">
+            <a:schemeClr val="accent1"/>
+          </a:lnRef>
+          <a:fillRef idx="3">
+            <a:schemeClr val="accent1"/>
+          </a:fillRef>
+          <a:effectRef idx="2">
+            <a:schemeClr val="accent1"/>
+          </a:effectRef>
+          <a:fontRef idx="minor">
+            <a:schemeClr val="lt1"/>
+          </a:fontRef>
+        </p:style>
+        <p:txBody>
+          <a:bodyPr rtlCol="0" anchor="ctr"/>
+          <a:lstStyle/>
+          <a:p>
+            <a:pPr algn="ctr"/>
+          </a:p>
+        </p:txBody>
+      </p:sp>
+      <p:sp>
+        <p:nvSpPr>
+          <p:cNvPr id="11" name="TextBox 10"/>
           <p:cNvSpPr txBox="1"/>
           <p:nvPr/>
         </p:nvSpPr>
         <p:spPr>
           <a:xfrm>
-            <a:off x="475488" y="1161288"/>
-            <a:ext cx="3300984" cy="3122676"/>
+            <a:off x="402336" y="4576572"/>
+            <a:ext cx="3355848" cy="237744"/>
+          </a:xfrm>
+          <a:prstGeom prst="rect">
+            <a:avLst/>
+          </a:prstGeom>
+          <a:noFill/>
+        </p:spPr>
+        <p:txBody>
+          <a:bodyPr wrap="none">
+            <a:spAutoFit/>
+          </a:bodyPr>
+          <a:lstStyle/>
+          <a:p>
+            <a:pPr algn="ctr"/>
+            <a:r>
+              <a:rPr sz="1100" b="1">
+                <a:solidFill>
+                  <a:srgbClr val="FFFFFF"/>
+                </a:solidFill>
+                <a:latin typeface="微软雅黑"/>
+                <ns3:rFonts xmlns:ns3="http://schemas.openxmlformats.org/wordprocessingml/2006/main" ns3:eastAsia="微软雅黑" ns3:ascii="微软雅黑" ns3:hAnsi="微软雅黑"/>
+              </a:rPr>
+              <a:t>痛点：发现慢 + 闭环弱</a:t>
+            </a:r>
+          </a:p>
+        </p:txBody>
+      </p:sp>
+      <p:sp>
+        <p:nvSpPr>
+          <p:cNvPr id="12" name="TextBox 11"/>
+          <p:cNvSpPr txBox="1"/>
+          <p:nvPr/>
+        </p:nvSpPr>
+        <p:spPr>
+          <a:xfrm>
+            <a:off x="475488" y="1143000"/>
+            <a:ext cx="3300984" cy="3232404"/>
           </a:xfrm>
           <a:prstGeom prst="rect">
             <a:avLst/>
@@ -18253,7 +19246,7 @@
                 <a:spcPct val="120000"/>
               </a:lnSpc>
               <a:spcAft>
-                <a:spcPts val="5900"/>
+                <a:spcPts val="6200"/>
               </a:spcAft>
             </a:pPr>
             <a:r>
@@ -18262,7 +19255,7 @@
                   <a:srgbClr val="1C202C"/>
                 </a:solidFill>
                 <a:latin typeface="微软雅黑"/>
-                <ns3:rFonts xmlns:ns3="http://schemas.openxmlformats.org/wordprocessingml/2006/main" ns3:eastAsia="微软雅黑" ns3:ascii="微软雅黑" ns3:hAnsi="微软雅黑"/>
+                <ns4:rFonts xmlns:ns4="http://schemas.openxmlformats.org/wordprocessingml/2006/main" ns4:eastAsia="微软雅黑" ns4:ascii="微软雅黑" ns4:hAnsi="微软雅黑"/>
               </a:rPr>
               <a:t>● 独居老人增多，跌倒后「发现空窗」是核心痛点</a:t>
             </a:r>
@@ -18273,7 +19266,7 @@
                 <a:spcPct val="120000"/>
               </a:lnSpc>
               <a:spcAft>
-                <a:spcPts val="5900"/>
+                <a:spcPts val="6200"/>
               </a:spcAft>
             </a:pPr>
             <a:r>
@@ -18282,7 +19275,7 @@
                   <a:srgbClr val="1C202C"/>
                 </a:solidFill>
                 <a:latin typeface="微软雅黑"/>
-                <ns4:rFonts xmlns:ns4="http://schemas.openxmlformats.org/wordprocessingml/2006/main" ns4:eastAsia="微软雅黑" ns4:ascii="微软雅黑" ns4:hAnsi="微软雅黑"/>
+                <ns5:rFonts xmlns:ns5="http://schemas.openxmlformats.org/wordprocessingml/2006/main" ns5:eastAsia="微软雅黑" ns5:ascii="微软雅黑" ns5:hAnsi="微软雅黑"/>
               </a:rPr>
               <a:t>● 情感陪伴需求上升，监测设备难以形成照护闭环</a:t>
             </a:r>
@@ -18293,7 +19286,7 @@
                 <a:spcPct val="120000"/>
               </a:lnSpc>
               <a:spcAft>
-                <a:spcPts val="5900"/>
+                <a:spcPts val="6200"/>
               </a:spcAft>
             </a:pPr>
             <a:r>
@@ -18302,7 +19295,7 @@
                   <a:srgbClr val="1C202C"/>
                 </a:solidFill>
                 <a:latin typeface="微软雅黑"/>
-                <ns5:rFonts xmlns:ns5="http://schemas.openxmlformats.org/wordprocessingml/2006/main" ns5:eastAsia="微软雅黑" ns5:ascii="微软雅黑" ns5:hAnsi="微软雅黑"/>
+                <ns6:rFonts xmlns:ns6="http://schemas.openxmlformats.org/wordprocessingml/2006/main" ns6:eastAsia="微软雅黑" ns6:ascii="微软雅黑" ns6:hAnsi="微软雅黑"/>
               </a:rPr>
               <a:t>● 政策导向：智慧养老与居家安全并重</a:t>
             </a:r>
@@ -18313,7 +19306,7 @@
                 <a:spcPct val="120000"/>
               </a:lnSpc>
               <a:spcAft>
-                <a:spcPts val="5900"/>
+                <a:spcPts val="6200"/>
               </a:spcAft>
             </a:pPr>
             <a:r>
@@ -18322,7 +19315,7 @@
                   <a:srgbClr val="143278"/>
                 </a:solidFill>
                 <a:latin typeface="微软雅黑"/>
-                <ns6:rFonts xmlns:ns6="http://schemas.openxmlformats.org/wordprocessingml/2006/main" ns6:eastAsia="微软雅黑" ns6:ascii="微软雅黑" ns6:hAnsi="微软雅黑"/>
+                <ns7:rFonts xmlns:ns7="http://schemas.openxmlformats.org/wordprocessingml/2006/main" ns7:eastAsia="微软雅黑" ns7:ascii="微软雅黑" ns7:hAnsi="微软雅黑"/>
               </a:rPr>
               <a:t>● 本项目聚焦可落地的仿真验证与人形接口</a:t>
             </a:r>
@@ -18331,14 +19324,14 @@
       </p:sp>
       <p:sp>
         <p:nvSpPr>
-          <p:cNvPr id="11" name="Rectangle 10"/>
+          <p:cNvPr id="13" name="Rectangle 12"/>
           <p:cNvSpPr/>
           <p:nvPr/>
         </p:nvSpPr>
         <p:spPr>
           <a:xfrm>
-            <a:off x="4023360" y="1020713"/>
-            <a:ext cx="4892040" cy="3806161"/>
+            <a:off x="4023360" y="933975"/>
+            <a:ext cx="4892040" cy="3979637"/>
           </a:xfrm>
           <a:prstGeom prst="rect">
             <a:avLst/>
@@ -18376,7 +19369,7 @@
       </p:sp>
       <p:pic>
         <p:nvPicPr>
-          <p:cNvPr id="12" name="Picture 11" descr="aging_chart.png"/>
+          <p:cNvPr id="14" name="Picture 13" descr="aging_chart.png"/>
           <p:cNvPicPr>
             <a:picLocks noChangeAspect="1"/>
           </p:cNvPicPr>
@@ -18390,8 +19383,8 @@
         </p:blipFill>
         <p:spPr>
           <a:xfrm>
-            <a:off x="4069080" y="1066433"/>
-            <a:ext cx="4800600" cy="3531841"/>
+            <a:off x="4069080" y="979695"/>
+            <a:ext cx="4800600" cy="3705317"/>
           </a:xfrm>
           <a:prstGeom prst="rect">
             <a:avLst/>
@@ -18400,13 +19393,13 @@
       </p:pic>
       <p:sp>
         <p:nvSpPr>
-          <p:cNvPr id="13" name="TextBox 12"/>
+          <p:cNvPr id="15" name="TextBox 14"/>
           <p:cNvSpPr txBox="1"/>
           <p:nvPr/>
         </p:nvSpPr>
         <p:spPr>
           <a:xfrm>
-            <a:off x="4069080" y="4653138"/>
+            <a:off x="4069080" y="4739876"/>
             <a:ext cx="4800600" cy="182880"/>
           </a:xfrm>
           <a:prstGeom prst="rect">
@@ -18427,88 +19420,9 @@
                   <a:srgbClr val="5A6273"/>
                 </a:solidFill>
                 <a:latin typeface="微软雅黑"/>
-                <ns7:rFonts xmlns:ns7="http://schemas.openxmlformats.org/wordprocessingml/2006/main" ns7:eastAsia="微软雅黑" ns7:ascii="微软雅黑" ns7:hAnsi="微软雅黑"/>
-              </a:rPr>
-              <a:t>理论框图</a:t>
-            </a:r>
-          </a:p>
-        </p:txBody>
-      </p:sp>
-      <p:sp>
-        <p:nvSpPr>
-          <p:cNvPr id="14" name="Rectangle 13"/>
-          <p:cNvSpPr/>
-          <p:nvPr/>
-        </p:nvSpPr>
-        <p:spPr>
-          <a:xfrm>
-            <a:off x="274320" y="4539996"/>
-            <a:ext cx="3611880" cy="310896"/>
-          </a:xfrm>
-          <a:prstGeom prst="rect">
-            <a:avLst/>
-          </a:prstGeom>
-          <a:solidFill>
-            <a:srgbClr val="143278"/>
-          </a:solidFill>
-          <a:ln>
-            <a:noFill/>
-          </a:ln>
-        </p:spPr>
-        <p:style>
-          <a:lnRef idx="1">
-            <a:schemeClr val="accent1"/>
-          </a:lnRef>
-          <a:fillRef idx="3">
-            <a:schemeClr val="accent1"/>
-          </a:fillRef>
-          <a:effectRef idx="2">
-            <a:schemeClr val="accent1"/>
-          </a:effectRef>
-          <a:fontRef idx="minor">
-            <a:schemeClr val="lt1"/>
-          </a:fontRef>
-        </p:style>
-        <p:txBody>
-          <a:bodyPr rtlCol="0" anchor="ctr"/>
-          <a:lstStyle/>
-          <a:p>
-            <a:pPr algn="ctr"/>
-          </a:p>
-        </p:txBody>
-      </p:sp>
-      <p:sp>
-        <p:nvSpPr>
-          <p:cNvPr id="15" name="TextBox 14"/>
-          <p:cNvSpPr txBox="1"/>
-          <p:nvPr/>
-        </p:nvSpPr>
-        <p:spPr>
-          <a:xfrm>
-            <a:off x="384048" y="4604004"/>
-            <a:ext cx="3392424" cy="219456"/>
-          </a:xfrm>
-          <a:prstGeom prst="rect">
-            <a:avLst/>
-          </a:prstGeom>
-          <a:noFill/>
-        </p:spPr>
-        <p:txBody>
-          <a:bodyPr wrap="none">
-            <a:spAutoFit/>
-          </a:bodyPr>
-          <a:lstStyle/>
-          <a:p>
-            <a:pPr algn="ctr"/>
-            <a:r>
-              <a:rPr sz="1100" b="1">
-                <a:solidFill>
-                  <a:srgbClr val="FFFFFF"/>
-                </a:solidFill>
-                <a:latin typeface="微软雅黑"/>
                 <ns8:rFonts xmlns:ns8="http://schemas.openxmlformats.org/wordprocessingml/2006/main" ns8:eastAsia="微软雅黑" ns8:ascii="微软雅黑" ns8:hAnsi="微软雅黑"/>
               </a:rPr>
-              <a:t>痛点：发现慢 + 闭环弱</a:t>
+              <a:t>国家统计局趋势示意</a:t>
             </a:r>
           </a:p>
         </p:txBody>
@@ -18784,7 +19698,7 @@
         <p:spPr>
           <a:xfrm>
             <a:off x="274320" y="996696"/>
-            <a:ext cx="3611880" cy="3451860"/>
+            <a:ext cx="3611880" cy="3854196"/>
           </a:xfrm>
           <a:prstGeom prst="rect">
             <a:avLst/>
@@ -18829,7 +19743,7 @@
         <p:spPr>
           <a:xfrm>
             <a:off x="274320" y="996696"/>
-            <a:ext cx="73152" cy="3451860"/>
+            <a:ext cx="73152" cy="3854196"/>
           </a:xfrm>
           <a:prstGeom prst="rect">
             <a:avLst/>
@@ -18865,14 +19779,93 @@
       </p:sp>
       <p:sp>
         <p:nvSpPr>
-          <p:cNvPr id="10" name="TextBox 9"/>
+          <p:cNvPr id="10" name="Rectangle 9"/>
+          <p:cNvSpPr/>
+          <p:nvPr/>
+        </p:nvSpPr>
+        <p:spPr>
+          <a:xfrm>
+            <a:off x="347472" y="4503420"/>
+            <a:ext cx="3465576" cy="310896"/>
+          </a:xfrm>
+          <a:prstGeom prst="rect">
+            <a:avLst/>
+          </a:prstGeom>
+          <a:solidFill>
+            <a:srgbClr val="143278"/>
+          </a:solidFill>
+          <a:ln>
+            <a:noFill/>
+          </a:ln>
+        </p:spPr>
+        <p:style>
+          <a:lnRef idx="1">
+            <a:schemeClr val="accent1"/>
+          </a:lnRef>
+          <a:fillRef idx="3">
+            <a:schemeClr val="accent1"/>
+          </a:fillRef>
+          <a:effectRef idx="2">
+            <a:schemeClr val="accent1"/>
+          </a:effectRef>
+          <a:fontRef idx="minor">
+            <a:schemeClr val="lt1"/>
+          </a:fontRef>
+        </p:style>
+        <p:txBody>
+          <a:bodyPr rtlCol="0" anchor="ctr"/>
+          <a:lstStyle/>
+          <a:p>
+            <a:pPr algn="ctr"/>
+          </a:p>
+        </p:txBody>
+      </p:sp>
+      <p:sp>
+        <p:nvSpPr>
+          <p:cNvPr id="11" name="TextBox 10"/>
           <p:cNvSpPr txBox="1"/>
           <p:nvPr/>
         </p:nvSpPr>
         <p:spPr>
           <a:xfrm>
-            <a:off x="475488" y="1161288"/>
-            <a:ext cx="3300984" cy="3122676"/>
+            <a:off x="402336" y="4576572"/>
+            <a:ext cx="3355848" cy="237744"/>
+          </a:xfrm>
+          <a:prstGeom prst="rect">
+            <a:avLst/>
+          </a:prstGeom>
+          <a:noFill/>
+        </p:spPr>
+        <p:txBody>
+          <a:bodyPr wrap="none">
+            <a:spAutoFit/>
+          </a:bodyPr>
+          <a:lstStyle/>
+          <a:p>
+            <a:pPr algn="ctr"/>
+            <a:r>
+              <a:rPr sz="1100" b="1">
+                <a:solidFill>
+                  <a:srgbClr val="FFFFFF"/>
+                </a:solidFill>
+                <a:latin typeface="微软雅黑"/>
+                <ns3:rFonts xmlns:ns3="http://schemas.openxmlformats.org/wordprocessingml/2006/main" ns3:eastAsia="微软雅黑" ns3:ascii="微软雅黑" ns3:hAnsi="微软雅黑"/>
+              </a:rPr>
+              <a:t>从堆叠到一体化闭环</a:t>
+            </a:r>
+          </a:p>
+        </p:txBody>
+      </p:sp>
+      <p:sp>
+        <p:nvSpPr>
+          <p:cNvPr id="12" name="TextBox 11"/>
+          <p:cNvSpPr txBox="1"/>
+          <p:nvPr/>
+        </p:nvSpPr>
+        <p:spPr>
+          <a:xfrm>
+            <a:off x="475488" y="1143000"/>
+            <a:ext cx="3300984" cy="3232404"/>
           </a:xfrm>
           <a:prstGeom prst="rect">
             <a:avLst/>
@@ -18890,7 +19883,7 @@
                 <a:spcPct val="120000"/>
               </a:lnSpc>
               <a:spcAft>
-                <a:spcPts val="5900"/>
+                <a:spcPts val="6200"/>
               </a:spcAft>
             </a:pPr>
             <a:r>
@@ -18899,7 +19892,7 @@
                   <a:srgbClr val="1C202C"/>
                 </a:solidFill>
                 <a:latin typeface="微软雅黑"/>
-                <ns3:rFonts xmlns:ns3="http://schemas.openxmlformats.org/wordprocessingml/2006/main" ns3:eastAsia="微软雅黑" ns3:ascii="微软雅黑" ns3:hAnsi="微软雅黑"/>
+                <ns4:rFonts xmlns:ns4="http://schemas.openxmlformats.org/wordprocessingml/2006/main" ns4:eastAsia="微软雅黑" ns4:ascii="微软雅黑" ns4:hAnsi="微软雅黑"/>
               </a:rPr>
               <a:t>● 传统音箱/摄像头/手环：功能割裂</a:t>
             </a:r>
@@ -18910,7 +19903,7 @@
                 <a:spcPct val="120000"/>
               </a:lnSpc>
               <a:spcAft>
-                <a:spcPts val="5900"/>
+                <a:spcPts val="6200"/>
               </a:spcAft>
             </a:pPr>
             <a:r>
@@ -18919,7 +19912,7 @@
                   <a:srgbClr val="1C202C"/>
                 </a:solidFill>
                 <a:latin typeface="微软雅黑"/>
-                <ns4:rFonts xmlns:ns4="http://schemas.openxmlformats.org/wordprocessingml/2006/main" ns4:eastAsia="微软雅黑" ns4:ascii="微软雅黑" ns4:hAnsi="微软雅黑"/>
+                <ns5:rFonts xmlns:ns5="http://schemas.openxmlformats.org/wordprocessingml/2006/main" ns5:eastAsia="微软雅黑" ns5:ascii="微软雅黑" ns5:hAnsi="微软雅黑"/>
               </a:rPr>
               <a:t>● 本作品：感知—决策—执行统一编排</a:t>
             </a:r>
@@ -18930,7 +19923,7 @@
                 <a:spcPct val="120000"/>
               </a:lnSpc>
               <a:spcAft>
-                <a:spcPts val="5900"/>
+                <a:spcPts val="6200"/>
               </a:spcAft>
             </a:pPr>
             <a:r>
@@ -18939,7 +19932,7 @@
                   <a:srgbClr val="1C202C"/>
                 </a:solidFill>
                 <a:latin typeface="微软雅黑"/>
-                <ns5:rFonts xmlns:ns5="http://schemas.openxmlformats.org/wordprocessingml/2006/main" ns5:eastAsia="微软雅黑" ns5:ascii="微软雅黑" ns5:hAnsi="微软雅黑"/>
+                <ns6:rFonts xmlns:ns6="http://schemas.openxmlformats.org/wordprocessingml/2006/main" ns6:eastAsia="微软雅黑" ns6:ascii="微软雅黑" ns6:hAnsi="微软雅黑"/>
               </a:rPr>
               <a:t>● 强调可解释风险与紧急硬优先级</a:t>
             </a:r>
@@ -18950,7 +19943,7 @@
                 <a:spcPct val="120000"/>
               </a:lnSpc>
               <a:spcAft>
-                <a:spcPts val="5900"/>
+                <a:spcPts val="6200"/>
               </a:spcAft>
             </a:pPr>
             <a:r>
@@ -18959,7 +19952,7 @@
                   <a:srgbClr val="1C202C"/>
                 </a:solidFill>
                 <a:latin typeface="微软雅黑"/>
-                <ns6:rFonts xmlns:ns6="http://schemas.openxmlformats.org/wordprocessingml/2006/main" ns6:eastAsia="微软雅黑" ns6:ascii="微软雅黑" ns6:hAnsi="微软雅黑"/>
+                <ns7:rFonts xmlns:ns7="http://schemas.openxmlformats.org/wordprocessingml/2006/main" ns7:eastAsia="微软雅黑" ns7:ascii="微软雅黑" ns7:hAnsi="微软雅黑"/>
               </a:rPr>
               <a:t>● 配套 Web 演示与量化评测脚本</a:t>
             </a:r>
@@ -18968,7 +19961,7 @@
       </p:sp>
       <p:sp>
         <p:nvSpPr>
-          <p:cNvPr id="11" name="Rectangle 10"/>
+          <p:cNvPr id="13" name="Rectangle 12"/>
           <p:cNvSpPr/>
           <p:nvPr/>
         </p:nvSpPr>
@@ -19013,7 +20006,7 @@
       </p:sp>
       <p:pic>
         <p:nvPicPr>
-          <p:cNvPr id="12" name="Picture 11" descr="compare.png"/>
+          <p:cNvPr id="14" name="Picture 13" descr="compare.png"/>
           <p:cNvPicPr>
             <a:picLocks noChangeAspect="1"/>
           </p:cNvPicPr>
@@ -19037,7 +20030,7 @@
       </p:pic>
       <p:sp>
         <p:nvSpPr>
-          <p:cNvPr id="13" name="TextBox 12"/>
+          <p:cNvPr id="15" name="TextBox 14"/>
           <p:cNvSpPr txBox="1"/>
           <p:nvPr/>
         </p:nvSpPr>
@@ -19064,88 +20057,9 @@
                   <a:srgbClr val="5A6273"/>
                 </a:solidFill>
                 <a:latin typeface="微软雅黑"/>
-                <ns7:rFonts xmlns:ns7="http://schemas.openxmlformats.org/wordprocessingml/2006/main" ns7:eastAsia="微软雅黑" ns7:ascii="微软雅黑" ns7:hAnsi="微软雅黑"/>
+                <ns8:rFonts xmlns:ns8="http://schemas.openxmlformats.org/wordprocessingml/2006/main" ns8:eastAsia="微软雅黑" ns8:ascii="微软雅黑" ns8:hAnsi="微软雅黑"/>
               </a:rPr>
               <a:t>理论框图</a:t>
-            </a:r>
-          </a:p>
-        </p:txBody>
-      </p:sp>
-      <p:sp>
-        <p:nvSpPr>
-          <p:cNvPr id="14" name="Rectangle 13"/>
-          <p:cNvSpPr/>
-          <p:nvPr/>
-        </p:nvSpPr>
-        <p:spPr>
-          <a:xfrm>
-            <a:off x="274320" y="4539996"/>
-            <a:ext cx="3611880" cy="310896"/>
-          </a:xfrm>
-          <a:prstGeom prst="rect">
-            <a:avLst/>
-          </a:prstGeom>
-          <a:solidFill>
-            <a:srgbClr val="143278"/>
-          </a:solidFill>
-          <a:ln>
-            <a:noFill/>
-          </a:ln>
-        </p:spPr>
-        <p:style>
-          <a:lnRef idx="1">
-            <a:schemeClr val="accent1"/>
-          </a:lnRef>
-          <a:fillRef idx="3">
-            <a:schemeClr val="accent1"/>
-          </a:fillRef>
-          <a:effectRef idx="2">
-            <a:schemeClr val="accent1"/>
-          </a:effectRef>
-          <a:fontRef idx="minor">
-            <a:schemeClr val="lt1"/>
-          </a:fontRef>
-        </p:style>
-        <p:txBody>
-          <a:bodyPr rtlCol="0" anchor="ctr"/>
-          <a:lstStyle/>
-          <a:p>
-            <a:pPr algn="ctr"/>
-          </a:p>
-        </p:txBody>
-      </p:sp>
-      <p:sp>
-        <p:nvSpPr>
-          <p:cNvPr id="15" name="TextBox 14"/>
-          <p:cNvSpPr txBox="1"/>
-          <p:nvPr/>
-        </p:nvSpPr>
-        <p:spPr>
-          <a:xfrm>
-            <a:off x="384048" y="4604004"/>
-            <a:ext cx="3392424" cy="219456"/>
-          </a:xfrm>
-          <a:prstGeom prst="rect">
-            <a:avLst/>
-          </a:prstGeom>
-          <a:noFill/>
-        </p:spPr>
-        <p:txBody>
-          <a:bodyPr wrap="none">
-            <a:spAutoFit/>
-          </a:bodyPr>
-          <a:lstStyle/>
-          <a:p>
-            <a:pPr algn="ctr"/>
-            <a:r>
-              <a:rPr sz="1100" b="1">
-                <a:solidFill>
-                  <a:srgbClr val="FFFFFF"/>
-                </a:solidFill>
-                <a:latin typeface="微软雅黑"/>
-                <ns8:rFonts xmlns:ns8="http://schemas.openxmlformats.org/wordprocessingml/2006/main" ns8:eastAsia="微软雅黑" ns8:ascii="微软雅黑" ns8:hAnsi="微软雅黑"/>
-              </a:rPr>
-              <a:t>从堆叠到一体化闭环</a:t>
             </a:r>
           </a:p>
         </p:txBody>
@@ -19421,7 +20335,7 @@
         <p:spPr>
           <a:xfrm>
             <a:off x="274320" y="996696"/>
-            <a:ext cx="3611880" cy="3451860"/>
+            <a:ext cx="3611880" cy="3854196"/>
           </a:xfrm>
           <a:prstGeom prst="rect">
             <a:avLst/>
@@ -19466,7 +20380,7 @@
         <p:spPr>
           <a:xfrm>
             <a:off x="274320" y="996696"/>
-            <a:ext cx="73152" cy="3451860"/>
+            <a:ext cx="73152" cy="3854196"/>
           </a:xfrm>
           <a:prstGeom prst="rect">
             <a:avLst/>
@@ -19502,14 +20416,93 @@
       </p:sp>
       <p:sp>
         <p:nvSpPr>
-          <p:cNvPr id="10" name="TextBox 9"/>
+          <p:cNvPr id="10" name="Rectangle 9"/>
+          <p:cNvSpPr/>
+          <p:nvPr/>
+        </p:nvSpPr>
+        <p:spPr>
+          <a:xfrm>
+            <a:off x="347472" y="4503420"/>
+            <a:ext cx="3465576" cy="310896"/>
+          </a:xfrm>
+          <a:prstGeom prst="rect">
+            <a:avLst/>
+          </a:prstGeom>
+          <a:solidFill>
+            <a:srgbClr val="143278"/>
+          </a:solidFill>
+          <a:ln>
+            <a:noFill/>
+          </a:ln>
+        </p:spPr>
+        <p:style>
+          <a:lnRef idx="1">
+            <a:schemeClr val="accent1"/>
+          </a:lnRef>
+          <a:fillRef idx="3">
+            <a:schemeClr val="accent1"/>
+          </a:fillRef>
+          <a:effectRef idx="2">
+            <a:schemeClr val="accent1"/>
+          </a:effectRef>
+          <a:fontRef idx="minor">
+            <a:schemeClr val="lt1"/>
+          </a:fontRef>
+        </p:style>
+        <p:txBody>
+          <a:bodyPr rtlCol="0" anchor="ctr"/>
+          <a:lstStyle/>
+          <a:p>
+            <a:pPr algn="ctr"/>
+          </a:p>
+        </p:txBody>
+      </p:sp>
+      <p:sp>
+        <p:nvSpPr>
+          <p:cNvPr id="11" name="TextBox 10"/>
           <p:cNvSpPr txBox="1"/>
           <p:nvPr/>
         </p:nvSpPr>
         <p:spPr>
           <a:xfrm>
-            <a:off x="475488" y="1161288"/>
-            <a:ext cx="3300984" cy="3122676"/>
+            <a:off x="402336" y="4576572"/>
+            <a:ext cx="3355848" cy="237744"/>
+          </a:xfrm>
+          <a:prstGeom prst="rect">
+            <a:avLst/>
+          </a:prstGeom>
+          <a:noFill/>
+        </p:spPr>
+        <p:txBody>
+          <a:bodyPr wrap="none">
+            <a:spAutoFit/>
+          </a:bodyPr>
+          <a:lstStyle/>
+          <a:p>
+            <a:pPr algn="ctr"/>
+            <a:r>
+              <a:rPr sz="1100" b="1">
+                <a:solidFill>
+                  <a:srgbClr val="FFFFFF"/>
+                </a:solidFill>
+                <a:latin typeface="微软雅黑"/>
+                <ns3:rFonts xmlns:ns3="http://schemas.openxmlformats.org/wordprocessingml/2006/main" ns3:eastAsia="微软雅黑" ns3:ascii="微软雅黑" ns3:hAnsi="微软雅黑"/>
+              </a:rPr>
+              <a:t>三大目标均可现场验证</a:t>
+            </a:r>
+          </a:p>
+        </p:txBody>
+      </p:sp>
+      <p:sp>
+        <p:nvSpPr>
+          <p:cNvPr id="12" name="TextBox 11"/>
+          <p:cNvSpPr txBox="1"/>
+          <p:nvPr/>
+        </p:nvSpPr>
+        <p:spPr>
+          <a:xfrm>
+            <a:off x="475488" y="1143000"/>
+            <a:ext cx="3300984" cy="3232404"/>
           </a:xfrm>
           <a:prstGeom prst="rect">
             <a:avLst/>
@@ -19527,7 +20520,7 @@
                 <a:spcPct val="120000"/>
               </a:lnSpc>
               <a:spcAft>
-                <a:spcPts val="4000"/>
+                <a:spcPts val="4200"/>
               </a:spcAft>
             </a:pPr>
             <a:r>
@@ -19536,7 +20529,7 @@
                   <a:srgbClr val="1C202C"/>
                 </a:solidFill>
                 <a:latin typeface="微软雅黑"/>
-                <ns3:rFonts xmlns:ns3="http://schemas.openxmlformats.org/wordprocessingml/2006/main" ns3:eastAsia="微软雅黑" ns3:ascii="微软雅黑" ns3:hAnsi="微软雅黑"/>
+                <ns4:rFonts xmlns:ns4="http://schemas.openxmlformats.org/wordprocessingml/2006/main" ns4:eastAsia="微软雅黑" ns4:ascii="微软雅黑" ns4:hAnsi="微软雅黑"/>
               </a:rPr>
               <a:t>● CareCompanion：养老人形陪伴软件平台</a:t>
             </a:r>
@@ -19547,7 +20540,7 @@
                 <a:spcPct val="120000"/>
               </a:lnSpc>
               <a:spcAft>
-                <a:spcPts val="4000"/>
+                <a:spcPts val="4200"/>
               </a:spcAft>
             </a:pPr>
             <a:r>
@@ -19556,7 +20549,7 @@
                   <a:srgbClr val="1C202C"/>
                 </a:solidFill>
                 <a:latin typeface="微软雅黑"/>
-                <ns4:rFonts xmlns:ns4="http://schemas.openxmlformats.org/wordprocessingml/2006/main" ns4:eastAsia="微软雅黑" ns4:ascii="微软雅黑" ns4:hAnsi="微软雅黑"/>
+                <ns5:rFonts xmlns:ns5="http://schemas.openxmlformats.org/wordprocessingml/2006/main" ns5:eastAsia="微软雅黑" ns5:ascii="微软雅黑" ns5:hAnsi="微软雅黑"/>
               </a:rPr>
               <a:t>● CareOrchestrator 统一调度各模块</a:t>
             </a:r>
@@ -19567,7 +20560,7 @@
                 <a:spcPct val="120000"/>
               </a:lnSpc>
               <a:spcAft>
-                <a:spcPts val="4000"/>
+                <a:spcPts val="4200"/>
               </a:spcAft>
             </a:pPr>
             <a:r>
@@ -19576,7 +20569,7 @@
                   <a:srgbClr val="1C202C"/>
                 </a:solidFill>
                 <a:latin typeface="微软雅黑"/>
-                <ns5:rFonts xmlns:ns5="http://schemas.openxmlformats.org/wordprocessingml/2006/main" ns5:eastAsia="微软雅黑" ns5:ascii="微软雅黑" ns5:hAnsi="微软雅黑"/>
+                <ns6:rFonts xmlns:ns6="http://schemas.openxmlformats.org/wordprocessingml/2006/main" ns6:eastAsia="微软雅黑" ns6:ascii="微软雅黑" ns6:hAnsi="微软雅黑"/>
               </a:rPr>
               <a:t>● 目标1：跌倒检测与紧急呼叫自动化</a:t>
             </a:r>
@@ -19587,7 +20580,7 @@
                 <a:spcPct val="120000"/>
               </a:lnSpc>
               <a:spcAft>
-                <a:spcPts val="4000"/>
+                <a:spcPts val="4200"/>
               </a:spcAft>
             </a:pPr>
             <a:r>
@@ -19596,7 +20589,7 @@
                   <a:srgbClr val="1C202C"/>
                 </a:solidFill>
                 <a:latin typeface="微软雅黑"/>
-                <ns6:rFonts xmlns:ns6="http://schemas.openxmlformats.org/wordprocessingml/2006/main" ns6:eastAsia="微软雅黑" ns6:ascii="微软雅黑" ns6:hAnsi="微软雅黑"/>
+                <ns7:rFonts xmlns:ns7="http://schemas.openxmlformats.org/wordprocessingml/2006/main" ns7:eastAsia="微软雅黑" ns7:ascii="微软雅黑" ns7:hAnsi="微软雅黑"/>
               </a:rPr>
               <a:t>● 目标2：情感对话与机器人动作联动</a:t>
             </a:r>
@@ -19607,7 +20600,7 @@
                 <a:spcPct val="120000"/>
               </a:lnSpc>
               <a:spcAft>
-                <a:spcPts val="4000"/>
+                <a:spcPts val="4200"/>
               </a:spcAft>
             </a:pPr>
             <a:r>
@@ -19616,7 +20609,7 @@
                   <a:srgbClr val="1C202C"/>
                 </a:solidFill>
                 <a:latin typeface="微软雅黑"/>
-                <ns7:rFonts xmlns:ns7="http://schemas.openxmlformats.org/wordprocessingml/2006/main" ns7:eastAsia="微软雅黑" ns7:ascii="微软雅黑" ns7:hAnsi="微软雅黑"/>
+                <ns8:rFonts xmlns:ns8="http://schemas.openxmlformats.org/wordprocessingml/2006/main" ns8:eastAsia="微软雅黑" ns8:ascii="微软雅黑" ns8:hAnsi="微软雅黑"/>
               </a:rPr>
               <a:t>● 目标3：ROS2 部署接口 + 开源可复现</a:t>
             </a:r>
@@ -19625,7 +20618,7 @@
       </p:sp>
       <p:sp>
         <p:nvSpPr>
-          <p:cNvPr id="11" name="Rectangle 10"/>
+          <p:cNvPr id="13" name="Rectangle 12"/>
           <p:cNvSpPr/>
           <p:nvPr/>
         </p:nvSpPr>
@@ -19670,7 +20663,7 @@
       </p:sp>
       <p:pic>
         <p:nvPicPr>
-          <p:cNvPr id="12" name="Picture 11" descr="architecture.png"/>
+          <p:cNvPr id="14" name="Picture 13" descr="architecture.png"/>
           <p:cNvPicPr>
             <a:picLocks noChangeAspect="1"/>
           </p:cNvPicPr>
@@ -19694,7 +20687,7 @@
       </p:pic>
       <p:sp>
         <p:nvSpPr>
-          <p:cNvPr id="13" name="TextBox 12"/>
+          <p:cNvPr id="15" name="TextBox 14"/>
           <p:cNvSpPr txBox="1"/>
           <p:nvPr/>
         </p:nvSpPr>
@@ -19721,88 +20714,9 @@
                   <a:srgbClr val="5A6273"/>
                 </a:solidFill>
                 <a:latin typeface="微软雅黑"/>
-                <ns8:rFonts xmlns:ns8="http://schemas.openxmlformats.org/wordprocessingml/2006/main" ns8:eastAsia="微软雅黑" ns8:ascii="微软雅黑" ns8:hAnsi="微软雅黑"/>
+                <ns9:rFonts xmlns:ns9="http://schemas.openxmlformats.org/wordprocessingml/2006/main" ns9:eastAsia="微软雅黑" ns9:ascii="微软雅黑" ns9:hAnsi="微软雅黑"/>
               </a:rPr>
               <a:t>理论框图</a:t>
-            </a:r>
-          </a:p>
-        </p:txBody>
-      </p:sp>
-      <p:sp>
-        <p:nvSpPr>
-          <p:cNvPr id="14" name="Rectangle 13"/>
-          <p:cNvSpPr/>
-          <p:nvPr/>
-        </p:nvSpPr>
-        <p:spPr>
-          <a:xfrm>
-            <a:off x="274320" y="4539996"/>
-            <a:ext cx="3611880" cy="310896"/>
-          </a:xfrm>
-          <a:prstGeom prst="rect">
-            <a:avLst/>
-          </a:prstGeom>
-          <a:solidFill>
-            <a:srgbClr val="143278"/>
-          </a:solidFill>
-          <a:ln>
-            <a:noFill/>
-          </a:ln>
-        </p:spPr>
-        <p:style>
-          <a:lnRef idx="1">
-            <a:schemeClr val="accent1"/>
-          </a:lnRef>
-          <a:fillRef idx="3">
-            <a:schemeClr val="accent1"/>
-          </a:fillRef>
-          <a:effectRef idx="2">
-            <a:schemeClr val="accent1"/>
-          </a:effectRef>
-          <a:fontRef idx="minor">
-            <a:schemeClr val="lt1"/>
-          </a:fontRef>
-        </p:style>
-        <p:txBody>
-          <a:bodyPr rtlCol="0" anchor="ctr"/>
-          <a:lstStyle/>
-          <a:p>
-            <a:pPr algn="ctr"/>
-          </a:p>
-        </p:txBody>
-      </p:sp>
-      <p:sp>
-        <p:nvSpPr>
-          <p:cNvPr id="15" name="TextBox 14"/>
-          <p:cNvSpPr txBox="1"/>
-          <p:nvPr/>
-        </p:nvSpPr>
-        <p:spPr>
-          <a:xfrm>
-            <a:off x="384048" y="4604004"/>
-            <a:ext cx="3392424" cy="219456"/>
-          </a:xfrm>
-          <a:prstGeom prst="rect">
-            <a:avLst/>
-          </a:prstGeom>
-          <a:noFill/>
-        </p:spPr>
-        <p:txBody>
-          <a:bodyPr wrap="none">
-            <a:spAutoFit/>
-          </a:bodyPr>
-          <a:lstStyle/>
-          <a:p>
-            <a:pPr algn="ctr"/>
-            <a:r>
-              <a:rPr sz="1100" b="1">
-                <a:solidFill>
-                  <a:srgbClr val="FFFFFF"/>
-                </a:solidFill>
-                <a:latin typeface="微软雅黑"/>
-                <ns9:rFonts xmlns:ns9="http://schemas.openxmlformats.org/wordprocessingml/2006/main" ns9:eastAsia="微软雅黑" ns9:ascii="微软雅黑" ns9:hAnsi="微软雅黑"/>
-              </a:rPr>
-              <a:t>三大目标均可现场验证</a:t>
             </a:r>
           </a:p>
         </p:txBody>
@@ -20760,7 +21674,7 @@
         <p:spPr>
           <a:xfrm>
             <a:off x="274320" y="996696"/>
-            <a:ext cx="3611880" cy="3451860"/>
+            <a:ext cx="3611880" cy="3854196"/>
           </a:xfrm>
           <a:prstGeom prst="rect">
             <a:avLst/>
@@ -20805,7 +21719,7 @@
         <p:spPr>
           <a:xfrm>
             <a:off x="274320" y="996696"/>
-            <a:ext cx="73152" cy="3451860"/>
+            <a:ext cx="73152" cy="3854196"/>
           </a:xfrm>
           <a:prstGeom prst="rect">
             <a:avLst/>
@@ -20841,14 +21755,93 @@
       </p:sp>
       <p:sp>
         <p:nvSpPr>
-          <p:cNvPr id="10" name="TextBox 9"/>
+          <p:cNvPr id="10" name="Rectangle 9"/>
+          <p:cNvSpPr/>
+          <p:nvPr/>
+        </p:nvSpPr>
+        <p:spPr>
+          <a:xfrm>
+            <a:off x="347472" y="4503420"/>
+            <a:ext cx="3465576" cy="310896"/>
+          </a:xfrm>
+          <a:prstGeom prst="rect">
+            <a:avLst/>
+          </a:prstGeom>
+          <a:solidFill>
+            <a:srgbClr val="143278"/>
+          </a:solidFill>
+          <a:ln>
+            <a:noFill/>
+          </a:ln>
+        </p:spPr>
+        <p:style>
+          <a:lnRef idx="1">
+            <a:schemeClr val="accent1"/>
+          </a:lnRef>
+          <a:fillRef idx="3">
+            <a:schemeClr val="accent1"/>
+          </a:fillRef>
+          <a:effectRef idx="2">
+            <a:schemeClr val="accent1"/>
+          </a:effectRef>
+          <a:fontRef idx="minor">
+            <a:schemeClr val="lt1"/>
+          </a:fontRef>
+        </p:style>
+        <p:txBody>
+          <a:bodyPr rtlCol="0" anchor="ctr"/>
+          <a:lstStyle/>
+          <a:p>
+            <a:pPr algn="ctr"/>
+          </a:p>
+        </p:txBody>
+      </p:sp>
+      <p:sp>
+        <p:nvSpPr>
+          <p:cNvPr id="11" name="TextBox 10"/>
           <p:cNvSpPr txBox="1"/>
           <p:nvPr/>
         </p:nvSpPr>
         <p:spPr>
           <a:xfrm>
-            <a:off x="475488" y="1161288"/>
-            <a:ext cx="3300984" cy="3122676"/>
+            <a:off x="402336" y="4576572"/>
+            <a:ext cx="3355848" cy="237744"/>
+          </a:xfrm>
+          <a:prstGeom prst="rect">
+            <a:avLst/>
+          </a:prstGeom>
+          <a:noFill/>
+        </p:spPr>
+        <p:txBody>
+          <a:bodyPr wrap="none">
+            <a:spAutoFit/>
+          </a:bodyPr>
+          <a:lstStyle/>
+          <a:p>
+            <a:pPr algn="ctr"/>
+            <a:r>
+              <a:rPr sz="1100" b="1">
+                <a:solidFill>
+                  <a:srgbClr val="FFFFFF"/>
+                </a:solidFill>
+                <a:latin typeface="微软雅黑"/>
+                <ns3:rFonts xmlns:ns3="http://schemas.openxmlformats.org/wordprocessingml/2006/main" ns3:eastAsia="微软雅黑" ns3:ascii="微软雅黑" ns3:hAnsi="微软雅黑"/>
+              </a:rPr>
+              <a:t>理论清晰、可替换</a:t>
+            </a:r>
+          </a:p>
+        </p:txBody>
+      </p:sp>
+      <p:sp>
+        <p:nvSpPr>
+          <p:cNvPr id="12" name="TextBox 11"/>
+          <p:cNvSpPr txBox="1"/>
+          <p:nvPr/>
+        </p:nvSpPr>
+        <p:spPr>
+          <a:xfrm>
+            <a:off x="475488" y="1143000"/>
+            <a:ext cx="3300984" cy="3232404"/>
           </a:xfrm>
           <a:prstGeom prst="rect">
             <a:avLst/>
@@ -20866,7 +21859,7 @@
                 <a:spcPct val="120000"/>
               </a:lnSpc>
               <a:spcAft>
-                <a:spcPts val="5900"/>
+                <a:spcPts val="6200"/>
               </a:spcAft>
             </a:pPr>
             <a:r>
@@ -20875,7 +21868,7 @@
                   <a:srgbClr val="1C202C"/>
                 </a:solidFill>
                 <a:latin typeface="微软雅黑"/>
-                <ns3:rFonts xmlns:ns3="http://schemas.openxmlformats.org/wordprocessingml/2006/main" ns3:eastAsia="微软雅黑" ns3:ascii="微软雅黑" ns3:hAnsi="微软雅黑"/>
+                <ns4:rFonts xmlns:ns4="http://schemas.openxmlformats.org/wordprocessingml/2006/main" ns4:eastAsia="微软雅黑" ns4:ascii="微软雅黑" ns4:hAnsi="微软雅黑"/>
               </a:rPr>
               <a:t>● 四层架构：感知 / 认知 / 执行 / 交互</a:t>
             </a:r>
@@ -20886,7 +21879,7 @@
                 <a:spcPct val="120000"/>
               </a:lnSpc>
               <a:spcAft>
-                <a:spcPts val="5900"/>
+                <a:spcPts val="6200"/>
               </a:spcAft>
             </a:pPr>
             <a:r>
@@ -20895,7 +21888,7 @@
                   <a:srgbClr val="1C202C"/>
                 </a:solidFill>
                 <a:latin typeface="微软雅黑"/>
-                <ns4:rFonts xmlns:ns4="http://schemas.openxmlformats.org/wordprocessingml/2006/main" ns4:eastAsia="微软雅黑" ns4:ascii="微软雅黑" ns4:hAnsi="微软雅黑"/>
+                <ns5:rFonts xmlns:ns5="http://schemas.openxmlformats.org/wordprocessingml/2006/main" ns5:eastAsia="微软雅黑" ns5:ascii="微软雅黑" ns5:hAnsi="微软雅黑"/>
               </a:rPr>
               <a:t>● 核心：CareOrchestrator + 状态机</a:t>
             </a:r>
@@ -20906,7 +21899,7 @@
                 <a:spcPct val="120000"/>
               </a:lnSpc>
               <a:spcAft>
-                <a:spcPts val="5900"/>
+                <a:spcPts val="6200"/>
               </a:spcAft>
             </a:pPr>
             <a:r>
@@ -20915,7 +21908,7 @@
                   <a:srgbClr val="1C202C"/>
                 </a:solidFill>
                 <a:latin typeface="微软雅黑"/>
-                <ns5:rFonts xmlns:ns5="http://schemas.openxmlformats.org/wordprocessingml/2006/main" ns5:eastAsia="微软雅黑" ns5:ascii="微软雅黑" ns5:hAnsi="微软雅黑"/>
+                <ns6:rFonts xmlns:ns6="http://schemas.openxmlformats.org/wordprocessingml/2006/main" ns6:eastAsia="微软雅黑" ns6:ascii="微软雅黑" ns6:hAnsi="微软雅黑"/>
               </a:rPr>
               <a:t>● 模块可替换：仿真、Web、ROS2 共用一套逻辑</a:t>
             </a:r>
@@ -20926,7 +21919,7 @@
                 <a:spcPct val="120000"/>
               </a:lnSpc>
               <a:spcAft>
-                <a:spcPts val="5900"/>
+                <a:spcPts val="6200"/>
               </a:spcAft>
             </a:pPr>
             <a:r>
@@ -20935,7 +21928,7 @@
                   <a:srgbClr val="1C202C"/>
                 </a:solidFill>
                 <a:latin typeface="微软雅黑"/>
-                <ns6:rFonts xmlns:ns6="http://schemas.openxmlformats.org/wordprocessingml/2006/main" ns6:eastAsia="微软雅黑" ns6:ascii="微软雅黑" ns6:hAnsi="微软雅黑"/>
+                <ns7:rFonts xmlns:ns7="http://schemas.openxmlformats.org/wordprocessingml/2006/main" ns7:eastAsia="微软雅黑" ns7:ascii="微软雅黑" ns7:hAnsi="微软雅黑"/>
               </a:rPr>
               <a:t>● 配置集中于 config/default.yaml</a:t>
             </a:r>
@@ -20944,7 +21937,7 @@
       </p:sp>
       <p:sp>
         <p:nvSpPr>
-          <p:cNvPr id="11" name="Rectangle 10"/>
+          <p:cNvPr id="13" name="Rectangle 12"/>
           <p:cNvSpPr/>
           <p:nvPr/>
         </p:nvSpPr>
@@ -20989,7 +21982,7 @@
       </p:sp>
       <p:pic>
         <p:nvPicPr>
-          <p:cNvPr id="12" name="Picture 11" descr="architecture.png"/>
+          <p:cNvPr id="14" name="Picture 13" descr="architecture.png"/>
           <p:cNvPicPr>
             <a:picLocks noChangeAspect="1"/>
           </p:cNvPicPr>
@@ -21013,7 +22006,7 @@
       </p:pic>
       <p:sp>
         <p:nvSpPr>
-          <p:cNvPr id="13" name="TextBox 12"/>
+          <p:cNvPr id="15" name="TextBox 14"/>
           <p:cNvSpPr txBox="1"/>
           <p:nvPr/>
         </p:nvSpPr>
@@ -21040,88 +22033,9 @@
                   <a:srgbClr val="5A6273"/>
                 </a:solidFill>
                 <a:latin typeface="微软雅黑"/>
-                <ns7:rFonts xmlns:ns7="http://schemas.openxmlformats.org/wordprocessingml/2006/main" ns7:eastAsia="微软雅黑" ns7:ascii="微软雅黑" ns7:hAnsi="微软雅黑"/>
+                <ns8:rFonts xmlns:ns8="http://schemas.openxmlformats.org/wordprocessingml/2006/main" ns8:eastAsia="微软雅黑" ns8:ascii="微软雅黑" ns8:hAnsi="微软雅黑"/>
               </a:rPr>
               <a:t>四层架构</a:t>
-            </a:r>
-          </a:p>
-        </p:txBody>
-      </p:sp>
-      <p:sp>
-        <p:nvSpPr>
-          <p:cNvPr id="14" name="Rectangle 13"/>
-          <p:cNvSpPr/>
-          <p:nvPr/>
-        </p:nvSpPr>
-        <p:spPr>
-          <a:xfrm>
-            <a:off x="274320" y="4539996"/>
-            <a:ext cx="3611880" cy="310896"/>
-          </a:xfrm>
-          <a:prstGeom prst="rect">
-            <a:avLst/>
-          </a:prstGeom>
-          <a:solidFill>
-            <a:srgbClr val="143278"/>
-          </a:solidFill>
-          <a:ln>
-            <a:noFill/>
-          </a:ln>
-        </p:spPr>
-        <p:style>
-          <a:lnRef idx="1">
-            <a:schemeClr val="accent1"/>
-          </a:lnRef>
-          <a:fillRef idx="3">
-            <a:schemeClr val="accent1"/>
-          </a:fillRef>
-          <a:effectRef idx="2">
-            <a:schemeClr val="accent1"/>
-          </a:effectRef>
-          <a:fontRef idx="minor">
-            <a:schemeClr val="lt1"/>
-          </a:fontRef>
-        </p:style>
-        <p:txBody>
-          <a:bodyPr rtlCol="0" anchor="ctr"/>
-          <a:lstStyle/>
-          <a:p>
-            <a:pPr algn="ctr"/>
-          </a:p>
-        </p:txBody>
-      </p:sp>
-      <p:sp>
-        <p:nvSpPr>
-          <p:cNvPr id="15" name="TextBox 14"/>
-          <p:cNvSpPr txBox="1"/>
-          <p:nvPr/>
-        </p:nvSpPr>
-        <p:spPr>
-          <a:xfrm>
-            <a:off x="384048" y="4604004"/>
-            <a:ext cx="3392424" cy="219456"/>
-          </a:xfrm>
-          <a:prstGeom prst="rect">
-            <a:avLst/>
-          </a:prstGeom>
-          <a:noFill/>
-        </p:spPr>
-        <p:txBody>
-          <a:bodyPr wrap="none">
-            <a:spAutoFit/>
-          </a:bodyPr>
-          <a:lstStyle/>
-          <a:p>
-            <a:pPr algn="ctr"/>
-            <a:r>
-              <a:rPr sz="1100" b="1">
-                <a:solidFill>
-                  <a:srgbClr val="FFFFFF"/>
-                </a:solidFill>
-                <a:latin typeface="微软雅黑"/>
-                <ns8:rFonts xmlns:ns8="http://schemas.openxmlformats.org/wordprocessingml/2006/main" ns8:eastAsia="微软雅黑" ns8:ascii="微软雅黑" ns8:hAnsi="微软雅黑"/>
-              </a:rPr>
-              <a:t>理论清晰、可替换</a:t>
             </a:r>
           </a:p>
         </p:txBody>

</xml_diff>

<commit_message>
docs: refresh defense pptx with sci figure set
Co-authored-by: Cursor <cursoragent@cursor.com>
</commit_message>
<xml_diff>
--- a/docs/答辩_CareCompanion.pptx
+++ b/docs/答辩_CareCompanion.pptx
@@ -19982,8 +19982,8 @@
         </p:nvSpPr>
         <p:spPr>
           <a:xfrm>
-            <a:off x="4023359" y="904006"/>
-            <a:ext cx="4892040" cy="4039575"/>
+            <a:off x="3295588" y="1005840"/>
+            <a:ext cx="6347582" cy="3835908"/>
           </a:xfrm>
           <a:prstGeom prst="rect">
             <a:avLst/>
@@ -20035,8 +20035,8 @@
         </p:blipFill>
         <p:spPr>
           <a:xfrm>
-            <a:off x="4069079" y="949726"/>
-            <a:ext cx="4800600" cy="3765255"/>
+            <a:off x="3341308" y="1051560"/>
+            <a:ext cx="6256142" cy="3561588"/>
           </a:xfrm>
           <a:prstGeom prst="rect">
             <a:avLst/>
@@ -20051,7 +20051,7 @@
         </p:nvSpPr>
         <p:spPr>
           <a:xfrm>
-            <a:off x="4069080" y="4769845"/>
+            <a:off x="4069080" y="4668012"/>
             <a:ext cx="4800600" cy="182880"/>
           </a:xfrm>
           <a:prstGeom prst="rect">

</xml_diff>

<commit_message>
fix: PPT figure overlap, clean pose asset, dedupe captions
Redesign architecture and sequence diagrams without layer occlusion, fix decision-tree multiline labels, strip duplicate Fig titles from charts, and remove watermark from pose demo image.

Co-authored-by: Cursor <cursoragent@cursor.com>
</commit_message>
<xml_diff>
--- a/docs/答辩_CareCompanion.pptx
+++ b/docs/答辩_CareCompanion.pptx
@@ -3246,8 +3246,8 @@
         </p:nvSpPr>
         <p:spPr>
           <a:xfrm>
-            <a:off x="863200" y="536158"/>
-            <a:ext cx="2845599" cy="4226631"/>
+            <a:off x="698590" y="535975"/>
+            <a:ext cx="3174819" cy="4208708"/>
           </a:xfrm>
           <a:prstGeom prst="rect">
             <a:avLst/>
@@ -3299,8 +3299,8 @@
         </p:blipFill>
         <p:spPr>
           <a:xfrm>
-            <a:off x="899776" y="572734"/>
-            <a:ext cx="2772447" cy="4153479"/>
+            <a:off x="735166" y="572551"/>
+            <a:ext cx="3101667" cy="4135556"/>
           </a:xfrm>
           <a:prstGeom prst="rect">
             <a:avLst/>
@@ -3315,8 +3315,8 @@
         </p:nvSpPr>
         <p:spPr>
           <a:xfrm>
-            <a:off x="137160" y="4823460"/>
-            <a:ext cx="4297680" cy="201168"/>
+            <a:off x="137160" y="4805172"/>
+            <a:ext cx="4297680" cy="219456"/>
           </a:xfrm>
           <a:prstGeom prst="rect">
             <a:avLst/>
@@ -4323,8 +4323,8 @@
         </p:nvSpPr>
         <p:spPr>
           <a:xfrm>
-            <a:off x="4345600" y="1119637"/>
-            <a:ext cx="4247558" cy="3352281"/>
+            <a:off x="4308652" y="1245662"/>
+            <a:ext cx="4321454" cy="3027078"/>
           </a:xfrm>
           <a:prstGeom prst="rect">
             <a:avLst/>
@@ -4376,8 +4376,8 @@
         </p:blipFill>
         <p:spPr>
           <a:xfrm>
-            <a:off x="4382176" y="1156213"/>
-            <a:ext cx="4174406" cy="3279129"/>
+            <a:off x="4345228" y="1282238"/>
+            <a:ext cx="4248302" cy="2953926"/>
           </a:xfrm>
           <a:prstGeom prst="rect">
             <a:avLst/>
@@ -4392,8 +4392,8 @@
         </p:nvSpPr>
         <p:spPr>
           <a:xfrm>
-            <a:off x="4160520" y="4594860"/>
-            <a:ext cx="4617720" cy="201168"/>
+            <a:off x="4160520" y="4521708"/>
+            <a:ext cx="4617720" cy="219456"/>
           </a:xfrm>
           <a:prstGeom prst="rect">
             <a:avLst/>
@@ -4415,7 +4415,7 @@
                 <a:latin typeface="微软雅黑"/>
                 <ns7:rFonts xmlns:ns7="http://schemas.openxmlformats.org/wordprocessingml/2006/main" ns7:eastAsia="微软雅黑" ns7:ascii="微软雅黑" ns7:hAnsi="微软雅黑"/>
               </a:rPr>
-              <a:t>Fig.2 有限状态机</a:t>
+              <a:t>有限状态机</a:t>
             </a:r>
           </a:p>
         </p:txBody>
@@ -5038,8 +5038,8 @@
         </p:nvSpPr>
         <p:spPr>
           <a:xfrm>
-            <a:off x="4262475" y="1148632"/>
-            <a:ext cx="4413808" cy="3294291"/>
+            <a:off x="4315756" y="1151595"/>
+            <a:ext cx="4307247" cy="3215213"/>
           </a:xfrm>
           <a:prstGeom prst="rect">
             <a:avLst/>
@@ -5091,8 +5091,8 @@
         </p:blipFill>
         <p:spPr>
           <a:xfrm>
-            <a:off x="4299051" y="1185208"/>
-            <a:ext cx="4340656" cy="3221139"/>
+            <a:off x="4352332" y="1188171"/>
+            <a:ext cx="4234095" cy="3142061"/>
           </a:xfrm>
           <a:prstGeom prst="rect">
             <a:avLst/>
@@ -5107,8 +5107,8 @@
         </p:nvSpPr>
         <p:spPr>
           <a:xfrm>
-            <a:off x="4160520" y="4594860"/>
-            <a:ext cx="4617720" cy="201168"/>
+            <a:off x="4160520" y="4521708"/>
+            <a:ext cx="4617720" cy="219456"/>
           </a:xfrm>
           <a:prstGeom prst="rect">
             <a:avLst/>
@@ -5753,8 +5753,8 @@
         </p:nvSpPr>
         <p:spPr>
           <a:xfrm>
-            <a:off x="5491515" y="1119637"/>
-            <a:ext cx="1955729" cy="3352281"/>
+            <a:off x="5243358" y="1151595"/>
+            <a:ext cx="2452043" cy="3215213"/>
           </a:xfrm>
           <a:prstGeom prst="rect">
             <a:avLst/>
@@ -5806,8 +5806,8 @@
         </p:blipFill>
         <p:spPr>
           <a:xfrm>
-            <a:off x="5528091" y="1156213"/>
-            <a:ext cx="1882577" cy="3279129"/>
+            <a:off x="5279934" y="1188171"/>
+            <a:ext cx="2378891" cy="3142061"/>
           </a:xfrm>
           <a:prstGeom prst="rect">
             <a:avLst/>
@@ -5822,8 +5822,8 @@
         </p:nvSpPr>
         <p:spPr>
           <a:xfrm>
-            <a:off x="4160520" y="4594860"/>
-            <a:ext cx="4617720" cy="201168"/>
+            <a:off x="4160520" y="4521708"/>
+            <a:ext cx="4617720" cy="219456"/>
           </a:xfrm>
           <a:prstGeom prst="rect">
             <a:avLst/>
@@ -5845,7 +5845,7 @@
                 <a:latin typeface="微软雅黑"/>
                 <ns7:rFonts xmlns:ns7="http://schemas.openxmlformats.org/wordprocessingml/2006/main" ns7:eastAsia="微软雅黑" ns7:ascii="微软雅黑" ns7:hAnsi="微软雅黑"/>
               </a:rPr>
-              <a:t>Fig.3 规则判定树</a:t>
+              <a:t>规则判定树</a:t>
             </a:r>
           </a:p>
         </p:txBody>
@@ -6468,8 +6468,8 @@
         </p:nvSpPr>
         <p:spPr>
           <a:xfrm>
-            <a:off x="4678977" y="1119637"/>
-            <a:ext cx="3580805" cy="3352281"/>
+            <a:off x="4540380" y="1151595"/>
+            <a:ext cx="3857998" cy="3215213"/>
           </a:xfrm>
           <a:prstGeom prst="rect">
             <a:avLst/>
@@ -6521,8 +6521,8 @@
         </p:blipFill>
         <p:spPr>
           <a:xfrm>
-            <a:off x="4715553" y="1156213"/>
-            <a:ext cx="3507653" cy="3279129"/>
+            <a:off x="4576956" y="1188171"/>
+            <a:ext cx="3784846" cy="3142061"/>
           </a:xfrm>
           <a:prstGeom prst="rect">
             <a:avLst/>
@@ -6537,8 +6537,8 @@
         </p:nvSpPr>
         <p:spPr>
           <a:xfrm>
-            <a:off x="4160520" y="4594860"/>
-            <a:ext cx="4617720" cy="201168"/>
+            <a:off x="4160520" y="4521708"/>
+            <a:ext cx="4617720" cy="219456"/>
           </a:xfrm>
           <a:prstGeom prst="rect">
             <a:avLst/>
@@ -6560,7 +6560,7 @@
                 <a:latin typeface="微软雅黑"/>
                 <ns7:rFonts xmlns:ns7="http://schemas.openxmlformats.org/wordprocessingml/2006/main" ns7:eastAsia="微软雅黑" ns7:ascii="微软雅黑" ns7:hAnsi="微软雅黑"/>
               </a:rPr>
-              <a:t>Fig.4 UML 时序图</a:t>
+              <a:t>对话时序图</a:t>
             </a:r>
           </a:p>
         </p:txBody>
@@ -7183,8 +7183,8 @@
         </p:nvSpPr>
         <p:spPr>
           <a:xfrm>
-            <a:off x="4262475" y="1373543"/>
-            <a:ext cx="4413808" cy="2844469"/>
+            <a:off x="4308652" y="1539913"/>
+            <a:ext cx="4321454" cy="2438576"/>
           </a:xfrm>
           <a:prstGeom prst="rect">
             <a:avLst/>
@@ -7236,8 +7236,8 @@
         </p:blipFill>
         <p:spPr>
           <a:xfrm>
-            <a:off x="4299051" y="1410119"/>
-            <a:ext cx="4340656" cy="2771317"/>
+            <a:off x="4345228" y="1576489"/>
+            <a:ext cx="4248302" cy="2365424"/>
           </a:xfrm>
           <a:prstGeom prst="rect">
             <a:avLst/>
@@ -7252,8 +7252,8 @@
         </p:nvSpPr>
         <p:spPr>
           <a:xfrm>
-            <a:off x="4160520" y="4594860"/>
-            <a:ext cx="4617720" cy="201168"/>
+            <a:off x="4160520" y="4521708"/>
+            <a:ext cx="4617720" cy="219456"/>
           </a:xfrm>
           <a:prstGeom prst="rect">
             <a:avLst/>
@@ -7275,7 +7275,7 @@
                 <a:latin typeface="微软雅黑"/>
                 <ns7:rFonts xmlns:ns7="http://schemas.openxmlformats.org/wordprocessingml/2006/main" ns7:eastAsia="微软雅黑" ns7:ascii="微软雅黑" ns7:hAnsi="微软雅黑"/>
               </a:rPr>
-              <a:t>Fig.5 泳道数据流</a:t>
+              <a:t>单帧泳道数据流</a:t>
             </a:r>
           </a:p>
         </p:txBody>
@@ -7977,8 +7977,8 @@
         </p:nvSpPr>
         <p:spPr>
           <a:xfrm>
-            <a:off x="4262475" y="1302319"/>
-            <a:ext cx="4413808" cy="2986916"/>
+            <a:off x="4308652" y="1302920"/>
+            <a:ext cx="4321454" cy="2912562"/>
           </a:xfrm>
           <a:prstGeom prst="rect">
             <a:avLst/>
@@ -8030,8 +8030,8 @@
         </p:blipFill>
         <p:spPr>
           <a:xfrm>
-            <a:off x="4299051" y="1338895"/>
-            <a:ext cx="4340656" cy="2913764"/>
+            <a:off x="4345228" y="1339496"/>
+            <a:ext cx="4248302" cy="2839410"/>
           </a:xfrm>
           <a:prstGeom prst="rect">
             <a:avLst/>
@@ -8046,8 +8046,8 @@
         </p:nvSpPr>
         <p:spPr>
           <a:xfrm>
-            <a:off x="4160520" y="4594860"/>
-            <a:ext cx="4617720" cy="201168"/>
+            <a:off x="4160520" y="4521708"/>
+            <a:ext cx="4617720" cy="219456"/>
           </a:xfrm>
           <a:prstGeom prst="rect">
             <a:avLst/>
@@ -8069,7 +8069,7 @@
                 <a:latin typeface="微软雅黑"/>
                 <ns8:rFonts xmlns:ns8="http://schemas.openxmlformats.org/wordprocessingml/2006/main" ns8:eastAsia="微软雅黑" ns8:ascii="微软雅黑" ns8:hAnsi="微软雅黑"/>
               </a:rPr>
-              <a:t>Fig.6 紧急响应时序</a:t>
+              <a:t>紧急响应时序</a:t>
             </a:r>
           </a:p>
         </p:txBody>
@@ -8740,8 +8740,8 @@
         </p:nvSpPr>
         <p:spPr>
           <a:xfrm>
-            <a:off x="4694986" y="1444247"/>
-            <a:ext cx="4097426" cy="2922516"/>
+            <a:off x="4694986" y="1530242"/>
+            <a:ext cx="4097426" cy="2750526"/>
           </a:xfrm>
           <a:prstGeom prst="rect">
             <a:avLst/>
@@ -8793,8 +8793,8 @@
         </p:blipFill>
         <p:spPr>
           <a:xfrm>
-            <a:off x="4731562" y="1480823"/>
-            <a:ext cx="4024274" cy="2849364"/>
+            <a:off x="4731562" y="1566818"/>
+            <a:ext cx="4024274" cy="2677374"/>
           </a:xfrm>
           <a:prstGeom prst="rect">
             <a:avLst/>
@@ -9419,8 +9419,8 @@
         </p:nvSpPr>
         <p:spPr>
           <a:xfrm>
-            <a:off x="4262475" y="1627409"/>
-            <a:ext cx="4413808" cy="2336736"/>
+            <a:off x="4308652" y="1614914"/>
+            <a:ext cx="4321454" cy="2288575"/>
           </a:xfrm>
           <a:prstGeom prst="rect">
             <a:avLst/>
@@ -9472,8 +9472,8 @@
         </p:blipFill>
         <p:spPr>
           <a:xfrm>
-            <a:off x="4299051" y="1663985"/>
-            <a:ext cx="4340656" cy="2263584"/>
+            <a:off x="4345228" y="1651490"/>
+            <a:ext cx="4248302" cy="2215423"/>
           </a:xfrm>
           <a:prstGeom prst="rect">
             <a:avLst/>
@@ -9488,8 +9488,8 @@
         </p:nvSpPr>
         <p:spPr>
           <a:xfrm>
-            <a:off x="4160520" y="4594860"/>
-            <a:ext cx="4617720" cy="201168"/>
+            <a:off x="4160520" y="4521708"/>
+            <a:ext cx="4617720" cy="219456"/>
           </a:xfrm>
           <a:prstGeom prst="rect">
             <a:avLst/>
@@ -9839,8 +9839,8 @@
         </p:blipFill>
         <p:spPr>
           <a:xfrm>
-            <a:off x="3483327" y="1192240"/>
-            <a:ext cx="2177344" cy="3261939"/>
+            <a:off x="3355219" y="1191691"/>
+            <a:ext cx="2433561" cy="3244748"/>
           </a:xfrm>
           <a:prstGeom prst="rect">
             <a:avLst/>
@@ -9855,8 +9855,8 @@
         </p:nvSpPr>
         <p:spPr>
           <a:xfrm>
-            <a:off x="365760" y="4613148"/>
-            <a:ext cx="8412480" cy="201168"/>
+            <a:off x="365760" y="4594860"/>
+            <a:ext cx="8412480" cy="219456"/>
           </a:xfrm>
           <a:prstGeom prst="rect">
             <a:avLst/>
@@ -10206,8 +10206,8 @@
         </p:blipFill>
         <p:spPr>
           <a:xfrm>
-            <a:off x="1028615" y="1191691"/>
-            <a:ext cx="2725081" cy="3244748"/>
+            <a:off x="1035833" y="1191143"/>
+            <a:ext cx="2710644" cy="3227557"/>
           </a:xfrm>
           <a:prstGeom prst="rect">
             <a:avLst/>
@@ -10222,8 +10222,8 @@
         </p:nvSpPr>
         <p:spPr>
           <a:xfrm>
-            <a:off x="347472" y="4594860"/>
-            <a:ext cx="4087368" cy="201168"/>
+            <a:off x="347472" y="4576572"/>
+            <a:ext cx="4087368" cy="219456"/>
           </a:xfrm>
           <a:prstGeom prst="rect">
             <a:avLst/>
@@ -10311,8 +10311,8 @@
         </p:blipFill>
         <p:spPr>
           <a:xfrm>
-            <a:off x="4845483" y="1191691"/>
-            <a:ext cx="3814721" cy="3244748"/>
+            <a:off x="4855588" y="1191143"/>
+            <a:ext cx="3794510" cy="3227557"/>
           </a:xfrm>
           <a:prstGeom prst="rect">
             <a:avLst/>
@@ -10327,8 +10327,8 @@
         </p:nvSpPr>
         <p:spPr>
           <a:xfrm>
-            <a:off x="4709159" y="4594860"/>
-            <a:ext cx="4087368" cy="201168"/>
+            <a:off x="4709159" y="4576572"/>
+            <a:ext cx="4087368" cy="219456"/>
           </a:xfrm>
           <a:prstGeom prst="rect">
             <a:avLst/>
@@ -10973,8 +10973,8 @@
         </p:nvSpPr>
         <p:spPr>
           <a:xfrm>
-            <a:off x="4262475" y="1850859"/>
-            <a:ext cx="4413808" cy="1889837"/>
+            <a:off x="4308652" y="1833609"/>
+            <a:ext cx="4321454" cy="1851184"/>
           </a:xfrm>
           <a:prstGeom prst="rect">
             <a:avLst/>
@@ -11026,8 +11026,8 @@
         </p:blipFill>
         <p:spPr>
           <a:xfrm>
-            <a:off x="4299051" y="1887435"/>
-            <a:ext cx="4340656" cy="1816685"/>
+            <a:off x="4345228" y="1870185"/>
+            <a:ext cx="4248302" cy="1778032"/>
           </a:xfrm>
           <a:prstGeom prst="rect">
             <a:avLst/>
@@ -11042,8 +11042,8 @@
         </p:nvSpPr>
         <p:spPr>
           <a:xfrm>
-            <a:off x="4160520" y="4594860"/>
-            <a:ext cx="4617720" cy="201168"/>
+            <a:off x="4160520" y="4521708"/>
+            <a:ext cx="4617720" cy="219456"/>
           </a:xfrm>
           <a:prstGeom prst="rect">
             <a:avLst/>
@@ -11393,7 +11393,7 @@
         </p:blipFill>
         <p:spPr>
           <a:xfrm>
-            <a:off x="470093" y="1780369"/>
+            <a:off x="470093" y="1771225"/>
             <a:ext cx="3842125" cy="2067393"/>
           </a:xfrm>
           <a:prstGeom prst="rect">
@@ -11409,8 +11409,8 @@
         </p:nvSpPr>
         <p:spPr>
           <a:xfrm>
-            <a:off x="347472" y="4594860"/>
-            <a:ext cx="4087368" cy="201168"/>
+            <a:off x="347472" y="4576572"/>
+            <a:ext cx="4087368" cy="219456"/>
           </a:xfrm>
           <a:prstGeom prst="rect">
             <a:avLst/>
@@ -11498,7 +11498,7 @@
         </p:blipFill>
         <p:spPr>
           <a:xfrm>
-            <a:off x="4831781" y="2380701"/>
+            <a:off x="4831781" y="2371557"/>
             <a:ext cx="3842125" cy="866729"/>
           </a:xfrm>
           <a:prstGeom prst="rect">
@@ -11514,8 +11514,8 @@
         </p:nvSpPr>
         <p:spPr>
           <a:xfrm>
-            <a:off x="4709159" y="4594860"/>
-            <a:ext cx="4087368" cy="201168"/>
+            <a:off x="4709159" y="4576572"/>
+            <a:ext cx="4087368" cy="219456"/>
           </a:xfrm>
           <a:prstGeom prst="rect">
             <a:avLst/>
@@ -11865,8 +11865,8 @@
         </p:blipFill>
         <p:spPr>
           <a:xfrm>
-            <a:off x="1420843" y="1192240"/>
-            <a:ext cx="6302312" cy="3261939"/>
+            <a:off x="1437450" y="1191691"/>
+            <a:ext cx="6269098" cy="3244748"/>
           </a:xfrm>
           <a:prstGeom prst="rect">
             <a:avLst/>
@@ -11881,8 +11881,8 @@
         </p:nvSpPr>
         <p:spPr>
           <a:xfrm>
-            <a:off x="365760" y="4613148"/>
-            <a:ext cx="8412480" cy="201168"/>
+            <a:off x="365760" y="4594860"/>
+            <a:ext cx="8412480" cy="219456"/>
           </a:xfrm>
           <a:prstGeom prst="rect">
             <a:avLst/>
@@ -12606,8 +12606,8 @@
         </p:nvSpPr>
         <p:spPr>
           <a:xfrm>
-            <a:off x="4262475" y="1222513"/>
-            <a:ext cx="4413808" cy="3146529"/>
+            <a:off x="4308652" y="1309415"/>
+            <a:ext cx="4321454" cy="2899573"/>
           </a:xfrm>
           <a:prstGeom prst="rect">
             <a:avLst/>
@@ -12659,8 +12659,8 @@
         </p:blipFill>
         <p:spPr>
           <a:xfrm>
-            <a:off x="4299051" y="1259089"/>
-            <a:ext cx="4340656" cy="3073377"/>
+            <a:off x="4345228" y="1345991"/>
+            <a:ext cx="4248302" cy="2826421"/>
           </a:xfrm>
           <a:prstGeom prst="rect">
             <a:avLst/>
@@ -12675,8 +12675,8 @@
         </p:nvSpPr>
         <p:spPr>
           <a:xfrm>
-            <a:off x="4160520" y="4594860"/>
-            <a:ext cx="4617720" cy="201168"/>
+            <a:off x="4160520" y="4521708"/>
+            <a:ext cx="4617720" cy="219456"/>
           </a:xfrm>
           <a:prstGeom prst="rect">
             <a:avLst/>
@@ -13321,8 +13321,8 @@
         </p:nvSpPr>
         <p:spPr>
           <a:xfrm>
-            <a:off x="4262475" y="1128834"/>
-            <a:ext cx="4413808" cy="3333886"/>
+            <a:off x="4341464" y="1151595"/>
+            <a:ext cx="4255831" cy="3215213"/>
           </a:xfrm>
           <a:prstGeom prst="rect">
             <a:avLst/>
@@ -13374,8 +13374,8 @@
         </p:blipFill>
         <p:spPr>
           <a:xfrm>
-            <a:off x="4299051" y="1165410"/>
-            <a:ext cx="4340656" cy="3260734"/>
+            <a:off x="4378040" y="1188171"/>
+            <a:ext cx="4182679" cy="3142061"/>
           </a:xfrm>
           <a:prstGeom prst="rect">
             <a:avLst/>
@@ -13390,8 +13390,8 @@
         </p:nvSpPr>
         <p:spPr>
           <a:xfrm>
-            <a:off x="4160520" y="4594860"/>
-            <a:ext cx="4617720" cy="201168"/>
+            <a:off x="4160520" y="4521708"/>
+            <a:ext cx="4617720" cy="219456"/>
           </a:xfrm>
           <a:prstGeom prst="rect">
             <a:avLst/>
@@ -14316,8 +14316,8 @@
         </p:blipFill>
         <p:spPr>
           <a:xfrm>
-            <a:off x="4296582" y="1242486"/>
-            <a:ext cx="1236634" cy="1236634"/>
+            <a:off x="4304995" y="1241755"/>
+            <a:ext cx="1219809" cy="1219809"/>
           </a:xfrm>
           <a:prstGeom prst="rect">
             <a:avLst/>
@@ -14332,8 +14332,8 @@
         </p:nvSpPr>
         <p:spPr>
           <a:xfrm>
-            <a:off x="4160520" y="2587751"/>
-            <a:ext cx="1508760" cy="201168"/>
+            <a:off x="4160520" y="2569463"/>
+            <a:ext cx="1508760" cy="219456"/>
           </a:xfrm>
           <a:prstGeom prst="rect">
             <a:avLst/>
@@ -14376,8 +14376,8 @@
         </p:blipFill>
         <p:spPr>
           <a:xfrm>
-            <a:off x="5922555" y="1191097"/>
-            <a:ext cx="2712136" cy="3209361"/>
+            <a:off x="5929665" y="1190365"/>
+            <a:ext cx="2697917" cy="3192536"/>
           </a:xfrm>
           <a:prstGeom prst="rect">
             <a:avLst/>
@@ -14392,8 +14392,8 @@
         </p:nvSpPr>
         <p:spPr>
           <a:xfrm>
-            <a:off x="5779007" y="4594860"/>
-            <a:ext cx="2999232" cy="201168"/>
+            <a:off x="5779007" y="4576572"/>
+            <a:ext cx="2999232" cy="219456"/>
           </a:xfrm>
           <a:prstGeom prst="rect">
             <a:avLst/>
@@ -15808,8 +15808,8 @@
         </p:nvSpPr>
         <p:spPr>
           <a:xfrm>
-            <a:off x="4786784" y="1119637"/>
-            <a:ext cx="3365191" cy="3352281"/>
+            <a:off x="4855588" y="1151595"/>
+            <a:ext cx="3227583" cy="3215213"/>
           </a:xfrm>
           <a:prstGeom prst="rect">
             <a:avLst/>
@@ -15861,8 +15861,8 @@
         </p:blipFill>
         <p:spPr>
           <a:xfrm>
-            <a:off x="4823360" y="1156213"/>
-            <a:ext cx="3292039" cy="3279129"/>
+            <a:off x="4892164" y="1188171"/>
+            <a:ext cx="3154431" cy="3142061"/>
           </a:xfrm>
           <a:prstGeom prst="rect">
             <a:avLst/>
@@ -15877,8 +15877,8 @@
         </p:nvSpPr>
         <p:spPr>
           <a:xfrm>
-            <a:off x="4160520" y="4594860"/>
-            <a:ext cx="4617720" cy="201168"/>
+            <a:off x="4160520" y="4521708"/>
+            <a:ext cx="4617720" cy="219456"/>
           </a:xfrm>
           <a:prstGeom prst="rect">
             <a:avLst/>
@@ -16566,8 +16566,8 @@
         </p:nvSpPr>
         <p:spPr>
           <a:xfrm>
-            <a:off x="4262475" y="1186911"/>
-            <a:ext cx="4413808" cy="3217732"/>
+            <a:off x="4308652" y="1183788"/>
+            <a:ext cx="4321454" cy="3150826"/>
           </a:xfrm>
           <a:prstGeom prst="rect">
             <a:avLst/>
@@ -16619,8 +16619,8 @@
         </p:blipFill>
         <p:spPr>
           <a:xfrm>
-            <a:off x="4299051" y="1223487"/>
-            <a:ext cx="4340656" cy="3144580"/>
+            <a:off x="4345228" y="1220364"/>
+            <a:ext cx="4248302" cy="3077674"/>
           </a:xfrm>
           <a:prstGeom prst="rect">
             <a:avLst/>
@@ -16635,8 +16635,8 @@
         </p:nvSpPr>
         <p:spPr>
           <a:xfrm>
-            <a:off x="4160520" y="4594860"/>
-            <a:ext cx="4617720" cy="201168"/>
+            <a:off x="4160520" y="4521708"/>
+            <a:ext cx="4617720" cy="219456"/>
           </a:xfrm>
           <a:prstGeom prst="rect">
             <a:avLst/>
@@ -17616,8 +17616,8 @@
         </p:blipFill>
         <p:spPr>
           <a:xfrm>
-            <a:off x="4342302" y="1288206"/>
-            <a:ext cx="1236634" cy="1236634"/>
+            <a:off x="4362602" y="1390802"/>
+            <a:ext cx="1168603" cy="1168603"/>
           </a:xfrm>
           <a:prstGeom prst="rect">
             <a:avLst/>
@@ -17632,8 +17632,8 @@
         </p:nvSpPr>
         <p:spPr>
           <a:xfrm>
-            <a:off x="4160520" y="2633472"/>
-            <a:ext cx="1600200" cy="201168"/>
+            <a:off x="4160520" y="2679191"/>
+            <a:ext cx="1572768" cy="219456"/>
           </a:xfrm>
           <a:prstGeom prst="rect">
             <a:avLst/>
@@ -17662,7 +17662,7 @@
       </p:sp>
       <p:pic>
         <p:nvPicPr>
-          <p:cNvPr id="17" name="Picture 16" descr="ppt_mediapipe_pose.png"/>
+          <p:cNvPr id="17" name="Picture 16" descr="ppt_header_perception.png"/>
           <p:cNvPicPr>
             <a:picLocks noChangeAspect="1"/>
           </p:cNvPicPr>
@@ -17676,8 +17676,8 @@
         </p:blipFill>
         <p:spPr>
           <a:xfrm>
-            <a:off x="6253219" y="1191097"/>
-            <a:ext cx="2142248" cy="3209361"/>
+            <a:off x="6007150" y="2006665"/>
+            <a:ext cx="2625242" cy="1358768"/>
           </a:xfrm>
           <a:prstGeom prst="rect">
             <a:avLst/>
@@ -17692,8 +17692,8 @@
         </p:nvSpPr>
         <p:spPr>
           <a:xfrm>
-            <a:off x="5870448" y="4594860"/>
-            <a:ext cx="2907791" cy="201168"/>
+            <a:off x="5861303" y="4329684"/>
+            <a:ext cx="2916936" cy="219456"/>
           </a:xfrm>
           <a:prstGeom prst="rect">
             <a:avLst/>
@@ -17715,7 +17715,7 @@
                 <a:latin typeface="微软雅黑"/>
                 <ns8:rFonts xmlns:ns8="http://schemas.openxmlformats.org/wordprocessingml/2006/main" ns8:eastAsia="微软雅黑" ns8:ascii="微软雅黑" ns8:hAnsi="微软雅黑"/>
               </a:rPr>
-              <a:t>演示界面</a:t>
+              <a:t>Web 感知界面</a:t>
             </a:r>
           </a:p>
         </p:txBody>
@@ -18765,7 +18765,7 @@
         </p:nvSpPr>
         <p:spPr>
           <a:xfrm>
-            <a:off x="115305" y="1540324"/>
+            <a:off x="115305" y="1531180"/>
             <a:ext cx="4204228" cy="2227443"/>
           </a:xfrm>
           <a:prstGeom prst="rect">
@@ -18818,7 +18818,7 @@
         </p:blipFill>
         <p:spPr>
           <a:xfrm>
-            <a:off x="151881" y="1576900"/>
+            <a:off x="151881" y="1567756"/>
             <a:ext cx="4131076" cy="2154291"/>
           </a:xfrm>
           <a:prstGeom prst="rect">
@@ -18834,8 +18834,8 @@
         </p:nvSpPr>
         <p:spPr>
           <a:xfrm>
-            <a:off x="109728" y="4850892"/>
-            <a:ext cx="4215383" cy="201168"/>
+            <a:off x="109728" y="4832604"/>
+            <a:ext cx="4215383" cy="219456"/>
           </a:xfrm>
           <a:prstGeom prst="rect">
             <a:avLst/>
@@ -19023,8 +19023,8 @@
         </p:nvSpPr>
         <p:spPr>
           <a:xfrm>
-            <a:off x="5897879" y="3026664"/>
-            <a:ext cx="1234440" cy="1161288"/>
+            <a:off x="5907024" y="3026664"/>
+            <a:ext cx="1216152" cy="1143000"/>
           </a:xfrm>
           <a:prstGeom prst="rect">
             <a:avLst/>
@@ -19076,8 +19076,8 @@
         </p:blipFill>
         <p:spPr>
           <a:xfrm>
-            <a:off x="5934455" y="3063240"/>
-            <a:ext cx="1161288" cy="1161288"/>
+            <a:off x="5943600" y="3063240"/>
+            <a:ext cx="1143000" cy="1143000"/>
           </a:xfrm>
           <a:prstGeom prst="rect">
             <a:avLst/>
@@ -19092,8 +19092,8 @@
         </p:nvSpPr>
         <p:spPr>
           <a:xfrm>
-            <a:off x="5806440" y="4279392"/>
-            <a:ext cx="1417320" cy="201168"/>
+            <a:off x="5806440" y="4261104"/>
+            <a:ext cx="1417320" cy="219456"/>
           </a:xfrm>
           <a:prstGeom prst="rect">
             <a:avLst/>
@@ -20544,8 +20544,8 @@
         </p:nvSpPr>
         <p:spPr>
           <a:xfrm>
-            <a:off x="4262475" y="1252679"/>
-            <a:ext cx="4413808" cy="3086196"/>
+            <a:off x="4308652" y="1248157"/>
+            <a:ext cx="4321454" cy="3022089"/>
           </a:xfrm>
           <a:prstGeom prst="rect">
             <a:avLst/>
@@ -20597,8 +20597,8 @@
         </p:blipFill>
         <p:spPr>
           <a:xfrm>
-            <a:off x="4299051" y="1289255"/>
-            <a:ext cx="4340656" cy="3013044"/>
+            <a:off x="4345228" y="1284733"/>
+            <a:ext cx="4248302" cy="2948937"/>
           </a:xfrm>
           <a:prstGeom prst="rect">
             <a:avLst/>
@@ -20613,8 +20613,8 @@
         </p:nvSpPr>
         <p:spPr>
           <a:xfrm>
-            <a:off x="4160520" y="4594860"/>
-            <a:ext cx="4617720" cy="201168"/>
+            <a:off x="4160520" y="4521708"/>
+            <a:ext cx="4617720" cy="219456"/>
           </a:xfrm>
           <a:prstGeom prst="rect">
             <a:avLst/>
@@ -21259,8 +21259,8 @@
         </p:nvSpPr>
         <p:spPr>
           <a:xfrm>
-            <a:off x="4262475" y="1548312"/>
-            <a:ext cx="4413808" cy="2494931"/>
+            <a:off x="4308652" y="1537499"/>
+            <a:ext cx="4321454" cy="2443404"/>
           </a:xfrm>
           <a:prstGeom prst="rect">
             <a:avLst/>
@@ -21312,8 +21312,8 @@
         </p:blipFill>
         <p:spPr>
           <a:xfrm>
-            <a:off x="4299051" y="1584888"/>
-            <a:ext cx="4340656" cy="2421779"/>
+            <a:off x="4345228" y="1574075"/>
+            <a:ext cx="4248302" cy="2370252"/>
           </a:xfrm>
           <a:prstGeom prst="rect">
             <a:avLst/>
@@ -21328,8 +21328,8 @@
         </p:nvSpPr>
         <p:spPr>
           <a:xfrm>
-            <a:off x="4160520" y="4594860"/>
-            <a:ext cx="4617720" cy="201168"/>
+            <a:off x="4160520" y="4521708"/>
+            <a:ext cx="4617720" cy="219456"/>
           </a:xfrm>
           <a:prstGeom prst="rect">
             <a:avLst/>
@@ -22053,8 +22053,8 @@
         </p:nvSpPr>
         <p:spPr>
           <a:xfrm>
-            <a:off x="4476308" y="1119637"/>
-            <a:ext cx="3986142" cy="3352281"/>
+            <a:off x="4308652" y="1221190"/>
+            <a:ext cx="4321454" cy="3076023"/>
           </a:xfrm>
           <a:prstGeom prst="rect">
             <a:avLst/>
@@ -22106,8 +22106,8 @@
         </p:blipFill>
         <p:spPr>
           <a:xfrm>
-            <a:off x="4512884" y="1156213"/>
-            <a:ext cx="3912990" cy="3279129"/>
+            <a:off x="4345228" y="1257766"/>
+            <a:ext cx="4248302" cy="3002871"/>
           </a:xfrm>
           <a:prstGeom prst="rect">
             <a:avLst/>
@@ -22122,8 +22122,8 @@
         </p:nvSpPr>
         <p:spPr>
           <a:xfrm>
-            <a:off x="4160520" y="4594860"/>
-            <a:ext cx="4617720" cy="201168"/>
+            <a:off x="4160520" y="4521708"/>
+            <a:ext cx="4617720" cy="219456"/>
           </a:xfrm>
           <a:prstGeom prst="rect">
             <a:avLst/>
@@ -22145,7 +22145,7 @@
                 <a:latin typeface="微软雅黑"/>
                 <ns8:rFonts xmlns:ns8="http://schemas.openxmlformats.org/wordprocessingml/2006/main" ns8:eastAsia="微软雅黑" ns8:ascii="微软雅黑" ns8:hAnsi="微软雅黑"/>
               </a:rPr>
-              <a:t>Fig.1 系统分层</a:t>
+              <a:t>系统四层架构</a:t>
             </a:r>
           </a:p>
         </p:txBody>
@@ -22816,8 +22816,8 @@
         </p:nvSpPr>
         <p:spPr>
           <a:xfrm>
-            <a:off x="4694986" y="1288332"/>
-            <a:ext cx="4097426" cy="3234347"/>
+            <a:off x="4694986" y="1469852"/>
+            <a:ext cx="4097426" cy="2871307"/>
           </a:xfrm>
           <a:prstGeom prst="rect">
             <a:avLst/>
@@ -22869,8 +22869,8 @@
         </p:blipFill>
         <p:spPr>
           <a:xfrm>
-            <a:off x="4731562" y="1324908"/>
-            <a:ext cx="4024274" cy="3161195"/>
+            <a:off x="4731562" y="1506428"/>
+            <a:ext cx="4024274" cy="2798155"/>
           </a:xfrm>
           <a:prstGeom prst="rect">
             <a:avLst/>
@@ -23495,8 +23495,8 @@
         </p:nvSpPr>
         <p:spPr>
           <a:xfrm>
-            <a:off x="4476308" y="1119637"/>
-            <a:ext cx="3986142" cy="3352281"/>
+            <a:off x="4308652" y="1221190"/>
+            <a:ext cx="4321454" cy="3076023"/>
           </a:xfrm>
           <a:prstGeom prst="rect">
             <a:avLst/>
@@ -23548,8 +23548,8 @@
         </p:blipFill>
         <p:spPr>
           <a:xfrm>
-            <a:off x="4512884" y="1156213"/>
-            <a:ext cx="3912990" cy="3279129"/>
+            <a:off x="4345228" y="1257766"/>
+            <a:ext cx="4248302" cy="3002871"/>
           </a:xfrm>
           <a:prstGeom prst="rect">
             <a:avLst/>
@@ -23564,8 +23564,8 @@
         </p:nvSpPr>
         <p:spPr>
           <a:xfrm>
-            <a:off x="4160520" y="4594860"/>
-            <a:ext cx="4617720" cy="201168"/>
+            <a:off x="4160520" y="4521708"/>
+            <a:ext cx="4617720" cy="219456"/>
           </a:xfrm>
           <a:prstGeom prst="rect">
             <a:avLst/>
@@ -23587,7 +23587,7 @@
                 <a:latin typeface="微软雅黑"/>
                 <ns7:rFonts xmlns:ns7="http://schemas.openxmlformats.org/wordprocessingml/2006/main" ns7:eastAsia="微软雅黑" ns7:ascii="微软雅黑" ns7:hAnsi="微软雅黑"/>
               </a:rPr>
-              <a:t>四层架构与调度核心</a:t>
+              <a:t>分层与 CareOrchestrator</a:t>
             </a:r>
           </a:p>
         </p:txBody>

</xml_diff>

<commit_message>
fix: clarify chart labels and redesign open-source and thanks slides
Separate eval metrics from axis labels, fix radar label overlap, enlarge pose screenshot, use native open-source layout, and center the closing slide.

Co-authored-by: Cursor <cursoragent@cursor.com>
</commit_message>
<xml_diff>
--- a/docs/答辩_CareCompanion.pptx
+++ b/docs/答辩_CareCompanion.pptx
@@ -8740,8 +8740,8 @@
         </p:nvSpPr>
         <p:spPr>
           <a:xfrm>
-            <a:off x="4694986" y="1530242"/>
-            <a:ext cx="4097426" cy="2750526"/>
+            <a:off x="4694986" y="1819631"/>
+            <a:ext cx="4097426" cy="2171748"/>
           </a:xfrm>
           <a:prstGeom prst="rect">
             <a:avLst/>
@@ -8779,7 +8779,7 @@
       </p:sp>
       <p:pic>
         <p:nvPicPr>
-          <p:cNvPr id="19" name="Picture 18" descr="eval_results.png"/>
+          <p:cNvPr id="19" name="Picture 18" descr="ppt_full_dashboard.png"/>
           <p:cNvPicPr>
             <a:picLocks noChangeAspect="1"/>
           </p:cNvPicPr>
@@ -8793,8 +8793,8 @@
         </p:blipFill>
         <p:spPr>
           <a:xfrm>
-            <a:off x="4731562" y="1566818"/>
-            <a:ext cx="4024274" cy="2677374"/>
+            <a:off x="4731562" y="1856207"/>
+            <a:ext cx="4024274" cy="2098596"/>
           </a:xfrm>
           <a:prstGeom prst="rect">
             <a:avLst/>
@@ -9786,8 +9786,8 @@
         </p:nvSpPr>
         <p:spPr>
           <a:xfrm>
-            <a:off x="274320" y="1033272"/>
-            <a:ext cx="8595360" cy="3781044"/>
+            <a:off x="274320" y="1014984"/>
+            <a:ext cx="8595360" cy="3817620"/>
           </a:xfrm>
           <a:prstGeom prst="rect">
             <a:avLst/>
@@ -9839,8 +9839,8 @@
         </p:blipFill>
         <p:spPr>
           <a:xfrm>
-            <a:off x="3355219" y="1191691"/>
-            <a:ext cx="2433561" cy="3244748"/>
+            <a:off x="3283278" y="1068339"/>
+            <a:ext cx="2577442" cy="3436589"/>
           </a:xfrm>
           <a:prstGeom prst="rect">
             <a:avLst/>
@@ -9855,8 +9855,8 @@
         </p:nvSpPr>
         <p:spPr>
           <a:xfrm>
-            <a:off x="365760" y="4594860"/>
-            <a:ext cx="8412480" cy="219456"/>
+            <a:off x="310896" y="4594860"/>
+            <a:ext cx="8522208" cy="219456"/>
           </a:xfrm>
           <a:prstGeom prst="rect">
             <a:avLst/>
@@ -11812,8 +11812,8 @@
         </p:nvSpPr>
         <p:spPr>
           <a:xfrm>
-            <a:off x="274320" y="1033272"/>
-            <a:ext cx="8595360" cy="3781044"/>
+            <a:off x="274320" y="1014984"/>
+            <a:ext cx="8595360" cy="3817620"/>
           </a:xfrm>
           <a:prstGeom prst="rect">
             <a:avLst/>
@@ -11865,8 +11865,8 @@
         </p:blipFill>
         <p:spPr>
           <a:xfrm>
-            <a:off x="1437450" y="1191691"/>
-            <a:ext cx="6269098" cy="3244748"/>
+            <a:off x="1387629" y="1165905"/>
+            <a:ext cx="6368740" cy="3296320"/>
           </a:xfrm>
           <a:prstGeom prst="rect">
             <a:avLst/>
@@ -11881,7 +11881,7 @@
         </p:nvSpPr>
         <p:spPr>
           <a:xfrm>
-            <a:off x="365760" y="4594860"/>
+            <a:off x="365760" y="4622292"/>
             <a:ext cx="8412480" cy="219456"/>
           </a:xfrm>
           <a:prstGeom prst="rect">
@@ -12606,8 +12606,8 @@
         </p:nvSpPr>
         <p:spPr>
           <a:xfrm>
-            <a:off x="4308652" y="1309415"/>
-            <a:ext cx="4321454" cy="2899573"/>
+            <a:off x="4308652" y="1308003"/>
+            <a:ext cx="4321454" cy="2902397"/>
           </a:xfrm>
           <a:prstGeom prst="rect">
             <a:avLst/>
@@ -12659,8 +12659,8 @@
         </p:blipFill>
         <p:spPr>
           <a:xfrm>
-            <a:off x="4345228" y="1345991"/>
-            <a:ext cx="4248302" cy="2826421"/>
+            <a:off x="4345228" y="1344579"/>
+            <a:ext cx="4248302" cy="2829245"/>
           </a:xfrm>
           <a:prstGeom prst="rect">
             <a:avLst/>
@@ -12698,7 +12698,7 @@
                 <a:latin typeface="微软雅黑"/>
                 <ns8:rFonts xmlns:ns8="http://schemas.openxmlformats.org/wordprocessingml/2006/main" ns8:eastAsia="微软雅黑" ns8:ascii="微软雅黑" ns8:hAnsi="微软雅黑"/>
               </a:rPr>
-              <a:t>混淆矩阵 + 场景得分</a:t>
+              <a:t>评测结果（6 场景）</a:t>
             </a:r>
           </a:p>
         </p:txBody>
@@ -13680,131 +13680,292 @@
           </a:p>
         </p:txBody>
       </p:sp>
-      <p:sp>
-        <p:nvSpPr>
-          <p:cNvPr id="8" name="Rectangle 7"/>
+      <p:graphicFrame>
+        <p:nvGraphicFramePr>
+          <p:cNvPr id="8" name="Table 7"/>
+          <p:cNvGraphicFramePr>
+            <a:graphicFrameLocks noGrp="1"/>
+          </p:cNvGraphicFramePr>
+          <p:nvPr/>
+        </p:nvGraphicFramePr>
+        <p:xfrm>
+          <a:off x="274320" y="996696"/>
+          <a:ext cx="3611880" cy="3854196"/>
+        </p:xfrm>
+        <a:graphic>
+          <a:graphicData uri="http://schemas.openxmlformats.org/drawingml/2006/table">
+            <a:tbl>
+              <a:tblPr firstRow="1" bandRow="1">
+                <a:tableStyleId>{5C22544A-7EE6-4342-B048-85BDC9FD1C3A}</a:tableStyleId>
+              </a:tblPr>
+              <a:tblGrid>
+                <a:gridCol w="868680"/>
+                <a:gridCol w="2743200"/>
+              </a:tblGrid>
+              <a:tr h="770839">
+                <a:tc>
+                  <a:txBody>
+                    <a:bodyPr anchor="ctr"/>
+                    <a:lstStyle/>
+                    <a:p>
+                      <a:pPr algn="ctr"/>
+                      <a:r>
+                        <a:rPr sz="900" b="1">
+                          <a:solidFill>
+                            <a:srgbClr val="FFFFFF"/>
+                          </a:solidFill>
+                          <a:latin typeface="微软雅黑"/>
+                          <ns3:rFonts xmlns:ns3="http://schemas.openxmlformats.org/wordprocessingml/2006/main" ns3:eastAsia="微软雅黑" ns3:ascii="微软雅黑" ns3:hAnsi="微软雅黑"/>
+                        </a:rPr>
+                        <a:t>GitHub</a:t>
+                      </a:r>
+                    </a:p>
+                  </a:txBody>
+                  <a:tcPr marL="50800" marR="50800" marT="25400" marB="25400">
+                    <a:solidFill>
+                      <a:srgbClr val="143278"/>
+                    </a:solidFill>
+                  </a:tcPr>
+                </a:tc>
+                <a:tc>
+                  <a:txBody>
+                    <a:bodyPr anchor="ctr" wrap="square"/>
+                    <a:lstStyle/>
+                    <a:p>
+                      <a:pPr algn="l"/>
+                      <a:r>
+                        <a:rPr sz="800" b="0">
+                          <a:solidFill>
+                            <a:srgbClr val="143278"/>
+                          </a:solidFill>
+                          <a:latin typeface="微软雅黑"/>
+                          <ns4:rFonts xmlns:ns4="http://schemas.openxmlformats.org/wordprocessingml/2006/main" ns4:eastAsia="微软雅黑" ns4:ascii="微软雅黑" ns4:hAnsi="微软雅黑"/>
+                        </a:rPr>
+                        <a:t>https://github.com/FBB123571/ElderCare-Humanoid-Platform</a:t>
+                      </a:r>
+                    </a:p>
+                  </a:txBody>
+                  <a:tcPr marL="63500">
+                    <a:solidFill>
+                      <a:srgbClr val="F1F7FF"/>
+                    </a:solidFill>
+                  </a:tcPr>
+                </a:tc>
+              </a:tr>
+              <a:tr h="770839">
+                <a:tc>
+                  <a:txBody>
+                    <a:bodyPr anchor="ctr"/>
+                    <a:lstStyle/>
+                    <a:p>
+                      <a:pPr algn="ctr"/>
+                      <a:r>
+                        <a:rPr sz="900" b="1">
+                          <a:solidFill>
+                            <a:srgbClr val="FFFFFF"/>
+                          </a:solidFill>
+                          <a:latin typeface="微软雅黑"/>
+                          <ns5:rFonts xmlns:ns5="http://schemas.openxmlformats.org/wordprocessingml/2006/main" ns5:eastAsia="微软雅黑" ns5:ascii="微软雅黑" ns5:hAnsi="微软雅黑"/>
+                        </a:rPr>
+                        <a:t>团队</a:t>
+                      </a:r>
+                    </a:p>
+                  </a:txBody>
+                  <a:tcPr marL="50800" marR="50800" marT="25400" marB="25400">
+                    <a:solidFill>
+                      <a:srgbClr val="143278"/>
+                    </a:solidFill>
+                  </a:tcPr>
+                </a:tc>
+                <a:tc>
+                  <a:txBody>
+                    <a:bodyPr anchor="ctr" wrap="square"/>
+                    <a:lstStyle/>
+                    <a:p>
+                      <a:pPr algn="l"/>
+                      <a:r>
+                        <a:rPr sz="900" b="0">
+                          <a:solidFill>
+                            <a:srgbClr val="143278"/>
+                          </a:solidFill>
+                          <a:latin typeface="微软雅黑"/>
+                          <ns6:rFonts xmlns:ns6="http://schemas.openxmlformats.org/wordprocessingml/2006/main" ns6:eastAsia="微软雅黑" ns6:ascii="微软雅黑" ns6:hAnsi="微软雅黑"/>
+                        </a:rPr>
+                        <a:t>从容应队（中山大学）</a:t>
+                      </a:r>
+                    </a:p>
+                  </a:txBody>
+                  <a:tcPr marL="63500">
+                    <a:solidFill>
+                      <a:srgbClr val="FFFFFF"/>
+                    </a:solidFill>
+                  </a:tcPr>
+                </a:tc>
+              </a:tr>
+              <a:tr h="770839">
+                <a:tc>
+                  <a:txBody>
+                    <a:bodyPr anchor="ctr"/>
+                    <a:lstStyle/>
+                    <a:p>
+                      <a:pPr algn="ctr"/>
+                      <a:r>
+                        <a:rPr sz="900" b="1">
+                          <a:solidFill>
+                            <a:srgbClr val="FFFFFF"/>
+                          </a:solidFill>
+                          <a:latin typeface="微软雅黑"/>
+                          <ns7:rFonts xmlns:ns7="http://schemas.openxmlformats.org/wordprocessingml/2006/main" ns7:eastAsia="微软雅黑" ns7:ascii="微软雅黑" ns7:hAnsi="微软雅黑"/>
+                        </a:rPr>
+                        <a:t>本地演示</a:t>
+                      </a:r>
+                    </a:p>
+                  </a:txBody>
+                  <a:tcPr marL="50800" marR="50800" marT="25400" marB="25400">
+                    <a:solidFill>
+                      <a:srgbClr val="143278"/>
+                    </a:solidFill>
+                  </a:tcPr>
+                </a:tc>
+                <a:tc>
+                  <a:txBody>
+                    <a:bodyPr anchor="ctr" wrap="square"/>
+                    <a:lstStyle/>
+                    <a:p>
+                      <a:pPr algn="l"/>
+                      <a:r>
+                        <a:rPr sz="900" b="0">
+                          <a:solidFill>
+                            <a:srgbClr val="143278"/>
+                          </a:solidFill>
+                          <a:latin typeface="微软雅黑"/>
+                          <ns8:rFonts xmlns:ns8="http://schemas.openxmlformats.org/wordprocessingml/2006/main" ns8:eastAsia="微软雅黑" ns8:ascii="微软雅黑" ns8:hAnsi="微软雅黑"/>
+                        </a:rPr>
+                        <a:t>bash scripts/run_web.sh</a:t>
+                      </a:r>
+                    </a:p>
+                  </a:txBody>
+                  <a:tcPr marL="63500">
+                    <a:solidFill>
+                      <a:srgbClr val="F1F7FF"/>
+                    </a:solidFill>
+                  </a:tcPr>
+                </a:tc>
+              </a:tr>
+              <a:tr h="770839">
+                <a:tc>
+                  <a:txBody>
+                    <a:bodyPr anchor="ctr"/>
+                    <a:lstStyle/>
+                    <a:p>
+                      <a:pPr algn="ctr"/>
+                      <a:r>
+                        <a:rPr sz="900" b="1">
+                          <a:solidFill>
+                            <a:srgbClr val="FFFFFF"/>
+                          </a:solidFill>
+                          <a:latin typeface="微软雅黑"/>
+                          <ns9:rFonts xmlns:ns9="http://schemas.openxmlformats.org/wordprocessingml/2006/main" ns9:eastAsia="微软雅黑" ns9:ascii="微软雅黑" ns9:hAnsi="微软雅黑"/>
+                        </a:rPr>
+                        <a:t>演示录像</a:t>
+                      </a:r>
+                    </a:p>
+                  </a:txBody>
+                  <a:tcPr marL="50800" marR="50800" marT="25400" marB="25400">
+                    <a:solidFill>
+                      <a:srgbClr val="143278"/>
+                    </a:solidFill>
+                  </a:tcPr>
+                </a:tc>
+                <a:tc>
+                  <a:txBody>
+                    <a:bodyPr anchor="ctr" wrap="square"/>
+                    <a:lstStyle/>
+                    <a:p>
+                      <a:pPr algn="l"/>
+                      <a:r>
+                        <a:rPr sz="900" b="0">
+                          <a:solidFill>
+                            <a:srgbClr val="143278"/>
+                          </a:solidFill>
+                          <a:latin typeface="微软雅黑"/>
+                          <ns10:rFonts xmlns:ns10="http://schemas.openxmlformats.org/wordprocessingml/2006/main" ns10:eastAsia="微软雅黑" ns10:ascii="微软雅黑" ns10:hAnsi="微软雅黑"/>
+                        </a:rPr>
+                        <a:t>docs/assets/demo_carecompanion.mp4</a:t>
+                      </a:r>
+                    </a:p>
+                  </a:txBody>
+                  <a:tcPr marL="63500">
+                    <a:solidFill>
+                      <a:srgbClr val="FFFFFF"/>
+                    </a:solidFill>
+                  </a:tcPr>
+                </a:tc>
+              </a:tr>
+              <a:tr h="770840">
+                <a:tc>
+                  <a:txBody>
+                    <a:bodyPr anchor="ctr"/>
+                    <a:lstStyle/>
+                    <a:p>
+                      <a:pPr algn="ctr"/>
+                      <a:r>
+                        <a:rPr sz="900" b="1">
+                          <a:solidFill>
+                            <a:srgbClr val="FFFFFF"/>
+                          </a:solidFill>
+                          <a:latin typeface="微软雅黑"/>
+                          <ns11:rFonts xmlns:ns11="http://schemas.openxmlformats.org/wordprocessingml/2006/main" ns11:eastAsia="微软雅黑" ns11:ascii="微软雅黑" ns11:hAnsi="微软雅黑"/>
+                        </a:rPr>
+                        <a:t>软著</a:t>
+                      </a:r>
+                    </a:p>
+                  </a:txBody>
+                  <a:tcPr marL="50800" marR="50800" marT="25400" marB="25400">
+                    <a:solidFill>
+                      <a:srgbClr val="143278"/>
+                    </a:solidFill>
+                  </a:tcPr>
+                </a:tc>
+                <a:tc>
+                  <a:txBody>
+                    <a:bodyPr anchor="ctr" wrap="square"/>
+                    <a:lstStyle/>
+                    <a:p>
+                      <a:pPr algn="l"/>
+                      <a:r>
+                        <a:rPr sz="900" b="0">
+                          <a:solidFill>
+                            <a:srgbClr val="143278"/>
+                          </a:solidFill>
+                          <a:latin typeface="微软雅黑"/>
+                          <ns12:rFonts xmlns:ns12="http://schemas.openxmlformats.org/wordprocessingml/2006/main" ns12:eastAsia="微软雅黑" ns12:ascii="微软雅黑" ns12:hAnsi="微软雅黑"/>
+                        </a:rPr>
+                        <a:t>申请中</a:t>
+                      </a:r>
+                    </a:p>
+                  </a:txBody>
+                  <a:tcPr marL="63500">
+                    <a:solidFill>
+                      <a:srgbClr val="F1F7FF"/>
+                    </a:solidFill>
+                  </a:tcPr>
+                </a:tc>
+              </a:tr>
+            </a:tbl>
+          </a:graphicData>
+        </a:graphic>
+      </p:graphicFrame>
+      <p:sp>
+        <p:nvSpPr>
+          <p:cNvPr id="9" name="Rectangle 8"/>
           <p:cNvSpPr/>
           <p:nvPr/>
         </p:nvSpPr>
         <p:spPr>
           <a:xfrm>
-            <a:off x="274320" y="1042416"/>
-            <a:ext cx="3611880" cy="679399"/>
-          </a:xfrm>
-          <a:prstGeom prst="rect">
-            <a:avLst/>
-          </a:prstGeom>
-          <a:solidFill>
-            <a:srgbClr val="F1F7FF"/>
-          </a:solidFill>
-          <a:ln>
-            <a:solidFill>
-              <a:srgbClr val="BAC8DC"/>
-            </a:solidFill>
-          </a:ln>
-        </p:spPr>
-        <p:style>
-          <a:lnRef idx="1">
-            <a:schemeClr val="accent1"/>
-          </a:lnRef>
-          <a:fillRef idx="3">
-            <a:schemeClr val="accent1"/>
-          </a:fillRef>
-          <a:effectRef idx="2">
-            <a:schemeClr val="accent1"/>
-          </a:effectRef>
-          <a:fontRef idx="minor">
-            <a:schemeClr val="lt1"/>
-          </a:fontRef>
-        </p:style>
-        <p:txBody>
-          <a:bodyPr rtlCol="0" anchor="ctr"/>
-          <a:lstStyle/>
-          <a:p>
-            <a:pPr algn="ctr"/>
-          </a:p>
-        </p:txBody>
-      </p:sp>
-      <p:sp>
-        <p:nvSpPr>
-          <p:cNvPr id="9" name="TextBox 8"/>
-          <p:cNvSpPr txBox="1"/>
-          <p:nvPr/>
-        </p:nvSpPr>
-        <p:spPr>
-          <a:xfrm>
-            <a:off x="411479" y="1097280"/>
-            <a:ext cx="914400" cy="642823"/>
-          </a:xfrm>
-          <a:prstGeom prst="rect">
-            <a:avLst/>
-          </a:prstGeom>
-          <a:noFill/>
-        </p:spPr>
-        <p:txBody>
-          <a:bodyPr wrap="none">
-            <a:spAutoFit/>
-          </a:bodyPr>
-          <a:lstStyle/>
-          <a:p>
-            <a:r>
-              <a:rPr sz="1000" b="1">
-                <a:solidFill>
-                  <a:srgbClr val="5A6273"/>
-                </a:solidFill>
-                <a:latin typeface="微软雅黑"/>
-                <ns3:rFonts xmlns:ns3="http://schemas.openxmlformats.org/wordprocessingml/2006/main" ns3:eastAsia="微软雅黑" ns3:ascii="微软雅黑" ns3:hAnsi="微软雅黑"/>
-              </a:rPr>
-              <a:t>GitHub 仓库</a:t>
-            </a:r>
-          </a:p>
-        </p:txBody>
-      </p:sp>
-      <p:sp>
-        <p:nvSpPr>
-          <p:cNvPr id="10" name="TextBox 9"/>
-          <p:cNvSpPr txBox="1"/>
-          <p:nvPr/>
-        </p:nvSpPr>
-        <p:spPr>
-          <a:xfrm>
-            <a:off x="1280160" y="1097280"/>
-            <a:ext cx="2468880" cy="642823"/>
-          </a:xfrm>
-          <a:prstGeom prst="rect">
-            <a:avLst/>
-          </a:prstGeom>
-          <a:noFill/>
-        </p:spPr>
-        <p:txBody>
-          <a:bodyPr wrap="none">
-            <a:spAutoFit/>
-          </a:bodyPr>
-          <a:lstStyle/>
-          <a:p>
-            <a:r>
-              <a:rPr sz="900" b="0">
-                <a:solidFill>
-                  <a:srgbClr val="143278"/>
-                </a:solidFill>
-                <a:latin typeface="微软雅黑"/>
-                <ns4:rFonts xmlns:ns4="http://schemas.openxmlformats.org/wordprocessingml/2006/main" ns4:eastAsia="微软雅黑" ns4:ascii="微软雅黑" ns4:hAnsi="微软雅黑"/>
-              </a:rPr>
-              <a:t>https://github.com/FBB123571/ElderCare-Humanoid-Platform</a:t>
-            </a:r>
-          </a:p>
-        </p:txBody>
-      </p:sp>
-      <p:sp>
-        <p:nvSpPr>
-          <p:cNvPr id="11" name="Rectangle 10"/>
-          <p:cNvSpPr/>
-          <p:nvPr/>
-        </p:nvSpPr>
-        <p:spPr>
-          <a:xfrm>
-            <a:off x="274320" y="1794967"/>
-            <a:ext cx="3611880" cy="679399"/>
+            <a:off x="4123944" y="996696"/>
+            <a:ext cx="4690872" cy="3854196"/>
           </a:xfrm>
           <a:prstGeom prst="rect">
             <a:avLst/>
@@ -13840,469 +14001,9 @@
           </a:p>
         </p:txBody>
       </p:sp>
-      <p:sp>
-        <p:nvSpPr>
-          <p:cNvPr id="12" name="TextBox 11"/>
-          <p:cNvSpPr txBox="1"/>
-          <p:nvPr/>
-        </p:nvSpPr>
-        <p:spPr>
-          <a:xfrm>
-            <a:off x="411479" y="1849831"/>
-            <a:ext cx="914400" cy="642823"/>
-          </a:xfrm>
-          <a:prstGeom prst="rect">
-            <a:avLst/>
-          </a:prstGeom>
-          <a:noFill/>
-        </p:spPr>
-        <p:txBody>
-          <a:bodyPr wrap="none">
-            <a:spAutoFit/>
-          </a:bodyPr>
-          <a:lstStyle/>
-          <a:p>
-            <a:r>
-              <a:rPr sz="1000" b="1">
-                <a:solidFill>
-                  <a:srgbClr val="5A6273"/>
-                </a:solidFill>
-                <a:latin typeface="微软雅黑"/>
-                <ns5:rFonts xmlns:ns5="http://schemas.openxmlformats.org/wordprocessingml/2006/main" ns5:eastAsia="微软雅黑" ns5:ascii="微软雅黑" ns5:hAnsi="微软雅黑"/>
-              </a:rPr>
-              <a:t>团队</a:t>
-            </a:r>
-          </a:p>
-        </p:txBody>
-      </p:sp>
-      <p:sp>
-        <p:nvSpPr>
-          <p:cNvPr id="13" name="TextBox 12"/>
-          <p:cNvSpPr txBox="1"/>
-          <p:nvPr/>
-        </p:nvSpPr>
-        <p:spPr>
-          <a:xfrm>
-            <a:off x="1280160" y="1849831"/>
-            <a:ext cx="2468880" cy="642823"/>
-          </a:xfrm>
-          <a:prstGeom prst="rect">
-            <a:avLst/>
-          </a:prstGeom>
-          <a:noFill/>
-        </p:spPr>
-        <p:txBody>
-          <a:bodyPr wrap="none">
-            <a:spAutoFit/>
-          </a:bodyPr>
-          <a:lstStyle/>
-          <a:p>
-            <a:r>
-              <a:rPr sz="1000" b="0">
-                <a:solidFill>
-                  <a:srgbClr val="143278"/>
-                </a:solidFill>
-                <a:latin typeface="微软雅黑"/>
-                <ns6:rFonts xmlns:ns6="http://schemas.openxmlformats.org/wordprocessingml/2006/main" ns6:eastAsia="微软雅黑" ns6:ascii="微软雅黑" ns6:hAnsi="微软雅黑"/>
-              </a:rPr>
-              <a:t>从容应队（中山大学）</a:t>
-            </a:r>
-          </a:p>
-        </p:txBody>
-      </p:sp>
-      <p:sp>
-        <p:nvSpPr>
-          <p:cNvPr id="14" name="Rectangle 13"/>
-          <p:cNvSpPr/>
-          <p:nvPr/>
-        </p:nvSpPr>
-        <p:spPr>
-          <a:xfrm>
-            <a:off x="274320" y="2547518"/>
-            <a:ext cx="3611880" cy="679399"/>
-          </a:xfrm>
-          <a:prstGeom prst="rect">
-            <a:avLst/>
-          </a:prstGeom>
-          <a:solidFill>
-            <a:srgbClr val="F1F7FF"/>
-          </a:solidFill>
-          <a:ln>
-            <a:solidFill>
-              <a:srgbClr val="BAC8DC"/>
-            </a:solidFill>
-          </a:ln>
-        </p:spPr>
-        <p:style>
-          <a:lnRef idx="1">
-            <a:schemeClr val="accent1"/>
-          </a:lnRef>
-          <a:fillRef idx="3">
-            <a:schemeClr val="accent1"/>
-          </a:fillRef>
-          <a:effectRef idx="2">
-            <a:schemeClr val="accent1"/>
-          </a:effectRef>
-          <a:fontRef idx="minor">
-            <a:schemeClr val="lt1"/>
-          </a:fontRef>
-        </p:style>
-        <p:txBody>
-          <a:bodyPr rtlCol="0" anchor="ctr"/>
-          <a:lstStyle/>
-          <a:p>
-            <a:pPr algn="ctr"/>
-          </a:p>
-        </p:txBody>
-      </p:sp>
-      <p:sp>
-        <p:nvSpPr>
-          <p:cNvPr id="15" name="TextBox 14"/>
-          <p:cNvSpPr txBox="1"/>
-          <p:nvPr/>
-        </p:nvSpPr>
-        <p:spPr>
-          <a:xfrm>
-            <a:off x="411479" y="2602382"/>
-            <a:ext cx="914400" cy="642823"/>
-          </a:xfrm>
-          <a:prstGeom prst="rect">
-            <a:avLst/>
-          </a:prstGeom>
-          <a:noFill/>
-        </p:spPr>
-        <p:txBody>
-          <a:bodyPr wrap="none">
-            <a:spAutoFit/>
-          </a:bodyPr>
-          <a:lstStyle/>
-          <a:p>
-            <a:r>
-              <a:rPr sz="1000" b="1">
-                <a:solidFill>
-                  <a:srgbClr val="5A6273"/>
-                </a:solidFill>
-                <a:latin typeface="微软雅黑"/>
-                <ns7:rFonts xmlns:ns7="http://schemas.openxmlformats.org/wordprocessingml/2006/main" ns7:eastAsia="微软雅黑" ns7:ascii="微软雅黑" ns7:hAnsi="微软雅黑"/>
-              </a:rPr>
-              <a:t>本地演示</a:t>
-            </a:r>
-          </a:p>
-        </p:txBody>
-      </p:sp>
-      <p:sp>
-        <p:nvSpPr>
-          <p:cNvPr id="16" name="TextBox 15"/>
-          <p:cNvSpPr txBox="1"/>
-          <p:nvPr/>
-        </p:nvSpPr>
-        <p:spPr>
-          <a:xfrm>
-            <a:off x="1280160" y="2602382"/>
-            <a:ext cx="2468880" cy="642823"/>
-          </a:xfrm>
-          <a:prstGeom prst="rect">
-            <a:avLst/>
-          </a:prstGeom>
-          <a:noFill/>
-        </p:spPr>
-        <p:txBody>
-          <a:bodyPr wrap="none">
-            <a:spAutoFit/>
-          </a:bodyPr>
-          <a:lstStyle/>
-          <a:p>
-            <a:r>
-              <a:rPr sz="1000" b="0">
-                <a:solidFill>
-                  <a:srgbClr val="143278"/>
-                </a:solidFill>
-                <a:latin typeface="微软雅黑"/>
-                <ns8:rFonts xmlns:ns8="http://schemas.openxmlformats.org/wordprocessingml/2006/main" ns8:eastAsia="微软雅黑" ns8:ascii="微软雅黑" ns8:hAnsi="微软雅黑"/>
-              </a:rPr>
-              <a:t>bash scripts/run_web.sh</a:t>
-            </a:r>
-          </a:p>
-        </p:txBody>
-      </p:sp>
-      <p:sp>
-        <p:nvSpPr>
-          <p:cNvPr id="17" name="Rectangle 16"/>
-          <p:cNvSpPr/>
-          <p:nvPr/>
-        </p:nvSpPr>
-        <p:spPr>
-          <a:xfrm>
-            <a:off x="274320" y="3300069"/>
-            <a:ext cx="3611880" cy="679399"/>
-          </a:xfrm>
-          <a:prstGeom prst="rect">
-            <a:avLst/>
-          </a:prstGeom>
-          <a:solidFill>
-            <a:srgbClr val="FFFFFF"/>
-          </a:solidFill>
-          <a:ln>
-            <a:solidFill>
-              <a:srgbClr val="BAC8DC"/>
-            </a:solidFill>
-          </a:ln>
-        </p:spPr>
-        <p:style>
-          <a:lnRef idx="1">
-            <a:schemeClr val="accent1"/>
-          </a:lnRef>
-          <a:fillRef idx="3">
-            <a:schemeClr val="accent1"/>
-          </a:fillRef>
-          <a:effectRef idx="2">
-            <a:schemeClr val="accent1"/>
-          </a:effectRef>
-          <a:fontRef idx="minor">
-            <a:schemeClr val="lt1"/>
-          </a:fontRef>
-        </p:style>
-        <p:txBody>
-          <a:bodyPr rtlCol="0" anchor="ctr"/>
-          <a:lstStyle/>
-          <a:p>
-            <a:pPr algn="ctr"/>
-          </a:p>
-        </p:txBody>
-      </p:sp>
-      <p:sp>
-        <p:nvSpPr>
-          <p:cNvPr id="18" name="TextBox 17"/>
-          <p:cNvSpPr txBox="1"/>
-          <p:nvPr/>
-        </p:nvSpPr>
-        <p:spPr>
-          <a:xfrm>
-            <a:off x="411479" y="3354933"/>
-            <a:ext cx="914400" cy="642823"/>
-          </a:xfrm>
-          <a:prstGeom prst="rect">
-            <a:avLst/>
-          </a:prstGeom>
-          <a:noFill/>
-        </p:spPr>
-        <p:txBody>
-          <a:bodyPr wrap="none">
-            <a:spAutoFit/>
-          </a:bodyPr>
-          <a:lstStyle/>
-          <a:p>
-            <a:r>
-              <a:rPr sz="1000" b="1">
-                <a:solidFill>
-                  <a:srgbClr val="5A6273"/>
-                </a:solidFill>
-                <a:latin typeface="微软雅黑"/>
-                <ns9:rFonts xmlns:ns9="http://schemas.openxmlformats.org/wordprocessingml/2006/main" ns9:eastAsia="微软雅黑" ns9:ascii="微软雅黑" ns9:hAnsi="微软雅黑"/>
-              </a:rPr>
-              <a:t>演示录像</a:t>
-            </a:r>
-          </a:p>
-        </p:txBody>
-      </p:sp>
-      <p:sp>
-        <p:nvSpPr>
-          <p:cNvPr id="19" name="TextBox 18"/>
-          <p:cNvSpPr txBox="1"/>
-          <p:nvPr/>
-        </p:nvSpPr>
-        <p:spPr>
-          <a:xfrm>
-            <a:off x="1280160" y="3354933"/>
-            <a:ext cx="2468880" cy="642823"/>
-          </a:xfrm>
-          <a:prstGeom prst="rect">
-            <a:avLst/>
-          </a:prstGeom>
-          <a:noFill/>
-        </p:spPr>
-        <p:txBody>
-          <a:bodyPr wrap="none">
-            <a:spAutoFit/>
-          </a:bodyPr>
-          <a:lstStyle/>
-          <a:p>
-            <a:r>
-              <a:rPr sz="1000" b="0">
-                <a:solidFill>
-                  <a:srgbClr val="143278"/>
-                </a:solidFill>
-                <a:latin typeface="微软雅黑"/>
-                <ns10:rFonts xmlns:ns10="http://schemas.openxmlformats.org/wordprocessingml/2006/main" ns10:eastAsia="微软雅黑" ns10:ascii="微软雅黑" ns10:hAnsi="微软雅黑"/>
-              </a:rPr>
-              <a:t>docs/assets/demo_carecompanion.mp4</a:t>
-            </a:r>
-          </a:p>
-        </p:txBody>
-      </p:sp>
-      <p:sp>
-        <p:nvSpPr>
-          <p:cNvPr id="20" name="Rectangle 19"/>
-          <p:cNvSpPr/>
-          <p:nvPr/>
-        </p:nvSpPr>
-        <p:spPr>
-          <a:xfrm>
-            <a:off x="274320" y="4052620"/>
-            <a:ext cx="3611880" cy="679399"/>
-          </a:xfrm>
-          <a:prstGeom prst="rect">
-            <a:avLst/>
-          </a:prstGeom>
-          <a:solidFill>
-            <a:srgbClr val="F1F7FF"/>
-          </a:solidFill>
-          <a:ln>
-            <a:solidFill>
-              <a:srgbClr val="BAC8DC"/>
-            </a:solidFill>
-          </a:ln>
-        </p:spPr>
-        <p:style>
-          <a:lnRef idx="1">
-            <a:schemeClr val="accent1"/>
-          </a:lnRef>
-          <a:fillRef idx="3">
-            <a:schemeClr val="accent1"/>
-          </a:fillRef>
-          <a:effectRef idx="2">
-            <a:schemeClr val="accent1"/>
-          </a:effectRef>
-          <a:fontRef idx="minor">
-            <a:schemeClr val="lt1"/>
-          </a:fontRef>
-        </p:style>
-        <p:txBody>
-          <a:bodyPr rtlCol="0" anchor="ctr"/>
-          <a:lstStyle/>
-          <a:p>
-            <a:pPr algn="ctr"/>
-          </a:p>
-        </p:txBody>
-      </p:sp>
-      <p:sp>
-        <p:nvSpPr>
-          <p:cNvPr id="21" name="TextBox 20"/>
-          <p:cNvSpPr txBox="1"/>
-          <p:nvPr/>
-        </p:nvSpPr>
-        <p:spPr>
-          <a:xfrm>
-            <a:off x="411479" y="4107484"/>
-            <a:ext cx="914400" cy="642823"/>
-          </a:xfrm>
-          <a:prstGeom prst="rect">
-            <a:avLst/>
-          </a:prstGeom>
-          <a:noFill/>
-        </p:spPr>
-        <p:txBody>
-          <a:bodyPr wrap="none">
-            <a:spAutoFit/>
-          </a:bodyPr>
-          <a:lstStyle/>
-          <a:p>
-            <a:r>
-              <a:rPr sz="1000" b="1">
-                <a:solidFill>
-                  <a:srgbClr val="5A6273"/>
-                </a:solidFill>
-                <a:latin typeface="微软雅黑"/>
-                <ns11:rFonts xmlns:ns11="http://schemas.openxmlformats.org/wordprocessingml/2006/main" ns11:eastAsia="微软雅黑" ns11:ascii="微软雅黑" ns11:hAnsi="微软雅黑"/>
-              </a:rPr>
-              <a:t>软著</a:t>
-            </a:r>
-          </a:p>
-        </p:txBody>
-      </p:sp>
-      <p:sp>
-        <p:nvSpPr>
-          <p:cNvPr id="22" name="TextBox 21"/>
-          <p:cNvSpPr txBox="1"/>
-          <p:nvPr/>
-        </p:nvSpPr>
-        <p:spPr>
-          <a:xfrm>
-            <a:off x="1280160" y="4107484"/>
-            <a:ext cx="2468880" cy="642823"/>
-          </a:xfrm>
-          <a:prstGeom prst="rect">
-            <a:avLst/>
-          </a:prstGeom>
-          <a:noFill/>
-        </p:spPr>
-        <p:txBody>
-          <a:bodyPr wrap="none">
-            <a:spAutoFit/>
-          </a:bodyPr>
-          <a:lstStyle/>
-          <a:p>
-            <a:r>
-              <a:rPr sz="1000" b="0">
-                <a:solidFill>
-                  <a:srgbClr val="143278"/>
-                </a:solidFill>
-                <a:latin typeface="微软雅黑"/>
-                <ns12:rFonts xmlns:ns12="http://schemas.openxmlformats.org/wordprocessingml/2006/main" ns12:eastAsia="微软雅黑" ns12:ascii="微软雅黑" ns12:hAnsi="微软雅黑"/>
-              </a:rPr>
-              <a:t>申请中</a:t>
-            </a:r>
-          </a:p>
-        </p:txBody>
-      </p:sp>
-      <p:sp>
-        <p:nvSpPr>
-          <p:cNvPr id="23" name="Rectangle 22"/>
-          <p:cNvSpPr/>
-          <p:nvPr/>
-        </p:nvSpPr>
-        <p:spPr>
-          <a:xfrm>
-            <a:off x="4105656" y="1033272"/>
-            <a:ext cx="4727448" cy="3744468"/>
-          </a:xfrm>
-          <a:prstGeom prst="rect">
-            <a:avLst/>
-          </a:prstGeom>
-          <a:solidFill>
-            <a:srgbClr val="FFFFFF"/>
-          </a:solidFill>
-          <a:ln w="9525">
-            <a:solidFill>
-              <a:srgbClr val="BAC8DC"/>
-            </a:solidFill>
-          </a:ln>
-        </p:spPr>
-        <p:style>
-          <a:lnRef idx="1">
-            <a:schemeClr val="accent1"/>
-          </a:lnRef>
-          <a:fillRef idx="3">
-            <a:schemeClr val="accent1"/>
-          </a:fillRef>
-          <a:effectRef idx="2">
-            <a:schemeClr val="accent1"/>
-          </a:effectRef>
-          <a:fontRef idx="minor">
-            <a:schemeClr val="lt1"/>
-          </a:fontRef>
-        </p:style>
-        <p:txBody>
-          <a:bodyPr rtlCol="0" anchor="ctr"/>
-          <a:lstStyle/>
-          <a:p>
-            <a:pPr algn="ctr"/>
-          </a:p>
-        </p:txBody>
-      </p:sp>
       <p:pic>
         <p:nvPicPr>
-          <p:cNvPr id="24" name="Picture 23" descr="ppt_demo_qr.png"/>
+          <p:cNvPr id="10" name="Picture 9" descr="ppt_demo_qr.png"/>
           <p:cNvPicPr>
             <a:picLocks noChangeAspect="1"/>
           </p:cNvPicPr>
@@ -14316,8 +14017,8 @@
         </p:blipFill>
         <p:spPr>
           <a:xfrm>
-            <a:off x="4304995" y="1241755"/>
-            <a:ext cx="1219809" cy="1219809"/>
+            <a:off x="5788152" y="1106424"/>
+            <a:ext cx="1362456" cy="1362456"/>
           </a:xfrm>
           <a:prstGeom prst="rect">
             <a:avLst/>
@@ -14326,14 +14027,14 @@
       </p:pic>
       <p:sp>
         <p:nvSpPr>
-          <p:cNvPr id="25" name="TextBox 24"/>
+          <p:cNvPr id="11" name="TextBox 10"/>
           <p:cNvSpPr txBox="1"/>
           <p:nvPr/>
         </p:nvSpPr>
         <p:spPr>
           <a:xfrm>
-            <a:off x="4160520" y="2569463"/>
-            <a:ext cx="1508760" cy="219456"/>
+            <a:off x="4123944" y="2560320"/>
+            <a:ext cx="4690872" cy="201168"/>
           </a:xfrm>
           <a:prstGeom prst="rect">
             <a:avLst/>
@@ -14341,59 +14042,35 @@
           <a:noFill/>
         </p:spPr>
         <p:txBody>
-          <a:bodyPr wrap="square" anchor="ctr">
+          <a:bodyPr wrap="none">
             <a:spAutoFit/>
           </a:bodyPr>
           <a:lstStyle/>
           <a:p>
             <a:pPr algn="ctr"/>
             <a:r>
-              <a:rPr sz="800" b="0">
-                <a:solidFill>
-                  <a:srgbClr val="5A6273"/>
+              <a:rPr sz="900" b="1">
+                <a:solidFill>
+                  <a:srgbClr val="143278"/>
                 </a:solidFill>
                 <a:latin typeface="微软雅黑"/>
                 <ns13:rFonts xmlns:ns13="http://schemas.openxmlformats.org/wordprocessingml/2006/main" ns13:eastAsia="微软雅黑" ns13:ascii="微软雅黑" ns13:hAnsi="微软雅黑"/>
               </a:rPr>
-              <a:t>扫码访问仓库</a:t>
-            </a:r>
-          </a:p>
-        </p:txBody>
-      </p:sp>
-      <p:pic>
-        <p:nvPicPr>
-          <p:cNvPr id="26" name="Picture 25" descr="repro_checklist.png"/>
-          <p:cNvPicPr>
-            <a:picLocks noChangeAspect="1"/>
-          </p:cNvPicPr>
-          <p:nvPr/>
-        </p:nvPicPr>
-        <p:blipFill>
-          <a:blip r:embed="rId3"/>
-          <a:stretch>
-            <a:fillRect/>
-          </a:stretch>
-        </p:blipFill>
-        <p:spPr>
-          <a:xfrm>
-            <a:off x="5929665" y="1190365"/>
-            <a:ext cx="2697917" cy="3192536"/>
-          </a:xfrm>
-          <a:prstGeom prst="rect">
-            <a:avLst/>
-          </a:prstGeom>
-        </p:spPr>
-      </p:pic>
-      <p:sp>
-        <p:nvSpPr>
-          <p:cNvPr id="27" name="TextBox 26"/>
+              <a:t>扫码访问 GitHub 仓库</a:t>
+            </a:r>
+          </a:p>
+        </p:txBody>
+      </p:sp>
+      <p:sp>
+        <p:nvSpPr>
+          <p:cNvPr id="12" name="TextBox 11"/>
           <p:cNvSpPr txBox="1"/>
           <p:nvPr/>
         </p:nvSpPr>
         <p:spPr>
           <a:xfrm>
-            <a:off x="5779007" y="4576572"/>
-            <a:ext cx="2999232" cy="219456"/>
+            <a:off x="4261104" y="2871215"/>
+            <a:ext cx="4416552" cy="1417320"/>
           </a:xfrm>
           <a:prstGeom prst="rect">
             <a:avLst/>
@@ -14401,21 +14078,93 @@
           <a:noFill/>
         </p:spPr>
         <p:txBody>
-          <a:bodyPr wrap="square" anchor="ctr">
+          <a:bodyPr wrap="square">
             <a:spAutoFit/>
           </a:bodyPr>
           <a:lstStyle/>
           <a:p>
-            <a:pPr algn="ctr"/>
-            <a:r>
-              <a:rPr sz="800" b="0">
-                <a:solidFill>
-                  <a:srgbClr val="5A6273"/>
+            <a:pPr>
+              <a:spcAft>
+                <a:spcPts val="500"/>
+              </a:spcAft>
+            </a:pPr>
+            <a:r>
+              <a:rPr sz="1000" b="0">
+                <a:solidFill>
+                  <a:srgbClr val="166534"/>
                 </a:solidFill>
                 <a:latin typeface="微软雅黑"/>
                 <ns14:rFonts xmlns:ns14="http://schemas.openxmlformats.org/wordprocessingml/2006/main" ns14:eastAsia="微软雅黑" ns14:ascii="微软雅黑" ns14:hAnsi="微软雅黑"/>
               </a:rPr>
-              <a:t>可复现性检查项</a:t>
+              <a:t>✓  完整源码与 README</a:t>
+            </a:r>
+          </a:p>
+          <a:p>
+            <a:pPr>
+              <a:spcAft>
+                <a:spcPts val="500"/>
+              </a:spcAft>
+            </a:pPr>
+            <a:r>
+              <a:rPr sz="1000" b="0">
+                <a:solidFill>
+                  <a:srgbClr val="166534"/>
+                </a:solidFill>
+                <a:latin typeface="微软雅黑"/>
+                <ns15:rFonts xmlns:ns15="http://schemas.openxmlformats.org/wordprocessingml/2006/main" ns15:eastAsia="微软雅黑" ns15:ascii="微软雅黑" ns15:hAnsi="微软雅黑"/>
+              </a:rPr>
+              <a:t>✓  一键启动脚本 run_web.sh</a:t>
+            </a:r>
+          </a:p>
+          <a:p>
+            <a:pPr>
+              <a:spcAft>
+                <a:spcPts val="500"/>
+              </a:spcAft>
+            </a:pPr>
+            <a:r>
+              <a:rPr sz="1000" b="0">
+                <a:solidFill>
+                  <a:srgbClr val="166534"/>
+                </a:solidFill>
+                <a:latin typeface="微软雅黑"/>
+                <ns16:rFonts xmlns:ns16="http://schemas.openxmlformats.org/wordprocessingml/2006/main" ns16:eastAsia="微软雅黑" ns16:ascii="微软雅黑" ns16:hAnsi="微软雅黑"/>
+              </a:rPr>
+              <a:t>✓  fall_eval_report.json</a:t>
+            </a:r>
+          </a:p>
+          <a:p>
+            <a:pPr>
+              <a:spcAft>
+                <a:spcPts val="500"/>
+              </a:spcAft>
+            </a:pPr>
+            <a:r>
+              <a:rPr sz="1000" b="0">
+                <a:solidFill>
+                  <a:srgbClr val="166534"/>
+                </a:solidFill>
+                <a:latin typeface="微软雅黑"/>
+                <ns17:rFonts xmlns:ns17="http://schemas.openxmlformats.org/wordprocessingml/2006/main" ns17:eastAsia="微软雅黑" ns17:ascii="微软雅黑" ns17:hAnsi="微软雅黑"/>
+              </a:rPr>
+              <a:t>✓  pytest 单元测试</a:t>
+            </a:r>
+          </a:p>
+          <a:p>
+            <a:pPr>
+              <a:spcAft>
+                <a:spcPts val="500"/>
+              </a:spcAft>
+            </a:pPr>
+            <a:r>
+              <a:rPr sz="1000" b="0">
+                <a:solidFill>
+                  <a:srgbClr val="B45309"/>
+                </a:solidFill>
+                <a:latin typeface="微软雅黑"/>
+                <ns18:rFonts xmlns:ns18="http://schemas.openxmlformats.org/wordprocessingml/2006/main" ns18:eastAsia="微软雅黑" ns18:ascii="微软雅黑" ns18:hAnsi="微软雅黑"/>
+              </a:rPr>
+              <a:t>○  软著申请中</a:t>
             </a:r>
           </a:p>
         </p:txBody>
@@ -15808,8 +15557,8 @@
         </p:nvSpPr>
         <p:spPr>
           <a:xfrm>
-            <a:off x="4855588" y="1151595"/>
-            <a:ext cx="3227583" cy="3215213"/>
+            <a:off x="4325517" y="1151595"/>
+            <a:ext cx="4287724" cy="3215213"/>
           </a:xfrm>
           <a:prstGeom prst="rect">
             <a:avLst/>
@@ -15861,8 +15610,8 @@
         </p:blipFill>
         <p:spPr>
           <a:xfrm>
-            <a:off x="4892164" y="1188171"/>
-            <a:ext cx="3154431" cy="3142061"/>
+            <a:off x="4362093" y="1188171"/>
+            <a:ext cx="4214572" cy="3142061"/>
           </a:xfrm>
           <a:prstGeom prst="rect">
             <a:avLst/>
@@ -15900,7 +15649,7 @@
                 <a:latin typeface="微软雅黑"/>
                 <ns8:rFonts xmlns:ns8="http://schemas.openxmlformats.org/wordprocessingml/2006/main" ns8:eastAsia="微软雅黑" ns8:ascii="微软雅黑" ns8:hAnsi="微软雅黑"/>
               </a:rPr>
-              <a:t>创新维度雷达图</a:t>
+              <a:t>创新维度自评</a:t>
             </a:r>
           </a:p>
         </p:txBody>
@@ -18722,14 +18471,14 @@
         </p:nvSpPr>
         <p:spPr>
           <a:xfrm>
-            <a:off x="0" y="420624"/>
-            <a:ext cx="4434840" cy="4722876"/>
+            <a:off x="0" y="4905756"/>
+            <a:ext cx="9144000" cy="237744"/>
           </a:xfrm>
           <a:prstGeom prst="rect">
             <a:avLst/>
           </a:prstGeom>
           <a:solidFill>
-            <a:srgbClr val="143278"/>
+            <a:srgbClr val="DBEAFE"/>
           </a:solidFill>
           <a:ln>
             <a:noFill/>
@@ -18759,14 +18508,282 @@
       </p:sp>
       <p:sp>
         <p:nvSpPr>
-          <p:cNvPr id="5" name="Rectangle 4"/>
+          <p:cNvPr id="5" name="TextBox 4"/>
+          <p:cNvSpPr txBox="1"/>
+          <p:nvPr/>
+        </p:nvSpPr>
+        <p:spPr>
+          <a:xfrm>
+            <a:off x="274320" y="4951476"/>
+            <a:ext cx="8595360" cy="182880"/>
+          </a:xfrm>
+          <a:prstGeom prst="rect">
+            <a:avLst/>
+          </a:prstGeom>
+          <a:noFill/>
+        </p:spPr>
+        <p:txBody>
+          <a:bodyPr wrap="none">
+            <a:spAutoFit/>
+          </a:bodyPr>
+          <a:lstStyle/>
+          <a:p>
+            <a:pPr algn="ctr"/>
+            <a:r>
+              <a:rPr sz="800" b="0">
+                <a:solidFill>
+                  <a:srgbClr val="5A6273"/>
+                </a:solidFill>
+                <a:latin typeface="微软雅黑"/>
+                <ns1:rFonts xmlns:ns1="http://schemas.openxmlformats.org/wordprocessingml/2006/main" ns1:eastAsia="微软雅黑" ns1:ascii="微软雅黑" ns1:hAnsi="微软雅黑"/>
+              </a:rPr>
+              <a:t>从容应队 · 中山大学 · 刘小凡/白冉 · 指导教师 彭键清</a:t>
+            </a:r>
+          </a:p>
+        </p:txBody>
+      </p:sp>
+      <p:sp>
+        <p:nvSpPr>
+          <p:cNvPr id="6" name="Rectangle 5"/>
           <p:cNvSpPr/>
           <p:nvPr/>
         </p:nvSpPr>
         <p:spPr>
           <a:xfrm>
-            <a:off x="115305" y="1531180"/>
-            <a:ext cx="4204228" cy="2227443"/>
+            <a:off x="0" y="420624"/>
+            <a:ext cx="9144000" cy="4485132"/>
+          </a:xfrm>
+          <a:prstGeom prst="rect">
+            <a:avLst/>
+          </a:prstGeom>
+          <a:solidFill>
+            <a:srgbClr val="F1F7FF"/>
+          </a:solidFill>
+          <a:ln>
+            <a:noFill/>
+          </a:ln>
+        </p:spPr>
+        <p:style>
+          <a:lnRef idx="1">
+            <a:schemeClr val="accent1"/>
+          </a:lnRef>
+          <a:fillRef idx="3">
+            <a:schemeClr val="accent1"/>
+          </a:fillRef>
+          <a:effectRef idx="2">
+            <a:schemeClr val="accent1"/>
+          </a:effectRef>
+          <a:fontRef idx="minor">
+            <a:schemeClr val="lt1"/>
+          </a:fontRef>
+        </p:style>
+        <p:txBody>
+          <a:bodyPr rtlCol="0" anchor="ctr"/>
+          <a:lstStyle/>
+          <a:p>
+            <a:pPr algn="ctr"/>
+          </a:p>
+        </p:txBody>
+      </p:sp>
+      <p:sp>
+        <p:nvSpPr>
+          <p:cNvPr id="7" name="TextBox 6"/>
+          <p:cNvSpPr txBox="1"/>
+          <p:nvPr/>
+        </p:nvSpPr>
+        <p:spPr>
+          <a:xfrm>
+            <a:off x="731520" y="960120"/>
+            <a:ext cx="7680960" cy="685800"/>
+          </a:xfrm>
+          <a:prstGeom prst="rect">
+            <a:avLst/>
+          </a:prstGeom>
+          <a:noFill/>
+        </p:spPr>
+        <p:txBody>
+          <a:bodyPr wrap="none">
+            <a:spAutoFit/>
+          </a:bodyPr>
+          <a:lstStyle/>
+          <a:p>
+            <a:pPr algn="ctr"/>
+            <a:r>
+              <a:rPr sz="3200" b="1">
+                <a:solidFill>
+                  <a:srgbClr val="143278"/>
+                </a:solidFill>
+                <a:latin typeface="微软雅黑"/>
+                <ns2:rFonts xmlns:ns2="http://schemas.openxmlformats.org/wordprocessingml/2006/main" ns2:eastAsia="微软雅黑" ns2:ascii="微软雅黑" ns2:hAnsi="微软雅黑"/>
+              </a:rPr>
+              <a:t>敬请批评指正</a:t>
+            </a:r>
+          </a:p>
+        </p:txBody>
+      </p:sp>
+      <p:sp>
+        <p:nvSpPr>
+          <p:cNvPr id="8" name="Rectangle 7"/>
+          <p:cNvSpPr/>
+          <p:nvPr/>
+        </p:nvSpPr>
+        <p:spPr>
+          <a:xfrm>
+            <a:off x="3749039" y="1664208"/>
+            <a:ext cx="1645920" cy="41148"/>
+          </a:xfrm>
+          <a:prstGeom prst="rect">
+            <a:avLst/>
+          </a:prstGeom>
+          <a:solidFill>
+            <a:srgbClr val="F59E0B"/>
+          </a:solidFill>
+          <a:ln>
+            <a:noFill/>
+          </a:ln>
+        </p:spPr>
+        <p:style>
+          <a:lnRef idx="1">
+            <a:schemeClr val="accent1"/>
+          </a:lnRef>
+          <a:fillRef idx="3">
+            <a:schemeClr val="accent1"/>
+          </a:fillRef>
+          <a:effectRef idx="2">
+            <a:schemeClr val="accent1"/>
+          </a:effectRef>
+          <a:fontRef idx="minor">
+            <a:schemeClr val="lt1"/>
+          </a:fontRef>
+        </p:style>
+        <p:txBody>
+          <a:bodyPr rtlCol="0" anchor="ctr"/>
+          <a:lstStyle/>
+          <a:p>
+            <a:pPr algn="ctr"/>
+          </a:p>
+        </p:txBody>
+      </p:sp>
+      <p:sp>
+        <p:nvSpPr>
+          <p:cNvPr id="9" name="TextBox 8"/>
+          <p:cNvSpPr txBox="1"/>
+          <p:nvPr/>
+        </p:nvSpPr>
+        <p:spPr>
+          <a:xfrm>
+            <a:off x="1097280" y="1828800"/>
+            <a:ext cx="6949440" cy="868680"/>
+          </a:xfrm>
+          <a:prstGeom prst="rect">
+            <a:avLst/>
+          </a:prstGeom>
+          <a:noFill/>
+        </p:spPr>
+        <p:txBody>
+          <a:bodyPr wrap="none">
+            <a:spAutoFit/>
+          </a:bodyPr>
+          <a:lstStyle/>
+          <a:p>
+            <a:pPr algn="ctr">
+              <a:spcAft>
+                <a:spcPts val="400"/>
+              </a:spcAft>
+            </a:pPr>
+            <a:r>
+              <a:rPr sz="1300" b="1">
+                <a:solidFill>
+                  <a:srgbClr val="143278"/>
+                </a:solidFill>
+                <a:latin typeface="微软雅黑"/>
+                <ns3:rFonts xmlns:ns3="http://schemas.openxmlformats.org/wordprocessingml/2006/main" ns3:eastAsia="微软雅黑" ns3:ascii="微软雅黑" ns3:hAnsi="微软雅黑"/>
+              </a:rPr>
+              <a:t>从容应队 · 中山大学</a:t>
+            </a:r>
+          </a:p>
+          <a:p>
+            <a:pPr algn="ctr">
+              <a:spcAft>
+                <a:spcPts val="400"/>
+              </a:spcAft>
+            </a:pPr>
+            <a:r>
+              <a:rPr sz="1200" b="0">
+                <a:solidFill>
+                  <a:srgbClr val="5A6273"/>
+                </a:solidFill>
+                <a:latin typeface="微软雅黑"/>
+                <ns4:rFonts xmlns:ns4="http://schemas.openxmlformats.org/wordprocessingml/2006/main" ns4:eastAsia="微软雅黑" ns4:ascii="微软雅黑" ns4:hAnsi="微软雅黑"/>
+              </a:rPr>
+              <a:t>队长 刘小凡  ·  队员 白冉</a:t>
+            </a:r>
+          </a:p>
+          <a:p>
+            <a:pPr algn="ctr">
+              <a:spcAft>
+                <a:spcPts val="400"/>
+              </a:spcAft>
+            </a:pPr>
+            <a:r>
+              <a:rPr sz="1200" b="0">
+                <a:solidFill>
+                  <a:srgbClr val="5A6273"/>
+                </a:solidFill>
+                <a:latin typeface="微软雅黑"/>
+                <ns5:rFonts xmlns:ns5="http://schemas.openxmlformats.org/wordprocessingml/2006/main" ns5:eastAsia="微软雅黑" ns5:ascii="微软雅黑" ns5:hAnsi="微软雅黑"/>
+              </a:rPr>
+              <a:t>指导教师 彭键清</a:t>
+            </a:r>
+          </a:p>
+        </p:txBody>
+      </p:sp>
+      <p:sp>
+        <p:nvSpPr>
+          <p:cNvPr id="10" name="TextBox 9"/>
+          <p:cNvSpPr txBox="1"/>
+          <p:nvPr/>
+        </p:nvSpPr>
+        <p:spPr>
+          <a:xfrm>
+            <a:off x="1371600" y="2697480"/>
+            <a:ext cx="6400800" cy="256032"/>
+          </a:xfrm>
+          <a:prstGeom prst="rect">
+            <a:avLst/>
+          </a:prstGeom>
+          <a:noFill/>
+        </p:spPr>
+        <p:txBody>
+          <a:bodyPr wrap="none">
+            <a:spAutoFit/>
+          </a:bodyPr>
+          <a:lstStyle/>
+          <a:p>
+            <a:pPr algn="ctr"/>
+            <a:r>
+              <a:rPr sz="900" b="0">
+                <a:solidFill>
+                  <a:srgbClr val="143278"/>
+                </a:solidFill>
+                <a:latin typeface="微软雅黑"/>
+                <ns6:rFonts xmlns:ns6="http://schemas.openxmlformats.org/wordprocessingml/2006/main" ns6:eastAsia="微软雅黑" ns6:ascii="微软雅黑" ns6:hAnsi="微软雅黑"/>
+              </a:rPr>
+              <a:t>https://github.com/FBB123571/ElderCare-Humanoid-Platform</a:t>
+            </a:r>
+          </a:p>
+        </p:txBody>
+      </p:sp>
+      <p:sp>
+        <p:nvSpPr>
+          <p:cNvPr id="11" name="Rectangle 10"/>
+          <p:cNvSpPr/>
+          <p:nvPr/>
+        </p:nvSpPr>
+        <p:spPr>
+          <a:xfrm>
+            <a:off x="2706110" y="3140964"/>
+            <a:ext cx="2177299" cy="1143000"/>
           </a:xfrm>
           <a:prstGeom prst="rect">
             <a:avLst/>
@@ -18804,7 +18821,7 @@
       </p:sp>
       <p:pic>
         <p:nvPicPr>
-          <p:cNvPr id="6" name="Picture 5" descr="ppt_full_dashboard.png"/>
+          <p:cNvPr id="12" name="Picture 11" descr="ppt_full_dashboard.png"/>
           <p:cNvPicPr>
             <a:picLocks noChangeAspect="1"/>
           </p:cNvPicPr>
@@ -18818,8 +18835,8 @@
         </p:blipFill>
         <p:spPr>
           <a:xfrm>
-            <a:off x="151881" y="1567756"/>
-            <a:ext cx="4131076" cy="2154291"/>
+            <a:off x="2742686" y="3177540"/>
+            <a:ext cx="2104147" cy="1097280"/>
           </a:xfrm>
           <a:prstGeom prst="rect">
             <a:avLst/>
@@ -18828,14 +18845,14 @@
       </p:pic>
       <p:sp>
         <p:nvSpPr>
-          <p:cNvPr id="7" name="TextBox 6"/>
+          <p:cNvPr id="13" name="TextBox 12"/>
           <p:cNvSpPr txBox="1"/>
           <p:nvPr/>
         </p:nvSpPr>
         <p:spPr>
           <a:xfrm>
-            <a:off x="109728" y="4832604"/>
-            <a:ext cx="4215383" cy="219456"/>
+            <a:off x="2263139" y="4352544"/>
+            <a:ext cx="3063240" cy="219456"/>
           </a:xfrm>
           <a:prstGeom prst="rect">
             <a:avLst/>
@@ -18855,214 +18872,16 @@
                   <a:srgbClr val="5A6273"/>
                 </a:solidFill>
                 <a:latin typeface="微软雅黑"/>
-                <ns1:rFonts xmlns:ns1="http://schemas.openxmlformats.org/wordprocessingml/2006/main" ns1:eastAsia="微软雅黑" ns1:ascii="微软雅黑" ns1:hAnsi="微软雅黑"/>
+                <ns7:rFonts xmlns:ns7="http://schemas.openxmlformats.org/wordprocessingml/2006/main" ns7:eastAsia="微软雅黑" ns7:ascii="微软雅黑" ns7:hAnsi="微软雅黑"/>
               </a:rPr>
-              <a:t>系统仪表盘</a:t>
-            </a:r>
-          </a:p>
-        </p:txBody>
-      </p:sp>
-      <p:sp>
-        <p:nvSpPr>
-          <p:cNvPr id="8" name="Rectangle 7"/>
-          <p:cNvSpPr/>
-          <p:nvPr/>
-        </p:nvSpPr>
-        <p:spPr>
-          <a:xfrm>
-            <a:off x="4434840" y="420624"/>
-            <a:ext cx="4709160" cy="4722876"/>
-          </a:xfrm>
-          <a:prstGeom prst="rect">
-            <a:avLst/>
-          </a:prstGeom>
-          <a:solidFill>
-            <a:srgbClr val="F1F7FF"/>
-          </a:solidFill>
-          <a:ln>
-            <a:noFill/>
-          </a:ln>
-        </p:spPr>
-        <p:style>
-          <a:lnRef idx="1">
-            <a:schemeClr val="accent1"/>
-          </a:lnRef>
-          <a:fillRef idx="3">
-            <a:schemeClr val="accent1"/>
-          </a:fillRef>
-          <a:effectRef idx="2">
-            <a:schemeClr val="accent1"/>
-          </a:effectRef>
-          <a:fontRef idx="minor">
-            <a:schemeClr val="lt1"/>
-          </a:fontRef>
-        </p:style>
-        <p:txBody>
-          <a:bodyPr rtlCol="0" anchor="ctr"/>
-          <a:lstStyle/>
-          <a:p>
-            <a:pPr algn="ctr"/>
-          </a:p>
-        </p:txBody>
-      </p:sp>
-      <p:sp>
-        <p:nvSpPr>
-          <p:cNvPr id="9" name="TextBox 8"/>
-          <p:cNvSpPr txBox="1"/>
-          <p:nvPr/>
-        </p:nvSpPr>
-        <p:spPr>
-          <a:xfrm>
-            <a:off x="4617720" y="1234440"/>
-            <a:ext cx="4343400" cy="594360"/>
-          </a:xfrm>
-          <a:prstGeom prst="rect">
-            <a:avLst/>
-          </a:prstGeom>
-          <a:noFill/>
-        </p:spPr>
-        <p:txBody>
-          <a:bodyPr wrap="none">
-            <a:spAutoFit/>
-          </a:bodyPr>
-          <a:lstStyle/>
-          <a:p>
-            <a:pPr algn="ctr"/>
-            <a:r>
-              <a:rPr sz="3000" b="1">
-                <a:solidFill>
-                  <a:srgbClr val="143278"/>
-                </a:solidFill>
-                <a:latin typeface="微软雅黑"/>
-                <ns2:rFonts xmlns:ns2="http://schemas.openxmlformats.org/wordprocessingml/2006/main" ns2:eastAsia="微软雅黑" ns2:ascii="微软雅黑" ns2:hAnsi="微软雅黑"/>
-              </a:rPr>
-              <a:t>敬请批评指正</a:t>
-            </a:r>
-          </a:p>
-        </p:txBody>
-      </p:sp>
-      <p:sp>
-        <p:nvSpPr>
-          <p:cNvPr id="10" name="TextBox 9"/>
-          <p:cNvSpPr txBox="1"/>
-          <p:nvPr/>
-        </p:nvSpPr>
-        <p:spPr>
-          <a:xfrm>
-            <a:off x="4617720" y="1965960"/>
-            <a:ext cx="4343400" cy="1005840"/>
-          </a:xfrm>
-          <a:prstGeom prst="rect">
-            <a:avLst/>
-          </a:prstGeom>
-          <a:noFill/>
-        </p:spPr>
-        <p:txBody>
-          <a:bodyPr wrap="none">
-            <a:spAutoFit/>
-          </a:bodyPr>
-          <a:lstStyle/>
-          <a:p>
-            <a:pPr algn="ctr">
-              <a:spcAft>
-                <a:spcPts val="600"/>
-              </a:spcAft>
-            </a:pPr>
-            <a:r>
-              <a:rPr sz="1300" b="1">
-                <a:solidFill>
-                  <a:srgbClr val="1C202C"/>
-                </a:solidFill>
-                <a:latin typeface="微软雅黑"/>
-                <ns3:rFonts xmlns:ns3="http://schemas.openxmlformats.org/wordprocessingml/2006/main" ns3:eastAsia="微软雅黑" ns3:ascii="微软雅黑" ns3:hAnsi="微软雅黑"/>
-              </a:rPr>
-              <a:t>从容应队 · 中山大学</a:t>
-            </a:r>
-          </a:p>
-          <a:p>
-            <a:pPr algn="ctr">
-              <a:spcAft>
-                <a:spcPts val="600"/>
-              </a:spcAft>
-            </a:pPr>
-            <a:r>
-              <a:rPr sz="1300" b="0">
-                <a:solidFill>
-                  <a:srgbClr val="1C202C"/>
-                </a:solidFill>
-                <a:latin typeface="微软雅黑"/>
-                <ns4:rFonts xmlns:ns4="http://schemas.openxmlformats.org/wordprocessingml/2006/main" ns4:eastAsia="微软雅黑" ns4:ascii="微软雅黑" ns4:hAnsi="微软雅黑"/>
-              </a:rPr>
-              <a:t>刘小凡 · 白冉</a:t>
-            </a:r>
-          </a:p>
-          <a:p>
-            <a:pPr algn="ctr">
-              <a:spcAft>
-                <a:spcPts val="600"/>
-              </a:spcAft>
-            </a:pPr>
-            <a:r>
-              <a:rPr sz="1300" b="0">
-                <a:solidFill>
-                  <a:srgbClr val="1C202C"/>
-                </a:solidFill>
-                <a:latin typeface="微软雅黑"/>
-                <ns5:rFonts xmlns:ns5="http://schemas.openxmlformats.org/wordprocessingml/2006/main" ns5:eastAsia="微软雅黑" ns5:ascii="微软雅黑" ns5:hAnsi="微软雅黑"/>
-              </a:rPr>
-              <a:t>指导教师 彭键清</a:t>
-            </a:r>
-          </a:p>
-        </p:txBody>
-      </p:sp>
-      <p:sp>
-        <p:nvSpPr>
-          <p:cNvPr id="11" name="Rectangle 10"/>
-          <p:cNvSpPr/>
-          <p:nvPr/>
-        </p:nvSpPr>
-        <p:spPr>
-          <a:xfrm>
-            <a:off x="5907024" y="3026664"/>
-            <a:ext cx="1216152" cy="1143000"/>
-          </a:xfrm>
-          <a:prstGeom prst="rect">
-            <a:avLst/>
-          </a:prstGeom>
-          <a:solidFill>
-            <a:srgbClr val="FCFDFF"/>
-          </a:solidFill>
-          <a:ln w="7620">
-            <a:solidFill>
-              <a:srgbClr val="BAC8DC"/>
-            </a:solidFill>
-          </a:ln>
-        </p:spPr>
-        <p:style>
-          <a:lnRef idx="1">
-            <a:schemeClr val="accent1"/>
-          </a:lnRef>
-          <a:fillRef idx="3">
-            <a:schemeClr val="accent1"/>
-          </a:fillRef>
-          <a:effectRef idx="2">
-            <a:schemeClr val="accent1"/>
-          </a:effectRef>
-          <a:fontRef idx="minor">
-            <a:schemeClr val="lt1"/>
-          </a:fontRef>
-        </p:style>
-        <p:txBody>
-          <a:bodyPr rtlCol="0" anchor="ctr"/>
-          <a:lstStyle/>
-          <a:p>
-            <a:pPr algn="ctr"/>
+              <a:t>Web 控制台</a:t>
+            </a:r>
           </a:p>
         </p:txBody>
       </p:sp>
       <p:pic>
         <p:nvPicPr>
-          <p:cNvPr id="12" name="Picture 11" descr="ppt_demo_qr.png"/>
+          <p:cNvPr id="14" name="Picture 13" descr="ppt_demo_qr.png"/>
           <p:cNvPicPr>
             <a:picLocks noChangeAspect="1"/>
           </p:cNvPicPr>
@@ -19076,8 +18895,8 @@
         </p:blipFill>
         <p:spPr>
           <a:xfrm>
-            <a:off x="5943600" y="3063240"/>
-            <a:ext cx="1143000" cy="1143000"/>
+            <a:off x="5783579" y="3246120"/>
+            <a:ext cx="960120" cy="960120"/>
           </a:xfrm>
           <a:prstGeom prst="rect">
             <a:avLst/>
@@ -19086,14 +18905,14 @@
       </p:pic>
       <p:sp>
         <p:nvSpPr>
-          <p:cNvPr id="13" name="TextBox 12"/>
+          <p:cNvPr id="15" name="TextBox 14"/>
           <p:cNvSpPr txBox="1"/>
           <p:nvPr/>
         </p:nvSpPr>
         <p:spPr>
           <a:xfrm>
-            <a:off x="5806440" y="4261104"/>
-            <a:ext cx="1417320" cy="219456"/>
+            <a:off x="5646419" y="4261104"/>
+            <a:ext cx="1234440" cy="219456"/>
           </a:xfrm>
           <a:prstGeom prst="rect">
             <a:avLst/>
@@ -19113,7 +18932,7 @@
                   <a:srgbClr val="5A6273"/>
                 </a:solidFill>
                 <a:latin typeface="微软雅黑"/>
-                <ns6:rFonts xmlns:ns6="http://schemas.openxmlformats.org/wordprocessingml/2006/main" ns6:eastAsia="微软雅黑" ns6:ascii="微软雅黑" ns6:hAnsi="微软雅黑"/>
+                <ns8:rFonts xmlns:ns8="http://schemas.openxmlformats.org/wordprocessingml/2006/main" ns8:eastAsia="微软雅黑" ns8:ascii="微软雅黑" ns8:hAnsi="微软雅黑"/>
               </a:rPr>
               <a:t>GitHub</a:t>
             </a:r>

</xml_diff>

<commit_message>
fix: dedupe PPT slides, fix cover overlap, enrich visuals per page
Distinct layouts for cover, team info, and section dividers; dual figures on project slide; clearer eval chart and fall tree labels; pose+risk duo screenshot.

Co-authored-by: Cursor <cursoragent@cursor.com>
</commit_message>
<xml_diff>
--- a/docs/答辩_CareCompanion.pptx
+++ b/docs/答辩_CareCompanion.pptx
@@ -3437,8 +3437,8 @@
         </p:nvSpPr>
         <p:spPr>
           <a:xfrm>
-            <a:off x="4800600" y="832104"/>
-            <a:ext cx="4114800" cy="457200"/>
+            <a:off x="4773168" y="804672"/>
+            <a:ext cx="4160520" cy="420624"/>
           </a:xfrm>
           <a:prstGeom prst="rect">
             <a:avLst/>
@@ -3446,13 +3446,13 @@
           <a:noFill/>
         </p:spPr>
         <p:txBody>
-          <a:bodyPr wrap="none">
+          <a:bodyPr wrap="square">
             <a:spAutoFit/>
           </a:bodyPr>
           <a:lstStyle/>
           <a:p>
             <a:r>
-              <a:rPr sz="3200" b="1">
+              <a:rPr sz="2800" b="1">
                 <a:solidFill>
                   <a:srgbClr val="FFFFFF"/>
                 </a:solidFill>
@@ -3472,8 +3472,8 @@
         </p:nvSpPr>
         <p:spPr>
           <a:xfrm>
-            <a:off x="4800600" y="1271016"/>
-            <a:ext cx="4114800" cy="457200"/>
+            <a:off x="4773168" y="1261872"/>
+            <a:ext cx="4160520" cy="420624"/>
           </a:xfrm>
           <a:prstGeom prst="rect">
             <a:avLst/>
@@ -3481,13 +3481,13 @@
           <a:noFill/>
         </p:spPr>
         <p:txBody>
-          <a:bodyPr wrap="none">
+          <a:bodyPr wrap="square">
             <a:spAutoFit/>
           </a:bodyPr>
           <a:lstStyle/>
           <a:p>
             <a:r>
-              <a:rPr sz="1500" b="1">
+              <a:rPr sz="1400" b="1">
                 <a:solidFill>
                   <a:srgbClr val="93C5FD"/>
                 </a:solidFill>
@@ -3507,8 +3507,8 @@
         </p:nvSpPr>
         <p:spPr>
           <a:xfrm>
-            <a:off x="4800600" y="1618488"/>
-            <a:ext cx="4114800" cy="457200"/>
+            <a:off x="4773168" y="1591055"/>
+            <a:ext cx="4160520" cy="420624"/>
           </a:xfrm>
           <a:prstGeom prst="rect">
             <a:avLst/>
@@ -3516,13 +3516,13 @@
           <a:noFill/>
         </p:spPr>
         <p:txBody>
-          <a:bodyPr wrap="none">
+          <a:bodyPr wrap="square">
             <a:spAutoFit/>
           </a:bodyPr>
           <a:lstStyle/>
           <a:p>
             <a:r>
-              <a:rPr sz="1300" b="0">
+              <a:rPr sz="1200" b="0">
                 <a:solidFill>
                   <a:srgbClr val="E2E8F0"/>
                 </a:solidFill>
@@ -3542,8 +3542,8 @@
         </p:nvSpPr>
         <p:spPr>
           <a:xfrm>
-            <a:off x="4800600" y="2148840"/>
-            <a:ext cx="3977639" cy="1325880"/>
+            <a:off x="4773168" y="2176272"/>
+            <a:ext cx="4023360" cy="1389888"/>
           </a:xfrm>
           <a:prstGeom prst="rect">
             <a:avLst/>
@@ -3587,8 +3587,8 @@
         </p:nvSpPr>
         <p:spPr>
           <a:xfrm>
-            <a:off x="4937760" y="2286000"/>
-            <a:ext cx="3657600" cy="1097280"/>
+            <a:off x="4901184" y="2286000"/>
+            <a:ext cx="3749039" cy="1170432"/>
           </a:xfrm>
           <a:prstGeom prst="rect">
             <a:avLst/>
@@ -3596,14 +3596,14 @@
           <a:noFill/>
         </p:spPr>
         <p:txBody>
-          <a:bodyPr wrap="none">
+          <a:bodyPr wrap="square">
             <a:spAutoFit/>
           </a:bodyPr>
           <a:lstStyle/>
           <a:p>
             <a:pPr>
               <a:spcAft>
-                <a:spcPts val="500"/>
+                <a:spcPts val="400"/>
               </a:spcAft>
             </a:pPr>
             <a:r>
@@ -3620,7 +3620,7 @@
           <a:p>
             <a:pPr>
               <a:spcAft>
-                <a:spcPts val="500"/>
+                <a:spcPts val="400"/>
               </a:spcAft>
             </a:pPr>
             <a:r>
@@ -3637,7 +3637,7 @@
           <a:p>
             <a:pPr>
               <a:spcAft>
-                <a:spcPts val="500"/>
+                <a:spcPts val="400"/>
               </a:spcAft>
             </a:pPr>
             <a:r>
@@ -3654,7 +3654,7 @@
           <a:p>
             <a:pPr>
               <a:spcAft>
-                <a:spcPts val="500"/>
+                <a:spcPts val="400"/>
               </a:spcAft>
             </a:pPr>
             <a:r>
@@ -3678,8 +3678,8 @@
         </p:nvSpPr>
         <p:spPr>
           <a:xfrm>
-            <a:off x="4800600" y="4686300"/>
-            <a:ext cx="4023360" cy="320040"/>
+            <a:off x="4773168" y="3621024"/>
+            <a:ext cx="4023360" cy="292608"/>
           </a:xfrm>
           <a:prstGeom prst="rect">
             <a:avLst/>
@@ -3692,15 +3692,16 @@
           </a:bodyPr>
           <a:lstStyle/>
           <a:p>
-            <a:r>
-              <a:rPr sz="900" b="0">
+            <a:pPr algn="ctr"/>
+            <a:r>
+              <a:rPr sz="800" b="0">
                 <a:solidFill>
                   <a:srgbClr val="94A3B8"/>
                 </a:solidFill>
                 <a:latin typeface="微软雅黑"/>
                 <ns9:rFonts xmlns:ns9="http://schemas.openxmlformats.org/wordprocessingml/2006/main" ns9:eastAsia="微软雅黑" ns9:ascii="微软雅黑" ns9:hAnsi="微软雅黑"/>
               </a:rPr>
-              <a:t>基于大语言模型的智能养老陪伴机器人仿真平台</a:t>
+              <a:t>基于大语言模型的居家养老陪伴仿真平台</a:t>
             </a:r>
           </a:p>
         </p:txBody>
@@ -9786,8 +9787,8 @@
         </p:nvSpPr>
         <p:spPr>
           <a:xfrm>
-            <a:off x="274320" y="1014984"/>
-            <a:ext cx="8595360" cy="3817620"/>
+            <a:off x="274320" y="1033272"/>
+            <a:ext cx="4233672" cy="3781044"/>
           </a:xfrm>
           <a:prstGeom prst="rect">
             <a:avLst/>
@@ -9839,8 +9840,8 @@
         </p:blipFill>
         <p:spPr>
           <a:xfrm>
-            <a:off x="3283278" y="1068339"/>
-            <a:ext cx="2577442" cy="3436589"/>
+            <a:off x="1180821" y="1191143"/>
+            <a:ext cx="2420668" cy="3227557"/>
           </a:xfrm>
           <a:prstGeom prst="rect">
             <a:avLst/>
@@ -9855,8 +9856,8 @@
         </p:nvSpPr>
         <p:spPr>
           <a:xfrm>
-            <a:off x="310896" y="4594860"/>
-            <a:ext cx="8522208" cy="219456"/>
+            <a:off x="347472" y="4576572"/>
+            <a:ext cx="4087368" cy="219456"/>
           </a:xfrm>
           <a:prstGeom prst="rect">
             <a:avLst/>
@@ -9878,7 +9879,112 @@
                 <a:latin typeface="微软雅黑"/>
                 <ns3:rFonts xmlns:ns3="http://schemas.openxmlformats.org/wordprocessingml/2006/main" ns3:eastAsia="微软雅黑" ns3:ascii="微软雅黑" ns3:hAnsi="微软雅黑"/>
               </a:rPr>
-              <a:t>全身照 → 骨架叠加</a:t>
+              <a:t>MediaPipe 骨架叠加</a:t>
+            </a:r>
+          </a:p>
+        </p:txBody>
+      </p:sp>
+      <p:sp>
+        <p:nvSpPr>
+          <p:cNvPr id="11" name="Rectangle 10"/>
+          <p:cNvSpPr/>
+          <p:nvPr/>
+        </p:nvSpPr>
+        <p:spPr>
+          <a:xfrm>
+            <a:off x="4636007" y="1033272"/>
+            <a:ext cx="4233672" cy="3781044"/>
+          </a:xfrm>
+          <a:prstGeom prst="rect">
+            <a:avLst/>
+          </a:prstGeom>
+          <a:solidFill>
+            <a:srgbClr val="FFFFFF"/>
+          </a:solidFill>
+          <a:ln w="9525">
+            <a:solidFill>
+              <a:srgbClr val="BAC8DC"/>
+            </a:solidFill>
+          </a:ln>
+        </p:spPr>
+        <p:style>
+          <a:lnRef idx="1">
+            <a:schemeClr val="accent1"/>
+          </a:lnRef>
+          <a:fillRef idx="3">
+            <a:schemeClr val="accent1"/>
+          </a:fillRef>
+          <a:effectRef idx="2">
+            <a:schemeClr val="accent1"/>
+          </a:effectRef>
+          <a:fontRef idx="minor">
+            <a:schemeClr val="lt1"/>
+          </a:fontRef>
+        </p:style>
+        <p:txBody>
+          <a:bodyPr rtlCol="0" anchor="ctr"/>
+          <a:lstStyle/>
+          <a:p>
+            <a:pPr algn="ctr"/>
+          </a:p>
+        </p:txBody>
+      </p:sp>
+      <p:pic>
+        <p:nvPicPr>
+          <p:cNvPr id="12" name="Picture 11" descr="ppt_risk_panel.png"/>
+          <p:cNvPicPr>
+            <a:picLocks noChangeAspect="1"/>
+          </p:cNvPicPr>
+          <p:nvPr/>
+        </p:nvPicPr>
+        <p:blipFill>
+          <a:blip r:embed="rId3"/>
+          <a:stretch>
+            <a:fillRect/>
+          </a:stretch>
+        </p:blipFill>
+        <p:spPr>
+          <a:xfrm>
+            <a:off x="5397521" y="1191143"/>
+            <a:ext cx="2710644" cy="3227557"/>
+          </a:xfrm>
+          <a:prstGeom prst="rect">
+            <a:avLst/>
+          </a:prstGeom>
+        </p:spPr>
+      </p:pic>
+      <p:sp>
+        <p:nvSpPr>
+          <p:cNvPr id="13" name="TextBox 12"/>
+          <p:cNvSpPr txBox="1"/>
+          <p:nvPr/>
+        </p:nvSpPr>
+        <p:spPr>
+          <a:xfrm>
+            <a:off x="4709159" y="4576572"/>
+            <a:ext cx="4087368" cy="219456"/>
+          </a:xfrm>
+          <a:prstGeom prst="rect">
+            <a:avLst/>
+          </a:prstGeom>
+          <a:noFill/>
+        </p:spPr>
+        <p:txBody>
+          <a:bodyPr wrap="square" anchor="ctr">
+            <a:spAutoFit/>
+          </a:bodyPr>
+          <a:lstStyle/>
+          <a:p>
+            <a:pPr algn="ctr"/>
+            <a:r>
+              <a:rPr sz="800" b="0">
+                <a:solidFill>
+                  <a:srgbClr val="5A6273"/>
+                </a:solidFill>
+                <a:latin typeface="微软雅黑"/>
+                <ns4:rFonts xmlns:ns4="http://schemas.openxmlformats.org/wordprocessingml/2006/main" ns4:eastAsia="微软雅黑" ns4:ascii="微软雅黑" ns4:hAnsi="微软雅黑"/>
+              </a:rPr>
+              <a:t>风险面板联动</a:t>
             </a:r>
           </a:p>
         </p:txBody>
@@ -12606,8 +12712,8 @@
         </p:nvSpPr>
         <p:spPr>
           <a:xfrm>
-            <a:off x="4308652" y="1308003"/>
-            <a:ext cx="4321454" cy="2902397"/>
+            <a:off x="4308652" y="1188926"/>
+            <a:ext cx="4321454" cy="3140550"/>
           </a:xfrm>
           <a:prstGeom prst="rect">
             <a:avLst/>
@@ -12659,8 +12765,8 @@
         </p:blipFill>
         <p:spPr>
           <a:xfrm>
-            <a:off x="4345228" y="1344579"/>
-            <a:ext cx="4248302" cy="2829245"/>
+            <a:off x="4345228" y="1225502"/>
+            <a:ext cx="4248302" cy="3067398"/>
           </a:xfrm>
           <a:prstGeom prst="rect">
             <a:avLst/>
@@ -12698,7 +12804,7 @@
                 <a:latin typeface="微软雅黑"/>
                 <ns8:rFonts xmlns:ns8="http://schemas.openxmlformats.org/wordprocessingml/2006/main" ns8:eastAsia="微软雅黑" ns8:ascii="微软雅黑" ns8:hAnsi="微软雅黑"/>
               </a:rPr>
-              <a:t>评测结果（6 场景）</a:t>
+              <a:t>P/R/F1 均为 100%（见左栏）</a:t>
             </a:r>
           </a:p>
         </p:txBody>
@@ -14835,8 +14941,8 @@
         </p:nvSpPr>
         <p:spPr>
           <a:xfrm>
-            <a:off x="4694986" y="1411241"/>
-            <a:ext cx="4097426" cy="2988529"/>
+            <a:off x="4694986" y="2415020"/>
+            <a:ext cx="4097426" cy="980971"/>
           </a:xfrm>
           <a:prstGeom prst="rect">
             <a:avLst/>
@@ -14874,7 +14980,7 @@
       </p:sp>
       <p:pic>
         <p:nvPicPr>
-          <p:cNvPr id="19" name="Picture 18" descr="roadmap_gantt.png"/>
+          <p:cNvPr id="19" name="Picture 18" descr="ppt_robot_commands.png"/>
           <p:cNvPicPr>
             <a:picLocks noChangeAspect="1"/>
           </p:cNvPicPr>
@@ -14888,8 +14994,8 @@
         </p:blipFill>
         <p:spPr>
           <a:xfrm>
-            <a:off x="4731562" y="1447817"/>
-            <a:ext cx="4024274" cy="2915377"/>
+            <a:off x="4731562" y="2451596"/>
+            <a:ext cx="4024274" cy="907819"/>
           </a:xfrm>
           <a:prstGeom prst="rect">
             <a:avLst/>
@@ -17739,16 +17845,16 @@
         </p:nvSpPr>
         <p:spPr>
           <a:xfrm>
-            <a:off x="274320" y="996696"/>
-            <a:ext cx="3611880" cy="3854196"/>
+            <a:off x="274320" y="1088136"/>
+            <a:ext cx="3611880" cy="493776"/>
           </a:xfrm>
           <a:prstGeom prst="rect">
             <a:avLst/>
           </a:prstGeom>
           <a:solidFill>
-            <a:srgbClr val="F1F7FF"/>
+            <a:srgbClr val="FFFFFF"/>
           </a:solidFill>
-          <a:ln w="10160">
+          <a:ln>
             <a:solidFill>
               <a:srgbClr val="BAC8DC"/>
             </a:solidFill>
@@ -17778,16 +17884,175 @@
       </p:sp>
       <p:sp>
         <p:nvSpPr>
-          <p:cNvPr id="9" name="Rectangle 8"/>
+          <p:cNvPr id="9" name="Oval 8"/>
           <p:cNvSpPr/>
           <p:nvPr/>
         </p:nvSpPr>
         <p:spPr>
           <a:xfrm>
-            <a:off x="274320" y="996696"/>
-            <a:ext cx="73152" cy="3854196"/>
-          </a:xfrm>
-          <a:prstGeom prst="rect">
+            <a:off x="384048" y="1197864"/>
+            <a:ext cx="256032" cy="256032"/>
+          </a:xfrm>
+          <a:prstGeom prst="ellipse">
+            <a:avLst/>
+          </a:prstGeom>
+          <a:solidFill>
+            <a:srgbClr val="F59E0B"/>
+          </a:solidFill>
+          <a:ln>
+            <a:noFill/>
+          </a:ln>
+        </p:spPr>
+        <p:style>
+          <a:lnRef idx="1">
+            <a:schemeClr val="accent1"/>
+          </a:lnRef>
+          <a:fillRef idx="3">
+            <a:schemeClr val="accent1"/>
+          </a:fillRef>
+          <a:effectRef idx="2">
+            <a:schemeClr val="accent1"/>
+          </a:effectRef>
+          <a:fontRef idx="minor">
+            <a:schemeClr val="lt1"/>
+          </a:fontRef>
+        </p:style>
+        <p:txBody>
+          <a:bodyPr rtlCol="0" anchor="ctr"/>
+          <a:lstStyle/>
+          <a:p>
+            <a:pPr algn="ctr"/>
+          </a:p>
+        </p:txBody>
+      </p:sp>
+      <p:sp>
+        <p:nvSpPr>
+          <p:cNvPr id="10" name="TextBox 9"/>
+          <p:cNvSpPr txBox="1"/>
+          <p:nvPr/>
+        </p:nvSpPr>
+        <p:spPr>
+          <a:xfrm>
+            <a:off x="384048" y="1225296"/>
+            <a:ext cx="256032" cy="201168"/>
+          </a:xfrm>
+          <a:prstGeom prst="rect">
+            <a:avLst/>
+          </a:prstGeom>
+          <a:noFill/>
+        </p:spPr>
+        <p:txBody>
+          <a:bodyPr wrap="none">
+            <a:spAutoFit/>
+          </a:bodyPr>
+          <a:lstStyle/>
+          <a:p>
+            <a:pPr algn="ctr"/>
+            <a:r>
+              <a:rPr sz="900" b="1">
+                <a:solidFill>
+                  <a:srgbClr val="FFFFFF"/>
+                </a:solidFill>
+                <a:latin typeface="微软雅黑"/>
+                <ns3:rFonts xmlns:ns3="http://schemas.openxmlformats.org/wordprocessingml/2006/main" ns3:eastAsia="微软雅黑" ns3:ascii="微软雅黑" ns3:hAnsi="微软雅黑"/>
+              </a:rPr>
+              <a:t>1</a:t>
+            </a:r>
+          </a:p>
+        </p:txBody>
+      </p:sp>
+      <p:sp>
+        <p:nvSpPr>
+          <p:cNvPr id="11" name="TextBox 10"/>
+          <p:cNvSpPr txBox="1"/>
+          <p:nvPr/>
+        </p:nvSpPr>
+        <p:spPr>
+          <a:xfrm>
+            <a:off x="713232" y="1216152"/>
+            <a:ext cx="3081528" cy="310896"/>
+          </a:xfrm>
+          <a:prstGeom prst="rect">
+            <a:avLst/>
+          </a:prstGeom>
+          <a:noFill/>
+        </p:spPr>
+        <p:txBody>
+          <a:bodyPr wrap="none">
+            <a:spAutoFit/>
+          </a:bodyPr>
+          <a:lstStyle/>
+          <a:p>
+            <a:r>
+              <a:rPr sz="1100" b="0">
+                <a:solidFill>
+                  <a:srgbClr val="143278"/>
+                </a:solidFill>
+                <a:latin typeface="微软雅黑"/>
+                <ns4:rFonts xmlns:ns4="http://schemas.openxmlformats.org/wordprocessingml/2006/main" ns4:eastAsia="微软雅黑" ns4:ascii="微软雅黑" ns4:hAnsi="微软雅黑"/>
+              </a:rPr>
+              <a:t>赛项：创新赛 · 机器人创新赛道</a:t>
+            </a:r>
+          </a:p>
+        </p:txBody>
+      </p:sp>
+      <p:sp>
+        <p:nvSpPr>
+          <p:cNvPr id="12" name="Rectangle 11"/>
+          <p:cNvSpPr/>
+          <p:nvPr/>
+        </p:nvSpPr>
+        <p:spPr>
+          <a:xfrm>
+            <a:off x="274320" y="1636776"/>
+            <a:ext cx="3611880" cy="493776"/>
+          </a:xfrm>
+          <a:prstGeom prst="rect">
+            <a:avLst/>
+          </a:prstGeom>
+          <a:solidFill>
+            <a:srgbClr val="FFFFFF"/>
+          </a:solidFill>
+          <a:ln>
+            <a:solidFill>
+              <a:srgbClr val="BAC8DC"/>
+            </a:solidFill>
+          </a:ln>
+        </p:spPr>
+        <p:style>
+          <a:lnRef idx="1">
+            <a:schemeClr val="accent1"/>
+          </a:lnRef>
+          <a:fillRef idx="3">
+            <a:schemeClr val="accent1"/>
+          </a:fillRef>
+          <a:effectRef idx="2">
+            <a:schemeClr val="accent1"/>
+          </a:effectRef>
+          <a:fontRef idx="minor">
+            <a:schemeClr val="lt1"/>
+          </a:fontRef>
+        </p:style>
+        <p:txBody>
+          <a:bodyPr rtlCol="0" anchor="ctr"/>
+          <a:lstStyle/>
+          <a:p>
+            <a:pPr algn="ctr"/>
+          </a:p>
+        </p:txBody>
+      </p:sp>
+      <p:sp>
+        <p:nvSpPr>
+          <p:cNvPr id="13" name="Oval 12"/>
+          <p:cNvSpPr/>
+          <p:nvPr/>
+        </p:nvSpPr>
+        <p:spPr>
+          <a:xfrm>
+            <a:off x="384048" y="1746504"/>
+            <a:ext cx="256032" cy="256032"/>
+          </a:xfrm>
+          <a:prstGeom prst="ellipse">
             <a:avLst/>
           </a:prstGeom>
           <a:solidFill>
@@ -17821,14 +18086,14 @@
       </p:sp>
       <p:sp>
         <p:nvSpPr>
-          <p:cNvPr id="10" name="TextBox 9"/>
+          <p:cNvPr id="14" name="TextBox 13"/>
           <p:cNvSpPr txBox="1"/>
           <p:nvPr/>
         </p:nvSpPr>
         <p:spPr>
           <a:xfrm>
-            <a:off x="438912" y="1106424"/>
-            <a:ext cx="3282696" cy="890397"/>
+            <a:off x="384048" y="1773936"/>
+            <a:ext cx="256032" cy="201168"/>
           </a:xfrm>
           <a:prstGeom prst="rect">
             <a:avLst/>
@@ -17836,128 +18101,35 @@
           <a:noFill/>
         </p:spPr>
         <p:txBody>
-          <a:bodyPr wrap="square" anchor="t" lIns="25400" tIns="0">
+          <a:bodyPr wrap="none">
             <a:spAutoFit/>
           </a:bodyPr>
           <a:lstStyle/>
           <a:p>
-            <a:pPr>
-              <a:lnSpc>
-                <a:spcPct val="112000"/>
-              </a:lnSpc>
-              <a:spcAft>
-                <a:spcPts val="200"/>
-              </a:spcAft>
-            </a:pPr>
-            <a:r>
-              <a:rPr sz="1200" b="0">
-                <a:solidFill>
-                  <a:srgbClr val="1C202C"/>
-                </a:solidFill>
-                <a:latin typeface="微软雅黑"/>
-                <ns3:rFonts xmlns:ns3="http://schemas.openxmlformats.org/wordprocessingml/2006/main" ns3:eastAsia="微软雅黑" ns3:ascii="微软雅黑" ns3:hAnsi="微软雅黑"/>
-              </a:rPr>
-              <a:t>● 赛项：创新赛 · 机器人创新赛道</a:t>
-            </a:r>
-          </a:p>
-        </p:txBody>
-      </p:sp>
-      <p:sp>
-        <p:nvSpPr>
-          <p:cNvPr id="11" name="TextBox 10"/>
-          <p:cNvSpPr txBox="1"/>
-          <p:nvPr/>
-        </p:nvSpPr>
-        <p:spPr>
-          <a:xfrm>
-            <a:off x="438912" y="2015109"/>
-            <a:ext cx="3282696" cy="890397"/>
-          </a:xfrm>
-          <a:prstGeom prst="rect">
-            <a:avLst/>
-          </a:prstGeom>
-          <a:noFill/>
-        </p:spPr>
-        <p:txBody>
-          <a:bodyPr wrap="square" anchor="t" lIns="25400" tIns="0">
-            <a:spAutoFit/>
-          </a:bodyPr>
-          <a:lstStyle/>
-          <a:p>
-            <a:pPr>
-              <a:lnSpc>
-                <a:spcPct val="112000"/>
-              </a:lnSpc>
-              <a:spcAft>
-                <a:spcPts val="200"/>
-              </a:spcAft>
-            </a:pPr>
-            <a:r>
-              <a:rPr sz="1200" b="0">
-                <a:solidFill>
-                  <a:srgbClr val="1C202C"/>
-                </a:solidFill>
-                <a:latin typeface="微软雅黑"/>
-                <ns4:rFonts xmlns:ns4="http://schemas.openxmlformats.org/wordprocessingml/2006/main" ns4:eastAsia="微软雅黑" ns4:ascii="微软雅黑" ns4:hAnsi="微软雅黑"/>
-              </a:rPr>
-              <a:t>● 作品：智能养老陪伴机器人仿真平台</a:t>
-            </a:r>
-          </a:p>
-        </p:txBody>
-      </p:sp>
-      <p:sp>
-        <p:nvSpPr>
-          <p:cNvPr id="12" name="TextBox 11"/>
-          <p:cNvSpPr txBox="1"/>
-          <p:nvPr/>
-        </p:nvSpPr>
-        <p:spPr>
-          <a:xfrm>
-            <a:off x="438912" y="2923794"/>
-            <a:ext cx="3282696" cy="890397"/>
-          </a:xfrm>
-          <a:prstGeom prst="rect">
-            <a:avLst/>
-          </a:prstGeom>
-          <a:noFill/>
-        </p:spPr>
-        <p:txBody>
-          <a:bodyPr wrap="square" anchor="t" lIns="25400" tIns="0">
-            <a:spAutoFit/>
-          </a:bodyPr>
-          <a:lstStyle/>
-          <a:p>
-            <a:pPr>
-              <a:lnSpc>
-                <a:spcPct val="112000"/>
-              </a:lnSpc>
-              <a:spcAft>
-                <a:spcPts val="200"/>
-              </a:spcAft>
-            </a:pPr>
-            <a:r>
-              <a:rPr sz="1200" b="0">
-                <a:solidFill>
-                  <a:srgbClr val="1C202C"/>
+            <a:pPr algn="ctr"/>
+            <a:r>
+              <a:rPr sz="900" b="1">
+                <a:solidFill>
+                  <a:srgbClr val="FFFFFF"/>
                 </a:solidFill>
                 <a:latin typeface="微软雅黑"/>
                 <ns5:rFonts xmlns:ns5="http://schemas.openxmlformats.org/wordprocessingml/2006/main" ns5:eastAsia="微软雅黑" ns5:ascii="微软雅黑" ns5:hAnsi="微软雅黑"/>
               </a:rPr>
-              <a:t>● （基于大语言模型）</a:t>
-            </a:r>
-          </a:p>
-        </p:txBody>
-      </p:sp>
-      <p:sp>
-        <p:nvSpPr>
-          <p:cNvPr id="13" name="TextBox 12"/>
+              <a:t>2</a:t>
+            </a:r>
+          </a:p>
+        </p:txBody>
+      </p:sp>
+      <p:sp>
+        <p:nvSpPr>
+          <p:cNvPr id="15" name="TextBox 14"/>
           <p:cNvSpPr txBox="1"/>
           <p:nvPr/>
         </p:nvSpPr>
         <p:spPr>
           <a:xfrm>
-            <a:off x="438912" y="3832479"/>
-            <a:ext cx="3282696" cy="890397"/>
+            <a:off x="713232" y="1764792"/>
+            <a:ext cx="3081528" cy="310896"/>
           </a:xfrm>
           <a:prstGeom prst="rect">
             <a:avLst/>
@@ -17965,43 +18137,299 @@
           <a:noFill/>
         </p:spPr>
         <p:txBody>
-          <a:bodyPr wrap="square" anchor="t" lIns="25400" tIns="0">
+          <a:bodyPr wrap="none">
             <a:spAutoFit/>
           </a:bodyPr>
           <a:lstStyle/>
           <a:p>
-            <a:pPr>
-              <a:lnSpc>
-                <a:spcPct val="112000"/>
-              </a:lnSpc>
-              <a:spcAft>
-                <a:spcPts val="200"/>
-              </a:spcAft>
-            </a:pPr>
-            <a:r>
-              <a:rPr sz="1200" b="0">
-                <a:solidFill>
-                  <a:srgbClr val="1C202C"/>
+            <a:r>
+              <a:rPr sz="1100" b="0">
+                <a:solidFill>
+                  <a:srgbClr val="143278"/>
                 </a:solidFill>
                 <a:latin typeface="微软雅黑"/>
                 <ns6:rFonts xmlns:ns6="http://schemas.openxmlformats.org/wordprocessingml/2006/main" ns6:eastAsia="微软雅黑" ns6:ascii="微软雅黑" ns6:hAnsi="微软雅黑"/>
               </a:rPr>
-              <a:t>● 特色：理论清晰 · 系统可演示 · 指标可复现</a:t>
+              <a:t>作品：智能养老陪伴机器人仿真平台</a:t>
+            </a:r>
+          </a:p>
+        </p:txBody>
+      </p:sp>
+      <p:sp>
+        <p:nvSpPr>
+          <p:cNvPr id="16" name="Rectangle 15"/>
+          <p:cNvSpPr/>
+          <p:nvPr/>
+        </p:nvSpPr>
+        <p:spPr>
+          <a:xfrm>
+            <a:off x="274320" y="2185416"/>
+            <a:ext cx="3611880" cy="493776"/>
+          </a:xfrm>
+          <a:prstGeom prst="rect">
+            <a:avLst/>
+          </a:prstGeom>
+          <a:solidFill>
+            <a:srgbClr val="FFFFFF"/>
+          </a:solidFill>
+          <a:ln>
+            <a:solidFill>
+              <a:srgbClr val="BAC8DC"/>
+            </a:solidFill>
+          </a:ln>
+        </p:spPr>
+        <p:style>
+          <a:lnRef idx="1">
+            <a:schemeClr val="accent1"/>
+          </a:lnRef>
+          <a:fillRef idx="3">
+            <a:schemeClr val="accent1"/>
+          </a:fillRef>
+          <a:effectRef idx="2">
+            <a:schemeClr val="accent1"/>
+          </a:effectRef>
+          <a:fontRef idx="minor">
+            <a:schemeClr val="lt1"/>
+          </a:fontRef>
+        </p:style>
+        <p:txBody>
+          <a:bodyPr rtlCol="0" anchor="ctr"/>
+          <a:lstStyle/>
+          <a:p>
+            <a:pPr algn="ctr"/>
+          </a:p>
+        </p:txBody>
+      </p:sp>
+      <p:sp>
+        <p:nvSpPr>
+          <p:cNvPr id="17" name="Oval 16"/>
+          <p:cNvSpPr/>
+          <p:nvPr/>
+        </p:nvSpPr>
+        <p:spPr>
+          <a:xfrm>
+            <a:off x="384048" y="2295144"/>
+            <a:ext cx="256032" cy="256032"/>
+          </a:xfrm>
+          <a:prstGeom prst="ellipse">
+            <a:avLst/>
+          </a:prstGeom>
+          <a:solidFill>
+            <a:srgbClr val="143278"/>
+          </a:solidFill>
+          <a:ln>
+            <a:noFill/>
+          </a:ln>
+        </p:spPr>
+        <p:style>
+          <a:lnRef idx="1">
+            <a:schemeClr val="accent1"/>
+          </a:lnRef>
+          <a:fillRef idx="3">
+            <a:schemeClr val="accent1"/>
+          </a:fillRef>
+          <a:effectRef idx="2">
+            <a:schemeClr val="accent1"/>
+          </a:effectRef>
+          <a:fontRef idx="minor">
+            <a:schemeClr val="lt1"/>
+          </a:fontRef>
+        </p:style>
+        <p:txBody>
+          <a:bodyPr rtlCol="0" anchor="ctr"/>
+          <a:lstStyle/>
+          <a:p>
+            <a:pPr algn="ctr"/>
+          </a:p>
+        </p:txBody>
+      </p:sp>
+      <p:sp>
+        <p:nvSpPr>
+          <p:cNvPr id="18" name="TextBox 17"/>
+          <p:cNvSpPr txBox="1"/>
+          <p:nvPr/>
+        </p:nvSpPr>
+        <p:spPr>
+          <a:xfrm>
+            <a:off x="384048" y="2322576"/>
+            <a:ext cx="256032" cy="201168"/>
+          </a:xfrm>
+          <a:prstGeom prst="rect">
+            <a:avLst/>
+          </a:prstGeom>
+          <a:noFill/>
+        </p:spPr>
+        <p:txBody>
+          <a:bodyPr wrap="none">
+            <a:spAutoFit/>
+          </a:bodyPr>
+          <a:lstStyle/>
+          <a:p>
+            <a:pPr algn="ctr"/>
+            <a:r>
+              <a:rPr sz="900" b="1">
+                <a:solidFill>
+                  <a:srgbClr val="FFFFFF"/>
+                </a:solidFill>
+                <a:latin typeface="微软雅黑"/>
+                <ns7:rFonts xmlns:ns7="http://schemas.openxmlformats.org/wordprocessingml/2006/main" ns7:eastAsia="微软雅黑" ns7:ascii="微软雅黑" ns7:hAnsi="微软雅黑"/>
+              </a:rPr>
+              <a:t>3</a:t>
+            </a:r>
+          </a:p>
+        </p:txBody>
+      </p:sp>
+      <p:sp>
+        <p:nvSpPr>
+          <p:cNvPr id="19" name="TextBox 18"/>
+          <p:cNvSpPr txBox="1"/>
+          <p:nvPr/>
+        </p:nvSpPr>
+        <p:spPr>
+          <a:xfrm>
+            <a:off x="713232" y="2313432"/>
+            <a:ext cx="3081528" cy="310896"/>
+          </a:xfrm>
+          <a:prstGeom prst="rect">
+            <a:avLst/>
+          </a:prstGeom>
+          <a:noFill/>
+        </p:spPr>
+        <p:txBody>
+          <a:bodyPr wrap="none">
+            <a:spAutoFit/>
+          </a:bodyPr>
+          <a:lstStyle/>
+          <a:p>
+            <a:r>
+              <a:rPr sz="1100" b="0">
+                <a:solidFill>
+                  <a:srgbClr val="143278"/>
+                </a:solidFill>
+                <a:latin typeface="微软雅黑"/>
+                <ns8:rFonts xmlns:ns8="http://schemas.openxmlformats.org/wordprocessingml/2006/main" ns8:eastAsia="微软雅黑" ns8:ascii="微软雅黑" ns8:hAnsi="微软雅黑"/>
+              </a:rPr>
+              <a:t>特色：理论清晰 · 系统可演示 · 指标可复现</a:t>
+            </a:r>
+          </a:p>
+        </p:txBody>
+      </p:sp>
+      <p:sp>
+        <p:nvSpPr>
+          <p:cNvPr id="20" name="Rectangle 19"/>
+          <p:cNvSpPr/>
+          <p:nvPr/>
+        </p:nvSpPr>
+        <p:spPr>
+          <a:xfrm>
+            <a:off x="4069080" y="996696"/>
+            <a:ext cx="4800600" cy="3854196"/>
+          </a:xfrm>
+          <a:prstGeom prst="rect">
+            <a:avLst/>
+          </a:prstGeom>
+          <a:solidFill>
+            <a:srgbClr val="FFFFFF"/>
+          </a:solidFill>
+          <a:ln>
+            <a:solidFill>
+              <a:srgbClr val="BAC8DC"/>
+            </a:solidFill>
+          </a:ln>
+        </p:spPr>
+        <p:style>
+          <a:lnRef idx="1">
+            <a:schemeClr val="accent1"/>
+          </a:lnRef>
+          <a:fillRef idx="3">
+            <a:schemeClr val="accent1"/>
+          </a:fillRef>
+          <a:effectRef idx="2">
+            <a:schemeClr val="accent1"/>
+          </a:effectRef>
+          <a:fontRef idx="minor">
+            <a:schemeClr val="lt1"/>
+          </a:fontRef>
+        </p:style>
+        <p:txBody>
+          <a:bodyPr rtlCol="0" anchor="ctr"/>
+          <a:lstStyle/>
+          <a:p>
+            <a:pPr algn="ctr"/>
+          </a:p>
+        </p:txBody>
+      </p:sp>
+      <p:pic>
+        <p:nvPicPr>
+          <p:cNvPr id="21" name="Picture 20" descr="ppt_full_dashboard.png"/>
+          <p:cNvPicPr>
+            <a:picLocks noChangeAspect="1"/>
+          </p:cNvPicPr>
+          <p:nvPr/>
+        </p:nvPicPr>
+        <p:blipFill>
+          <a:blip r:embed="rId2"/>
+          <a:stretch>
+            <a:fillRect/>
+          </a:stretch>
+        </p:blipFill>
+        <p:spPr>
+          <a:xfrm>
+            <a:off x="5417306" y="1092708"/>
+            <a:ext cx="2104147" cy="1097280"/>
+          </a:xfrm>
+          <a:prstGeom prst="rect">
+            <a:avLst/>
+          </a:prstGeom>
+        </p:spPr>
+      </p:pic>
+      <p:sp>
+        <p:nvSpPr>
+          <p:cNvPr id="22" name="TextBox 21"/>
+          <p:cNvSpPr txBox="1"/>
+          <p:nvPr/>
+        </p:nvSpPr>
+        <p:spPr>
+          <a:xfrm>
+            <a:off x="4160520" y="2267712"/>
+            <a:ext cx="4617720" cy="219456"/>
+          </a:xfrm>
+          <a:prstGeom prst="rect">
+            <a:avLst/>
+          </a:prstGeom>
+          <a:noFill/>
+        </p:spPr>
+        <p:txBody>
+          <a:bodyPr wrap="square" anchor="ctr">
+            <a:spAutoFit/>
+          </a:bodyPr>
+          <a:lstStyle/>
+          <a:p>
+            <a:pPr algn="ctr"/>
+            <a:r>
+              <a:rPr sz="800" b="0">
+                <a:solidFill>
+                  <a:srgbClr val="5A6273"/>
+                </a:solidFill>
+                <a:latin typeface="微软雅黑"/>
+                <ns9:rFonts xmlns:ns9="http://schemas.openxmlformats.org/wordprocessingml/2006/main" ns9:eastAsia="微软雅黑" ns9:ascii="微软雅黑" ns9:hAnsi="微软雅黑"/>
+              </a:rPr>
+              <a:t>Web 控制台预览</a:t>
             </a:r>
           </a:p>
         </p:txBody>
       </p:sp>
       <p:graphicFrame>
         <p:nvGraphicFramePr>
-          <p:cNvPr id="14" name="Table 13"/>
+          <p:cNvPr id="23" name="Table 22"/>
           <p:cNvGraphicFramePr>
             <a:graphicFrameLocks noGrp="1"/>
           </p:cNvGraphicFramePr>
           <p:nvPr/>
         </p:nvGraphicFramePr>
         <p:xfrm>
-          <a:off x="4069080" y="996696"/>
-          <a:ext cx="4800600" cy="3854196"/>
+          <a:off x="4142232" y="2569464"/>
+          <a:ext cx="4654296" cy="2208276"/>
         </p:xfrm>
         <a:graphic>
           <a:graphicData uri="http://schemas.openxmlformats.org/drawingml/2006/table">
@@ -18010,10 +18438,10 @@
                 <a:tableStyleId>{5C22544A-7EE6-4342-B048-85BDC9FD1C3A}</a:tableStyleId>
               </a:tblPr>
               <a:tblGrid>
-                <a:gridCol w="841248"/>
-                <a:gridCol w="3959352"/>
+                <a:gridCol w="804672"/>
+                <a:gridCol w="3849624"/>
               </a:tblGrid>
-              <a:tr h="550599">
+              <a:tr h="368046">
                 <a:tc>
                   <a:txBody>
                     <a:bodyPr anchor="ctr"/>
@@ -18021,12 +18449,12 @@
                     <a:p>
                       <a:pPr algn="ctr"/>
                       <a:r>
-                        <a:rPr sz="1000" b="1">
+                        <a:rPr sz="900" b="1">
                           <a:solidFill>
                             <a:srgbClr val="FFFFFF"/>
                           </a:solidFill>
                           <a:latin typeface="微软雅黑"/>
-                          <ns7:rFonts xmlns:ns7="http://schemas.openxmlformats.org/wordprocessingml/2006/main" ns7:eastAsia="微软雅黑" ns7:ascii="微软雅黑" ns7:hAnsi="微软雅黑"/>
+                          <ns10:rFonts xmlns:ns10="http://schemas.openxmlformats.org/wordprocessingml/2006/main" ns10:eastAsia="微软雅黑" ns10:ascii="微软雅黑" ns10:hAnsi="微软雅黑"/>
                         </a:rPr>
                         <a:t>团队</a:t>
                       </a:r>
@@ -18045,25 +18473,25 @@
                     <a:p>
                       <a:pPr algn="l"/>
                       <a:r>
-                        <a:rPr sz="1000" b="0">
+                        <a:rPr sz="900" b="0">
                           <a:solidFill>
                             <a:srgbClr val="143278"/>
                           </a:solidFill>
                           <a:latin typeface="微软雅黑"/>
-                          <ns8:rFonts xmlns:ns8="http://schemas.openxmlformats.org/wordprocessingml/2006/main" ns8:eastAsia="微软雅黑" ns8:ascii="微软雅黑" ns8:hAnsi="微软雅黑"/>
+                          <ns11:rFonts xmlns:ns11="http://schemas.openxmlformats.org/wordprocessingml/2006/main" ns11:eastAsia="微软雅黑" ns11:ascii="微软雅黑" ns11:hAnsi="微软雅黑"/>
                         </a:rPr>
                         <a:t>从容应队</a:t>
                       </a:r>
                     </a:p>
                   </a:txBody>
-                  <a:tcPr marL="76200" marR="50800">
+                  <a:tcPr>
                     <a:solidFill>
                       <a:srgbClr val="F1F7FF"/>
                     </a:solidFill>
                   </a:tcPr>
                 </a:tc>
               </a:tr>
-              <a:tr h="550599">
+              <a:tr h="368046">
                 <a:tc>
                   <a:txBody>
                     <a:bodyPr anchor="ctr"/>
@@ -18071,12 +18499,12 @@
                     <a:p>
                       <a:pPr algn="ctr"/>
                       <a:r>
-                        <a:rPr sz="1000" b="1">
+                        <a:rPr sz="900" b="1">
                           <a:solidFill>
                             <a:srgbClr val="FFFFFF"/>
                           </a:solidFill>
                           <a:latin typeface="微软雅黑"/>
-                          <ns9:rFonts xmlns:ns9="http://schemas.openxmlformats.org/wordprocessingml/2006/main" ns9:eastAsia="微软雅黑" ns9:ascii="微软雅黑" ns9:hAnsi="微软雅黑"/>
+                          <ns12:rFonts xmlns:ns12="http://schemas.openxmlformats.org/wordprocessingml/2006/main" ns12:eastAsia="微软雅黑" ns12:ascii="微软雅黑" ns12:hAnsi="微软雅黑"/>
                         </a:rPr>
                         <a:t>学校</a:t>
                       </a:r>
@@ -18095,25 +18523,25 @@
                     <a:p>
                       <a:pPr algn="l"/>
                       <a:r>
-                        <a:rPr sz="1000" b="0">
+                        <a:rPr sz="900" b="0">
                           <a:solidFill>
                             <a:srgbClr val="143278"/>
                           </a:solidFill>
                           <a:latin typeface="微软雅黑"/>
-                          <ns10:rFonts xmlns:ns10="http://schemas.openxmlformats.org/wordprocessingml/2006/main" ns10:eastAsia="微软雅黑" ns10:ascii="微软雅黑" ns10:hAnsi="微软雅黑"/>
+                          <ns13:rFonts xmlns:ns13="http://schemas.openxmlformats.org/wordprocessingml/2006/main" ns13:eastAsia="微软雅黑" ns13:ascii="微软雅黑" ns13:hAnsi="微软雅黑"/>
                         </a:rPr>
                         <a:t>中山大学</a:t>
                       </a:r>
                     </a:p>
                   </a:txBody>
-                  <a:tcPr marL="76200" marR="50800">
+                  <a:tcPr>
                     <a:solidFill>
-                      <a:srgbClr val="F1F7FF"/>
+                      <a:srgbClr val="FFFFFF"/>
                     </a:solidFill>
                   </a:tcPr>
                 </a:tc>
               </a:tr>
-              <a:tr h="550599">
+              <a:tr h="368046">
                 <a:tc>
                   <a:txBody>
                     <a:bodyPr anchor="ctr"/>
@@ -18121,14 +18549,14 @@
                     <a:p>
                       <a:pPr algn="ctr"/>
                       <a:r>
-                        <a:rPr sz="1000" b="1">
+                        <a:rPr sz="900" b="1">
                           <a:solidFill>
                             <a:srgbClr val="FFFFFF"/>
                           </a:solidFill>
                           <a:latin typeface="微软雅黑"/>
-                          <ns11:rFonts xmlns:ns11="http://schemas.openxmlformats.org/wordprocessingml/2006/main" ns11:eastAsia="微软雅黑" ns11:ascii="微软雅黑" ns11:hAnsi="微软雅黑"/>
+                          <ns14:rFonts xmlns:ns14="http://schemas.openxmlformats.org/wordprocessingml/2006/main" ns14:eastAsia="微软雅黑" ns14:ascii="微软雅黑" ns14:hAnsi="微软雅黑"/>
                         </a:rPr>
-                        <a:t>队长</a:t>
+                        <a:t>队长 / 队员</a:t>
                       </a:r>
                     </a:p>
                   </a:txBody>
@@ -18145,25 +18573,25 @@
                     <a:p>
                       <a:pPr algn="l"/>
                       <a:r>
-                        <a:rPr sz="1000" b="0">
+                        <a:rPr sz="900" b="0">
                           <a:solidFill>
                             <a:srgbClr val="143278"/>
                           </a:solidFill>
                           <a:latin typeface="微软雅黑"/>
-                          <ns12:rFonts xmlns:ns12="http://schemas.openxmlformats.org/wordprocessingml/2006/main" ns12:eastAsia="微软雅黑" ns12:ascii="微软雅黑" ns12:hAnsi="微软雅黑"/>
+                          <ns15:rFonts xmlns:ns15="http://schemas.openxmlformats.org/wordprocessingml/2006/main" ns15:eastAsia="微软雅黑" ns15:ascii="微软雅黑" ns15:hAnsi="微软雅黑"/>
                         </a:rPr>
-                        <a:t>刘小凡</a:t>
+                        <a:t>刘小凡 / 白冉</a:t>
                       </a:r>
                     </a:p>
                   </a:txBody>
-                  <a:tcPr marL="76200" marR="50800">
+                  <a:tcPr>
                     <a:solidFill>
                       <a:srgbClr val="F1F7FF"/>
                     </a:solidFill>
                   </a:tcPr>
                 </a:tc>
               </a:tr>
-              <a:tr h="550599">
+              <a:tr h="368046">
                 <a:tc>
                   <a:txBody>
                     <a:bodyPr anchor="ctr"/>
@@ -18171,62 +18599,12 @@
                     <a:p>
                       <a:pPr algn="ctr"/>
                       <a:r>
-                        <a:rPr sz="1000" b="1">
+                        <a:rPr sz="900" b="1">
                           <a:solidFill>
                             <a:srgbClr val="FFFFFF"/>
                           </a:solidFill>
                           <a:latin typeface="微软雅黑"/>
-                          <ns13:rFonts xmlns:ns13="http://schemas.openxmlformats.org/wordprocessingml/2006/main" ns13:eastAsia="微软雅黑" ns13:ascii="微软雅黑" ns13:hAnsi="微软雅黑"/>
-                        </a:rPr>
-                        <a:t>队员</a:t>
-                      </a:r>
-                    </a:p>
-                  </a:txBody>
-                  <a:tcPr marL="50800" marR="50800" marT="25400" marB="25400">
-                    <a:solidFill>
-                      <a:srgbClr val="143278"/>
-                    </a:solidFill>
-                  </a:tcPr>
-                </a:tc>
-                <a:tc>
-                  <a:txBody>
-                    <a:bodyPr anchor="ctr" wrap="square"/>
-                    <a:lstStyle/>
-                    <a:p>
-                      <a:pPr algn="l"/>
-                      <a:r>
-                        <a:rPr sz="1000" b="0">
-                          <a:solidFill>
-                            <a:srgbClr val="143278"/>
-                          </a:solidFill>
-                          <a:latin typeface="微软雅黑"/>
-                          <ns14:rFonts xmlns:ns14="http://schemas.openxmlformats.org/wordprocessingml/2006/main" ns14:eastAsia="微软雅黑" ns14:ascii="微软雅黑" ns14:hAnsi="微软雅黑"/>
-                        </a:rPr>
-                        <a:t>白冉</a:t>
-                      </a:r>
-                    </a:p>
-                  </a:txBody>
-                  <a:tcPr marL="76200" marR="50800">
-                    <a:solidFill>
-                      <a:srgbClr val="F1F7FF"/>
-                    </a:solidFill>
-                  </a:tcPr>
-                </a:tc>
-              </a:tr>
-              <a:tr h="550599">
-                <a:tc>
-                  <a:txBody>
-                    <a:bodyPr anchor="ctr"/>
-                    <a:lstStyle/>
-                    <a:p>
-                      <a:pPr algn="ctr"/>
-                      <a:r>
-                        <a:rPr sz="1000" b="1">
-                          <a:solidFill>
-                            <a:srgbClr val="FFFFFF"/>
-                          </a:solidFill>
-                          <a:latin typeface="微软雅黑"/>
-                          <ns15:rFonts xmlns:ns15="http://schemas.openxmlformats.org/wordprocessingml/2006/main" ns15:eastAsia="微软雅黑" ns15:ascii="微软雅黑" ns15:hAnsi="微软雅黑"/>
+                          <ns16:rFonts xmlns:ns16="http://schemas.openxmlformats.org/wordprocessingml/2006/main" ns16:eastAsia="微软雅黑" ns16:ascii="微软雅黑" ns16:hAnsi="微软雅黑"/>
                         </a:rPr>
                         <a:t>指导教师</a:t>
                       </a:r>
@@ -18245,25 +18623,25 @@
                     <a:p>
                       <a:pPr algn="l"/>
                       <a:r>
-                        <a:rPr sz="1000" b="0">
+                        <a:rPr sz="900" b="0">
                           <a:solidFill>
                             <a:srgbClr val="143278"/>
                           </a:solidFill>
                           <a:latin typeface="微软雅黑"/>
-                          <ns16:rFonts xmlns:ns16="http://schemas.openxmlformats.org/wordprocessingml/2006/main" ns16:eastAsia="微软雅黑" ns16:ascii="微软雅黑" ns16:hAnsi="微软雅黑"/>
+                          <ns17:rFonts xmlns:ns17="http://schemas.openxmlformats.org/wordprocessingml/2006/main" ns17:eastAsia="微软雅黑" ns17:ascii="微软雅黑" ns17:hAnsi="微软雅黑"/>
                         </a:rPr>
                         <a:t>彭键清</a:t>
                       </a:r>
                     </a:p>
                   </a:txBody>
-                  <a:tcPr marL="76200" marR="50800">
+                  <a:tcPr>
                     <a:solidFill>
-                      <a:srgbClr val="F1F7FF"/>
+                      <a:srgbClr val="FFFFFF"/>
                     </a:solidFill>
                   </a:tcPr>
                 </a:tc>
               </a:tr>
-              <a:tr h="550599">
+              <a:tr h="368046">
                 <a:tc>
                   <a:txBody>
                     <a:bodyPr anchor="ctr"/>
@@ -18271,12 +18649,12 @@
                     <a:p>
                       <a:pPr algn="ctr"/>
                       <a:r>
-                        <a:rPr sz="1000" b="1">
+                        <a:rPr sz="900" b="1">
                           <a:solidFill>
                             <a:srgbClr val="FFFFFF"/>
                           </a:solidFill>
                           <a:latin typeface="微软雅黑"/>
-                          <ns17:rFonts xmlns:ns17="http://schemas.openxmlformats.org/wordprocessingml/2006/main" ns17:eastAsia="微软雅黑" ns17:ascii="微软雅黑" ns17:hAnsi="微软雅黑"/>
+                          <ns18:rFonts xmlns:ns18="http://schemas.openxmlformats.org/wordprocessingml/2006/main" ns18:eastAsia="微软雅黑" ns18:ascii="微软雅黑" ns18:hAnsi="微软雅黑"/>
                         </a:rPr>
                         <a:t>团队编号</a:t>
                       </a:r>
@@ -18295,25 +18673,25 @@
                     <a:p>
                       <a:pPr algn="l"/>
                       <a:r>
-                        <a:rPr sz="1000" b="0">
+                        <a:rPr sz="900" b="0">
                           <a:solidFill>
                             <a:srgbClr val="143278"/>
                           </a:solidFill>
                           <a:latin typeface="微软雅黑"/>
-                          <ns18:rFonts xmlns:ns18="http://schemas.openxmlformats.org/wordprocessingml/2006/main" ns18:eastAsia="微软雅黑" ns18:ascii="微软雅黑" ns18:hAnsi="微软雅黑"/>
+                          <ns19:rFonts xmlns:ns19="http://schemas.openxmlformats.org/wordprocessingml/2006/main" ns19:eastAsia="微软雅黑" ns19:ascii="微软雅黑" ns19:hAnsi="微软雅黑"/>
                         </a:rPr>
                         <a:t>CRAIC2026-TEAM-8FJQKLMI</a:t>
                       </a:r>
                     </a:p>
                   </a:txBody>
-                  <a:tcPr marL="76200" marR="50800">
+                  <a:tcPr>
                     <a:solidFill>
                       <a:srgbClr val="F1F7FF"/>
                     </a:solidFill>
                   </a:tcPr>
                 </a:tc>
               </a:tr>
-              <a:tr h="550602">
+              <a:tr h="368046">
                 <a:tc>
                   <a:txBody>
                     <a:bodyPr anchor="ctr"/>
@@ -18321,12 +18699,12 @@
                     <a:p>
                       <a:pPr algn="ctr"/>
                       <a:r>
-                        <a:rPr sz="1000" b="1">
+                        <a:rPr sz="900" b="1">
                           <a:solidFill>
                             <a:srgbClr val="FFFFFF"/>
                           </a:solidFill>
                           <a:latin typeface="微软雅黑"/>
-                          <ns19:rFonts xmlns:ns19="http://schemas.openxmlformats.org/wordprocessingml/2006/main" ns19:eastAsia="微软雅黑" ns19:ascii="微软雅黑" ns19:hAnsi="微软雅黑"/>
+                          <ns20:rFonts xmlns:ns20="http://schemas.openxmlformats.org/wordprocessingml/2006/main" ns20:eastAsia="微软雅黑" ns20:ascii="微软雅黑" ns20:hAnsi="微软雅黑"/>
                         </a:rPr>
                         <a:t>作品编号</a:t>
                       </a:r>
@@ -18345,20 +18723,20 @@
                     <a:p>
                       <a:pPr algn="l"/>
                       <a:r>
-                        <a:rPr sz="1000" b="0">
+                        <a:rPr sz="900" b="0">
                           <a:solidFill>
                             <a:srgbClr val="143278"/>
                           </a:solidFill>
                           <a:latin typeface="微软雅黑"/>
-                          <ns20:rFonts xmlns:ns20="http://schemas.openxmlformats.org/wordprocessingml/2006/main" ns20:eastAsia="微软雅黑" ns20:ascii="微软雅黑" ns20:hAnsi="微软雅黑"/>
+                          <ns21:rFonts xmlns:ns21="http://schemas.openxmlformats.org/wordprocessingml/2006/main" ns21:eastAsia="微软雅黑" ns21:ascii="微软雅黑" ns21:hAnsi="微软雅黑"/>
                         </a:rPr>
                         <a:t>CRAIC20264ZEFT1DF</a:t>
                       </a:r>
                     </a:p>
                   </a:txBody>
-                  <a:tcPr marL="76200" marR="50800">
+                  <a:tcPr>
                     <a:solidFill>
-                      <a:srgbClr val="F1F7FF"/>
+                      <a:srgbClr val="FFFFFF"/>
                     </a:solidFill>
                   </a:tcPr>
                 </a:tc>
@@ -19605,8 +19983,8 @@
         </p:nvSpPr>
         <p:spPr>
           <a:xfrm>
-            <a:off x="4694986" y="1472215"/>
-            <a:ext cx="4097426" cy="2866581"/>
+            <a:off x="4803525" y="1249756"/>
+            <a:ext cx="3880348" cy="3311499"/>
           </a:xfrm>
           <a:prstGeom prst="rect">
             <a:avLst/>
@@ -19644,7 +20022,7 @@
       </p:sp>
       <p:pic>
         <p:nvPicPr>
-          <p:cNvPr id="19" name="Picture 18" descr="aging_trend.png"/>
+          <p:cNvPr id="19" name="Picture 18" descr="ppt_emotion_input.png"/>
           <p:cNvPicPr>
             <a:picLocks noChangeAspect="1"/>
           </p:cNvPicPr>
@@ -19658,8 +20036,8 @@
         </p:blipFill>
         <p:spPr>
           <a:xfrm>
-            <a:off x="4731562" y="1508791"/>
-            <a:ext cx="4024274" cy="2793429"/>
+            <a:off x="4840101" y="1286332"/>
+            <a:ext cx="3807196" cy="3238347"/>
           </a:xfrm>
           <a:prstGeom prst="rect">
             <a:avLst/>
@@ -20363,8 +20741,8 @@
         </p:nvSpPr>
         <p:spPr>
           <a:xfrm>
-            <a:off x="4308652" y="1248157"/>
-            <a:ext cx="4321454" cy="3022089"/>
+            <a:off x="4308652" y="1223033"/>
+            <a:ext cx="4321454" cy="3072336"/>
           </a:xfrm>
           <a:prstGeom prst="rect">
             <a:avLst/>
@@ -20416,8 +20794,8 @@
         </p:blipFill>
         <p:spPr>
           <a:xfrm>
-            <a:off x="4345228" y="1284733"/>
-            <a:ext cx="4248302" cy="2948937"/>
+            <a:off x="4345228" y="1259609"/>
+            <a:ext cx="4248302" cy="2999184"/>
           </a:xfrm>
           <a:prstGeom prst="rect">
             <a:avLst/>
@@ -21556,7 +21934,7 @@
               </a:spcAft>
             </a:pPr>
             <a:r>
-              <a:rPr sz="1300" b="0">
+              <a:rPr sz="1200" b="0">
                 <a:solidFill>
                   <a:srgbClr val="1C202C"/>
                 </a:solidFill>
@@ -21599,7 +21977,7 @@
               </a:spcAft>
             </a:pPr>
             <a:r>
-              <a:rPr sz="1300" b="0">
+              <a:rPr sz="1200" b="0">
                 <a:solidFill>
                   <a:srgbClr val="1C202C"/>
                 </a:solidFill>
@@ -21642,7 +22020,7 @@
               </a:spcAft>
             </a:pPr>
             <a:r>
-              <a:rPr sz="1300" b="0">
+              <a:rPr sz="1200" b="0">
                 <a:solidFill>
                   <a:srgbClr val="1C202C"/>
                 </a:solidFill>
@@ -21685,7 +22063,7 @@
               </a:spcAft>
             </a:pPr>
             <a:r>
-              <a:rPr sz="1300" b="0">
+              <a:rPr sz="1200" b="0">
                 <a:solidFill>
                   <a:srgbClr val="1C202C"/>
                 </a:solidFill>
@@ -21821,97 +22199,9 @@
           </a:p>
         </p:txBody>
       </p:sp>
-      <p:sp>
-        <p:nvSpPr>
-          <p:cNvPr id="17" name="Rectangle 16"/>
-          <p:cNvSpPr/>
-          <p:nvPr/>
-        </p:nvSpPr>
-        <p:spPr>
-          <a:xfrm>
-            <a:off x="3968496" y="996696"/>
-            <a:ext cx="10972" cy="3854196"/>
-          </a:xfrm>
-          <a:prstGeom prst="rect">
-            <a:avLst/>
-          </a:prstGeom>
-          <a:solidFill>
-            <a:srgbClr val="BAC8DC"/>
-          </a:solidFill>
-          <a:ln>
-            <a:noFill/>
-          </a:ln>
-        </p:spPr>
-        <p:style>
-          <a:lnRef idx="1">
-            <a:schemeClr val="accent1"/>
-          </a:lnRef>
-          <a:fillRef idx="3">
-            <a:schemeClr val="accent1"/>
-          </a:fillRef>
-          <a:effectRef idx="2">
-            <a:schemeClr val="accent1"/>
-          </a:effectRef>
-          <a:fontRef idx="minor">
-            <a:schemeClr val="lt1"/>
-          </a:fontRef>
-        </p:style>
-        <p:txBody>
-          <a:bodyPr rtlCol="0" anchor="ctr"/>
-          <a:lstStyle/>
-          <a:p>
-            <a:pPr algn="ctr"/>
-          </a:p>
-        </p:txBody>
-      </p:sp>
-      <p:sp>
-        <p:nvSpPr>
-          <p:cNvPr id="18" name="Rectangle 17"/>
-          <p:cNvSpPr/>
-          <p:nvPr/>
-        </p:nvSpPr>
-        <p:spPr>
-          <a:xfrm>
-            <a:off x="4308652" y="1221190"/>
-            <a:ext cx="4321454" cy="3076023"/>
-          </a:xfrm>
-          <a:prstGeom prst="rect">
-            <a:avLst/>
-          </a:prstGeom>
-          <a:solidFill>
-            <a:srgbClr val="FCFDFF"/>
-          </a:solidFill>
-          <a:ln w="7620">
-            <a:solidFill>
-              <a:srgbClr val="BAC8DC"/>
-            </a:solidFill>
-          </a:ln>
-        </p:spPr>
-        <p:style>
-          <a:lnRef idx="1">
-            <a:schemeClr val="accent1"/>
-          </a:lnRef>
-          <a:fillRef idx="3">
-            <a:schemeClr val="accent1"/>
-          </a:fillRef>
-          <a:effectRef idx="2">
-            <a:schemeClr val="accent1"/>
-          </a:effectRef>
-          <a:fontRef idx="minor">
-            <a:schemeClr val="lt1"/>
-          </a:fontRef>
-        </p:style>
-        <p:txBody>
-          <a:bodyPr rtlCol="0" anchor="ctr"/>
-          <a:lstStyle/>
-          <a:p>
-            <a:pPr algn="ctr"/>
-          </a:p>
-        </p:txBody>
-      </p:sp>
       <p:pic>
         <p:nvPicPr>
-          <p:cNvPr id="19" name="Picture 18" descr="architecture_layers.png"/>
+          <p:cNvPr id="17" name="Picture 16" descr="architecture_layers.png"/>
           <p:cNvPicPr>
             <a:picLocks noChangeAspect="1"/>
           </p:cNvPicPr>
@@ -21925,8 +22215,8 @@
         </p:blipFill>
         <p:spPr>
           <a:xfrm>
-            <a:off x="4345228" y="1257766"/>
-            <a:ext cx="4248302" cy="3002871"/>
+            <a:off x="5473522" y="1104542"/>
+            <a:ext cx="1991714" cy="1407823"/>
           </a:xfrm>
           <a:prstGeom prst="rect">
             <a:avLst/>
@@ -21935,13 +22225,13 @@
       </p:pic>
       <p:sp>
         <p:nvSpPr>
-          <p:cNvPr id="20" name="TextBox 19"/>
+          <p:cNvPr id="18" name="TextBox 17"/>
           <p:cNvSpPr txBox="1"/>
           <p:nvPr/>
         </p:nvSpPr>
         <p:spPr>
           <a:xfrm>
-            <a:off x="4160520" y="4521708"/>
+            <a:off x="4160520" y="2620213"/>
             <a:ext cx="4617720" cy="219456"/>
           </a:xfrm>
           <a:prstGeom prst="rect">
@@ -21964,7 +22254,67 @@
                 <a:latin typeface="微软雅黑"/>
                 <ns8:rFonts xmlns:ns8="http://schemas.openxmlformats.org/wordprocessingml/2006/main" ns8:eastAsia="微软雅黑" ns8:ascii="微软雅黑" ns8:hAnsi="微软雅黑"/>
               </a:rPr>
-              <a:t>系统四层架构</a:t>
+              <a:t>四层架构</a:t>
+            </a:r>
+          </a:p>
+        </p:txBody>
+      </p:sp>
+      <p:pic>
+        <p:nvPicPr>
+          <p:cNvPr id="19" name="Picture 18" descr="state_machine.png"/>
+          <p:cNvPicPr>
+            <a:picLocks noChangeAspect="1"/>
+          </p:cNvPicPr>
+          <p:nvPr/>
+        </p:nvPicPr>
+        <p:blipFill>
+          <a:blip r:embed="rId3"/>
+          <a:stretch>
+            <a:fillRect/>
+          </a:stretch>
+        </p:blipFill>
+        <p:spPr>
+          <a:xfrm>
+            <a:off x="5457021" y="2885336"/>
+            <a:ext cx="2024716" cy="1407823"/>
+          </a:xfrm>
+          <a:prstGeom prst="rect">
+            <a:avLst/>
+          </a:prstGeom>
+        </p:spPr>
+      </p:pic>
+      <p:sp>
+        <p:nvSpPr>
+          <p:cNvPr id="20" name="TextBox 19"/>
+          <p:cNvSpPr txBox="1"/>
+          <p:nvPr/>
+        </p:nvSpPr>
+        <p:spPr>
+          <a:xfrm>
+            <a:off x="4160520" y="4401007"/>
+            <a:ext cx="4617720" cy="219456"/>
+          </a:xfrm>
+          <a:prstGeom prst="rect">
+            <a:avLst/>
+          </a:prstGeom>
+          <a:noFill/>
+        </p:spPr>
+        <p:txBody>
+          <a:bodyPr wrap="square" anchor="ctr">
+            <a:spAutoFit/>
+          </a:bodyPr>
+          <a:lstStyle/>
+          <a:p>
+            <a:pPr algn="ctr"/>
+            <a:r>
+              <a:rPr sz="800" b="0">
+                <a:solidFill>
+                  <a:srgbClr val="5A6273"/>
+                </a:solidFill>
+                <a:latin typeface="微软雅黑"/>
+                <ns9:rFonts xmlns:ns9="http://schemas.openxmlformats.org/wordprocessingml/2006/main" ns9:eastAsia="微软雅黑" ns9:ascii="微软雅黑" ns9:hAnsi="微软雅黑"/>
+              </a:rPr>
+              <a:t>状态机概览</a:t>
             </a:r>
           </a:p>
         </p:txBody>
@@ -22635,8 +22985,8 @@
         </p:nvSpPr>
         <p:spPr>
           <a:xfrm>
-            <a:off x="4694986" y="1469852"/>
-            <a:ext cx="4097426" cy="2871307"/>
+            <a:off x="4694986" y="1375751"/>
+            <a:ext cx="4097426" cy="3059508"/>
           </a:xfrm>
           <a:prstGeom prst="rect">
             <a:avLst/>
@@ -22674,7 +23024,7 @@
       </p:sp>
       <p:pic>
         <p:nvPicPr>
-          <p:cNvPr id="19" name="Picture 18" descr="state_machine.png"/>
+          <p:cNvPr id="19" name="Picture 18" descr="risk_fusion.png"/>
           <p:cNvPicPr>
             <a:picLocks noChangeAspect="1"/>
           </p:cNvPicPr>
@@ -22688,8 +23038,8 @@
         </p:blipFill>
         <p:spPr>
           <a:xfrm>
-            <a:off x="4731562" y="1506428"/>
-            <a:ext cx="4024274" cy="2798155"/>
+            <a:off x="4731562" y="1412327"/>
+            <a:ext cx="4024274" cy="2986356"/>
           </a:xfrm>
           <a:prstGeom prst="rect">
             <a:avLst/>
@@ -23406,7 +23756,7 @@
                 <a:latin typeface="微软雅黑"/>
                 <ns7:rFonts xmlns:ns7="http://schemas.openxmlformats.org/wordprocessingml/2006/main" ns7:eastAsia="微软雅黑" ns7:ascii="微软雅黑" ns7:hAnsi="微软雅黑"/>
               </a:rPr>
-              <a:t>分层与 CareOrchestrator</a:t>
+              <a:t>四层架构详图</a:t>
             </a:r>
           </a:p>
         </p:txBody>

</xml_diff>

<commit_message>
fix: redesign PPT slides 7/12/18/22/26/29 layout and figures
Combine project goals into one large diagram, rewrite fall decision tree,
add skeleton annotation cards, fix eval chart overlap and radar label clipping,
and raise QR slide captions.

Co-authored-by: Cursor <cursoragent@cursor.com>
</commit_message>
<xml_diff>
--- a/docs/答辩_CareCompanion.pptx
+++ b/docs/答辩_CareCompanion.pptx
@@ -5754,8 +5754,8 @@
         </p:nvSpPr>
         <p:spPr>
           <a:xfrm>
-            <a:off x="5243358" y="1151595"/>
-            <a:ext cx="2452043" cy="3215213"/>
+            <a:off x="4969110" y="1151595"/>
+            <a:ext cx="3000538" cy="3215213"/>
           </a:xfrm>
           <a:prstGeom prst="rect">
             <a:avLst/>
@@ -5807,8 +5807,8 @@
         </p:blipFill>
         <p:spPr>
           <a:xfrm>
-            <a:off x="5279934" y="1188171"/>
-            <a:ext cx="2378891" cy="3142061"/>
+            <a:off x="5005686" y="1188171"/>
+            <a:ext cx="2927386" cy="3142061"/>
           </a:xfrm>
           <a:prstGeom prst="rect">
             <a:avLst/>
@@ -9787,8 +9787,268 @@
         </p:nvSpPr>
         <p:spPr>
           <a:xfrm>
-            <a:off x="274320" y="1033272"/>
-            <a:ext cx="4233672" cy="3781044"/>
+            <a:off x="274320" y="996696"/>
+            <a:ext cx="3611880" cy="3854196"/>
+          </a:xfrm>
+          <a:prstGeom prst="rect">
+            <a:avLst/>
+          </a:prstGeom>
+          <a:solidFill>
+            <a:srgbClr val="F1F7FF"/>
+          </a:solidFill>
+          <a:ln w="10160">
+            <a:solidFill>
+              <a:srgbClr val="BAC8DC"/>
+            </a:solidFill>
+          </a:ln>
+        </p:spPr>
+        <p:style>
+          <a:lnRef idx="1">
+            <a:schemeClr val="accent1"/>
+          </a:lnRef>
+          <a:fillRef idx="3">
+            <a:schemeClr val="accent1"/>
+          </a:fillRef>
+          <a:effectRef idx="2">
+            <a:schemeClr val="accent1"/>
+          </a:effectRef>
+          <a:fontRef idx="minor">
+            <a:schemeClr val="lt1"/>
+          </a:fontRef>
+        </p:style>
+        <p:txBody>
+          <a:bodyPr rtlCol="0" anchor="ctr"/>
+          <a:lstStyle/>
+          <a:p>
+            <a:pPr algn="ctr"/>
+          </a:p>
+        </p:txBody>
+      </p:sp>
+      <p:sp>
+        <p:nvSpPr>
+          <p:cNvPr id="9" name="Rectangle 8"/>
+          <p:cNvSpPr/>
+          <p:nvPr/>
+        </p:nvSpPr>
+        <p:spPr>
+          <a:xfrm>
+            <a:off x="274320" y="996696"/>
+            <a:ext cx="73152" cy="3854196"/>
+          </a:xfrm>
+          <a:prstGeom prst="rect">
+            <a:avLst/>
+          </a:prstGeom>
+          <a:solidFill>
+            <a:srgbClr val="143278"/>
+          </a:solidFill>
+          <a:ln>
+            <a:noFill/>
+          </a:ln>
+        </p:spPr>
+        <p:style>
+          <a:lnRef idx="1">
+            <a:schemeClr val="accent1"/>
+          </a:lnRef>
+          <a:fillRef idx="3">
+            <a:schemeClr val="accent1"/>
+          </a:fillRef>
+          <a:effectRef idx="2">
+            <a:schemeClr val="accent1"/>
+          </a:effectRef>
+          <a:fontRef idx="minor">
+            <a:schemeClr val="lt1"/>
+          </a:fontRef>
+        </p:style>
+        <p:txBody>
+          <a:bodyPr rtlCol="0" anchor="ctr"/>
+          <a:lstStyle/>
+          <a:p>
+            <a:pPr algn="ctr"/>
+          </a:p>
+        </p:txBody>
+      </p:sp>
+      <p:sp>
+        <p:nvSpPr>
+          <p:cNvPr id="10" name="TextBox 9"/>
+          <p:cNvSpPr txBox="1"/>
+          <p:nvPr/>
+        </p:nvSpPr>
+        <p:spPr>
+          <a:xfrm>
+            <a:off x="438912" y="1106424"/>
+            <a:ext cx="3282696" cy="890397"/>
+          </a:xfrm>
+          <a:prstGeom prst="rect">
+            <a:avLst/>
+          </a:prstGeom>
+          <a:noFill/>
+        </p:spPr>
+        <p:txBody>
+          <a:bodyPr wrap="square" anchor="t" lIns="25400" tIns="0">
+            <a:spAutoFit/>
+          </a:bodyPr>
+          <a:lstStyle/>
+          <a:p>
+            <a:pPr>
+              <a:lnSpc>
+                <a:spcPct val="112000"/>
+              </a:lnSpc>
+              <a:spcAft>
+                <a:spcPts val="200"/>
+              </a:spcAft>
+            </a:pPr>
+            <a:r>
+              <a:rPr sz="1200" b="0">
+                <a:solidFill>
+                  <a:srgbClr val="1C202C"/>
+                </a:solidFill>
+                <a:latin typeface="微软雅黑"/>
+                <ns3:rFonts xmlns:ns3="http://schemas.openxmlformats.org/wordprocessingml/2006/main" ns3:eastAsia="微软雅黑" ns3:ascii="微软雅黑" ns3:hAnsi="微软雅黑"/>
+              </a:rPr>
+              <a:t>● MediaPipe 提取 33 个骨架关键点</a:t>
+            </a:r>
+          </a:p>
+        </p:txBody>
+      </p:sp>
+      <p:sp>
+        <p:nvSpPr>
+          <p:cNvPr id="11" name="TextBox 10"/>
+          <p:cNvSpPr txBox="1"/>
+          <p:nvPr/>
+        </p:nvSpPr>
+        <p:spPr>
+          <a:xfrm>
+            <a:off x="438912" y="2015109"/>
+            <a:ext cx="3282696" cy="890397"/>
+          </a:xfrm>
+          <a:prstGeom prst="rect">
+            <a:avLst/>
+          </a:prstGeom>
+          <a:noFill/>
+        </p:spPr>
+        <p:txBody>
+          <a:bodyPr wrap="square" anchor="t" lIns="25400" tIns="0">
+            <a:spAutoFit/>
+          </a:bodyPr>
+          <a:lstStyle/>
+          <a:p>
+            <a:pPr>
+              <a:lnSpc>
+                <a:spcPct val="112000"/>
+              </a:lnSpc>
+              <a:spcAft>
+                <a:spcPts val="200"/>
+              </a:spcAft>
+            </a:pPr>
+            <a:r>
+              <a:rPr sz="1200" b="0">
+                <a:solidFill>
+                  <a:srgbClr val="1C202C"/>
+                </a:solidFill>
+                <a:latin typeface="微软雅黑"/>
+                <ns4:rFonts xmlns:ns4="http://schemas.openxmlformats.org/wordprocessingml/2006/main" ns4:eastAsia="微软雅黑" ns4:ascii="微软雅黑" ns4:hAnsi="微软雅黑"/>
+              </a:rPr>
+              <a:t>● 由肩-髋-踝计算宽高比 R</a:t>
+            </a:r>
+          </a:p>
+        </p:txBody>
+      </p:sp>
+      <p:sp>
+        <p:nvSpPr>
+          <p:cNvPr id="12" name="TextBox 11"/>
+          <p:cNvSpPr txBox="1"/>
+          <p:nvPr/>
+        </p:nvSpPr>
+        <p:spPr>
+          <a:xfrm>
+            <a:off x="438912" y="2923794"/>
+            <a:ext cx="3282696" cy="890397"/>
+          </a:xfrm>
+          <a:prstGeom prst="rect">
+            <a:avLst/>
+          </a:prstGeom>
+          <a:noFill/>
+        </p:spPr>
+        <p:txBody>
+          <a:bodyPr wrap="square" anchor="t" lIns="25400" tIns="0">
+            <a:spAutoFit/>
+          </a:bodyPr>
+          <a:lstStyle/>
+          <a:p>
+            <a:pPr>
+              <a:lnSpc>
+                <a:spcPct val="112000"/>
+              </a:lnSpc>
+              <a:spcAft>
+                <a:spcPts val="200"/>
+              </a:spcAft>
+            </a:pPr>
+            <a:r>
+              <a:rPr sz="1200" b="0">
+                <a:solidFill>
+                  <a:srgbClr val="1C202C"/>
+                </a:solidFill>
+                <a:latin typeface="微软雅黑"/>
+                <ns5:rFonts xmlns:ns5="http://schemas.openxmlformats.org/wordprocessingml/2006/main" ns5:eastAsia="微软雅黑" ns5:ascii="微软雅黑" ns5:hAnsi="微软雅黑"/>
+              </a:rPr>
+              <a:t>● 竖直速度突增触发跌倒规则</a:t>
+            </a:r>
+          </a:p>
+        </p:txBody>
+      </p:sp>
+      <p:sp>
+        <p:nvSpPr>
+          <p:cNvPr id="13" name="TextBox 12"/>
+          <p:cNvSpPr txBox="1"/>
+          <p:nvPr/>
+        </p:nvSpPr>
+        <p:spPr>
+          <a:xfrm>
+            <a:off x="438912" y="3832479"/>
+            <a:ext cx="3282696" cy="890397"/>
+          </a:xfrm>
+          <a:prstGeom prst="rect">
+            <a:avLst/>
+          </a:prstGeom>
+          <a:noFill/>
+        </p:spPr>
+        <p:txBody>
+          <a:bodyPr wrap="square" anchor="t" lIns="25400" tIns="0">
+            <a:spAutoFit/>
+          </a:bodyPr>
+          <a:lstStyle/>
+          <a:p>
+            <a:pPr>
+              <a:lnSpc>
+                <a:spcPct val="112000"/>
+              </a:lnSpc>
+              <a:spcAft>
+                <a:spcPts val="200"/>
+              </a:spcAft>
+            </a:pPr>
+            <a:r>
+              <a:rPr sz="1200" b="0">
+                <a:solidFill>
+                  <a:srgbClr val="1C202C"/>
+                </a:solidFill>
+                <a:latin typeface="微软雅黑"/>
+                <ns6:rFonts xmlns:ns6="http://schemas.openxmlformats.org/wordprocessingml/2006/main" ns6:eastAsia="微软雅黑" ns6:ascii="微软雅黑" ns6:hAnsi="微软雅黑"/>
+              </a:rPr>
+              <a:t>● 上传照片与摄像头共用同一逻辑</a:t>
+            </a:r>
+          </a:p>
+        </p:txBody>
+      </p:sp>
+      <p:sp>
+        <p:nvSpPr>
+          <p:cNvPr id="14" name="Rectangle 13"/>
+          <p:cNvSpPr/>
+          <p:nvPr/>
+        </p:nvSpPr>
+        <p:spPr>
+          <a:xfrm>
+            <a:off x="4105656" y="1033272"/>
+            <a:ext cx="4727448" cy="3744468"/>
           </a:xfrm>
           <a:prstGeom prst="rect">
             <a:avLst/>
@@ -9824,9 +10084,52 @@
           </a:p>
         </p:txBody>
       </p:sp>
+      <p:sp>
+        <p:nvSpPr>
+          <p:cNvPr id="15" name="Rectangle 14"/>
+          <p:cNvSpPr/>
+          <p:nvPr/>
+        </p:nvSpPr>
+        <p:spPr>
+          <a:xfrm>
+            <a:off x="3968496" y="996696"/>
+            <a:ext cx="10972" cy="3854196"/>
+          </a:xfrm>
+          <a:prstGeom prst="rect">
+            <a:avLst/>
+          </a:prstGeom>
+          <a:solidFill>
+            <a:srgbClr val="BAC8DC"/>
+          </a:solidFill>
+          <a:ln>
+            <a:noFill/>
+          </a:ln>
+        </p:spPr>
+        <p:style>
+          <a:lnRef idx="1">
+            <a:schemeClr val="accent1"/>
+          </a:lnRef>
+          <a:fillRef idx="3">
+            <a:schemeClr val="accent1"/>
+          </a:fillRef>
+          <a:effectRef idx="2">
+            <a:schemeClr val="accent1"/>
+          </a:effectRef>
+          <a:fontRef idx="minor">
+            <a:schemeClr val="lt1"/>
+          </a:fontRef>
+        </p:style>
+        <p:txBody>
+          <a:bodyPr rtlCol="0" anchor="ctr"/>
+          <a:lstStyle/>
+          <a:p>
+            <a:pPr algn="ctr"/>
+          </a:p>
+        </p:txBody>
+      </p:sp>
       <p:pic>
         <p:nvPicPr>
-          <p:cNvPr id="9" name="Picture 8" descr="ppt_mediapipe_pose.png"/>
+          <p:cNvPr id="16" name="Picture 15" descr="ppt_mediapipe_pose.png"/>
           <p:cNvPicPr>
             <a:picLocks noChangeAspect="1"/>
           </p:cNvPicPr>
@@ -9840,8 +10143,8 @@
         </p:blipFill>
         <p:spPr>
           <a:xfrm>
-            <a:off x="1180821" y="1191143"/>
-            <a:ext cx="2420668" cy="3227557"/>
+            <a:off x="4343462" y="1171277"/>
+            <a:ext cx="2258442" cy="3011256"/>
           </a:xfrm>
           <a:prstGeom prst="rect">
             <a:avLst/>
@@ -9850,14 +10153,14 @@
       </p:pic>
       <p:sp>
         <p:nvSpPr>
-          <p:cNvPr id="10" name="TextBox 9"/>
+          <p:cNvPr id="17" name="TextBox 16"/>
           <p:cNvSpPr txBox="1"/>
           <p:nvPr/>
         </p:nvSpPr>
         <p:spPr>
           <a:xfrm>
-            <a:off x="347472" y="4576572"/>
-            <a:ext cx="4087368" cy="219456"/>
+            <a:off x="4215383" y="4283964"/>
+            <a:ext cx="2514600" cy="219456"/>
           </a:xfrm>
           <a:prstGeom prst="rect">
             <a:avLst/>
@@ -9877,7 +10180,7 @@
                   <a:srgbClr val="5A6273"/>
                 </a:solidFill>
                 <a:latin typeface="微软雅黑"/>
-                <ns3:rFonts xmlns:ns3="http://schemas.openxmlformats.org/wordprocessingml/2006/main" ns3:eastAsia="微软雅黑" ns3:ascii="微软雅黑" ns3:hAnsi="微软雅黑"/>
+                <ns7:rFonts xmlns:ns7="http://schemas.openxmlformats.org/wordprocessingml/2006/main" ns7:eastAsia="微软雅黑" ns7:ascii="微软雅黑" ns7:hAnsi="微软雅黑"/>
               </a:rPr>
               <a:t>MediaPipe 骨架叠加</a:t>
             </a:r>
@@ -9886,22 +10189,22 @@
       </p:sp>
       <p:sp>
         <p:nvSpPr>
-          <p:cNvPr id="11" name="Rectangle 10"/>
+          <p:cNvPr id="18" name="Rectangle 17"/>
           <p:cNvSpPr/>
           <p:nvPr/>
         </p:nvSpPr>
         <p:spPr>
           <a:xfrm>
-            <a:off x="4636007" y="1033272"/>
-            <a:ext cx="4233672" cy="3781044"/>
-          </a:xfrm>
-          <a:prstGeom prst="rect">
-            <a:avLst/>
-          </a:prstGeom>
-          <a:solidFill>
-            <a:srgbClr val="FFFFFF"/>
-          </a:solidFill>
-          <a:ln w="9525">
+            <a:off x="6876288" y="1234440"/>
+            <a:ext cx="1847088" cy="804672"/>
+          </a:xfrm>
+          <a:prstGeom prst="rect">
+            <a:avLst/>
+          </a:prstGeom>
+          <a:solidFill>
+            <a:srgbClr val="F1F7FF"/>
+          </a:solidFill>
+          <a:ln w="7620">
             <a:solidFill>
               <a:srgbClr val="BAC8DC"/>
             </a:solidFill>
@@ -9929,40 +10232,16 @@
           </a:p>
         </p:txBody>
       </p:sp>
-      <p:pic>
-        <p:nvPicPr>
-          <p:cNvPr id="12" name="Picture 11" descr="ppt_risk_panel.png"/>
-          <p:cNvPicPr>
-            <a:picLocks noChangeAspect="1"/>
-          </p:cNvPicPr>
-          <p:nvPr/>
-        </p:nvPicPr>
-        <p:blipFill>
-          <a:blip r:embed="rId3"/>
-          <a:stretch>
-            <a:fillRect/>
-          </a:stretch>
-        </p:blipFill>
-        <p:spPr>
-          <a:xfrm>
-            <a:off x="5397521" y="1191143"/>
-            <a:ext cx="2710644" cy="3227557"/>
-          </a:xfrm>
-          <a:prstGeom prst="rect">
-            <a:avLst/>
-          </a:prstGeom>
-        </p:spPr>
-      </p:pic>
-      <p:sp>
-        <p:nvSpPr>
-          <p:cNvPr id="13" name="TextBox 12"/>
+      <p:sp>
+        <p:nvSpPr>
+          <p:cNvPr id="19" name="TextBox 18"/>
           <p:cNvSpPr txBox="1"/>
           <p:nvPr/>
         </p:nvSpPr>
         <p:spPr>
           <a:xfrm>
-            <a:off x="4709159" y="4576572"/>
-            <a:ext cx="4087368" cy="219456"/>
+            <a:off x="7004303" y="1325880"/>
+            <a:ext cx="1627632" cy="640080"/>
           </a:xfrm>
           <a:prstGeom prst="rect">
             <a:avLst/>
@@ -9970,21 +10249,231 @@
           <a:noFill/>
         </p:spPr>
         <p:txBody>
-          <a:bodyPr wrap="square" anchor="ctr">
+          <a:bodyPr wrap="square">
             <a:spAutoFit/>
           </a:bodyPr>
           <a:lstStyle/>
           <a:p>
-            <a:pPr algn="ctr"/>
-            <a:r>
-              <a:rPr sz="800" b="0">
-                <a:solidFill>
-                  <a:srgbClr val="5A6273"/>
-                </a:solidFill>
-                <a:latin typeface="微软雅黑"/>
-                <ns4:rFonts xmlns:ns4="http://schemas.openxmlformats.org/wordprocessingml/2006/main" ns4:eastAsia="微软雅黑" ns4:ascii="微软雅黑" ns4:hAnsi="微软雅黑"/>
-              </a:rPr>
-              <a:t>风险面板联动</a:t>
+            <a:r>
+              <a:rPr sz="1200" b="1">
+                <a:solidFill>
+                  <a:srgbClr val="F59E0B"/>
+                </a:solidFill>
+                <a:latin typeface="微软雅黑"/>
+                <ns8:rFonts xmlns:ns8="http://schemas.openxmlformats.org/wordprocessingml/2006/main" ns8:eastAsia="微软雅黑" ns8:ascii="微软雅黑" ns8:hAnsi="微软雅黑"/>
+              </a:rPr>
+              <a:t>① 关键点</a:t>
+            </a:r>
+          </a:p>
+          <a:p>
+            <a:pPr>
+              <a:spcBef>
+                <a:spcPts val="300"/>
+              </a:spcBef>
+            </a:pPr>
+            <a:r>
+              <a:rPr sz="1100" b="0">
+                <a:solidFill>
+                  <a:srgbClr val="143278"/>
+                </a:solidFill>
+                <a:latin typeface="微软雅黑"/>
+                <ns9:rFonts xmlns:ns9="http://schemas.openxmlformats.org/wordprocessingml/2006/main" ns9:eastAsia="微软雅黑" ns9:ascii="微软雅黑" ns9:hAnsi="微软雅黑"/>
+              </a:rPr>
+              <a:t>鼻、肩、髋、踝等构成人体构型</a:t>
+            </a:r>
+          </a:p>
+        </p:txBody>
+      </p:sp>
+      <p:sp>
+        <p:nvSpPr>
+          <p:cNvPr id="20" name="Rectangle 19"/>
+          <p:cNvSpPr/>
+          <p:nvPr/>
+        </p:nvSpPr>
+        <p:spPr>
+          <a:xfrm>
+            <a:off x="6876288" y="2130552"/>
+            <a:ext cx="1847088" cy="804672"/>
+          </a:xfrm>
+          <a:prstGeom prst="rect">
+            <a:avLst/>
+          </a:prstGeom>
+          <a:solidFill>
+            <a:srgbClr val="F1F7FF"/>
+          </a:solidFill>
+          <a:ln w="7620">
+            <a:solidFill>
+              <a:srgbClr val="BAC8DC"/>
+            </a:solidFill>
+          </a:ln>
+        </p:spPr>
+        <p:style>
+          <a:lnRef idx="1">
+            <a:schemeClr val="accent1"/>
+          </a:lnRef>
+          <a:fillRef idx="3">
+            <a:schemeClr val="accent1"/>
+          </a:fillRef>
+          <a:effectRef idx="2">
+            <a:schemeClr val="accent1"/>
+          </a:effectRef>
+          <a:fontRef idx="minor">
+            <a:schemeClr val="lt1"/>
+          </a:fontRef>
+        </p:style>
+        <p:txBody>
+          <a:bodyPr rtlCol="0" anchor="ctr"/>
+          <a:lstStyle/>
+          <a:p>
+            <a:pPr algn="ctr"/>
+          </a:p>
+        </p:txBody>
+      </p:sp>
+      <p:sp>
+        <p:nvSpPr>
+          <p:cNvPr id="21" name="TextBox 20"/>
+          <p:cNvSpPr txBox="1"/>
+          <p:nvPr/>
+        </p:nvSpPr>
+        <p:spPr>
+          <a:xfrm>
+            <a:off x="7004303" y="2221992"/>
+            <a:ext cx="1627632" cy="640080"/>
+          </a:xfrm>
+          <a:prstGeom prst="rect">
+            <a:avLst/>
+          </a:prstGeom>
+          <a:noFill/>
+        </p:spPr>
+        <p:txBody>
+          <a:bodyPr wrap="square">
+            <a:spAutoFit/>
+          </a:bodyPr>
+          <a:lstStyle/>
+          <a:p>
+            <a:r>
+              <a:rPr sz="1200" b="1">
+                <a:solidFill>
+                  <a:srgbClr val="F59E0B"/>
+                </a:solidFill>
+                <a:latin typeface="微软雅黑"/>
+                <ns10:rFonts xmlns:ns10="http://schemas.openxmlformats.org/wordprocessingml/2006/main" ns10:eastAsia="微软雅黑" ns10:ascii="微软雅黑" ns10:hAnsi="微软雅黑"/>
+              </a:rPr>
+              <a:t>② 宽高比 R</a:t>
+            </a:r>
+          </a:p>
+          <a:p>
+            <a:pPr>
+              <a:spcBef>
+                <a:spcPts val="300"/>
+              </a:spcBef>
+            </a:pPr>
+            <a:r>
+              <a:rPr sz="1100" b="0">
+                <a:solidFill>
+                  <a:srgbClr val="143278"/>
+                </a:solidFill>
+                <a:latin typeface="微软雅黑"/>
+                <ns11:rFonts xmlns:ns11="http://schemas.openxmlformats.org/wordprocessingml/2006/main" ns11:eastAsia="微软雅黑" ns11:ascii="微软雅黑" ns11:hAnsi="微软雅黑"/>
+              </a:rPr>
+              <a:t>躯干投影宽高比异常 → 姿态变化</a:t>
+            </a:r>
+          </a:p>
+        </p:txBody>
+      </p:sp>
+      <p:sp>
+        <p:nvSpPr>
+          <p:cNvPr id="22" name="Rectangle 21"/>
+          <p:cNvSpPr/>
+          <p:nvPr/>
+        </p:nvSpPr>
+        <p:spPr>
+          <a:xfrm>
+            <a:off x="6876288" y="3026664"/>
+            <a:ext cx="1847088" cy="804672"/>
+          </a:xfrm>
+          <a:prstGeom prst="rect">
+            <a:avLst/>
+          </a:prstGeom>
+          <a:solidFill>
+            <a:srgbClr val="F1F7FF"/>
+          </a:solidFill>
+          <a:ln w="7620">
+            <a:solidFill>
+              <a:srgbClr val="BAC8DC"/>
+            </a:solidFill>
+          </a:ln>
+        </p:spPr>
+        <p:style>
+          <a:lnRef idx="1">
+            <a:schemeClr val="accent1"/>
+          </a:lnRef>
+          <a:fillRef idx="3">
+            <a:schemeClr val="accent1"/>
+          </a:fillRef>
+          <a:effectRef idx="2">
+            <a:schemeClr val="accent1"/>
+          </a:effectRef>
+          <a:fontRef idx="minor">
+            <a:schemeClr val="lt1"/>
+          </a:fontRef>
+        </p:style>
+        <p:txBody>
+          <a:bodyPr rtlCol="0" anchor="ctr"/>
+          <a:lstStyle/>
+          <a:p>
+            <a:pPr algn="ctr"/>
+          </a:p>
+        </p:txBody>
+      </p:sp>
+      <p:sp>
+        <p:nvSpPr>
+          <p:cNvPr id="23" name="TextBox 22"/>
+          <p:cNvSpPr txBox="1"/>
+          <p:nvPr/>
+        </p:nvSpPr>
+        <p:spPr>
+          <a:xfrm>
+            <a:off x="7004303" y="3118104"/>
+            <a:ext cx="1627632" cy="640080"/>
+          </a:xfrm>
+          <a:prstGeom prst="rect">
+            <a:avLst/>
+          </a:prstGeom>
+          <a:noFill/>
+        </p:spPr>
+        <p:txBody>
+          <a:bodyPr wrap="square">
+            <a:spAutoFit/>
+          </a:bodyPr>
+          <a:lstStyle/>
+          <a:p>
+            <a:r>
+              <a:rPr sz="1200" b="1">
+                <a:solidFill>
+                  <a:srgbClr val="F59E0B"/>
+                </a:solidFill>
+                <a:latin typeface="微软雅黑"/>
+                <ns12:rFonts xmlns:ns12="http://schemas.openxmlformats.org/wordprocessingml/2006/main" ns12:eastAsia="微软雅黑" ns12:ascii="微软雅黑" ns12:hAnsi="微软雅黑"/>
+              </a:rPr>
+              <a:t>③ 竖直速度 vy</a:t>
+            </a:r>
+          </a:p>
+          <a:p>
+            <a:pPr>
+              <a:spcBef>
+                <a:spcPts val="300"/>
+              </a:spcBef>
+            </a:pPr>
+            <a:r>
+              <a:rPr sz="1100" b="0">
+                <a:solidFill>
+                  <a:srgbClr val="143278"/>
+                </a:solidFill>
+                <a:latin typeface="微软雅黑"/>
+                <ns13:rFonts xmlns:ns13="http://schemas.openxmlformats.org/wordprocessingml/2006/main" ns13:eastAsia="微软雅黑" ns13:ascii="微软雅黑" ns13:hAnsi="微软雅黑"/>
+              </a:rPr>
+              <a:t>关键点整体下移超阈 → 判定跌倒</a:t>
             </a:r>
           </a:p>
         </p:txBody>
@@ -12712,8 +13201,8 @@
         </p:nvSpPr>
         <p:spPr>
           <a:xfrm>
-            <a:off x="4308652" y="1188926"/>
-            <a:ext cx="4321454" cy="3140550"/>
+            <a:off x="4308652" y="1328651"/>
+            <a:ext cx="4321454" cy="2861100"/>
           </a:xfrm>
           <a:prstGeom prst="rect">
             <a:avLst/>
@@ -12765,8 +13254,8 @@
         </p:blipFill>
         <p:spPr>
           <a:xfrm>
-            <a:off x="4345228" y="1225502"/>
-            <a:ext cx="4248302" cy="3067398"/>
+            <a:off x="4345228" y="1365227"/>
+            <a:ext cx="4248302" cy="2787948"/>
           </a:xfrm>
           <a:prstGeom prst="rect">
             <a:avLst/>
@@ -15663,8 +16152,8 @@
         </p:nvSpPr>
         <p:spPr>
           <a:xfrm>
-            <a:off x="4325517" y="1151595"/>
-            <a:ext cx="4287724" cy="3215213"/>
+            <a:off x="4760077" y="1151595"/>
+            <a:ext cx="3418605" cy="3215213"/>
           </a:xfrm>
           <a:prstGeom prst="rect">
             <a:avLst/>
@@ -15716,8 +16205,8 @@
         </p:blipFill>
         <p:spPr>
           <a:xfrm>
-            <a:off x="4362093" y="1188171"/>
-            <a:ext cx="4214572" cy="3142061"/>
+            <a:off x="4796653" y="1188171"/>
+            <a:ext cx="3345453" cy="3142061"/>
           </a:xfrm>
           <a:prstGeom prst="rect">
             <a:avLst/>
@@ -17471,8 +17960,8 @@
         </p:blipFill>
         <p:spPr>
           <a:xfrm>
-            <a:off x="4362602" y="1390802"/>
-            <a:ext cx="1168603" cy="1168603"/>
+            <a:off x="4300880" y="1379372"/>
+            <a:ext cx="1292047" cy="1292047"/>
           </a:xfrm>
           <a:prstGeom prst="rect">
             <a:avLst/>
@@ -17487,7 +17976,7 @@
         </p:nvSpPr>
         <p:spPr>
           <a:xfrm>
-            <a:off x="4160520" y="2679191"/>
+            <a:off x="4160520" y="2798063"/>
             <a:ext cx="1572768" cy="219456"/>
           </a:xfrm>
           <a:prstGeom prst="rect">
@@ -17531,8 +18020,8 @@
         </p:blipFill>
         <p:spPr>
           <a:xfrm>
-            <a:off x="6007150" y="2006665"/>
-            <a:ext cx="2625242" cy="1358768"/>
+            <a:off x="6036320" y="1957755"/>
+            <a:ext cx="2566903" cy="1328573"/>
           </a:xfrm>
           <a:prstGeom prst="rect">
             <a:avLst/>
@@ -17547,7 +18036,7 @@
         </p:nvSpPr>
         <p:spPr>
           <a:xfrm>
-            <a:off x="5861303" y="4329684"/>
+            <a:off x="5861303" y="4192524"/>
             <a:ext cx="2916936" cy="219456"/>
           </a:xfrm>
           <a:prstGeom prst="rect">
@@ -21934,7 +22423,7 @@
               </a:spcAft>
             </a:pPr>
             <a:r>
-              <a:rPr sz="1200" b="0">
+              <a:rPr sz="1300" b="0">
                 <a:solidFill>
                   <a:srgbClr val="1C202C"/>
                 </a:solidFill>
@@ -21977,7 +22466,7 @@
               </a:spcAft>
             </a:pPr>
             <a:r>
-              <a:rPr sz="1200" b="0">
+              <a:rPr sz="1300" b="0">
                 <a:solidFill>
                   <a:srgbClr val="1C202C"/>
                 </a:solidFill>
@@ -22020,7 +22509,7 @@
               </a:spcAft>
             </a:pPr>
             <a:r>
-              <a:rPr sz="1200" b="0">
+              <a:rPr sz="1300" b="0">
                 <a:solidFill>
                   <a:srgbClr val="1C202C"/>
                 </a:solidFill>
@@ -22063,7 +22552,7 @@
               </a:spcAft>
             </a:pPr>
             <a:r>
-              <a:rPr sz="1200" b="0">
+              <a:rPr sz="1300" b="0">
                 <a:solidFill>
                   <a:srgbClr val="1C202C"/>
                 </a:solidFill>
@@ -22199,9 +22688,97 @@
           </a:p>
         </p:txBody>
       </p:sp>
+      <p:sp>
+        <p:nvSpPr>
+          <p:cNvPr id="17" name="Rectangle 16"/>
+          <p:cNvSpPr/>
+          <p:nvPr/>
+        </p:nvSpPr>
+        <p:spPr>
+          <a:xfrm>
+            <a:off x="3968496" y="996696"/>
+            <a:ext cx="10972" cy="3854196"/>
+          </a:xfrm>
+          <a:prstGeom prst="rect">
+            <a:avLst/>
+          </a:prstGeom>
+          <a:solidFill>
+            <a:srgbClr val="BAC8DC"/>
+          </a:solidFill>
+          <a:ln>
+            <a:noFill/>
+          </a:ln>
+        </p:spPr>
+        <p:style>
+          <a:lnRef idx="1">
+            <a:schemeClr val="accent1"/>
+          </a:lnRef>
+          <a:fillRef idx="3">
+            <a:schemeClr val="accent1"/>
+          </a:fillRef>
+          <a:effectRef idx="2">
+            <a:schemeClr val="accent1"/>
+          </a:effectRef>
+          <a:fontRef idx="minor">
+            <a:schemeClr val="lt1"/>
+          </a:fontRef>
+        </p:style>
+        <p:txBody>
+          <a:bodyPr rtlCol="0" anchor="ctr"/>
+          <a:lstStyle/>
+          <a:p>
+            <a:pPr algn="ctr"/>
+          </a:p>
+        </p:txBody>
+      </p:sp>
+      <p:sp>
+        <p:nvSpPr>
+          <p:cNvPr id="18" name="Rectangle 17"/>
+          <p:cNvSpPr/>
+          <p:nvPr/>
+        </p:nvSpPr>
+        <p:spPr>
+          <a:xfrm>
+            <a:off x="4416594" y="1151595"/>
+            <a:ext cx="4105571" cy="3215213"/>
+          </a:xfrm>
+          <a:prstGeom prst="rect">
+            <a:avLst/>
+          </a:prstGeom>
+          <a:solidFill>
+            <a:srgbClr val="FCFDFF"/>
+          </a:solidFill>
+          <a:ln w="7620">
+            <a:solidFill>
+              <a:srgbClr val="BAC8DC"/>
+            </a:solidFill>
+          </a:ln>
+        </p:spPr>
+        <p:style>
+          <a:lnRef idx="1">
+            <a:schemeClr val="accent1"/>
+          </a:lnRef>
+          <a:fillRef idx="3">
+            <a:schemeClr val="accent1"/>
+          </a:fillRef>
+          <a:effectRef idx="2">
+            <a:schemeClr val="accent1"/>
+          </a:effectRef>
+          <a:fontRef idx="minor">
+            <a:schemeClr val="lt1"/>
+          </a:fontRef>
+        </p:style>
+        <p:txBody>
+          <a:bodyPr rtlCol="0" anchor="ctr"/>
+          <a:lstStyle/>
+          <a:p>
+            <a:pPr algn="ctr"/>
+          </a:p>
+        </p:txBody>
+      </p:sp>
       <p:pic>
         <p:nvPicPr>
-          <p:cNvPr id="17" name="Picture 16" descr="architecture_layers.png"/>
+          <p:cNvPr id="19" name="Picture 18" descr="project_goals_combo.png"/>
           <p:cNvPicPr>
             <a:picLocks noChangeAspect="1"/>
           </p:cNvPicPr>
@@ -22215,8 +22792,8 @@
         </p:blipFill>
         <p:spPr>
           <a:xfrm>
-            <a:off x="5473522" y="1104542"/>
-            <a:ext cx="1991714" cy="1407823"/>
+            <a:off x="4453170" y="1188171"/>
+            <a:ext cx="4032419" cy="3142061"/>
           </a:xfrm>
           <a:prstGeom prst="rect">
             <a:avLst/>
@@ -22225,13 +22802,13 @@
       </p:pic>
       <p:sp>
         <p:nvSpPr>
-          <p:cNvPr id="18" name="TextBox 17"/>
+          <p:cNvPr id="20" name="TextBox 19"/>
           <p:cNvSpPr txBox="1"/>
           <p:nvPr/>
         </p:nvSpPr>
         <p:spPr>
           <a:xfrm>
-            <a:off x="4160520" y="2620213"/>
+            <a:off x="4160520" y="4521708"/>
             <a:ext cx="4617720" cy="219456"/>
           </a:xfrm>
           <a:prstGeom prst="rect">
@@ -22254,67 +22831,7 @@
                 <a:latin typeface="微软雅黑"/>
                 <ns8:rFonts xmlns:ns8="http://schemas.openxmlformats.org/wordprocessingml/2006/main" ns8:eastAsia="微软雅黑" ns8:ascii="微软雅黑" ns8:hAnsi="微软雅黑"/>
               </a:rPr>
-              <a:t>四层架构</a:t>
-            </a:r>
-          </a:p>
-        </p:txBody>
-      </p:sp>
-      <p:pic>
-        <p:nvPicPr>
-          <p:cNvPr id="19" name="Picture 18" descr="state_machine.png"/>
-          <p:cNvPicPr>
-            <a:picLocks noChangeAspect="1"/>
-          </p:cNvPicPr>
-          <p:nvPr/>
-        </p:nvPicPr>
-        <p:blipFill>
-          <a:blip r:embed="rId3"/>
-          <a:stretch>
-            <a:fillRect/>
-          </a:stretch>
-        </p:blipFill>
-        <p:spPr>
-          <a:xfrm>
-            <a:off x="5457021" y="2885336"/>
-            <a:ext cx="2024716" cy="1407823"/>
-          </a:xfrm>
-          <a:prstGeom prst="rect">
-            <a:avLst/>
-          </a:prstGeom>
-        </p:spPr>
-      </p:pic>
-      <p:sp>
-        <p:nvSpPr>
-          <p:cNvPr id="20" name="TextBox 19"/>
-          <p:cNvSpPr txBox="1"/>
-          <p:nvPr/>
-        </p:nvSpPr>
-        <p:spPr>
-          <a:xfrm>
-            <a:off x="4160520" y="4401007"/>
-            <a:ext cx="4617720" cy="219456"/>
-          </a:xfrm>
-          <a:prstGeom prst="rect">
-            <a:avLst/>
-          </a:prstGeom>
-          <a:noFill/>
-        </p:spPr>
-        <p:txBody>
-          <a:bodyPr wrap="square" anchor="ctr">
-            <a:spAutoFit/>
-          </a:bodyPr>
-          <a:lstStyle/>
-          <a:p>
-            <a:pPr algn="ctr"/>
-            <a:r>
-              <a:rPr sz="800" b="0">
-                <a:solidFill>
-                  <a:srgbClr val="5A6273"/>
-                </a:solidFill>
-                <a:latin typeface="微软雅黑"/>
-                <ns9:rFonts xmlns:ns9="http://schemas.openxmlformats.org/wordprocessingml/2006/main" ns9:eastAsia="微软雅黑" ns9:ascii="微软雅黑" ns9:hAnsi="微软雅黑"/>
-              </a:rPr>
-              <a:t>状态机概览</a:t>
+              <a:t>架构与状态机总览</a:t>
             </a:r>
           </a:p>
         </p:txBody>

</xml_diff>

<commit_message>
fix: clean up PPT layout on slides 7/12/25/26/29
Use top-bar architecture diagram, rectangular fall flowchart, matplotlib
radar axis labels, tighter QR/thanks captions, and larger part-4 preview.

Co-authored-by: Cursor <cursoragent@cursor.com>
</commit_message>
<xml_diff>
--- a/docs/答辩_CareCompanion.pptx
+++ b/docs/答辩_CareCompanion.pptx
@@ -5754,8 +5754,8 @@
         </p:nvSpPr>
         <p:spPr>
           <a:xfrm>
-            <a:off x="4969110" y="1151595"/>
-            <a:ext cx="3000538" cy="3215213"/>
+            <a:off x="4673166" y="1151595"/>
+            <a:ext cx="3592426" cy="3215213"/>
           </a:xfrm>
           <a:prstGeom prst="rect">
             <a:avLst/>
@@ -5807,8 +5807,8 @@
         </p:blipFill>
         <p:spPr>
           <a:xfrm>
-            <a:off x="5005686" y="1188171"/>
-            <a:ext cx="2927386" cy="3142061"/>
+            <a:off x="4709742" y="1188171"/>
+            <a:ext cx="3519274" cy="3142061"/>
           </a:xfrm>
           <a:prstGeom prst="rect">
             <a:avLst/>
@@ -8741,8 +8741,8 @@
         </p:nvSpPr>
         <p:spPr>
           <a:xfrm>
-            <a:off x="4694986" y="1819631"/>
-            <a:ext cx="4097426" cy="2171748"/>
+            <a:off x="4503008" y="1719518"/>
+            <a:ext cx="4481382" cy="2371975"/>
           </a:xfrm>
           <a:prstGeom prst="rect">
             <a:avLst/>
@@ -8794,8 +8794,8 @@
         </p:blipFill>
         <p:spPr>
           <a:xfrm>
-            <a:off x="4731562" y="1856207"/>
-            <a:ext cx="4024274" cy="2098596"/>
+            <a:off x="4539584" y="1756094"/>
+            <a:ext cx="4408230" cy="2298823"/>
           </a:xfrm>
           <a:prstGeom prst="rect">
             <a:avLst/>
@@ -15430,8 +15430,8 @@
         </p:nvSpPr>
         <p:spPr>
           <a:xfrm>
-            <a:off x="4694986" y="2415020"/>
-            <a:ext cx="4097426" cy="980971"/>
+            <a:off x="4503008" y="1719518"/>
+            <a:ext cx="4481382" cy="2371975"/>
           </a:xfrm>
           <a:prstGeom prst="rect">
             <a:avLst/>
@@ -15469,7 +15469,7 @@
       </p:sp>
       <p:pic>
         <p:nvPicPr>
-          <p:cNvPr id="19" name="Picture 18" descr="ppt_robot_commands.png"/>
+          <p:cNvPr id="19" name="Picture 18" descr="ppt_full_dashboard.png"/>
           <p:cNvPicPr>
             <a:picLocks noChangeAspect="1"/>
           </p:cNvPicPr>
@@ -15483,8 +15483,8 @@
         </p:blipFill>
         <p:spPr>
           <a:xfrm>
-            <a:off x="4731562" y="2451596"/>
-            <a:ext cx="4024274" cy="907819"/>
+            <a:off x="4539584" y="1756094"/>
+            <a:ext cx="4408230" cy="2298823"/>
           </a:xfrm>
           <a:prstGeom prst="rect">
             <a:avLst/>
@@ -16152,8 +16152,8 @@
         </p:nvSpPr>
         <p:spPr>
           <a:xfrm>
-            <a:off x="4760077" y="1151595"/>
-            <a:ext cx="3418605" cy="3215213"/>
+            <a:off x="4875814" y="1151595"/>
+            <a:ext cx="3187131" cy="3215213"/>
           </a:xfrm>
           <a:prstGeom prst="rect">
             <a:avLst/>
@@ -16205,8 +16205,8 @@
         </p:blipFill>
         <p:spPr>
           <a:xfrm>
-            <a:off x="4796653" y="1188171"/>
-            <a:ext cx="3345453" cy="3142061"/>
+            <a:off x="4912390" y="1188171"/>
+            <a:ext cx="3113979" cy="3142061"/>
           </a:xfrm>
           <a:prstGeom prst="rect">
             <a:avLst/>
@@ -16244,7 +16244,7 @@
                 <a:latin typeface="微软雅黑"/>
                 <ns8:rFonts xmlns:ns8="http://schemas.openxmlformats.org/wordprocessingml/2006/main" ns8:eastAsia="微软雅黑" ns8:ascii="微软雅黑" ns8:hAnsi="微软雅黑"/>
               </a:rPr>
-              <a:t>创新维度自评</a:t>
+              <a:t>实验结果</a:t>
             </a:r>
           </a:p>
         </p:txBody>
@@ -17960,8 +17960,8 @@
         </p:blipFill>
         <p:spPr>
           <a:xfrm>
-            <a:off x="4300880" y="1379372"/>
-            <a:ext cx="1292047" cy="1292047"/>
+            <a:off x="4280306" y="1203350"/>
+            <a:ext cx="1388059" cy="1388059"/>
           </a:xfrm>
           <a:prstGeom prst="rect">
             <a:avLst/>
@@ -17976,8 +17976,8 @@
         </p:nvSpPr>
         <p:spPr>
           <a:xfrm>
-            <a:off x="4160520" y="2798063"/>
-            <a:ext cx="1572768" cy="219456"/>
+            <a:off x="4160520" y="2585923"/>
+            <a:ext cx="1627632" cy="219456"/>
           </a:xfrm>
           <a:prstGeom prst="rect">
             <a:avLst/>
@@ -17992,7 +17992,7 @@
           <a:p>
             <a:pPr algn="ctr"/>
             <a:r>
-              <a:rPr sz="800" b="0">
+              <a:rPr sz="900" b="0">
                 <a:solidFill>
                   <a:srgbClr val="5A6273"/>
                 </a:solidFill>
@@ -18020,8 +18020,8 @@
         </p:blipFill>
         <p:spPr>
           <a:xfrm>
-            <a:off x="6036320" y="1957755"/>
-            <a:ext cx="2566903" cy="1328573"/>
+            <a:off x="6019769" y="2012554"/>
+            <a:ext cx="2673156" cy="1383567"/>
           </a:xfrm>
           <a:prstGeom prst="rect">
             <a:avLst/>
@@ -18036,8 +18036,8 @@
         </p:nvSpPr>
         <p:spPr>
           <a:xfrm>
-            <a:off x="5861303" y="4192524"/>
-            <a:ext cx="2916936" cy="219456"/>
+            <a:off x="5934456" y="2581431"/>
+            <a:ext cx="2843783" cy="219456"/>
           </a:xfrm>
           <a:prstGeom prst="rect">
             <a:avLst/>
@@ -18052,7 +18052,7 @@
           <a:p>
             <a:pPr algn="ctr"/>
             <a:r>
-              <a:rPr sz="800" b="0">
+              <a:rPr sz="900" b="0">
                 <a:solidFill>
                   <a:srgbClr val="5A6273"/>
                 </a:solidFill>
@@ -19641,54 +19641,9 @@
           </a:p>
         </p:txBody>
       </p:sp>
-      <p:sp>
-        <p:nvSpPr>
-          <p:cNvPr id="11" name="Rectangle 10"/>
-          <p:cNvSpPr/>
-          <p:nvPr/>
-        </p:nvSpPr>
-        <p:spPr>
-          <a:xfrm>
-            <a:off x="2706110" y="3140964"/>
-            <a:ext cx="2177299" cy="1143000"/>
-          </a:xfrm>
-          <a:prstGeom prst="rect">
-            <a:avLst/>
-          </a:prstGeom>
-          <a:solidFill>
-            <a:srgbClr val="FCFDFF"/>
-          </a:solidFill>
-          <a:ln w="7620">
-            <a:solidFill>
-              <a:srgbClr val="BAC8DC"/>
-            </a:solidFill>
-          </a:ln>
-        </p:spPr>
-        <p:style>
-          <a:lnRef idx="1">
-            <a:schemeClr val="accent1"/>
-          </a:lnRef>
-          <a:fillRef idx="3">
-            <a:schemeClr val="accent1"/>
-          </a:fillRef>
-          <a:effectRef idx="2">
-            <a:schemeClr val="accent1"/>
-          </a:effectRef>
-          <a:fontRef idx="minor">
-            <a:schemeClr val="lt1"/>
-          </a:fontRef>
-        </p:style>
-        <p:txBody>
-          <a:bodyPr rtlCol="0" anchor="ctr"/>
-          <a:lstStyle/>
-          <a:p>
-            <a:pPr algn="ctr"/>
-          </a:p>
-        </p:txBody>
-      </p:sp>
       <p:pic>
         <p:nvPicPr>
-          <p:cNvPr id="12" name="Picture 11" descr="ppt_full_dashboard.png"/>
+          <p:cNvPr id="11" name="Picture 10" descr="ppt_full_dashboard.png"/>
           <p:cNvPicPr>
             <a:picLocks noChangeAspect="1"/>
           </p:cNvPicPr>
@@ -19702,8 +19657,8 @@
         </p:blipFill>
         <p:spPr>
           <a:xfrm>
-            <a:off x="2742686" y="3177540"/>
-            <a:ext cx="2104147" cy="1097280"/>
+            <a:off x="2645324" y="3116640"/>
+            <a:ext cx="2390311" cy="1246510"/>
           </a:xfrm>
           <a:prstGeom prst="rect">
             <a:avLst/>
@@ -19712,14 +19667,14 @@
       </p:pic>
       <p:sp>
         <p:nvSpPr>
-          <p:cNvPr id="13" name="TextBox 12"/>
+          <p:cNvPr id="12" name="TextBox 11"/>
           <p:cNvSpPr txBox="1"/>
           <p:nvPr/>
         </p:nvSpPr>
         <p:spPr>
           <a:xfrm>
-            <a:off x="2263139" y="4352544"/>
-            <a:ext cx="3063240" cy="219456"/>
+            <a:off x="2354580" y="4382902"/>
+            <a:ext cx="2971800" cy="219456"/>
           </a:xfrm>
           <a:prstGeom prst="rect">
             <a:avLst/>
@@ -19734,7 +19689,7 @@
           <a:p>
             <a:pPr algn="ctr"/>
             <a:r>
-              <a:rPr sz="800" b="0">
+              <a:rPr sz="900" b="0">
                 <a:solidFill>
                   <a:srgbClr val="5A6273"/>
                 </a:solidFill>
@@ -19748,7 +19703,7 @@
       </p:sp>
       <p:pic>
         <p:nvPicPr>
-          <p:cNvPr id="14" name="Picture 13" descr="ppt_demo_qr.png"/>
+          <p:cNvPr id="13" name="Picture 12" descr="ppt_demo_qr.png"/>
           <p:cNvPicPr>
             <a:picLocks noChangeAspect="1"/>
           </p:cNvPicPr>
@@ -19762,8 +19717,8 @@
         </p:blipFill>
         <p:spPr>
           <a:xfrm>
-            <a:off x="5783579" y="3246120"/>
-            <a:ext cx="960120" cy="960120"/>
+            <a:off x="5618988" y="3182112"/>
+            <a:ext cx="1170432" cy="1170432"/>
           </a:xfrm>
           <a:prstGeom prst="rect">
             <a:avLst/>
@@ -19772,14 +19727,14 @@
       </p:pic>
       <p:sp>
         <p:nvSpPr>
-          <p:cNvPr id="15" name="TextBox 14"/>
+          <p:cNvPr id="14" name="TextBox 13"/>
           <p:cNvSpPr txBox="1"/>
           <p:nvPr/>
         </p:nvSpPr>
         <p:spPr>
           <a:xfrm>
-            <a:off x="5646419" y="4261104"/>
-            <a:ext cx="1234440" cy="219456"/>
+            <a:off x="5618988" y="4361688"/>
+            <a:ext cx="1170432" cy="219456"/>
           </a:xfrm>
           <a:prstGeom prst="rect">
             <a:avLst/>
@@ -19794,14 +19749,14 @@
           <a:p>
             <a:pPr algn="ctr"/>
             <a:r>
-              <a:rPr sz="800" b="0">
+              <a:rPr sz="900" b="0">
                 <a:solidFill>
                   <a:srgbClr val="5A6273"/>
                 </a:solidFill>
                 <a:latin typeface="微软雅黑"/>
                 <ns8:rFonts xmlns:ns8="http://schemas.openxmlformats.org/wordprocessingml/2006/main" ns8:eastAsia="微软雅黑" ns8:ascii="微软雅黑" ns8:hAnsi="微软雅黑"/>
               </a:rPr>
-              <a:t>GitHub</a:t>
+              <a:t>GitHub 仓库</a:t>
             </a:r>
           </a:p>
         </p:txBody>
@@ -20472,8 +20427,8 @@
         </p:nvSpPr>
         <p:spPr>
           <a:xfrm>
-            <a:off x="4803525" y="1249756"/>
-            <a:ext cx="3880348" cy="3311499"/>
+            <a:off x="4613757" y="1088341"/>
+            <a:ext cx="4259885" cy="3634328"/>
           </a:xfrm>
           <a:prstGeom prst="rect">
             <a:avLst/>
@@ -20525,8 +20480,8 @@
         </p:blipFill>
         <p:spPr>
           <a:xfrm>
-            <a:off x="4840101" y="1286332"/>
-            <a:ext cx="3807196" cy="3238347"/>
+            <a:off x="4650333" y="1124917"/>
+            <a:ext cx="4186733" cy="3561176"/>
           </a:xfrm>
           <a:prstGeom prst="rect">
             <a:avLst/>
@@ -22739,8 +22694,8 @@
         </p:nvSpPr>
         <p:spPr>
           <a:xfrm>
-            <a:off x="4416594" y="1151595"/>
-            <a:ext cx="4105571" cy="3215213"/>
+            <a:off x="4308652" y="1161748"/>
+            <a:ext cx="4321454" cy="3194907"/>
           </a:xfrm>
           <a:prstGeom prst="rect">
             <a:avLst/>
@@ -22792,8 +22747,8 @@
         </p:blipFill>
         <p:spPr>
           <a:xfrm>
-            <a:off x="4453170" y="1188171"/>
-            <a:ext cx="4032419" cy="3142061"/>
+            <a:off x="4345228" y="1198324"/>
+            <a:ext cx="4248302" cy="3121755"/>
           </a:xfrm>
           <a:prstGeom prst="rect">
             <a:avLst/>
@@ -23502,8 +23457,8 @@
         </p:nvSpPr>
         <p:spPr>
           <a:xfrm>
-            <a:off x="4694986" y="1375751"/>
-            <a:ext cx="4097426" cy="3059508"/>
+            <a:off x="4503008" y="1233287"/>
+            <a:ext cx="4481382" cy="3344436"/>
           </a:xfrm>
           <a:prstGeom prst="rect">
             <a:avLst/>
@@ -23555,8 +23510,8 @@
         </p:blipFill>
         <p:spPr>
           <a:xfrm>
-            <a:off x="4731562" y="1412327"/>
-            <a:ext cx="4024274" cy="2986356"/>
+            <a:off x="4539584" y="1269863"/>
+            <a:ext cx="4408230" cy="3271284"/>
           </a:xfrm>
           <a:prstGeom prst="rect">
             <a:avLst/>

</xml_diff>

<commit_message>
fix: PPT architecture layers, state machine, screenshots, innovation chart
Separate layer title/subtitle spacing, redraw state machine in Chinese,
enlarge duo screenshots with top-aligned captions, replace clipped radar
with horizontal bar chart, and disable trim on combo figure.

Co-authored-by: Cursor <cursoragent@cursor.com>
</commit_message>
<xml_diff>
--- a/docs/答辩_CareCompanion.pptx
+++ b/docs/答辩_CareCompanion.pptx
@@ -4324,8 +4324,8 @@
         </p:nvSpPr>
         <p:spPr>
           <a:xfrm>
-            <a:off x="4308652" y="1245662"/>
-            <a:ext cx="4321454" cy="3027078"/>
+            <a:off x="4308652" y="1168319"/>
+            <a:ext cx="4321454" cy="3181765"/>
           </a:xfrm>
           <a:prstGeom prst="rect">
             <a:avLst/>
@@ -4377,8 +4377,8 @@
         </p:blipFill>
         <p:spPr>
           <a:xfrm>
-            <a:off x="4345228" y="1282238"/>
-            <a:ext cx="4248302" cy="2953926"/>
+            <a:off x="4345228" y="1204895"/>
+            <a:ext cx="4248302" cy="3108613"/>
           </a:xfrm>
           <a:prstGeom prst="rect">
             <a:avLst/>
@@ -5039,8 +5039,8 @@
         </p:nvSpPr>
         <p:spPr>
           <a:xfrm>
-            <a:off x="4315756" y="1151595"/>
-            <a:ext cx="4307247" cy="3215213"/>
+            <a:off x="4317727" y="1151595"/>
+            <a:ext cx="4303304" cy="3215213"/>
           </a:xfrm>
           <a:prstGeom prst="rect">
             <a:avLst/>
@@ -5092,8 +5092,8 @@
         </p:blipFill>
         <p:spPr>
           <a:xfrm>
-            <a:off x="4352332" y="1188171"/>
-            <a:ext cx="4234095" cy="3142061"/>
+            <a:off x="4354303" y="1188171"/>
+            <a:ext cx="4230152" cy="3142061"/>
           </a:xfrm>
           <a:prstGeom prst="rect">
             <a:avLst/>
@@ -5754,8 +5754,8 @@
         </p:nvSpPr>
         <p:spPr>
           <a:xfrm>
-            <a:off x="4673166" y="1151595"/>
-            <a:ext cx="3592426" cy="3215213"/>
+            <a:off x="4675239" y="1151595"/>
+            <a:ext cx="3588281" cy="3215213"/>
           </a:xfrm>
           <a:prstGeom prst="rect">
             <a:avLst/>
@@ -5807,8 +5807,8 @@
         </p:blipFill>
         <p:spPr>
           <a:xfrm>
-            <a:off x="4709742" y="1188171"/>
-            <a:ext cx="3519274" cy="3142061"/>
+            <a:off x="4711815" y="1188171"/>
+            <a:ext cx="3515129" cy="3142061"/>
           </a:xfrm>
           <a:prstGeom prst="rect">
             <a:avLst/>
@@ -6469,8 +6469,8 @@
         </p:nvSpPr>
         <p:spPr>
           <a:xfrm>
-            <a:off x="4540380" y="1151595"/>
-            <a:ext cx="3857998" cy="3215213"/>
+            <a:off x="4539971" y="1151595"/>
+            <a:ext cx="3858816" cy="3215213"/>
           </a:xfrm>
           <a:prstGeom prst="rect">
             <a:avLst/>
@@ -6522,8 +6522,8 @@
         </p:blipFill>
         <p:spPr>
           <a:xfrm>
-            <a:off x="4576956" y="1188171"/>
-            <a:ext cx="3784846" cy="3142061"/>
+            <a:off x="4576547" y="1188171"/>
+            <a:ext cx="3785664" cy="3142061"/>
           </a:xfrm>
           <a:prstGeom prst="rect">
             <a:avLst/>
@@ -7184,8 +7184,8 @@
         </p:nvSpPr>
         <p:spPr>
           <a:xfrm>
-            <a:off x="4308652" y="1539913"/>
-            <a:ext cx="4321454" cy="2438576"/>
+            <a:off x="4308652" y="1539215"/>
+            <a:ext cx="4321454" cy="2439973"/>
           </a:xfrm>
           <a:prstGeom prst="rect">
             <a:avLst/>
@@ -7237,8 +7237,8 @@
         </p:blipFill>
         <p:spPr>
           <a:xfrm>
-            <a:off x="4345228" y="1576489"/>
-            <a:ext cx="4248302" cy="2365424"/>
+            <a:off x="4345228" y="1575791"/>
+            <a:ext cx="4248302" cy="2366821"/>
           </a:xfrm>
           <a:prstGeom prst="rect">
             <a:avLst/>
@@ -7978,8 +7978,8 @@
         </p:nvSpPr>
         <p:spPr>
           <a:xfrm>
-            <a:off x="4308652" y="1302920"/>
-            <a:ext cx="4321454" cy="2912562"/>
+            <a:off x="4308652" y="1301375"/>
+            <a:ext cx="4321454" cy="2915652"/>
           </a:xfrm>
           <a:prstGeom prst="rect">
             <a:avLst/>
@@ -8031,8 +8031,8 @@
         </p:blipFill>
         <p:spPr>
           <a:xfrm>
-            <a:off x="4345228" y="1339496"/>
-            <a:ext cx="4248302" cy="2839410"/>
+            <a:off x="4345228" y="1337951"/>
+            <a:ext cx="4248302" cy="2842500"/>
           </a:xfrm>
           <a:prstGeom prst="rect">
             <a:avLst/>
@@ -10749,7 +10749,7 @@
         <p:spPr>
           <a:xfrm>
             <a:off x="274320" y="1033272"/>
-            <a:ext cx="4233672" cy="3781044"/>
+            <a:ext cx="4242816" cy="3799332"/>
           </a:xfrm>
           <a:prstGeom prst="rect">
             <a:avLst/>
@@ -10801,8 +10801,8 @@
         </p:blipFill>
         <p:spPr>
           <a:xfrm>
-            <a:off x="1035833" y="1191143"/>
-            <a:ext cx="2710644" cy="3227557"/>
+            <a:off x="960154" y="1078992"/>
+            <a:ext cx="2871146" cy="3418667"/>
           </a:xfrm>
           <a:prstGeom prst="rect">
             <a:avLst/>
@@ -10817,8 +10817,8 @@
         </p:nvSpPr>
         <p:spPr>
           <a:xfrm>
-            <a:off x="347472" y="4576572"/>
-            <a:ext cx="4087368" cy="219456"/>
+            <a:off x="320040" y="4543379"/>
+            <a:ext cx="4151376" cy="219456"/>
           </a:xfrm>
           <a:prstGeom prst="rect">
             <a:avLst/>
@@ -10833,7 +10833,7 @@
           <a:p>
             <a:pPr algn="ctr"/>
             <a:r>
-              <a:rPr sz="800" b="0">
+              <a:rPr sz="900" b="0">
                 <a:solidFill>
                   <a:srgbClr val="5A6273"/>
                 </a:solidFill>
@@ -10853,8 +10853,8 @@
         </p:nvSpPr>
         <p:spPr>
           <a:xfrm>
-            <a:off x="4636007" y="1033272"/>
-            <a:ext cx="4233672" cy="3781044"/>
+            <a:off x="4626864" y="1033272"/>
+            <a:ext cx="4242816" cy="3799332"/>
           </a:xfrm>
           <a:prstGeom prst="rect">
             <a:avLst/>
@@ -10906,8 +10906,8 @@
         </p:blipFill>
         <p:spPr>
           <a:xfrm>
-            <a:off x="4855588" y="1191143"/>
-            <a:ext cx="3794510" cy="3227557"/>
+            <a:off x="4738676" y="1078992"/>
+            <a:ext cx="4019190" cy="3418667"/>
           </a:xfrm>
           <a:prstGeom prst="rect">
             <a:avLst/>
@@ -10922,8 +10922,8 @@
         </p:nvSpPr>
         <p:spPr>
           <a:xfrm>
-            <a:off x="4709159" y="4576572"/>
-            <a:ext cx="4087368" cy="219456"/>
+            <a:off x="4672584" y="4543379"/>
+            <a:ext cx="4151376" cy="219456"/>
           </a:xfrm>
           <a:prstGeom prst="rect">
             <a:avLst/>
@@ -10938,7 +10938,7 @@
           <a:p>
             <a:pPr algn="ctr"/>
             <a:r>
-              <a:rPr sz="800" b="0">
+              <a:rPr sz="900" b="0">
                 <a:solidFill>
                   <a:srgbClr val="5A6273"/>
                 </a:solidFill>
@@ -11936,7 +11936,7 @@
         <p:spPr>
           <a:xfrm>
             <a:off x="274320" y="1033272"/>
-            <a:ext cx="4233672" cy="3781044"/>
+            <a:ext cx="4242816" cy="3799332"/>
           </a:xfrm>
           <a:prstGeom prst="rect">
             <a:avLst/>
@@ -11988,8 +11988,8 @@
         </p:blipFill>
         <p:spPr>
           <a:xfrm>
-            <a:off x="470093" y="1771225"/>
-            <a:ext cx="3842125" cy="2067393"/>
+            <a:off x="361553" y="1078992"/>
+            <a:ext cx="4068348" cy="2189121"/>
           </a:xfrm>
           <a:prstGeom prst="rect">
             <a:avLst/>
@@ -12004,8 +12004,8 @@
         </p:nvSpPr>
         <p:spPr>
           <a:xfrm>
-            <a:off x="347472" y="4576572"/>
-            <a:ext cx="4087368" cy="219456"/>
+            <a:off x="320040" y="3313833"/>
+            <a:ext cx="4151376" cy="219456"/>
           </a:xfrm>
           <a:prstGeom prst="rect">
             <a:avLst/>
@@ -12020,7 +12020,7 @@
           <a:p>
             <a:pPr algn="ctr"/>
             <a:r>
-              <a:rPr sz="800" b="0">
+              <a:rPr sz="900" b="0">
                 <a:solidFill>
                   <a:srgbClr val="5A6273"/>
                 </a:solidFill>
@@ -12040,8 +12040,8 @@
         </p:nvSpPr>
         <p:spPr>
           <a:xfrm>
-            <a:off x="4636007" y="1033272"/>
-            <a:ext cx="4233672" cy="3781044"/>
+            <a:off x="4626864" y="1033272"/>
+            <a:ext cx="4242816" cy="3799332"/>
           </a:xfrm>
           <a:prstGeom prst="rect">
             <a:avLst/>
@@ -12093,8 +12093,8 @@
         </p:blipFill>
         <p:spPr>
           <a:xfrm>
-            <a:off x="4831781" y="2371557"/>
-            <a:ext cx="3842125" cy="866729"/>
+            <a:off x="4714097" y="1078992"/>
+            <a:ext cx="4068348" cy="917762"/>
           </a:xfrm>
           <a:prstGeom prst="rect">
             <a:avLst/>
@@ -12109,8 +12109,8 @@
         </p:nvSpPr>
         <p:spPr>
           <a:xfrm>
-            <a:off x="4709159" y="4576572"/>
-            <a:ext cx="4087368" cy="219456"/>
+            <a:off x="4672584" y="2042474"/>
+            <a:ext cx="4151376" cy="219456"/>
           </a:xfrm>
           <a:prstGeom prst="rect">
             <a:avLst/>
@@ -12125,7 +12125,7 @@
           <a:p>
             <a:pPr algn="ctr"/>
             <a:r>
-              <a:rPr sz="800" b="0">
+              <a:rPr sz="900" b="0">
                 <a:solidFill>
                   <a:srgbClr val="5A6273"/>
                 </a:solidFill>
@@ -16152,8 +16152,8 @@
         </p:nvSpPr>
         <p:spPr>
           <a:xfrm>
-            <a:off x="4875814" y="1151595"/>
-            <a:ext cx="3187131" cy="3215213"/>
+            <a:off x="4308652" y="1202355"/>
+            <a:ext cx="4321454" cy="3113692"/>
           </a:xfrm>
           <a:prstGeom prst="rect">
             <a:avLst/>
@@ -16205,8 +16205,8 @@
         </p:blipFill>
         <p:spPr>
           <a:xfrm>
-            <a:off x="4912390" y="1188171"/>
-            <a:ext cx="3113979" cy="3142061"/>
+            <a:off x="4345228" y="1238931"/>
+            <a:ext cx="4248302" cy="3040540"/>
           </a:xfrm>
           <a:prstGeom prst="rect">
             <a:avLst/>
@@ -16910,8 +16910,8 @@
         </p:nvSpPr>
         <p:spPr>
           <a:xfrm>
-            <a:off x="4308652" y="1183788"/>
-            <a:ext cx="4321454" cy="3150826"/>
+            <a:off x="4308652" y="1186781"/>
+            <a:ext cx="4321454" cy="3144841"/>
           </a:xfrm>
           <a:prstGeom prst="rect">
             <a:avLst/>
@@ -16963,8 +16963,8 @@
         </p:blipFill>
         <p:spPr>
           <a:xfrm>
-            <a:off x="4345228" y="1220364"/>
-            <a:ext cx="4248302" cy="3077674"/>
+            <a:off x="4345228" y="1223357"/>
+            <a:ext cx="4248302" cy="3071689"/>
           </a:xfrm>
           <a:prstGeom prst="rect">
             <a:avLst/>
@@ -17960,8 +17960,8 @@
         </p:blipFill>
         <p:spPr>
           <a:xfrm>
-            <a:off x="4280306" y="1203350"/>
-            <a:ext cx="1388059" cy="1388059"/>
+            <a:off x="4287393" y="1124712"/>
+            <a:ext cx="1346454" cy="1346454"/>
           </a:xfrm>
           <a:prstGeom prst="rect">
             <a:avLst/>
@@ -17976,8 +17976,8 @@
         </p:nvSpPr>
         <p:spPr>
           <a:xfrm>
-            <a:off x="4160520" y="2585923"/>
-            <a:ext cx="1627632" cy="219456"/>
+            <a:off x="4160520" y="2507742"/>
+            <a:ext cx="1600200" cy="219456"/>
           </a:xfrm>
           <a:prstGeom prst="rect">
             <a:avLst/>
@@ -18020,8 +18020,8 @@
         </p:blipFill>
         <p:spPr>
           <a:xfrm>
-            <a:off x="6019769" y="2012554"/>
-            <a:ext cx="2673156" cy="1383567"/>
+            <a:off x="5935736" y="1124712"/>
+            <a:ext cx="2813791" cy="1456357"/>
           </a:xfrm>
           <a:prstGeom prst="rect">
             <a:avLst/>
@@ -18036,8 +18036,8 @@
         </p:nvSpPr>
         <p:spPr>
           <a:xfrm>
-            <a:off x="5934456" y="2581431"/>
-            <a:ext cx="2843783" cy="219456"/>
+            <a:off x="5907024" y="2617645"/>
+            <a:ext cx="2871215" cy="219456"/>
           </a:xfrm>
           <a:prstGeom prst="rect">
             <a:avLst/>
@@ -19657,7 +19657,7 @@
         </p:blipFill>
         <p:spPr>
           <a:xfrm>
-            <a:off x="2645324" y="3116640"/>
+            <a:off x="2645324" y="3090672"/>
             <a:ext cx="2390311" cy="1246510"/>
           </a:xfrm>
           <a:prstGeom prst="rect">
@@ -19717,7 +19717,7 @@
         </p:blipFill>
         <p:spPr>
           <a:xfrm>
-            <a:off x="5618988" y="3182112"/>
+            <a:off x="5618988" y="3145536"/>
             <a:ext cx="1170432" cy="1170432"/>
           </a:xfrm>
           <a:prstGeom prst="rect">
@@ -21185,8 +21185,8 @@
         </p:nvSpPr>
         <p:spPr>
           <a:xfrm>
-            <a:off x="4308652" y="1223033"/>
-            <a:ext cx="4321454" cy="3072336"/>
+            <a:off x="4308652" y="1222555"/>
+            <a:ext cx="4321454" cy="3073292"/>
           </a:xfrm>
           <a:prstGeom prst="rect">
             <a:avLst/>
@@ -21238,8 +21238,8 @@
         </p:blipFill>
         <p:spPr>
           <a:xfrm>
-            <a:off x="4345228" y="1259609"/>
-            <a:ext cx="4248302" cy="2999184"/>
+            <a:off x="4345228" y="1259131"/>
+            <a:ext cx="4248302" cy="3000140"/>
           </a:xfrm>
           <a:prstGeom prst="rect">
             <a:avLst/>
@@ -22694,8 +22694,8 @@
         </p:nvSpPr>
         <p:spPr>
           <a:xfrm>
-            <a:off x="4308652" y="1161748"/>
-            <a:ext cx="4321454" cy="3194907"/>
+            <a:off x="4330280" y="1151595"/>
+            <a:ext cx="4278199" cy="3215213"/>
           </a:xfrm>
           <a:prstGeom prst="rect">
             <a:avLst/>
@@ -22747,8 +22747,8 @@
         </p:blipFill>
         <p:spPr>
           <a:xfrm>
-            <a:off x="4345228" y="1198324"/>
-            <a:ext cx="4248302" cy="3121755"/>
+            <a:off x="4366856" y="1188171"/>
+            <a:ext cx="4205047" cy="3142061"/>
           </a:xfrm>
           <a:prstGeom prst="rect">
             <a:avLst/>
@@ -23457,8 +23457,8 @@
         </p:nvSpPr>
         <p:spPr>
           <a:xfrm>
-            <a:off x="4503008" y="1233287"/>
-            <a:ext cx="4481382" cy="3344436"/>
+            <a:off x="4503008" y="1231763"/>
+            <a:ext cx="4481382" cy="3347485"/>
           </a:xfrm>
           <a:prstGeom prst="rect">
             <a:avLst/>
@@ -23510,8 +23510,8 @@
         </p:blipFill>
         <p:spPr>
           <a:xfrm>
-            <a:off x="4539584" y="1269863"/>
-            <a:ext cx="4408230" cy="3271284"/>
+            <a:off x="4539584" y="1268339"/>
+            <a:ext cx="4408230" cy="3274333"/>
           </a:xfrm>
           <a:prstGeom prst="rect">
             <a:avLst/>

</xml_diff>

<commit_message>
fix: final PPT layout — layer text columns, centered media blocks
Prevent architecture title/subtitle overlap with side-by-side text and
correct vertical stacking under the orchestrator bar; center each
screenshot/QR column as image+caption unit in the panel.

Co-authored-by: Cursor <cursoragent@cursor.com>
</commit_message>
<xml_diff>
--- a/docs/答辩_CareCompanion.pptx
+++ b/docs/答辩_CareCompanion.pptx
@@ -10801,8 +10801,8 @@
         </p:blipFill>
         <p:spPr>
           <a:xfrm>
-            <a:off x="960154" y="1078992"/>
-            <a:ext cx="2871146" cy="3418667"/>
+            <a:off x="961575" y="1088136"/>
+            <a:ext cx="2868304" cy="3415284"/>
           </a:xfrm>
           <a:prstGeom prst="rect">
             <a:avLst/>
@@ -10817,7 +10817,7 @@
         </p:nvSpPr>
         <p:spPr>
           <a:xfrm>
-            <a:off x="320040" y="4543379"/>
+            <a:off x="320040" y="4558284"/>
             <a:ext cx="4151376" cy="219456"/>
           </a:xfrm>
           <a:prstGeom prst="rect">
@@ -10906,8 +10906,8 @@
         </p:blipFill>
         <p:spPr>
           <a:xfrm>
-            <a:off x="4738676" y="1078992"/>
-            <a:ext cx="4019190" cy="3418667"/>
+            <a:off x="4740665" y="1088136"/>
+            <a:ext cx="4015213" cy="3415284"/>
           </a:xfrm>
           <a:prstGeom prst="rect">
             <a:avLst/>
@@ -10922,7 +10922,7 @@
         </p:nvSpPr>
         <p:spPr>
           <a:xfrm>
-            <a:off x="4672584" y="4543379"/>
+            <a:off x="4672584" y="4558284"/>
             <a:ext cx="4151376" cy="219456"/>
           </a:xfrm>
           <a:prstGeom prst="rect">
@@ -11988,7 +11988,7 @@
         </p:blipFill>
         <p:spPr>
           <a:xfrm>
-            <a:off x="361553" y="1078992"/>
+            <a:off x="361553" y="1701217"/>
             <a:ext cx="4068348" cy="2189121"/>
           </a:xfrm>
           <a:prstGeom prst="rect">
@@ -12004,7 +12004,7 @@
         </p:nvSpPr>
         <p:spPr>
           <a:xfrm>
-            <a:off x="320040" y="3313833"/>
+            <a:off x="320040" y="3945202"/>
             <a:ext cx="4151376" cy="219456"/>
           </a:xfrm>
           <a:prstGeom prst="rect">
@@ -12093,7 +12093,7 @@
         </p:blipFill>
         <p:spPr>
           <a:xfrm>
-            <a:off x="4714097" y="1078992"/>
+            <a:off x="4714097" y="2336896"/>
             <a:ext cx="4068348" cy="917762"/>
           </a:xfrm>
           <a:prstGeom prst="rect">
@@ -12109,7 +12109,7 @@
         </p:nvSpPr>
         <p:spPr>
           <a:xfrm>
-            <a:off x="4672584" y="2042474"/>
+            <a:off x="4672584" y="3309523"/>
             <a:ext cx="4151376" cy="219456"/>
           </a:xfrm>
           <a:prstGeom prst="rect">
@@ -17960,8 +17960,8 @@
         </p:blipFill>
         <p:spPr>
           <a:xfrm>
-            <a:off x="4287393" y="1124712"/>
-            <a:ext cx="1346454" cy="1346454"/>
+            <a:off x="4193804" y="1987814"/>
+            <a:ext cx="1597639" cy="1597639"/>
           </a:xfrm>
           <a:prstGeom prst="rect">
             <a:avLst/>
@@ -17976,8 +17976,8 @@
         </p:nvSpPr>
         <p:spPr>
           <a:xfrm>
-            <a:off x="4160520" y="2507742"/>
-            <a:ext cx="1600200" cy="219456"/>
+            <a:off x="4160520" y="3640317"/>
+            <a:ext cx="1664208" cy="219456"/>
           </a:xfrm>
           <a:prstGeom prst="rect">
             <a:avLst/>
@@ -18020,8 +18020,8 @@
         </p:blipFill>
         <p:spPr>
           <a:xfrm>
-            <a:off x="5935736" y="1124712"/>
-            <a:ext cx="2813791" cy="1456357"/>
+            <a:off x="5980998" y="2070050"/>
+            <a:ext cx="2768986" cy="1433166"/>
           </a:xfrm>
           <a:prstGeom prst="rect">
             <a:avLst/>
@@ -18036,8 +18036,8 @@
         </p:nvSpPr>
         <p:spPr>
           <a:xfrm>
-            <a:off x="5907024" y="2617645"/>
-            <a:ext cx="2871215" cy="219456"/>
+            <a:off x="5952744" y="3558081"/>
+            <a:ext cx="2825495" cy="219456"/>
           </a:xfrm>
           <a:prstGeom prst="rect">
             <a:avLst/>
@@ -22694,8 +22694,8 @@
         </p:nvSpPr>
         <p:spPr>
           <a:xfrm>
-            <a:off x="4330280" y="1151595"/>
-            <a:ext cx="4278199" cy="3215213"/>
+            <a:off x="4328389" y="1151595"/>
+            <a:ext cx="4281981" cy="3215213"/>
           </a:xfrm>
           <a:prstGeom prst="rect">
             <a:avLst/>
@@ -22747,8 +22747,8 @@
         </p:blipFill>
         <p:spPr>
           <a:xfrm>
-            <a:off x="4366856" y="1188171"/>
-            <a:ext cx="4205047" cy="3142061"/>
+            <a:off x="4364965" y="1188171"/>
+            <a:ext cx="4208829" cy="3142061"/>
           </a:xfrm>
           <a:prstGeom prst="rect">
             <a:avLst/>

</xml_diff>

<commit_message>
fix: enlarge architecture section in project goals combo figure
Give the top four-layer diagram ~62% of the figure height with larger
layer boxes and fonts; shrink the state machine panel accordingly.

Co-authored-by: Cursor <cursoragent@cursor.com>
</commit_message>
<xml_diff>
--- a/docs/答辩_CareCompanion.pptx
+++ b/docs/答辩_CareCompanion.pptx
@@ -22694,8 +22694,8 @@
         </p:nvSpPr>
         <p:spPr>
           <a:xfrm>
-            <a:off x="4328389" y="1151595"/>
-            <a:ext cx="4281981" cy="3215213"/>
+            <a:off x="4340636" y="1151595"/>
+            <a:ext cx="4257487" cy="3215213"/>
           </a:xfrm>
           <a:prstGeom prst="rect">
             <a:avLst/>
@@ -22747,8 +22747,8 @@
         </p:blipFill>
         <p:spPr>
           <a:xfrm>
-            <a:off x="4364965" y="1188171"/>
-            <a:ext cx="4208829" cy="3142061"/>
+            <a:off x="4377212" y="1188171"/>
+            <a:ext cx="4184335" cy="3142061"/>
           </a:xfrm>
           <a:prstGeom prst="rect">
             <a:avLst/>

</xml_diff>

<commit_message>
feat: add 30s scenario demo (Web + ROS2 JSONL + G1 merge)
One-shot run_full_scenario_demo.sh records robot_cmd timeline, renders
echo-style video, merges with Web fall clip and G1 locomotion; embed in PPT.
</commit_message>
<xml_diff>
--- a/docs/答辩_CareCompanion.pptx
+++ b/docs/答辩_CareCompanion.pptx
@@ -37,6 +37,7 @@
     <p:sldId id="285" r:id="rId36"/>
     <p:sldId id="286" r:id="rId37"/>
     <p:sldId id="287" r:id="rId38"/>
+    <p:sldId id="288" r:id="rId39"/>
   </p:sldIdLst>
   <p:sldSz cx="9144000" cy="5143500" type="screen4x3"/>
   <p:notesSz cx="6858000" cy="9144000"/>
@@ -12720,7 +12721,7 @@
                 <a:latin typeface="微软雅黑"/>
                 <ns2:rFonts xmlns:ns2="http://schemas.openxmlformats.org/wordprocessingml/2006/main" ns2:eastAsia="微软雅黑" ns2:ascii="微软雅黑" ns2:hAnsi="微软雅黑"/>
               </a:rPr>
-              <a:t>Web 全流程演示录像</a:t>
+              <a:t>情景剧总片（Web → ROS2 → G1）</a:t>
             </a:r>
           </a:p>
         </p:txBody>
@@ -12894,7 +12895,7 @@
                 <a:latin typeface="微软雅黑"/>
                 <ns3:rFonts xmlns:ns3="http://schemas.openxmlformats.org/wordprocessingml/2006/main" ns3:eastAsia="微软雅黑" ns3:ascii="微软雅黑" ns3:hAnsi="微软雅黑"/>
               </a:rPr>
-              <a:t>● 监测 → 老人倾诉 → 模拟跌倒 → 紧急流程</a:t>
+              <a:t>● 约 30 秒：跌倒紧急 → 指令下发 → 人形行走</a:t>
             </a:r>
           </a:p>
         </p:txBody>
@@ -12937,7 +12938,7 @@
                 <a:latin typeface="微软雅黑"/>
                 <ns4:rFonts xmlns:ns4="http://schemas.openxmlformats.org/wordprocessingml/2006/main" ns4:eastAsia="微软雅黑" ns4:ascii="微软雅黑" ns4:hAnsi="微软雅黑"/>
               </a:rPr>
-              <a:t>● 仓库内可离线播放，不依赖外网</a:t>
+              <a:t>● 决策层 / 通信层 / 执行层分层展示</a:t>
             </a:r>
           </a:p>
         </p:txBody>
@@ -12980,7 +12981,7 @@
                 <a:latin typeface="微软雅黑"/>
                 <ns5:rFonts xmlns:ns5="http://schemas.openxmlformats.org/wordprocessingml/2006/main" ns5:eastAsia="微软雅黑" ns5:ascii="微软雅黑" ns5:hAnsi="微软雅黑"/>
               </a:rPr>
-              <a:t>● 与现场 run_web.sh 操作一致</a:t>
+              <a:t>● 生成：bash scripts/run_full_scenario_demo.sh</a:t>
             </a:r>
           </a:p>
         </p:txBody>
@@ -13075,7 +13076,7 @@
       </p:sp>
       <p:pic>
         <p:nvPicPr>
-          <p:cNvPr id="15" name="demo_carecompanion.mp4">
+          <p:cNvPr id="15" name="demo_full_scenario.mp4">
             <a:hlinkClick r:id="" action="ppaction://media"/>
           </p:cNvPr>
           <p:cNvPicPr>
@@ -13137,7 +13138,7 @@
                 <a:latin typeface="微软雅黑"/>
                 <ns7:rFonts xmlns:ns7="http://schemas.openxmlformats.org/wordprocessingml/2006/main" ns7:eastAsia="微软雅黑" ns7:ascii="微软雅黑" ns7:hAnsi="微软雅黑"/>
               </a:rPr>
-              <a:t>demo_carecompanion.mp4</a:t>
+              <a:t>demo_full_scenario.mp4</a:t>
             </a:r>
           </a:p>
         </p:txBody>
@@ -13378,7 +13379,7 @@
                 <a:latin typeface="微软雅黑"/>
                 <ns2:rFonts xmlns:ns2="http://schemas.openxmlformats.org/wordprocessingml/2006/main" ns2:eastAsia="微软雅黑" ns2:ascii="微软雅黑" ns2:hAnsi="微软雅黑"/>
               </a:rPr>
-              <a:t>人形仿真行走（Isaac Lab · Unitree G1）</a:t>
+              <a:t>Web 全流程演示录像</a:t>
             </a:r>
           </a:p>
         </p:txBody>
@@ -13552,7 +13553,7 @@
                 <a:latin typeface="微软雅黑"/>
                 <ns3:rFonts xmlns:ns3="http://schemas.openxmlformats.org/wordprocessingml/2006/main" ns3:eastAsia="微软雅黑" ns3:ascii="微软雅黑" ns3:hAnsi="微软雅黑"/>
               </a:rPr>
-              <a:t>● Isaac Lab 平地速度跟踪预训练策略</a:t>
+              <a:t>● 监测 → 老人倾诉 → 模拟跌倒 → 紧急流程</a:t>
             </a:r>
           </a:p>
         </p:txBody>
@@ -13595,7 +13596,7 @@
                 <a:latin typeface="微软雅黑"/>
                 <ns4:rFonts xmlns:ns4="http://schemas.openxmlformats.org/wordprocessingml/2006/main" ns4:eastAsia="微软雅黑" ns4:ascii="微软雅黑" ns4:hAnsi="微软雅黑"/>
               </a:rPr>
-              <a:t>● 固定前进 0.8 m/s，世界坐标侧拍全身</a:t>
+              <a:t>● 仓库内可离线播放，不依赖外网</a:t>
             </a:r>
           </a:p>
         </p:txBody>
@@ -13638,7 +13639,7 @@
                 <a:latin typeface="微软雅黑"/>
                 <ns5:rFonts xmlns:ns5="http://schemas.openxmlformats.org/wordprocessingml/2006/main" ns5:eastAsia="微软雅黑" ns5:ascii="微软雅黑" ns5:hAnsi="微软雅黑"/>
               </a:rPr>
-              <a:t>● 录屏段位移约 6 m，关节持续摆动</a:t>
+              <a:t>● 与现场 run_web.sh 操作一致</a:t>
             </a:r>
           </a:p>
         </p:txBody>
@@ -13681,7 +13682,7 @@
                 <a:latin typeface="微软雅黑"/>
                 <ns6:rFonts xmlns:ns6="http://schemas.openxmlformats.org/wordprocessingml/2006/main" ns6:eastAsia="微软雅黑" ns6:ascii="微软雅黑" ns6:hAnsi="微软雅黑"/>
               </a:rPr>
-              <a:t>● 说明仿真层已对接，可扩展 ROS2 真机</a:t>
+              <a:t>● 右栏可全屏播放</a:t>
             </a:r>
           </a:p>
         </p:txBody>
@@ -13733,7 +13734,7 @@
       </p:sp>
       <p:pic>
         <p:nvPicPr>
-          <p:cNvPr id="15" name="demo_isaac_g1_locomotion.mp4">
+          <p:cNvPr id="15" name="demo_carecompanion.mp4">
             <a:hlinkClick r:id="" action="ppaction://media"/>
           </p:cNvPr>
           <p:cNvPicPr>
@@ -13795,7 +13796,7 @@
                 <a:latin typeface="微软雅黑"/>
                 <ns7:rFonts xmlns:ns7="http://schemas.openxmlformats.org/wordprocessingml/2006/main" ns7:eastAsia="微软雅黑" ns7:ascii="微软雅黑" ns7:hAnsi="微软雅黑"/>
               </a:rPr>
-              <a:t>demo_isaac_g1_locomotion.mp4</a:t>
+              <a:t>demo_carecompanion.mp4</a:t>
             </a:r>
           </a:p>
         </p:txBody>
@@ -14000,7 +14001,7 @@
                 <a:latin typeface="微软雅黑"/>
                 <ns1:rFonts xmlns:ns1="http://schemas.openxmlformats.org/wordprocessingml/2006/main" ns1:eastAsia="微软雅黑" ns1:ascii="微软雅黑" ns1:hAnsi="微软雅黑"/>
               </a:rPr>
-              <a:t>从容应队 · 中山大学 · 刘小凡/白冉 · 指导教师 彭键清</a:t>
+              <a:t>演示录像  |  从容应队 · 中山大学 · 刘小凡/白冉 · 指导教师 彭键清</a:t>
             </a:r>
           </a:p>
         </p:txBody>
@@ -14036,7 +14037,7 @@
                 <a:latin typeface="微软雅黑"/>
                 <ns2:rFonts xmlns:ns2="http://schemas.openxmlformats.org/wordprocessingml/2006/main" ns2:eastAsia="微软雅黑" ns2:ascii="微软雅黑" ns2:hAnsi="微软雅黑"/>
               </a:rPr>
-              <a:t>测试结果</a:t>
+              <a:t>人形仿真行走（Isaac Lab · Unitree G1）</a:t>
             </a:r>
           </a:p>
         </p:txBody>
@@ -14181,7 +14182,7 @@
         <p:spPr>
           <a:xfrm>
             <a:off x="438912" y="1106424"/>
-            <a:ext cx="3282696" cy="812673"/>
+            <a:ext cx="3282696" cy="890397"/>
           </a:xfrm>
           <a:prstGeom prst="rect">
             <a:avLst/>
@@ -14203,14 +14204,14 @@
               </a:spcAft>
             </a:pPr>
             <a:r>
-              <a:rPr sz="1300" b="0">
+              <a:rPr sz="1200" b="0">
                 <a:solidFill>
                   <a:srgbClr val="1C202C"/>
                 </a:solidFill>
                 <a:latin typeface="微软雅黑"/>
                 <ns3:rFonts xmlns:ns3="http://schemas.openxmlformats.org/wordprocessingml/2006/main" ns3:eastAsia="微软雅黑" ns3:ascii="微软雅黑" ns3:hAnsi="微软雅黑"/>
               </a:rPr>
-              <a:t>● 跌倒检测 P/R/F1：合成 6 场景均为 100%</a:t>
+              <a:t>● Isaac Lab 平地速度跟踪预训练策略</a:t>
             </a:r>
           </a:p>
         </p:txBody>
@@ -14223,8 +14224,8 @@
         </p:nvSpPr>
         <p:spPr>
           <a:xfrm>
-            <a:off x="438912" y="1937385"/>
-            <a:ext cx="3282696" cy="812673"/>
+            <a:off x="438912" y="2015109"/>
+            <a:ext cx="3282696" cy="890397"/>
           </a:xfrm>
           <a:prstGeom prst="rect">
             <a:avLst/>
@@ -14246,14 +14247,14 @@
               </a:spcAft>
             </a:pPr>
             <a:r>
-              <a:rPr sz="1300" b="0">
+              <a:rPr sz="1200" b="0">
                 <a:solidFill>
                   <a:srgbClr val="1C202C"/>
                 </a:solidFill>
                 <a:latin typeface="微软雅黑"/>
                 <ns4:rFonts xmlns:ns4="http://schemas.openxmlformats.org/wordprocessingml/2006/main" ns4:eastAsia="微软雅黑" ns4:ascii="微软雅黑" ns4:hAnsi="微软雅黑"/>
               </a:rPr>
-              <a:t>● 紧急链路脚本跑通率 100%</a:t>
+              <a:t>● 固定前进 0.8 m/s，世界坐标侧拍全身</a:t>
             </a:r>
           </a:p>
         </p:txBody>
@@ -14266,8 +14267,8 @@
         </p:nvSpPr>
         <p:spPr>
           <a:xfrm>
-            <a:off x="438912" y="2768346"/>
-            <a:ext cx="3282696" cy="812673"/>
+            <a:off x="438912" y="2923794"/>
+            <a:ext cx="3282696" cy="890397"/>
           </a:xfrm>
           <a:prstGeom prst="rect">
             <a:avLst/>
@@ -14289,14 +14290,14 @@
               </a:spcAft>
             </a:pPr>
             <a:r>
-              <a:rPr sz="1300" b="0">
+              <a:rPr sz="1200" b="0">
                 <a:solidFill>
                   <a:srgbClr val="1C202C"/>
                 </a:solidFill>
                 <a:latin typeface="微软雅黑"/>
                 <ns5:rFonts xmlns:ns5="http://schemas.openxmlformats.org/wordprocessingml/2006/main" ns5:eastAsia="微软雅黑" ns5:ascii="微软雅黑" ns5:hAnsi="微软雅黑"/>
               </a:rPr>
-              <a:t>● 单帧决策在 CPU 上 &lt; 50ms（见右下图）</a:t>
+              <a:t>● 录屏段位移约 6 m，关节持续摆动</a:t>
             </a:r>
           </a:p>
         </p:txBody>
@@ -14309,8 +14310,8 @@
         </p:nvSpPr>
         <p:spPr>
           <a:xfrm>
-            <a:off x="438912" y="3599307"/>
-            <a:ext cx="3282696" cy="812673"/>
+            <a:off x="438912" y="3832479"/>
+            <a:ext cx="3282696" cy="890397"/>
           </a:xfrm>
           <a:prstGeom prst="rect">
             <a:avLst/>
@@ -14332,14 +14333,14 @@
               </a:spcAft>
             </a:pPr>
             <a:r>
-              <a:rPr sz="1300" b="0">
+              <a:rPr sz="1200" b="0">
                 <a:solidFill>
                   <a:srgbClr val="1C202C"/>
                 </a:solidFill>
                 <a:latin typeface="微软雅黑"/>
                 <ns6:rFonts xmlns:ns6="http://schemas.openxmlformats.org/wordprocessingml/2006/main" ns6:eastAsia="微软雅黑" ns6:ascii="微软雅黑" ns6:hAnsi="微软雅黑"/>
               </a:rPr>
-              <a:t>● 单元测试和无头演示都过了</a:t>
+              <a:t>● 说明仿真层已对接，可扩展 ROS2 真机</a:t>
             </a:r>
           </a:p>
         </p:txBody>
@@ -14347,85 +14348,6 @@
       <p:sp>
         <p:nvSpPr>
           <p:cNvPr id="14" name="Rectangle 13"/>
-          <p:cNvSpPr/>
-          <p:nvPr/>
-        </p:nvSpPr>
-        <p:spPr>
-          <a:xfrm>
-            <a:off x="365760" y="4539996"/>
-            <a:ext cx="3429000" cy="292608"/>
-          </a:xfrm>
-          <a:prstGeom prst="rect">
-            <a:avLst/>
-          </a:prstGeom>
-          <a:solidFill>
-            <a:srgbClr val="143278"/>
-          </a:solidFill>
-          <a:ln>
-            <a:noFill/>
-          </a:ln>
-        </p:spPr>
-        <p:style>
-          <a:lnRef idx="1">
-            <a:schemeClr val="accent1"/>
-          </a:lnRef>
-          <a:fillRef idx="3">
-            <a:schemeClr val="accent1"/>
-          </a:fillRef>
-          <a:effectRef idx="2">
-            <a:schemeClr val="accent1"/>
-          </a:effectRef>
-          <a:fontRef idx="minor">
-            <a:schemeClr val="lt1"/>
-          </a:fontRef>
-        </p:style>
-        <p:txBody>
-          <a:bodyPr rtlCol="0" anchor="ctr"/>
-          <a:lstStyle/>
-          <a:p>
-            <a:pPr algn="ctr"/>
-          </a:p>
-        </p:txBody>
-      </p:sp>
-      <p:sp>
-        <p:nvSpPr>
-          <p:cNvPr id="15" name="TextBox 14"/>
-          <p:cNvSpPr txBox="1"/>
-          <p:nvPr/>
-        </p:nvSpPr>
-        <p:spPr>
-          <a:xfrm>
-            <a:off x="402336" y="4604004"/>
-            <a:ext cx="3355848" cy="182880"/>
-          </a:xfrm>
-          <a:prstGeom prst="rect">
-            <a:avLst/>
-          </a:prstGeom>
-          <a:noFill/>
-        </p:spPr>
-        <p:txBody>
-          <a:bodyPr wrap="none" anchor="ctr">
-            <a:spAutoFit/>
-          </a:bodyPr>
-          <a:lstStyle/>
-          <a:p>
-            <a:pPr algn="ctr"/>
-            <a:r>
-              <a:rPr sz="1100" b="1">
-                <a:solidFill>
-                  <a:srgbClr val="FFFFFF"/>
-                </a:solidFill>
-                <a:latin typeface="微软雅黑"/>
-                <ns7:rFonts xmlns:ns7="http://schemas.openxmlformats.org/wordprocessingml/2006/main" ns7:eastAsia="微软雅黑" ns7:ascii="微软雅黑" ns7:hAnsi="微软雅黑"/>
-              </a:rPr>
-              <a:t>数据：fall_eval_report.json</a:t>
-            </a:r>
-          </a:p>
-        </p:txBody>
-      </p:sp>
-      <p:sp>
-        <p:nvSpPr>
-          <p:cNvPr id="16" name="Rectangle 15"/>
           <p:cNvSpPr/>
           <p:nvPr/>
         </p:nvSpPr>
@@ -14468,112 +14390,33 @@
           </a:p>
         </p:txBody>
       </p:sp>
-      <p:sp>
-        <p:nvSpPr>
-          <p:cNvPr id="17" name="Rectangle 16"/>
-          <p:cNvSpPr/>
-          <p:nvPr/>
-        </p:nvSpPr>
-        <p:spPr>
-          <a:xfrm>
-            <a:off x="3968496" y="996696"/>
-            <a:ext cx="10972" cy="3854196"/>
-          </a:xfrm>
-          <a:prstGeom prst="rect">
-            <a:avLst/>
-          </a:prstGeom>
-          <a:solidFill>
-            <a:srgbClr val="BAC8DC"/>
-          </a:solidFill>
-          <a:ln>
-            <a:noFill/>
-          </a:ln>
-        </p:spPr>
-        <p:style>
-          <a:lnRef idx="1">
-            <a:schemeClr val="accent1"/>
-          </a:lnRef>
-          <a:fillRef idx="3">
-            <a:schemeClr val="accent1"/>
-          </a:fillRef>
-          <a:effectRef idx="2">
-            <a:schemeClr val="accent1"/>
-          </a:effectRef>
-          <a:fontRef idx="minor">
-            <a:schemeClr val="lt1"/>
-          </a:fontRef>
-        </p:style>
-        <p:txBody>
-          <a:bodyPr rtlCol="0" anchor="ctr"/>
-          <a:lstStyle/>
-          <a:p>
-            <a:pPr algn="ctr"/>
-          </a:p>
-        </p:txBody>
-      </p:sp>
-      <p:sp>
-        <p:nvSpPr>
-          <p:cNvPr id="18" name="Rectangle 17"/>
-          <p:cNvSpPr/>
-          <p:nvPr/>
-        </p:nvSpPr>
-        <p:spPr>
-          <a:xfrm>
-            <a:off x="4308652" y="1328651"/>
-            <a:ext cx="4321454" cy="2861100"/>
-          </a:xfrm>
-          <a:prstGeom prst="rect">
-            <a:avLst/>
-          </a:prstGeom>
-          <a:solidFill>
-            <a:srgbClr val="FCFDFF"/>
-          </a:solidFill>
-          <a:ln w="7620">
-            <a:solidFill>
-              <a:srgbClr val="BAC8DC"/>
-            </a:solidFill>
-          </a:ln>
-        </p:spPr>
-        <p:style>
-          <a:lnRef idx="1">
-            <a:schemeClr val="accent1"/>
-          </a:lnRef>
-          <a:fillRef idx="3">
-            <a:schemeClr val="accent1"/>
-          </a:fillRef>
-          <a:effectRef idx="2">
-            <a:schemeClr val="accent1"/>
-          </a:effectRef>
-          <a:fontRef idx="minor">
-            <a:schemeClr val="lt1"/>
-          </a:fontRef>
-        </p:style>
-        <p:txBody>
-          <a:bodyPr rtlCol="0" anchor="ctr"/>
-          <a:lstStyle/>
-          <a:p>
-            <a:pPr algn="ctr"/>
-          </a:p>
-        </p:txBody>
-      </p:sp>
       <p:pic>
         <p:nvPicPr>
-          <p:cNvPr id="19" name="Picture 18" descr="eval_results.png"/>
+          <p:cNvPr id="15" name="demo_isaac_g1_locomotion.mp4">
+            <a:hlinkClick r:id="" action="ppaction://media"/>
+          </p:cNvPr>
           <p:cNvPicPr>
             <a:picLocks noChangeAspect="1"/>
           </p:cNvPicPr>
-          <p:nvPr/>
+          <p:nvPr>
+            <a:videoFile r:link="rId3"/>
+            <p:extLst>
+              <p:ext uri="{DAA4B4D4-6D71-4841-9C94-3DE7FCFB9230}">
+                <p14:media xmlns:p14="http://schemas.microsoft.com/office/powerpoint/2010/main" r:embed="rId2"/>
+              </p:ext>
+            </p:extLst>
+          </p:nvPr>
         </p:nvPicPr>
         <p:blipFill>
-          <a:blip r:embed="rId2"/>
+          <a:blip r:embed="rId4"/>
           <a:stretch>
             <a:fillRect/>
           </a:stretch>
         </p:blipFill>
         <p:spPr>
           <a:xfrm>
-            <a:off x="4345228" y="1365227"/>
-            <a:ext cx="4248302" cy="2787948"/>
+            <a:off x="4160520" y="1106424"/>
+            <a:ext cx="4617720" cy="3396996"/>
           </a:xfrm>
           <a:prstGeom prst="rect">
             <a:avLst/>
@@ -14582,13 +14425,13 @@
       </p:pic>
       <p:sp>
         <p:nvSpPr>
-          <p:cNvPr id="20" name="TextBox 19"/>
+          <p:cNvPr id="16" name="TextBox 15"/>
           <p:cNvSpPr txBox="1"/>
           <p:nvPr/>
         </p:nvSpPr>
         <p:spPr>
           <a:xfrm>
-            <a:off x="4160520" y="4521708"/>
+            <a:off x="4160520" y="4539996"/>
             <a:ext cx="4617720" cy="219456"/>
           </a:xfrm>
           <a:prstGeom prst="rect">
@@ -14604,14 +14447,14 @@
           <a:p>
             <a:pPr algn="ctr"/>
             <a:r>
-              <a:rPr sz="800" b="0">
+              <a:rPr sz="900" b="0">
                 <a:solidFill>
                   <a:srgbClr val="5A6273"/>
                 </a:solidFill>
                 <a:latin typeface="微软雅黑"/>
-                <ns8:rFonts xmlns:ns8="http://schemas.openxmlformats.org/wordprocessingml/2006/main" ns8:eastAsia="微软雅黑" ns8:ascii="微软雅黑" ns8:hAnsi="微软雅黑"/>
-              </a:rPr>
-              <a:t>P/R/F1 均为 100%（见左栏）</a:t>
+                <ns7:rFonts xmlns:ns7="http://schemas.openxmlformats.org/wordprocessingml/2006/main" ns7:eastAsia="微软雅黑" ns7:ascii="微软雅黑" ns7:hAnsi="微软雅黑"/>
+              </a:rPr>
+              <a:t>demo_isaac_g1_locomotion.mp4</a:t>
             </a:r>
           </a:p>
         </p:txBody>
@@ -14621,6 +14464,28 @@
   <p:clrMapOvr>
     <a:masterClrMapping/>
   </p:clrMapOvr>
+  <p:timing>
+    <p:tnLst>
+      <p:par>
+        <p:cTn id="1" dur="indefinite" restart="never" nodeType="tmRoot">
+          <p:childTnLst>
+            <p:video>
+              <p:cMediaNode vol="80000">
+                <p:cTn id="2" fill="hold" display="0">
+                  <p:stCondLst>
+                    <p:cond delay="indefinite"/>
+                  </p:stCondLst>
+                </p:cTn>
+                <p:tgtEl>
+                  <p:spTgt spid="15"/>
+                </p:tgtEl>
+              </p:cMediaNode>
+            </p:video>
+          </p:childTnLst>
+        </p:cTn>
+      </p:par>
+    </p:tnLst>
+  </p:timing>
 </p:sld>
 </file>
 
@@ -14830,7 +14695,7 @@
                 <a:latin typeface="微软雅黑"/>
                 <ns2:rFonts xmlns:ns2="http://schemas.openxmlformats.org/wordprocessingml/2006/main" ns2:eastAsia="微软雅黑" ns2:ascii="微软雅黑" ns2:hAnsi="微软雅黑"/>
               </a:rPr>
-              <a:t>性能与延迟</a:t>
+              <a:t>测试结果</a:t>
             </a:r>
           </a:p>
         </p:txBody>
@@ -14975,7 +14840,7 @@
         <p:spPr>
           <a:xfrm>
             <a:off x="438912" y="1106424"/>
-            <a:ext cx="3282696" cy="890397"/>
+            <a:ext cx="3282696" cy="812673"/>
           </a:xfrm>
           <a:prstGeom prst="rect">
             <a:avLst/>
@@ -15004,7 +14869,7 @@
                 <a:latin typeface="微软雅黑"/>
                 <ns3:rFonts xmlns:ns3="http://schemas.openxmlformats.org/wordprocessingml/2006/main" ns3:eastAsia="微软雅黑" ns3:ascii="微软雅黑" ns3:hAnsi="微软雅黑"/>
               </a:rPr>
-              <a:t>● 骨架提取约占时最多，仍满足实时要求</a:t>
+              <a:t>● 跌倒检测 P/R/F1：合成 6 场景均为 100%</a:t>
             </a:r>
           </a:p>
         </p:txBody>
@@ -15017,8 +14882,8 @@
         </p:nvSpPr>
         <p:spPr>
           <a:xfrm>
-            <a:off x="438912" y="2015109"/>
-            <a:ext cx="3282696" cy="890397"/>
+            <a:off x="438912" y="1937385"/>
+            <a:ext cx="3282696" cy="812673"/>
           </a:xfrm>
           <a:prstGeom prst="rect">
             <a:avLst/>
@@ -15047,7 +14912,7 @@
                 <a:latin typeface="微软雅黑"/>
                 <ns4:rFonts xmlns:ns4="http://schemas.openxmlformats.org/wordprocessingml/2006/main" ns4:eastAsia="微软雅黑" ns4:ascii="微软雅黑" ns4:hAnsi="微软雅黑"/>
               </a:rPr>
-              <a:t>● 融合与规则判定开销较小</a:t>
+              <a:t>● 紧急链路脚本跑通率 100%</a:t>
             </a:r>
           </a:p>
         </p:txBody>
@@ -15060,8 +14925,8 @@
         </p:nvSpPr>
         <p:spPr>
           <a:xfrm>
-            <a:off x="438912" y="2923794"/>
-            <a:ext cx="3282696" cy="890397"/>
+            <a:off x="438912" y="2768346"/>
+            <a:ext cx="3282696" cy="812673"/>
           </a:xfrm>
           <a:prstGeom prst="rect">
             <a:avLst/>
@@ -15090,7 +14955,7 @@
                 <a:latin typeface="微软雅黑"/>
                 <ns5:rFonts xmlns:ns5="http://schemas.openxmlformats.org/wordprocessingml/2006/main" ns5:eastAsia="微软雅黑" ns5:ascii="微软雅黑" ns5:hAnsi="微软雅黑"/>
               </a:rPr>
-              <a:t>● 端到端在 CPU 上约 42ms</a:t>
+              <a:t>● 单帧决策在 CPU 上 &lt; 50ms（见右下图）</a:t>
             </a:r>
           </a:p>
         </p:txBody>
@@ -15103,8 +14968,8 @@
         </p:nvSpPr>
         <p:spPr>
           <a:xfrm>
-            <a:off x="438912" y="3832479"/>
-            <a:ext cx="3282696" cy="890397"/>
+            <a:off x="438912" y="3599307"/>
+            <a:ext cx="3282696" cy="812673"/>
           </a:xfrm>
           <a:prstGeom prst="rect">
             <a:avLst/>
@@ -15133,7 +14998,7 @@
                 <a:latin typeface="微软雅黑"/>
                 <ns6:rFonts xmlns:ns6="http://schemas.openxmlformats.org/wordprocessingml/2006/main" ns6:eastAsia="微软雅黑" ns6:ascii="微软雅黑" ns6:hAnsi="微软雅黑"/>
               </a:rPr>
-              <a:t>● 现场演示不依赖 GPU</a:t>
+              <a:t>● 单元测试和无头演示都过了</a:t>
             </a:r>
           </a:p>
         </p:txBody>
@@ -15141,6 +15006,85 @@
       <p:sp>
         <p:nvSpPr>
           <p:cNvPr id="14" name="Rectangle 13"/>
+          <p:cNvSpPr/>
+          <p:nvPr/>
+        </p:nvSpPr>
+        <p:spPr>
+          <a:xfrm>
+            <a:off x="365760" y="4539996"/>
+            <a:ext cx="3429000" cy="292608"/>
+          </a:xfrm>
+          <a:prstGeom prst="rect">
+            <a:avLst/>
+          </a:prstGeom>
+          <a:solidFill>
+            <a:srgbClr val="143278"/>
+          </a:solidFill>
+          <a:ln>
+            <a:noFill/>
+          </a:ln>
+        </p:spPr>
+        <p:style>
+          <a:lnRef idx="1">
+            <a:schemeClr val="accent1"/>
+          </a:lnRef>
+          <a:fillRef idx="3">
+            <a:schemeClr val="accent1"/>
+          </a:fillRef>
+          <a:effectRef idx="2">
+            <a:schemeClr val="accent1"/>
+          </a:effectRef>
+          <a:fontRef idx="minor">
+            <a:schemeClr val="lt1"/>
+          </a:fontRef>
+        </p:style>
+        <p:txBody>
+          <a:bodyPr rtlCol="0" anchor="ctr"/>
+          <a:lstStyle/>
+          <a:p>
+            <a:pPr algn="ctr"/>
+          </a:p>
+        </p:txBody>
+      </p:sp>
+      <p:sp>
+        <p:nvSpPr>
+          <p:cNvPr id="15" name="TextBox 14"/>
+          <p:cNvSpPr txBox="1"/>
+          <p:nvPr/>
+        </p:nvSpPr>
+        <p:spPr>
+          <a:xfrm>
+            <a:off x="402336" y="4604004"/>
+            <a:ext cx="3355848" cy="182880"/>
+          </a:xfrm>
+          <a:prstGeom prst="rect">
+            <a:avLst/>
+          </a:prstGeom>
+          <a:noFill/>
+        </p:spPr>
+        <p:txBody>
+          <a:bodyPr wrap="none" anchor="ctr">
+            <a:spAutoFit/>
+          </a:bodyPr>
+          <a:lstStyle/>
+          <a:p>
+            <a:pPr algn="ctr"/>
+            <a:r>
+              <a:rPr sz="1100" b="1">
+                <a:solidFill>
+                  <a:srgbClr val="FFFFFF"/>
+                </a:solidFill>
+                <a:latin typeface="微软雅黑"/>
+                <ns7:rFonts xmlns:ns7="http://schemas.openxmlformats.org/wordprocessingml/2006/main" ns7:eastAsia="微软雅黑" ns7:ascii="微软雅黑" ns7:hAnsi="微软雅黑"/>
+              </a:rPr>
+              <a:t>数据：fall_eval_report.json</a:t>
+            </a:r>
+          </a:p>
+        </p:txBody>
+      </p:sp>
+      <p:sp>
+        <p:nvSpPr>
+          <p:cNvPr id="16" name="Rectangle 15"/>
           <p:cNvSpPr/>
           <p:nvPr/>
         </p:nvSpPr>
@@ -15185,7 +15129,7 @@
       </p:sp>
       <p:sp>
         <p:nvSpPr>
-          <p:cNvPr id="15" name="Rectangle 14"/>
+          <p:cNvPr id="17" name="Rectangle 16"/>
           <p:cNvSpPr/>
           <p:nvPr/>
         </p:nvSpPr>
@@ -15228,14 +15172,14 @@
       </p:sp>
       <p:sp>
         <p:nvSpPr>
-          <p:cNvPr id="16" name="Rectangle 15"/>
+          <p:cNvPr id="18" name="Rectangle 17"/>
           <p:cNvSpPr/>
           <p:nvPr/>
         </p:nvSpPr>
         <p:spPr>
           <a:xfrm>
-            <a:off x="4341464" y="1151595"/>
-            <a:ext cx="4255831" cy="3215213"/>
+            <a:off x="4308652" y="1328651"/>
+            <a:ext cx="4321454" cy="2861100"/>
           </a:xfrm>
           <a:prstGeom prst="rect">
             <a:avLst/>
@@ -15273,7 +15217,7 @@
       </p:sp>
       <p:pic>
         <p:nvPicPr>
-          <p:cNvPr id="17" name="Picture 16" descr="latency_bar.png"/>
+          <p:cNvPr id="19" name="Picture 18" descr="eval_results.png"/>
           <p:cNvPicPr>
             <a:picLocks noChangeAspect="1"/>
           </p:cNvPicPr>
@@ -15287,8 +15231,8 @@
         </p:blipFill>
         <p:spPr>
           <a:xfrm>
-            <a:off x="4378040" y="1188171"/>
-            <a:ext cx="4182679" cy="3142061"/>
+            <a:off x="4345228" y="1365227"/>
+            <a:ext cx="4248302" cy="2787948"/>
           </a:xfrm>
           <a:prstGeom prst="rect">
             <a:avLst/>
@@ -15297,7 +15241,7 @@
       </p:pic>
       <p:sp>
         <p:nvSpPr>
-          <p:cNvPr id="18" name="TextBox 17"/>
+          <p:cNvPr id="20" name="TextBox 19"/>
           <p:cNvSpPr txBox="1"/>
           <p:nvPr/>
         </p:nvSpPr>
@@ -15324,9 +15268,9 @@
                   <a:srgbClr val="5A6273"/>
                 </a:solidFill>
                 <a:latin typeface="微软雅黑"/>
-                <ns7:rFonts xmlns:ns7="http://schemas.openxmlformats.org/wordprocessingml/2006/main" ns7:eastAsia="微软雅黑" ns7:ascii="微软雅黑" ns7:hAnsi="微软雅黑"/>
-              </a:rPr>
-              <a:t>单帧链路耗时（本机粗测）</a:t>
+                <ns8:rFonts xmlns:ns8="http://schemas.openxmlformats.org/wordprocessingml/2006/main" ns8:eastAsia="微软雅黑" ns8:ascii="微软雅黑" ns8:hAnsi="微软雅黑"/>
+              </a:rPr>
+              <a:t>P/R/F1 均为 100%（见左栏）</a:t>
             </a:r>
           </a:p>
         </p:txBody>
@@ -15545,6 +15489,721 @@
                 <a:latin typeface="微软雅黑"/>
                 <ns2:rFonts xmlns:ns2="http://schemas.openxmlformats.org/wordprocessingml/2006/main" ns2:eastAsia="微软雅黑" ns2:ascii="微软雅黑" ns2:hAnsi="微软雅黑"/>
               </a:rPr>
+              <a:t>性能与延迟</a:t>
+            </a:r>
+          </a:p>
+        </p:txBody>
+      </p:sp>
+      <p:sp>
+        <p:nvSpPr>
+          <p:cNvPr id="7" name="Rectangle 6"/>
+          <p:cNvSpPr/>
+          <p:nvPr/>
+        </p:nvSpPr>
+        <p:spPr>
+          <a:xfrm>
+            <a:off x="274320" y="886968"/>
+            <a:ext cx="1143000" cy="50292"/>
+          </a:xfrm>
+          <a:prstGeom prst="rect">
+            <a:avLst/>
+          </a:prstGeom>
+          <a:solidFill>
+            <a:srgbClr val="F59E0B"/>
+          </a:solidFill>
+          <a:ln>
+            <a:noFill/>
+          </a:ln>
+        </p:spPr>
+        <p:style>
+          <a:lnRef idx="1">
+            <a:schemeClr val="accent1"/>
+          </a:lnRef>
+          <a:fillRef idx="3">
+            <a:schemeClr val="accent1"/>
+          </a:fillRef>
+          <a:effectRef idx="2">
+            <a:schemeClr val="accent1"/>
+          </a:effectRef>
+          <a:fontRef idx="minor">
+            <a:schemeClr val="lt1"/>
+          </a:fontRef>
+        </p:style>
+        <p:txBody>
+          <a:bodyPr rtlCol="0" anchor="ctr"/>
+          <a:lstStyle/>
+          <a:p>
+            <a:pPr algn="ctr"/>
+          </a:p>
+        </p:txBody>
+      </p:sp>
+      <p:sp>
+        <p:nvSpPr>
+          <p:cNvPr id="8" name="Rectangle 7"/>
+          <p:cNvSpPr/>
+          <p:nvPr/>
+        </p:nvSpPr>
+        <p:spPr>
+          <a:xfrm>
+            <a:off x="274320" y="996696"/>
+            <a:ext cx="3611880" cy="3854196"/>
+          </a:xfrm>
+          <a:prstGeom prst="rect">
+            <a:avLst/>
+          </a:prstGeom>
+          <a:solidFill>
+            <a:srgbClr val="F1F7FF"/>
+          </a:solidFill>
+          <a:ln w="10160">
+            <a:solidFill>
+              <a:srgbClr val="BAC8DC"/>
+            </a:solidFill>
+          </a:ln>
+        </p:spPr>
+        <p:style>
+          <a:lnRef idx="1">
+            <a:schemeClr val="accent1"/>
+          </a:lnRef>
+          <a:fillRef idx="3">
+            <a:schemeClr val="accent1"/>
+          </a:fillRef>
+          <a:effectRef idx="2">
+            <a:schemeClr val="accent1"/>
+          </a:effectRef>
+          <a:fontRef idx="minor">
+            <a:schemeClr val="lt1"/>
+          </a:fontRef>
+        </p:style>
+        <p:txBody>
+          <a:bodyPr rtlCol="0" anchor="ctr"/>
+          <a:lstStyle/>
+          <a:p>
+            <a:pPr algn="ctr"/>
+          </a:p>
+        </p:txBody>
+      </p:sp>
+      <p:sp>
+        <p:nvSpPr>
+          <p:cNvPr id="9" name="Rectangle 8"/>
+          <p:cNvSpPr/>
+          <p:nvPr/>
+        </p:nvSpPr>
+        <p:spPr>
+          <a:xfrm>
+            <a:off x="274320" y="996696"/>
+            <a:ext cx="73152" cy="3854196"/>
+          </a:xfrm>
+          <a:prstGeom prst="rect">
+            <a:avLst/>
+          </a:prstGeom>
+          <a:solidFill>
+            <a:srgbClr val="143278"/>
+          </a:solidFill>
+          <a:ln>
+            <a:noFill/>
+          </a:ln>
+        </p:spPr>
+        <p:style>
+          <a:lnRef idx="1">
+            <a:schemeClr val="accent1"/>
+          </a:lnRef>
+          <a:fillRef idx="3">
+            <a:schemeClr val="accent1"/>
+          </a:fillRef>
+          <a:effectRef idx="2">
+            <a:schemeClr val="accent1"/>
+          </a:effectRef>
+          <a:fontRef idx="minor">
+            <a:schemeClr val="lt1"/>
+          </a:fontRef>
+        </p:style>
+        <p:txBody>
+          <a:bodyPr rtlCol="0" anchor="ctr"/>
+          <a:lstStyle/>
+          <a:p>
+            <a:pPr algn="ctr"/>
+          </a:p>
+        </p:txBody>
+      </p:sp>
+      <p:sp>
+        <p:nvSpPr>
+          <p:cNvPr id="10" name="TextBox 9"/>
+          <p:cNvSpPr txBox="1"/>
+          <p:nvPr/>
+        </p:nvSpPr>
+        <p:spPr>
+          <a:xfrm>
+            <a:off x="438912" y="1106424"/>
+            <a:ext cx="3282696" cy="890397"/>
+          </a:xfrm>
+          <a:prstGeom prst="rect">
+            <a:avLst/>
+          </a:prstGeom>
+          <a:noFill/>
+        </p:spPr>
+        <p:txBody>
+          <a:bodyPr wrap="square" anchor="t" lIns="25400" tIns="0">
+            <a:spAutoFit/>
+          </a:bodyPr>
+          <a:lstStyle/>
+          <a:p>
+            <a:pPr>
+              <a:lnSpc>
+                <a:spcPct val="112000"/>
+              </a:lnSpc>
+              <a:spcAft>
+                <a:spcPts val="200"/>
+              </a:spcAft>
+            </a:pPr>
+            <a:r>
+              <a:rPr sz="1300" b="0">
+                <a:solidFill>
+                  <a:srgbClr val="1C202C"/>
+                </a:solidFill>
+                <a:latin typeface="微软雅黑"/>
+                <ns3:rFonts xmlns:ns3="http://schemas.openxmlformats.org/wordprocessingml/2006/main" ns3:eastAsia="微软雅黑" ns3:ascii="微软雅黑" ns3:hAnsi="微软雅黑"/>
+              </a:rPr>
+              <a:t>● 骨架提取约占时最多，仍满足实时要求</a:t>
+            </a:r>
+          </a:p>
+        </p:txBody>
+      </p:sp>
+      <p:sp>
+        <p:nvSpPr>
+          <p:cNvPr id="11" name="TextBox 10"/>
+          <p:cNvSpPr txBox="1"/>
+          <p:nvPr/>
+        </p:nvSpPr>
+        <p:spPr>
+          <a:xfrm>
+            <a:off x="438912" y="2015109"/>
+            <a:ext cx="3282696" cy="890397"/>
+          </a:xfrm>
+          <a:prstGeom prst="rect">
+            <a:avLst/>
+          </a:prstGeom>
+          <a:noFill/>
+        </p:spPr>
+        <p:txBody>
+          <a:bodyPr wrap="square" anchor="t" lIns="25400" tIns="0">
+            <a:spAutoFit/>
+          </a:bodyPr>
+          <a:lstStyle/>
+          <a:p>
+            <a:pPr>
+              <a:lnSpc>
+                <a:spcPct val="112000"/>
+              </a:lnSpc>
+              <a:spcAft>
+                <a:spcPts val="200"/>
+              </a:spcAft>
+            </a:pPr>
+            <a:r>
+              <a:rPr sz="1300" b="0">
+                <a:solidFill>
+                  <a:srgbClr val="1C202C"/>
+                </a:solidFill>
+                <a:latin typeface="微软雅黑"/>
+                <ns4:rFonts xmlns:ns4="http://schemas.openxmlformats.org/wordprocessingml/2006/main" ns4:eastAsia="微软雅黑" ns4:ascii="微软雅黑" ns4:hAnsi="微软雅黑"/>
+              </a:rPr>
+              <a:t>● 融合与规则判定开销较小</a:t>
+            </a:r>
+          </a:p>
+        </p:txBody>
+      </p:sp>
+      <p:sp>
+        <p:nvSpPr>
+          <p:cNvPr id="12" name="TextBox 11"/>
+          <p:cNvSpPr txBox="1"/>
+          <p:nvPr/>
+        </p:nvSpPr>
+        <p:spPr>
+          <a:xfrm>
+            <a:off x="438912" y="2923794"/>
+            <a:ext cx="3282696" cy="890397"/>
+          </a:xfrm>
+          <a:prstGeom prst="rect">
+            <a:avLst/>
+          </a:prstGeom>
+          <a:noFill/>
+        </p:spPr>
+        <p:txBody>
+          <a:bodyPr wrap="square" anchor="t" lIns="25400" tIns="0">
+            <a:spAutoFit/>
+          </a:bodyPr>
+          <a:lstStyle/>
+          <a:p>
+            <a:pPr>
+              <a:lnSpc>
+                <a:spcPct val="112000"/>
+              </a:lnSpc>
+              <a:spcAft>
+                <a:spcPts val="200"/>
+              </a:spcAft>
+            </a:pPr>
+            <a:r>
+              <a:rPr sz="1300" b="0">
+                <a:solidFill>
+                  <a:srgbClr val="1C202C"/>
+                </a:solidFill>
+                <a:latin typeface="微软雅黑"/>
+                <ns5:rFonts xmlns:ns5="http://schemas.openxmlformats.org/wordprocessingml/2006/main" ns5:eastAsia="微软雅黑" ns5:ascii="微软雅黑" ns5:hAnsi="微软雅黑"/>
+              </a:rPr>
+              <a:t>● 端到端在 CPU 上约 42ms</a:t>
+            </a:r>
+          </a:p>
+        </p:txBody>
+      </p:sp>
+      <p:sp>
+        <p:nvSpPr>
+          <p:cNvPr id="13" name="TextBox 12"/>
+          <p:cNvSpPr txBox="1"/>
+          <p:nvPr/>
+        </p:nvSpPr>
+        <p:spPr>
+          <a:xfrm>
+            <a:off x="438912" y="3832479"/>
+            <a:ext cx="3282696" cy="890397"/>
+          </a:xfrm>
+          <a:prstGeom prst="rect">
+            <a:avLst/>
+          </a:prstGeom>
+          <a:noFill/>
+        </p:spPr>
+        <p:txBody>
+          <a:bodyPr wrap="square" anchor="t" lIns="25400" tIns="0">
+            <a:spAutoFit/>
+          </a:bodyPr>
+          <a:lstStyle/>
+          <a:p>
+            <a:pPr>
+              <a:lnSpc>
+                <a:spcPct val="112000"/>
+              </a:lnSpc>
+              <a:spcAft>
+                <a:spcPts val="200"/>
+              </a:spcAft>
+            </a:pPr>
+            <a:r>
+              <a:rPr sz="1300" b="0">
+                <a:solidFill>
+                  <a:srgbClr val="1C202C"/>
+                </a:solidFill>
+                <a:latin typeface="微软雅黑"/>
+                <ns6:rFonts xmlns:ns6="http://schemas.openxmlformats.org/wordprocessingml/2006/main" ns6:eastAsia="微软雅黑" ns6:ascii="微软雅黑" ns6:hAnsi="微软雅黑"/>
+              </a:rPr>
+              <a:t>● 现场演示不依赖 GPU</a:t>
+            </a:r>
+          </a:p>
+        </p:txBody>
+      </p:sp>
+      <p:sp>
+        <p:nvSpPr>
+          <p:cNvPr id="14" name="Rectangle 13"/>
+          <p:cNvSpPr/>
+          <p:nvPr/>
+        </p:nvSpPr>
+        <p:spPr>
+          <a:xfrm>
+            <a:off x="4105656" y="1033272"/>
+            <a:ext cx="4727448" cy="3744468"/>
+          </a:xfrm>
+          <a:prstGeom prst="rect">
+            <a:avLst/>
+          </a:prstGeom>
+          <a:solidFill>
+            <a:srgbClr val="FFFFFF"/>
+          </a:solidFill>
+          <a:ln w="9525">
+            <a:solidFill>
+              <a:srgbClr val="BAC8DC"/>
+            </a:solidFill>
+          </a:ln>
+        </p:spPr>
+        <p:style>
+          <a:lnRef idx="1">
+            <a:schemeClr val="accent1"/>
+          </a:lnRef>
+          <a:fillRef idx="3">
+            <a:schemeClr val="accent1"/>
+          </a:fillRef>
+          <a:effectRef idx="2">
+            <a:schemeClr val="accent1"/>
+          </a:effectRef>
+          <a:fontRef idx="minor">
+            <a:schemeClr val="lt1"/>
+          </a:fontRef>
+        </p:style>
+        <p:txBody>
+          <a:bodyPr rtlCol="0" anchor="ctr"/>
+          <a:lstStyle/>
+          <a:p>
+            <a:pPr algn="ctr"/>
+          </a:p>
+        </p:txBody>
+      </p:sp>
+      <p:sp>
+        <p:nvSpPr>
+          <p:cNvPr id="15" name="Rectangle 14"/>
+          <p:cNvSpPr/>
+          <p:nvPr/>
+        </p:nvSpPr>
+        <p:spPr>
+          <a:xfrm>
+            <a:off x="3968496" y="996696"/>
+            <a:ext cx="10972" cy="3854196"/>
+          </a:xfrm>
+          <a:prstGeom prst="rect">
+            <a:avLst/>
+          </a:prstGeom>
+          <a:solidFill>
+            <a:srgbClr val="BAC8DC"/>
+          </a:solidFill>
+          <a:ln>
+            <a:noFill/>
+          </a:ln>
+        </p:spPr>
+        <p:style>
+          <a:lnRef idx="1">
+            <a:schemeClr val="accent1"/>
+          </a:lnRef>
+          <a:fillRef idx="3">
+            <a:schemeClr val="accent1"/>
+          </a:fillRef>
+          <a:effectRef idx="2">
+            <a:schemeClr val="accent1"/>
+          </a:effectRef>
+          <a:fontRef idx="minor">
+            <a:schemeClr val="lt1"/>
+          </a:fontRef>
+        </p:style>
+        <p:txBody>
+          <a:bodyPr rtlCol="0" anchor="ctr"/>
+          <a:lstStyle/>
+          <a:p>
+            <a:pPr algn="ctr"/>
+          </a:p>
+        </p:txBody>
+      </p:sp>
+      <p:sp>
+        <p:nvSpPr>
+          <p:cNvPr id="16" name="Rectangle 15"/>
+          <p:cNvSpPr/>
+          <p:nvPr/>
+        </p:nvSpPr>
+        <p:spPr>
+          <a:xfrm>
+            <a:off x="4341464" y="1151595"/>
+            <a:ext cx="4255831" cy="3215213"/>
+          </a:xfrm>
+          <a:prstGeom prst="rect">
+            <a:avLst/>
+          </a:prstGeom>
+          <a:solidFill>
+            <a:srgbClr val="FCFDFF"/>
+          </a:solidFill>
+          <a:ln w="7620">
+            <a:solidFill>
+              <a:srgbClr val="BAC8DC"/>
+            </a:solidFill>
+          </a:ln>
+        </p:spPr>
+        <p:style>
+          <a:lnRef idx="1">
+            <a:schemeClr val="accent1"/>
+          </a:lnRef>
+          <a:fillRef idx="3">
+            <a:schemeClr val="accent1"/>
+          </a:fillRef>
+          <a:effectRef idx="2">
+            <a:schemeClr val="accent1"/>
+          </a:effectRef>
+          <a:fontRef idx="minor">
+            <a:schemeClr val="lt1"/>
+          </a:fontRef>
+        </p:style>
+        <p:txBody>
+          <a:bodyPr rtlCol="0" anchor="ctr"/>
+          <a:lstStyle/>
+          <a:p>
+            <a:pPr algn="ctr"/>
+          </a:p>
+        </p:txBody>
+      </p:sp>
+      <p:pic>
+        <p:nvPicPr>
+          <p:cNvPr id="17" name="Picture 16" descr="latency_bar.png"/>
+          <p:cNvPicPr>
+            <a:picLocks noChangeAspect="1"/>
+          </p:cNvPicPr>
+          <p:nvPr/>
+        </p:nvPicPr>
+        <p:blipFill>
+          <a:blip r:embed="rId2"/>
+          <a:stretch>
+            <a:fillRect/>
+          </a:stretch>
+        </p:blipFill>
+        <p:spPr>
+          <a:xfrm>
+            <a:off x="4378040" y="1188171"/>
+            <a:ext cx="4182679" cy="3142061"/>
+          </a:xfrm>
+          <a:prstGeom prst="rect">
+            <a:avLst/>
+          </a:prstGeom>
+        </p:spPr>
+      </p:pic>
+      <p:sp>
+        <p:nvSpPr>
+          <p:cNvPr id="18" name="TextBox 17"/>
+          <p:cNvSpPr txBox="1"/>
+          <p:nvPr/>
+        </p:nvSpPr>
+        <p:spPr>
+          <a:xfrm>
+            <a:off x="4160520" y="4521708"/>
+            <a:ext cx="4617720" cy="219456"/>
+          </a:xfrm>
+          <a:prstGeom prst="rect">
+            <a:avLst/>
+          </a:prstGeom>
+          <a:noFill/>
+        </p:spPr>
+        <p:txBody>
+          <a:bodyPr wrap="square" anchor="ctr">
+            <a:spAutoFit/>
+          </a:bodyPr>
+          <a:lstStyle/>
+          <a:p>
+            <a:pPr algn="ctr"/>
+            <a:r>
+              <a:rPr sz="800" b="0">
+                <a:solidFill>
+                  <a:srgbClr val="5A6273"/>
+                </a:solidFill>
+                <a:latin typeface="微软雅黑"/>
+                <ns7:rFonts xmlns:ns7="http://schemas.openxmlformats.org/wordprocessingml/2006/main" ns7:eastAsia="微软雅黑" ns7:ascii="微软雅黑" ns7:hAnsi="微软雅黑"/>
+              </a:rPr>
+              <a:t>单帧链路耗时（本机粗测）</a:t>
+            </a:r>
+          </a:p>
+        </p:txBody>
+      </p:sp>
+    </p:spTree>
+  </p:cSld>
+  <p:clrMapOvr>
+    <a:masterClrMapping/>
+  </p:clrMapOvr>
+</p:sld>
+</file>
+
+<file path=ppt/slides/slide27.xml><?xml version="1.0" encoding="utf-8"?>
+<p:sld xmlns:a="http://schemas.openxmlformats.org/drawingml/2006/main" xmlns:p="http://schemas.openxmlformats.org/presentationml/2006/main" xmlns:r="http://schemas.openxmlformats.org/officeDocument/2006/relationships">
+  <p:cSld>
+    <p:bg>
+      <p:bgPr>
+        <a:solidFill>
+          <a:srgbClr val="FFFFFF"/>
+        </a:solidFill>
+        <a:effectLst/>
+      </p:bgPr>
+    </p:bg>
+    <p:spTree>
+      <p:nvGrpSpPr>
+        <p:cNvPr id="1" name=""/>
+        <p:cNvGrpSpPr/>
+        <p:nvPr/>
+      </p:nvGrpSpPr>
+      <p:grpSpPr/>
+      <p:sp>
+        <p:nvSpPr>
+          <p:cNvPr id="2" name="Rectangle 1"/>
+          <p:cNvSpPr/>
+          <p:nvPr/>
+        </p:nvSpPr>
+        <p:spPr>
+          <a:xfrm>
+            <a:off x="0" y="0"/>
+            <a:ext cx="9144000" cy="420624"/>
+          </a:xfrm>
+          <a:prstGeom prst="rect">
+            <a:avLst/>
+          </a:prstGeom>
+          <a:solidFill>
+            <a:srgbClr val="143278"/>
+          </a:solidFill>
+          <a:ln>
+            <a:noFill/>
+          </a:ln>
+        </p:spPr>
+        <p:style>
+          <a:lnRef idx="1">
+            <a:schemeClr val="accent1"/>
+          </a:lnRef>
+          <a:fillRef idx="3">
+            <a:schemeClr val="accent1"/>
+          </a:fillRef>
+          <a:effectRef idx="2">
+            <a:schemeClr val="accent1"/>
+          </a:effectRef>
+          <a:fontRef idx="minor">
+            <a:schemeClr val="lt1"/>
+          </a:fontRef>
+        </p:style>
+        <p:txBody>
+          <a:bodyPr rtlCol="0" anchor="ctr"/>
+          <a:lstStyle/>
+          <a:p>
+            <a:pPr algn="ctr"/>
+          </a:p>
+        </p:txBody>
+      </p:sp>
+      <p:sp>
+        <p:nvSpPr>
+          <p:cNvPr id="3" name="TextBox 2"/>
+          <p:cNvSpPr txBox="1"/>
+          <p:nvPr/>
+        </p:nvSpPr>
+        <p:spPr>
+          <a:xfrm>
+            <a:off x="274320" y="54864"/>
+            <a:ext cx="8595360" cy="347472"/>
+          </a:xfrm>
+          <a:prstGeom prst="rect">
+            <a:avLst/>
+          </a:prstGeom>
+          <a:noFill/>
+        </p:spPr>
+        <p:txBody>
+          <a:bodyPr wrap="none">
+            <a:spAutoFit/>
+          </a:bodyPr>
+          <a:lstStyle/>
+          <a:p>
+            <a:r>
+              <a:rPr sz="900" b="1">
+                <a:solidFill>
+                  <a:srgbClr val="FFFFFF"/>
+                </a:solidFill>
+                <a:latin typeface="微软雅黑"/>
+                <ns0:rFonts xmlns:ns0="http://schemas.openxmlformats.org/wordprocessingml/2006/main" ns0:eastAsia="微软雅黑" ns0:ascii="微软雅黑" ns0:hAnsi="微软雅黑"/>
+              </a:rPr>
+              <a:t>第二十八届中国机器人及人工智能大赛  |  创新赛 · 机器人创新赛道</a:t>
+            </a:r>
+          </a:p>
+        </p:txBody>
+      </p:sp>
+      <p:sp>
+        <p:nvSpPr>
+          <p:cNvPr id="4" name="Rectangle 3"/>
+          <p:cNvSpPr/>
+          <p:nvPr/>
+        </p:nvSpPr>
+        <p:spPr>
+          <a:xfrm>
+            <a:off x="0" y="4905756"/>
+            <a:ext cx="9144000" cy="237744"/>
+          </a:xfrm>
+          <a:prstGeom prst="rect">
+            <a:avLst/>
+          </a:prstGeom>
+          <a:solidFill>
+            <a:srgbClr val="DBEAFE"/>
+          </a:solidFill>
+          <a:ln>
+            <a:noFill/>
+          </a:ln>
+        </p:spPr>
+        <p:style>
+          <a:lnRef idx="1">
+            <a:schemeClr val="accent1"/>
+          </a:lnRef>
+          <a:fillRef idx="3">
+            <a:schemeClr val="accent1"/>
+          </a:fillRef>
+          <a:effectRef idx="2">
+            <a:schemeClr val="accent1"/>
+          </a:effectRef>
+          <a:fontRef idx="minor">
+            <a:schemeClr val="lt1"/>
+          </a:fontRef>
+        </p:style>
+        <p:txBody>
+          <a:bodyPr rtlCol="0" anchor="ctr"/>
+          <a:lstStyle/>
+          <a:p>
+            <a:pPr algn="ctr"/>
+          </a:p>
+        </p:txBody>
+      </p:sp>
+      <p:sp>
+        <p:nvSpPr>
+          <p:cNvPr id="5" name="TextBox 4"/>
+          <p:cNvSpPr txBox="1"/>
+          <p:nvPr/>
+        </p:nvSpPr>
+        <p:spPr>
+          <a:xfrm>
+            <a:off x="274320" y="4951476"/>
+            <a:ext cx="8595360" cy="182880"/>
+          </a:xfrm>
+          <a:prstGeom prst="rect">
+            <a:avLst/>
+          </a:prstGeom>
+          <a:noFill/>
+        </p:spPr>
+        <p:txBody>
+          <a:bodyPr wrap="none">
+            <a:spAutoFit/>
+          </a:bodyPr>
+          <a:lstStyle/>
+          <a:p>
+            <a:pPr algn="ctr"/>
+            <a:r>
+              <a:rPr sz="800" b="0">
+                <a:solidFill>
+                  <a:srgbClr val="5A6273"/>
+                </a:solidFill>
+                <a:latin typeface="微软雅黑"/>
+                <ns1:rFonts xmlns:ns1="http://schemas.openxmlformats.org/wordprocessingml/2006/main" ns1:eastAsia="微软雅黑" ns1:ascii="微软雅黑" ns1:hAnsi="微软雅黑"/>
+              </a:rPr>
+              <a:t>从容应队 · 中山大学 · 刘小凡/白冉 · 指导教师 彭键清</a:t>
+            </a:r>
+          </a:p>
+        </p:txBody>
+      </p:sp>
+      <p:sp>
+        <p:nvSpPr>
+          <p:cNvPr id="6" name="TextBox 5"/>
+          <p:cNvSpPr txBox="1"/>
+          <p:nvPr/>
+        </p:nvSpPr>
+        <p:spPr>
+          <a:xfrm>
+            <a:off x="274320" y="466344"/>
+            <a:ext cx="8595360" cy="457200"/>
+          </a:xfrm>
+          <a:prstGeom prst="rect">
+            <a:avLst/>
+          </a:prstGeom>
+          <a:noFill/>
+        </p:spPr>
+        <p:txBody>
+          <a:bodyPr wrap="none">
+            <a:spAutoFit/>
+          </a:bodyPr>
+          <a:lstStyle/>
+          <a:p>
+            <a:pPr algn="l"/>
+            <a:r>
+              <a:rPr sz="2000" b="1">
+                <a:solidFill>
+                  <a:srgbClr val="143278"/>
+                </a:solidFill>
+                <a:latin typeface="微软雅黑"/>
+                <ns2:rFonts xmlns:ns2="http://schemas.openxmlformats.org/wordprocessingml/2006/main" ns2:eastAsia="微软雅黑" ns2:ascii="微软雅黑" ns2:hAnsi="微软雅黑"/>
+              </a:rPr>
               <a:t>开源与可复现性</a:t>
             </a:r>
           </a:p>
@@ -15615,7 +16274,7 @@
                 <a:gridCol w="868680"/>
                 <a:gridCol w="2743200"/>
               </a:tblGrid>
-              <a:tr h="642366">
+              <a:tr h="550599">
                 <a:tc>
                   <a:txBody>
                     <a:bodyPr anchor="ctr"/>
@@ -15665,7 +16324,7 @@
                   </a:tcPr>
                 </a:tc>
               </a:tr>
-              <a:tr h="642366">
+              <a:tr h="550599">
                 <a:tc>
                   <a:txBody>
                     <a:bodyPr anchor="ctr"/>
@@ -15715,7 +16374,7 @@
                   </a:tcPr>
                 </a:tc>
               </a:tr>
-              <a:tr h="642366">
+              <a:tr h="550599">
                 <a:tc>
                   <a:txBody>
                     <a:bodyPr anchor="ctr"/>
@@ -15765,7 +16424,7 @@
                   </a:tcPr>
                 </a:tc>
               </a:tr>
-              <a:tr h="642366">
+              <a:tr h="550599">
                 <a:tc>
                   <a:txBody>
                     <a:bodyPr anchor="ctr"/>
@@ -15779,6 +16438,56 @@
                           </a:solidFill>
                           <a:latin typeface="微软雅黑"/>
                           <ns9:rFonts xmlns:ns9="http://schemas.openxmlformats.org/wordprocessingml/2006/main" ns9:eastAsia="微软雅黑" ns9:ascii="微软雅黑" ns9:hAnsi="微软雅黑"/>
+                        </a:rPr>
+                        <a:t>情景剧总片</a:t>
+                      </a:r>
+                    </a:p>
+                  </a:txBody>
+                  <a:tcPr marL="50800" marR="50800" marT="25400" marB="25400">
+                    <a:solidFill>
+                      <a:srgbClr val="143278"/>
+                    </a:solidFill>
+                  </a:tcPr>
+                </a:tc>
+                <a:tc>
+                  <a:txBody>
+                    <a:bodyPr anchor="ctr" wrap="square"/>
+                    <a:lstStyle/>
+                    <a:p>
+                      <a:pPr algn="l"/>
+                      <a:r>
+                        <a:rPr sz="900" b="0">
+                          <a:solidFill>
+                            <a:srgbClr val="143278"/>
+                          </a:solidFill>
+                          <a:latin typeface="微软雅黑"/>
+                          <ns10:rFonts xmlns:ns10="http://schemas.openxmlformats.org/wordprocessingml/2006/main" ns10:eastAsia="微软雅黑" ns10:ascii="微软雅黑" ns10:hAnsi="微软雅黑"/>
+                        </a:rPr>
+                        <a:t>docs/assets/demo_full_scenario.mp4</a:t>
+                      </a:r>
+                    </a:p>
+                  </a:txBody>
+                  <a:tcPr marL="63500">
+                    <a:solidFill>
+                      <a:srgbClr val="FFFFFF"/>
+                    </a:solidFill>
+                  </a:tcPr>
+                </a:tc>
+              </a:tr>
+              <a:tr h="550599">
+                <a:tc>
+                  <a:txBody>
+                    <a:bodyPr anchor="ctr"/>
+                    <a:lstStyle/>
+                    <a:p>
+                      <a:pPr algn="ctr"/>
+                      <a:r>
+                        <a:rPr sz="900" b="1">
+                          <a:solidFill>
+                            <a:srgbClr val="FFFFFF"/>
+                          </a:solidFill>
+                          <a:latin typeface="微软雅黑"/>
+                          <ns11:rFonts xmlns:ns11="http://schemas.openxmlformats.org/wordprocessingml/2006/main" ns11:eastAsia="微软雅黑" ns11:ascii="微软雅黑" ns11:hAnsi="微软雅黑"/>
                         </a:rPr>
                         <a:t>Web 演示</a:t>
                       </a:r>
@@ -15802,7 +16511,7 @@
                             <a:srgbClr val="143278"/>
                           </a:solidFill>
                           <a:latin typeface="微软雅黑"/>
-                          <ns10:rFonts xmlns:ns10="http://schemas.openxmlformats.org/wordprocessingml/2006/main" ns10:eastAsia="微软雅黑" ns10:ascii="微软雅黑" ns10:hAnsi="微软雅黑"/>
+                          <ns12:rFonts xmlns:ns12="http://schemas.openxmlformats.org/wordprocessingml/2006/main" ns12:eastAsia="微软雅黑" ns12:ascii="微软雅黑" ns12:hAnsi="微软雅黑"/>
                         </a:rPr>
                         <a:t>docs/assets/demo_carecompanion.mp4</a:t>
                       </a:r>
@@ -15810,12 +16519,12 @@
                   </a:txBody>
                   <a:tcPr marL="63500">
                     <a:solidFill>
-                      <a:srgbClr val="FFFFFF"/>
+                      <a:srgbClr val="F1F7FF"/>
                     </a:solidFill>
                   </a:tcPr>
                 </a:tc>
               </a:tr>
-              <a:tr h="642366">
+              <a:tr h="550599">
                 <a:tc>
                   <a:txBody>
                     <a:bodyPr anchor="ctr"/>
@@ -15828,7 +16537,7 @@
                             <a:srgbClr val="FFFFFF"/>
                           </a:solidFill>
                           <a:latin typeface="微软雅黑"/>
-                          <ns11:rFonts xmlns:ns11="http://schemas.openxmlformats.org/wordprocessingml/2006/main" ns11:eastAsia="微软雅黑" ns11:ascii="微软雅黑" ns11:hAnsi="微软雅黑"/>
+                          <ns13:rFonts xmlns:ns13="http://schemas.openxmlformats.org/wordprocessingml/2006/main" ns13:eastAsia="微软雅黑" ns13:ascii="微软雅黑" ns13:hAnsi="微软雅黑"/>
                         </a:rPr>
                         <a:t>G1 仿真</a:t>
                       </a:r>
@@ -15852,7 +16561,7 @@
                             <a:srgbClr val="143278"/>
                           </a:solidFill>
                           <a:latin typeface="微软雅黑"/>
-                          <ns12:rFonts xmlns:ns12="http://schemas.openxmlformats.org/wordprocessingml/2006/main" ns12:eastAsia="微软雅黑" ns12:ascii="微软雅黑" ns12:hAnsi="微软雅黑"/>
+                          <ns14:rFonts xmlns:ns14="http://schemas.openxmlformats.org/wordprocessingml/2006/main" ns14:eastAsia="微软雅黑" ns14:ascii="微软雅黑" ns14:hAnsi="微软雅黑"/>
                         </a:rPr>
                         <a:t>docs/assets/demo_isaac_g1_locomotion.mp4</a:t>
                       </a:r>
@@ -15860,12 +16569,12 @@
                   </a:txBody>
                   <a:tcPr marL="63500">
                     <a:solidFill>
-                      <a:srgbClr val="F1F7FF"/>
+                      <a:srgbClr val="FFFFFF"/>
                     </a:solidFill>
                   </a:tcPr>
                 </a:tc>
               </a:tr>
-              <a:tr h="642366">
+              <a:tr h="550602">
                 <a:tc>
                   <a:txBody>
                     <a:bodyPr anchor="ctr"/>
@@ -15878,7 +16587,7 @@
                             <a:srgbClr val="FFFFFF"/>
                           </a:solidFill>
                           <a:latin typeface="微软雅黑"/>
-                          <ns13:rFonts xmlns:ns13="http://schemas.openxmlformats.org/wordprocessingml/2006/main" ns13:eastAsia="微软雅黑" ns13:ascii="微软雅黑" ns13:hAnsi="微软雅黑"/>
+                          <ns15:rFonts xmlns:ns15="http://schemas.openxmlformats.org/wordprocessingml/2006/main" ns15:eastAsia="微软雅黑" ns15:ascii="微软雅黑" ns15:hAnsi="微软雅黑"/>
                         </a:rPr>
                         <a:t>软著</a:t>
                       </a:r>
@@ -15902,7 +16611,7 @@
                             <a:srgbClr val="143278"/>
                           </a:solidFill>
                           <a:latin typeface="微软雅黑"/>
-                          <ns14:rFonts xmlns:ns14="http://schemas.openxmlformats.org/wordprocessingml/2006/main" ns14:eastAsia="微软雅黑" ns14:ascii="微软雅黑" ns14:hAnsi="微软雅黑"/>
+                          <ns16:rFonts xmlns:ns16="http://schemas.openxmlformats.org/wordprocessingml/2006/main" ns16:eastAsia="微软雅黑" ns16:ascii="微软雅黑" ns16:hAnsi="微软雅黑"/>
                         </a:rPr>
                         <a:t>申请中</a:t>
                       </a:r>
@@ -15910,7 +16619,7 @@
                   </a:txBody>
                   <a:tcPr marL="63500">
                     <a:solidFill>
-                      <a:srgbClr val="FFFFFF"/>
+                      <a:srgbClr val="F1F7FF"/>
                     </a:solidFill>
                   </a:tcPr>
                 </a:tc>
@@ -16017,7 +16726,7 @@
                   <a:srgbClr val="143278"/>
                 </a:solidFill>
                 <a:latin typeface="微软雅黑"/>
-                <ns15:rFonts xmlns:ns15="http://schemas.openxmlformats.org/wordprocessingml/2006/main" ns15:eastAsia="微软雅黑" ns15:ascii="微软雅黑" ns15:hAnsi="微软雅黑"/>
+                <ns17:rFonts xmlns:ns17="http://schemas.openxmlformats.org/wordprocessingml/2006/main" ns17:eastAsia="微软雅黑" ns17:ascii="微软雅黑" ns17:hAnsi="微软雅黑"/>
               </a:rPr>
               <a:t>扫码访问 GitHub 仓库</a:t>
             </a:r>
@@ -16057,7 +16766,7 @@
                   <a:srgbClr val="166534"/>
                 </a:solidFill>
                 <a:latin typeface="微软雅黑"/>
-                <ns16:rFonts xmlns:ns16="http://schemas.openxmlformats.org/wordprocessingml/2006/main" ns16:eastAsia="微软雅黑" ns16:ascii="微软雅黑" ns16:hAnsi="微软雅黑"/>
+                <ns18:rFonts xmlns:ns18="http://schemas.openxmlformats.org/wordprocessingml/2006/main" ns18:eastAsia="微软雅黑" ns18:ascii="微软雅黑" ns18:hAnsi="微软雅黑"/>
               </a:rPr>
               <a:t>✓  完整源码与 README</a:t>
             </a:r>
@@ -16074,7 +16783,7 @@
                   <a:srgbClr val="166534"/>
                 </a:solidFill>
                 <a:latin typeface="微软雅黑"/>
-                <ns17:rFonts xmlns:ns17="http://schemas.openxmlformats.org/wordprocessingml/2006/main" ns17:eastAsia="微软雅黑" ns17:ascii="微软雅黑" ns17:hAnsi="微软雅黑"/>
+                <ns19:rFonts xmlns:ns19="http://schemas.openxmlformats.org/wordprocessingml/2006/main" ns19:eastAsia="微软雅黑" ns19:ascii="微软雅黑" ns19:hAnsi="微软雅黑"/>
               </a:rPr>
               <a:t>✓  一键启动脚本 run_web.sh</a:t>
             </a:r>
@@ -16091,7 +16800,7 @@
                   <a:srgbClr val="166534"/>
                 </a:solidFill>
                 <a:latin typeface="微软雅黑"/>
-                <ns18:rFonts xmlns:ns18="http://schemas.openxmlformats.org/wordprocessingml/2006/main" ns18:eastAsia="微软雅黑" ns18:ascii="微软雅黑" ns18:hAnsi="微软雅黑"/>
+                <ns20:rFonts xmlns:ns20="http://schemas.openxmlformats.org/wordprocessingml/2006/main" ns20:eastAsia="微软雅黑" ns20:ascii="微软雅黑" ns20:hAnsi="微软雅黑"/>
               </a:rPr>
               <a:t>✓  fall_eval_report.json</a:t>
             </a:r>
@@ -16108,7 +16817,7 @@
                   <a:srgbClr val="166534"/>
                 </a:solidFill>
                 <a:latin typeface="微软雅黑"/>
-                <ns19:rFonts xmlns:ns19="http://schemas.openxmlformats.org/wordprocessingml/2006/main" ns19:eastAsia="微软雅黑" ns19:ascii="微软雅黑" ns19:hAnsi="微软雅黑"/>
+                <ns21:rFonts xmlns:ns21="http://schemas.openxmlformats.org/wordprocessingml/2006/main" ns21:eastAsia="微软雅黑" ns21:ascii="微软雅黑" ns21:hAnsi="微软雅黑"/>
               </a:rPr>
               <a:t>✓  pytest 单元测试</a:t>
             </a:r>
@@ -16125,740 +16834,13 @@
                   <a:srgbClr val="B45309"/>
                 </a:solidFill>
                 <a:latin typeface="微软雅黑"/>
-                <ns20:rFonts xmlns:ns20="http://schemas.openxmlformats.org/wordprocessingml/2006/main" ns20:eastAsia="微软雅黑" ns20:ascii="微软雅黑" ns20:hAnsi="微软雅黑"/>
+                <ns22:rFonts xmlns:ns22="http://schemas.openxmlformats.org/wordprocessingml/2006/main" ns22:eastAsia="微软雅黑" ns22:ascii="微软雅黑" ns22:hAnsi="微软雅黑"/>
               </a:rPr>
               <a:t>○  软著申请中</a:t>
             </a:r>
           </a:p>
         </p:txBody>
       </p:sp>
-    </p:spTree>
-  </p:cSld>
-  <p:clrMapOvr>
-    <a:masterClrMapping/>
-  </p:clrMapOvr>
-</p:sld>
-</file>
-
-<file path=ppt/slides/slide27.xml><?xml version="1.0" encoding="utf-8"?>
-<p:sld xmlns:a="http://schemas.openxmlformats.org/drawingml/2006/main" xmlns:p="http://schemas.openxmlformats.org/presentationml/2006/main" xmlns:r="http://schemas.openxmlformats.org/officeDocument/2006/relationships">
-  <p:cSld>
-    <p:bg>
-      <p:bgPr>
-        <a:solidFill>
-          <a:srgbClr val="FFFFFF"/>
-        </a:solidFill>
-        <a:effectLst/>
-      </p:bgPr>
-    </p:bg>
-    <p:spTree>
-      <p:nvGrpSpPr>
-        <p:cNvPr id="1" name=""/>
-        <p:cNvGrpSpPr/>
-        <p:nvPr/>
-      </p:nvGrpSpPr>
-      <p:grpSpPr/>
-      <p:sp>
-        <p:nvSpPr>
-          <p:cNvPr id="2" name="Rectangle 1"/>
-          <p:cNvSpPr/>
-          <p:nvPr/>
-        </p:nvSpPr>
-        <p:spPr>
-          <a:xfrm>
-            <a:off x="0" y="0"/>
-            <a:ext cx="9144000" cy="420624"/>
-          </a:xfrm>
-          <a:prstGeom prst="rect">
-            <a:avLst/>
-          </a:prstGeom>
-          <a:solidFill>
-            <a:srgbClr val="143278"/>
-          </a:solidFill>
-          <a:ln>
-            <a:noFill/>
-          </a:ln>
-        </p:spPr>
-        <p:style>
-          <a:lnRef idx="1">
-            <a:schemeClr val="accent1"/>
-          </a:lnRef>
-          <a:fillRef idx="3">
-            <a:schemeClr val="accent1"/>
-          </a:fillRef>
-          <a:effectRef idx="2">
-            <a:schemeClr val="accent1"/>
-          </a:effectRef>
-          <a:fontRef idx="minor">
-            <a:schemeClr val="lt1"/>
-          </a:fontRef>
-        </p:style>
-        <p:txBody>
-          <a:bodyPr rtlCol="0" anchor="ctr"/>
-          <a:lstStyle/>
-          <a:p>
-            <a:pPr algn="ctr"/>
-          </a:p>
-        </p:txBody>
-      </p:sp>
-      <p:sp>
-        <p:nvSpPr>
-          <p:cNvPr id="3" name="TextBox 2"/>
-          <p:cNvSpPr txBox="1"/>
-          <p:nvPr/>
-        </p:nvSpPr>
-        <p:spPr>
-          <a:xfrm>
-            <a:off x="274320" y="54864"/>
-            <a:ext cx="8595360" cy="347472"/>
-          </a:xfrm>
-          <a:prstGeom prst="rect">
-            <a:avLst/>
-          </a:prstGeom>
-          <a:noFill/>
-        </p:spPr>
-        <p:txBody>
-          <a:bodyPr wrap="none">
-            <a:spAutoFit/>
-          </a:bodyPr>
-          <a:lstStyle/>
-          <a:p>
-            <a:r>
-              <a:rPr sz="900" b="1">
-                <a:solidFill>
-                  <a:srgbClr val="FFFFFF"/>
-                </a:solidFill>
-                <a:latin typeface="微软雅黑"/>
-                <ns0:rFonts xmlns:ns0="http://schemas.openxmlformats.org/wordprocessingml/2006/main" ns0:eastAsia="微软雅黑" ns0:ascii="微软雅黑" ns0:hAnsi="微软雅黑"/>
-              </a:rPr>
-              <a:t>第二十八届中国机器人及人工智能大赛  |  创新赛 · 机器人创新赛道</a:t>
-            </a:r>
-          </a:p>
-        </p:txBody>
-      </p:sp>
-      <p:sp>
-        <p:nvSpPr>
-          <p:cNvPr id="4" name="Rectangle 3"/>
-          <p:cNvSpPr/>
-          <p:nvPr/>
-        </p:nvSpPr>
-        <p:spPr>
-          <a:xfrm>
-            <a:off x="0" y="4905756"/>
-            <a:ext cx="9144000" cy="237744"/>
-          </a:xfrm>
-          <a:prstGeom prst="rect">
-            <a:avLst/>
-          </a:prstGeom>
-          <a:solidFill>
-            <a:srgbClr val="DBEAFE"/>
-          </a:solidFill>
-          <a:ln>
-            <a:noFill/>
-          </a:ln>
-        </p:spPr>
-        <p:style>
-          <a:lnRef idx="1">
-            <a:schemeClr val="accent1"/>
-          </a:lnRef>
-          <a:fillRef idx="3">
-            <a:schemeClr val="accent1"/>
-          </a:fillRef>
-          <a:effectRef idx="2">
-            <a:schemeClr val="accent1"/>
-          </a:effectRef>
-          <a:fontRef idx="minor">
-            <a:schemeClr val="lt1"/>
-          </a:fontRef>
-        </p:style>
-        <p:txBody>
-          <a:bodyPr rtlCol="0" anchor="ctr"/>
-          <a:lstStyle/>
-          <a:p>
-            <a:pPr algn="ctr"/>
-          </a:p>
-        </p:txBody>
-      </p:sp>
-      <p:sp>
-        <p:nvSpPr>
-          <p:cNvPr id="5" name="TextBox 4"/>
-          <p:cNvSpPr txBox="1"/>
-          <p:nvPr/>
-        </p:nvSpPr>
-        <p:spPr>
-          <a:xfrm>
-            <a:off x="274320" y="4951476"/>
-            <a:ext cx="8595360" cy="182880"/>
-          </a:xfrm>
-          <a:prstGeom prst="rect">
-            <a:avLst/>
-          </a:prstGeom>
-          <a:noFill/>
-        </p:spPr>
-        <p:txBody>
-          <a:bodyPr wrap="none">
-            <a:spAutoFit/>
-          </a:bodyPr>
-          <a:lstStyle/>
-          <a:p>
-            <a:pPr algn="ctr"/>
-            <a:r>
-              <a:rPr sz="800" b="0">
-                <a:solidFill>
-                  <a:srgbClr val="5A6273"/>
-                </a:solidFill>
-                <a:latin typeface="微软雅黑"/>
-                <ns1:rFonts xmlns:ns1="http://schemas.openxmlformats.org/wordprocessingml/2006/main" ns1:eastAsia="微软雅黑" ns1:ascii="微软雅黑" ns1:hAnsi="微软雅黑"/>
-              </a:rPr>
-              <a:t>从容应队 · 中山大学 · 刘小凡/白冉 · 指导教师 彭键清</a:t>
-            </a:r>
-          </a:p>
-        </p:txBody>
-      </p:sp>
-      <p:sp>
-        <p:nvSpPr>
-          <p:cNvPr id="6" name="Rectangle 5"/>
-          <p:cNvSpPr/>
-          <p:nvPr/>
-        </p:nvSpPr>
-        <p:spPr>
-          <a:xfrm>
-            <a:off x="0" y="420624"/>
-            <a:ext cx="4343400" cy="4430268"/>
-          </a:xfrm>
-          <a:prstGeom prst="rect">
-            <a:avLst/>
-          </a:prstGeom>
-          <a:solidFill>
-            <a:srgbClr val="143278"/>
-          </a:solidFill>
-          <a:ln>
-            <a:noFill/>
-          </a:ln>
-        </p:spPr>
-        <p:style>
-          <a:lnRef idx="1">
-            <a:schemeClr val="accent1"/>
-          </a:lnRef>
-          <a:fillRef idx="3">
-            <a:schemeClr val="accent1"/>
-          </a:fillRef>
-          <a:effectRef idx="2">
-            <a:schemeClr val="accent1"/>
-          </a:effectRef>
-          <a:fontRef idx="minor">
-            <a:schemeClr val="lt1"/>
-          </a:fontRef>
-        </p:style>
-        <p:txBody>
-          <a:bodyPr rtlCol="0" anchor="ctr"/>
-          <a:lstStyle/>
-          <a:p>
-            <a:pPr algn="ctr"/>
-          </a:p>
-        </p:txBody>
-      </p:sp>
-      <p:sp>
-        <p:nvSpPr>
-          <p:cNvPr id="7" name="Oval 6"/>
-          <p:cNvSpPr/>
-          <p:nvPr/>
-        </p:nvSpPr>
-        <p:spPr>
-          <a:xfrm>
-            <a:off x="384048" y="740664"/>
-            <a:ext cx="658368" cy="658368"/>
-          </a:xfrm>
-          <a:prstGeom prst="ellipse">
-            <a:avLst/>
-          </a:prstGeom>
-          <a:solidFill>
-            <a:srgbClr val="F59E0B"/>
-          </a:solidFill>
-          <a:ln>
-            <a:noFill/>
-          </a:ln>
-        </p:spPr>
-        <p:style>
-          <a:lnRef idx="1">
-            <a:schemeClr val="accent1"/>
-          </a:lnRef>
-          <a:fillRef idx="3">
-            <a:schemeClr val="accent1"/>
-          </a:fillRef>
-          <a:effectRef idx="2">
-            <a:schemeClr val="accent1"/>
-          </a:effectRef>
-          <a:fontRef idx="minor">
-            <a:schemeClr val="lt1"/>
-          </a:fontRef>
-        </p:style>
-        <p:txBody>
-          <a:bodyPr rtlCol="0" anchor="ctr"/>
-          <a:lstStyle/>
-          <a:p>
-            <a:pPr algn="ctr"/>
-          </a:p>
-        </p:txBody>
-      </p:sp>
-      <p:sp>
-        <p:nvSpPr>
-          <p:cNvPr id="8" name="TextBox 7"/>
-          <p:cNvSpPr txBox="1"/>
-          <p:nvPr/>
-        </p:nvSpPr>
-        <p:spPr>
-          <a:xfrm>
-            <a:off x="384048" y="804672"/>
-            <a:ext cx="658368" cy="411480"/>
-          </a:xfrm>
-          <a:prstGeom prst="rect">
-            <a:avLst/>
-          </a:prstGeom>
-          <a:noFill/>
-        </p:spPr>
-        <p:txBody>
-          <a:bodyPr wrap="none">
-            <a:spAutoFit/>
-          </a:bodyPr>
-          <a:lstStyle/>
-          <a:p>
-            <a:pPr algn="ctr"/>
-            <a:r>
-              <a:rPr sz="2200" b="1">
-                <a:solidFill>
-                  <a:srgbClr val="FFFFFF"/>
-                </a:solidFill>
-                <a:latin typeface="微软雅黑"/>
-                <ns2:rFonts xmlns:ns2="http://schemas.openxmlformats.org/wordprocessingml/2006/main" ns2:eastAsia="微软雅黑" ns2:ascii="微软雅黑" ns2:hAnsi="微软雅黑"/>
-              </a:rPr>
-              <a:t>四</a:t>
-            </a:r>
-          </a:p>
-        </p:txBody>
-      </p:sp>
-      <p:sp>
-        <p:nvSpPr>
-          <p:cNvPr id="9" name="TextBox 8"/>
-          <p:cNvSpPr txBox="1"/>
-          <p:nvPr/>
-        </p:nvSpPr>
-        <p:spPr>
-          <a:xfrm>
-            <a:off x="347472" y="1472184"/>
-            <a:ext cx="3840480" cy="457200"/>
-          </a:xfrm>
-          <a:prstGeom prst="rect">
-            <a:avLst/>
-          </a:prstGeom>
-          <a:noFill/>
-        </p:spPr>
-        <p:txBody>
-          <a:bodyPr wrap="none">
-            <a:spAutoFit/>
-          </a:bodyPr>
-          <a:lstStyle/>
-          <a:p>
-            <a:r>
-              <a:rPr sz="2400" b="1">
-                <a:solidFill>
-                  <a:srgbClr val="FFFFFF"/>
-                </a:solidFill>
-                <a:latin typeface="微软雅黑"/>
-                <ns3:rFonts xmlns:ns3="http://schemas.openxmlformats.org/wordprocessingml/2006/main" ns3:eastAsia="微软雅黑" ns3:ascii="微软雅黑" ns3:hAnsi="微软雅黑"/>
-              </a:rPr>
-              <a:t>第四部分</a:t>
-            </a:r>
-          </a:p>
-        </p:txBody>
-      </p:sp>
-      <p:sp>
-        <p:nvSpPr>
-          <p:cNvPr id="10" name="TextBox 9"/>
-          <p:cNvSpPr txBox="1"/>
-          <p:nvPr/>
-        </p:nvSpPr>
-        <p:spPr>
-          <a:xfrm>
-            <a:off x="365760" y="1947672"/>
-            <a:ext cx="3840480" cy="347472"/>
-          </a:xfrm>
-          <a:prstGeom prst="rect">
-            <a:avLst/>
-          </a:prstGeom>
-          <a:noFill/>
-        </p:spPr>
-        <p:txBody>
-          <a:bodyPr wrap="none">
-            <a:spAutoFit/>
-          </a:bodyPr>
-          <a:lstStyle/>
-          <a:p>
-            <a:r>
-              <a:rPr sz="1200" b="0">
-                <a:solidFill>
-                  <a:srgbClr val="BFDBFE"/>
-                </a:solidFill>
-                <a:latin typeface="微软雅黑"/>
-                <ns4:rFonts xmlns:ns4="http://schemas.openxmlformats.org/wordprocessingml/2006/main" ns4:eastAsia="微软雅黑" ns4:ascii="微软雅黑" ns4:hAnsi="微软雅黑"/>
-              </a:rPr>
-              <a:t>创新 · 计划</a:t>
-            </a:r>
-          </a:p>
-        </p:txBody>
-      </p:sp>
-      <p:sp>
-        <p:nvSpPr>
-          <p:cNvPr id="11" name="Rectangle 10"/>
-          <p:cNvSpPr/>
-          <p:nvPr/>
-        </p:nvSpPr>
-        <p:spPr>
-          <a:xfrm>
-            <a:off x="384048" y="2432304"/>
-            <a:ext cx="3657600" cy="384048"/>
-          </a:xfrm>
-          <a:prstGeom prst="rect">
-            <a:avLst/>
-          </a:prstGeom>
-          <a:solidFill>
-            <a:srgbClr val="1E4082"/>
-          </a:solidFill>
-          <a:ln>
-            <a:solidFill>
-              <a:srgbClr val="648CC8"/>
-            </a:solidFill>
-          </a:ln>
-        </p:spPr>
-        <p:style>
-          <a:lnRef idx="1">
-            <a:schemeClr val="accent1"/>
-          </a:lnRef>
-          <a:fillRef idx="3">
-            <a:schemeClr val="accent1"/>
-          </a:fillRef>
-          <a:effectRef idx="2">
-            <a:schemeClr val="accent1"/>
-          </a:effectRef>
-          <a:fontRef idx="minor">
-            <a:schemeClr val="lt1"/>
-          </a:fontRef>
-        </p:style>
-        <p:txBody>
-          <a:bodyPr rtlCol="0" anchor="ctr"/>
-          <a:lstStyle/>
-          <a:p>
-            <a:pPr algn="ctr"/>
-          </a:p>
-        </p:txBody>
-      </p:sp>
-      <p:sp>
-        <p:nvSpPr>
-          <p:cNvPr id="12" name="TextBox 11"/>
-          <p:cNvSpPr txBox="1"/>
-          <p:nvPr/>
-        </p:nvSpPr>
-        <p:spPr>
-          <a:xfrm>
-            <a:off x="502920" y="2505456"/>
-            <a:ext cx="3429000" cy="256032"/>
-          </a:xfrm>
-          <a:prstGeom prst="rect">
-            <a:avLst/>
-          </a:prstGeom>
-          <a:noFill/>
-        </p:spPr>
-        <p:txBody>
-          <a:bodyPr wrap="none">
-            <a:spAutoFit/>
-          </a:bodyPr>
-          <a:lstStyle/>
-          <a:p>
-            <a:r>
-              <a:rPr sz="1100" b="0">
-                <a:solidFill>
-                  <a:srgbClr val="E2E8F0"/>
-                </a:solidFill>
-                <a:latin typeface="微软雅黑"/>
-                <ns5:rFonts xmlns:ns5="http://schemas.openxmlformats.org/wordprocessingml/2006/main" ns5:eastAsia="微软雅黑" ns5:ascii="微软雅黑" ns5:hAnsi="微软雅黑"/>
-              </a:rPr>
-              <a:t>五个方向</a:t>
-            </a:r>
-          </a:p>
-        </p:txBody>
-      </p:sp>
-      <p:sp>
-        <p:nvSpPr>
-          <p:cNvPr id="13" name="Rectangle 12"/>
-          <p:cNvSpPr/>
-          <p:nvPr/>
-        </p:nvSpPr>
-        <p:spPr>
-          <a:xfrm>
-            <a:off x="384048" y="2871216"/>
-            <a:ext cx="3657600" cy="384048"/>
-          </a:xfrm>
-          <a:prstGeom prst="rect">
-            <a:avLst/>
-          </a:prstGeom>
-          <a:solidFill>
-            <a:srgbClr val="1E4082"/>
-          </a:solidFill>
-          <a:ln>
-            <a:solidFill>
-              <a:srgbClr val="648CC8"/>
-            </a:solidFill>
-          </a:ln>
-        </p:spPr>
-        <p:style>
-          <a:lnRef idx="1">
-            <a:schemeClr val="accent1"/>
-          </a:lnRef>
-          <a:fillRef idx="3">
-            <a:schemeClr val="accent1"/>
-          </a:fillRef>
-          <a:effectRef idx="2">
-            <a:schemeClr val="accent1"/>
-          </a:effectRef>
-          <a:fontRef idx="minor">
-            <a:schemeClr val="lt1"/>
-          </a:fontRef>
-        </p:style>
-        <p:txBody>
-          <a:bodyPr rtlCol="0" anchor="ctr"/>
-          <a:lstStyle/>
-          <a:p>
-            <a:pPr algn="ctr"/>
-          </a:p>
-        </p:txBody>
-      </p:sp>
-      <p:sp>
-        <p:nvSpPr>
-          <p:cNvPr id="14" name="TextBox 13"/>
-          <p:cNvSpPr txBox="1"/>
-          <p:nvPr/>
-        </p:nvSpPr>
-        <p:spPr>
-          <a:xfrm>
-            <a:off x="502920" y="2944368"/>
-            <a:ext cx="3429000" cy="256032"/>
-          </a:xfrm>
-          <a:prstGeom prst="rect">
-            <a:avLst/>
-          </a:prstGeom>
-          <a:noFill/>
-        </p:spPr>
-        <p:txBody>
-          <a:bodyPr wrap="none">
-            <a:spAutoFit/>
-          </a:bodyPr>
-          <a:lstStyle/>
-          <a:p>
-            <a:r>
-              <a:rPr sz="1100" b="0">
-                <a:solidFill>
-                  <a:srgbClr val="E2E8F0"/>
-                </a:solidFill>
-                <a:latin typeface="微软雅黑"/>
-                <ns6:rFonts xmlns:ns6="http://schemas.openxmlformats.org/wordprocessingml/2006/main" ns6:eastAsia="微软雅黑" ns6:ascii="微软雅黑" ns6:hAnsi="微软雅黑"/>
-              </a:rPr>
-              <a:t>真机</a:t>
-            </a:r>
-          </a:p>
-        </p:txBody>
-      </p:sp>
-      <p:sp>
-        <p:nvSpPr>
-          <p:cNvPr id="15" name="Rectangle 14"/>
-          <p:cNvSpPr/>
-          <p:nvPr/>
-        </p:nvSpPr>
-        <p:spPr>
-          <a:xfrm>
-            <a:off x="384048" y="3310128"/>
-            <a:ext cx="3657600" cy="384048"/>
-          </a:xfrm>
-          <a:prstGeom prst="rect">
-            <a:avLst/>
-          </a:prstGeom>
-          <a:solidFill>
-            <a:srgbClr val="1E4082"/>
-          </a:solidFill>
-          <a:ln>
-            <a:solidFill>
-              <a:srgbClr val="648CC8"/>
-            </a:solidFill>
-          </a:ln>
-        </p:spPr>
-        <p:style>
-          <a:lnRef idx="1">
-            <a:schemeClr val="accent1"/>
-          </a:lnRef>
-          <a:fillRef idx="3">
-            <a:schemeClr val="accent1"/>
-          </a:fillRef>
-          <a:effectRef idx="2">
-            <a:schemeClr val="accent1"/>
-          </a:effectRef>
-          <a:fontRef idx="minor">
-            <a:schemeClr val="lt1"/>
-          </a:fontRef>
-        </p:style>
-        <p:txBody>
-          <a:bodyPr rtlCol="0" anchor="ctr"/>
-          <a:lstStyle/>
-          <a:p>
-            <a:pPr algn="ctr"/>
-          </a:p>
-        </p:txBody>
-      </p:sp>
-      <p:sp>
-        <p:nvSpPr>
-          <p:cNvPr id="16" name="TextBox 15"/>
-          <p:cNvSpPr txBox="1"/>
-          <p:nvPr/>
-        </p:nvSpPr>
-        <p:spPr>
-          <a:xfrm>
-            <a:off x="502920" y="3383280"/>
-            <a:ext cx="3429000" cy="256032"/>
-          </a:xfrm>
-          <a:prstGeom prst="rect">
-            <a:avLst/>
-          </a:prstGeom>
-          <a:noFill/>
-        </p:spPr>
-        <p:txBody>
-          <a:bodyPr wrap="none">
-            <a:spAutoFit/>
-          </a:bodyPr>
-          <a:lstStyle/>
-          <a:p>
-            <a:r>
-              <a:rPr sz="1100" b="0">
-                <a:solidFill>
-                  <a:srgbClr val="E2E8F0"/>
-                </a:solidFill>
-                <a:latin typeface="微软雅黑"/>
-                <ns7:rFonts xmlns:ns7="http://schemas.openxmlformats.org/wordprocessingml/2006/main" ns7:eastAsia="微软雅黑" ns7:ascii="微软雅黑" ns7:hAnsi="微软雅黑"/>
-              </a:rPr>
-              <a:t>软著</a:t>
-            </a:r>
-          </a:p>
-        </p:txBody>
-      </p:sp>
-      <p:sp>
-        <p:nvSpPr>
-          <p:cNvPr id="17" name="Rectangle 16"/>
-          <p:cNvSpPr/>
-          <p:nvPr/>
-        </p:nvSpPr>
-        <p:spPr>
-          <a:xfrm>
-            <a:off x="4343400" y="420624"/>
-            <a:ext cx="4800600" cy="4430268"/>
-          </a:xfrm>
-          <a:prstGeom prst="rect">
-            <a:avLst/>
-          </a:prstGeom>
-          <a:solidFill>
-            <a:srgbClr val="F1F7FF"/>
-          </a:solidFill>
-          <a:ln>
-            <a:noFill/>
-          </a:ln>
-        </p:spPr>
-        <p:style>
-          <a:lnRef idx="1">
-            <a:schemeClr val="accent1"/>
-          </a:lnRef>
-          <a:fillRef idx="3">
-            <a:schemeClr val="accent1"/>
-          </a:fillRef>
-          <a:effectRef idx="2">
-            <a:schemeClr val="accent1"/>
-          </a:effectRef>
-          <a:fontRef idx="minor">
-            <a:schemeClr val="lt1"/>
-          </a:fontRef>
-        </p:style>
-        <p:txBody>
-          <a:bodyPr rtlCol="0" anchor="ctr"/>
-          <a:lstStyle/>
-          <a:p>
-            <a:pPr algn="ctr"/>
-          </a:p>
-        </p:txBody>
-      </p:sp>
-      <p:sp>
-        <p:nvSpPr>
-          <p:cNvPr id="18" name="Rectangle 17"/>
-          <p:cNvSpPr/>
-          <p:nvPr/>
-        </p:nvSpPr>
-        <p:spPr>
-          <a:xfrm>
-            <a:off x="4503008" y="1719518"/>
-            <a:ext cx="4481382" cy="2371975"/>
-          </a:xfrm>
-          <a:prstGeom prst="rect">
-            <a:avLst/>
-          </a:prstGeom>
-          <a:solidFill>
-            <a:srgbClr val="FCFDFF"/>
-          </a:solidFill>
-          <a:ln w="7620">
-            <a:solidFill>
-              <a:srgbClr val="BAC8DC"/>
-            </a:solidFill>
-          </a:ln>
-        </p:spPr>
-        <p:style>
-          <a:lnRef idx="1">
-            <a:schemeClr val="accent1"/>
-          </a:lnRef>
-          <a:fillRef idx="3">
-            <a:schemeClr val="accent1"/>
-          </a:fillRef>
-          <a:effectRef idx="2">
-            <a:schemeClr val="accent1"/>
-          </a:effectRef>
-          <a:fontRef idx="minor">
-            <a:schemeClr val="lt1"/>
-          </a:fontRef>
-        </p:style>
-        <p:txBody>
-          <a:bodyPr rtlCol="0" anchor="ctr"/>
-          <a:lstStyle/>
-          <a:p>
-            <a:pPr algn="ctr"/>
-          </a:p>
-        </p:txBody>
-      </p:sp>
-      <p:pic>
-        <p:nvPicPr>
-          <p:cNvPr id="19" name="Picture 18" descr="ppt_full_dashboard.png"/>
-          <p:cNvPicPr>
-            <a:picLocks noChangeAspect="1"/>
-          </p:cNvPicPr>
-          <p:nvPr/>
-        </p:nvPicPr>
-        <p:blipFill>
-          <a:blip r:embed="rId2"/>
-          <a:stretch>
-            <a:fillRect/>
-          </a:stretch>
-        </p:blipFill>
-        <p:spPr>
-          <a:xfrm>
-            <a:off x="4539584" y="1756094"/>
-            <a:ext cx="4408230" cy="2298823"/>
-          </a:xfrm>
-          <a:prstGeom prst="rect">
-            <a:avLst/>
-          </a:prstGeom>
-        </p:spPr>
-      </p:pic>
     </p:spTree>
   </p:cSld>
   <p:clrMapOvr>
@@ -17044,52 +17026,59 @@
       </p:sp>
       <p:sp>
         <p:nvSpPr>
-          <p:cNvPr id="6" name="TextBox 5"/>
-          <p:cNvSpPr txBox="1"/>
-          <p:nvPr/>
-        </p:nvSpPr>
-        <p:spPr>
-          <a:xfrm>
-            <a:off x="274320" y="466344"/>
-            <a:ext cx="8595360" cy="457200"/>
-          </a:xfrm>
-          <a:prstGeom prst="rect">
-            <a:avLst/>
-          </a:prstGeom>
-          <a:noFill/>
-        </p:spPr>
-        <p:txBody>
-          <a:bodyPr wrap="none">
-            <a:spAutoFit/>
-          </a:bodyPr>
-          <a:lstStyle/>
-          <a:p>
-            <a:pPr algn="l"/>
-            <a:r>
-              <a:rPr sz="2000" b="1">
-                <a:solidFill>
-                  <a:srgbClr val="143278"/>
-                </a:solidFill>
-                <a:latin typeface="微软雅黑"/>
-                <ns2:rFonts xmlns:ns2="http://schemas.openxmlformats.org/wordprocessingml/2006/main" ns2:eastAsia="微软雅黑" ns2:ascii="微软雅黑" ns2:hAnsi="微软雅黑"/>
-              </a:rPr>
-              <a:t>创新点</a:t>
-            </a:r>
-          </a:p>
-        </p:txBody>
-      </p:sp>
-      <p:sp>
-        <p:nvSpPr>
-          <p:cNvPr id="7" name="Rectangle 6"/>
+          <p:cNvPr id="6" name="Rectangle 5"/>
           <p:cNvSpPr/>
           <p:nvPr/>
         </p:nvSpPr>
         <p:spPr>
           <a:xfrm>
-            <a:off x="274320" y="886968"/>
-            <a:ext cx="1143000" cy="50292"/>
-          </a:xfrm>
-          <a:prstGeom prst="rect">
+            <a:off x="0" y="420624"/>
+            <a:ext cx="4343400" cy="4430268"/>
+          </a:xfrm>
+          <a:prstGeom prst="rect">
+            <a:avLst/>
+          </a:prstGeom>
+          <a:solidFill>
+            <a:srgbClr val="143278"/>
+          </a:solidFill>
+          <a:ln>
+            <a:noFill/>
+          </a:ln>
+        </p:spPr>
+        <p:style>
+          <a:lnRef idx="1">
+            <a:schemeClr val="accent1"/>
+          </a:lnRef>
+          <a:fillRef idx="3">
+            <a:schemeClr val="accent1"/>
+          </a:fillRef>
+          <a:effectRef idx="2">
+            <a:schemeClr val="accent1"/>
+          </a:effectRef>
+          <a:fontRef idx="minor">
+            <a:schemeClr val="lt1"/>
+          </a:fontRef>
+        </p:style>
+        <p:txBody>
+          <a:bodyPr rtlCol="0" anchor="ctr"/>
+          <a:lstStyle/>
+          <a:p>
+            <a:pPr algn="ctr"/>
+          </a:p>
+        </p:txBody>
+      </p:sp>
+      <p:sp>
+        <p:nvSpPr>
+          <p:cNvPr id="7" name="Oval 6"/>
+          <p:cNvSpPr/>
+          <p:nvPr/>
+        </p:nvSpPr>
+        <p:spPr>
+          <a:xfrm>
+            <a:off x="384048" y="740664"/>
+            <a:ext cx="658368" cy="658368"/>
+          </a:xfrm>
+          <a:prstGeom prst="ellipse">
             <a:avLst/>
           </a:prstGeom>
           <a:solidFill>
@@ -17123,24 +17112,130 @@
       </p:sp>
       <p:sp>
         <p:nvSpPr>
-          <p:cNvPr id="8" name="Rectangle 7"/>
+          <p:cNvPr id="8" name="TextBox 7"/>
+          <p:cNvSpPr txBox="1"/>
+          <p:nvPr/>
+        </p:nvSpPr>
+        <p:spPr>
+          <a:xfrm>
+            <a:off x="384048" y="804672"/>
+            <a:ext cx="658368" cy="411480"/>
+          </a:xfrm>
+          <a:prstGeom prst="rect">
+            <a:avLst/>
+          </a:prstGeom>
+          <a:noFill/>
+        </p:spPr>
+        <p:txBody>
+          <a:bodyPr wrap="none">
+            <a:spAutoFit/>
+          </a:bodyPr>
+          <a:lstStyle/>
+          <a:p>
+            <a:pPr algn="ctr"/>
+            <a:r>
+              <a:rPr sz="2200" b="1">
+                <a:solidFill>
+                  <a:srgbClr val="FFFFFF"/>
+                </a:solidFill>
+                <a:latin typeface="微软雅黑"/>
+                <ns2:rFonts xmlns:ns2="http://schemas.openxmlformats.org/wordprocessingml/2006/main" ns2:eastAsia="微软雅黑" ns2:ascii="微软雅黑" ns2:hAnsi="微软雅黑"/>
+              </a:rPr>
+              <a:t>四</a:t>
+            </a:r>
+          </a:p>
+        </p:txBody>
+      </p:sp>
+      <p:sp>
+        <p:nvSpPr>
+          <p:cNvPr id="9" name="TextBox 8"/>
+          <p:cNvSpPr txBox="1"/>
+          <p:nvPr/>
+        </p:nvSpPr>
+        <p:spPr>
+          <a:xfrm>
+            <a:off x="347472" y="1472184"/>
+            <a:ext cx="3840480" cy="457200"/>
+          </a:xfrm>
+          <a:prstGeom prst="rect">
+            <a:avLst/>
+          </a:prstGeom>
+          <a:noFill/>
+        </p:spPr>
+        <p:txBody>
+          <a:bodyPr wrap="none">
+            <a:spAutoFit/>
+          </a:bodyPr>
+          <a:lstStyle/>
+          <a:p>
+            <a:r>
+              <a:rPr sz="2400" b="1">
+                <a:solidFill>
+                  <a:srgbClr val="FFFFFF"/>
+                </a:solidFill>
+                <a:latin typeface="微软雅黑"/>
+                <ns3:rFonts xmlns:ns3="http://schemas.openxmlformats.org/wordprocessingml/2006/main" ns3:eastAsia="微软雅黑" ns3:ascii="微软雅黑" ns3:hAnsi="微软雅黑"/>
+              </a:rPr>
+              <a:t>第四部分</a:t>
+            </a:r>
+          </a:p>
+        </p:txBody>
+      </p:sp>
+      <p:sp>
+        <p:nvSpPr>
+          <p:cNvPr id="10" name="TextBox 9"/>
+          <p:cNvSpPr txBox="1"/>
+          <p:nvPr/>
+        </p:nvSpPr>
+        <p:spPr>
+          <a:xfrm>
+            <a:off x="365760" y="1947672"/>
+            <a:ext cx="3840480" cy="347472"/>
+          </a:xfrm>
+          <a:prstGeom prst="rect">
+            <a:avLst/>
+          </a:prstGeom>
+          <a:noFill/>
+        </p:spPr>
+        <p:txBody>
+          <a:bodyPr wrap="none">
+            <a:spAutoFit/>
+          </a:bodyPr>
+          <a:lstStyle/>
+          <a:p>
+            <a:r>
+              <a:rPr sz="1200" b="0">
+                <a:solidFill>
+                  <a:srgbClr val="BFDBFE"/>
+                </a:solidFill>
+                <a:latin typeface="微软雅黑"/>
+                <ns4:rFonts xmlns:ns4="http://schemas.openxmlformats.org/wordprocessingml/2006/main" ns4:eastAsia="微软雅黑" ns4:ascii="微软雅黑" ns4:hAnsi="微软雅黑"/>
+              </a:rPr>
+              <a:t>创新 · 计划</a:t>
+            </a:r>
+          </a:p>
+        </p:txBody>
+      </p:sp>
+      <p:sp>
+        <p:nvSpPr>
+          <p:cNvPr id="11" name="Rectangle 10"/>
           <p:cNvSpPr/>
           <p:nvPr/>
         </p:nvSpPr>
         <p:spPr>
           <a:xfrm>
-            <a:off x="274320" y="996696"/>
-            <a:ext cx="3611880" cy="3854196"/>
+            <a:off x="384048" y="2432304"/>
+            <a:ext cx="3657600" cy="384048"/>
           </a:xfrm>
           <a:prstGeom prst="rect">
             <a:avLst/>
           </a:prstGeom>
           <a:solidFill>
-            <a:srgbClr val="F1F7FF"/>
+            <a:srgbClr val="1E4082"/>
           </a:solidFill>
-          <a:ln w="10160">
+          <a:ln>
             <a:solidFill>
-              <a:srgbClr val="BAC8DC"/>
+              <a:srgbClr val="648CC8"/>
             </a:solidFill>
           </a:ln>
         </p:spPr>
@@ -17168,23 +17263,60 @@
       </p:sp>
       <p:sp>
         <p:nvSpPr>
-          <p:cNvPr id="9" name="Rectangle 8"/>
+          <p:cNvPr id="12" name="TextBox 11"/>
+          <p:cNvSpPr txBox="1"/>
+          <p:nvPr/>
+        </p:nvSpPr>
+        <p:spPr>
+          <a:xfrm>
+            <a:off x="502920" y="2505456"/>
+            <a:ext cx="3429000" cy="256032"/>
+          </a:xfrm>
+          <a:prstGeom prst="rect">
+            <a:avLst/>
+          </a:prstGeom>
+          <a:noFill/>
+        </p:spPr>
+        <p:txBody>
+          <a:bodyPr wrap="none">
+            <a:spAutoFit/>
+          </a:bodyPr>
+          <a:lstStyle/>
+          <a:p>
+            <a:r>
+              <a:rPr sz="1100" b="0">
+                <a:solidFill>
+                  <a:srgbClr val="E2E8F0"/>
+                </a:solidFill>
+                <a:latin typeface="微软雅黑"/>
+                <ns5:rFonts xmlns:ns5="http://schemas.openxmlformats.org/wordprocessingml/2006/main" ns5:eastAsia="微软雅黑" ns5:ascii="微软雅黑" ns5:hAnsi="微软雅黑"/>
+              </a:rPr>
+              <a:t>五个方向</a:t>
+            </a:r>
+          </a:p>
+        </p:txBody>
+      </p:sp>
+      <p:sp>
+        <p:nvSpPr>
+          <p:cNvPr id="13" name="Rectangle 12"/>
           <p:cNvSpPr/>
           <p:nvPr/>
         </p:nvSpPr>
         <p:spPr>
           <a:xfrm>
-            <a:off x="274320" y="996696"/>
-            <a:ext cx="73152" cy="3854196"/>
+            <a:off x="384048" y="2871216"/>
+            <a:ext cx="3657600" cy="384048"/>
           </a:xfrm>
           <a:prstGeom prst="rect">
             <a:avLst/>
           </a:prstGeom>
           <a:solidFill>
-            <a:srgbClr val="143278"/>
+            <a:srgbClr val="1E4082"/>
           </a:solidFill>
           <a:ln>
-            <a:noFill/>
+            <a:solidFill>
+              <a:srgbClr val="648CC8"/>
+            </a:solidFill>
           </a:ln>
         </p:spPr>
         <p:style>
@@ -17211,14 +17343,14 @@
       </p:sp>
       <p:sp>
         <p:nvSpPr>
-          <p:cNvPr id="10" name="TextBox 9"/>
+          <p:cNvPr id="14" name="TextBox 13"/>
           <p:cNvSpPr txBox="1"/>
           <p:nvPr/>
         </p:nvSpPr>
         <p:spPr>
           <a:xfrm>
-            <a:off x="438912" y="1106424"/>
-            <a:ext cx="3282696" cy="708660"/>
+            <a:off x="502920" y="2944368"/>
+            <a:ext cx="3429000" cy="256032"/>
           </a:xfrm>
           <a:prstGeom prst="rect">
             <a:avLst/>
@@ -17226,200 +17358,20 @@
           <a:noFill/>
         </p:spPr>
         <p:txBody>
-          <a:bodyPr wrap="square" anchor="t" lIns="25400" tIns="0">
+          <a:bodyPr wrap="none">
             <a:spAutoFit/>
           </a:bodyPr>
           <a:lstStyle/>
           <a:p>
-            <a:pPr>
-              <a:lnSpc>
-                <a:spcPct val="112000"/>
-              </a:lnSpc>
-              <a:spcAft>
-                <a:spcPts val="200"/>
-              </a:spcAft>
-            </a:pPr>
-            <a:r>
-              <a:rPr sz="1300" b="0">
-                <a:solidFill>
-                  <a:srgbClr val="1C202C"/>
-                </a:solidFill>
-                <a:latin typeface="微软雅黑"/>
-                <ns3:rFonts xmlns:ns3="http://schemas.openxmlformats.org/wordprocessingml/2006/main" ns3:eastAsia="微软雅黑" ns3:ascii="微软雅黑" ns3:hAnsi="微软雅黑"/>
-              </a:rPr>
-              <a:t>● 多路信号融合，结果能解释</a:t>
-            </a:r>
-          </a:p>
-        </p:txBody>
-      </p:sp>
-      <p:sp>
-        <p:nvSpPr>
-          <p:cNvPr id="11" name="TextBox 10"/>
-          <p:cNvSpPr txBox="1"/>
-          <p:nvPr/>
-        </p:nvSpPr>
-        <p:spPr>
-          <a:xfrm>
-            <a:off x="438912" y="1833372"/>
-            <a:ext cx="3282696" cy="708660"/>
-          </a:xfrm>
-          <a:prstGeom prst="rect">
-            <a:avLst/>
-          </a:prstGeom>
-          <a:noFill/>
-        </p:spPr>
-        <p:txBody>
-          <a:bodyPr wrap="square" anchor="t" lIns="25400" tIns="0">
-            <a:spAutoFit/>
-          </a:bodyPr>
-          <a:lstStyle/>
-          <a:p>
-            <a:pPr>
-              <a:lnSpc>
-                <a:spcPct val="112000"/>
-              </a:lnSpc>
-              <a:spcAft>
-                <a:spcPts val="200"/>
-              </a:spcAft>
-            </a:pPr>
-            <a:r>
-              <a:rPr sz="1300" b="0">
-                <a:solidFill>
-                  <a:srgbClr val="1C202C"/>
-                </a:solidFill>
-                <a:latin typeface="微软雅黑"/>
-                <ns4:rFonts xmlns:ns4="http://schemas.openxmlformats.org/wordprocessingml/2006/main" ns4:eastAsia="微软雅黑" ns4:ascii="微软雅黑" ns4:hAnsi="微软雅黑"/>
-              </a:rPr>
-              <a:t>● 紧急态在状态机里优先级最高</a:t>
-            </a:r>
-          </a:p>
-        </p:txBody>
-      </p:sp>
-      <p:sp>
-        <p:nvSpPr>
-          <p:cNvPr id="12" name="TextBox 11"/>
-          <p:cNvSpPr txBox="1"/>
-          <p:nvPr/>
-        </p:nvSpPr>
-        <p:spPr>
-          <a:xfrm>
-            <a:off x="438912" y="2560320"/>
-            <a:ext cx="3282696" cy="708660"/>
-          </a:xfrm>
-          <a:prstGeom prst="rect">
-            <a:avLst/>
-          </a:prstGeom>
-          <a:noFill/>
-        </p:spPr>
-        <p:txBody>
-          <a:bodyPr wrap="square" anchor="t" lIns="25400" tIns="0">
-            <a:spAutoFit/>
-          </a:bodyPr>
-          <a:lstStyle/>
-          <a:p>
-            <a:pPr>
-              <a:lnSpc>
-                <a:spcPct val="112000"/>
-              </a:lnSpc>
-              <a:spcAft>
-                <a:spcPts val="200"/>
-              </a:spcAft>
-            </a:pPr>
-            <a:r>
-              <a:rPr sz="1300" b="0">
-                <a:solidFill>
-                  <a:srgbClr val="1C202C"/>
-                </a:solidFill>
-                <a:latin typeface="微软雅黑"/>
-                <ns5:rFonts xmlns:ns5="http://schemas.openxmlformats.org/wordprocessingml/2006/main" ns5:eastAsia="微软雅黑" ns5:ascii="微软雅黑" ns5:hAnsi="微软雅黑"/>
-              </a:rPr>
-              <a:t>● 视觉用 MediaPipe，不是纯参数滑块</a:t>
-            </a:r>
-          </a:p>
-        </p:txBody>
-      </p:sp>
-      <p:sp>
-        <p:nvSpPr>
-          <p:cNvPr id="13" name="TextBox 12"/>
-          <p:cNvSpPr txBox="1"/>
-          <p:nvPr/>
-        </p:nvSpPr>
-        <p:spPr>
-          <a:xfrm>
-            <a:off x="438912" y="3287268"/>
-            <a:ext cx="3282696" cy="708660"/>
-          </a:xfrm>
-          <a:prstGeom prst="rect">
-            <a:avLst/>
-          </a:prstGeom>
-          <a:noFill/>
-        </p:spPr>
-        <p:txBody>
-          <a:bodyPr wrap="square" anchor="t" lIns="25400" tIns="0">
-            <a:spAutoFit/>
-          </a:bodyPr>
-          <a:lstStyle/>
-          <a:p>
-            <a:pPr>
-              <a:lnSpc>
-                <a:spcPct val="112000"/>
-              </a:lnSpc>
-              <a:spcAft>
-                <a:spcPts val="200"/>
-              </a:spcAft>
-            </a:pPr>
-            <a:r>
-              <a:rPr sz="1300" b="0">
-                <a:solidFill>
-                  <a:srgbClr val="1C202C"/>
+            <a:r>
+              <a:rPr sz="1100" b="0">
+                <a:solidFill>
+                  <a:srgbClr val="E2E8F0"/>
                 </a:solidFill>
                 <a:latin typeface="微软雅黑"/>
                 <ns6:rFonts xmlns:ns6="http://schemas.openxmlformats.org/wordprocessingml/2006/main" ns6:eastAsia="微软雅黑" ns6:ascii="微软雅黑" ns6:hAnsi="微软雅黑"/>
               </a:rPr>
-              <a:t>● 代码和评测脚本都开源</a:t>
-            </a:r>
-          </a:p>
-        </p:txBody>
-      </p:sp>
-      <p:sp>
-        <p:nvSpPr>
-          <p:cNvPr id="14" name="TextBox 13"/>
-          <p:cNvSpPr txBox="1"/>
-          <p:nvPr/>
-        </p:nvSpPr>
-        <p:spPr>
-          <a:xfrm>
-            <a:off x="438912" y="4014216"/>
-            <a:ext cx="3282696" cy="708660"/>
-          </a:xfrm>
-          <a:prstGeom prst="rect">
-            <a:avLst/>
-          </a:prstGeom>
-          <a:noFill/>
-        </p:spPr>
-        <p:txBody>
-          <a:bodyPr wrap="square" anchor="t" lIns="25400" tIns="0">
-            <a:spAutoFit/>
-          </a:bodyPr>
-          <a:lstStyle/>
-          <a:p>
-            <a:pPr>
-              <a:lnSpc>
-                <a:spcPct val="112000"/>
-              </a:lnSpc>
-              <a:spcAft>
-                <a:spcPts val="200"/>
-              </a:spcAft>
-            </a:pPr>
-            <a:r>
-              <a:rPr sz="1300" b="0">
-                <a:solidFill>
-                  <a:srgbClr val="1C202C"/>
-                </a:solidFill>
-                <a:latin typeface="微软雅黑"/>
-                <ns7:rFonts xmlns:ns7="http://schemas.openxmlformats.org/wordprocessingml/2006/main" ns7:eastAsia="微软雅黑" ns7:ascii="微软雅黑" ns7:hAnsi="微软雅黑"/>
-              </a:rPr>
-              <a:t>● 场景对准居家养老</a:t>
+              <a:t>真机</a:t>
             </a:r>
           </a:p>
         </p:txBody>
@@ -17432,18 +17384,18 @@
         </p:nvSpPr>
         <p:spPr>
           <a:xfrm>
-            <a:off x="4105656" y="1033272"/>
-            <a:ext cx="4727448" cy="3744468"/>
+            <a:off x="384048" y="3310128"/>
+            <a:ext cx="3657600" cy="384048"/>
           </a:xfrm>
           <a:prstGeom prst="rect">
             <a:avLst/>
           </a:prstGeom>
           <a:solidFill>
-            <a:srgbClr val="FFFFFF"/>
+            <a:srgbClr val="1E4082"/>
           </a:solidFill>
-          <a:ln w="9525">
+          <a:ln>
             <a:solidFill>
-              <a:srgbClr val="BAC8DC"/>
+              <a:srgbClr val="648CC8"/>
             </a:solidFill>
           </a:ln>
         </p:spPr>
@@ -17471,20 +17423,55 @@
       </p:sp>
       <p:sp>
         <p:nvSpPr>
-          <p:cNvPr id="16" name="Rectangle 15"/>
+          <p:cNvPr id="16" name="TextBox 15"/>
+          <p:cNvSpPr txBox="1"/>
+          <p:nvPr/>
+        </p:nvSpPr>
+        <p:spPr>
+          <a:xfrm>
+            <a:off x="502920" y="3383280"/>
+            <a:ext cx="3429000" cy="256032"/>
+          </a:xfrm>
+          <a:prstGeom prst="rect">
+            <a:avLst/>
+          </a:prstGeom>
+          <a:noFill/>
+        </p:spPr>
+        <p:txBody>
+          <a:bodyPr wrap="none">
+            <a:spAutoFit/>
+          </a:bodyPr>
+          <a:lstStyle/>
+          <a:p>
+            <a:r>
+              <a:rPr sz="1100" b="0">
+                <a:solidFill>
+                  <a:srgbClr val="E2E8F0"/>
+                </a:solidFill>
+                <a:latin typeface="微软雅黑"/>
+                <ns7:rFonts xmlns:ns7="http://schemas.openxmlformats.org/wordprocessingml/2006/main" ns7:eastAsia="微软雅黑" ns7:ascii="微软雅黑" ns7:hAnsi="微软雅黑"/>
+              </a:rPr>
+              <a:t>软著</a:t>
+            </a:r>
+          </a:p>
+        </p:txBody>
+      </p:sp>
+      <p:sp>
+        <p:nvSpPr>
+          <p:cNvPr id="17" name="Rectangle 16"/>
           <p:cNvSpPr/>
           <p:nvPr/>
         </p:nvSpPr>
         <p:spPr>
           <a:xfrm>
-            <a:off x="3968496" y="996696"/>
-            <a:ext cx="10972" cy="3854196"/>
+            <a:off x="4343400" y="420624"/>
+            <a:ext cx="4800600" cy="4430268"/>
           </a:xfrm>
           <a:prstGeom prst="rect">
             <a:avLst/>
           </a:prstGeom>
           <a:solidFill>
-            <a:srgbClr val="BAC8DC"/>
+            <a:srgbClr val="F1F7FF"/>
           </a:solidFill>
           <a:ln>
             <a:noFill/>
@@ -17514,14 +17501,14 @@
       </p:sp>
       <p:sp>
         <p:nvSpPr>
-          <p:cNvPr id="17" name="Rectangle 16"/>
+          <p:cNvPr id="18" name="Rectangle 17"/>
           <p:cNvSpPr/>
           <p:nvPr/>
         </p:nvSpPr>
         <p:spPr>
           <a:xfrm>
-            <a:off x="4308652" y="1202355"/>
-            <a:ext cx="4321454" cy="3113692"/>
+            <a:off x="4503008" y="1719518"/>
+            <a:ext cx="4481382" cy="2371975"/>
           </a:xfrm>
           <a:prstGeom prst="rect">
             <a:avLst/>
@@ -17559,7 +17546,7 @@
       </p:sp>
       <p:pic>
         <p:nvPicPr>
-          <p:cNvPr id="18" name="Picture 17" descr="innovation_radar.png"/>
+          <p:cNvPr id="19" name="Picture 18" descr="ppt_full_dashboard.png"/>
           <p:cNvPicPr>
             <a:picLocks noChangeAspect="1"/>
           </p:cNvPicPr>
@@ -17573,50 +17560,14 @@
         </p:blipFill>
         <p:spPr>
           <a:xfrm>
-            <a:off x="4345228" y="1238931"/>
-            <a:ext cx="4248302" cy="3040540"/>
+            <a:off x="4539584" y="1756094"/>
+            <a:ext cx="4408230" cy="2298823"/>
           </a:xfrm>
           <a:prstGeom prst="rect">
             <a:avLst/>
           </a:prstGeom>
         </p:spPr>
       </p:pic>
-      <p:sp>
-        <p:nvSpPr>
-          <p:cNvPr id="19" name="TextBox 18"/>
-          <p:cNvSpPr txBox="1"/>
-          <p:nvPr/>
-        </p:nvSpPr>
-        <p:spPr>
-          <a:xfrm>
-            <a:off x="4160520" y="4521708"/>
-            <a:ext cx="4617720" cy="219456"/>
-          </a:xfrm>
-          <a:prstGeom prst="rect">
-            <a:avLst/>
-          </a:prstGeom>
-          <a:noFill/>
-        </p:spPr>
-        <p:txBody>
-          <a:bodyPr wrap="square" anchor="ctr">
-            <a:spAutoFit/>
-          </a:bodyPr>
-          <a:lstStyle/>
-          <a:p>
-            <a:pPr algn="ctr"/>
-            <a:r>
-              <a:rPr sz="800" b="0">
-                <a:solidFill>
-                  <a:srgbClr val="5A6273"/>
-                </a:solidFill>
-                <a:latin typeface="微软雅黑"/>
-                <ns8:rFonts xmlns:ns8="http://schemas.openxmlformats.org/wordprocessingml/2006/main" ns8:eastAsia="微软雅黑" ns8:ascii="微软雅黑" ns8:hAnsi="微软雅黑"/>
-              </a:rPr>
-              <a:t>实验结果</a:t>
-            </a:r>
-          </a:p>
-        </p:txBody>
-      </p:sp>
     </p:spTree>
   </p:cSld>
   <p:clrMapOvr>
@@ -17831,7 +17782,7 @@
                 <a:latin typeface="微软雅黑"/>
                 <ns2:rFonts xmlns:ns2="http://schemas.openxmlformats.org/wordprocessingml/2006/main" ns2:eastAsia="微软雅黑" ns2:ascii="微软雅黑" ns2:hAnsi="微软雅黑"/>
               </a:rPr>
-              <a:t>后面打算做什么</a:t>
+              <a:t>创新点</a:t>
             </a:r>
           </a:p>
         </p:txBody>
@@ -18005,7 +17956,7 @@
                 <a:latin typeface="微软雅黑"/>
                 <ns3:rFonts xmlns:ns3="http://schemas.openxmlformats.org/wordprocessingml/2006/main" ns3:eastAsia="微软雅黑" ns3:ascii="微软雅黑" ns3:hAnsi="微软雅黑"/>
               </a:rPr>
-              <a:t>● 对接 Unitree 等人形真机</a:t>
+              <a:t>● 多路信号融合，结果能解释</a:t>
             </a:r>
           </a:p>
         </p:txBody>
@@ -18048,7 +17999,7 @@
                 <a:latin typeface="微软雅黑"/>
                 <ns4:rFonts xmlns:ns4="http://schemas.openxmlformats.org/wordprocessingml/2006/main" ns4:eastAsia="微软雅黑" ns4:ascii="微软雅黑" ns4:hAnsi="微软雅黑"/>
               </a:rPr>
-              <a:t>● 补充公开跌倒数据集</a:t>
+              <a:t>● 紧急态在状态机里优先级最高</a:t>
             </a:r>
           </a:p>
         </p:txBody>
@@ -18091,7 +18042,7 @@
                 <a:latin typeface="微软雅黑"/>
                 <ns5:rFonts xmlns:ns5="http://schemas.openxmlformats.org/wordprocessingml/2006/main" ns5:eastAsia="微软雅黑" ns5:ascii="微软雅黑" ns5:hAnsi="微软雅黑"/>
               </a:rPr>
-              <a:t>● 做多房间、弱光等复杂场景</a:t>
+              <a:t>● 视觉用 MediaPipe，不是纯参数滑块</a:t>
             </a:r>
           </a:p>
         </p:txBody>
@@ -18134,7 +18085,7 @@
                 <a:latin typeface="微软雅黑"/>
                 <ns6:rFonts xmlns:ns6="http://schemas.openxmlformats.org/wordprocessingml/2006/main" ns6:eastAsia="微软雅黑" ns6:ascii="微软雅黑" ns6:hAnsi="微软雅黑"/>
               </a:rPr>
-              <a:t>● 去养老院做访谈和试用</a:t>
+              <a:t>● 代码和评测脚本都开源</a:t>
             </a:r>
           </a:p>
         </p:txBody>
@@ -18177,7 +18128,7 @@
                 <a:latin typeface="微软雅黑"/>
                 <ns7:rFonts xmlns:ns7="http://schemas.openxmlformats.org/wordprocessingml/2006/main" ns7:eastAsia="微软雅黑" ns7:ascii="微软雅黑" ns7:hAnsi="微软雅黑"/>
               </a:rPr>
-              <a:t>● 软著和专利在准备</a:t>
+              <a:t>● 场景对准居家养老</a:t>
             </a:r>
           </a:p>
         </p:txBody>
@@ -18278,8 +18229,8 @@
         </p:nvSpPr>
         <p:spPr>
           <a:xfrm>
-            <a:off x="4308652" y="1186781"/>
-            <a:ext cx="4321454" cy="3144841"/>
+            <a:off x="4308652" y="1202355"/>
+            <a:ext cx="4321454" cy="3113692"/>
           </a:xfrm>
           <a:prstGeom prst="rect">
             <a:avLst/>
@@ -18317,7 +18268,7 @@
       </p:sp>
       <p:pic>
         <p:nvPicPr>
-          <p:cNvPr id="18" name="Picture 17" descr="roadmap_gantt.png"/>
+          <p:cNvPr id="18" name="Picture 17" descr="innovation_radar.png"/>
           <p:cNvPicPr>
             <a:picLocks noChangeAspect="1"/>
           </p:cNvPicPr>
@@ -18331,8 +18282,8 @@
         </p:blipFill>
         <p:spPr>
           <a:xfrm>
-            <a:off x="4345228" y="1223357"/>
-            <a:ext cx="4248302" cy="3071689"/>
+            <a:off x="4345228" y="1238931"/>
+            <a:ext cx="4248302" cy="3040540"/>
           </a:xfrm>
           <a:prstGeom prst="rect">
             <a:avLst/>
@@ -18370,7 +18321,7 @@
                 <a:latin typeface="微软雅黑"/>
                 <ns8:rFonts xmlns:ns8="http://schemas.openxmlformats.org/wordprocessingml/2006/main" ns8:eastAsia="微软雅黑" ns8:ascii="微软雅黑" ns8:hAnsi="微软雅黑"/>
               </a:rPr>
-              <a:t>里程碑甘特图（示意）</a:t>
+              <a:t>实验结果</a:t>
             </a:r>
           </a:p>
         </p:txBody>
@@ -19759,7 +19710,7 @@
                 <a:latin typeface="微软雅黑"/>
                 <ns2:rFonts xmlns:ns2="http://schemas.openxmlformats.org/wordprocessingml/2006/main" ns2:eastAsia="微软雅黑" ns2:ascii="微软雅黑" ns2:hAnsi="微软雅黑"/>
               </a:rPr>
-              <a:t>参考资料</a:t>
+              <a:t>后面打算做什么</a:t>
             </a:r>
           </a:p>
         </p:txBody>
@@ -19809,14 +19760,102 @@
       </p:sp>
       <p:sp>
         <p:nvSpPr>
-          <p:cNvPr id="8" name="TextBox 7"/>
+          <p:cNvPr id="8" name="Rectangle 7"/>
+          <p:cNvSpPr/>
+          <p:nvPr/>
+        </p:nvSpPr>
+        <p:spPr>
+          <a:xfrm>
+            <a:off x="274320" y="996696"/>
+            <a:ext cx="3611880" cy="3854196"/>
+          </a:xfrm>
+          <a:prstGeom prst="rect">
+            <a:avLst/>
+          </a:prstGeom>
+          <a:solidFill>
+            <a:srgbClr val="F1F7FF"/>
+          </a:solidFill>
+          <a:ln w="10160">
+            <a:solidFill>
+              <a:srgbClr val="BAC8DC"/>
+            </a:solidFill>
+          </a:ln>
+        </p:spPr>
+        <p:style>
+          <a:lnRef idx="1">
+            <a:schemeClr val="accent1"/>
+          </a:lnRef>
+          <a:fillRef idx="3">
+            <a:schemeClr val="accent1"/>
+          </a:fillRef>
+          <a:effectRef idx="2">
+            <a:schemeClr val="accent1"/>
+          </a:effectRef>
+          <a:fontRef idx="minor">
+            <a:schemeClr val="lt1"/>
+          </a:fontRef>
+        </p:style>
+        <p:txBody>
+          <a:bodyPr rtlCol="0" anchor="ctr"/>
+          <a:lstStyle/>
+          <a:p>
+            <a:pPr algn="ctr"/>
+          </a:p>
+        </p:txBody>
+      </p:sp>
+      <p:sp>
+        <p:nvSpPr>
+          <p:cNvPr id="9" name="Rectangle 8"/>
+          <p:cNvSpPr/>
+          <p:nvPr/>
+        </p:nvSpPr>
+        <p:spPr>
+          <a:xfrm>
+            <a:off x="274320" y="996696"/>
+            <a:ext cx="73152" cy="3854196"/>
+          </a:xfrm>
+          <a:prstGeom prst="rect">
+            <a:avLst/>
+          </a:prstGeom>
+          <a:solidFill>
+            <a:srgbClr val="143278"/>
+          </a:solidFill>
+          <a:ln>
+            <a:noFill/>
+          </a:ln>
+        </p:spPr>
+        <p:style>
+          <a:lnRef idx="1">
+            <a:schemeClr val="accent1"/>
+          </a:lnRef>
+          <a:fillRef idx="3">
+            <a:schemeClr val="accent1"/>
+          </a:fillRef>
+          <a:effectRef idx="2">
+            <a:schemeClr val="accent1"/>
+          </a:effectRef>
+          <a:fontRef idx="minor">
+            <a:schemeClr val="lt1"/>
+          </a:fontRef>
+        </p:style>
+        <p:txBody>
+          <a:bodyPr rtlCol="0" anchor="ctr"/>
+          <a:lstStyle/>
+          <a:p>
+            <a:pPr algn="ctr"/>
+          </a:p>
+        </p:txBody>
+      </p:sp>
+      <p:sp>
+        <p:nvSpPr>
+          <p:cNvPr id="10" name="TextBox 9"/>
           <p:cNvSpPr txBox="1"/>
           <p:nvPr/>
         </p:nvSpPr>
         <p:spPr>
           <a:xfrm>
-            <a:off x="502920" y="1234440"/>
-            <a:ext cx="8138160" cy="3200400"/>
+            <a:off x="438912" y="1106424"/>
+            <a:ext cx="3282696" cy="708660"/>
           </a:xfrm>
           <a:prstGeom prst="rect">
             <a:avLst/>
@@ -19824,14 +19863,17 @@
           <a:noFill/>
         </p:spPr>
         <p:txBody>
-          <a:bodyPr wrap="none">
+          <a:bodyPr wrap="square" anchor="t" lIns="25400" tIns="0">
             <a:spAutoFit/>
           </a:bodyPr>
           <a:lstStyle/>
           <a:p>
             <a:pPr>
+              <a:lnSpc>
+                <a:spcPct val="112000"/>
+              </a:lnSpc>
               <a:spcAft>
-                <a:spcPts val="1000"/>
+                <a:spcPts val="200"/>
               </a:spcAft>
             </a:pPr>
             <a:r>
@@ -19842,13 +19884,39 @@
                 <a:latin typeface="微软雅黑"/>
                 <ns3:rFonts xmlns:ns3="http://schemas.openxmlformats.org/wordprocessingml/2006/main" ns3:eastAsia="微软雅黑" ns3:ascii="微软雅黑" ns3:hAnsi="微软雅黑"/>
               </a:rPr>
-              <a:t>[1] Google MediaPipe Pose 技术文档</a:t>
-            </a:r>
-          </a:p>
+              <a:t>● 对接 Unitree 等人形真机</a:t>
+            </a:r>
+          </a:p>
+        </p:txBody>
+      </p:sp>
+      <p:sp>
+        <p:nvSpPr>
+          <p:cNvPr id="11" name="TextBox 10"/>
+          <p:cNvSpPr txBox="1"/>
+          <p:nvPr/>
+        </p:nvSpPr>
+        <p:spPr>
+          <a:xfrm>
+            <a:off x="438912" y="1833372"/>
+            <a:ext cx="3282696" cy="708660"/>
+          </a:xfrm>
+          <a:prstGeom prst="rect">
+            <a:avLst/>
+          </a:prstGeom>
+          <a:noFill/>
+        </p:spPr>
+        <p:txBody>
+          <a:bodyPr wrap="square" anchor="t" lIns="25400" tIns="0">
+            <a:spAutoFit/>
+          </a:bodyPr>
+          <a:lstStyle/>
           <a:p>
             <a:pPr>
+              <a:lnSpc>
+                <a:spcPct val="112000"/>
+              </a:lnSpc>
               <a:spcAft>
-                <a:spcPts val="1000"/>
+                <a:spcPts val="200"/>
               </a:spcAft>
             </a:pPr>
             <a:r>
@@ -19859,13 +19927,39 @@
                 <a:latin typeface="微软雅黑"/>
                 <ns4:rFonts xmlns:ns4="http://schemas.openxmlformats.org/wordprocessingml/2006/main" ns4:eastAsia="微软雅黑" ns4:ascii="微软雅黑" ns4:hAnsi="微软雅黑"/>
               </a:rPr>
-              <a:t>[2] Unitree / ROS2 开发文档</a:t>
-            </a:r>
-          </a:p>
+              <a:t>● 补充公开跌倒数据集</a:t>
+            </a:r>
+          </a:p>
+        </p:txBody>
+      </p:sp>
+      <p:sp>
+        <p:nvSpPr>
+          <p:cNvPr id="12" name="TextBox 11"/>
+          <p:cNvSpPr txBox="1"/>
+          <p:nvPr/>
+        </p:nvSpPr>
+        <p:spPr>
+          <a:xfrm>
+            <a:off x="438912" y="2560320"/>
+            <a:ext cx="3282696" cy="708660"/>
+          </a:xfrm>
+          <a:prstGeom prst="rect">
+            <a:avLst/>
+          </a:prstGeom>
+          <a:noFill/>
+        </p:spPr>
+        <p:txBody>
+          <a:bodyPr wrap="square" anchor="t" lIns="25400" tIns="0">
+            <a:spAutoFit/>
+          </a:bodyPr>
+          <a:lstStyle/>
           <a:p>
             <a:pPr>
+              <a:lnSpc>
+                <a:spcPct val="112000"/>
+              </a:lnSpc>
               <a:spcAft>
-                <a:spcPts val="1000"/>
+                <a:spcPts val="200"/>
               </a:spcAft>
             </a:pPr>
             <a:r>
@@ -19876,13 +19970,39 @@
                 <a:latin typeface="微软雅黑"/>
                 <ns5:rFonts xmlns:ns5="http://schemas.openxmlformats.org/wordprocessingml/2006/main" ns5:eastAsia="微软雅黑" ns5:ascii="微软雅黑" ns5:hAnsi="微软雅黑"/>
               </a:rPr>
-              <a:t>[3] 「十四五」国家老龄事业发展规划</a:t>
-            </a:r>
-          </a:p>
+              <a:t>● 做多房间、弱光等复杂场景</a:t>
+            </a:r>
+          </a:p>
+        </p:txBody>
+      </p:sp>
+      <p:sp>
+        <p:nvSpPr>
+          <p:cNvPr id="13" name="TextBox 12"/>
+          <p:cNvSpPr txBox="1"/>
+          <p:nvPr/>
+        </p:nvSpPr>
+        <p:spPr>
+          <a:xfrm>
+            <a:off x="438912" y="3287268"/>
+            <a:ext cx="3282696" cy="708660"/>
+          </a:xfrm>
+          <a:prstGeom prst="rect">
+            <a:avLst/>
+          </a:prstGeom>
+          <a:noFill/>
+        </p:spPr>
+        <p:txBody>
+          <a:bodyPr wrap="square" anchor="t" lIns="25400" tIns="0">
+            <a:spAutoFit/>
+          </a:bodyPr>
+          <a:lstStyle/>
           <a:p>
             <a:pPr>
+              <a:lnSpc>
+                <a:spcPct val="112000"/>
+              </a:lnSpc>
               <a:spcAft>
-                <a:spcPts val="1000"/>
+                <a:spcPts val="200"/>
               </a:spcAft>
             </a:pPr>
             <a:r>
@@ -19893,13 +20013,39 @@
                 <a:latin typeface="微软雅黑"/>
                 <ns6:rFonts xmlns:ns6="http://schemas.openxmlformats.org/wordprocessingml/2006/main" ns6:eastAsia="微软雅黑" ns6:ascii="微软雅黑" ns6:hAnsi="微软雅黑"/>
               </a:rPr>
-              <a:t>[4] 项目技术报告 docs/TECHNICAL_REPORT.md</a:t>
-            </a:r>
-          </a:p>
+              <a:t>● 去养老院做访谈和试用</a:t>
+            </a:r>
+          </a:p>
+        </p:txBody>
+      </p:sp>
+      <p:sp>
+        <p:nvSpPr>
+          <p:cNvPr id="14" name="TextBox 13"/>
+          <p:cNvSpPr txBox="1"/>
+          <p:nvPr/>
+        </p:nvSpPr>
+        <p:spPr>
+          <a:xfrm>
+            <a:off x="438912" y="4014216"/>
+            <a:ext cx="3282696" cy="708660"/>
+          </a:xfrm>
+          <a:prstGeom prst="rect">
+            <a:avLst/>
+          </a:prstGeom>
+          <a:noFill/>
+        </p:spPr>
+        <p:txBody>
+          <a:bodyPr wrap="square" anchor="t" lIns="25400" tIns="0">
+            <a:spAutoFit/>
+          </a:bodyPr>
+          <a:lstStyle/>
           <a:p>
             <a:pPr>
+              <a:lnSpc>
+                <a:spcPct val="112000"/>
+              </a:lnSpc>
               <a:spcAft>
-                <a:spcPts val="1000"/>
+                <a:spcPts val="200"/>
               </a:spcAft>
             </a:pPr>
             <a:r>
@@ -19910,7 +20056,200 @@
                 <a:latin typeface="微软雅黑"/>
                 <ns7:rFonts xmlns:ns7="http://schemas.openxmlformats.org/wordprocessingml/2006/main" ns7:eastAsia="微软雅黑" ns7:ascii="微软雅黑" ns7:hAnsi="微软雅黑"/>
               </a:rPr>
-              <a:t>[5] 源码 https://github.com/FBB123571/ElderCare-Humanoid-Platform</a:t>
+              <a:t>● 软著和专利在准备</a:t>
+            </a:r>
+          </a:p>
+        </p:txBody>
+      </p:sp>
+      <p:sp>
+        <p:nvSpPr>
+          <p:cNvPr id="15" name="Rectangle 14"/>
+          <p:cNvSpPr/>
+          <p:nvPr/>
+        </p:nvSpPr>
+        <p:spPr>
+          <a:xfrm>
+            <a:off x="4105656" y="1033272"/>
+            <a:ext cx="4727448" cy="3744468"/>
+          </a:xfrm>
+          <a:prstGeom prst="rect">
+            <a:avLst/>
+          </a:prstGeom>
+          <a:solidFill>
+            <a:srgbClr val="FFFFFF"/>
+          </a:solidFill>
+          <a:ln w="9525">
+            <a:solidFill>
+              <a:srgbClr val="BAC8DC"/>
+            </a:solidFill>
+          </a:ln>
+        </p:spPr>
+        <p:style>
+          <a:lnRef idx="1">
+            <a:schemeClr val="accent1"/>
+          </a:lnRef>
+          <a:fillRef idx="3">
+            <a:schemeClr val="accent1"/>
+          </a:fillRef>
+          <a:effectRef idx="2">
+            <a:schemeClr val="accent1"/>
+          </a:effectRef>
+          <a:fontRef idx="minor">
+            <a:schemeClr val="lt1"/>
+          </a:fontRef>
+        </p:style>
+        <p:txBody>
+          <a:bodyPr rtlCol="0" anchor="ctr"/>
+          <a:lstStyle/>
+          <a:p>
+            <a:pPr algn="ctr"/>
+          </a:p>
+        </p:txBody>
+      </p:sp>
+      <p:sp>
+        <p:nvSpPr>
+          <p:cNvPr id="16" name="Rectangle 15"/>
+          <p:cNvSpPr/>
+          <p:nvPr/>
+        </p:nvSpPr>
+        <p:spPr>
+          <a:xfrm>
+            <a:off x="3968496" y="996696"/>
+            <a:ext cx="10972" cy="3854196"/>
+          </a:xfrm>
+          <a:prstGeom prst="rect">
+            <a:avLst/>
+          </a:prstGeom>
+          <a:solidFill>
+            <a:srgbClr val="BAC8DC"/>
+          </a:solidFill>
+          <a:ln>
+            <a:noFill/>
+          </a:ln>
+        </p:spPr>
+        <p:style>
+          <a:lnRef idx="1">
+            <a:schemeClr val="accent1"/>
+          </a:lnRef>
+          <a:fillRef idx="3">
+            <a:schemeClr val="accent1"/>
+          </a:fillRef>
+          <a:effectRef idx="2">
+            <a:schemeClr val="accent1"/>
+          </a:effectRef>
+          <a:fontRef idx="minor">
+            <a:schemeClr val="lt1"/>
+          </a:fontRef>
+        </p:style>
+        <p:txBody>
+          <a:bodyPr rtlCol="0" anchor="ctr"/>
+          <a:lstStyle/>
+          <a:p>
+            <a:pPr algn="ctr"/>
+          </a:p>
+        </p:txBody>
+      </p:sp>
+      <p:sp>
+        <p:nvSpPr>
+          <p:cNvPr id="17" name="Rectangle 16"/>
+          <p:cNvSpPr/>
+          <p:nvPr/>
+        </p:nvSpPr>
+        <p:spPr>
+          <a:xfrm>
+            <a:off x="4308652" y="1186781"/>
+            <a:ext cx="4321454" cy="3144841"/>
+          </a:xfrm>
+          <a:prstGeom prst="rect">
+            <a:avLst/>
+          </a:prstGeom>
+          <a:solidFill>
+            <a:srgbClr val="FCFDFF"/>
+          </a:solidFill>
+          <a:ln w="7620">
+            <a:solidFill>
+              <a:srgbClr val="BAC8DC"/>
+            </a:solidFill>
+          </a:ln>
+        </p:spPr>
+        <p:style>
+          <a:lnRef idx="1">
+            <a:schemeClr val="accent1"/>
+          </a:lnRef>
+          <a:fillRef idx="3">
+            <a:schemeClr val="accent1"/>
+          </a:fillRef>
+          <a:effectRef idx="2">
+            <a:schemeClr val="accent1"/>
+          </a:effectRef>
+          <a:fontRef idx="minor">
+            <a:schemeClr val="lt1"/>
+          </a:fontRef>
+        </p:style>
+        <p:txBody>
+          <a:bodyPr rtlCol="0" anchor="ctr"/>
+          <a:lstStyle/>
+          <a:p>
+            <a:pPr algn="ctr"/>
+          </a:p>
+        </p:txBody>
+      </p:sp>
+      <p:pic>
+        <p:nvPicPr>
+          <p:cNvPr id="18" name="Picture 17" descr="roadmap_gantt.png"/>
+          <p:cNvPicPr>
+            <a:picLocks noChangeAspect="1"/>
+          </p:cNvPicPr>
+          <p:nvPr/>
+        </p:nvPicPr>
+        <p:blipFill>
+          <a:blip r:embed="rId2"/>
+          <a:stretch>
+            <a:fillRect/>
+          </a:stretch>
+        </p:blipFill>
+        <p:spPr>
+          <a:xfrm>
+            <a:off x="4345228" y="1223357"/>
+            <a:ext cx="4248302" cy="3071689"/>
+          </a:xfrm>
+          <a:prstGeom prst="rect">
+            <a:avLst/>
+          </a:prstGeom>
+        </p:spPr>
+      </p:pic>
+      <p:sp>
+        <p:nvSpPr>
+          <p:cNvPr id="19" name="TextBox 18"/>
+          <p:cNvSpPr txBox="1"/>
+          <p:nvPr/>
+        </p:nvSpPr>
+        <p:spPr>
+          <a:xfrm>
+            <a:off x="4160520" y="4521708"/>
+            <a:ext cx="4617720" cy="219456"/>
+          </a:xfrm>
+          <a:prstGeom prst="rect">
+            <a:avLst/>
+          </a:prstGeom>
+          <a:noFill/>
+        </p:spPr>
+        <p:txBody>
+          <a:bodyPr wrap="square" anchor="ctr">
+            <a:spAutoFit/>
+          </a:bodyPr>
+          <a:lstStyle/>
+          <a:p>
+            <a:pPr algn="ctr"/>
+            <a:r>
+              <a:rPr sz="800" b="0">
+                <a:solidFill>
+                  <a:srgbClr val="5A6273"/>
+                </a:solidFill>
+                <a:latin typeface="微软雅黑"/>
+                <ns8:rFonts xmlns:ns8="http://schemas.openxmlformats.org/wordprocessingml/2006/main" ns8:eastAsia="微软雅黑" ns8:ascii="微软雅黑" ns8:hAnsi="微软雅黑"/>
+              </a:rPr>
+              <a:t>里程碑甘特图（示意）</a:t>
             </a:r>
           </a:p>
         </p:txBody>
@@ -20129,7 +20468,7 @@
                 <a:latin typeface="微软雅黑"/>
                 <ns2:rFonts xmlns:ns2="http://schemas.openxmlformats.org/wordprocessingml/2006/main" ns2:eastAsia="微软雅黑" ns2:ascii="微软雅黑" ns2:hAnsi="微软雅黑"/>
               </a:rPr>
-              <a:t>扫码查看代码与演示视频</a:t>
+              <a:t>参考资料</a:t>
             </a:r>
           </a:p>
         </p:txBody>
@@ -20179,102 +20518,14 @@
       </p:sp>
       <p:sp>
         <p:nvSpPr>
-          <p:cNvPr id="8" name="Rectangle 7"/>
-          <p:cNvSpPr/>
-          <p:nvPr/>
-        </p:nvSpPr>
-        <p:spPr>
-          <a:xfrm>
-            <a:off x="274320" y="996696"/>
-            <a:ext cx="3611880" cy="3854196"/>
-          </a:xfrm>
-          <a:prstGeom prst="rect">
-            <a:avLst/>
-          </a:prstGeom>
-          <a:solidFill>
-            <a:srgbClr val="F1F7FF"/>
-          </a:solidFill>
-          <a:ln w="10160">
-            <a:solidFill>
-              <a:srgbClr val="BAC8DC"/>
-            </a:solidFill>
-          </a:ln>
-        </p:spPr>
-        <p:style>
-          <a:lnRef idx="1">
-            <a:schemeClr val="accent1"/>
-          </a:lnRef>
-          <a:fillRef idx="3">
-            <a:schemeClr val="accent1"/>
-          </a:fillRef>
-          <a:effectRef idx="2">
-            <a:schemeClr val="accent1"/>
-          </a:effectRef>
-          <a:fontRef idx="minor">
-            <a:schemeClr val="lt1"/>
-          </a:fontRef>
-        </p:style>
-        <p:txBody>
-          <a:bodyPr rtlCol="0" anchor="ctr"/>
-          <a:lstStyle/>
-          <a:p>
-            <a:pPr algn="ctr"/>
-          </a:p>
-        </p:txBody>
-      </p:sp>
-      <p:sp>
-        <p:nvSpPr>
-          <p:cNvPr id="9" name="Rectangle 8"/>
-          <p:cNvSpPr/>
-          <p:nvPr/>
-        </p:nvSpPr>
-        <p:spPr>
-          <a:xfrm>
-            <a:off x="274320" y="996696"/>
-            <a:ext cx="73152" cy="3854196"/>
-          </a:xfrm>
-          <a:prstGeom prst="rect">
-            <a:avLst/>
-          </a:prstGeom>
-          <a:solidFill>
-            <a:srgbClr val="143278"/>
-          </a:solidFill>
-          <a:ln>
-            <a:noFill/>
-          </a:ln>
-        </p:spPr>
-        <p:style>
-          <a:lnRef idx="1">
-            <a:schemeClr val="accent1"/>
-          </a:lnRef>
-          <a:fillRef idx="3">
-            <a:schemeClr val="accent1"/>
-          </a:fillRef>
-          <a:effectRef idx="2">
-            <a:schemeClr val="accent1"/>
-          </a:effectRef>
-          <a:fontRef idx="minor">
-            <a:schemeClr val="lt1"/>
-          </a:fontRef>
-        </p:style>
-        <p:txBody>
-          <a:bodyPr rtlCol="0" anchor="ctr"/>
-          <a:lstStyle/>
-          <a:p>
-            <a:pPr algn="ctr"/>
-          </a:p>
-        </p:txBody>
-      </p:sp>
-      <p:sp>
-        <p:nvSpPr>
-          <p:cNvPr id="10" name="TextBox 9"/>
+          <p:cNvPr id="8" name="TextBox 7"/>
           <p:cNvSpPr txBox="1"/>
           <p:nvPr/>
         </p:nvSpPr>
         <p:spPr>
           <a:xfrm>
-            <a:off x="438912" y="1106424"/>
-            <a:ext cx="3282696" cy="890397"/>
+            <a:off x="502920" y="1234440"/>
+            <a:ext cx="8138160" cy="3200400"/>
           </a:xfrm>
           <a:prstGeom prst="rect">
             <a:avLst/>
@@ -20282,17 +20533,14 @@
           <a:noFill/>
         </p:spPr>
         <p:txBody>
-          <a:bodyPr wrap="square" anchor="t" lIns="25400" tIns="0">
+          <a:bodyPr wrap="none">
             <a:spAutoFit/>
           </a:bodyPr>
           <a:lstStyle/>
           <a:p>
             <a:pPr>
-              <a:lnSpc>
-                <a:spcPct val="112000"/>
-              </a:lnSpc>
               <a:spcAft>
-                <a:spcPts val="200"/>
+                <a:spcPts val="1000"/>
               </a:spcAft>
             </a:pPr>
             <a:r>
@@ -20303,39 +20551,13 @@
                 <a:latin typeface="微软雅黑"/>
                 <ns3:rFonts xmlns:ns3="http://schemas.openxmlformats.org/wordprocessingml/2006/main" ns3:eastAsia="微软雅黑" ns3:ascii="微软雅黑" ns3:hAnsi="微软雅黑"/>
               </a:rPr>
-              <a:t>● GitHub 完整源码与文档</a:t>
-            </a:r>
-          </a:p>
-        </p:txBody>
-      </p:sp>
-      <p:sp>
-        <p:nvSpPr>
-          <p:cNvPr id="11" name="TextBox 10"/>
-          <p:cNvSpPr txBox="1"/>
-          <p:nvPr/>
-        </p:nvSpPr>
-        <p:spPr>
-          <a:xfrm>
-            <a:off x="438912" y="2015109"/>
-            <a:ext cx="3282696" cy="890397"/>
-          </a:xfrm>
-          <a:prstGeom prst="rect">
-            <a:avLst/>
-          </a:prstGeom>
-          <a:noFill/>
-        </p:spPr>
-        <p:txBody>
-          <a:bodyPr wrap="square" anchor="t" lIns="25400" tIns="0">
-            <a:spAutoFit/>
-          </a:bodyPr>
-          <a:lstStyle/>
+              <a:t>[1] Google MediaPipe Pose 技术文档</a:t>
+            </a:r>
+          </a:p>
           <a:p>
             <a:pPr>
-              <a:lnSpc>
-                <a:spcPct val="112000"/>
-              </a:lnSpc>
               <a:spcAft>
-                <a:spcPts val="200"/>
+                <a:spcPts val="1000"/>
               </a:spcAft>
             </a:pPr>
             <a:r>
@@ -20346,39 +20568,13 @@
                 <a:latin typeface="微软雅黑"/>
                 <ns4:rFonts xmlns:ns4="http://schemas.openxmlformats.org/wordprocessingml/2006/main" ns4:eastAsia="微软雅黑" ns4:ascii="微软雅黑" ns4:hAnsi="微软雅黑"/>
               </a:rPr>
-              <a:t>● 在线 Web 演示（现场可复现）</a:t>
-            </a:r>
-          </a:p>
-        </p:txBody>
-      </p:sp>
-      <p:sp>
-        <p:nvSpPr>
-          <p:cNvPr id="12" name="TextBox 11"/>
-          <p:cNvSpPr txBox="1"/>
-          <p:nvPr/>
-        </p:nvSpPr>
-        <p:spPr>
-          <a:xfrm>
-            <a:off x="438912" y="2923794"/>
-            <a:ext cx="3282696" cy="890397"/>
-          </a:xfrm>
-          <a:prstGeom prst="rect">
-            <a:avLst/>
-          </a:prstGeom>
-          <a:noFill/>
-        </p:spPr>
-        <p:txBody>
-          <a:bodyPr wrap="square" anchor="t" lIns="25400" tIns="0">
-            <a:spAutoFit/>
-          </a:bodyPr>
-          <a:lstStyle/>
+              <a:t>[2] Unitree / ROS2 开发文档</a:t>
+            </a:r>
+          </a:p>
           <a:p>
             <a:pPr>
-              <a:lnSpc>
-                <a:spcPct val="112000"/>
-              </a:lnSpc>
               <a:spcAft>
-                <a:spcPts val="200"/>
+                <a:spcPts val="1000"/>
               </a:spcAft>
             </a:pPr>
             <a:r>
@@ -20389,39 +20585,13 @@
                 <a:latin typeface="微软雅黑"/>
                 <ns5:rFonts xmlns:ns5="http://schemas.openxmlformats.org/wordprocessingml/2006/main" ns5:eastAsia="微软雅黑" ns5:ascii="微软雅黑" ns5:hAnsi="微软雅黑"/>
               </a:rPr>
-              <a:t>● 演示录像已附仓库</a:t>
-            </a:r>
-          </a:p>
-        </p:txBody>
-      </p:sp>
-      <p:sp>
-        <p:nvSpPr>
-          <p:cNvPr id="13" name="TextBox 12"/>
-          <p:cNvSpPr txBox="1"/>
-          <p:nvPr/>
-        </p:nvSpPr>
-        <p:spPr>
-          <a:xfrm>
-            <a:off x="438912" y="3832479"/>
-            <a:ext cx="3282696" cy="890397"/>
-          </a:xfrm>
-          <a:prstGeom prst="rect">
-            <a:avLst/>
-          </a:prstGeom>
-          <a:noFill/>
-        </p:spPr>
-        <p:txBody>
-          <a:bodyPr wrap="square" anchor="t" lIns="25400" tIns="0">
-            <a:spAutoFit/>
-          </a:bodyPr>
-          <a:lstStyle/>
+              <a:t>[3] 「十四五」国家老龄事业发展规划</a:t>
+            </a:r>
+          </a:p>
           <a:p>
             <a:pPr>
-              <a:lnSpc>
-                <a:spcPct val="112000"/>
-              </a:lnSpc>
               <a:spcAft>
-                <a:spcPts val="200"/>
+                <a:spcPts val="1000"/>
               </a:spcAft>
             </a:pPr>
             <a:r>
@@ -20432,172 +20602,24 @@
                 <a:latin typeface="微软雅黑"/>
                 <ns6:rFonts xmlns:ns6="http://schemas.openxmlformats.org/wordprocessingml/2006/main" ns6:eastAsia="微软雅黑" ns6:ascii="微软雅黑" ns6:hAnsi="微软雅黑"/>
               </a:rPr>
-              <a:t>● 欢迎评委扫码查阅</a:t>
-            </a:r>
-          </a:p>
-        </p:txBody>
-      </p:sp>
-      <p:sp>
-        <p:nvSpPr>
-          <p:cNvPr id="14" name="Rectangle 13"/>
-          <p:cNvSpPr/>
-          <p:nvPr/>
-        </p:nvSpPr>
-        <p:spPr>
-          <a:xfrm>
-            <a:off x="4105656" y="1033272"/>
-            <a:ext cx="4727448" cy="3744468"/>
-          </a:xfrm>
-          <a:prstGeom prst="rect">
-            <a:avLst/>
-          </a:prstGeom>
-          <a:solidFill>
-            <a:srgbClr val="FFFFFF"/>
-          </a:solidFill>
-          <a:ln w="9525">
-            <a:solidFill>
-              <a:srgbClr val="BAC8DC"/>
-            </a:solidFill>
-          </a:ln>
-        </p:spPr>
-        <p:style>
-          <a:lnRef idx="1">
-            <a:schemeClr val="accent1"/>
-          </a:lnRef>
-          <a:fillRef idx="3">
-            <a:schemeClr val="accent1"/>
-          </a:fillRef>
-          <a:effectRef idx="2">
-            <a:schemeClr val="accent1"/>
-          </a:effectRef>
-          <a:fontRef idx="minor">
-            <a:schemeClr val="lt1"/>
-          </a:fontRef>
-        </p:style>
-        <p:txBody>
-          <a:bodyPr rtlCol="0" anchor="ctr"/>
-          <a:lstStyle/>
-          <a:p>
-            <a:pPr algn="ctr"/>
-          </a:p>
-        </p:txBody>
-      </p:sp>
-      <p:pic>
-        <p:nvPicPr>
-          <p:cNvPr id="15" name="Picture 14" descr="ppt_demo_qr.png"/>
-          <p:cNvPicPr>
-            <a:picLocks noChangeAspect="1"/>
-          </p:cNvPicPr>
-          <p:nvPr/>
-        </p:nvPicPr>
-        <p:blipFill>
-          <a:blip r:embed="rId2"/>
-          <a:stretch>
-            <a:fillRect/>
-          </a:stretch>
-        </p:blipFill>
-        <p:spPr>
-          <a:xfrm>
-            <a:off x="4193804" y="1987814"/>
-            <a:ext cx="1597639" cy="1597639"/>
-          </a:xfrm>
-          <a:prstGeom prst="rect">
-            <a:avLst/>
-          </a:prstGeom>
-        </p:spPr>
-      </p:pic>
-      <p:sp>
-        <p:nvSpPr>
-          <p:cNvPr id="16" name="TextBox 15"/>
-          <p:cNvSpPr txBox="1"/>
-          <p:nvPr/>
-        </p:nvSpPr>
-        <p:spPr>
-          <a:xfrm>
-            <a:off x="4160520" y="3640317"/>
-            <a:ext cx="1664208" cy="219456"/>
-          </a:xfrm>
-          <a:prstGeom prst="rect">
-            <a:avLst/>
-          </a:prstGeom>
-          <a:noFill/>
-        </p:spPr>
-        <p:txBody>
-          <a:bodyPr wrap="square" anchor="ctr">
-            <a:spAutoFit/>
-          </a:bodyPr>
-          <a:lstStyle/>
-          <a:p>
-            <a:pPr algn="ctr"/>
-            <a:r>
-              <a:rPr sz="900" b="0">
-                <a:solidFill>
-                  <a:srgbClr val="5A6273"/>
+              <a:t>[4] 项目技术报告 docs/TECHNICAL_REPORT.md</a:t>
+            </a:r>
+          </a:p>
+          <a:p>
+            <a:pPr>
+              <a:spcAft>
+                <a:spcPts val="1000"/>
+              </a:spcAft>
+            </a:pPr>
+            <a:r>
+              <a:rPr sz="1300" b="0">
+                <a:solidFill>
+                  <a:srgbClr val="1C202C"/>
                 </a:solidFill>
                 <a:latin typeface="微软雅黑"/>
                 <ns7:rFonts xmlns:ns7="http://schemas.openxmlformats.org/wordprocessingml/2006/main" ns7:eastAsia="微软雅黑" ns7:ascii="微软雅黑" ns7:hAnsi="微软雅黑"/>
               </a:rPr>
-              <a:t>仓库二维码</a:t>
-            </a:r>
-          </a:p>
-        </p:txBody>
-      </p:sp>
-      <p:pic>
-        <p:nvPicPr>
-          <p:cNvPr id="17" name="Picture 16" descr="ppt_header_perception.png"/>
-          <p:cNvPicPr>
-            <a:picLocks noChangeAspect="1"/>
-          </p:cNvPicPr>
-          <p:nvPr/>
-        </p:nvPicPr>
-        <p:blipFill>
-          <a:blip r:embed="rId3"/>
-          <a:stretch>
-            <a:fillRect/>
-          </a:stretch>
-        </p:blipFill>
-        <p:spPr>
-          <a:xfrm>
-            <a:off x="5980998" y="2070050"/>
-            <a:ext cx="2768986" cy="1433166"/>
-          </a:xfrm>
-          <a:prstGeom prst="rect">
-            <a:avLst/>
-          </a:prstGeom>
-        </p:spPr>
-      </p:pic>
-      <p:sp>
-        <p:nvSpPr>
-          <p:cNvPr id="18" name="TextBox 17"/>
-          <p:cNvSpPr txBox="1"/>
-          <p:nvPr/>
-        </p:nvSpPr>
-        <p:spPr>
-          <a:xfrm>
-            <a:off x="5952744" y="3558081"/>
-            <a:ext cx="2825495" cy="219456"/>
-          </a:xfrm>
-          <a:prstGeom prst="rect">
-            <a:avLst/>
-          </a:prstGeom>
-          <a:noFill/>
-        </p:spPr>
-        <p:txBody>
-          <a:bodyPr wrap="square" anchor="ctr">
-            <a:spAutoFit/>
-          </a:bodyPr>
-          <a:lstStyle/>
-          <a:p>
-            <a:pPr algn="ctr"/>
-            <a:r>
-              <a:rPr sz="900" b="0">
-                <a:solidFill>
-                  <a:srgbClr val="5A6273"/>
-                </a:solidFill>
-                <a:latin typeface="微软雅黑"/>
-                <ns8:rFonts xmlns:ns8="http://schemas.openxmlformats.org/wordprocessingml/2006/main" ns8:eastAsia="微软雅黑" ns8:ascii="微软雅黑" ns8:hAnsi="微软雅黑"/>
-              </a:rPr>
-              <a:t>Web 感知界面</a:t>
+              <a:t>[5] 源码 https://github.com/FBB123571/ElderCare-Humanoid-Platform</a:t>
             </a:r>
           </a:p>
         </p:txBody>
@@ -20611,6 +20633,693 @@
 </file>
 
 <file path=ppt/slides/slide32.xml><?xml version="1.0" encoding="utf-8"?>
+<p:sld xmlns:a="http://schemas.openxmlformats.org/drawingml/2006/main" xmlns:p="http://schemas.openxmlformats.org/presentationml/2006/main" xmlns:r="http://schemas.openxmlformats.org/officeDocument/2006/relationships">
+  <p:cSld>
+    <p:bg>
+      <p:bgPr>
+        <a:solidFill>
+          <a:srgbClr val="FFFFFF"/>
+        </a:solidFill>
+        <a:effectLst/>
+      </p:bgPr>
+    </p:bg>
+    <p:spTree>
+      <p:nvGrpSpPr>
+        <p:cNvPr id="1" name=""/>
+        <p:cNvGrpSpPr/>
+        <p:nvPr/>
+      </p:nvGrpSpPr>
+      <p:grpSpPr/>
+      <p:sp>
+        <p:nvSpPr>
+          <p:cNvPr id="2" name="Rectangle 1"/>
+          <p:cNvSpPr/>
+          <p:nvPr/>
+        </p:nvSpPr>
+        <p:spPr>
+          <a:xfrm>
+            <a:off x="0" y="0"/>
+            <a:ext cx="9144000" cy="420624"/>
+          </a:xfrm>
+          <a:prstGeom prst="rect">
+            <a:avLst/>
+          </a:prstGeom>
+          <a:solidFill>
+            <a:srgbClr val="143278"/>
+          </a:solidFill>
+          <a:ln>
+            <a:noFill/>
+          </a:ln>
+        </p:spPr>
+        <p:style>
+          <a:lnRef idx="1">
+            <a:schemeClr val="accent1"/>
+          </a:lnRef>
+          <a:fillRef idx="3">
+            <a:schemeClr val="accent1"/>
+          </a:fillRef>
+          <a:effectRef idx="2">
+            <a:schemeClr val="accent1"/>
+          </a:effectRef>
+          <a:fontRef idx="minor">
+            <a:schemeClr val="lt1"/>
+          </a:fontRef>
+        </p:style>
+        <p:txBody>
+          <a:bodyPr rtlCol="0" anchor="ctr"/>
+          <a:lstStyle/>
+          <a:p>
+            <a:pPr algn="ctr"/>
+          </a:p>
+        </p:txBody>
+      </p:sp>
+      <p:sp>
+        <p:nvSpPr>
+          <p:cNvPr id="3" name="TextBox 2"/>
+          <p:cNvSpPr txBox="1"/>
+          <p:nvPr/>
+        </p:nvSpPr>
+        <p:spPr>
+          <a:xfrm>
+            <a:off x="274320" y="54864"/>
+            <a:ext cx="8595360" cy="347472"/>
+          </a:xfrm>
+          <a:prstGeom prst="rect">
+            <a:avLst/>
+          </a:prstGeom>
+          <a:noFill/>
+        </p:spPr>
+        <p:txBody>
+          <a:bodyPr wrap="none">
+            <a:spAutoFit/>
+          </a:bodyPr>
+          <a:lstStyle/>
+          <a:p>
+            <a:r>
+              <a:rPr sz="900" b="1">
+                <a:solidFill>
+                  <a:srgbClr val="FFFFFF"/>
+                </a:solidFill>
+                <a:latin typeface="微软雅黑"/>
+                <ns0:rFonts xmlns:ns0="http://schemas.openxmlformats.org/wordprocessingml/2006/main" ns0:eastAsia="微软雅黑" ns0:ascii="微软雅黑" ns0:hAnsi="微软雅黑"/>
+              </a:rPr>
+              <a:t>第二十八届中国机器人及人工智能大赛  |  创新赛 · 机器人创新赛道</a:t>
+            </a:r>
+          </a:p>
+        </p:txBody>
+      </p:sp>
+      <p:sp>
+        <p:nvSpPr>
+          <p:cNvPr id="4" name="Rectangle 3"/>
+          <p:cNvSpPr/>
+          <p:nvPr/>
+        </p:nvSpPr>
+        <p:spPr>
+          <a:xfrm>
+            <a:off x="0" y="4905756"/>
+            <a:ext cx="9144000" cy="237744"/>
+          </a:xfrm>
+          <a:prstGeom prst="rect">
+            <a:avLst/>
+          </a:prstGeom>
+          <a:solidFill>
+            <a:srgbClr val="DBEAFE"/>
+          </a:solidFill>
+          <a:ln>
+            <a:noFill/>
+          </a:ln>
+        </p:spPr>
+        <p:style>
+          <a:lnRef idx="1">
+            <a:schemeClr val="accent1"/>
+          </a:lnRef>
+          <a:fillRef idx="3">
+            <a:schemeClr val="accent1"/>
+          </a:fillRef>
+          <a:effectRef idx="2">
+            <a:schemeClr val="accent1"/>
+          </a:effectRef>
+          <a:fontRef idx="minor">
+            <a:schemeClr val="lt1"/>
+          </a:fontRef>
+        </p:style>
+        <p:txBody>
+          <a:bodyPr rtlCol="0" anchor="ctr"/>
+          <a:lstStyle/>
+          <a:p>
+            <a:pPr algn="ctr"/>
+          </a:p>
+        </p:txBody>
+      </p:sp>
+      <p:sp>
+        <p:nvSpPr>
+          <p:cNvPr id="5" name="TextBox 4"/>
+          <p:cNvSpPr txBox="1"/>
+          <p:nvPr/>
+        </p:nvSpPr>
+        <p:spPr>
+          <a:xfrm>
+            <a:off x="274320" y="4951476"/>
+            <a:ext cx="8595360" cy="182880"/>
+          </a:xfrm>
+          <a:prstGeom prst="rect">
+            <a:avLst/>
+          </a:prstGeom>
+          <a:noFill/>
+        </p:spPr>
+        <p:txBody>
+          <a:bodyPr wrap="none">
+            <a:spAutoFit/>
+          </a:bodyPr>
+          <a:lstStyle/>
+          <a:p>
+            <a:pPr algn="ctr"/>
+            <a:r>
+              <a:rPr sz="800" b="0">
+                <a:solidFill>
+                  <a:srgbClr val="5A6273"/>
+                </a:solidFill>
+                <a:latin typeface="微软雅黑"/>
+                <ns1:rFonts xmlns:ns1="http://schemas.openxmlformats.org/wordprocessingml/2006/main" ns1:eastAsia="微软雅黑" ns1:ascii="微软雅黑" ns1:hAnsi="微软雅黑"/>
+              </a:rPr>
+              <a:t>从容应队 · 中山大学 · 刘小凡/白冉 · 指导教师 彭键清</a:t>
+            </a:r>
+          </a:p>
+        </p:txBody>
+      </p:sp>
+      <p:sp>
+        <p:nvSpPr>
+          <p:cNvPr id="6" name="TextBox 5"/>
+          <p:cNvSpPr txBox="1"/>
+          <p:nvPr/>
+        </p:nvSpPr>
+        <p:spPr>
+          <a:xfrm>
+            <a:off x="274320" y="466344"/>
+            <a:ext cx="8595360" cy="457200"/>
+          </a:xfrm>
+          <a:prstGeom prst="rect">
+            <a:avLst/>
+          </a:prstGeom>
+          <a:noFill/>
+        </p:spPr>
+        <p:txBody>
+          <a:bodyPr wrap="none">
+            <a:spAutoFit/>
+          </a:bodyPr>
+          <a:lstStyle/>
+          <a:p>
+            <a:pPr algn="l"/>
+            <a:r>
+              <a:rPr sz="2000" b="1">
+                <a:solidFill>
+                  <a:srgbClr val="143278"/>
+                </a:solidFill>
+                <a:latin typeface="微软雅黑"/>
+                <ns2:rFonts xmlns:ns2="http://schemas.openxmlformats.org/wordprocessingml/2006/main" ns2:eastAsia="微软雅黑" ns2:ascii="微软雅黑" ns2:hAnsi="微软雅黑"/>
+              </a:rPr>
+              <a:t>扫码查看代码与演示视频</a:t>
+            </a:r>
+          </a:p>
+        </p:txBody>
+      </p:sp>
+      <p:sp>
+        <p:nvSpPr>
+          <p:cNvPr id="7" name="Rectangle 6"/>
+          <p:cNvSpPr/>
+          <p:nvPr/>
+        </p:nvSpPr>
+        <p:spPr>
+          <a:xfrm>
+            <a:off x="274320" y="886968"/>
+            <a:ext cx="1143000" cy="50292"/>
+          </a:xfrm>
+          <a:prstGeom prst="rect">
+            <a:avLst/>
+          </a:prstGeom>
+          <a:solidFill>
+            <a:srgbClr val="F59E0B"/>
+          </a:solidFill>
+          <a:ln>
+            <a:noFill/>
+          </a:ln>
+        </p:spPr>
+        <p:style>
+          <a:lnRef idx="1">
+            <a:schemeClr val="accent1"/>
+          </a:lnRef>
+          <a:fillRef idx="3">
+            <a:schemeClr val="accent1"/>
+          </a:fillRef>
+          <a:effectRef idx="2">
+            <a:schemeClr val="accent1"/>
+          </a:effectRef>
+          <a:fontRef idx="minor">
+            <a:schemeClr val="lt1"/>
+          </a:fontRef>
+        </p:style>
+        <p:txBody>
+          <a:bodyPr rtlCol="0" anchor="ctr"/>
+          <a:lstStyle/>
+          <a:p>
+            <a:pPr algn="ctr"/>
+          </a:p>
+        </p:txBody>
+      </p:sp>
+      <p:sp>
+        <p:nvSpPr>
+          <p:cNvPr id="8" name="Rectangle 7"/>
+          <p:cNvSpPr/>
+          <p:nvPr/>
+        </p:nvSpPr>
+        <p:spPr>
+          <a:xfrm>
+            <a:off x="274320" y="996696"/>
+            <a:ext cx="3611880" cy="3854196"/>
+          </a:xfrm>
+          <a:prstGeom prst="rect">
+            <a:avLst/>
+          </a:prstGeom>
+          <a:solidFill>
+            <a:srgbClr val="F1F7FF"/>
+          </a:solidFill>
+          <a:ln w="10160">
+            <a:solidFill>
+              <a:srgbClr val="BAC8DC"/>
+            </a:solidFill>
+          </a:ln>
+        </p:spPr>
+        <p:style>
+          <a:lnRef idx="1">
+            <a:schemeClr val="accent1"/>
+          </a:lnRef>
+          <a:fillRef idx="3">
+            <a:schemeClr val="accent1"/>
+          </a:fillRef>
+          <a:effectRef idx="2">
+            <a:schemeClr val="accent1"/>
+          </a:effectRef>
+          <a:fontRef idx="minor">
+            <a:schemeClr val="lt1"/>
+          </a:fontRef>
+        </p:style>
+        <p:txBody>
+          <a:bodyPr rtlCol="0" anchor="ctr"/>
+          <a:lstStyle/>
+          <a:p>
+            <a:pPr algn="ctr"/>
+          </a:p>
+        </p:txBody>
+      </p:sp>
+      <p:sp>
+        <p:nvSpPr>
+          <p:cNvPr id="9" name="Rectangle 8"/>
+          <p:cNvSpPr/>
+          <p:nvPr/>
+        </p:nvSpPr>
+        <p:spPr>
+          <a:xfrm>
+            <a:off x="274320" y="996696"/>
+            <a:ext cx="73152" cy="3854196"/>
+          </a:xfrm>
+          <a:prstGeom prst="rect">
+            <a:avLst/>
+          </a:prstGeom>
+          <a:solidFill>
+            <a:srgbClr val="143278"/>
+          </a:solidFill>
+          <a:ln>
+            <a:noFill/>
+          </a:ln>
+        </p:spPr>
+        <p:style>
+          <a:lnRef idx="1">
+            <a:schemeClr val="accent1"/>
+          </a:lnRef>
+          <a:fillRef idx="3">
+            <a:schemeClr val="accent1"/>
+          </a:fillRef>
+          <a:effectRef idx="2">
+            <a:schemeClr val="accent1"/>
+          </a:effectRef>
+          <a:fontRef idx="minor">
+            <a:schemeClr val="lt1"/>
+          </a:fontRef>
+        </p:style>
+        <p:txBody>
+          <a:bodyPr rtlCol="0" anchor="ctr"/>
+          <a:lstStyle/>
+          <a:p>
+            <a:pPr algn="ctr"/>
+          </a:p>
+        </p:txBody>
+      </p:sp>
+      <p:sp>
+        <p:nvSpPr>
+          <p:cNvPr id="10" name="TextBox 9"/>
+          <p:cNvSpPr txBox="1"/>
+          <p:nvPr/>
+        </p:nvSpPr>
+        <p:spPr>
+          <a:xfrm>
+            <a:off x="438912" y="1106424"/>
+            <a:ext cx="3282696" cy="890397"/>
+          </a:xfrm>
+          <a:prstGeom prst="rect">
+            <a:avLst/>
+          </a:prstGeom>
+          <a:noFill/>
+        </p:spPr>
+        <p:txBody>
+          <a:bodyPr wrap="square" anchor="t" lIns="25400" tIns="0">
+            <a:spAutoFit/>
+          </a:bodyPr>
+          <a:lstStyle/>
+          <a:p>
+            <a:pPr>
+              <a:lnSpc>
+                <a:spcPct val="112000"/>
+              </a:lnSpc>
+              <a:spcAft>
+                <a:spcPts val="200"/>
+              </a:spcAft>
+            </a:pPr>
+            <a:r>
+              <a:rPr sz="1300" b="0">
+                <a:solidFill>
+                  <a:srgbClr val="1C202C"/>
+                </a:solidFill>
+                <a:latin typeface="微软雅黑"/>
+                <ns3:rFonts xmlns:ns3="http://schemas.openxmlformats.org/wordprocessingml/2006/main" ns3:eastAsia="微软雅黑" ns3:ascii="微软雅黑" ns3:hAnsi="微软雅黑"/>
+              </a:rPr>
+              <a:t>● GitHub 完整源码与文档</a:t>
+            </a:r>
+          </a:p>
+        </p:txBody>
+      </p:sp>
+      <p:sp>
+        <p:nvSpPr>
+          <p:cNvPr id="11" name="TextBox 10"/>
+          <p:cNvSpPr txBox="1"/>
+          <p:nvPr/>
+        </p:nvSpPr>
+        <p:spPr>
+          <a:xfrm>
+            <a:off x="438912" y="2015109"/>
+            <a:ext cx="3282696" cy="890397"/>
+          </a:xfrm>
+          <a:prstGeom prst="rect">
+            <a:avLst/>
+          </a:prstGeom>
+          <a:noFill/>
+        </p:spPr>
+        <p:txBody>
+          <a:bodyPr wrap="square" anchor="t" lIns="25400" tIns="0">
+            <a:spAutoFit/>
+          </a:bodyPr>
+          <a:lstStyle/>
+          <a:p>
+            <a:pPr>
+              <a:lnSpc>
+                <a:spcPct val="112000"/>
+              </a:lnSpc>
+              <a:spcAft>
+                <a:spcPts val="200"/>
+              </a:spcAft>
+            </a:pPr>
+            <a:r>
+              <a:rPr sz="1300" b="0">
+                <a:solidFill>
+                  <a:srgbClr val="1C202C"/>
+                </a:solidFill>
+                <a:latin typeface="微软雅黑"/>
+                <ns4:rFonts xmlns:ns4="http://schemas.openxmlformats.org/wordprocessingml/2006/main" ns4:eastAsia="微软雅黑" ns4:ascii="微软雅黑" ns4:hAnsi="微软雅黑"/>
+              </a:rPr>
+              <a:t>● 在线 Web 演示（现场可复现）</a:t>
+            </a:r>
+          </a:p>
+        </p:txBody>
+      </p:sp>
+      <p:sp>
+        <p:nvSpPr>
+          <p:cNvPr id="12" name="TextBox 11"/>
+          <p:cNvSpPr txBox="1"/>
+          <p:nvPr/>
+        </p:nvSpPr>
+        <p:spPr>
+          <a:xfrm>
+            <a:off x="438912" y="2923794"/>
+            <a:ext cx="3282696" cy="890397"/>
+          </a:xfrm>
+          <a:prstGeom prst="rect">
+            <a:avLst/>
+          </a:prstGeom>
+          <a:noFill/>
+        </p:spPr>
+        <p:txBody>
+          <a:bodyPr wrap="square" anchor="t" lIns="25400" tIns="0">
+            <a:spAutoFit/>
+          </a:bodyPr>
+          <a:lstStyle/>
+          <a:p>
+            <a:pPr>
+              <a:lnSpc>
+                <a:spcPct val="112000"/>
+              </a:lnSpc>
+              <a:spcAft>
+                <a:spcPts val="200"/>
+              </a:spcAft>
+            </a:pPr>
+            <a:r>
+              <a:rPr sz="1300" b="0">
+                <a:solidFill>
+                  <a:srgbClr val="1C202C"/>
+                </a:solidFill>
+                <a:latin typeface="微软雅黑"/>
+                <ns5:rFonts xmlns:ns5="http://schemas.openxmlformats.org/wordprocessingml/2006/main" ns5:eastAsia="微软雅黑" ns5:ascii="微软雅黑" ns5:hAnsi="微软雅黑"/>
+              </a:rPr>
+              <a:t>● 演示录像已附仓库</a:t>
+            </a:r>
+          </a:p>
+        </p:txBody>
+      </p:sp>
+      <p:sp>
+        <p:nvSpPr>
+          <p:cNvPr id="13" name="TextBox 12"/>
+          <p:cNvSpPr txBox="1"/>
+          <p:nvPr/>
+        </p:nvSpPr>
+        <p:spPr>
+          <a:xfrm>
+            <a:off x="438912" y="3832479"/>
+            <a:ext cx="3282696" cy="890397"/>
+          </a:xfrm>
+          <a:prstGeom prst="rect">
+            <a:avLst/>
+          </a:prstGeom>
+          <a:noFill/>
+        </p:spPr>
+        <p:txBody>
+          <a:bodyPr wrap="square" anchor="t" lIns="25400" tIns="0">
+            <a:spAutoFit/>
+          </a:bodyPr>
+          <a:lstStyle/>
+          <a:p>
+            <a:pPr>
+              <a:lnSpc>
+                <a:spcPct val="112000"/>
+              </a:lnSpc>
+              <a:spcAft>
+                <a:spcPts val="200"/>
+              </a:spcAft>
+            </a:pPr>
+            <a:r>
+              <a:rPr sz="1300" b="0">
+                <a:solidFill>
+                  <a:srgbClr val="1C202C"/>
+                </a:solidFill>
+                <a:latin typeface="微软雅黑"/>
+                <ns6:rFonts xmlns:ns6="http://schemas.openxmlformats.org/wordprocessingml/2006/main" ns6:eastAsia="微软雅黑" ns6:ascii="微软雅黑" ns6:hAnsi="微软雅黑"/>
+              </a:rPr>
+              <a:t>● 欢迎评委扫码查阅</a:t>
+            </a:r>
+          </a:p>
+        </p:txBody>
+      </p:sp>
+      <p:sp>
+        <p:nvSpPr>
+          <p:cNvPr id="14" name="Rectangle 13"/>
+          <p:cNvSpPr/>
+          <p:nvPr/>
+        </p:nvSpPr>
+        <p:spPr>
+          <a:xfrm>
+            <a:off x="4105656" y="1033272"/>
+            <a:ext cx="4727448" cy="3744468"/>
+          </a:xfrm>
+          <a:prstGeom prst="rect">
+            <a:avLst/>
+          </a:prstGeom>
+          <a:solidFill>
+            <a:srgbClr val="FFFFFF"/>
+          </a:solidFill>
+          <a:ln w="9525">
+            <a:solidFill>
+              <a:srgbClr val="BAC8DC"/>
+            </a:solidFill>
+          </a:ln>
+        </p:spPr>
+        <p:style>
+          <a:lnRef idx="1">
+            <a:schemeClr val="accent1"/>
+          </a:lnRef>
+          <a:fillRef idx="3">
+            <a:schemeClr val="accent1"/>
+          </a:fillRef>
+          <a:effectRef idx="2">
+            <a:schemeClr val="accent1"/>
+          </a:effectRef>
+          <a:fontRef idx="minor">
+            <a:schemeClr val="lt1"/>
+          </a:fontRef>
+        </p:style>
+        <p:txBody>
+          <a:bodyPr rtlCol="0" anchor="ctr"/>
+          <a:lstStyle/>
+          <a:p>
+            <a:pPr algn="ctr"/>
+          </a:p>
+        </p:txBody>
+      </p:sp>
+      <p:pic>
+        <p:nvPicPr>
+          <p:cNvPr id="15" name="Picture 14" descr="ppt_demo_qr.png"/>
+          <p:cNvPicPr>
+            <a:picLocks noChangeAspect="1"/>
+          </p:cNvPicPr>
+          <p:nvPr/>
+        </p:nvPicPr>
+        <p:blipFill>
+          <a:blip r:embed="rId2"/>
+          <a:stretch>
+            <a:fillRect/>
+          </a:stretch>
+        </p:blipFill>
+        <p:spPr>
+          <a:xfrm>
+            <a:off x="4193804" y="1987814"/>
+            <a:ext cx="1597639" cy="1597639"/>
+          </a:xfrm>
+          <a:prstGeom prst="rect">
+            <a:avLst/>
+          </a:prstGeom>
+        </p:spPr>
+      </p:pic>
+      <p:sp>
+        <p:nvSpPr>
+          <p:cNvPr id="16" name="TextBox 15"/>
+          <p:cNvSpPr txBox="1"/>
+          <p:nvPr/>
+        </p:nvSpPr>
+        <p:spPr>
+          <a:xfrm>
+            <a:off x="4160520" y="3640317"/>
+            <a:ext cx="1664208" cy="219456"/>
+          </a:xfrm>
+          <a:prstGeom prst="rect">
+            <a:avLst/>
+          </a:prstGeom>
+          <a:noFill/>
+        </p:spPr>
+        <p:txBody>
+          <a:bodyPr wrap="square" anchor="ctr">
+            <a:spAutoFit/>
+          </a:bodyPr>
+          <a:lstStyle/>
+          <a:p>
+            <a:pPr algn="ctr"/>
+            <a:r>
+              <a:rPr sz="900" b="0">
+                <a:solidFill>
+                  <a:srgbClr val="5A6273"/>
+                </a:solidFill>
+                <a:latin typeface="微软雅黑"/>
+                <ns7:rFonts xmlns:ns7="http://schemas.openxmlformats.org/wordprocessingml/2006/main" ns7:eastAsia="微软雅黑" ns7:ascii="微软雅黑" ns7:hAnsi="微软雅黑"/>
+              </a:rPr>
+              <a:t>仓库二维码</a:t>
+            </a:r>
+          </a:p>
+        </p:txBody>
+      </p:sp>
+      <p:pic>
+        <p:nvPicPr>
+          <p:cNvPr id="17" name="Picture 16" descr="ppt_header_perception.png"/>
+          <p:cNvPicPr>
+            <a:picLocks noChangeAspect="1"/>
+          </p:cNvPicPr>
+          <p:nvPr/>
+        </p:nvPicPr>
+        <p:blipFill>
+          <a:blip r:embed="rId3"/>
+          <a:stretch>
+            <a:fillRect/>
+          </a:stretch>
+        </p:blipFill>
+        <p:spPr>
+          <a:xfrm>
+            <a:off x="5980998" y="2070050"/>
+            <a:ext cx="2768986" cy="1433166"/>
+          </a:xfrm>
+          <a:prstGeom prst="rect">
+            <a:avLst/>
+          </a:prstGeom>
+        </p:spPr>
+      </p:pic>
+      <p:sp>
+        <p:nvSpPr>
+          <p:cNvPr id="18" name="TextBox 17"/>
+          <p:cNvSpPr txBox="1"/>
+          <p:nvPr/>
+        </p:nvSpPr>
+        <p:spPr>
+          <a:xfrm>
+            <a:off x="5952744" y="3558081"/>
+            <a:ext cx="2825495" cy="219456"/>
+          </a:xfrm>
+          <a:prstGeom prst="rect">
+            <a:avLst/>
+          </a:prstGeom>
+          <a:noFill/>
+        </p:spPr>
+        <p:txBody>
+          <a:bodyPr wrap="square" anchor="ctr">
+            <a:spAutoFit/>
+          </a:bodyPr>
+          <a:lstStyle/>
+          <a:p>
+            <a:pPr algn="ctr"/>
+            <a:r>
+              <a:rPr sz="900" b="0">
+                <a:solidFill>
+                  <a:srgbClr val="5A6273"/>
+                </a:solidFill>
+                <a:latin typeface="微软雅黑"/>
+                <ns8:rFonts xmlns:ns8="http://schemas.openxmlformats.org/wordprocessingml/2006/main" ns8:eastAsia="微软雅黑" ns8:ascii="微软雅黑" ns8:hAnsi="微软雅黑"/>
+              </a:rPr>
+              <a:t>Web 感知界面</a:t>
+            </a:r>
+          </a:p>
+        </p:txBody>
+      </p:sp>
+    </p:spTree>
+  </p:cSld>
+  <p:clrMapOvr>
+    <a:masterClrMapping/>
+  </p:clrMapOvr>
+</p:sld>
+</file>
+
+<file path=ppt/slides/slide33.xml><?xml version="1.0" encoding="utf-8"?>
 <p:sld xmlns:a="http://schemas.openxmlformats.org/drawingml/2006/main" xmlns:p="http://schemas.openxmlformats.org/presentationml/2006/main" xmlns:r="http://schemas.openxmlformats.org/officeDocument/2006/relationships">
   <p:cSld>
     <p:spTree>

</xml_diff>